<commit_message>
Make presentation walkthrough self contained
</commit_message>
<xml_diff>
--- a/docs/synthaml-final-presentation.pptx
+++ b/docs/synthaml-final-presentation.pptx
@@ -2,17 +2,19 @@
 <file path=ppt/presentation.xml><?xml version="1.0" encoding="utf-8"?>
 <p:presentation xmlns:p="http://schemas.openxmlformats.org/presentationml/2006/main">
   <p:sldMasterIdLst>
-    <p:sldMasterId xmlns:r="http://schemas.openxmlformats.org/officeDocument/2006/relationships" id="2147483648" r:id="Rc5fe4bcdfedf4e7d"/>
+    <p:sldMasterId xmlns:r="http://schemas.openxmlformats.org/officeDocument/2006/relationships" id="2147483648" r:id="R075a5bffb660409a"/>
   </p:sldMasterIdLst>
   <p:notesMasterIdLst>
-    <p:notesMasterId xmlns:r="http://schemas.openxmlformats.org/officeDocument/2006/relationships" r:id="R7ee79b8dce8d4777"/>
+    <p:notesMasterId xmlns:r="http://schemas.openxmlformats.org/officeDocument/2006/relationships" r:id="Ra22c9a7c37104b86"/>
   </p:notesMasterIdLst>
   <p:sldIdLst>
-    <p:sldId xmlns:r="http://schemas.openxmlformats.org/officeDocument/2006/relationships" id="256" r:id="R29e7c01aaf5d4a8b"/>
-    <p:sldId xmlns:r="http://schemas.openxmlformats.org/officeDocument/2006/relationships" id="257" r:id="R94c03c032de5496c"/>
-    <p:sldId xmlns:r="http://schemas.openxmlformats.org/officeDocument/2006/relationships" id="258" r:id="R9b042871efff4313"/>
-    <p:sldId xmlns:r="http://schemas.openxmlformats.org/officeDocument/2006/relationships" id="259" r:id="R53a617b5ea9249e4"/>
-    <p:sldId xmlns:r="http://schemas.openxmlformats.org/officeDocument/2006/relationships" id="260" r:id="R8f3fc4e005cb473d"/>
+    <p:sldId xmlns:r="http://schemas.openxmlformats.org/officeDocument/2006/relationships" id="256" r:id="R0acf43b7cd364132"/>
+    <p:sldId xmlns:r="http://schemas.openxmlformats.org/officeDocument/2006/relationships" id="257" r:id="R7e78d1395ca6439c"/>
+    <p:sldId xmlns:r="http://schemas.openxmlformats.org/officeDocument/2006/relationships" id="258" r:id="Radaeae9a6c284316"/>
+    <p:sldId xmlns:r="http://schemas.openxmlformats.org/officeDocument/2006/relationships" id="259" r:id="Ra11ed55bc22e40b0"/>
+    <p:sldId xmlns:r="http://schemas.openxmlformats.org/officeDocument/2006/relationships" id="260" r:id="Rb112e70ca3864fa6"/>
+    <p:sldId xmlns:r="http://schemas.openxmlformats.org/officeDocument/2006/relationships" id="261" r:id="R58db244b75164c69"/>
+    <p:sldId xmlns:r="http://schemas.openxmlformats.org/officeDocument/2006/relationships" id="262" r:id="R1ce8b8d226a149e5"/>
   </p:sldIdLst>
   <p:sldSz cx="12192000" cy="6858000"/>
   <p:notesSz cx="6858000" cy="9144000"/>
@@ -785,6 +787,138 @@
 </p:notes>
 </file>
 
+<file path=ppt/notesSlides/notesSlide6.xml><?xml version="1.0" encoding="utf-8"?>
+<p:notes xmlns:p="http://schemas.openxmlformats.org/presentationml/2006/main">
+  <p:cSld>
+    <p:spTree>
+      <p:nvGrpSpPr>
+        <p:cNvPr id="1" name=""/>
+        <p:cNvGrpSpPr/>
+        <p:nvPr/>
+      </p:nvGrpSpPr>
+      <p:grpSpPr>
+        <a:xfrm xmlns:a="http://schemas.openxmlformats.org/drawingml/2006/main"/>
+      </p:grpSpPr>
+      <p:sp>
+        <p:nvSpPr>
+          <p:cNvPr id="2" name="Slide Image Placeholder 1"/>
+          <p:cNvSpPr>
+            <a:spLocks xmlns:a="http://schemas.openxmlformats.org/drawingml/2006/main" noGrp="1"/>
+          </p:cNvSpPr>
+          <p:nvPr>
+            <p:ph type="sldImg" idx="0"/>
+          </p:nvPr>
+        </p:nvSpPr>
+        <p:spPr/>
+      </p:sp>
+      <p:sp>
+        <p:nvSpPr>
+          <p:cNvPr id="3" name="Notes Placeholder 2"/>
+          <p:cNvSpPr>
+            <a:spLocks xmlns:a="http://schemas.openxmlformats.org/drawingml/2006/main" noGrp="1"/>
+          </p:cNvSpPr>
+          <p:nvPr>
+            <p:ph type="body" idx="1"/>
+          </p:nvPr>
+        </p:nvSpPr>
+        <p:spPr/>
+        <p:txBody>
+          <a:bodyPr xmlns:a="http://schemas.openxmlformats.org/drawingml/2006/main"/>
+          <a:lstStyle xmlns:a="http://schemas.openxmlformats.org/drawingml/2006/main"/>
+          <a:p xmlns:a="http://schemas.openxmlformats.org/drawingml/2006/main"/>
+        </p:txBody>
+      </p:sp>
+      <p:sp>
+        <p:nvSpPr>
+          <p:cNvPr id="4" name="Slide Number Placeholder 3"/>
+          <p:cNvSpPr>
+            <a:spLocks xmlns:a="http://schemas.openxmlformats.org/drawingml/2006/main" noGrp="1"/>
+          </p:cNvSpPr>
+          <p:nvPr>
+            <p:ph type="sldNum" idx="5"/>
+          </p:nvPr>
+        </p:nvSpPr>
+        <p:spPr/>
+        <p:txBody>
+          <a:bodyPr xmlns:a="http://schemas.openxmlformats.org/drawingml/2006/main"/>
+          <a:lstStyle xmlns:a="http://schemas.openxmlformats.org/drawingml/2006/main"/>
+          <a:p xmlns:a="http://schemas.openxmlformats.org/drawingml/2006/main"/>
+        </p:txBody>
+      </p:sp>
+    </p:spTree>
+  </p:cSld>
+  <p:clrMapOvr>
+    <a:masterClrMapping xmlns:a="http://schemas.openxmlformats.org/drawingml/2006/main"/>
+  </p:clrMapOvr>
+</p:notes>
+</file>
+
+<file path=ppt/notesSlides/notesSlide7.xml><?xml version="1.0" encoding="utf-8"?>
+<p:notes xmlns:p="http://schemas.openxmlformats.org/presentationml/2006/main">
+  <p:cSld>
+    <p:spTree>
+      <p:nvGrpSpPr>
+        <p:cNvPr id="1" name=""/>
+        <p:cNvGrpSpPr/>
+        <p:nvPr/>
+      </p:nvGrpSpPr>
+      <p:grpSpPr>
+        <a:xfrm xmlns:a="http://schemas.openxmlformats.org/drawingml/2006/main"/>
+      </p:grpSpPr>
+      <p:sp>
+        <p:nvSpPr>
+          <p:cNvPr id="2" name="Slide Image Placeholder 1"/>
+          <p:cNvSpPr>
+            <a:spLocks xmlns:a="http://schemas.openxmlformats.org/drawingml/2006/main" noGrp="1"/>
+          </p:cNvSpPr>
+          <p:nvPr>
+            <p:ph type="sldImg" idx="0"/>
+          </p:nvPr>
+        </p:nvSpPr>
+        <p:spPr/>
+      </p:sp>
+      <p:sp>
+        <p:nvSpPr>
+          <p:cNvPr id="3" name="Notes Placeholder 2"/>
+          <p:cNvSpPr>
+            <a:spLocks xmlns:a="http://schemas.openxmlformats.org/drawingml/2006/main" noGrp="1"/>
+          </p:cNvSpPr>
+          <p:nvPr>
+            <p:ph type="body" idx="1"/>
+          </p:nvPr>
+        </p:nvSpPr>
+        <p:spPr/>
+        <p:txBody>
+          <a:bodyPr xmlns:a="http://schemas.openxmlformats.org/drawingml/2006/main"/>
+          <a:lstStyle xmlns:a="http://schemas.openxmlformats.org/drawingml/2006/main"/>
+          <a:p xmlns:a="http://schemas.openxmlformats.org/drawingml/2006/main"/>
+        </p:txBody>
+      </p:sp>
+      <p:sp>
+        <p:nvSpPr>
+          <p:cNvPr id="4" name="Slide Number Placeholder 3"/>
+          <p:cNvSpPr>
+            <a:spLocks xmlns:a="http://schemas.openxmlformats.org/drawingml/2006/main" noGrp="1"/>
+          </p:cNvSpPr>
+          <p:nvPr>
+            <p:ph type="sldNum" idx="5"/>
+          </p:nvPr>
+        </p:nvSpPr>
+        <p:spPr/>
+        <p:txBody>
+          <a:bodyPr xmlns:a="http://schemas.openxmlformats.org/drawingml/2006/main"/>
+          <a:lstStyle xmlns:a="http://schemas.openxmlformats.org/drawingml/2006/main"/>
+          <a:p xmlns:a="http://schemas.openxmlformats.org/drawingml/2006/main"/>
+        </p:txBody>
+      </p:sp>
+    </p:spTree>
+  </p:cSld>
+  <p:clrMapOvr>
+    <a:masterClrMapping xmlns:a="http://schemas.openxmlformats.org/drawingml/2006/main"/>
+  </p:clrMapOvr>
+</p:notes>
+</file>
+
 <file path=ppt/slideLayouts/slideLayout2.xml><?xml version="1.0" encoding="utf-8"?>
 <p:sldLayout xmlns:p="http://schemas.openxmlformats.org/presentationml/2006/main" type="title">
   <p:cSld name="Title Slide">
@@ -823,7 +957,7 @@
   </p:cSld>
   <p:clrMap bg1="lt1" tx1="dk1" bg2="lt2" tx2="dk2" accent1="accent1" accent2="accent2" accent3="accent3" accent4="accent4" accent5="accent5" accent6="accent6" hlink="hlink" folHlink="folHlink"/>
   <p:sldLayoutIdLst>
-    <p:sldLayoutId xmlns:r="http://schemas.openxmlformats.org/officeDocument/2006/relationships" id="2147483649" r:id="Rdff81ff351294ae2"/>
+    <p:sldLayoutId xmlns:r="http://schemas.openxmlformats.org/officeDocument/2006/relationships" id="2147483649" r:id="R7d51d66f04a543a1"/>
   </p:sldLayoutIdLst>
   <p:txStyles>
     <p:titleStyle>
@@ -1122,7 +1256,7 @@
           <p:cNvPr id="1" name="">
             <a:extLst xmlns:a="http://schemas.openxmlformats.org/drawingml/2006/main">
               <a:ext uri="{FF2B5EF4-FFF2-40B4-BE49-F238E27FC236}">
-                <a16:creationId xmlns:a16="http://schemas.microsoft.com/office/drawing/2014/main" id="{059C7065-68CA-465E-BB21-D5D8F450A8FA}"/>
+                <a16:creationId xmlns:a16="http://schemas.microsoft.com/office/drawing/2014/main" id="{96014991-7200-42F1-943D-ABE227C29AFD}"/>
               </a:ext>
             </a:extLst>
           </p:cNvPr>
@@ -1157,7 +1291,7 @@
           <p:cNvPr id="2" name="">
             <a:extLst xmlns:a="http://schemas.openxmlformats.org/drawingml/2006/main">
               <a:ext uri="{FF2B5EF4-FFF2-40B4-BE49-F238E27FC236}">
-                <a16:creationId xmlns:a16="http://schemas.microsoft.com/office/drawing/2014/main" id="{5444AA5E-0339-41D5-A321-B127DEBCF16F}"/>
+                <a16:creationId xmlns:a16="http://schemas.microsoft.com/office/drawing/2014/main" id="{86478515-747A-4562-9EDF-048C9EC6FE71}"/>
               </a:ext>
             </a:extLst>
           </p:cNvPr>
@@ -1192,7 +1326,7 @@
           <p:cNvPr id="3" name="">
             <a:extLst xmlns:a="http://schemas.openxmlformats.org/drawingml/2006/main">
               <a:ext uri="{FF2B5EF4-FFF2-40B4-BE49-F238E27FC236}">
-                <a16:creationId xmlns:a16="http://schemas.microsoft.com/office/drawing/2014/main" id="{41DB14A4-3586-4412-9623-5BE83B5794B8}"/>
+                <a16:creationId xmlns:a16="http://schemas.microsoft.com/office/drawing/2014/main" id="{8F56A218-B160-4EEB-B5C2-D9BCFB8906C7}"/>
               </a:ext>
             </a:extLst>
           </p:cNvPr>
@@ -1256,7 +1390,7 @@
           <p:cNvPr id="4" name="">
             <a:extLst xmlns:a="http://schemas.openxmlformats.org/drawingml/2006/main">
               <a:ext uri="{FF2B5EF4-FFF2-40B4-BE49-F238E27FC236}">
-                <a16:creationId xmlns:a16="http://schemas.microsoft.com/office/drawing/2014/main" id="{ECDA9086-ECDB-44F8-B545-6947A87BAF8C}"/>
+                <a16:creationId xmlns:a16="http://schemas.microsoft.com/office/drawing/2014/main" id="{80673FD3-9F61-465E-825B-19012A5682A7}"/>
               </a:ext>
             </a:extLst>
           </p:cNvPr>
@@ -1320,7 +1454,7 @@
           <p:cNvPr id="5" name="">
             <a:extLst xmlns:a="http://schemas.openxmlformats.org/drawingml/2006/main">
               <a:ext uri="{FF2B5EF4-FFF2-40B4-BE49-F238E27FC236}">
-                <a16:creationId xmlns:a16="http://schemas.microsoft.com/office/drawing/2014/main" id="{4A262BE2-CD14-42D6-99CC-98770AC0D1C0}"/>
+                <a16:creationId xmlns:a16="http://schemas.microsoft.com/office/drawing/2014/main" id="{9454000B-FE01-4852-8CB6-E1181E88C674}"/>
               </a:ext>
             </a:extLst>
           </p:cNvPr>
@@ -1384,7 +1518,7 @@
           <p:cNvPr id="6" name="">
             <a:extLst xmlns:a="http://schemas.openxmlformats.org/drawingml/2006/main">
               <a:ext uri="{FF2B5EF4-FFF2-40B4-BE49-F238E27FC236}">
-                <a16:creationId xmlns:a16="http://schemas.microsoft.com/office/drawing/2014/main" id="{613ABF4A-A1AF-4747-BFA0-58C8BE0B9D62}"/>
+                <a16:creationId xmlns:a16="http://schemas.microsoft.com/office/drawing/2014/main" id="{BFCCD11E-5CD4-4575-B7BB-F14601D250F1}"/>
               </a:ext>
             </a:extLst>
           </p:cNvPr>
@@ -1419,7 +1553,7 @@
           <p:cNvPr id="7" name="">
             <a:extLst xmlns:a="http://schemas.openxmlformats.org/drawingml/2006/main">
               <a:ext uri="{FF2B5EF4-FFF2-40B4-BE49-F238E27FC236}">
-                <a16:creationId xmlns:a16="http://schemas.microsoft.com/office/drawing/2014/main" id="{44E5773A-82EA-45FD-96F2-E7DFDE7B6494}"/>
+                <a16:creationId xmlns:a16="http://schemas.microsoft.com/office/drawing/2014/main" id="{97C604CB-3D14-45D0-9936-6CB67EA8F35C}"/>
               </a:ext>
             </a:extLst>
           </p:cNvPr>
@@ -1483,7 +1617,7 @@
           <p:cNvPr id="8" name="">
             <a:extLst xmlns:a="http://schemas.openxmlformats.org/drawingml/2006/main">
               <a:ext uri="{FF2B5EF4-FFF2-40B4-BE49-F238E27FC236}">
-                <a16:creationId xmlns:a16="http://schemas.microsoft.com/office/drawing/2014/main" id="{DB072E82-DF4D-4FC9-8328-8107911F9D6C}"/>
+                <a16:creationId xmlns:a16="http://schemas.microsoft.com/office/drawing/2014/main" id="{9F4CAA0B-2BEC-4F63-8F99-C09AFA9CCF96}"/>
               </a:ext>
             </a:extLst>
           </p:cNvPr>
@@ -1547,7 +1681,7 @@
           <p:cNvPr id="9" name="">
             <a:extLst xmlns:a="http://schemas.openxmlformats.org/drawingml/2006/main">
               <a:ext uri="{FF2B5EF4-FFF2-40B4-BE49-F238E27FC236}">
-                <a16:creationId xmlns:a16="http://schemas.microsoft.com/office/drawing/2014/main" id="{4BC1EBE7-48BF-4C12-9D25-69948105F3B2}"/>
+                <a16:creationId xmlns:a16="http://schemas.microsoft.com/office/drawing/2014/main" id="{43467AFE-12DE-4524-896A-A06EFD72880D}"/>
               </a:ext>
             </a:extLst>
           </p:cNvPr>
@@ -1611,7 +1745,7 @@
           <p:cNvPr id="10" name="">
             <a:extLst xmlns:a="http://schemas.openxmlformats.org/drawingml/2006/main">
               <a:ext uri="{FF2B5EF4-FFF2-40B4-BE49-F238E27FC236}">
-                <a16:creationId xmlns:a16="http://schemas.microsoft.com/office/drawing/2014/main" id="{F98F23B9-C2DE-45DE-95F5-38E2B257D8C6}"/>
+                <a16:creationId xmlns:a16="http://schemas.microsoft.com/office/drawing/2014/main" id="{2EADFEDF-FCFE-4B06-B0EA-E29954176215}"/>
               </a:ext>
             </a:extLst>
           </p:cNvPr>
@@ -1675,7 +1809,7 @@
           <p:cNvPr id="11" name="">
             <a:extLst xmlns:a="http://schemas.openxmlformats.org/drawingml/2006/main">
               <a:ext uri="{FF2B5EF4-FFF2-40B4-BE49-F238E27FC236}">
-                <a16:creationId xmlns:a16="http://schemas.microsoft.com/office/drawing/2014/main" id="{5D29A785-7D0B-4DE3-A739-A25AE30EB04F}"/>
+                <a16:creationId xmlns:a16="http://schemas.microsoft.com/office/drawing/2014/main" id="{28F1FEC6-6230-4320-9DF6-B8DF61AD1611}"/>
               </a:ext>
             </a:extLst>
           </p:cNvPr>
@@ -1739,7 +1873,7 @@
           <p:cNvPr id="12" name="">
             <a:extLst xmlns:a="http://schemas.openxmlformats.org/drawingml/2006/main">
               <a:ext uri="{FF2B5EF4-FFF2-40B4-BE49-F238E27FC236}">
-                <a16:creationId xmlns:a16="http://schemas.microsoft.com/office/drawing/2014/main" id="{C14D4DB3-F0CB-452F-ACAC-1E21F5ADD4CE}"/>
+                <a16:creationId xmlns:a16="http://schemas.microsoft.com/office/drawing/2014/main" id="{059A4D4D-8C5C-4DD1-9624-791043C876E7}"/>
               </a:ext>
             </a:extLst>
           </p:cNvPr>
@@ -1803,7 +1937,7 @@
           <p:cNvPr id="13" name="">
             <a:extLst xmlns:a="http://schemas.openxmlformats.org/drawingml/2006/main">
               <a:ext uri="{FF2B5EF4-FFF2-40B4-BE49-F238E27FC236}">
-                <a16:creationId xmlns:a16="http://schemas.microsoft.com/office/drawing/2014/main" id="{8034D5EC-A277-4FEF-9B99-C0146625E112}"/>
+                <a16:creationId xmlns:a16="http://schemas.microsoft.com/office/drawing/2014/main" id="{F5B627A4-9F14-4F34-B802-C966457B8215}"/>
               </a:ext>
             </a:extLst>
           </p:cNvPr>
@@ -1838,7 +1972,7 @@
           <p:cNvPr id="14" name="">
             <a:extLst xmlns:a="http://schemas.openxmlformats.org/drawingml/2006/main">
               <a:ext uri="{FF2B5EF4-FFF2-40B4-BE49-F238E27FC236}">
-                <a16:creationId xmlns:a16="http://schemas.microsoft.com/office/drawing/2014/main" id="{376EBF68-4F9B-4363-BCF3-62C0E35BD339}"/>
+                <a16:creationId xmlns:a16="http://schemas.microsoft.com/office/drawing/2014/main" id="{AC5D1352-CBB6-46D7-9708-870D83DA71C4}"/>
               </a:ext>
             </a:extLst>
           </p:cNvPr>
@@ -1902,7 +2036,7 @@
           <p:cNvPr id="15" name="">
             <a:extLst xmlns:a="http://schemas.openxmlformats.org/drawingml/2006/main">
               <a:ext uri="{FF2B5EF4-FFF2-40B4-BE49-F238E27FC236}">
-                <a16:creationId xmlns:a16="http://schemas.microsoft.com/office/drawing/2014/main" id="{C84AE864-6A43-4C6E-8CF4-C6A167F5D880}"/>
+                <a16:creationId xmlns:a16="http://schemas.microsoft.com/office/drawing/2014/main" id="{91EBE77E-1A9A-4260-A252-E225CFF5E8D0}"/>
               </a:ext>
             </a:extLst>
           </p:cNvPr>
@@ -1989,7 +2123,7 @@
           <p:cNvPr id="16" name="">
             <a:extLst xmlns:a="http://schemas.openxmlformats.org/drawingml/2006/main">
               <a:ext uri="{FF2B5EF4-FFF2-40B4-BE49-F238E27FC236}">
-                <a16:creationId xmlns:a16="http://schemas.microsoft.com/office/drawing/2014/main" id="{CF28A4A6-42C4-4F5B-A19F-D452246C53DC}"/>
+                <a16:creationId xmlns:a16="http://schemas.microsoft.com/office/drawing/2014/main" id="{CB27CA8F-DCA3-4CCD-90F1-6D7B1F2864DE}"/>
               </a:ext>
             </a:extLst>
           </p:cNvPr>
@@ -2051,7 +2185,7 @@
     </p:spTree>
     <p:extLst>
       <p:ext uri="{BB962C8B-B14F-4D97-AF65-F5344CB8AC3E}">
-        <p14:creationId xmlns:p14="http://schemas.microsoft.com/office/powerpoint/2010/main" val="1280508986"/>
+        <p14:creationId xmlns:p14="http://schemas.microsoft.com/office/powerpoint/2010/main" val="1423851769"/>
       </p:ext>
     </p:extLst>
   </p:cSld>
@@ -2075,7 +2209,7 @@
           <p:cNvPr id="1" name="">
             <a:extLst xmlns:a="http://schemas.openxmlformats.org/drawingml/2006/main">
               <a:ext uri="{FF2B5EF4-FFF2-40B4-BE49-F238E27FC236}">
-                <a16:creationId xmlns:a16="http://schemas.microsoft.com/office/drawing/2014/main" id="{C9221212-9672-4D56-90CF-6DCFCE664449}"/>
+                <a16:creationId xmlns:a16="http://schemas.microsoft.com/office/drawing/2014/main" id="{92A8B4A1-DC9E-4DCE-B551-FD19D9B17BE0}"/>
               </a:ext>
             </a:extLst>
           </p:cNvPr>
@@ -2110,7 +2244,7 @@
           <p:cNvPr id="2" name="kicker-marker">
             <a:extLst xmlns:a="http://schemas.openxmlformats.org/drawingml/2006/main">
               <a:ext uri="{FF2B5EF4-FFF2-40B4-BE49-F238E27FC236}">
-                <a16:creationId xmlns:a16="http://schemas.microsoft.com/office/drawing/2014/main" id="{FEDFC97D-7C42-4E3C-B011-A1112DA7DC26}"/>
+                <a16:creationId xmlns:a16="http://schemas.microsoft.com/office/drawing/2014/main" id="{3B9A5D22-2BFD-4EC0-A31B-CCEBD5D54467}"/>
               </a:ext>
             </a:extLst>
           </p:cNvPr>
@@ -2145,7 +2279,7 @@
           <p:cNvPr id="3" name="kicker-label">
             <a:extLst xmlns:a="http://schemas.openxmlformats.org/drawingml/2006/main">
               <a:ext uri="{FF2B5EF4-FFF2-40B4-BE49-F238E27FC236}">
-                <a16:creationId xmlns:a16="http://schemas.microsoft.com/office/drawing/2014/main" id="{A251E6D1-3CBE-4D3C-B029-440714B33E3D}"/>
+                <a16:creationId xmlns:a16="http://schemas.microsoft.com/office/drawing/2014/main" id="{314F0864-5326-45DC-BCF6-06B99A0463F1}"/>
               </a:ext>
             </a:extLst>
           </p:cNvPr>
@@ -2209,7 +2343,7 @@
           <p:cNvPr id="4" name="">
             <a:extLst xmlns:a="http://schemas.openxmlformats.org/drawingml/2006/main">
               <a:ext uri="{FF2B5EF4-FFF2-40B4-BE49-F238E27FC236}">
-                <a16:creationId xmlns:a16="http://schemas.microsoft.com/office/drawing/2014/main" id="{E3719825-27D4-43A5-BA8C-675CE305CC27}"/>
+                <a16:creationId xmlns:a16="http://schemas.microsoft.com/office/drawing/2014/main" id="{033F248D-D368-49BE-9FEB-19394386FA34}"/>
               </a:ext>
             </a:extLst>
           </p:cNvPr>
@@ -2273,7 +2407,7 @@
           <p:cNvPr id="5" name="">
             <a:extLst xmlns:a="http://schemas.openxmlformats.org/drawingml/2006/main">
               <a:ext uri="{FF2B5EF4-FFF2-40B4-BE49-F238E27FC236}">
-                <a16:creationId xmlns:a16="http://schemas.microsoft.com/office/drawing/2014/main" id="{ED7FBEBE-E8DD-4A66-9DDF-51E6952CE40C}"/>
+                <a16:creationId xmlns:a16="http://schemas.microsoft.com/office/drawing/2014/main" id="{577C9575-EBBA-4751-BA4E-0494694EC8F7}"/>
               </a:ext>
             </a:extLst>
           </p:cNvPr>
@@ -2337,7 +2471,7 @@
           <p:cNvPr id="6" name="">
             <a:extLst xmlns:a="http://schemas.openxmlformats.org/drawingml/2006/main">
               <a:ext uri="{FF2B5EF4-FFF2-40B4-BE49-F238E27FC236}">
-                <a16:creationId xmlns:a16="http://schemas.microsoft.com/office/drawing/2014/main" id="{E84622BE-EF43-45E1-9FB4-852247BE1F95}"/>
+                <a16:creationId xmlns:a16="http://schemas.microsoft.com/office/drawing/2014/main" id="{25F40B14-13FE-4CBD-B706-31098810A39B}"/>
               </a:ext>
             </a:extLst>
           </p:cNvPr>
@@ -2372,7 +2506,7 @@
           <p:cNvPr id="7" name="">
             <a:extLst xmlns:a="http://schemas.openxmlformats.org/drawingml/2006/main">
               <a:ext uri="{FF2B5EF4-FFF2-40B4-BE49-F238E27FC236}">
-                <a16:creationId xmlns:a16="http://schemas.microsoft.com/office/drawing/2014/main" id="{6478AD4D-D34C-4B8C-B589-FD77CF14BBE0}"/>
+                <a16:creationId xmlns:a16="http://schemas.microsoft.com/office/drawing/2014/main" id="{2217FA45-45EE-4E66-B8D7-91B3FA555BAD}"/>
               </a:ext>
             </a:extLst>
           </p:cNvPr>
@@ -2436,7 +2570,7 @@
           <p:cNvPr id="8" name="">
             <a:extLst xmlns:a="http://schemas.openxmlformats.org/drawingml/2006/main">
               <a:ext uri="{FF2B5EF4-FFF2-40B4-BE49-F238E27FC236}">
-                <a16:creationId xmlns:a16="http://schemas.microsoft.com/office/drawing/2014/main" id="{912133EA-D787-45A2-A7D9-662ED4FA5624}"/>
+                <a16:creationId xmlns:a16="http://schemas.microsoft.com/office/drawing/2014/main" id="{F874244F-B766-4861-B3EB-593A5C72FA93}"/>
               </a:ext>
             </a:extLst>
           </p:cNvPr>
@@ -2500,7 +2634,7 @@
           <p:cNvPr id="9" name="">
             <a:extLst xmlns:a="http://schemas.openxmlformats.org/drawingml/2006/main">
               <a:ext uri="{FF2B5EF4-FFF2-40B4-BE49-F238E27FC236}">
-                <a16:creationId xmlns:a16="http://schemas.microsoft.com/office/drawing/2014/main" id="{F66270E5-41B2-4F4D-8EAA-5C97AC7F338C}"/>
+                <a16:creationId xmlns:a16="http://schemas.microsoft.com/office/drawing/2014/main" id="{FCB1387A-13FA-404B-BCA5-075E2A1D582D}"/>
               </a:ext>
             </a:extLst>
           </p:cNvPr>
@@ -2564,7 +2698,7 @@
           <p:cNvPr id="10" name="">
             <a:extLst xmlns:a="http://schemas.openxmlformats.org/drawingml/2006/main">
               <a:ext uri="{FF2B5EF4-FFF2-40B4-BE49-F238E27FC236}">
-                <a16:creationId xmlns:a16="http://schemas.microsoft.com/office/drawing/2014/main" id="{681B6051-154D-444E-8FC1-2F922C4275A8}"/>
+                <a16:creationId xmlns:a16="http://schemas.microsoft.com/office/drawing/2014/main" id="{A08BAA51-FEA3-472A-B34E-55698362B5EB}"/>
               </a:ext>
             </a:extLst>
           </p:cNvPr>
@@ -2599,7 +2733,7 @@
           <p:cNvPr id="11" name="">
             <a:extLst xmlns:a="http://schemas.openxmlformats.org/drawingml/2006/main">
               <a:ext uri="{FF2B5EF4-FFF2-40B4-BE49-F238E27FC236}">
-                <a16:creationId xmlns:a16="http://schemas.microsoft.com/office/drawing/2014/main" id="{78D46A60-0ED5-42B2-8A90-451DB63A0841}"/>
+                <a16:creationId xmlns:a16="http://schemas.microsoft.com/office/drawing/2014/main" id="{9DCD97D0-058D-4545-89F9-98A19ABE7B5B}"/>
               </a:ext>
             </a:extLst>
           </p:cNvPr>
@@ -2634,7 +2768,7 @@
           <p:cNvPr id="12" name="">
             <a:extLst xmlns:a="http://schemas.openxmlformats.org/drawingml/2006/main">
               <a:ext uri="{FF2B5EF4-FFF2-40B4-BE49-F238E27FC236}">
-                <a16:creationId xmlns:a16="http://schemas.microsoft.com/office/drawing/2014/main" id="{47BE34C7-0176-4986-9228-C9C96373105B}"/>
+                <a16:creationId xmlns:a16="http://schemas.microsoft.com/office/drawing/2014/main" id="{5558A199-1693-4A5D-AA22-1EA8EC15C506}"/>
               </a:ext>
             </a:extLst>
           </p:cNvPr>
@@ -2669,7 +2803,7 @@
           <p:cNvPr id="13" name="">
             <a:extLst xmlns:a="http://schemas.openxmlformats.org/drawingml/2006/main">
               <a:ext uri="{FF2B5EF4-FFF2-40B4-BE49-F238E27FC236}">
-                <a16:creationId xmlns:a16="http://schemas.microsoft.com/office/drawing/2014/main" id="{138D2E08-31B0-4C64-83BC-DE6A8E24A12B}"/>
+                <a16:creationId xmlns:a16="http://schemas.microsoft.com/office/drawing/2014/main" id="{CDAFC42E-8BA5-4E6E-9904-3BD437D09891}"/>
               </a:ext>
             </a:extLst>
           </p:cNvPr>
@@ -2733,7 +2867,7 @@
           <p:cNvPr id="14" name="">
             <a:extLst xmlns:a="http://schemas.openxmlformats.org/drawingml/2006/main">
               <a:ext uri="{FF2B5EF4-FFF2-40B4-BE49-F238E27FC236}">
-                <a16:creationId xmlns:a16="http://schemas.microsoft.com/office/drawing/2014/main" id="{553265AA-CEF3-407C-AA67-985BB5D479A2}"/>
+                <a16:creationId xmlns:a16="http://schemas.microsoft.com/office/drawing/2014/main" id="{422F314F-E5B8-42B8-BF33-9D66B706301F}"/>
               </a:ext>
             </a:extLst>
           </p:cNvPr>
@@ -2797,7 +2931,7 @@
           <p:cNvPr id="15" name="">
             <a:extLst xmlns:a="http://schemas.openxmlformats.org/drawingml/2006/main">
               <a:ext uri="{FF2B5EF4-FFF2-40B4-BE49-F238E27FC236}">
-                <a16:creationId xmlns:a16="http://schemas.microsoft.com/office/drawing/2014/main" id="{EF6B9418-19EC-4384-A3B2-DD4D72B28442}"/>
+                <a16:creationId xmlns:a16="http://schemas.microsoft.com/office/drawing/2014/main" id="{8A21CAB5-15D6-4844-91AB-930C2A9710D2}"/>
               </a:ext>
             </a:extLst>
           </p:cNvPr>
@@ -2861,7 +2995,7 @@
           <p:cNvPr id="16" name="">
             <a:extLst xmlns:a="http://schemas.openxmlformats.org/drawingml/2006/main">
               <a:ext uri="{FF2B5EF4-FFF2-40B4-BE49-F238E27FC236}">
-                <a16:creationId xmlns:a16="http://schemas.microsoft.com/office/drawing/2014/main" id="{398C8CE8-7B1E-4EC4-ABCD-8DB8F87F498E}"/>
+                <a16:creationId xmlns:a16="http://schemas.microsoft.com/office/drawing/2014/main" id="{8CB582C1-3190-40BF-B55D-9ADAEC305A1E}"/>
               </a:ext>
             </a:extLst>
           </p:cNvPr>
@@ -2896,7 +3030,7 @@
           <p:cNvPr id="17" name="">
             <a:extLst xmlns:a="http://schemas.openxmlformats.org/drawingml/2006/main">
               <a:ext uri="{FF2B5EF4-FFF2-40B4-BE49-F238E27FC236}">
-                <a16:creationId xmlns:a16="http://schemas.microsoft.com/office/drawing/2014/main" id="{5AACCDEF-2C3A-4736-9221-24EE84C6F051}"/>
+                <a16:creationId xmlns:a16="http://schemas.microsoft.com/office/drawing/2014/main" id="{399718F2-1D3A-4D59-8037-1E5B0E6C1256}"/>
               </a:ext>
             </a:extLst>
           </p:cNvPr>
@@ -2931,7 +3065,7 @@
           <p:cNvPr id="18" name="">
             <a:extLst xmlns:a="http://schemas.openxmlformats.org/drawingml/2006/main">
               <a:ext uri="{FF2B5EF4-FFF2-40B4-BE49-F238E27FC236}">
-                <a16:creationId xmlns:a16="http://schemas.microsoft.com/office/drawing/2014/main" id="{08CF526E-8B4C-44FD-8876-7E1F57428F83}"/>
+                <a16:creationId xmlns:a16="http://schemas.microsoft.com/office/drawing/2014/main" id="{2A4A1220-3650-45D7-BA87-56C4EE035150}"/>
               </a:ext>
             </a:extLst>
           </p:cNvPr>
@@ -2966,7 +3100,7 @@
           <p:cNvPr id="19" name="">
             <a:extLst xmlns:a="http://schemas.openxmlformats.org/drawingml/2006/main">
               <a:ext uri="{FF2B5EF4-FFF2-40B4-BE49-F238E27FC236}">
-                <a16:creationId xmlns:a16="http://schemas.microsoft.com/office/drawing/2014/main" id="{5C374DE8-E6CE-424C-A10E-58795A3958BC}"/>
+                <a16:creationId xmlns:a16="http://schemas.microsoft.com/office/drawing/2014/main" id="{64526249-513A-451C-BCA7-E892DAD7972B}"/>
               </a:ext>
             </a:extLst>
           </p:cNvPr>
@@ -3030,7 +3164,7 @@
           <p:cNvPr id="20" name="">
             <a:extLst xmlns:a="http://schemas.openxmlformats.org/drawingml/2006/main">
               <a:ext uri="{FF2B5EF4-FFF2-40B4-BE49-F238E27FC236}">
-                <a16:creationId xmlns:a16="http://schemas.microsoft.com/office/drawing/2014/main" id="{D21BAF52-9156-41B6-AE52-F18EB949E66E}"/>
+                <a16:creationId xmlns:a16="http://schemas.microsoft.com/office/drawing/2014/main" id="{F30EC71B-3D1C-4B0C-9388-0ECA235DF3FE}"/>
               </a:ext>
             </a:extLst>
           </p:cNvPr>
@@ -3094,7 +3228,7 @@
           <p:cNvPr id="21" name="">
             <a:extLst xmlns:a="http://schemas.openxmlformats.org/drawingml/2006/main">
               <a:ext uri="{FF2B5EF4-FFF2-40B4-BE49-F238E27FC236}">
-                <a16:creationId xmlns:a16="http://schemas.microsoft.com/office/drawing/2014/main" id="{4611B2C1-EFAA-4F54-BAA6-EB9484B3B1EB}"/>
+                <a16:creationId xmlns:a16="http://schemas.microsoft.com/office/drawing/2014/main" id="{E6C87395-D9ED-4053-80D7-815CAC44FCBD}"/>
               </a:ext>
             </a:extLst>
           </p:cNvPr>
@@ -3158,7 +3292,7 @@
           <p:cNvPr id="22" name="">
             <a:extLst xmlns:a="http://schemas.openxmlformats.org/drawingml/2006/main">
               <a:ext uri="{FF2B5EF4-FFF2-40B4-BE49-F238E27FC236}">
-                <a16:creationId xmlns:a16="http://schemas.microsoft.com/office/drawing/2014/main" id="{C4CE437E-A474-4735-8E05-8CB2ABA469CB}"/>
+                <a16:creationId xmlns:a16="http://schemas.microsoft.com/office/drawing/2014/main" id="{991BF42E-1DF5-4B06-BDAF-9B0E57BAF769}"/>
               </a:ext>
             </a:extLst>
           </p:cNvPr>
@@ -3191,7 +3325,7 @@
           <p:cNvPr id="23" name="">
             <a:extLst xmlns:a="http://schemas.openxmlformats.org/drawingml/2006/main">
               <a:ext uri="{FF2B5EF4-FFF2-40B4-BE49-F238E27FC236}">
-                <a16:creationId xmlns:a16="http://schemas.microsoft.com/office/drawing/2014/main" id="{B8B2B26B-EF1B-467F-8D5C-428F9DD3033B}"/>
+                <a16:creationId xmlns:a16="http://schemas.microsoft.com/office/drawing/2014/main" id="{F900D388-4D04-46B9-8674-C4453B13680A}"/>
               </a:ext>
             </a:extLst>
           </p:cNvPr>
@@ -3255,7 +3389,7 @@
           <p:cNvPr id="24" name="">
             <a:extLst xmlns:a="http://schemas.openxmlformats.org/drawingml/2006/main">
               <a:ext uri="{FF2B5EF4-FFF2-40B4-BE49-F238E27FC236}">
-                <a16:creationId xmlns:a16="http://schemas.microsoft.com/office/drawing/2014/main" id="{4B0B2A71-6BEF-4E27-A9FA-2F435A969121}"/>
+                <a16:creationId xmlns:a16="http://schemas.microsoft.com/office/drawing/2014/main" id="{D212AC8B-8F76-4EDF-8986-5512B854A851}"/>
               </a:ext>
             </a:extLst>
           </p:cNvPr>
@@ -3342,7 +3476,7 @@
           <p:cNvPr id="25" name="">
             <a:extLst xmlns:a="http://schemas.openxmlformats.org/drawingml/2006/main">
               <a:ext uri="{FF2B5EF4-FFF2-40B4-BE49-F238E27FC236}">
-                <a16:creationId xmlns:a16="http://schemas.microsoft.com/office/drawing/2014/main" id="{C4E65D3B-0D22-4238-982D-FD735F699F48}"/>
+                <a16:creationId xmlns:a16="http://schemas.microsoft.com/office/drawing/2014/main" id="{5E7967DA-14DE-4D57-AE08-E74671C8F64C}"/>
               </a:ext>
             </a:extLst>
           </p:cNvPr>
@@ -3377,7 +3511,7 @@
           <p:cNvPr id="26" name="">
             <a:extLst xmlns:a="http://schemas.openxmlformats.org/drawingml/2006/main">
               <a:ext uri="{FF2B5EF4-FFF2-40B4-BE49-F238E27FC236}">
-                <a16:creationId xmlns:a16="http://schemas.microsoft.com/office/drawing/2014/main" id="{2DE160E7-BE72-47AE-BAEE-DEC413C751E8}"/>
+                <a16:creationId xmlns:a16="http://schemas.microsoft.com/office/drawing/2014/main" id="{A74627AA-A296-4DD6-8EE6-F42D5F2AC6EC}"/>
               </a:ext>
             </a:extLst>
           </p:cNvPr>
@@ -3439,7 +3573,7 @@
     </p:spTree>
     <p:extLst>
       <p:ext uri="{BB962C8B-B14F-4D97-AF65-F5344CB8AC3E}">
-        <p14:creationId xmlns:p14="http://schemas.microsoft.com/office/powerpoint/2010/main" val="1550211779"/>
+        <p14:creationId xmlns:p14="http://schemas.microsoft.com/office/powerpoint/2010/main" val="1815123974"/>
       </p:ext>
     </p:extLst>
   </p:cSld>
@@ -3463,7 +3597,7 @@
           <p:cNvPr id="1" name="">
             <a:extLst xmlns:a="http://schemas.openxmlformats.org/drawingml/2006/main">
               <a:ext uri="{FF2B5EF4-FFF2-40B4-BE49-F238E27FC236}">
-                <a16:creationId xmlns:a16="http://schemas.microsoft.com/office/drawing/2014/main" id="{F0B04866-69F3-420A-BD8D-CE814FC28846}"/>
+                <a16:creationId xmlns:a16="http://schemas.microsoft.com/office/drawing/2014/main" id="{DEAD3854-15B0-4DD3-BCBB-AB81A1C7ADFB}"/>
               </a:ext>
             </a:extLst>
           </p:cNvPr>
@@ -3498,7 +3632,7 @@
           <p:cNvPr id="2" name="kicker-marker">
             <a:extLst xmlns:a="http://schemas.openxmlformats.org/drawingml/2006/main">
               <a:ext uri="{FF2B5EF4-FFF2-40B4-BE49-F238E27FC236}">
-                <a16:creationId xmlns:a16="http://schemas.microsoft.com/office/drawing/2014/main" id="{87F2851D-B0AC-437C-B699-584A7BB77C9A}"/>
+                <a16:creationId xmlns:a16="http://schemas.microsoft.com/office/drawing/2014/main" id="{5A5F85D8-0BC2-47C2-AF11-2933986BC0C9}"/>
               </a:ext>
             </a:extLst>
           </p:cNvPr>
@@ -3533,7 +3667,7 @@
           <p:cNvPr id="3" name="kicker-label">
             <a:extLst xmlns:a="http://schemas.openxmlformats.org/drawingml/2006/main">
               <a:ext uri="{FF2B5EF4-FFF2-40B4-BE49-F238E27FC236}">
-                <a16:creationId xmlns:a16="http://schemas.microsoft.com/office/drawing/2014/main" id="{5A38BA42-CD53-4AE7-B937-B4BDCA7444CC}"/>
+                <a16:creationId xmlns:a16="http://schemas.microsoft.com/office/drawing/2014/main" id="{4340ACE2-453E-482D-BD85-E3704403CDCF}"/>
               </a:ext>
             </a:extLst>
           </p:cNvPr>
@@ -3597,7 +3731,7 @@
           <p:cNvPr id="4" name="">
             <a:extLst xmlns:a="http://schemas.openxmlformats.org/drawingml/2006/main">
               <a:ext uri="{FF2B5EF4-FFF2-40B4-BE49-F238E27FC236}">
-                <a16:creationId xmlns:a16="http://schemas.microsoft.com/office/drawing/2014/main" id="{7E918849-BE2E-452B-AA04-C509068A5F7A}"/>
+                <a16:creationId xmlns:a16="http://schemas.microsoft.com/office/drawing/2014/main" id="{BDDBC1C5-6952-4C3F-B75F-3A03495569DD}"/>
               </a:ext>
             </a:extLst>
           </p:cNvPr>
@@ -3661,7 +3795,7 @@
           <p:cNvPr id="5" name="">
             <a:extLst xmlns:a="http://schemas.openxmlformats.org/drawingml/2006/main">
               <a:ext uri="{FF2B5EF4-FFF2-40B4-BE49-F238E27FC236}">
-                <a16:creationId xmlns:a16="http://schemas.microsoft.com/office/drawing/2014/main" id="{B15F4C47-13C1-4F17-B476-CDEB337D2358}"/>
+                <a16:creationId xmlns:a16="http://schemas.microsoft.com/office/drawing/2014/main" id="{7D76F513-C31F-44FC-ADFA-ADF34BD4FCA8}"/>
               </a:ext>
             </a:extLst>
           </p:cNvPr>
@@ -3696,7 +3830,7 @@
           <p:cNvPr id="6" name="">
             <a:extLst xmlns:a="http://schemas.openxmlformats.org/drawingml/2006/main">
               <a:ext uri="{FF2B5EF4-FFF2-40B4-BE49-F238E27FC236}">
-                <a16:creationId xmlns:a16="http://schemas.microsoft.com/office/drawing/2014/main" id="{99B802B4-5C60-43E0-9881-09EC0F449292}"/>
+                <a16:creationId xmlns:a16="http://schemas.microsoft.com/office/drawing/2014/main" id="{B9BC5881-298F-422B-94C0-34C31863757F}"/>
               </a:ext>
             </a:extLst>
           </p:cNvPr>
@@ -3760,7 +3894,7 @@
           <p:cNvPr id="7" name="">
             <a:extLst xmlns:a="http://schemas.openxmlformats.org/drawingml/2006/main">
               <a:ext uri="{FF2B5EF4-FFF2-40B4-BE49-F238E27FC236}">
-                <a16:creationId xmlns:a16="http://schemas.microsoft.com/office/drawing/2014/main" id="{81E08368-8237-40C7-91FD-5A6BB9226EE6}"/>
+                <a16:creationId xmlns:a16="http://schemas.microsoft.com/office/drawing/2014/main" id="{D916305C-910A-4424-BF34-A8D520B3F7AC}"/>
               </a:ext>
             </a:extLst>
           </p:cNvPr>
@@ -3793,7 +3927,7 @@
           <p:cNvPr id="8" name="">
             <a:extLst xmlns:a="http://schemas.openxmlformats.org/drawingml/2006/main">
               <a:ext uri="{FF2B5EF4-FFF2-40B4-BE49-F238E27FC236}">
-                <a16:creationId xmlns:a16="http://schemas.microsoft.com/office/drawing/2014/main" id="{687743FC-4A99-46D5-9BEB-4600CB97F63E}"/>
+                <a16:creationId xmlns:a16="http://schemas.microsoft.com/office/drawing/2014/main" id="{B185F800-E555-47CE-9A51-264932EDE3A7}"/>
               </a:ext>
             </a:extLst>
           </p:cNvPr>
@@ -3857,7 +3991,7 @@
           <p:cNvPr id="9" name="">
             <a:extLst xmlns:a="http://schemas.openxmlformats.org/drawingml/2006/main">
               <a:ext uri="{FF2B5EF4-FFF2-40B4-BE49-F238E27FC236}">
-                <a16:creationId xmlns:a16="http://schemas.microsoft.com/office/drawing/2014/main" id="{66EB8F0B-0556-4822-A463-7C3FC071462B}"/>
+                <a16:creationId xmlns:a16="http://schemas.microsoft.com/office/drawing/2014/main" id="{9BB35A6D-4099-4C0D-B289-07CD6419DD8C}"/>
               </a:ext>
             </a:extLst>
           </p:cNvPr>
@@ -3921,7 +4055,7 @@
           <p:cNvPr id="10" name="">
             <a:extLst xmlns:a="http://schemas.openxmlformats.org/drawingml/2006/main">
               <a:ext uri="{FF2B5EF4-FFF2-40B4-BE49-F238E27FC236}">
-                <a16:creationId xmlns:a16="http://schemas.microsoft.com/office/drawing/2014/main" id="{E7D58C24-655F-475A-BB5D-04DBC9A2505F}"/>
+                <a16:creationId xmlns:a16="http://schemas.microsoft.com/office/drawing/2014/main" id="{01478845-4956-4315-AEBA-C486CAD17224}"/>
               </a:ext>
             </a:extLst>
           </p:cNvPr>
@@ -3985,7 +4119,7 @@
           <p:cNvPr id="11" name="">
             <a:extLst xmlns:a="http://schemas.openxmlformats.org/drawingml/2006/main">
               <a:ext uri="{FF2B5EF4-FFF2-40B4-BE49-F238E27FC236}">
-                <a16:creationId xmlns:a16="http://schemas.microsoft.com/office/drawing/2014/main" id="{3AEAC7AE-DC41-4662-8EBD-1DDE913CFBDA}"/>
+                <a16:creationId xmlns:a16="http://schemas.microsoft.com/office/drawing/2014/main" id="{E2A9B59C-CFC5-48A8-8E7C-12ABBD0910A9}"/>
               </a:ext>
             </a:extLst>
           </p:cNvPr>
@@ -4020,7 +4154,7 @@
           <p:cNvPr id="12" name="">
             <a:extLst xmlns:a="http://schemas.openxmlformats.org/drawingml/2006/main">
               <a:ext uri="{FF2B5EF4-FFF2-40B4-BE49-F238E27FC236}">
-                <a16:creationId xmlns:a16="http://schemas.microsoft.com/office/drawing/2014/main" id="{D7511E9D-33B3-4752-9F67-5B18B2C84406}"/>
+                <a16:creationId xmlns:a16="http://schemas.microsoft.com/office/drawing/2014/main" id="{8D8151FE-FBBD-487B-B1A4-131D7CE0CBCB}"/>
               </a:ext>
             </a:extLst>
           </p:cNvPr>
@@ -4055,7 +4189,7 @@
           <p:cNvPr id="13" name="">
             <a:extLst xmlns:a="http://schemas.openxmlformats.org/drawingml/2006/main">
               <a:ext uri="{FF2B5EF4-FFF2-40B4-BE49-F238E27FC236}">
-                <a16:creationId xmlns:a16="http://schemas.microsoft.com/office/drawing/2014/main" id="{633EB690-A1BE-4199-B92B-98F83673ED2C}"/>
+                <a16:creationId xmlns:a16="http://schemas.microsoft.com/office/drawing/2014/main" id="{5B864DDE-CE47-4CB6-928B-B182372EC672}"/>
               </a:ext>
             </a:extLst>
           </p:cNvPr>
@@ -4088,7 +4222,7 @@
           <p:cNvPr id="14" name="">
             <a:extLst xmlns:a="http://schemas.openxmlformats.org/drawingml/2006/main">
               <a:ext uri="{FF2B5EF4-FFF2-40B4-BE49-F238E27FC236}">
-                <a16:creationId xmlns:a16="http://schemas.microsoft.com/office/drawing/2014/main" id="{2EF22390-9963-4012-9BCE-162820281815}"/>
+                <a16:creationId xmlns:a16="http://schemas.microsoft.com/office/drawing/2014/main" id="{9EE99387-B0C1-4DDF-A7BA-EEF1C7206443}"/>
               </a:ext>
             </a:extLst>
           </p:cNvPr>
@@ -4152,7 +4286,7 @@
           <p:cNvPr id="15" name="">
             <a:extLst xmlns:a="http://schemas.openxmlformats.org/drawingml/2006/main">
               <a:ext uri="{FF2B5EF4-FFF2-40B4-BE49-F238E27FC236}">
-                <a16:creationId xmlns:a16="http://schemas.microsoft.com/office/drawing/2014/main" id="{EC248EB9-7FE5-44C1-AD22-A9190BB211AB}"/>
+                <a16:creationId xmlns:a16="http://schemas.microsoft.com/office/drawing/2014/main" id="{9CC8308A-D7B1-49BC-BA83-A67965CF2992}"/>
               </a:ext>
             </a:extLst>
           </p:cNvPr>
@@ -4216,7 +4350,7 @@
           <p:cNvPr id="16" name="">
             <a:extLst xmlns:a="http://schemas.openxmlformats.org/drawingml/2006/main">
               <a:ext uri="{FF2B5EF4-FFF2-40B4-BE49-F238E27FC236}">
-                <a16:creationId xmlns:a16="http://schemas.microsoft.com/office/drawing/2014/main" id="{14678180-3A4D-484D-B6F6-CB56C64638E7}"/>
+                <a16:creationId xmlns:a16="http://schemas.microsoft.com/office/drawing/2014/main" id="{ABAB8892-A218-43BC-B0C8-7E445F06A1D3}"/>
               </a:ext>
             </a:extLst>
           </p:cNvPr>
@@ -4280,7 +4414,7 @@
           <p:cNvPr id="17" name="">
             <a:extLst xmlns:a="http://schemas.openxmlformats.org/drawingml/2006/main">
               <a:ext uri="{FF2B5EF4-FFF2-40B4-BE49-F238E27FC236}">
-                <a16:creationId xmlns:a16="http://schemas.microsoft.com/office/drawing/2014/main" id="{3A05C1FB-A2F8-4ECB-B953-8C1A12B1BDD5}"/>
+                <a16:creationId xmlns:a16="http://schemas.microsoft.com/office/drawing/2014/main" id="{1D4C3965-8C94-43CB-80BB-AC8905C41BD0}"/>
               </a:ext>
             </a:extLst>
           </p:cNvPr>
@@ -4315,7 +4449,7 @@
           <p:cNvPr id="18" name="">
             <a:extLst xmlns:a="http://schemas.openxmlformats.org/drawingml/2006/main">
               <a:ext uri="{FF2B5EF4-FFF2-40B4-BE49-F238E27FC236}">
-                <a16:creationId xmlns:a16="http://schemas.microsoft.com/office/drawing/2014/main" id="{B636E58C-1F5E-4335-8B90-21090310AC36}"/>
+                <a16:creationId xmlns:a16="http://schemas.microsoft.com/office/drawing/2014/main" id="{886CECDC-420E-4085-B2C6-8AAE96DC6FA4}"/>
               </a:ext>
             </a:extLst>
           </p:cNvPr>
@@ -4350,7 +4484,7 @@
           <p:cNvPr id="19" name="">
             <a:extLst xmlns:a="http://schemas.openxmlformats.org/drawingml/2006/main">
               <a:ext uri="{FF2B5EF4-FFF2-40B4-BE49-F238E27FC236}">
-                <a16:creationId xmlns:a16="http://schemas.microsoft.com/office/drawing/2014/main" id="{C27934AB-B530-4208-AA5C-3B22EF433DC1}"/>
+                <a16:creationId xmlns:a16="http://schemas.microsoft.com/office/drawing/2014/main" id="{B86FA9F3-ED27-4FEA-A9FB-B1BC19767509}"/>
               </a:ext>
             </a:extLst>
           </p:cNvPr>
@@ -4383,7 +4517,7 @@
           <p:cNvPr id="20" name="">
             <a:extLst xmlns:a="http://schemas.openxmlformats.org/drawingml/2006/main">
               <a:ext uri="{FF2B5EF4-FFF2-40B4-BE49-F238E27FC236}">
-                <a16:creationId xmlns:a16="http://schemas.microsoft.com/office/drawing/2014/main" id="{E85A2D8B-BE8B-4443-A99E-393A7DB14B7D}"/>
+                <a16:creationId xmlns:a16="http://schemas.microsoft.com/office/drawing/2014/main" id="{EB956C91-0C56-433A-BFEA-86A2357CB7A9}"/>
               </a:ext>
             </a:extLst>
           </p:cNvPr>
@@ -4447,7 +4581,7 @@
           <p:cNvPr id="21" name="">
             <a:extLst xmlns:a="http://schemas.openxmlformats.org/drawingml/2006/main">
               <a:ext uri="{FF2B5EF4-FFF2-40B4-BE49-F238E27FC236}">
-                <a16:creationId xmlns:a16="http://schemas.microsoft.com/office/drawing/2014/main" id="{B183236B-40E2-4D62-B76C-DEB2071EE4C1}"/>
+                <a16:creationId xmlns:a16="http://schemas.microsoft.com/office/drawing/2014/main" id="{E282E68A-5F23-4941-BB89-3C49A8F2433F}"/>
               </a:ext>
             </a:extLst>
           </p:cNvPr>
@@ -4511,7 +4645,7 @@
           <p:cNvPr id="22" name="">
             <a:extLst xmlns:a="http://schemas.openxmlformats.org/drawingml/2006/main">
               <a:ext uri="{FF2B5EF4-FFF2-40B4-BE49-F238E27FC236}">
-                <a16:creationId xmlns:a16="http://schemas.microsoft.com/office/drawing/2014/main" id="{B525002B-5EC7-46F0-8859-03D84C9423E7}"/>
+                <a16:creationId xmlns:a16="http://schemas.microsoft.com/office/drawing/2014/main" id="{750860D4-640D-40CE-B331-283DB67A7DB6}"/>
               </a:ext>
             </a:extLst>
           </p:cNvPr>
@@ -4575,7 +4709,7 @@
           <p:cNvPr id="23" name="">
             <a:extLst xmlns:a="http://schemas.openxmlformats.org/drawingml/2006/main">
               <a:ext uri="{FF2B5EF4-FFF2-40B4-BE49-F238E27FC236}">
-                <a16:creationId xmlns:a16="http://schemas.microsoft.com/office/drawing/2014/main" id="{5B08A2B8-D7E2-43C4-B893-9D5521A2AB1C}"/>
+                <a16:creationId xmlns:a16="http://schemas.microsoft.com/office/drawing/2014/main" id="{C828E6BF-67B2-4871-9ADD-0F18BB90B62A}"/>
               </a:ext>
             </a:extLst>
           </p:cNvPr>
@@ -4610,7 +4744,7 @@
           <p:cNvPr id="24" name="">
             <a:extLst xmlns:a="http://schemas.openxmlformats.org/drawingml/2006/main">
               <a:ext uri="{FF2B5EF4-FFF2-40B4-BE49-F238E27FC236}">
-                <a16:creationId xmlns:a16="http://schemas.microsoft.com/office/drawing/2014/main" id="{2AC1A2B5-5052-453E-AD5A-5724176737E0}"/>
+                <a16:creationId xmlns:a16="http://schemas.microsoft.com/office/drawing/2014/main" id="{7716E884-3950-4772-A3C5-2A0C23C5192D}"/>
               </a:ext>
             </a:extLst>
           </p:cNvPr>
@@ -4645,7 +4779,7 @@
           <p:cNvPr id="25" name="">
             <a:extLst xmlns:a="http://schemas.openxmlformats.org/drawingml/2006/main">
               <a:ext uri="{FF2B5EF4-FFF2-40B4-BE49-F238E27FC236}">
-                <a16:creationId xmlns:a16="http://schemas.microsoft.com/office/drawing/2014/main" id="{30C812D7-8952-4F08-A4A4-8D18C483CE19}"/>
+                <a16:creationId xmlns:a16="http://schemas.microsoft.com/office/drawing/2014/main" id="{F10F6576-E984-4C1C-9739-0AAA4394CA6B}"/>
               </a:ext>
             </a:extLst>
           </p:cNvPr>
@@ -4678,7 +4812,7 @@
           <p:cNvPr id="26" name="">
             <a:extLst xmlns:a="http://schemas.openxmlformats.org/drawingml/2006/main">
               <a:ext uri="{FF2B5EF4-FFF2-40B4-BE49-F238E27FC236}">
-                <a16:creationId xmlns:a16="http://schemas.microsoft.com/office/drawing/2014/main" id="{B938C700-D33E-4191-9AF8-73A72A979C2A}"/>
+                <a16:creationId xmlns:a16="http://schemas.microsoft.com/office/drawing/2014/main" id="{D98EC6D1-2AE6-48BF-9AB0-7858D77134A9}"/>
               </a:ext>
             </a:extLst>
           </p:cNvPr>
@@ -4742,7 +4876,7 @@
           <p:cNvPr id="27" name="">
             <a:extLst xmlns:a="http://schemas.openxmlformats.org/drawingml/2006/main">
               <a:ext uri="{FF2B5EF4-FFF2-40B4-BE49-F238E27FC236}">
-                <a16:creationId xmlns:a16="http://schemas.microsoft.com/office/drawing/2014/main" id="{8ACD4CF6-F36C-4507-B9CB-0227F5BA1567}"/>
+                <a16:creationId xmlns:a16="http://schemas.microsoft.com/office/drawing/2014/main" id="{118B6688-6C1C-4F95-BF60-A5EB0EBCD739}"/>
               </a:ext>
             </a:extLst>
           </p:cNvPr>
@@ -4806,7 +4940,7 @@
           <p:cNvPr id="28" name="">
             <a:extLst xmlns:a="http://schemas.openxmlformats.org/drawingml/2006/main">
               <a:ext uri="{FF2B5EF4-FFF2-40B4-BE49-F238E27FC236}">
-                <a16:creationId xmlns:a16="http://schemas.microsoft.com/office/drawing/2014/main" id="{5A0B0C76-799E-4EA9-A2F2-2CBD3EC58D3F}"/>
+                <a16:creationId xmlns:a16="http://schemas.microsoft.com/office/drawing/2014/main" id="{6F328494-C50B-4242-82DE-CFD8E24A2C8B}"/>
               </a:ext>
             </a:extLst>
           </p:cNvPr>
@@ -4870,7 +5004,7 @@
           <p:cNvPr id="29" name="">
             <a:extLst xmlns:a="http://schemas.openxmlformats.org/drawingml/2006/main">
               <a:ext uri="{FF2B5EF4-FFF2-40B4-BE49-F238E27FC236}">
-                <a16:creationId xmlns:a16="http://schemas.microsoft.com/office/drawing/2014/main" id="{58D04DCA-1337-4F66-807E-56BB26D6B8D1}"/>
+                <a16:creationId xmlns:a16="http://schemas.microsoft.com/office/drawing/2014/main" id="{0D2E9430-4787-438E-889A-C77E35C27255}"/>
               </a:ext>
             </a:extLst>
           </p:cNvPr>
@@ -4932,7 +5066,7 @@
     </p:spTree>
     <p:extLst>
       <p:ext uri="{BB962C8B-B14F-4D97-AF65-F5344CB8AC3E}">
-        <p14:creationId xmlns:p14="http://schemas.microsoft.com/office/powerpoint/2010/main" val="785013885"/>
+        <p14:creationId xmlns:p14="http://schemas.microsoft.com/office/powerpoint/2010/main" val="243443564"/>
       </p:ext>
     </p:extLst>
   </p:cSld>
@@ -4956,7 +5090,7 @@
           <p:cNvPr id="1" name="">
             <a:extLst xmlns:a="http://schemas.openxmlformats.org/drawingml/2006/main">
               <a:ext uri="{FF2B5EF4-FFF2-40B4-BE49-F238E27FC236}">
-                <a16:creationId xmlns:a16="http://schemas.microsoft.com/office/drawing/2014/main" id="{ED33FA9D-B7A8-422F-99D0-57615C307C36}"/>
+                <a16:creationId xmlns:a16="http://schemas.microsoft.com/office/drawing/2014/main" id="{D3F16523-125A-4998-8406-6EA816CE4492}"/>
               </a:ext>
             </a:extLst>
           </p:cNvPr>
@@ -4991,7 +5125,7 @@
           <p:cNvPr id="2" name="kicker-marker">
             <a:extLst xmlns:a="http://schemas.openxmlformats.org/drawingml/2006/main">
               <a:ext uri="{FF2B5EF4-FFF2-40B4-BE49-F238E27FC236}">
-                <a16:creationId xmlns:a16="http://schemas.microsoft.com/office/drawing/2014/main" id="{94772922-870B-44BB-9D6B-6E7893599441}"/>
+                <a16:creationId xmlns:a16="http://schemas.microsoft.com/office/drawing/2014/main" id="{40EBB054-FF9A-4FD7-B240-F5D6D3253591}"/>
               </a:ext>
             </a:extLst>
           </p:cNvPr>
@@ -5026,7 +5160,7 @@
           <p:cNvPr id="3" name="kicker-label">
             <a:extLst xmlns:a="http://schemas.openxmlformats.org/drawingml/2006/main">
               <a:ext uri="{FF2B5EF4-FFF2-40B4-BE49-F238E27FC236}">
-                <a16:creationId xmlns:a16="http://schemas.microsoft.com/office/drawing/2014/main" id="{D6B4AA3E-622D-4A76-9AE3-A2F90250D081}"/>
+                <a16:creationId xmlns:a16="http://schemas.microsoft.com/office/drawing/2014/main" id="{E67223F9-D0EF-4EB8-A654-EA2510077F4B}"/>
               </a:ext>
             </a:extLst>
           </p:cNvPr>
@@ -5090,7 +5224,7 @@
           <p:cNvPr id="4" name="">
             <a:extLst xmlns:a="http://schemas.openxmlformats.org/drawingml/2006/main">
               <a:ext uri="{FF2B5EF4-FFF2-40B4-BE49-F238E27FC236}">
-                <a16:creationId xmlns:a16="http://schemas.microsoft.com/office/drawing/2014/main" id="{C11F8B70-4E9F-42C9-B104-A52D8483EBB3}"/>
+                <a16:creationId xmlns:a16="http://schemas.microsoft.com/office/drawing/2014/main" id="{842C29BF-79C2-4681-8AF2-D19BE08B6EC7}"/>
               </a:ext>
             </a:extLst>
           </p:cNvPr>
@@ -5154,7 +5288,7 @@
           <p:cNvPr id="5" name="">
             <a:extLst xmlns:a="http://schemas.openxmlformats.org/drawingml/2006/main">
               <a:ext uri="{FF2B5EF4-FFF2-40B4-BE49-F238E27FC236}">
-                <a16:creationId xmlns:a16="http://schemas.microsoft.com/office/drawing/2014/main" id="{3893C4E6-0309-4E86-8D21-5086257E97A3}"/>
+                <a16:creationId xmlns:a16="http://schemas.microsoft.com/office/drawing/2014/main" id="{33C80162-184A-4BEC-8786-130D241D6590}"/>
               </a:ext>
             </a:extLst>
           </p:cNvPr>
@@ -5189,7 +5323,7 @@
           <p:cNvPr id="6" name="">
             <a:extLst xmlns:a="http://schemas.openxmlformats.org/drawingml/2006/main">
               <a:ext uri="{FF2B5EF4-FFF2-40B4-BE49-F238E27FC236}">
-                <a16:creationId xmlns:a16="http://schemas.microsoft.com/office/drawing/2014/main" id="{D25973CA-922B-4BEA-B29D-F6A3FC2A8A08}"/>
+                <a16:creationId xmlns:a16="http://schemas.microsoft.com/office/drawing/2014/main" id="{C8FC66E2-D511-409B-86D8-F1F108D59CC7}"/>
               </a:ext>
             </a:extLst>
           </p:cNvPr>
@@ -5253,7 +5387,7 @@
           <p:cNvPr id="7" name="">
             <a:extLst xmlns:a="http://schemas.openxmlformats.org/drawingml/2006/main">
               <a:ext uri="{FF2B5EF4-FFF2-40B4-BE49-F238E27FC236}">
-                <a16:creationId xmlns:a16="http://schemas.microsoft.com/office/drawing/2014/main" id="{EBEBCD02-3AC6-46D7-AEE8-BACB65601603}"/>
+                <a16:creationId xmlns:a16="http://schemas.microsoft.com/office/drawing/2014/main" id="{0F2EBE2C-618E-4320-AA8C-E9A60B4BD213}"/>
               </a:ext>
             </a:extLst>
           </p:cNvPr>
@@ -5317,7 +5451,7 @@
           <p:cNvPr id="8" name="">
             <a:extLst xmlns:a="http://schemas.openxmlformats.org/drawingml/2006/main">
               <a:ext uri="{FF2B5EF4-FFF2-40B4-BE49-F238E27FC236}">
-                <a16:creationId xmlns:a16="http://schemas.microsoft.com/office/drawing/2014/main" id="{F382C7E4-0DD0-40FB-A1AE-667E1277DC83}"/>
+                <a16:creationId xmlns:a16="http://schemas.microsoft.com/office/drawing/2014/main" id="{28B858EA-8946-4179-9280-322484D9A86F}"/>
               </a:ext>
             </a:extLst>
           </p:cNvPr>
@@ -5381,7 +5515,7 @@
           <p:cNvPr id="9" name="">
             <a:extLst xmlns:a="http://schemas.openxmlformats.org/drawingml/2006/main">
               <a:ext uri="{FF2B5EF4-FFF2-40B4-BE49-F238E27FC236}">
-                <a16:creationId xmlns:a16="http://schemas.microsoft.com/office/drawing/2014/main" id="{FAEAAC1E-6D74-4761-A75A-41A6A2771B8B}"/>
+                <a16:creationId xmlns:a16="http://schemas.microsoft.com/office/drawing/2014/main" id="{0D0EBB59-7D50-4E37-AF43-9A205FC56D2F}"/>
               </a:ext>
             </a:extLst>
           </p:cNvPr>
@@ -5416,7 +5550,7 @@
           <p:cNvPr id="10" name="">
             <a:extLst xmlns:a="http://schemas.openxmlformats.org/drawingml/2006/main">
               <a:ext uri="{FF2B5EF4-FFF2-40B4-BE49-F238E27FC236}">
-                <a16:creationId xmlns:a16="http://schemas.microsoft.com/office/drawing/2014/main" id="{0F704B96-5E2A-4722-885F-9C5B41AFDE27}"/>
+                <a16:creationId xmlns:a16="http://schemas.microsoft.com/office/drawing/2014/main" id="{75368E6C-CCFE-416F-9237-5896DEDEC912}"/>
               </a:ext>
             </a:extLst>
           </p:cNvPr>
@@ -5451,7 +5585,7 @@
           <p:cNvPr id="11" name="">
             <a:extLst xmlns:a="http://schemas.openxmlformats.org/drawingml/2006/main">
               <a:ext uri="{FF2B5EF4-FFF2-40B4-BE49-F238E27FC236}">
-                <a16:creationId xmlns:a16="http://schemas.microsoft.com/office/drawing/2014/main" id="{ACB10698-73BF-4BFB-AF07-9367B73D10F3}"/>
+                <a16:creationId xmlns:a16="http://schemas.microsoft.com/office/drawing/2014/main" id="{94D60A14-A307-42C5-BF1A-62F70947E955}"/>
               </a:ext>
             </a:extLst>
           </p:cNvPr>
@@ -5515,7 +5649,7 @@
           <p:cNvPr id="12" name="">
             <a:extLst xmlns:a="http://schemas.openxmlformats.org/drawingml/2006/main">
               <a:ext uri="{FF2B5EF4-FFF2-40B4-BE49-F238E27FC236}">
-                <a16:creationId xmlns:a16="http://schemas.microsoft.com/office/drawing/2014/main" id="{86D09876-E155-453A-9ED4-EDF6A8CF4B32}"/>
+                <a16:creationId xmlns:a16="http://schemas.microsoft.com/office/drawing/2014/main" id="{FC0CA719-E11F-431E-800E-6E28DCFE09D2}"/>
               </a:ext>
             </a:extLst>
           </p:cNvPr>
@@ -5579,7 +5713,7 @@
           <p:cNvPr id="13" name="">
             <a:extLst xmlns:a="http://schemas.openxmlformats.org/drawingml/2006/main">
               <a:ext uri="{FF2B5EF4-FFF2-40B4-BE49-F238E27FC236}">
-                <a16:creationId xmlns:a16="http://schemas.microsoft.com/office/drawing/2014/main" id="{158C3D4B-3298-4712-B1F3-3E45BDFF776B}"/>
+                <a16:creationId xmlns:a16="http://schemas.microsoft.com/office/drawing/2014/main" id="{261661A1-24C0-4E9F-BF08-BC8F5B8E6117}"/>
               </a:ext>
             </a:extLst>
           </p:cNvPr>
@@ -5614,7 +5748,7 @@
           <p:cNvPr id="14" name="">
             <a:extLst xmlns:a="http://schemas.openxmlformats.org/drawingml/2006/main">
               <a:ext uri="{FF2B5EF4-FFF2-40B4-BE49-F238E27FC236}">
-                <a16:creationId xmlns:a16="http://schemas.microsoft.com/office/drawing/2014/main" id="{7183002E-A5A8-41BD-923D-F4767AE725AF}"/>
+                <a16:creationId xmlns:a16="http://schemas.microsoft.com/office/drawing/2014/main" id="{514E4B03-AD83-4426-A1BD-3A8E0531CD92}"/>
               </a:ext>
             </a:extLst>
           </p:cNvPr>
@@ -5649,7 +5783,7 @@
           <p:cNvPr id="15" name="">
             <a:extLst xmlns:a="http://schemas.openxmlformats.org/drawingml/2006/main">
               <a:ext uri="{FF2B5EF4-FFF2-40B4-BE49-F238E27FC236}">
-                <a16:creationId xmlns:a16="http://schemas.microsoft.com/office/drawing/2014/main" id="{173C65D9-6B9A-4BC9-AFCB-AFFE1FA11192}"/>
+                <a16:creationId xmlns:a16="http://schemas.microsoft.com/office/drawing/2014/main" id="{4E4EDA4B-2225-4F7F-AEC5-6020638399D8}"/>
               </a:ext>
             </a:extLst>
           </p:cNvPr>
@@ -5713,7 +5847,7 @@
           <p:cNvPr id="16" name="">
             <a:extLst xmlns:a="http://schemas.openxmlformats.org/drawingml/2006/main">
               <a:ext uri="{FF2B5EF4-FFF2-40B4-BE49-F238E27FC236}">
-                <a16:creationId xmlns:a16="http://schemas.microsoft.com/office/drawing/2014/main" id="{CEB9C3DC-6593-4604-930C-81D01C268FEE}"/>
+                <a16:creationId xmlns:a16="http://schemas.microsoft.com/office/drawing/2014/main" id="{82E08083-E1C3-4348-A65A-4F007F690CC7}"/>
               </a:ext>
             </a:extLst>
           </p:cNvPr>
@@ -5748,7 +5882,7 @@
           <p:cNvPr id="17" name="">
             <a:extLst xmlns:a="http://schemas.openxmlformats.org/drawingml/2006/main">
               <a:ext uri="{FF2B5EF4-FFF2-40B4-BE49-F238E27FC236}">
-                <a16:creationId xmlns:a16="http://schemas.microsoft.com/office/drawing/2014/main" id="{B4A8E3D9-649B-4FC8-AD7D-8E0DBED3492C}"/>
+                <a16:creationId xmlns:a16="http://schemas.microsoft.com/office/drawing/2014/main" id="{1B685B7F-CE6E-4418-9B73-022B7120A57E}"/>
               </a:ext>
             </a:extLst>
           </p:cNvPr>
@@ -5812,7 +5946,7 @@
           <p:cNvPr id="18" name="">
             <a:extLst xmlns:a="http://schemas.openxmlformats.org/drawingml/2006/main">
               <a:ext uri="{FF2B5EF4-FFF2-40B4-BE49-F238E27FC236}">
-                <a16:creationId xmlns:a16="http://schemas.microsoft.com/office/drawing/2014/main" id="{F2055B00-279B-426B-8884-EFD46D44C28F}"/>
+                <a16:creationId xmlns:a16="http://schemas.microsoft.com/office/drawing/2014/main" id="{1C5965E1-39DD-4199-8A15-E74B1629DA83}"/>
               </a:ext>
             </a:extLst>
           </p:cNvPr>
@@ -5847,7 +5981,7 @@
           <p:cNvPr id="19" name="">
             <a:extLst xmlns:a="http://schemas.openxmlformats.org/drawingml/2006/main">
               <a:ext uri="{FF2B5EF4-FFF2-40B4-BE49-F238E27FC236}">
-                <a16:creationId xmlns:a16="http://schemas.microsoft.com/office/drawing/2014/main" id="{7A01DFF3-A274-406E-B53E-DF6206DB0298}"/>
+                <a16:creationId xmlns:a16="http://schemas.microsoft.com/office/drawing/2014/main" id="{7F28899D-20E0-4619-87D4-B93940D47D1E}"/>
               </a:ext>
             </a:extLst>
           </p:cNvPr>
@@ -5911,7 +6045,7 @@
           <p:cNvPr id="20" name="">
             <a:extLst xmlns:a="http://schemas.openxmlformats.org/drawingml/2006/main">
               <a:ext uri="{FF2B5EF4-FFF2-40B4-BE49-F238E27FC236}">
-                <a16:creationId xmlns:a16="http://schemas.microsoft.com/office/drawing/2014/main" id="{074D70EA-335D-4F99-9143-3C67D4829098}"/>
+                <a16:creationId xmlns:a16="http://schemas.microsoft.com/office/drawing/2014/main" id="{547843B7-75FD-425A-8AB5-A617CA690FD3}"/>
               </a:ext>
             </a:extLst>
           </p:cNvPr>
@@ -5946,7 +6080,7 @@
           <p:cNvPr id="21" name="">
             <a:extLst xmlns:a="http://schemas.openxmlformats.org/drawingml/2006/main">
               <a:ext uri="{FF2B5EF4-FFF2-40B4-BE49-F238E27FC236}">
-                <a16:creationId xmlns:a16="http://schemas.microsoft.com/office/drawing/2014/main" id="{1752259A-2251-46AB-9977-31F39C3DFE8D}"/>
+                <a16:creationId xmlns:a16="http://schemas.microsoft.com/office/drawing/2014/main" id="{D94EAD9D-6B9F-4B0A-8C67-CD6214A85873}"/>
               </a:ext>
             </a:extLst>
           </p:cNvPr>
@@ -6010,7 +6144,7 @@
           <p:cNvPr id="22" name="">
             <a:extLst xmlns:a="http://schemas.openxmlformats.org/drawingml/2006/main">
               <a:ext uri="{FF2B5EF4-FFF2-40B4-BE49-F238E27FC236}">
-                <a16:creationId xmlns:a16="http://schemas.microsoft.com/office/drawing/2014/main" id="{CB66FEA7-4FBC-41A4-AD06-BE309C0FF901}"/>
+                <a16:creationId xmlns:a16="http://schemas.microsoft.com/office/drawing/2014/main" id="{3D3698E3-2146-4ED7-AFE3-FEE527C363BC}"/>
               </a:ext>
             </a:extLst>
           </p:cNvPr>
@@ -6045,7 +6179,7 @@
           <p:cNvPr id="23" name="">
             <a:extLst xmlns:a="http://schemas.openxmlformats.org/drawingml/2006/main">
               <a:ext uri="{FF2B5EF4-FFF2-40B4-BE49-F238E27FC236}">
-                <a16:creationId xmlns:a16="http://schemas.microsoft.com/office/drawing/2014/main" id="{EBF277AE-E840-430D-8E68-9A01EBABAC29}"/>
+                <a16:creationId xmlns:a16="http://schemas.microsoft.com/office/drawing/2014/main" id="{7E86EF10-5D7F-4B3A-AB72-73547845CA67}"/>
               </a:ext>
             </a:extLst>
           </p:cNvPr>
@@ -6109,7 +6243,7 @@
           <p:cNvPr id="24" name="">
             <a:extLst xmlns:a="http://schemas.openxmlformats.org/drawingml/2006/main">
               <a:ext uri="{FF2B5EF4-FFF2-40B4-BE49-F238E27FC236}">
-                <a16:creationId xmlns:a16="http://schemas.microsoft.com/office/drawing/2014/main" id="{E8FE79AE-BF27-4C3F-898A-E62FF8F1FA37}"/>
+                <a16:creationId xmlns:a16="http://schemas.microsoft.com/office/drawing/2014/main" id="{43D571AD-0CA3-4DCD-AFEB-2FD23368750E}"/>
               </a:ext>
             </a:extLst>
           </p:cNvPr>
@@ -6144,7 +6278,7 @@
           <p:cNvPr id="25" name="">
             <a:extLst xmlns:a="http://schemas.openxmlformats.org/drawingml/2006/main">
               <a:ext uri="{FF2B5EF4-FFF2-40B4-BE49-F238E27FC236}">
-                <a16:creationId xmlns:a16="http://schemas.microsoft.com/office/drawing/2014/main" id="{68777175-10A6-4AB9-8CC1-F9B4EEF38A42}"/>
+                <a16:creationId xmlns:a16="http://schemas.microsoft.com/office/drawing/2014/main" id="{D863B11F-06AD-4244-99A4-F0D500EC74C3}"/>
               </a:ext>
             </a:extLst>
           </p:cNvPr>
@@ -6208,7 +6342,7 @@
           <p:cNvPr id="26" name="">
             <a:extLst xmlns:a="http://schemas.openxmlformats.org/drawingml/2006/main">
               <a:ext uri="{FF2B5EF4-FFF2-40B4-BE49-F238E27FC236}">
-                <a16:creationId xmlns:a16="http://schemas.microsoft.com/office/drawing/2014/main" id="{3519014F-9974-4EE1-9E6A-DE895DA0075F}"/>
+                <a16:creationId xmlns:a16="http://schemas.microsoft.com/office/drawing/2014/main" id="{429092F8-1328-499A-98A2-6857B94707E6}"/>
               </a:ext>
             </a:extLst>
           </p:cNvPr>
@@ -6293,7 +6427,7 @@
     </p:spTree>
     <p:extLst>
       <p:ext uri="{BB962C8B-B14F-4D97-AF65-F5344CB8AC3E}">
-        <p14:creationId xmlns:p14="http://schemas.microsoft.com/office/powerpoint/2010/main" val="435300566"/>
+        <p14:creationId xmlns:p14="http://schemas.microsoft.com/office/powerpoint/2010/main" val="222101471"/>
       </p:ext>
     </p:extLst>
   </p:cSld>
@@ -6317,7 +6451,7 @@
           <p:cNvPr id="1" name="">
             <a:extLst xmlns:a="http://schemas.openxmlformats.org/drawingml/2006/main">
               <a:ext uri="{FF2B5EF4-FFF2-40B4-BE49-F238E27FC236}">
-                <a16:creationId xmlns:a16="http://schemas.microsoft.com/office/drawing/2014/main" id="{A222B86C-ADDC-4DE9-B351-CDCBE663DD5F}"/>
+                <a16:creationId xmlns:a16="http://schemas.microsoft.com/office/drawing/2014/main" id="{33326B6E-A8F6-45CF-ADD0-DEBBD16EA677}"/>
               </a:ext>
             </a:extLst>
           </p:cNvPr>
@@ -6352,7 +6486,7 @@
           <p:cNvPr id="2" name="kicker-marker">
             <a:extLst xmlns:a="http://schemas.openxmlformats.org/drawingml/2006/main">
               <a:ext uri="{FF2B5EF4-FFF2-40B4-BE49-F238E27FC236}">
-                <a16:creationId xmlns:a16="http://schemas.microsoft.com/office/drawing/2014/main" id="{244ABD94-3EDD-492B-AA09-C5ED9F32CD27}"/>
+                <a16:creationId xmlns:a16="http://schemas.microsoft.com/office/drawing/2014/main" id="{A65B358F-AD87-4517-A790-3D14473D5C1C}"/>
               </a:ext>
             </a:extLst>
           </p:cNvPr>
@@ -6387,7 +6521,7 @@
           <p:cNvPr id="3" name="kicker-label">
             <a:extLst xmlns:a="http://schemas.openxmlformats.org/drawingml/2006/main">
               <a:ext uri="{FF2B5EF4-FFF2-40B4-BE49-F238E27FC236}">
-                <a16:creationId xmlns:a16="http://schemas.microsoft.com/office/drawing/2014/main" id="{7FD6A0D2-9754-48D3-9158-01D9B570ECCB}"/>
+                <a16:creationId xmlns:a16="http://schemas.microsoft.com/office/drawing/2014/main" id="{55FE27EC-4E10-4584-B7BA-C3B62C34FBB0}"/>
               </a:ext>
             </a:extLst>
           </p:cNvPr>
@@ -6399,7 +6533,7 @@
         <p:spPr>
           <a:xfrm xmlns:a="http://schemas.openxmlformats.org/drawingml/2006/main">
             <a:off x="876300" y="438150"/>
-            <a:ext cx="2476500" cy="266700"/>
+            <a:ext cx="2857500" cy="266700"/>
           </a:xfrm>
           <a:prstGeom xmlns:a="http://schemas.openxmlformats.org/drawingml/2006/main" prst="rect">
             <a:avLst/>
@@ -6441,7 +6575,7 @@
                 <a:ea typeface="Aptos"/>
                 <a:cs typeface="Aptos"/>
               </a:rPr>
-              <a:t>DEMO</a:t>
+              <a:t>UI WALKTHROUGH 1</a:t>
             </a:r>
           </a:p>
         </p:txBody>
@@ -6451,19 +6585,19 @@
           <p:cNvPr id="4" name="">
             <a:extLst xmlns:a="http://schemas.openxmlformats.org/drawingml/2006/main">
               <a:ext uri="{FF2B5EF4-FFF2-40B4-BE49-F238E27FC236}">
-                <a16:creationId xmlns:a16="http://schemas.microsoft.com/office/drawing/2014/main" id="{D99AFDB7-A8D3-4E56-9136-2301E0FEA422}"/>
-              </a:ext>
-            </a:extLst>
-          </p:cNvPr>
-          <p:cNvSpPr>
-            <a:spLocks xmlns:a="http://schemas.openxmlformats.org/drawingml/2006/main" noGrp="1"/>
-          </p:cNvSpPr>
-          <p:nvPr/>
-        </p:nvSpPr>
-        <p:spPr>
-          <a:xfrm xmlns:a="http://schemas.openxmlformats.org/drawingml/2006/main">
-            <a:off x="666750" y="895350"/>
-            <a:ext cx="8572500" cy="914400"/>
+                <a16:creationId xmlns:a16="http://schemas.microsoft.com/office/drawing/2014/main" id="{38BDABD8-3A3E-4A95-AA90-A0D064DBD7A6}"/>
+              </a:ext>
+            </a:extLst>
+          </p:cNvPr>
+          <p:cNvSpPr>
+            <a:spLocks xmlns:a="http://schemas.openxmlformats.org/drawingml/2006/main" noGrp="1"/>
+          </p:cNvSpPr>
+          <p:nvPr/>
+        </p:nvSpPr>
+        <p:spPr>
+          <a:xfrm xmlns:a="http://schemas.openxmlformats.org/drawingml/2006/main">
+            <a:off x="666750" y="914400"/>
+            <a:ext cx="9906000" cy="590550"/>
           </a:xfrm>
           <a:prstGeom xmlns:a="http://schemas.openxmlformats.org/drawingml/2006/main" prst="rect">
             <a:avLst/>
@@ -6487,7 +6621,7 @@
           <a:lstStyle xmlns:a="http://schemas.openxmlformats.org/drawingml/2006/main"/>
           <a:p xmlns:a="http://schemas.openxmlformats.org/drawingml/2006/main">
             <a:pPr algn="l">
-              <a:defRPr sz="2700" b="1">
+              <a:defRPr sz="2475" b="1">
                 <a:solidFill>
                   <a:srgbClr val="14213D"/>
                 </a:solidFill>
@@ -6497,7 +6631,7 @@
               </a:defRPr>
             </a:pPr>
             <a:r>
-              <a:rPr sz="2700" b="1">
+              <a:rPr sz="2475" b="1">
                 <a:solidFill>
                   <a:srgbClr val="14213D"/>
                 </a:solidFill>
@@ -6505,7 +6639,7 @@
                 <a:ea typeface="Aptos Display"/>
                 <a:cs typeface="Aptos Display"/>
               </a:rPr>
-              <a:t>The demo shows the artifact is usable: paste, generate, evaluate, export.</a:t>
+              <a:t>The reviewer starts by pasting a warning and checking the extracted scenario brief.</a:t>
             </a:r>
           </a:p>
         </p:txBody>
@@ -6515,7 +6649,7 @@
           <p:cNvPr id="5" name="">
             <a:extLst xmlns:a="http://schemas.openxmlformats.org/drawingml/2006/main">
               <a:ext uri="{FF2B5EF4-FFF2-40B4-BE49-F238E27FC236}">
-                <a16:creationId xmlns:a16="http://schemas.microsoft.com/office/drawing/2014/main" id="{8DCDCFA5-82F5-4B21-AB8D-6B786713FFD7}"/>
+                <a16:creationId xmlns:a16="http://schemas.microsoft.com/office/drawing/2014/main" id="{7EC9671A-7D34-40DC-81C5-4177B6998EBC}"/>
               </a:ext>
             </a:extLst>
           </p:cNvPr>
@@ -6550,7 +6684,7 @@
           <p:cNvPr id="6" name="">
             <a:extLst xmlns:a="http://schemas.openxmlformats.org/drawingml/2006/main">
               <a:ext uri="{FF2B5EF4-FFF2-40B4-BE49-F238E27FC236}">
-                <a16:creationId xmlns:a16="http://schemas.microsoft.com/office/drawing/2014/main" id="{72E39E35-AA44-4289-BEB6-8101701CA8B5}"/>
+                <a16:creationId xmlns:a16="http://schemas.microsoft.com/office/drawing/2014/main" id="{D3A2DDBD-A165-4A24-BCA1-32412E2F64BA}"/>
               </a:ext>
             </a:extLst>
           </p:cNvPr>
@@ -6562,7 +6696,7 @@
         <p:spPr>
           <a:xfrm xmlns:a="http://schemas.openxmlformats.org/drawingml/2006/main">
             <a:off x="666750" y="6457950"/>
-            <a:ext cx="2857500" cy="190500"/>
+            <a:ext cx="3238500" cy="190500"/>
           </a:xfrm>
           <a:prstGeom xmlns:a="http://schemas.openxmlformats.org/drawingml/2006/main" prst="rect">
             <a:avLst/>
@@ -6604,29 +6738,51 @@
                 <a:ea typeface="Aptos"/>
                 <a:cs typeface="Aptos"/>
               </a:rPr>
-              <a:t>Demo playthrough | 4</a:t>
+              <a:t>Artifact walkthrough | 4</a:t>
             </a:r>
           </a:p>
         </p:txBody>
       </p:sp>
-      <p:sp>
-        <p:nvSpPr>
-          <p:cNvPr id="7" name="">
-            <a:extLst xmlns:a="http://schemas.openxmlformats.org/drawingml/2006/main">
-              <a:ext uri="{FF2B5EF4-FFF2-40B4-BE49-F238E27FC236}">
-                <a16:creationId xmlns:a16="http://schemas.microsoft.com/office/drawing/2014/main" id="{E922DD6E-39F0-469D-A61D-C64FB3D68775}"/>
-              </a:ext>
-            </a:extLst>
-          </p:cNvPr>
-          <p:cNvSpPr>
-            <a:spLocks xmlns:a="http://schemas.openxmlformats.org/drawingml/2006/main" noGrp="1"/>
-          </p:cNvSpPr>
-          <p:nvPr/>
-        </p:nvSpPr>
-        <p:spPr>
-          <a:xfrm xmlns:a="http://schemas.openxmlformats.org/drawingml/2006/main">
-            <a:off x="914400" y="2381250"/>
-            <a:ext cx="1200150" cy="266700"/>
+      <p:pic>
+        <p:nvPicPr>
+          <p:cNvPr id="7" name=""/>
+          <p:cNvPicPr>
+            <a:picLocks xmlns:a="http://schemas.openxmlformats.org/drawingml/2006/main" noChangeAspect="1"/>
+          </p:cNvPicPr>
+          <p:nvPr/>
+        </p:nvPicPr>
+        <p:blipFill>
+          <a:blip xmlns:r="http://schemas.openxmlformats.org/officeDocument/2006/relationships" xmlns:a="http://schemas.openxmlformats.org/drawingml/2006/main" r:embed="Rb5fd72488dad44d8"/>
+          <a:stretch xmlns:a="http://schemas.openxmlformats.org/drawingml/2006/main"/>
+        </p:blipFill>
+        <p:spPr>
+          <a:xfrm xmlns:a="http://schemas.openxmlformats.org/drawingml/2006/main">
+            <a:off x="2201333" y="1714500"/>
+            <a:ext cx="7789333" cy="4381500"/>
+          </a:xfrm>
+          <a:prstGeom xmlns:a="http://schemas.openxmlformats.org/drawingml/2006/main" prst="rect">
+            <a:avLst/>
+          </a:prstGeom>
+        </p:spPr>
+      </p:pic>
+      <p:sp>
+        <p:nvSpPr>
+          <p:cNvPr id="8" name="">
+            <a:extLst xmlns:a="http://schemas.openxmlformats.org/drawingml/2006/main">
+              <a:ext uri="{FF2B5EF4-FFF2-40B4-BE49-F238E27FC236}">
+                <a16:creationId xmlns:a16="http://schemas.microsoft.com/office/drawing/2014/main" id="{E4C41424-C58E-4C7A-8458-72BDFBC91675}"/>
+              </a:ext>
+            </a:extLst>
+          </p:cNvPr>
+          <p:cNvSpPr>
+            <a:spLocks xmlns:a="http://schemas.openxmlformats.org/drawingml/2006/main" noGrp="1"/>
+          </p:cNvSpPr>
+          <p:nvPr/>
+        </p:nvSpPr>
+        <p:spPr>
+          <a:xfrm xmlns:a="http://schemas.openxmlformats.org/drawingml/2006/main">
+            <a:off x="2200275" y="1714500"/>
+            <a:ext cx="7791450" cy="4381500"/>
           </a:xfrm>
           <a:prstGeom xmlns:a="http://schemas.openxmlformats.org/drawingml/2006/main" prst="rect">
             <a:avLst/>
@@ -6636,96 +6792,188 @@
               <a:alpha val="0"/>
             </a:srgbClr>
           </a:solidFill>
-          <a:ln xmlns:a="http://schemas.openxmlformats.org/drawingml/2006/main" w="0">
-            <a:solidFill>
-              <a:srgbClr val="000000">
-                <a:alpha val="0"/>
-              </a:srgbClr>
-            </a:solidFill>
-            <a:prstDash val="solid"/>
-          </a:ln>
-        </p:spPr>
-        <p:txBody>
-          <a:bodyPr xmlns:a="http://schemas.openxmlformats.org/drawingml/2006/main" lIns="0" tIns="0" rIns="0" bIns="0" anchor="t"/>
+          <a:ln xmlns:a="http://schemas.openxmlformats.org/drawingml/2006/main" w="9525">
+            <a:solidFill>
+              <a:srgbClr val="D8D0C0"/>
+            </a:solidFill>
+            <a:prstDash val="solid"/>
+          </a:ln>
+        </p:spPr>
+      </p:sp>
+    </p:spTree>
+    <p:extLst>
+      <p:ext uri="{BB962C8B-B14F-4D97-AF65-F5344CB8AC3E}">
+        <p14:creationId xmlns:p14="http://schemas.microsoft.com/office/powerpoint/2010/main" val="887115630"/>
+      </p:ext>
+    </p:extLst>
+  </p:cSld>
+</p:sld>
+</file>
+
+<file path=ppt/slides/slide6.xml><?xml version="1.0" encoding="utf-8"?>
+<p:sld xmlns:p="http://schemas.openxmlformats.org/presentationml/2006/main">
+  <p:cSld>
+    <p:spTree>
+      <p:nvGrpSpPr>
+        <p:cNvPr id="1" name=""/>
+        <p:cNvGrpSpPr/>
+        <p:nvPr/>
+      </p:nvGrpSpPr>
+      <p:grpSpPr>
+        <a:xfrm xmlns:a="http://schemas.openxmlformats.org/drawingml/2006/main"/>
+      </p:grpSpPr>
+      <p:sp>
+        <p:nvSpPr>
+          <p:cNvPr id="1" name="">
+            <a:extLst xmlns:a="http://schemas.openxmlformats.org/drawingml/2006/main">
+              <a:ext uri="{FF2B5EF4-FFF2-40B4-BE49-F238E27FC236}">
+                <a16:creationId xmlns:a16="http://schemas.microsoft.com/office/drawing/2014/main" id="{D3C25145-C1DA-4F9E-9FA9-0AA1D5402711}"/>
+              </a:ext>
+            </a:extLst>
+          </p:cNvPr>
+          <p:cNvSpPr>
+            <a:spLocks xmlns:a="http://schemas.openxmlformats.org/drawingml/2006/main" noGrp="1"/>
+          </p:cNvSpPr>
+          <p:nvPr/>
+        </p:nvSpPr>
+        <p:spPr>
+          <a:xfrm xmlns:a="http://schemas.openxmlformats.org/drawingml/2006/main">
+            <a:off x="0" y="0"/>
+            <a:ext cx="12192000" cy="6858000"/>
+          </a:xfrm>
+          <a:prstGeom xmlns:a="http://schemas.openxmlformats.org/drawingml/2006/main" prst="rect">
+            <a:avLst/>
+          </a:prstGeom>
+          <a:solidFill xmlns:a="http://schemas.openxmlformats.org/drawingml/2006/main">
+            <a:srgbClr val="F7F3EA"/>
+          </a:solidFill>
+          <a:ln xmlns:a="http://schemas.openxmlformats.org/drawingml/2006/main" w="0">
+            <a:solidFill>
+              <a:srgbClr val="000000">
+                <a:alpha val="0"/>
+              </a:srgbClr>
+            </a:solidFill>
+            <a:prstDash val="solid"/>
+          </a:ln>
+        </p:spPr>
+      </p:sp>
+      <p:sp>
+        <p:nvSpPr>
+          <p:cNvPr id="2" name="kicker-marker">
+            <a:extLst xmlns:a="http://schemas.openxmlformats.org/drawingml/2006/main">
+              <a:ext uri="{FF2B5EF4-FFF2-40B4-BE49-F238E27FC236}">
+                <a16:creationId xmlns:a16="http://schemas.microsoft.com/office/drawing/2014/main" id="{2E15FD38-B1A5-4AEF-8DF5-C794F8767DA7}"/>
+              </a:ext>
+            </a:extLst>
+          </p:cNvPr>
+          <p:cNvSpPr>
+            <a:spLocks xmlns:a="http://schemas.openxmlformats.org/drawingml/2006/main" noGrp="1"/>
+          </p:cNvSpPr>
+          <p:nvPr/>
+        </p:nvSpPr>
+        <p:spPr>
+          <a:xfrm xmlns:a="http://schemas.openxmlformats.org/drawingml/2006/main">
+            <a:off x="666750" y="514350"/>
+            <a:ext cx="85725" cy="85725"/>
+          </a:xfrm>
+          <a:prstGeom xmlns:a="http://schemas.openxmlformats.org/drawingml/2006/main" prst="rect">
+            <a:avLst/>
+          </a:prstGeom>
+          <a:solidFill xmlns:a="http://schemas.openxmlformats.org/drawingml/2006/main">
+            <a:srgbClr val="D89C27"/>
+          </a:solidFill>
+          <a:ln xmlns:a="http://schemas.openxmlformats.org/drawingml/2006/main" w="0">
+            <a:solidFill>
+              <a:srgbClr val="000000">
+                <a:alpha val="0"/>
+              </a:srgbClr>
+            </a:solidFill>
+            <a:prstDash val="solid"/>
+          </a:ln>
+        </p:spPr>
+      </p:sp>
+      <p:sp>
+        <p:nvSpPr>
+          <p:cNvPr id="3" name="kicker-label">
+            <a:extLst xmlns:a="http://schemas.openxmlformats.org/drawingml/2006/main">
+              <a:ext uri="{FF2B5EF4-FFF2-40B4-BE49-F238E27FC236}">
+                <a16:creationId xmlns:a16="http://schemas.microsoft.com/office/drawing/2014/main" id="{28746954-358C-43E9-9EAC-71BE6C519E42}"/>
+              </a:ext>
+            </a:extLst>
+          </p:cNvPr>
+          <p:cNvSpPr>
+            <a:spLocks xmlns:a="http://schemas.openxmlformats.org/drawingml/2006/main" noGrp="1"/>
+          </p:cNvSpPr>
+          <p:nvPr/>
+        </p:nvSpPr>
+        <p:spPr>
+          <a:xfrm xmlns:a="http://schemas.openxmlformats.org/drawingml/2006/main">
+            <a:off x="876300" y="438150"/>
+            <a:ext cx="2857500" cy="266700"/>
+          </a:xfrm>
+          <a:prstGeom xmlns:a="http://schemas.openxmlformats.org/drawingml/2006/main" prst="rect">
+            <a:avLst/>
+          </a:prstGeom>
+          <a:solidFill xmlns:a="http://schemas.openxmlformats.org/drawingml/2006/main">
+            <a:srgbClr val="000000">
+              <a:alpha val="0"/>
+            </a:srgbClr>
+          </a:solidFill>
+          <a:ln xmlns:a="http://schemas.openxmlformats.org/drawingml/2006/main" w="0">
+            <a:solidFill>
+              <a:srgbClr val="000000">
+                <a:alpha val="0"/>
+              </a:srgbClr>
+            </a:solidFill>
+            <a:prstDash val="solid"/>
+          </a:ln>
+        </p:spPr>
+        <p:txBody>
+          <a:bodyPr xmlns:a="http://schemas.openxmlformats.org/drawingml/2006/main" lIns="0" tIns="0" rIns="0" bIns="0" anchor="ctr"/>
           <a:lstStyle xmlns:a="http://schemas.openxmlformats.org/drawingml/2006/main"/>
           <a:p xmlns:a="http://schemas.openxmlformats.org/drawingml/2006/main">
             <a:pPr algn="l">
-              <a:defRPr sz="1350" b="1">
+              <a:defRPr sz="1050" b="1">
                 <a:solidFill>
                   <a:srgbClr val="0E7C66"/>
                 </a:solidFill>
-                <a:latin typeface="Aptos Mono"/>
-                <a:ea typeface="Aptos Mono"/>
-                <a:cs typeface="Aptos Mono"/>
+                <a:latin typeface="Aptos"/>
+                <a:ea typeface="Aptos"/>
+                <a:cs typeface="Aptos"/>
               </a:defRPr>
             </a:pPr>
             <a:r>
-              <a:rPr sz="1350" b="1">
+              <a:rPr sz="1050" b="1">
                 <a:solidFill>
                   <a:srgbClr val="0E7C66"/>
                 </a:solidFill>
-                <a:latin typeface="Aptos Mono"/>
-                <a:ea typeface="Aptos Mono"/>
-                <a:cs typeface="Aptos Mono"/>
+                <a:latin typeface="Aptos"/>
+                <a:ea typeface="Aptos"/>
+                <a:cs typeface="Aptos"/>
               </a:rPr>
-              <a:t>0:00-0:15</a:t>
+              <a:t>UI WALKTHROUGH 2</a:t>
             </a:r>
           </a:p>
         </p:txBody>
       </p:sp>
       <p:sp>
         <p:nvSpPr>
-          <p:cNvPr id="8" name="">
-            <a:extLst xmlns:a="http://schemas.openxmlformats.org/drawingml/2006/main">
-              <a:ext uri="{FF2B5EF4-FFF2-40B4-BE49-F238E27FC236}">
-                <a16:creationId xmlns:a16="http://schemas.microsoft.com/office/drawing/2014/main" id="{AF883502-2DCF-47F3-8503-2CAC98F0A8FC}"/>
-              </a:ext>
-            </a:extLst>
-          </p:cNvPr>
-          <p:cNvSpPr>
-            <a:spLocks xmlns:a="http://schemas.openxmlformats.org/drawingml/2006/main" noGrp="1"/>
-          </p:cNvSpPr>
-          <p:nvPr/>
-        </p:nvSpPr>
-        <p:spPr>
-          <a:xfrm xmlns:a="http://schemas.openxmlformats.org/drawingml/2006/main">
-            <a:off x="2400300" y="2495550"/>
-            <a:ext cx="419100" cy="19050"/>
-          </a:xfrm>
-          <a:prstGeom xmlns:a="http://schemas.openxmlformats.org/drawingml/2006/main" prst="rect">
-            <a:avLst/>
-          </a:prstGeom>
-          <a:solidFill xmlns:a="http://schemas.openxmlformats.org/drawingml/2006/main">
-            <a:srgbClr val="D8D0C0"/>
-          </a:solidFill>
-          <a:ln xmlns:a="http://schemas.openxmlformats.org/drawingml/2006/main" w="0">
-            <a:solidFill>
-              <a:srgbClr val="000000">
-                <a:alpha val="0"/>
-              </a:srgbClr>
-            </a:solidFill>
-            <a:prstDash val="solid"/>
-          </a:ln>
-        </p:spPr>
-      </p:sp>
-      <p:sp>
-        <p:nvSpPr>
-          <p:cNvPr id="9" name="">
-            <a:extLst xmlns:a="http://schemas.openxmlformats.org/drawingml/2006/main">
-              <a:ext uri="{FF2B5EF4-FFF2-40B4-BE49-F238E27FC236}">
-                <a16:creationId xmlns:a16="http://schemas.microsoft.com/office/drawing/2014/main" id="{A459B96E-D0A4-4E90-A1BE-21960BF97373}"/>
-              </a:ext>
-            </a:extLst>
-          </p:cNvPr>
-          <p:cNvSpPr>
-            <a:spLocks xmlns:a="http://schemas.openxmlformats.org/drawingml/2006/main" noGrp="1"/>
-          </p:cNvSpPr>
-          <p:nvPr/>
-        </p:nvSpPr>
-        <p:spPr>
-          <a:xfrm xmlns:a="http://schemas.openxmlformats.org/drawingml/2006/main">
-            <a:off x="3143250" y="2343150"/>
-            <a:ext cx="2095500" cy="304800"/>
+          <p:cNvPr id="4" name="">
+            <a:extLst xmlns:a="http://schemas.openxmlformats.org/drawingml/2006/main">
+              <a:ext uri="{FF2B5EF4-FFF2-40B4-BE49-F238E27FC236}">
+                <a16:creationId xmlns:a16="http://schemas.microsoft.com/office/drawing/2014/main" id="{15F9CEB0-B6A9-4346-9CC4-FB103578B947}"/>
+              </a:ext>
+            </a:extLst>
+          </p:cNvPr>
+          <p:cNvSpPr>
+            <a:spLocks xmlns:a="http://schemas.openxmlformats.org/drawingml/2006/main" noGrp="1"/>
+          </p:cNvSpPr>
+          <p:nvPr/>
+        </p:nvSpPr>
+        <p:spPr>
+          <a:xfrm xmlns:a="http://schemas.openxmlformats.org/drawingml/2006/main">
+            <a:off x="666750" y="914400"/>
+            <a:ext cx="9906000" cy="590550"/>
           </a:xfrm>
           <a:prstGeom xmlns:a="http://schemas.openxmlformats.org/drawingml/2006/main" prst="rect">
             <a:avLst/>
@@ -6749,47 +6997,82 @@
           <a:lstStyle xmlns:a="http://schemas.openxmlformats.org/drawingml/2006/main"/>
           <a:p xmlns:a="http://schemas.openxmlformats.org/drawingml/2006/main">
             <a:pPr algn="l">
-              <a:defRPr sz="1800" b="1">
+              <a:defRPr sz="2475" b="1">
                 <a:solidFill>
                   <a:srgbClr val="14213D"/>
                 </a:solidFill>
-                <a:latin typeface="Aptos"/>
-                <a:ea typeface="Aptos"/>
-                <a:cs typeface="Aptos"/>
+                <a:latin typeface="Aptos Display"/>
+                <a:ea typeface="Aptos Display"/>
+                <a:cs typeface="Aptos Display"/>
               </a:defRPr>
             </a:pPr>
             <a:r>
-              <a:rPr sz="1800" b="1">
+              <a:rPr sz="2475" b="1">
                 <a:solidFill>
                   <a:srgbClr val="14213D"/>
                 </a:solidFill>
-                <a:latin typeface="Aptos"/>
-                <a:ea typeface="Aptos"/>
-                <a:cs typeface="Aptos"/>
+                <a:latin typeface="Aptos Display"/>
+                <a:ea typeface="Aptos Display"/>
+                <a:cs typeface="Aptos Display"/>
               </a:rPr>
-              <a:t>Open app</a:t>
+              <a:t>The evaluation tab compares SynthAML’s guided data against the simple baseline.</a:t>
             </a:r>
           </a:p>
         </p:txBody>
       </p:sp>
       <p:sp>
         <p:nvSpPr>
-          <p:cNvPr id="10" name="">
-            <a:extLst xmlns:a="http://schemas.openxmlformats.org/drawingml/2006/main">
-              <a:ext uri="{FF2B5EF4-FFF2-40B4-BE49-F238E27FC236}">
-                <a16:creationId xmlns:a16="http://schemas.microsoft.com/office/drawing/2014/main" id="{02CF1FF6-C65F-477E-93EE-B08EBC48EA09}"/>
-              </a:ext>
-            </a:extLst>
-          </p:cNvPr>
-          <p:cNvSpPr>
-            <a:spLocks xmlns:a="http://schemas.openxmlformats.org/drawingml/2006/main" noGrp="1"/>
-          </p:cNvSpPr>
-          <p:nvPr/>
-        </p:nvSpPr>
-        <p:spPr>
-          <a:xfrm xmlns:a="http://schemas.openxmlformats.org/drawingml/2006/main">
-            <a:off x="5429250" y="2381250"/>
-            <a:ext cx="4953000" cy="400050"/>
+          <p:cNvPr id="5" name="">
+            <a:extLst xmlns:a="http://schemas.openxmlformats.org/drawingml/2006/main">
+              <a:ext uri="{FF2B5EF4-FFF2-40B4-BE49-F238E27FC236}">
+                <a16:creationId xmlns:a16="http://schemas.microsoft.com/office/drawing/2014/main" id="{086A01ED-82FB-4A2D-AE04-759F88CB1026}"/>
+              </a:ext>
+            </a:extLst>
+          </p:cNvPr>
+          <p:cNvSpPr>
+            <a:spLocks xmlns:a="http://schemas.openxmlformats.org/drawingml/2006/main" noGrp="1"/>
+          </p:cNvSpPr>
+          <p:nvPr/>
+        </p:nvSpPr>
+        <p:spPr>
+          <a:xfrm xmlns:a="http://schemas.openxmlformats.org/drawingml/2006/main">
+            <a:off x="666750" y="6343650"/>
+            <a:ext cx="10858500" cy="9525"/>
+          </a:xfrm>
+          <a:prstGeom xmlns:a="http://schemas.openxmlformats.org/drawingml/2006/main" prst="rect">
+            <a:avLst/>
+          </a:prstGeom>
+          <a:solidFill xmlns:a="http://schemas.openxmlformats.org/drawingml/2006/main">
+            <a:srgbClr val="D8D0C0"/>
+          </a:solidFill>
+          <a:ln xmlns:a="http://schemas.openxmlformats.org/drawingml/2006/main" w="0">
+            <a:solidFill>
+              <a:srgbClr val="000000">
+                <a:alpha val="0"/>
+              </a:srgbClr>
+            </a:solidFill>
+            <a:prstDash val="solid"/>
+          </a:ln>
+        </p:spPr>
+      </p:sp>
+      <p:sp>
+        <p:nvSpPr>
+          <p:cNvPr id="6" name="">
+            <a:extLst xmlns:a="http://schemas.openxmlformats.org/drawingml/2006/main">
+              <a:ext uri="{FF2B5EF4-FFF2-40B4-BE49-F238E27FC236}">
+                <a16:creationId xmlns:a16="http://schemas.microsoft.com/office/drawing/2014/main" id="{F8D5C591-BE96-43E7-A2C8-A2AADB08B584}"/>
+              </a:ext>
+            </a:extLst>
+          </p:cNvPr>
+          <p:cNvSpPr>
+            <a:spLocks xmlns:a="http://schemas.openxmlformats.org/drawingml/2006/main" noGrp="1"/>
+          </p:cNvSpPr>
+          <p:nvPr/>
+        </p:nvSpPr>
+        <p:spPr>
+          <a:xfrm xmlns:a="http://schemas.openxmlformats.org/drawingml/2006/main">
+            <a:off x="666750" y="6457950"/>
+            <a:ext cx="3238500" cy="190500"/>
           </a:xfrm>
           <a:prstGeom xmlns:a="http://schemas.openxmlformats.org/drawingml/2006/main" prst="rect">
             <a:avLst/>
@@ -6813,9 +7096,9 @@
           <a:lstStyle xmlns:a="http://schemas.openxmlformats.org/drawingml/2006/main"/>
           <a:p xmlns:a="http://schemas.openxmlformats.org/drawingml/2006/main">
             <a:pPr algn="l">
-              <a:defRPr sz="1275" b="0">
-                <a:solidFill>
-                  <a:srgbClr val="4D4A43"/>
+              <a:defRPr sz="825" b="0">
+                <a:solidFill>
+                  <a:srgbClr val="6E6A61"/>
                 </a:solidFill>
                 <a:latin typeface="Aptos"/>
                 <a:ea typeface="Aptos"/>
@@ -6823,37 +7106,59 @@
               </a:defRPr>
             </a:pPr>
             <a:r>
-              <a:rPr sz="1275" b="0">
-                <a:solidFill>
-                  <a:srgbClr val="4D4A43"/>
+              <a:rPr sz="825" b="0">
+                <a:solidFill>
+                  <a:srgbClr val="6E6A61"/>
                 </a:solidFill>
                 <a:latin typeface="Aptos"/>
                 <a:ea typeface="Aptos"/>
                 <a:cs typeface="Aptos"/>
               </a:rPr>
-              <a:t>Show SynthAML running at localhost and the sample warning text.</a:t>
+              <a:t>Artifact walkthrough | 5</a:t>
             </a:r>
           </a:p>
         </p:txBody>
       </p:sp>
-      <p:sp>
-        <p:nvSpPr>
-          <p:cNvPr id="11" name="">
-            <a:extLst xmlns:a="http://schemas.openxmlformats.org/drawingml/2006/main">
-              <a:ext uri="{FF2B5EF4-FFF2-40B4-BE49-F238E27FC236}">
-                <a16:creationId xmlns:a16="http://schemas.microsoft.com/office/drawing/2014/main" id="{FE60DBCC-29BC-42BE-8F3C-43EAA7AE96F3}"/>
-              </a:ext>
-            </a:extLst>
-          </p:cNvPr>
-          <p:cNvSpPr>
-            <a:spLocks xmlns:a="http://schemas.openxmlformats.org/drawingml/2006/main" noGrp="1"/>
-          </p:cNvSpPr>
-          <p:nvPr/>
-        </p:nvSpPr>
-        <p:spPr>
-          <a:xfrm xmlns:a="http://schemas.openxmlformats.org/drawingml/2006/main">
-            <a:off x="914400" y="3200400"/>
-            <a:ext cx="1200150" cy="266700"/>
+      <p:pic>
+        <p:nvPicPr>
+          <p:cNvPr id="7" name=""/>
+          <p:cNvPicPr>
+            <a:picLocks xmlns:a="http://schemas.openxmlformats.org/drawingml/2006/main" noChangeAspect="1"/>
+          </p:cNvPicPr>
+          <p:nvPr/>
+        </p:nvPicPr>
+        <p:blipFill>
+          <a:blip xmlns:r="http://schemas.openxmlformats.org/officeDocument/2006/relationships" xmlns:a="http://schemas.openxmlformats.org/drawingml/2006/main" r:embed="R2f4c99d407004046"/>
+          <a:stretch xmlns:a="http://schemas.openxmlformats.org/drawingml/2006/main"/>
+        </p:blipFill>
+        <p:spPr>
+          <a:xfrm xmlns:a="http://schemas.openxmlformats.org/drawingml/2006/main">
+            <a:off x="2201333" y="1714500"/>
+            <a:ext cx="7789333" cy="4381500"/>
+          </a:xfrm>
+          <a:prstGeom xmlns:a="http://schemas.openxmlformats.org/drawingml/2006/main" prst="rect">
+            <a:avLst/>
+          </a:prstGeom>
+        </p:spPr>
+      </p:pic>
+      <p:sp>
+        <p:nvSpPr>
+          <p:cNvPr id="8" name="">
+            <a:extLst xmlns:a="http://schemas.openxmlformats.org/drawingml/2006/main">
+              <a:ext uri="{FF2B5EF4-FFF2-40B4-BE49-F238E27FC236}">
+                <a16:creationId xmlns:a16="http://schemas.microsoft.com/office/drawing/2014/main" id="{6DE34F63-AD7C-4BC2-88E4-275CF27B60AE}"/>
+              </a:ext>
+            </a:extLst>
+          </p:cNvPr>
+          <p:cNvSpPr>
+            <a:spLocks xmlns:a="http://schemas.openxmlformats.org/drawingml/2006/main" noGrp="1"/>
+          </p:cNvSpPr>
+          <p:nvPr/>
+        </p:nvSpPr>
+        <p:spPr>
+          <a:xfrm xmlns:a="http://schemas.openxmlformats.org/drawingml/2006/main">
+            <a:off x="2200275" y="1714500"/>
+            <a:ext cx="7791450" cy="4381500"/>
           </a:xfrm>
           <a:prstGeom xmlns:a="http://schemas.openxmlformats.org/drawingml/2006/main" prst="rect">
             <a:avLst/>
@@ -6863,96 +7168,188 @@
               <a:alpha val="0"/>
             </a:srgbClr>
           </a:solidFill>
-          <a:ln xmlns:a="http://schemas.openxmlformats.org/drawingml/2006/main" w="0">
-            <a:solidFill>
-              <a:srgbClr val="000000">
-                <a:alpha val="0"/>
-              </a:srgbClr>
-            </a:solidFill>
-            <a:prstDash val="solid"/>
-          </a:ln>
-        </p:spPr>
-        <p:txBody>
-          <a:bodyPr xmlns:a="http://schemas.openxmlformats.org/drawingml/2006/main" lIns="0" tIns="0" rIns="0" bIns="0" anchor="t"/>
+          <a:ln xmlns:a="http://schemas.openxmlformats.org/drawingml/2006/main" w="9525">
+            <a:solidFill>
+              <a:srgbClr val="D8D0C0"/>
+            </a:solidFill>
+            <a:prstDash val="solid"/>
+          </a:ln>
+        </p:spPr>
+      </p:sp>
+    </p:spTree>
+    <p:extLst>
+      <p:ext uri="{BB962C8B-B14F-4D97-AF65-F5344CB8AC3E}">
+        <p14:creationId xmlns:p14="http://schemas.microsoft.com/office/powerpoint/2010/main" val="1212798690"/>
+      </p:ext>
+    </p:extLst>
+  </p:cSld>
+</p:sld>
+</file>
+
+<file path=ppt/slides/slide7.xml><?xml version="1.0" encoding="utf-8"?>
+<p:sld xmlns:p="http://schemas.openxmlformats.org/presentationml/2006/main">
+  <p:cSld>
+    <p:spTree>
+      <p:nvGrpSpPr>
+        <p:cNvPr id="1" name=""/>
+        <p:cNvGrpSpPr/>
+        <p:nvPr/>
+      </p:nvGrpSpPr>
+      <p:grpSpPr>
+        <a:xfrm xmlns:a="http://schemas.openxmlformats.org/drawingml/2006/main"/>
+      </p:grpSpPr>
+      <p:sp>
+        <p:nvSpPr>
+          <p:cNvPr id="1" name="">
+            <a:extLst xmlns:a="http://schemas.openxmlformats.org/drawingml/2006/main">
+              <a:ext uri="{FF2B5EF4-FFF2-40B4-BE49-F238E27FC236}">
+                <a16:creationId xmlns:a16="http://schemas.microsoft.com/office/drawing/2014/main" id="{41EAC072-E739-4112-A856-F14C66671C57}"/>
+              </a:ext>
+            </a:extLst>
+          </p:cNvPr>
+          <p:cNvSpPr>
+            <a:spLocks xmlns:a="http://schemas.openxmlformats.org/drawingml/2006/main" noGrp="1"/>
+          </p:cNvSpPr>
+          <p:nvPr/>
+        </p:nvSpPr>
+        <p:spPr>
+          <a:xfrm xmlns:a="http://schemas.openxmlformats.org/drawingml/2006/main">
+            <a:off x="0" y="0"/>
+            <a:ext cx="12192000" cy="6858000"/>
+          </a:xfrm>
+          <a:prstGeom xmlns:a="http://schemas.openxmlformats.org/drawingml/2006/main" prst="rect">
+            <a:avLst/>
+          </a:prstGeom>
+          <a:solidFill xmlns:a="http://schemas.openxmlformats.org/drawingml/2006/main">
+            <a:srgbClr val="F7F3EA"/>
+          </a:solidFill>
+          <a:ln xmlns:a="http://schemas.openxmlformats.org/drawingml/2006/main" w="0">
+            <a:solidFill>
+              <a:srgbClr val="000000">
+                <a:alpha val="0"/>
+              </a:srgbClr>
+            </a:solidFill>
+            <a:prstDash val="solid"/>
+          </a:ln>
+        </p:spPr>
+      </p:sp>
+      <p:sp>
+        <p:nvSpPr>
+          <p:cNvPr id="2" name="kicker-marker">
+            <a:extLst xmlns:a="http://schemas.openxmlformats.org/drawingml/2006/main">
+              <a:ext uri="{FF2B5EF4-FFF2-40B4-BE49-F238E27FC236}">
+                <a16:creationId xmlns:a16="http://schemas.microsoft.com/office/drawing/2014/main" id="{777F29EA-02BE-45F2-ABE0-1A0DA5D22393}"/>
+              </a:ext>
+            </a:extLst>
+          </p:cNvPr>
+          <p:cNvSpPr>
+            <a:spLocks xmlns:a="http://schemas.openxmlformats.org/drawingml/2006/main" noGrp="1"/>
+          </p:cNvSpPr>
+          <p:nvPr/>
+        </p:nvSpPr>
+        <p:spPr>
+          <a:xfrm xmlns:a="http://schemas.openxmlformats.org/drawingml/2006/main">
+            <a:off x="666750" y="514350"/>
+            <a:ext cx="85725" cy="85725"/>
+          </a:xfrm>
+          <a:prstGeom xmlns:a="http://schemas.openxmlformats.org/drawingml/2006/main" prst="rect">
+            <a:avLst/>
+          </a:prstGeom>
+          <a:solidFill xmlns:a="http://schemas.openxmlformats.org/drawingml/2006/main">
+            <a:srgbClr val="D89C27"/>
+          </a:solidFill>
+          <a:ln xmlns:a="http://schemas.openxmlformats.org/drawingml/2006/main" w="0">
+            <a:solidFill>
+              <a:srgbClr val="000000">
+                <a:alpha val="0"/>
+              </a:srgbClr>
+            </a:solidFill>
+            <a:prstDash val="solid"/>
+          </a:ln>
+        </p:spPr>
+      </p:sp>
+      <p:sp>
+        <p:nvSpPr>
+          <p:cNvPr id="3" name="kicker-label">
+            <a:extLst xmlns:a="http://schemas.openxmlformats.org/drawingml/2006/main">
+              <a:ext uri="{FF2B5EF4-FFF2-40B4-BE49-F238E27FC236}">
+                <a16:creationId xmlns:a16="http://schemas.microsoft.com/office/drawing/2014/main" id="{1DDBEB07-32C1-4F90-A806-A6216037E99D}"/>
+              </a:ext>
+            </a:extLst>
+          </p:cNvPr>
+          <p:cNvSpPr>
+            <a:spLocks xmlns:a="http://schemas.openxmlformats.org/drawingml/2006/main" noGrp="1"/>
+          </p:cNvSpPr>
+          <p:nvPr/>
+        </p:nvSpPr>
+        <p:spPr>
+          <a:xfrm xmlns:a="http://schemas.openxmlformats.org/drawingml/2006/main">
+            <a:off x="876300" y="438150"/>
+            <a:ext cx="2857500" cy="266700"/>
+          </a:xfrm>
+          <a:prstGeom xmlns:a="http://schemas.openxmlformats.org/drawingml/2006/main" prst="rect">
+            <a:avLst/>
+          </a:prstGeom>
+          <a:solidFill xmlns:a="http://schemas.openxmlformats.org/drawingml/2006/main">
+            <a:srgbClr val="000000">
+              <a:alpha val="0"/>
+            </a:srgbClr>
+          </a:solidFill>
+          <a:ln xmlns:a="http://schemas.openxmlformats.org/drawingml/2006/main" w="0">
+            <a:solidFill>
+              <a:srgbClr val="000000">
+                <a:alpha val="0"/>
+              </a:srgbClr>
+            </a:solidFill>
+            <a:prstDash val="solid"/>
+          </a:ln>
+        </p:spPr>
+        <p:txBody>
+          <a:bodyPr xmlns:a="http://schemas.openxmlformats.org/drawingml/2006/main" lIns="0" tIns="0" rIns="0" bIns="0" anchor="ctr"/>
           <a:lstStyle xmlns:a="http://schemas.openxmlformats.org/drawingml/2006/main"/>
           <a:p xmlns:a="http://schemas.openxmlformats.org/drawingml/2006/main">
             <a:pPr algn="l">
-              <a:defRPr sz="1350" b="1">
+              <a:defRPr sz="1050" b="1">
                 <a:solidFill>
                   <a:srgbClr val="0E7C66"/>
                 </a:solidFill>
-                <a:latin typeface="Aptos Mono"/>
-                <a:ea typeface="Aptos Mono"/>
-                <a:cs typeface="Aptos Mono"/>
+                <a:latin typeface="Aptos"/>
+                <a:ea typeface="Aptos"/>
+                <a:cs typeface="Aptos"/>
               </a:defRPr>
             </a:pPr>
             <a:r>
-              <a:rPr sz="1350" b="1">
+              <a:rPr sz="1050" b="1">
                 <a:solidFill>
                   <a:srgbClr val="0E7C66"/>
                 </a:solidFill>
-                <a:latin typeface="Aptos Mono"/>
-                <a:ea typeface="Aptos Mono"/>
-                <a:cs typeface="Aptos Mono"/>
+                <a:latin typeface="Aptos"/>
+                <a:ea typeface="Aptos"/>
+                <a:cs typeface="Aptos"/>
               </a:rPr>
-              <a:t>0:15-0:30</a:t>
+              <a:t>UI WALKTHROUGH 3</a:t>
             </a:r>
           </a:p>
         </p:txBody>
       </p:sp>
       <p:sp>
         <p:nvSpPr>
-          <p:cNvPr id="12" name="">
-            <a:extLst xmlns:a="http://schemas.openxmlformats.org/drawingml/2006/main">
-              <a:ext uri="{FF2B5EF4-FFF2-40B4-BE49-F238E27FC236}">
-                <a16:creationId xmlns:a16="http://schemas.microsoft.com/office/drawing/2014/main" id="{D943F78B-CEE6-4A9B-9813-D0C632FBFA51}"/>
-              </a:ext>
-            </a:extLst>
-          </p:cNvPr>
-          <p:cNvSpPr>
-            <a:spLocks xmlns:a="http://schemas.openxmlformats.org/drawingml/2006/main" noGrp="1"/>
-          </p:cNvSpPr>
-          <p:nvPr/>
-        </p:nvSpPr>
-        <p:spPr>
-          <a:xfrm xmlns:a="http://schemas.openxmlformats.org/drawingml/2006/main">
-            <a:off x="2400300" y="3314700"/>
-            <a:ext cx="419100" cy="19050"/>
-          </a:xfrm>
-          <a:prstGeom xmlns:a="http://schemas.openxmlformats.org/drawingml/2006/main" prst="rect">
-            <a:avLst/>
-          </a:prstGeom>
-          <a:solidFill xmlns:a="http://schemas.openxmlformats.org/drawingml/2006/main">
-            <a:srgbClr val="D8D0C0"/>
-          </a:solidFill>
-          <a:ln xmlns:a="http://schemas.openxmlformats.org/drawingml/2006/main" w="0">
-            <a:solidFill>
-              <a:srgbClr val="000000">
-                <a:alpha val="0"/>
-              </a:srgbClr>
-            </a:solidFill>
-            <a:prstDash val="solid"/>
-          </a:ln>
-        </p:spPr>
-      </p:sp>
-      <p:sp>
-        <p:nvSpPr>
-          <p:cNvPr id="13" name="">
-            <a:extLst xmlns:a="http://schemas.openxmlformats.org/drawingml/2006/main">
-              <a:ext uri="{FF2B5EF4-FFF2-40B4-BE49-F238E27FC236}">
-                <a16:creationId xmlns:a16="http://schemas.microsoft.com/office/drawing/2014/main" id="{97DCD3AB-AD77-4044-ADE6-9B572786FCE4}"/>
-              </a:ext>
-            </a:extLst>
-          </p:cNvPr>
-          <p:cNvSpPr>
-            <a:spLocks xmlns:a="http://schemas.openxmlformats.org/drawingml/2006/main" noGrp="1"/>
-          </p:cNvSpPr>
-          <p:nvPr/>
-        </p:nvSpPr>
-        <p:spPr>
-          <a:xfrm xmlns:a="http://schemas.openxmlformats.org/drawingml/2006/main">
-            <a:off x="3143250" y="3162300"/>
-            <a:ext cx="2095500" cy="304800"/>
+          <p:cNvPr id="4" name="">
+            <a:extLst xmlns:a="http://schemas.openxmlformats.org/drawingml/2006/main">
+              <a:ext uri="{FF2B5EF4-FFF2-40B4-BE49-F238E27FC236}">
+                <a16:creationId xmlns:a16="http://schemas.microsoft.com/office/drawing/2014/main" id="{6EB7FDB9-1F28-4E02-9352-940FAC9FBCBD}"/>
+              </a:ext>
+            </a:extLst>
+          </p:cNvPr>
+          <p:cNvSpPr>
+            <a:spLocks xmlns:a="http://schemas.openxmlformats.org/drawingml/2006/main" noGrp="1"/>
+          </p:cNvSpPr>
+          <p:nvPr/>
+        </p:nvSpPr>
+        <p:spPr>
+          <a:xfrm xmlns:a="http://schemas.openxmlformats.org/drawingml/2006/main">
+            <a:off x="666750" y="914400"/>
+            <a:ext cx="9906000" cy="590550"/>
           </a:xfrm>
           <a:prstGeom xmlns:a="http://schemas.openxmlformats.org/drawingml/2006/main" prst="rect">
             <a:avLst/>
@@ -6976,47 +7373,82 @@
           <a:lstStyle xmlns:a="http://schemas.openxmlformats.org/drawingml/2006/main"/>
           <a:p xmlns:a="http://schemas.openxmlformats.org/drawingml/2006/main">
             <a:pPr algn="l">
-              <a:defRPr sz="1800" b="1">
+              <a:defRPr sz="2475" b="1">
                 <a:solidFill>
                   <a:srgbClr val="14213D"/>
                 </a:solidFill>
-                <a:latin typeface="Aptos"/>
-                <a:ea typeface="Aptos"/>
-                <a:cs typeface="Aptos"/>
+                <a:latin typeface="Aptos Display"/>
+                <a:ea typeface="Aptos Display"/>
+                <a:cs typeface="Aptos Display"/>
               </a:defRPr>
             </a:pPr>
             <a:r>
-              <a:rPr sz="1800" b="1">
+              <a:rPr sz="2475" b="1">
                 <a:solidFill>
                   <a:srgbClr val="14213D"/>
                 </a:solidFill>
-                <a:latin typeface="Aptos"/>
-                <a:ea typeface="Aptos"/>
-                <a:cs typeface="Aptos"/>
+                <a:latin typeface="Aptos Display"/>
+                <a:ea typeface="Aptos Display"/>
+                <a:cs typeface="Aptos Display"/>
               </a:rPr>
-              <a:t>Inspect typology</a:t>
+              <a:t>The export package gives the user guided data, baseline data, and evaluation JSON.</a:t>
             </a:r>
           </a:p>
         </p:txBody>
       </p:sp>
       <p:sp>
         <p:nvSpPr>
-          <p:cNvPr id="14" name="">
-            <a:extLst xmlns:a="http://schemas.openxmlformats.org/drawingml/2006/main">
-              <a:ext uri="{FF2B5EF4-FFF2-40B4-BE49-F238E27FC236}">
-                <a16:creationId xmlns:a16="http://schemas.microsoft.com/office/drawing/2014/main" id="{667B9C03-FE1E-4BC8-93F4-9B60DD486548}"/>
-              </a:ext>
-            </a:extLst>
-          </p:cNvPr>
-          <p:cNvSpPr>
-            <a:spLocks xmlns:a="http://schemas.openxmlformats.org/drawingml/2006/main" noGrp="1"/>
-          </p:cNvSpPr>
-          <p:nvPr/>
-        </p:nvSpPr>
-        <p:spPr>
-          <a:xfrm xmlns:a="http://schemas.openxmlformats.org/drawingml/2006/main">
-            <a:off x="5429250" y="3200400"/>
-            <a:ext cx="4953000" cy="400050"/>
+          <p:cNvPr id="5" name="">
+            <a:extLst xmlns:a="http://schemas.openxmlformats.org/drawingml/2006/main">
+              <a:ext uri="{FF2B5EF4-FFF2-40B4-BE49-F238E27FC236}">
+                <a16:creationId xmlns:a16="http://schemas.microsoft.com/office/drawing/2014/main" id="{77D40310-1ECC-4114-8380-FD28DC71E9A7}"/>
+              </a:ext>
+            </a:extLst>
+          </p:cNvPr>
+          <p:cNvSpPr>
+            <a:spLocks xmlns:a="http://schemas.openxmlformats.org/drawingml/2006/main" noGrp="1"/>
+          </p:cNvSpPr>
+          <p:nvPr/>
+        </p:nvSpPr>
+        <p:spPr>
+          <a:xfrm xmlns:a="http://schemas.openxmlformats.org/drawingml/2006/main">
+            <a:off x="666750" y="6343650"/>
+            <a:ext cx="10858500" cy="9525"/>
+          </a:xfrm>
+          <a:prstGeom xmlns:a="http://schemas.openxmlformats.org/drawingml/2006/main" prst="rect">
+            <a:avLst/>
+          </a:prstGeom>
+          <a:solidFill xmlns:a="http://schemas.openxmlformats.org/drawingml/2006/main">
+            <a:srgbClr val="D8D0C0"/>
+          </a:solidFill>
+          <a:ln xmlns:a="http://schemas.openxmlformats.org/drawingml/2006/main" w="0">
+            <a:solidFill>
+              <a:srgbClr val="000000">
+                <a:alpha val="0"/>
+              </a:srgbClr>
+            </a:solidFill>
+            <a:prstDash val="solid"/>
+          </a:ln>
+        </p:spPr>
+      </p:sp>
+      <p:sp>
+        <p:nvSpPr>
+          <p:cNvPr id="6" name="">
+            <a:extLst xmlns:a="http://schemas.openxmlformats.org/drawingml/2006/main">
+              <a:ext uri="{FF2B5EF4-FFF2-40B4-BE49-F238E27FC236}">
+                <a16:creationId xmlns:a16="http://schemas.microsoft.com/office/drawing/2014/main" id="{0887A216-EC69-45D8-B66E-C0821341A275}"/>
+              </a:ext>
+            </a:extLst>
+          </p:cNvPr>
+          <p:cNvSpPr>
+            <a:spLocks xmlns:a="http://schemas.openxmlformats.org/drawingml/2006/main" noGrp="1"/>
+          </p:cNvSpPr>
+          <p:nvPr/>
+        </p:nvSpPr>
+        <p:spPr>
+          <a:xfrm xmlns:a="http://schemas.openxmlformats.org/drawingml/2006/main">
+            <a:off x="666750" y="6457950"/>
+            <a:ext cx="3238500" cy="190500"/>
           </a:xfrm>
           <a:prstGeom xmlns:a="http://schemas.openxmlformats.org/drawingml/2006/main" prst="rect">
             <a:avLst/>
@@ -7040,9 +7472,9 @@
           <a:lstStyle xmlns:a="http://schemas.openxmlformats.org/drawingml/2006/main"/>
           <a:p xmlns:a="http://schemas.openxmlformats.org/drawingml/2006/main">
             <a:pPr algn="l">
-              <a:defRPr sz="1275" b="0">
-                <a:solidFill>
-                  <a:srgbClr val="4D4A43"/>
+              <a:defRPr sz="825" b="0">
+                <a:solidFill>
+                  <a:srgbClr val="6E6A61"/>
                 </a:solidFill>
                 <a:latin typeface="Aptos"/>
                 <a:ea typeface="Aptos"/>
@@ -7050,37 +7482,59 @@
               </a:defRPr>
             </a:pPr>
             <a:r>
-              <a:rPr sz="1275" b="0">
-                <a:solidFill>
-                  <a:srgbClr val="4D4A43"/>
+              <a:rPr sz="825" b="0">
+                <a:solidFill>
+                  <a:srgbClr val="6E6A61"/>
                 </a:solidFill>
                 <a:latin typeface="Aptos"/>
                 <a:ea typeface="Aptos"/>
                 <a:cs typeface="Aptos"/>
               </a:rPr>
-              <a:t>Point to extracted regions, narratives, methods, and amount range.</a:t>
+              <a:t>Artifact walkthrough | 6</a:t>
             </a:r>
           </a:p>
         </p:txBody>
       </p:sp>
-      <p:sp>
-        <p:nvSpPr>
-          <p:cNvPr id="15" name="">
-            <a:extLst xmlns:a="http://schemas.openxmlformats.org/drawingml/2006/main">
-              <a:ext uri="{FF2B5EF4-FFF2-40B4-BE49-F238E27FC236}">
-                <a16:creationId xmlns:a16="http://schemas.microsoft.com/office/drawing/2014/main" id="{B0F3B02E-E54C-48CE-9D58-D6FD42D54E36}"/>
-              </a:ext>
-            </a:extLst>
-          </p:cNvPr>
-          <p:cNvSpPr>
-            <a:spLocks xmlns:a="http://schemas.openxmlformats.org/drawingml/2006/main" noGrp="1"/>
-          </p:cNvSpPr>
-          <p:nvPr/>
-        </p:nvSpPr>
-        <p:spPr>
-          <a:xfrm xmlns:a="http://schemas.openxmlformats.org/drawingml/2006/main">
-            <a:off x="914400" y="4019550"/>
-            <a:ext cx="1200150" cy="266700"/>
+      <p:pic>
+        <p:nvPicPr>
+          <p:cNvPr id="7" name=""/>
+          <p:cNvPicPr>
+            <a:picLocks xmlns:a="http://schemas.openxmlformats.org/drawingml/2006/main" noChangeAspect="1"/>
+          </p:cNvPicPr>
+          <p:nvPr/>
+        </p:nvPicPr>
+        <p:blipFill>
+          <a:blip xmlns:r="http://schemas.openxmlformats.org/officeDocument/2006/relationships" xmlns:a="http://schemas.openxmlformats.org/drawingml/2006/main" r:embed="R77671aa4fe8e4b11"/>
+          <a:stretch xmlns:a="http://schemas.openxmlformats.org/drawingml/2006/main"/>
+        </p:blipFill>
+        <p:spPr>
+          <a:xfrm xmlns:a="http://schemas.openxmlformats.org/drawingml/2006/main">
+            <a:off x="2201333" y="1714500"/>
+            <a:ext cx="7789333" cy="4381500"/>
+          </a:xfrm>
+          <a:prstGeom xmlns:a="http://schemas.openxmlformats.org/drawingml/2006/main" prst="rect">
+            <a:avLst/>
+          </a:prstGeom>
+        </p:spPr>
+      </p:pic>
+      <p:sp>
+        <p:nvSpPr>
+          <p:cNvPr id="8" name="">
+            <a:extLst xmlns:a="http://schemas.openxmlformats.org/drawingml/2006/main">
+              <a:ext uri="{FF2B5EF4-FFF2-40B4-BE49-F238E27FC236}">
+                <a16:creationId xmlns:a16="http://schemas.microsoft.com/office/drawing/2014/main" id="{CA2972D0-8C31-4FC4-B93D-0C3B6962B946}"/>
+              </a:ext>
+            </a:extLst>
+          </p:cNvPr>
+          <p:cNvSpPr>
+            <a:spLocks xmlns:a="http://schemas.openxmlformats.org/drawingml/2006/main" noGrp="1"/>
+          </p:cNvSpPr>
+          <p:nvPr/>
+        </p:nvSpPr>
+        <p:spPr>
+          <a:xfrm xmlns:a="http://schemas.openxmlformats.org/drawingml/2006/main">
+            <a:off x="2200275" y="1714500"/>
+            <a:ext cx="7791450" cy="4381500"/>
           </a:xfrm>
           <a:prstGeom xmlns:a="http://schemas.openxmlformats.org/drawingml/2006/main" prst="rect">
             <a:avLst/>
@@ -7090,6 +7544,76 @@
               <a:alpha val="0"/>
             </a:srgbClr>
           </a:solidFill>
+          <a:ln xmlns:a="http://schemas.openxmlformats.org/drawingml/2006/main" w="9525">
+            <a:solidFill>
+              <a:srgbClr val="D8D0C0"/>
+            </a:solidFill>
+            <a:prstDash val="solid"/>
+          </a:ln>
+        </p:spPr>
+      </p:sp>
+      <p:sp>
+        <p:nvSpPr>
+          <p:cNvPr id="9" name="">
+            <a:extLst xmlns:a="http://schemas.openxmlformats.org/drawingml/2006/main">
+              <a:ext uri="{FF2B5EF4-FFF2-40B4-BE49-F238E27FC236}">
+                <a16:creationId xmlns:a16="http://schemas.microsoft.com/office/drawing/2014/main" id="{A0FA8A05-CFF5-4682-9321-A2520C2865C7}"/>
+              </a:ext>
+            </a:extLst>
+          </p:cNvPr>
+          <p:cNvSpPr>
+            <a:spLocks xmlns:a="http://schemas.openxmlformats.org/drawingml/2006/main" noGrp="1"/>
+          </p:cNvSpPr>
+          <p:nvPr/>
+        </p:nvSpPr>
+        <p:spPr>
+          <a:xfrm xmlns:a="http://schemas.openxmlformats.org/drawingml/2006/main">
+            <a:off x="6496050" y="5657850"/>
+            <a:ext cx="3486150" cy="323850"/>
+          </a:xfrm>
+          <a:prstGeom xmlns:a="http://schemas.openxmlformats.org/drawingml/2006/main" prst="rect">
+            <a:avLst/>
+          </a:prstGeom>
+          <a:solidFill xmlns:a="http://schemas.openxmlformats.org/drawingml/2006/main">
+            <a:srgbClr val="111D32"/>
+          </a:solidFill>
+          <a:ln xmlns:a="http://schemas.openxmlformats.org/drawingml/2006/main" w="0">
+            <a:solidFill>
+              <a:srgbClr val="000000">
+                <a:alpha val="0"/>
+              </a:srgbClr>
+            </a:solidFill>
+            <a:prstDash val="solid"/>
+          </a:ln>
+        </p:spPr>
+      </p:sp>
+      <p:sp>
+        <p:nvSpPr>
+          <p:cNvPr id="10" name="">
+            <a:extLst xmlns:a="http://schemas.openxmlformats.org/drawingml/2006/main">
+              <a:ext uri="{FF2B5EF4-FFF2-40B4-BE49-F238E27FC236}">
+                <a16:creationId xmlns:a16="http://schemas.microsoft.com/office/drawing/2014/main" id="{E69CB6F7-1198-4367-80E1-4DB47F3A3AF2}"/>
+              </a:ext>
+            </a:extLst>
+          </p:cNvPr>
+          <p:cNvSpPr>
+            <a:spLocks xmlns:a="http://schemas.openxmlformats.org/drawingml/2006/main" noGrp="1"/>
+          </p:cNvSpPr>
+          <p:nvPr/>
+        </p:nvSpPr>
+        <p:spPr>
+          <a:xfrm xmlns:a="http://schemas.openxmlformats.org/drawingml/2006/main">
+            <a:off x="6705600" y="5724525"/>
+            <a:ext cx="3067050" cy="190500"/>
+          </a:xfrm>
+          <a:prstGeom xmlns:a="http://schemas.openxmlformats.org/drawingml/2006/main" prst="rect">
+            <a:avLst/>
+          </a:prstGeom>
+          <a:solidFill xmlns:a="http://schemas.openxmlformats.org/drawingml/2006/main">
+            <a:srgbClr val="000000">
+              <a:alpha val="0"/>
+            </a:srgbClr>
+          </a:solidFill>
           <a:ln xmlns:a="http://schemas.openxmlformats.org/drawingml/2006/main" w="0">
             <a:solidFill>
               <a:srgbClr val="000000">
@@ -7103,515 +7627,26 @@
           <a:bodyPr xmlns:a="http://schemas.openxmlformats.org/drawingml/2006/main" lIns="0" tIns="0" rIns="0" bIns="0" anchor="t"/>
           <a:lstStyle xmlns:a="http://schemas.openxmlformats.org/drawingml/2006/main"/>
           <a:p xmlns:a="http://schemas.openxmlformats.org/drawingml/2006/main">
-            <a:pPr algn="l">
-              <a:defRPr sz="1350" b="1">
-                <a:solidFill>
-                  <a:srgbClr val="0E7C66"/>
-                </a:solidFill>
-                <a:latin typeface="Aptos Mono"/>
-                <a:ea typeface="Aptos Mono"/>
-                <a:cs typeface="Aptos Mono"/>
+            <a:pPr algn="ctr">
+              <a:defRPr sz="1050" b="1">
+                <a:solidFill>
+                  <a:srgbClr val="F7F3EA"/>
+                </a:solidFill>
+                <a:latin typeface="Aptos"/>
+                <a:ea typeface="Aptos"/>
+                <a:cs typeface="Aptos"/>
               </a:defRPr>
             </a:pPr>
             <a:r>
-              <a:rPr sz="1350" b="1">
-                <a:solidFill>
-                  <a:srgbClr val="0E7C66"/>
-                </a:solidFill>
-                <a:latin typeface="Aptos Mono"/>
-                <a:ea typeface="Aptos Mono"/>
-                <a:cs typeface="Aptos Mono"/>
+              <a:rPr sz="1050" b="1">
+                <a:solidFill>
+                  <a:srgbClr val="F7F3EA"/>
+                </a:solidFill>
+                <a:latin typeface="Aptos"/>
+                <a:ea typeface="Aptos"/>
+                <a:cs typeface="Aptos"/>
               </a:rPr>
-              <a:t>0:30-0:45</a:t>
-            </a:r>
-          </a:p>
-        </p:txBody>
-      </p:sp>
-      <p:sp>
-        <p:nvSpPr>
-          <p:cNvPr id="16" name="">
-            <a:extLst xmlns:a="http://schemas.openxmlformats.org/drawingml/2006/main">
-              <a:ext uri="{FF2B5EF4-FFF2-40B4-BE49-F238E27FC236}">
-                <a16:creationId xmlns:a16="http://schemas.microsoft.com/office/drawing/2014/main" id="{ED4D6785-F4A9-4EF8-9B5D-F777174C5933}"/>
-              </a:ext>
-            </a:extLst>
-          </p:cNvPr>
-          <p:cNvSpPr>
-            <a:spLocks xmlns:a="http://schemas.openxmlformats.org/drawingml/2006/main" noGrp="1"/>
-          </p:cNvSpPr>
-          <p:nvPr/>
-        </p:nvSpPr>
-        <p:spPr>
-          <a:xfrm xmlns:a="http://schemas.openxmlformats.org/drawingml/2006/main">
-            <a:off x="2400300" y="4133850"/>
-            <a:ext cx="419100" cy="19050"/>
-          </a:xfrm>
-          <a:prstGeom xmlns:a="http://schemas.openxmlformats.org/drawingml/2006/main" prst="rect">
-            <a:avLst/>
-          </a:prstGeom>
-          <a:solidFill xmlns:a="http://schemas.openxmlformats.org/drawingml/2006/main">
-            <a:srgbClr val="D8D0C0"/>
-          </a:solidFill>
-          <a:ln xmlns:a="http://schemas.openxmlformats.org/drawingml/2006/main" w="0">
-            <a:solidFill>
-              <a:srgbClr val="000000">
-                <a:alpha val="0"/>
-              </a:srgbClr>
-            </a:solidFill>
-            <a:prstDash val="solid"/>
-          </a:ln>
-        </p:spPr>
-      </p:sp>
-      <p:sp>
-        <p:nvSpPr>
-          <p:cNvPr id="17" name="">
-            <a:extLst xmlns:a="http://schemas.openxmlformats.org/drawingml/2006/main">
-              <a:ext uri="{FF2B5EF4-FFF2-40B4-BE49-F238E27FC236}">
-                <a16:creationId xmlns:a16="http://schemas.microsoft.com/office/drawing/2014/main" id="{56272C24-749C-416E-BDD2-4A8DB9617309}"/>
-              </a:ext>
-            </a:extLst>
-          </p:cNvPr>
-          <p:cNvSpPr>
-            <a:spLocks xmlns:a="http://schemas.openxmlformats.org/drawingml/2006/main" noGrp="1"/>
-          </p:cNvSpPr>
-          <p:nvPr/>
-        </p:nvSpPr>
-        <p:spPr>
-          <a:xfrm xmlns:a="http://schemas.openxmlformats.org/drawingml/2006/main">
-            <a:off x="3143250" y="3981450"/>
-            <a:ext cx="2095500" cy="304800"/>
-          </a:xfrm>
-          <a:prstGeom xmlns:a="http://schemas.openxmlformats.org/drawingml/2006/main" prst="rect">
-            <a:avLst/>
-          </a:prstGeom>
-          <a:solidFill xmlns:a="http://schemas.openxmlformats.org/drawingml/2006/main">
-            <a:srgbClr val="000000">
-              <a:alpha val="0"/>
-            </a:srgbClr>
-          </a:solidFill>
-          <a:ln xmlns:a="http://schemas.openxmlformats.org/drawingml/2006/main" w="0">
-            <a:solidFill>
-              <a:srgbClr val="000000">
-                <a:alpha val="0"/>
-              </a:srgbClr>
-            </a:solidFill>
-            <a:prstDash val="solid"/>
-          </a:ln>
-        </p:spPr>
-        <p:txBody>
-          <a:bodyPr xmlns:a="http://schemas.openxmlformats.org/drawingml/2006/main" lIns="0" tIns="0" rIns="0" bIns="0" anchor="t"/>
-          <a:lstStyle xmlns:a="http://schemas.openxmlformats.org/drawingml/2006/main"/>
-          <a:p xmlns:a="http://schemas.openxmlformats.org/drawingml/2006/main">
-            <a:pPr algn="l">
-              <a:defRPr sz="1800" b="1">
-                <a:solidFill>
-                  <a:srgbClr val="14213D"/>
-                </a:solidFill>
-                <a:latin typeface="Aptos"/>
-                <a:ea typeface="Aptos"/>
-                <a:cs typeface="Aptos"/>
-              </a:defRPr>
-            </a:pPr>
-            <a:r>
-              <a:rPr sz="1800" b="1">
-                <a:solidFill>
-                  <a:srgbClr val="14213D"/>
-                </a:solidFill>
-                <a:latin typeface="Aptos"/>
-                <a:ea typeface="Aptos"/>
-                <a:cs typeface="Aptos"/>
-              </a:rPr>
-              <a:t>Generated data</a:t>
-            </a:r>
-          </a:p>
-        </p:txBody>
-      </p:sp>
-      <p:sp>
-        <p:nvSpPr>
-          <p:cNvPr id="18" name="">
-            <a:extLst xmlns:a="http://schemas.openxmlformats.org/drawingml/2006/main">
-              <a:ext uri="{FF2B5EF4-FFF2-40B4-BE49-F238E27FC236}">
-                <a16:creationId xmlns:a16="http://schemas.microsoft.com/office/drawing/2014/main" id="{B236F958-09E1-4F9F-B7B0-C7FB55EB06BD}"/>
-              </a:ext>
-            </a:extLst>
-          </p:cNvPr>
-          <p:cNvSpPr>
-            <a:spLocks xmlns:a="http://schemas.openxmlformats.org/drawingml/2006/main" noGrp="1"/>
-          </p:cNvSpPr>
-          <p:nvPr/>
-        </p:nvSpPr>
-        <p:spPr>
-          <a:xfrm xmlns:a="http://schemas.openxmlformats.org/drawingml/2006/main">
-            <a:off x="5429250" y="4019550"/>
-            <a:ext cx="4953000" cy="400050"/>
-          </a:xfrm>
-          <a:prstGeom xmlns:a="http://schemas.openxmlformats.org/drawingml/2006/main" prst="rect">
-            <a:avLst/>
-          </a:prstGeom>
-          <a:solidFill xmlns:a="http://schemas.openxmlformats.org/drawingml/2006/main">
-            <a:srgbClr val="000000">
-              <a:alpha val="0"/>
-            </a:srgbClr>
-          </a:solidFill>
-          <a:ln xmlns:a="http://schemas.openxmlformats.org/drawingml/2006/main" w="0">
-            <a:solidFill>
-              <a:srgbClr val="000000">
-                <a:alpha val="0"/>
-              </a:srgbClr>
-            </a:solidFill>
-            <a:prstDash val="solid"/>
-          </a:ln>
-        </p:spPr>
-        <p:txBody>
-          <a:bodyPr xmlns:a="http://schemas.openxmlformats.org/drawingml/2006/main" lIns="0" tIns="0" rIns="0" bIns="0" anchor="t"/>
-          <a:lstStyle xmlns:a="http://schemas.openxmlformats.org/drawingml/2006/main"/>
-          <a:p xmlns:a="http://schemas.openxmlformats.org/drawingml/2006/main">
-            <a:pPr algn="l">
-              <a:defRPr sz="1275" b="0">
-                <a:solidFill>
-                  <a:srgbClr val="4D4A43"/>
-                </a:solidFill>
-                <a:latin typeface="Aptos"/>
-                <a:ea typeface="Aptos"/>
-                <a:cs typeface="Aptos"/>
-              </a:defRPr>
-            </a:pPr>
-            <a:r>
-              <a:rPr sz="1275" b="0">
-                <a:solidFill>
-                  <a:srgbClr val="4D4A43"/>
-                </a:solidFill>
-                <a:latin typeface="Aptos"/>
-                <a:ea typeface="Aptos"/>
-                <a:cs typeface="Aptos"/>
-              </a:rPr>
-              <a:t>Show labeled records plus the timing or amount chart.</a:t>
-            </a:r>
-          </a:p>
-        </p:txBody>
-      </p:sp>
-      <p:sp>
-        <p:nvSpPr>
-          <p:cNvPr id="19" name="">
-            <a:extLst xmlns:a="http://schemas.openxmlformats.org/drawingml/2006/main">
-              <a:ext uri="{FF2B5EF4-FFF2-40B4-BE49-F238E27FC236}">
-                <a16:creationId xmlns:a16="http://schemas.microsoft.com/office/drawing/2014/main" id="{BA2AB524-CE9E-46FA-86B6-9EA58838B145}"/>
-              </a:ext>
-            </a:extLst>
-          </p:cNvPr>
-          <p:cNvSpPr>
-            <a:spLocks xmlns:a="http://schemas.openxmlformats.org/drawingml/2006/main" noGrp="1"/>
-          </p:cNvSpPr>
-          <p:nvPr/>
-        </p:nvSpPr>
-        <p:spPr>
-          <a:xfrm xmlns:a="http://schemas.openxmlformats.org/drawingml/2006/main">
-            <a:off x="914400" y="4838700"/>
-            <a:ext cx="1200150" cy="266700"/>
-          </a:xfrm>
-          <a:prstGeom xmlns:a="http://schemas.openxmlformats.org/drawingml/2006/main" prst="rect">
-            <a:avLst/>
-          </a:prstGeom>
-          <a:solidFill xmlns:a="http://schemas.openxmlformats.org/drawingml/2006/main">
-            <a:srgbClr val="000000">
-              <a:alpha val="0"/>
-            </a:srgbClr>
-          </a:solidFill>
-          <a:ln xmlns:a="http://schemas.openxmlformats.org/drawingml/2006/main" w="0">
-            <a:solidFill>
-              <a:srgbClr val="000000">
-                <a:alpha val="0"/>
-              </a:srgbClr>
-            </a:solidFill>
-            <a:prstDash val="solid"/>
-          </a:ln>
-        </p:spPr>
-        <p:txBody>
-          <a:bodyPr xmlns:a="http://schemas.openxmlformats.org/drawingml/2006/main" lIns="0" tIns="0" rIns="0" bIns="0" anchor="t"/>
-          <a:lstStyle xmlns:a="http://schemas.openxmlformats.org/drawingml/2006/main"/>
-          <a:p xmlns:a="http://schemas.openxmlformats.org/drawingml/2006/main">
-            <a:pPr algn="l">
-              <a:defRPr sz="1350" b="1">
-                <a:solidFill>
-                  <a:srgbClr val="0E7C66"/>
-                </a:solidFill>
-                <a:latin typeface="Aptos Mono"/>
-                <a:ea typeface="Aptos Mono"/>
-                <a:cs typeface="Aptos Mono"/>
-              </a:defRPr>
-            </a:pPr>
-            <a:r>
-              <a:rPr sz="1350" b="1">
-                <a:solidFill>
-                  <a:srgbClr val="0E7C66"/>
-                </a:solidFill>
-                <a:latin typeface="Aptos Mono"/>
-                <a:ea typeface="Aptos Mono"/>
-                <a:cs typeface="Aptos Mono"/>
-              </a:rPr>
-              <a:t>0:45-1:00</a:t>
-            </a:r>
-          </a:p>
-        </p:txBody>
-      </p:sp>
-      <p:sp>
-        <p:nvSpPr>
-          <p:cNvPr id="20" name="">
-            <a:extLst xmlns:a="http://schemas.openxmlformats.org/drawingml/2006/main">
-              <a:ext uri="{FF2B5EF4-FFF2-40B4-BE49-F238E27FC236}">
-                <a16:creationId xmlns:a16="http://schemas.microsoft.com/office/drawing/2014/main" id="{9C01CCA8-C71F-4A4E-8C93-43D66E9F35A2}"/>
-              </a:ext>
-            </a:extLst>
-          </p:cNvPr>
-          <p:cNvSpPr>
-            <a:spLocks xmlns:a="http://schemas.openxmlformats.org/drawingml/2006/main" noGrp="1"/>
-          </p:cNvSpPr>
-          <p:nvPr/>
-        </p:nvSpPr>
-        <p:spPr>
-          <a:xfrm xmlns:a="http://schemas.openxmlformats.org/drawingml/2006/main">
-            <a:off x="2400300" y="4953000"/>
-            <a:ext cx="419100" cy="19050"/>
-          </a:xfrm>
-          <a:prstGeom xmlns:a="http://schemas.openxmlformats.org/drawingml/2006/main" prst="rect">
-            <a:avLst/>
-          </a:prstGeom>
-          <a:solidFill xmlns:a="http://schemas.openxmlformats.org/drawingml/2006/main">
-            <a:srgbClr val="D8D0C0"/>
-          </a:solidFill>
-          <a:ln xmlns:a="http://schemas.openxmlformats.org/drawingml/2006/main" w="0">
-            <a:solidFill>
-              <a:srgbClr val="000000">
-                <a:alpha val="0"/>
-              </a:srgbClr>
-            </a:solidFill>
-            <a:prstDash val="solid"/>
-          </a:ln>
-        </p:spPr>
-      </p:sp>
-      <p:sp>
-        <p:nvSpPr>
-          <p:cNvPr id="21" name="">
-            <a:extLst xmlns:a="http://schemas.openxmlformats.org/drawingml/2006/main">
-              <a:ext uri="{FF2B5EF4-FFF2-40B4-BE49-F238E27FC236}">
-                <a16:creationId xmlns:a16="http://schemas.microsoft.com/office/drawing/2014/main" id="{6041978F-28CA-4F49-9428-F51237AA70CA}"/>
-              </a:ext>
-            </a:extLst>
-          </p:cNvPr>
-          <p:cNvSpPr>
-            <a:spLocks xmlns:a="http://schemas.openxmlformats.org/drawingml/2006/main" noGrp="1"/>
-          </p:cNvSpPr>
-          <p:nvPr/>
-        </p:nvSpPr>
-        <p:spPr>
-          <a:xfrm xmlns:a="http://schemas.openxmlformats.org/drawingml/2006/main">
-            <a:off x="3143250" y="4800600"/>
-            <a:ext cx="2095500" cy="304800"/>
-          </a:xfrm>
-          <a:prstGeom xmlns:a="http://schemas.openxmlformats.org/drawingml/2006/main" prst="rect">
-            <a:avLst/>
-          </a:prstGeom>
-          <a:solidFill xmlns:a="http://schemas.openxmlformats.org/drawingml/2006/main">
-            <a:srgbClr val="000000">
-              <a:alpha val="0"/>
-            </a:srgbClr>
-          </a:solidFill>
-          <a:ln xmlns:a="http://schemas.openxmlformats.org/drawingml/2006/main" w="0">
-            <a:solidFill>
-              <a:srgbClr val="000000">
-                <a:alpha val="0"/>
-              </a:srgbClr>
-            </a:solidFill>
-            <a:prstDash val="solid"/>
-          </a:ln>
-        </p:spPr>
-        <p:txBody>
-          <a:bodyPr xmlns:a="http://schemas.openxmlformats.org/drawingml/2006/main" lIns="0" tIns="0" rIns="0" bIns="0" anchor="t"/>
-          <a:lstStyle xmlns:a="http://schemas.openxmlformats.org/drawingml/2006/main"/>
-          <a:p xmlns:a="http://schemas.openxmlformats.org/drawingml/2006/main">
-            <a:pPr algn="l">
-              <a:defRPr sz="1800" b="1">
-                <a:solidFill>
-                  <a:srgbClr val="14213D"/>
-                </a:solidFill>
-                <a:latin typeface="Aptos"/>
-                <a:ea typeface="Aptos"/>
-                <a:cs typeface="Aptos"/>
-              </a:defRPr>
-            </a:pPr>
-            <a:r>
-              <a:rPr sz="1800" b="1">
-                <a:solidFill>
-                  <a:srgbClr val="14213D"/>
-                </a:solidFill>
-                <a:latin typeface="Aptos"/>
-                <a:ea typeface="Aptos"/>
-                <a:cs typeface="Aptos"/>
-              </a:rPr>
-              <a:t>Evaluate/export</a:t>
-            </a:r>
-          </a:p>
-        </p:txBody>
-      </p:sp>
-      <p:sp>
-        <p:nvSpPr>
-          <p:cNvPr id="22" name="">
-            <a:extLst xmlns:a="http://schemas.openxmlformats.org/drawingml/2006/main">
-              <a:ext uri="{FF2B5EF4-FFF2-40B4-BE49-F238E27FC236}">
-                <a16:creationId xmlns:a16="http://schemas.microsoft.com/office/drawing/2014/main" id="{CF6B25E5-3A3F-485C-8E8F-9D5DE7F78737}"/>
-              </a:ext>
-            </a:extLst>
-          </p:cNvPr>
-          <p:cNvSpPr>
-            <a:spLocks xmlns:a="http://schemas.openxmlformats.org/drawingml/2006/main" noGrp="1"/>
-          </p:cNvSpPr>
-          <p:nvPr/>
-        </p:nvSpPr>
-        <p:spPr>
-          <a:xfrm xmlns:a="http://schemas.openxmlformats.org/drawingml/2006/main">
-            <a:off x="5429250" y="4838700"/>
-            <a:ext cx="4953000" cy="400050"/>
-          </a:xfrm>
-          <a:prstGeom xmlns:a="http://schemas.openxmlformats.org/drawingml/2006/main" prst="rect">
-            <a:avLst/>
-          </a:prstGeom>
-          <a:solidFill xmlns:a="http://schemas.openxmlformats.org/drawingml/2006/main">
-            <a:srgbClr val="000000">
-              <a:alpha val="0"/>
-            </a:srgbClr>
-          </a:solidFill>
-          <a:ln xmlns:a="http://schemas.openxmlformats.org/drawingml/2006/main" w="0">
-            <a:solidFill>
-              <a:srgbClr val="000000">
-                <a:alpha val="0"/>
-              </a:srgbClr>
-            </a:solidFill>
-            <a:prstDash val="solid"/>
-          </a:ln>
-        </p:spPr>
-        <p:txBody>
-          <a:bodyPr xmlns:a="http://schemas.openxmlformats.org/drawingml/2006/main" lIns="0" tIns="0" rIns="0" bIns="0" anchor="t"/>
-          <a:lstStyle xmlns:a="http://schemas.openxmlformats.org/drawingml/2006/main"/>
-          <a:p xmlns:a="http://schemas.openxmlformats.org/drawingml/2006/main">
-            <a:pPr algn="l">
-              <a:defRPr sz="1275" b="0">
-                <a:solidFill>
-                  <a:srgbClr val="4D4A43"/>
-                </a:solidFill>
-                <a:latin typeface="Aptos"/>
-                <a:ea typeface="Aptos"/>
-                <a:cs typeface="Aptos"/>
-              </a:defRPr>
-            </a:pPr>
-            <a:r>
-              <a:rPr sz="1275" b="0">
-                <a:solidFill>
-                  <a:srgbClr val="4D4A43"/>
-                </a:solidFill>
-                <a:latin typeface="Aptos"/>
-                <a:ea typeface="Aptos"/>
-                <a:cs typeface="Aptos"/>
-              </a:rPr>
-              <a:t>Open Evaluation tab, show baseline gap, then download CSV.</a:t>
-            </a:r>
-          </a:p>
-        </p:txBody>
-      </p:sp>
-      <p:sp>
-        <p:nvSpPr>
-          <p:cNvPr id="23" name="">
-            <a:extLst xmlns:a="http://schemas.openxmlformats.org/drawingml/2006/main">
-              <a:ext uri="{FF2B5EF4-FFF2-40B4-BE49-F238E27FC236}">
-                <a16:creationId xmlns:a16="http://schemas.microsoft.com/office/drawing/2014/main" id="{85EF5BF3-47AD-4C7E-8B6A-62D0AD3D2EF1}"/>
-              </a:ext>
-            </a:extLst>
-          </p:cNvPr>
-          <p:cNvSpPr>
-            <a:spLocks xmlns:a="http://schemas.openxmlformats.org/drawingml/2006/main" noGrp="1"/>
-          </p:cNvSpPr>
-          <p:nvPr/>
-        </p:nvSpPr>
-        <p:spPr>
-          <a:xfrm xmlns:a="http://schemas.openxmlformats.org/drawingml/2006/main">
-            <a:off x="8477250" y="914400"/>
-            <a:ext cx="2362200" cy="704850"/>
-          </a:xfrm>
-          <a:prstGeom xmlns:a="http://schemas.openxmlformats.org/drawingml/2006/main" prst="rect">
-            <a:avLst/>
-          </a:prstGeom>
-          <a:solidFill xmlns:a="http://schemas.openxmlformats.org/drawingml/2006/main">
-            <a:srgbClr val="14213D"/>
-          </a:solidFill>
-          <a:ln xmlns:a="http://schemas.openxmlformats.org/drawingml/2006/main" w="0">
-            <a:solidFill>
-              <a:srgbClr val="000000">
-                <a:alpha val="0"/>
-              </a:srgbClr>
-            </a:solidFill>
-            <a:prstDash val="solid"/>
-          </a:ln>
-        </p:spPr>
-      </p:sp>
-      <p:sp>
-        <p:nvSpPr>
-          <p:cNvPr id="24" name="">
-            <a:extLst xmlns:a="http://schemas.openxmlformats.org/drawingml/2006/main">
-              <a:ext uri="{FF2B5EF4-FFF2-40B4-BE49-F238E27FC236}">
-                <a16:creationId xmlns:a16="http://schemas.microsoft.com/office/drawing/2014/main" id="{439BB7BA-F4BF-48A9-A7D1-5C1914F67B12}"/>
-              </a:ext>
-            </a:extLst>
-          </p:cNvPr>
-          <p:cNvSpPr>
-            <a:spLocks xmlns:a="http://schemas.openxmlformats.org/drawingml/2006/main" noGrp="1"/>
-          </p:cNvSpPr>
-          <p:nvPr/>
-        </p:nvSpPr>
-        <p:spPr>
-          <a:xfrm xmlns:a="http://schemas.openxmlformats.org/drawingml/2006/main">
-            <a:off x="8705850" y="1066800"/>
-            <a:ext cx="1905000" cy="400050"/>
-          </a:xfrm>
-          <a:prstGeom xmlns:a="http://schemas.openxmlformats.org/drawingml/2006/main" prst="rect">
-            <a:avLst/>
-          </a:prstGeom>
-          <a:solidFill xmlns:a="http://schemas.openxmlformats.org/drawingml/2006/main">
-            <a:srgbClr val="000000">
-              <a:alpha val="0"/>
-            </a:srgbClr>
-          </a:solidFill>
-          <a:ln xmlns:a="http://schemas.openxmlformats.org/drawingml/2006/main" w="0">
-            <a:solidFill>
-              <a:srgbClr val="000000">
-                <a:alpha val="0"/>
-              </a:srgbClr>
-            </a:solidFill>
-            <a:prstDash val="solid"/>
-          </a:ln>
-        </p:spPr>
-        <p:txBody>
-          <a:bodyPr xmlns:a="http://schemas.openxmlformats.org/drawingml/2006/main" lIns="0" tIns="0" rIns="0" bIns="0" anchor="ctr"/>
-          <a:lstStyle xmlns:a="http://schemas.openxmlformats.org/drawingml/2006/main"/>
-          <a:p xmlns:a="http://schemas.openxmlformats.org/drawingml/2006/main">
-            <a:pPr algn="ctr">
-              <a:defRPr sz="1350" b="1">
-                <a:solidFill>
-                  <a:srgbClr val="F7F3EA"/>
-                </a:solidFill>
-                <a:latin typeface="Aptos"/>
-                <a:ea typeface="Aptos"/>
-                <a:cs typeface="Aptos"/>
-              </a:defRPr>
-            </a:pPr>
-            <a:r>
-              <a:rPr sz="1350" b="1">
-                <a:solidFill>
-                  <a:srgbClr val="F7F3EA"/>
-                </a:solidFill>
-                <a:latin typeface="Aptos"/>
-                <a:ea typeface="Aptos"/>
-                <a:cs typeface="Aptos"/>
-              </a:rPr>
-              <a:t>Close with: human review stays in the loop.</a:t>
+              <a:t>No live app is required during presentation.</a:t>
             </a:r>
           </a:p>
         </p:txBody>
@@ -7619,7 +7654,7 @@
     </p:spTree>
     <p:extLst>
       <p:ext uri="{BB962C8B-B14F-4D97-AF65-F5344CB8AC3E}">
-        <p14:creationId xmlns:p14="http://schemas.microsoft.com/office/powerpoint/2010/main" val="1564416979"/>
+        <p14:creationId xmlns:p14="http://schemas.microsoft.com/office/powerpoint/2010/main" val="1168524145"/>
       </p:ext>
     </p:extLst>
   </p:cSld>

</xml_diff>

<commit_message>
Add DeepSeek real-case evaluation
</commit_message>
<xml_diff>
--- a/docs/synthaml-final-presentation.pptx
+++ b/docs/synthaml-final-presentation.pptx
@@ -2,19 +2,19 @@
 <file path=ppt/presentation.xml><?xml version="1.0" encoding="utf-8"?>
 <p:presentation xmlns:p="http://schemas.openxmlformats.org/presentationml/2006/main">
   <p:sldMasterIdLst>
-    <p:sldMasterId xmlns:r="http://schemas.openxmlformats.org/officeDocument/2006/relationships" id="2147483648" r:id="R9cf91f72f57f45be"/>
+    <p:sldMasterId xmlns:r="http://schemas.openxmlformats.org/officeDocument/2006/relationships" id="2147483648" r:id="Rf9075db16f65465d"/>
   </p:sldMasterIdLst>
   <p:notesMasterIdLst>
-    <p:notesMasterId xmlns:r="http://schemas.openxmlformats.org/officeDocument/2006/relationships" r:id="R201c168304a4495f"/>
+    <p:notesMasterId xmlns:r="http://schemas.openxmlformats.org/officeDocument/2006/relationships" r:id="R7366794b1f2642ed"/>
   </p:notesMasterIdLst>
   <p:sldIdLst>
-    <p:sldId xmlns:r="http://schemas.openxmlformats.org/officeDocument/2006/relationships" id="256" r:id="R23a6d68145cf40f9"/>
-    <p:sldId xmlns:r="http://schemas.openxmlformats.org/officeDocument/2006/relationships" id="257" r:id="R2caec95f6dc841d8"/>
-    <p:sldId xmlns:r="http://schemas.openxmlformats.org/officeDocument/2006/relationships" id="258" r:id="R2726d5cdae34490d"/>
-    <p:sldId xmlns:r="http://schemas.openxmlformats.org/officeDocument/2006/relationships" id="259" r:id="R115878e6c43c4ada"/>
-    <p:sldId xmlns:r="http://schemas.openxmlformats.org/officeDocument/2006/relationships" id="260" r:id="R21c1ee68fcd04685"/>
-    <p:sldId xmlns:r="http://schemas.openxmlformats.org/officeDocument/2006/relationships" id="261" r:id="R9a8101ce993149cb"/>
-    <p:sldId xmlns:r="http://schemas.openxmlformats.org/officeDocument/2006/relationships" id="262" r:id="R7c866245b0b14801"/>
+    <p:sldId xmlns:r="http://schemas.openxmlformats.org/officeDocument/2006/relationships" id="256" r:id="R11e8d9c39751487c"/>
+    <p:sldId xmlns:r="http://schemas.openxmlformats.org/officeDocument/2006/relationships" id="257" r:id="Rd95e46c953c44fb6"/>
+    <p:sldId xmlns:r="http://schemas.openxmlformats.org/officeDocument/2006/relationships" id="258" r:id="Rcb6e1c68a92d448f"/>
+    <p:sldId xmlns:r="http://schemas.openxmlformats.org/officeDocument/2006/relationships" id="259" r:id="Rf98ed07e3e914e7b"/>
+    <p:sldId xmlns:r="http://schemas.openxmlformats.org/officeDocument/2006/relationships" id="260" r:id="R4f12585061de40ff"/>
+    <p:sldId xmlns:r="http://schemas.openxmlformats.org/officeDocument/2006/relationships" id="261" r:id="R74c331c0f151454f"/>
+    <p:sldId xmlns:r="http://schemas.openxmlformats.org/officeDocument/2006/relationships" id="262" r:id="R6ab3bcc266644c66"/>
   </p:sldIdLst>
   <p:sldSz cx="12192000" cy="6858000"/>
   <p:notesSz cx="6858000" cy="9144000"/>
@@ -957,7 +957,7 @@
   </p:cSld>
   <p:clrMap bg1="lt1" tx1="dk1" bg2="lt2" tx2="dk2" accent1="accent1" accent2="accent2" accent3="accent3" accent4="accent4" accent5="accent5" accent6="accent6" hlink="hlink" folHlink="folHlink"/>
   <p:sldLayoutIdLst>
-    <p:sldLayoutId xmlns:r="http://schemas.openxmlformats.org/officeDocument/2006/relationships" id="2147483649" r:id="Raac3433f383a47ff"/>
+    <p:sldLayoutId xmlns:r="http://schemas.openxmlformats.org/officeDocument/2006/relationships" id="2147483649" r:id="R06d429fafe734cb6"/>
   </p:sldLayoutIdLst>
   <p:txStyles>
     <p:titleStyle>
@@ -1256,7 +1256,7 @@
           <p:cNvPr id="1" name="">
             <a:extLst xmlns:a="http://schemas.openxmlformats.org/drawingml/2006/main">
               <a:ext uri="{FF2B5EF4-FFF2-40B4-BE49-F238E27FC236}">
-                <a16:creationId xmlns:a16="http://schemas.microsoft.com/office/drawing/2014/main" id="{49402CD6-3CA4-461C-8D99-829B971F17BC}"/>
+                <a16:creationId xmlns:a16="http://schemas.microsoft.com/office/drawing/2014/main" id="{EAAE4788-7BBE-4510-BFF8-6DAD711DADF5}"/>
               </a:ext>
             </a:extLst>
           </p:cNvPr>
@@ -1291,7 +1291,7 @@
           <p:cNvPr id="2" name="">
             <a:extLst xmlns:a="http://schemas.openxmlformats.org/drawingml/2006/main">
               <a:ext uri="{FF2B5EF4-FFF2-40B4-BE49-F238E27FC236}">
-                <a16:creationId xmlns:a16="http://schemas.microsoft.com/office/drawing/2014/main" id="{770E6B11-CA0C-4673-A65D-8EAC71CF2313}"/>
+                <a16:creationId xmlns:a16="http://schemas.microsoft.com/office/drawing/2014/main" id="{A243AC54-A971-449C-AE93-BA79697DBD98}"/>
               </a:ext>
             </a:extLst>
           </p:cNvPr>
@@ -1326,7 +1326,7 @@
           <p:cNvPr id="3" name="">
             <a:extLst xmlns:a="http://schemas.openxmlformats.org/drawingml/2006/main">
               <a:ext uri="{FF2B5EF4-FFF2-40B4-BE49-F238E27FC236}">
-                <a16:creationId xmlns:a16="http://schemas.microsoft.com/office/drawing/2014/main" id="{4DBB873B-5308-4A04-9FF1-A6DC5F91F136}"/>
+                <a16:creationId xmlns:a16="http://schemas.microsoft.com/office/drawing/2014/main" id="{23EB6C8F-079D-4137-A3A8-8A8D04A1C94F}"/>
               </a:ext>
             </a:extLst>
           </p:cNvPr>
@@ -1390,7 +1390,7 @@
           <p:cNvPr id="4" name="">
             <a:extLst xmlns:a="http://schemas.openxmlformats.org/drawingml/2006/main">
               <a:ext uri="{FF2B5EF4-FFF2-40B4-BE49-F238E27FC236}">
-                <a16:creationId xmlns:a16="http://schemas.microsoft.com/office/drawing/2014/main" id="{2AE45B50-6AD5-4DBA-B585-71C5E01275BD}"/>
+                <a16:creationId xmlns:a16="http://schemas.microsoft.com/office/drawing/2014/main" id="{5B19EFC8-6033-4283-88AE-9DF3C8AFD15C}"/>
               </a:ext>
             </a:extLst>
           </p:cNvPr>
@@ -1454,7 +1454,7 @@
           <p:cNvPr id="5" name="">
             <a:extLst xmlns:a="http://schemas.openxmlformats.org/drawingml/2006/main">
               <a:ext uri="{FF2B5EF4-FFF2-40B4-BE49-F238E27FC236}">
-                <a16:creationId xmlns:a16="http://schemas.microsoft.com/office/drawing/2014/main" id="{15A70026-6E78-437F-966C-9509D36E7EA9}"/>
+                <a16:creationId xmlns:a16="http://schemas.microsoft.com/office/drawing/2014/main" id="{C3530E68-CF31-426C-962C-FF1A4FB5224F}"/>
               </a:ext>
             </a:extLst>
           </p:cNvPr>
@@ -1518,7 +1518,7 @@
           <p:cNvPr id="6" name="">
             <a:extLst xmlns:a="http://schemas.openxmlformats.org/drawingml/2006/main">
               <a:ext uri="{FF2B5EF4-FFF2-40B4-BE49-F238E27FC236}">
-                <a16:creationId xmlns:a16="http://schemas.microsoft.com/office/drawing/2014/main" id="{31B02579-DA4B-45B2-9DE7-004F5ED07309}"/>
+                <a16:creationId xmlns:a16="http://schemas.microsoft.com/office/drawing/2014/main" id="{B797A339-7F90-4FC1-9F76-4A2571A687AD}"/>
               </a:ext>
             </a:extLst>
           </p:cNvPr>
@@ -1553,7 +1553,7 @@
           <p:cNvPr id="7" name="">
             <a:extLst xmlns:a="http://schemas.openxmlformats.org/drawingml/2006/main">
               <a:ext uri="{FF2B5EF4-FFF2-40B4-BE49-F238E27FC236}">
-                <a16:creationId xmlns:a16="http://schemas.microsoft.com/office/drawing/2014/main" id="{A8E465C7-4038-4BE4-97BF-940D99261E9D}"/>
+                <a16:creationId xmlns:a16="http://schemas.microsoft.com/office/drawing/2014/main" id="{F90CC83F-9FF3-46A4-93E3-E44D36AA0E98}"/>
               </a:ext>
             </a:extLst>
           </p:cNvPr>
@@ -1617,7 +1617,7 @@
           <p:cNvPr id="8" name="">
             <a:extLst xmlns:a="http://schemas.openxmlformats.org/drawingml/2006/main">
               <a:ext uri="{FF2B5EF4-FFF2-40B4-BE49-F238E27FC236}">
-                <a16:creationId xmlns:a16="http://schemas.microsoft.com/office/drawing/2014/main" id="{C3FA9CA7-240E-4D46-8BE1-9CF6C8C4460A}"/>
+                <a16:creationId xmlns:a16="http://schemas.microsoft.com/office/drawing/2014/main" id="{5455CB8B-4B79-4959-BCCC-B0768E08BCB1}"/>
               </a:ext>
             </a:extLst>
           </p:cNvPr>
@@ -1681,7 +1681,7 @@
           <p:cNvPr id="9" name="">
             <a:extLst xmlns:a="http://schemas.openxmlformats.org/drawingml/2006/main">
               <a:ext uri="{FF2B5EF4-FFF2-40B4-BE49-F238E27FC236}">
-                <a16:creationId xmlns:a16="http://schemas.microsoft.com/office/drawing/2014/main" id="{055057BB-A355-473D-A3B1-F89D7FFD2F78}"/>
+                <a16:creationId xmlns:a16="http://schemas.microsoft.com/office/drawing/2014/main" id="{35B67680-9792-43CA-8322-036BB7DAE357}"/>
               </a:ext>
             </a:extLst>
           </p:cNvPr>
@@ -1745,7 +1745,7 @@
           <p:cNvPr id="10" name="">
             <a:extLst xmlns:a="http://schemas.openxmlformats.org/drawingml/2006/main">
               <a:ext uri="{FF2B5EF4-FFF2-40B4-BE49-F238E27FC236}">
-                <a16:creationId xmlns:a16="http://schemas.microsoft.com/office/drawing/2014/main" id="{67F820B9-0460-4ABF-B247-F33112DDAFF1}"/>
+                <a16:creationId xmlns:a16="http://schemas.microsoft.com/office/drawing/2014/main" id="{8CDDDBB2-F445-4873-BCF7-3DC2D7337402}"/>
               </a:ext>
             </a:extLst>
           </p:cNvPr>
@@ -1809,7 +1809,7 @@
           <p:cNvPr id="11" name="">
             <a:extLst xmlns:a="http://schemas.openxmlformats.org/drawingml/2006/main">
               <a:ext uri="{FF2B5EF4-FFF2-40B4-BE49-F238E27FC236}">
-                <a16:creationId xmlns:a16="http://schemas.microsoft.com/office/drawing/2014/main" id="{B466A758-FCD1-439A-BB6C-D21C1B7B7028}"/>
+                <a16:creationId xmlns:a16="http://schemas.microsoft.com/office/drawing/2014/main" id="{FABE706C-2661-417E-979D-CCFE9AADB4E3}"/>
               </a:ext>
             </a:extLst>
           </p:cNvPr>
@@ -1873,7 +1873,7 @@
           <p:cNvPr id="12" name="">
             <a:extLst xmlns:a="http://schemas.openxmlformats.org/drawingml/2006/main">
               <a:ext uri="{FF2B5EF4-FFF2-40B4-BE49-F238E27FC236}">
-                <a16:creationId xmlns:a16="http://schemas.microsoft.com/office/drawing/2014/main" id="{ADD0D94C-78F2-48F0-AA41-CF01A9106B5E}"/>
+                <a16:creationId xmlns:a16="http://schemas.microsoft.com/office/drawing/2014/main" id="{87C4FF01-3D3E-439E-BCEE-E35B5BF184FD}"/>
               </a:ext>
             </a:extLst>
           </p:cNvPr>
@@ -1937,7 +1937,7 @@
           <p:cNvPr id="13" name="">
             <a:extLst xmlns:a="http://schemas.openxmlformats.org/drawingml/2006/main">
               <a:ext uri="{FF2B5EF4-FFF2-40B4-BE49-F238E27FC236}">
-                <a16:creationId xmlns:a16="http://schemas.microsoft.com/office/drawing/2014/main" id="{4EF89F77-A293-4CC2-A373-18D76481FDF6}"/>
+                <a16:creationId xmlns:a16="http://schemas.microsoft.com/office/drawing/2014/main" id="{A60F892E-E723-4A41-9AD8-019A8C430CF3}"/>
               </a:ext>
             </a:extLst>
           </p:cNvPr>
@@ -1972,7 +1972,7 @@
           <p:cNvPr id="14" name="">
             <a:extLst xmlns:a="http://schemas.openxmlformats.org/drawingml/2006/main">
               <a:ext uri="{FF2B5EF4-FFF2-40B4-BE49-F238E27FC236}">
-                <a16:creationId xmlns:a16="http://schemas.microsoft.com/office/drawing/2014/main" id="{586381EF-1CC8-49A4-8124-B3A758B76DCF}"/>
+                <a16:creationId xmlns:a16="http://schemas.microsoft.com/office/drawing/2014/main" id="{95A53FDE-CD7B-4F50-B22D-7862A402A16B}"/>
               </a:ext>
             </a:extLst>
           </p:cNvPr>
@@ -2036,7 +2036,7 @@
           <p:cNvPr id="15" name="">
             <a:extLst xmlns:a="http://schemas.openxmlformats.org/drawingml/2006/main">
               <a:ext uri="{FF2B5EF4-FFF2-40B4-BE49-F238E27FC236}">
-                <a16:creationId xmlns:a16="http://schemas.microsoft.com/office/drawing/2014/main" id="{073FE6B1-93CA-4596-A99F-CFE8E6576E91}"/>
+                <a16:creationId xmlns:a16="http://schemas.microsoft.com/office/drawing/2014/main" id="{5308B064-9C9E-4CFB-8F15-C9F4F6246D52}"/>
               </a:ext>
             </a:extLst>
           </p:cNvPr>
@@ -2123,7 +2123,7 @@
           <p:cNvPr id="16" name="">
             <a:extLst xmlns:a="http://schemas.openxmlformats.org/drawingml/2006/main">
               <a:ext uri="{FF2B5EF4-FFF2-40B4-BE49-F238E27FC236}">
-                <a16:creationId xmlns:a16="http://schemas.microsoft.com/office/drawing/2014/main" id="{7694ED7E-8ADB-4D67-AE57-64F68B57D35E}"/>
+                <a16:creationId xmlns:a16="http://schemas.microsoft.com/office/drawing/2014/main" id="{EA63DD07-A2BB-4E5C-B87E-583FC600294F}"/>
               </a:ext>
             </a:extLst>
           </p:cNvPr>
@@ -2185,7 +2185,7 @@
     </p:spTree>
     <p:extLst>
       <p:ext uri="{BB962C8B-B14F-4D97-AF65-F5344CB8AC3E}">
-        <p14:creationId xmlns:p14="http://schemas.microsoft.com/office/powerpoint/2010/main" val="121373382"/>
+        <p14:creationId xmlns:p14="http://schemas.microsoft.com/office/powerpoint/2010/main" val="1822223100"/>
       </p:ext>
     </p:extLst>
   </p:cSld>
@@ -2209,7 +2209,7 @@
           <p:cNvPr id="1" name="">
             <a:extLst xmlns:a="http://schemas.openxmlformats.org/drawingml/2006/main">
               <a:ext uri="{FF2B5EF4-FFF2-40B4-BE49-F238E27FC236}">
-                <a16:creationId xmlns:a16="http://schemas.microsoft.com/office/drawing/2014/main" id="{D67AE232-188F-4F79-A33D-CD7179FAABAD}"/>
+                <a16:creationId xmlns:a16="http://schemas.microsoft.com/office/drawing/2014/main" id="{F8784461-1FA4-45A0-84BA-A04EB717FDC6}"/>
               </a:ext>
             </a:extLst>
           </p:cNvPr>
@@ -2244,7 +2244,7 @@
           <p:cNvPr id="2" name="kicker-marker">
             <a:extLst xmlns:a="http://schemas.openxmlformats.org/drawingml/2006/main">
               <a:ext uri="{FF2B5EF4-FFF2-40B4-BE49-F238E27FC236}">
-                <a16:creationId xmlns:a16="http://schemas.microsoft.com/office/drawing/2014/main" id="{EF2D1263-0FE5-4D4D-87CC-D3EDEB9CD850}"/>
+                <a16:creationId xmlns:a16="http://schemas.microsoft.com/office/drawing/2014/main" id="{597C9AC6-D396-4DBF-8BE2-D90BAFA0207A}"/>
               </a:ext>
             </a:extLst>
           </p:cNvPr>
@@ -2279,7 +2279,7 @@
           <p:cNvPr id="3" name="kicker-label">
             <a:extLst xmlns:a="http://schemas.openxmlformats.org/drawingml/2006/main">
               <a:ext uri="{FF2B5EF4-FFF2-40B4-BE49-F238E27FC236}">
-                <a16:creationId xmlns:a16="http://schemas.microsoft.com/office/drawing/2014/main" id="{E8729760-685E-4076-B1B7-7E57F157F464}"/>
+                <a16:creationId xmlns:a16="http://schemas.microsoft.com/office/drawing/2014/main" id="{6EAD2A1C-AAD7-4CA7-B310-2FAC551386B1}"/>
               </a:ext>
             </a:extLst>
           </p:cNvPr>
@@ -2343,7 +2343,7 @@
           <p:cNvPr id="4" name="">
             <a:extLst xmlns:a="http://schemas.openxmlformats.org/drawingml/2006/main">
               <a:ext uri="{FF2B5EF4-FFF2-40B4-BE49-F238E27FC236}">
-                <a16:creationId xmlns:a16="http://schemas.microsoft.com/office/drawing/2014/main" id="{48B62EA4-4833-4C11-9FDC-55F3253D3C04}"/>
+                <a16:creationId xmlns:a16="http://schemas.microsoft.com/office/drawing/2014/main" id="{D41E4B94-25AF-4527-ADC9-3175B30833F0}"/>
               </a:ext>
             </a:extLst>
           </p:cNvPr>
@@ -2407,7 +2407,7 @@
           <p:cNvPr id="5" name="">
             <a:extLst xmlns:a="http://schemas.openxmlformats.org/drawingml/2006/main">
               <a:ext uri="{FF2B5EF4-FFF2-40B4-BE49-F238E27FC236}">
-                <a16:creationId xmlns:a16="http://schemas.microsoft.com/office/drawing/2014/main" id="{9DB983C7-D5BB-4742-9EFE-B8AC754001A6}"/>
+                <a16:creationId xmlns:a16="http://schemas.microsoft.com/office/drawing/2014/main" id="{D8E342B1-00D8-4DA5-B652-723DF8473D69}"/>
               </a:ext>
             </a:extLst>
           </p:cNvPr>
@@ -2471,7 +2471,7 @@
           <p:cNvPr id="6" name="">
             <a:extLst xmlns:a="http://schemas.openxmlformats.org/drawingml/2006/main">
               <a:ext uri="{FF2B5EF4-FFF2-40B4-BE49-F238E27FC236}">
-                <a16:creationId xmlns:a16="http://schemas.microsoft.com/office/drawing/2014/main" id="{42150BDA-8F84-41D2-B8D4-56FCFF0575DB}"/>
+                <a16:creationId xmlns:a16="http://schemas.microsoft.com/office/drawing/2014/main" id="{A751CA0D-D2E2-4DFA-9727-F18994E18E29}"/>
               </a:ext>
             </a:extLst>
           </p:cNvPr>
@@ -2506,7 +2506,7 @@
           <p:cNvPr id="7" name="">
             <a:extLst xmlns:a="http://schemas.openxmlformats.org/drawingml/2006/main">
               <a:ext uri="{FF2B5EF4-FFF2-40B4-BE49-F238E27FC236}">
-                <a16:creationId xmlns:a16="http://schemas.microsoft.com/office/drawing/2014/main" id="{67774D79-7B73-4001-B32D-CA0681040C55}"/>
+                <a16:creationId xmlns:a16="http://schemas.microsoft.com/office/drawing/2014/main" id="{6E668450-E468-4C45-8F01-B485F41FF0AB}"/>
               </a:ext>
             </a:extLst>
           </p:cNvPr>
@@ -2570,7 +2570,7 @@
           <p:cNvPr id="8" name="">
             <a:extLst xmlns:a="http://schemas.openxmlformats.org/drawingml/2006/main">
               <a:ext uri="{FF2B5EF4-FFF2-40B4-BE49-F238E27FC236}">
-                <a16:creationId xmlns:a16="http://schemas.microsoft.com/office/drawing/2014/main" id="{47F2E549-BFAC-4E5E-B08E-8ED788BC7D8A}"/>
+                <a16:creationId xmlns:a16="http://schemas.microsoft.com/office/drawing/2014/main" id="{6EB1FBF4-6ECC-4042-996E-D8BD51F593C9}"/>
               </a:ext>
             </a:extLst>
           </p:cNvPr>
@@ -2634,7 +2634,7 @@
           <p:cNvPr id="9" name="">
             <a:extLst xmlns:a="http://schemas.openxmlformats.org/drawingml/2006/main">
               <a:ext uri="{FF2B5EF4-FFF2-40B4-BE49-F238E27FC236}">
-                <a16:creationId xmlns:a16="http://schemas.microsoft.com/office/drawing/2014/main" id="{7934D4EB-7709-4AC2-A371-35470E907271}"/>
+                <a16:creationId xmlns:a16="http://schemas.microsoft.com/office/drawing/2014/main" id="{D252DC6B-7871-410B-A845-3296D57F1F1B}"/>
               </a:ext>
             </a:extLst>
           </p:cNvPr>
@@ -2698,7 +2698,7 @@
           <p:cNvPr id="10" name="">
             <a:extLst xmlns:a="http://schemas.openxmlformats.org/drawingml/2006/main">
               <a:ext uri="{FF2B5EF4-FFF2-40B4-BE49-F238E27FC236}">
-                <a16:creationId xmlns:a16="http://schemas.microsoft.com/office/drawing/2014/main" id="{E6AD3C56-6F10-45D9-AB5D-5DF0D8F83D20}"/>
+                <a16:creationId xmlns:a16="http://schemas.microsoft.com/office/drawing/2014/main" id="{9B67390B-5ED8-4786-B194-B676D93E3177}"/>
               </a:ext>
             </a:extLst>
           </p:cNvPr>
@@ -2733,7 +2733,7 @@
           <p:cNvPr id="11" name="">
             <a:extLst xmlns:a="http://schemas.openxmlformats.org/drawingml/2006/main">
               <a:ext uri="{FF2B5EF4-FFF2-40B4-BE49-F238E27FC236}">
-                <a16:creationId xmlns:a16="http://schemas.microsoft.com/office/drawing/2014/main" id="{B5A6B6E9-3653-40AF-A76B-6F36E91F3690}"/>
+                <a16:creationId xmlns:a16="http://schemas.microsoft.com/office/drawing/2014/main" id="{270C31B4-C4CB-44DB-822F-C16713B2BBF7}"/>
               </a:ext>
             </a:extLst>
           </p:cNvPr>
@@ -2768,7 +2768,7 @@
           <p:cNvPr id="12" name="">
             <a:extLst xmlns:a="http://schemas.openxmlformats.org/drawingml/2006/main">
               <a:ext uri="{FF2B5EF4-FFF2-40B4-BE49-F238E27FC236}">
-                <a16:creationId xmlns:a16="http://schemas.microsoft.com/office/drawing/2014/main" id="{E84D6DB3-D00E-4D0B-A479-DF0DDC2C00A9}"/>
+                <a16:creationId xmlns:a16="http://schemas.microsoft.com/office/drawing/2014/main" id="{C07DFD48-4077-46F6-85E9-144A6DD3D853}"/>
               </a:ext>
             </a:extLst>
           </p:cNvPr>
@@ -2803,7 +2803,7 @@
           <p:cNvPr id="13" name="">
             <a:extLst xmlns:a="http://schemas.openxmlformats.org/drawingml/2006/main">
               <a:ext uri="{FF2B5EF4-FFF2-40B4-BE49-F238E27FC236}">
-                <a16:creationId xmlns:a16="http://schemas.microsoft.com/office/drawing/2014/main" id="{571B84DD-5202-49BB-A527-D80A8D9623BE}"/>
+                <a16:creationId xmlns:a16="http://schemas.microsoft.com/office/drawing/2014/main" id="{BFB2E00E-30D7-4502-AEF2-47175908FE55}"/>
               </a:ext>
             </a:extLst>
           </p:cNvPr>
@@ -2867,7 +2867,7 @@
           <p:cNvPr id="14" name="">
             <a:extLst xmlns:a="http://schemas.openxmlformats.org/drawingml/2006/main">
               <a:ext uri="{FF2B5EF4-FFF2-40B4-BE49-F238E27FC236}">
-                <a16:creationId xmlns:a16="http://schemas.microsoft.com/office/drawing/2014/main" id="{BD6FF791-3020-4791-B9DD-81D9AF566C6D}"/>
+                <a16:creationId xmlns:a16="http://schemas.microsoft.com/office/drawing/2014/main" id="{E1292E17-F091-42D6-9F50-CA820C0860A0}"/>
               </a:ext>
             </a:extLst>
           </p:cNvPr>
@@ -2931,7 +2931,7 @@
           <p:cNvPr id="15" name="">
             <a:extLst xmlns:a="http://schemas.openxmlformats.org/drawingml/2006/main">
               <a:ext uri="{FF2B5EF4-FFF2-40B4-BE49-F238E27FC236}">
-                <a16:creationId xmlns:a16="http://schemas.microsoft.com/office/drawing/2014/main" id="{8F9B0BA6-F663-4C72-B478-3FB2022C72B5}"/>
+                <a16:creationId xmlns:a16="http://schemas.microsoft.com/office/drawing/2014/main" id="{A0A40A22-E153-4342-8367-31E38F7A4C69}"/>
               </a:ext>
             </a:extLst>
           </p:cNvPr>
@@ -2995,7 +2995,7 @@
           <p:cNvPr id="16" name="">
             <a:extLst xmlns:a="http://schemas.openxmlformats.org/drawingml/2006/main">
               <a:ext uri="{FF2B5EF4-FFF2-40B4-BE49-F238E27FC236}">
-                <a16:creationId xmlns:a16="http://schemas.microsoft.com/office/drawing/2014/main" id="{E442C7D1-E057-479B-84F5-17280A64D4AE}"/>
+                <a16:creationId xmlns:a16="http://schemas.microsoft.com/office/drawing/2014/main" id="{3E4AF0DD-C6D8-4B85-9017-4E6138B7C529}"/>
               </a:ext>
             </a:extLst>
           </p:cNvPr>
@@ -3030,7 +3030,7 @@
           <p:cNvPr id="17" name="">
             <a:extLst xmlns:a="http://schemas.openxmlformats.org/drawingml/2006/main">
               <a:ext uri="{FF2B5EF4-FFF2-40B4-BE49-F238E27FC236}">
-                <a16:creationId xmlns:a16="http://schemas.microsoft.com/office/drawing/2014/main" id="{734B866F-173A-4ED8-8DBC-8364A2BFB5FC}"/>
+                <a16:creationId xmlns:a16="http://schemas.microsoft.com/office/drawing/2014/main" id="{8534A143-496E-4863-A90C-0D94A6041AB1}"/>
               </a:ext>
             </a:extLst>
           </p:cNvPr>
@@ -3065,7 +3065,7 @@
           <p:cNvPr id="18" name="">
             <a:extLst xmlns:a="http://schemas.openxmlformats.org/drawingml/2006/main">
               <a:ext uri="{FF2B5EF4-FFF2-40B4-BE49-F238E27FC236}">
-                <a16:creationId xmlns:a16="http://schemas.microsoft.com/office/drawing/2014/main" id="{1B14F57B-77B4-499C-8756-71643C22B829}"/>
+                <a16:creationId xmlns:a16="http://schemas.microsoft.com/office/drawing/2014/main" id="{4E6881C6-E553-44F5-BF09-E6B583944044}"/>
               </a:ext>
             </a:extLst>
           </p:cNvPr>
@@ -3100,7 +3100,7 @@
           <p:cNvPr id="19" name="">
             <a:extLst xmlns:a="http://schemas.openxmlformats.org/drawingml/2006/main">
               <a:ext uri="{FF2B5EF4-FFF2-40B4-BE49-F238E27FC236}">
-                <a16:creationId xmlns:a16="http://schemas.microsoft.com/office/drawing/2014/main" id="{4E366DC7-110A-490A-AAC3-3818CDE32FD1}"/>
+                <a16:creationId xmlns:a16="http://schemas.microsoft.com/office/drawing/2014/main" id="{CE7A55AB-9B49-4F9E-8134-D0A275EDED4A}"/>
               </a:ext>
             </a:extLst>
           </p:cNvPr>
@@ -3164,7 +3164,7 @@
           <p:cNvPr id="20" name="">
             <a:extLst xmlns:a="http://schemas.openxmlformats.org/drawingml/2006/main">
               <a:ext uri="{FF2B5EF4-FFF2-40B4-BE49-F238E27FC236}">
-                <a16:creationId xmlns:a16="http://schemas.microsoft.com/office/drawing/2014/main" id="{7B7A9399-FD17-412F-A5CF-A27D12111F0A}"/>
+                <a16:creationId xmlns:a16="http://schemas.microsoft.com/office/drawing/2014/main" id="{084B2571-D12F-4E0A-A3C2-BB2CA51F9541}"/>
               </a:ext>
             </a:extLst>
           </p:cNvPr>
@@ -3228,7 +3228,7 @@
           <p:cNvPr id="21" name="">
             <a:extLst xmlns:a="http://schemas.openxmlformats.org/drawingml/2006/main">
               <a:ext uri="{FF2B5EF4-FFF2-40B4-BE49-F238E27FC236}">
-                <a16:creationId xmlns:a16="http://schemas.microsoft.com/office/drawing/2014/main" id="{F0C89064-772C-456A-BAD0-3AFAA626DD2D}"/>
+                <a16:creationId xmlns:a16="http://schemas.microsoft.com/office/drawing/2014/main" id="{9860B8FA-7BBF-45D8-97F7-A360F7D6D177}"/>
               </a:ext>
             </a:extLst>
           </p:cNvPr>
@@ -3292,7 +3292,7 @@
           <p:cNvPr id="22" name="">
             <a:extLst xmlns:a="http://schemas.openxmlformats.org/drawingml/2006/main">
               <a:ext uri="{FF2B5EF4-FFF2-40B4-BE49-F238E27FC236}">
-                <a16:creationId xmlns:a16="http://schemas.microsoft.com/office/drawing/2014/main" id="{E5048323-F44B-4F2B-8D76-6C8E0CC9C326}"/>
+                <a16:creationId xmlns:a16="http://schemas.microsoft.com/office/drawing/2014/main" id="{09F45E3A-9CDE-46EE-B539-F8F20B9220A0}"/>
               </a:ext>
             </a:extLst>
           </p:cNvPr>
@@ -3325,7 +3325,7 @@
           <p:cNvPr id="23" name="">
             <a:extLst xmlns:a="http://schemas.openxmlformats.org/drawingml/2006/main">
               <a:ext uri="{FF2B5EF4-FFF2-40B4-BE49-F238E27FC236}">
-                <a16:creationId xmlns:a16="http://schemas.microsoft.com/office/drawing/2014/main" id="{8F269E71-8517-4E05-BA0E-AF7887EEAA27}"/>
+                <a16:creationId xmlns:a16="http://schemas.microsoft.com/office/drawing/2014/main" id="{E57B4FE9-2924-4FBA-AACB-E6020DDDA109}"/>
               </a:ext>
             </a:extLst>
           </p:cNvPr>
@@ -3389,7 +3389,7 @@
           <p:cNvPr id="24" name="">
             <a:extLst xmlns:a="http://schemas.openxmlformats.org/drawingml/2006/main">
               <a:ext uri="{FF2B5EF4-FFF2-40B4-BE49-F238E27FC236}">
-                <a16:creationId xmlns:a16="http://schemas.microsoft.com/office/drawing/2014/main" id="{62495AD7-8AFD-413C-99FF-B7620B97116C}"/>
+                <a16:creationId xmlns:a16="http://schemas.microsoft.com/office/drawing/2014/main" id="{FE99F61A-0DF7-42A8-9877-DFE1EA74E784}"/>
               </a:ext>
             </a:extLst>
           </p:cNvPr>
@@ -3476,7 +3476,7 @@
           <p:cNvPr id="25" name="">
             <a:extLst xmlns:a="http://schemas.openxmlformats.org/drawingml/2006/main">
               <a:ext uri="{FF2B5EF4-FFF2-40B4-BE49-F238E27FC236}">
-                <a16:creationId xmlns:a16="http://schemas.microsoft.com/office/drawing/2014/main" id="{86C2E56D-A757-4470-A9D0-45D07BE2742D}"/>
+                <a16:creationId xmlns:a16="http://schemas.microsoft.com/office/drawing/2014/main" id="{4076C7CA-7144-4907-B4FE-B54F8E774F28}"/>
               </a:ext>
             </a:extLst>
           </p:cNvPr>
@@ -3511,7 +3511,7 @@
           <p:cNvPr id="26" name="">
             <a:extLst xmlns:a="http://schemas.openxmlformats.org/drawingml/2006/main">
               <a:ext uri="{FF2B5EF4-FFF2-40B4-BE49-F238E27FC236}">
-                <a16:creationId xmlns:a16="http://schemas.microsoft.com/office/drawing/2014/main" id="{27F0F783-F9A4-455A-B6BF-87CE67CF1BBE}"/>
+                <a16:creationId xmlns:a16="http://schemas.microsoft.com/office/drawing/2014/main" id="{B6213308-1E61-457F-8523-D89E8A2F37E3}"/>
               </a:ext>
             </a:extLst>
           </p:cNvPr>
@@ -3573,7 +3573,7 @@
     </p:spTree>
     <p:extLst>
       <p:ext uri="{BB962C8B-B14F-4D97-AF65-F5344CB8AC3E}">
-        <p14:creationId xmlns:p14="http://schemas.microsoft.com/office/powerpoint/2010/main" val="1468561781"/>
+        <p14:creationId xmlns:p14="http://schemas.microsoft.com/office/powerpoint/2010/main" val="1699724769"/>
       </p:ext>
     </p:extLst>
   </p:cSld>
@@ -3597,7 +3597,7 @@
           <p:cNvPr id="1" name="">
             <a:extLst xmlns:a="http://schemas.openxmlformats.org/drawingml/2006/main">
               <a:ext uri="{FF2B5EF4-FFF2-40B4-BE49-F238E27FC236}">
-                <a16:creationId xmlns:a16="http://schemas.microsoft.com/office/drawing/2014/main" id="{A8937CC4-5C12-41AF-A175-83B3F52A3E48}"/>
+                <a16:creationId xmlns:a16="http://schemas.microsoft.com/office/drawing/2014/main" id="{CB8AEF2B-0BA1-4B8B-A9D7-D4648473D055}"/>
               </a:ext>
             </a:extLst>
           </p:cNvPr>
@@ -3632,7 +3632,7 @@
           <p:cNvPr id="2" name="kicker-marker">
             <a:extLst xmlns:a="http://schemas.openxmlformats.org/drawingml/2006/main">
               <a:ext uri="{FF2B5EF4-FFF2-40B4-BE49-F238E27FC236}">
-                <a16:creationId xmlns:a16="http://schemas.microsoft.com/office/drawing/2014/main" id="{BE4327C2-DB61-4B1F-B0CB-B3D1713A87BE}"/>
+                <a16:creationId xmlns:a16="http://schemas.microsoft.com/office/drawing/2014/main" id="{819E5AB9-D8E7-4940-AFC2-87D3E5B803F0}"/>
               </a:ext>
             </a:extLst>
           </p:cNvPr>
@@ -3667,7 +3667,7 @@
           <p:cNvPr id="3" name="kicker-label">
             <a:extLst xmlns:a="http://schemas.openxmlformats.org/drawingml/2006/main">
               <a:ext uri="{FF2B5EF4-FFF2-40B4-BE49-F238E27FC236}">
-                <a16:creationId xmlns:a16="http://schemas.microsoft.com/office/drawing/2014/main" id="{6F3FA078-1177-4E1C-B601-3E6D70E08C16}"/>
+                <a16:creationId xmlns:a16="http://schemas.microsoft.com/office/drawing/2014/main" id="{25E8E524-A313-4F28-87CC-7BDF4ACEF3A7}"/>
               </a:ext>
             </a:extLst>
           </p:cNvPr>
@@ -3731,7 +3731,7 @@
           <p:cNvPr id="4" name="">
             <a:extLst xmlns:a="http://schemas.openxmlformats.org/drawingml/2006/main">
               <a:ext uri="{FF2B5EF4-FFF2-40B4-BE49-F238E27FC236}">
-                <a16:creationId xmlns:a16="http://schemas.microsoft.com/office/drawing/2014/main" id="{BBA8C972-BA8A-4305-95E2-3DFBA92A85C4}"/>
+                <a16:creationId xmlns:a16="http://schemas.microsoft.com/office/drawing/2014/main" id="{3FF4F2EE-9DD7-47BD-9D67-1FDF8E4D468B}"/>
               </a:ext>
             </a:extLst>
           </p:cNvPr>
@@ -3795,7 +3795,7 @@
           <p:cNvPr id="5" name="">
             <a:extLst xmlns:a="http://schemas.openxmlformats.org/drawingml/2006/main">
               <a:ext uri="{FF2B5EF4-FFF2-40B4-BE49-F238E27FC236}">
-                <a16:creationId xmlns:a16="http://schemas.microsoft.com/office/drawing/2014/main" id="{8B2B97EE-A6CB-462C-B2A1-8B39BD6D840C}"/>
+                <a16:creationId xmlns:a16="http://schemas.microsoft.com/office/drawing/2014/main" id="{B9E7A633-075F-4C82-A288-E201B9CD079D}"/>
               </a:ext>
             </a:extLst>
           </p:cNvPr>
@@ -3830,7 +3830,7 @@
           <p:cNvPr id="6" name="">
             <a:extLst xmlns:a="http://schemas.openxmlformats.org/drawingml/2006/main">
               <a:ext uri="{FF2B5EF4-FFF2-40B4-BE49-F238E27FC236}">
-                <a16:creationId xmlns:a16="http://schemas.microsoft.com/office/drawing/2014/main" id="{46FA7461-A49B-41CB-A4DF-7F1A3195873D}"/>
+                <a16:creationId xmlns:a16="http://schemas.microsoft.com/office/drawing/2014/main" id="{F26A5852-0121-4331-BCD3-6B392048E5C0}"/>
               </a:ext>
             </a:extLst>
           </p:cNvPr>
@@ -3894,7 +3894,7 @@
           <p:cNvPr id="7" name="">
             <a:extLst xmlns:a="http://schemas.openxmlformats.org/drawingml/2006/main">
               <a:ext uri="{FF2B5EF4-FFF2-40B4-BE49-F238E27FC236}">
-                <a16:creationId xmlns:a16="http://schemas.microsoft.com/office/drawing/2014/main" id="{060C0C5B-8722-45D6-A6A0-F998A0079456}"/>
+                <a16:creationId xmlns:a16="http://schemas.microsoft.com/office/drawing/2014/main" id="{870909AE-BFCB-444D-AE36-62EB301E4E6D}"/>
               </a:ext>
             </a:extLst>
           </p:cNvPr>
@@ -3927,7 +3927,7 @@
           <p:cNvPr id="8" name="">
             <a:extLst xmlns:a="http://schemas.openxmlformats.org/drawingml/2006/main">
               <a:ext uri="{FF2B5EF4-FFF2-40B4-BE49-F238E27FC236}">
-                <a16:creationId xmlns:a16="http://schemas.microsoft.com/office/drawing/2014/main" id="{E5EE1B99-AE9D-4CB1-BA63-3EF2D0309D98}"/>
+                <a16:creationId xmlns:a16="http://schemas.microsoft.com/office/drawing/2014/main" id="{54FB02E0-6C94-4613-B402-E0622C8FD0C6}"/>
               </a:ext>
             </a:extLst>
           </p:cNvPr>
@@ -3991,7 +3991,7 @@
           <p:cNvPr id="9" name="">
             <a:extLst xmlns:a="http://schemas.openxmlformats.org/drawingml/2006/main">
               <a:ext uri="{FF2B5EF4-FFF2-40B4-BE49-F238E27FC236}">
-                <a16:creationId xmlns:a16="http://schemas.microsoft.com/office/drawing/2014/main" id="{16401E3D-E4DF-431A-8B7E-B9FF2AC2521C}"/>
+                <a16:creationId xmlns:a16="http://schemas.microsoft.com/office/drawing/2014/main" id="{BF20EF37-ED7A-4920-8A68-E0B470BAD23A}"/>
               </a:ext>
             </a:extLst>
           </p:cNvPr>
@@ -4055,7 +4055,7 @@
           <p:cNvPr id="10" name="">
             <a:extLst xmlns:a="http://schemas.openxmlformats.org/drawingml/2006/main">
               <a:ext uri="{FF2B5EF4-FFF2-40B4-BE49-F238E27FC236}">
-                <a16:creationId xmlns:a16="http://schemas.microsoft.com/office/drawing/2014/main" id="{2A35A6CB-C40B-4BD0-8573-D1D976C1C400}"/>
+                <a16:creationId xmlns:a16="http://schemas.microsoft.com/office/drawing/2014/main" id="{2F183BB8-B702-4829-9F97-C875D66D2A05}"/>
               </a:ext>
             </a:extLst>
           </p:cNvPr>
@@ -4119,7 +4119,7 @@
           <p:cNvPr id="11" name="">
             <a:extLst xmlns:a="http://schemas.openxmlformats.org/drawingml/2006/main">
               <a:ext uri="{FF2B5EF4-FFF2-40B4-BE49-F238E27FC236}">
-                <a16:creationId xmlns:a16="http://schemas.microsoft.com/office/drawing/2014/main" id="{AE63ACA7-30ED-41AA-9390-1C39CA3059F9}"/>
+                <a16:creationId xmlns:a16="http://schemas.microsoft.com/office/drawing/2014/main" id="{F900D429-73FA-488B-BFC9-BD0B403B925F}"/>
               </a:ext>
             </a:extLst>
           </p:cNvPr>
@@ -4154,7 +4154,7 @@
           <p:cNvPr id="12" name="">
             <a:extLst xmlns:a="http://schemas.openxmlformats.org/drawingml/2006/main">
               <a:ext uri="{FF2B5EF4-FFF2-40B4-BE49-F238E27FC236}">
-                <a16:creationId xmlns:a16="http://schemas.microsoft.com/office/drawing/2014/main" id="{042095F1-87FA-4677-9823-CF35F2E4F963}"/>
+                <a16:creationId xmlns:a16="http://schemas.microsoft.com/office/drawing/2014/main" id="{B7B7DE90-FEC8-46C5-A540-4E0B5D1CDDFF}"/>
               </a:ext>
             </a:extLst>
           </p:cNvPr>
@@ -4189,7 +4189,7 @@
           <p:cNvPr id="13" name="">
             <a:extLst xmlns:a="http://schemas.openxmlformats.org/drawingml/2006/main">
               <a:ext uri="{FF2B5EF4-FFF2-40B4-BE49-F238E27FC236}">
-                <a16:creationId xmlns:a16="http://schemas.microsoft.com/office/drawing/2014/main" id="{993C7518-4B4E-4849-A162-7EAFC283C2DF}"/>
+                <a16:creationId xmlns:a16="http://schemas.microsoft.com/office/drawing/2014/main" id="{90A05EFA-C1CA-4CBF-8601-63E32F6C209E}"/>
               </a:ext>
             </a:extLst>
           </p:cNvPr>
@@ -4222,7 +4222,7 @@
           <p:cNvPr id="14" name="">
             <a:extLst xmlns:a="http://schemas.openxmlformats.org/drawingml/2006/main">
               <a:ext uri="{FF2B5EF4-FFF2-40B4-BE49-F238E27FC236}">
-                <a16:creationId xmlns:a16="http://schemas.microsoft.com/office/drawing/2014/main" id="{A5F78E75-D8C4-49F2-BE19-640739122EE1}"/>
+                <a16:creationId xmlns:a16="http://schemas.microsoft.com/office/drawing/2014/main" id="{056B04BA-1B9A-4612-980D-E08F629C7CCF}"/>
               </a:ext>
             </a:extLst>
           </p:cNvPr>
@@ -4286,7 +4286,7 @@
           <p:cNvPr id="15" name="">
             <a:extLst xmlns:a="http://schemas.openxmlformats.org/drawingml/2006/main">
               <a:ext uri="{FF2B5EF4-FFF2-40B4-BE49-F238E27FC236}">
-                <a16:creationId xmlns:a16="http://schemas.microsoft.com/office/drawing/2014/main" id="{38F5E4B2-2179-41C0-A039-53601D7DBE10}"/>
+                <a16:creationId xmlns:a16="http://schemas.microsoft.com/office/drawing/2014/main" id="{8B409F2C-F2F9-45FA-967A-C8997019011C}"/>
               </a:ext>
             </a:extLst>
           </p:cNvPr>
@@ -4350,7 +4350,7 @@
           <p:cNvPr id="16" name="">
             <a:extLst xmlns:a="http://schemas.openxmlformats.org/drawingml/2006/main">
               <a:ext uri="{FF2B5EF4-FFF2-40B4-BE49-F238E27FC236}">
-                <a16:creationId xmlns:a16="http://schemas.microsoft.com/office/drawing/2014/main" id="{8D1C4923-1E61-4DB9-A5D9-0014D9D17877}"/>
+                <a16:creationId xmlns:a16="http://schemas.microsoft.com/office/drawing/2014/main" id="{E5508AA0-11CB-4F2E-B06D-45630A21937A}"/>
               </a:ext>
             </a:extLst>
           </p:cNvPr>
@@ -4414,7 +4414,7 @@
           <p:cNvPr id="17" name="">
             <a:extLst xmlns:a="http://schemas.openxmlformats.org/drawingml/2006/main">
               <a:ext uri="{FF2B5EF4-FFF2-40B4-BE49-F238E27FC236}">
-                <a16:creationId xmlns:a16="http://schemas.microsoft.com/office/drawing/2014/main" id="{F93838F1-C14D-4A85-BE29-03E6FCE16E20}"/>
+                <a16:creationId xmlns:a16="http://schemas.microsoft.com/office/drawing/2014/main" id="{3F671744-00BE-4CF3-B579-7E2E81340AD8}"/>
               </a:ext>
             </a:extLst>
           </p:cNvPr>
@@ -4449,7 +4449,7 @@
           <p:cNvPr id="18" name="">
             <a:extLst xmlns:a="http://schemas.openxmlformats.org/drawingml/2006/main">
               <a:ext uri="{FF2B5EF4-FFF2-40B4-BE49-F238E27FC236}">
-                <a16:creationId xmlns:a16="http://schemas.microsoft.com/office/drawing/2014/main" id="{D41ECF09-81F0-4108-B6EB-24A77DEE9370}"/>
+                <a16:creationId xmlns:a16="http://schemas.microsoft.com/office/drawing/2014/main" id="{ACF95708-B27B-47E1-AA41-A202B09E0C1F}"/>
               </a:ext>
             </a:extLst>
           </p:cNvPr>
@@ -4484,7 +4484,7 @@
           <p:cNvPr id="19" name="">
             <a:extLst xmlns:a="http://schemas.openxmlformats.org/drawingml/2006/main">
               <a:ext uri="{FF2B5EF4-FFF2-40B4-BE49-F238E27FC236}">
-                <a16:creationId xmlns:a16="http://schemas.microsoft.com/office/drawing/2014/main" id="{27B92D8E-4BE1-4A5B-8D87-0C3849CDD178}"/>
+                <a16:creationId xmlns:a16="http://schemas.microsoft.com/office/drawing/2014/main" id="{6286D67A-95E0-4277-A4E6-AA4F581A5C6F}"/>
               </a:ext>
             </a:extLst>
           </p:cNvPr>
@@ -4517,7 +4517,7 @@
           <p:cNvPr id="20" name="">
             <a:extLst xmlns:a="http://schemas.openxmlformats.org/drawingml/2006/main">
               <a:ext uri="{FF2B5EF4-FFF2-40B4-BE49-F238E27FC236}">
-                <a16:creationId xmlns:a16="http://schemas.microsoft.com/office/drawing/2014/main" id="{79859A9A-A328-4EF6-96EE-3A3E4DD7DFF6}"/>
+                <a16:creationId xmlns:a16="http://schemas.microsoft.com/office/drawing/2014/main" id="{C64845EE-CA8E-4218-AA2C-9227B6B099BB}"/>
               </a:ext>
             </a:extLst>
           </p:cNvPr>
@@ -4581,7 +4581,7 @@
           <p:cNvPr id="21" name="">
             <a:extLst xmlns:a="http://schemas.openxmlformats.org/drawingml/2006/main">
               <a:ext uri="{FF2B5EF4-FFF2-40B4-BE49-F238E27FC236}">
-                <a16:creationId xmlns:a16="http://schemas.microsoft.com/office/drawing/2014/main" id="{74519905-B54A-41B9-9C8A-2898839A9002}"/>
+                <a16:creationId xmlns:a16="http://schemas.microsoft.com/office/drawing/2014/main" id="{0C38BE44-218A-4678-806F-134A466683C6}"/>
               </a:ext>
             </a:extLst>
           </p:cNvPr>
@@ -4645,7 +4645,7 @@
           <p:cNvPr id="22" name="">
             <a:extLst xmlns:a="http://schemas.openxmlformats.org/drawingml/2006/main">
               <a:ext uri="{FF2B5EF4-FFF2-40B4-BE49-F238E27FC236}">
-                <a16:creationId xmlns:a16="http://schemas.microsoft.com/office/drawing/2014/main" id="{2000C649-5AEF-4364-93A1-687A253022EE}"/>
+                <a16:creationId xmlns:a16="http://schemas.microsoft.com/office/drawing/2014/main" id="{B42FD6CC-60E2-4F5F-A75C-22B097206924}"/>
               </a:ext>
             </a:extLst>
           </p:cNvPr>
@@ -4709,7 +4709,7 @@
           <p:cNvPr id="23" name="">
             <a:extLst xmlns:a="http://schemas.openxmlformats.org/drawingml/2006/main">
               <a:ext uri="{FF2B5EF4-FFF2-40B4-BE49-F238E27FC236}">
-                <a16:creationId xmlns:a16="http://schemas.microsoft.com/office/drawing/2014/main" id="{878D5E4B-790C-4F16-9B89-A3D56D23648C}"/>
+                <a16:creationId xmlns:a16="http://schemas.microsoft.com/office/drawing/2014/main" id="{1EF63095-4E80-4B41-8121-D0F3F274E57E}"/>
               </a:ext>
             </a:extLst>
           </p:cNvPr>
@@ -4744,7 +4744,7 @@
           <p:cNvPr id="24" name="">
             <a:extLst xmlns:a="http://schemas.openxmlformats.org/drawingml/2006/main">
               <a:ext uri="{FF2B5EF4-FFF2-40B4-BE49-F238E27FC236}">
-                <a16:creationId xmlns:a16="http://schemas.microsoft.com/office/drawing/2014/main" id="{33FE1238-390A-494E-ACE9-58FAF1C650BD}"/>
+                <a16:creationId xmlns:a16="http://schemas.microsoft.com/office/drawing/2014/main" id="{EDD30F11-79A1-42AF-BDA7-182F20D8EB2C}"/>
               </a:ext>
             </a:extLst>
           </p:cNvPr>
@@ -4779,7 +4779,7 @@
           <p:cNvPr id="25" name="">
             <a:extLst xmlns:a="http://schemas.openxmlformats.org/drawingml/2006/main">
               <a:ext uri="{FF2B5EF4-FFF2-40B4-BE49-F238E27FC236}">
-                <a16:creationId xmlns:a16="http://schemas.microsoft.com/office/drawing/2014/main" id="{A7A80790-C6B9-4ACB-93AD-9E5BCDDF08BD}"/>
+                <a16:creationId xmlns:a16="http://schemas.microsoft.com/office/drawing/2014/main" id="{244D8212-F905-4D31-9660-A13F806CE064}"/>
               </a:ext>
             </a:extLst>
           </p:cNvPr>
@@ -4812,7 +4812,7 @@
           <p:cNvPr id="26" name="">
             <a:extLst xmlns:a="http://schemas.openxmlformats.org/drawingml/2006/main">
               <a:ext uri="{FF2B5EF4-FFF2-40B4-BE49-F238E27FC236}">
-                <a16:creationId xmlns:a16="http://schemas.microsoft.com/office/drawing/2014/main" id="{3E4382FB-5A69-4E21-920F-87AD4A5AEFCB}"/>
+                <a16:creationId xmlns:a16="http://schemas.microsoft.com/office/drawing/2014/main" id="{52BFA641-DAD7-4097-81CD-D3D7F57FB982}"/>
               </a:ext>
             </a:extLst>
           </p:cNvPr>
@@ -4876,7 +4876,7 @@
           <p:cNvPr id="27" name="">
             <a:extLst xmlns:a="http://schemas.openxmlformats.org/drawingml/2006/main">
               <a:ext uri="{FF2B5EF4-FFF2-40B4-BE49-F238E27FC236}">
-                <a16:creationId xmlns:a16="http://schemas.microsoft.com/office/drawing/2014/main" id="{6AC34AD8-17A8-4797-8F59-160CD0ED0801}"/>
+                <a16:creationId xmlns:a16="http://schemas.microsoft.com/office/drawing/2014/main" id="{2615AA31-B8C0-4E1E-AB80-95AA4E7E8AD0}"/>
               </a:ext>
             </a:extLst>
           </p:cNvPr>
@@ -4940,7 +4940,7 @@
           <p:cNvPr id="28" name="">
             <a:extLst xmlns:a="http://schemas.openxmlformats.org/drawingml/2006/main">
               <a:ext uri="{FF2B5EF4-FFF2-40B4-BE49-F238E27FC236}">
-                <a16:creationId xmlns:a16="http://schemas.microsoft.com/office/drawing/2014/main" id="{D8BAFC14-DC58-4054-8531-B913B7A03FA2}"/>
+                <a16:creationId xmlns:a16="http://schemas.microsoft.com/office/drawing/2014/main" id="{2A7C0EE2-EA57-4C4B-8462-DD78031EB39D}"/>
               </a:ext>
             </a:extLst>
           </p:cNvPr>
@@ -5004,7 +5004,7 @@
           <p:cNvPr id="29" name="">
             <a:extLst xmlns:a="http://schemas.openxmlformats.org/drawingml/2006/main">
               <a:ext uri="{FF2B5EF4-FFF2-40B4-BE49-F238E27FC236}">
-                <a16:creationId xmlns:a16="http://schemas.microsoft.com/office/drawing/2014/main" id="{1FCA50CB-A479-4918-9326-B0F6FB72EEF4}"/>
+                <a16:creationId xmlns:a16="http://schemas.microsoft.com/office/drawing/2014/main" id="{95201D86-F761-470C-B376-E7D616389336}"/>
               </a:ext>
             </a:extLst>
           </p:cNvPr>
@@ -5066,7 +5066,7 @@
     </p:spTree>
     <p:extLst>
       <p:ext uri="{BB962C8B-B14F-4D97-AF65-F5344CB8AC3E}">
-        <p14:creationId xmlns:p14="http://schemas.microsoft.com/office/powerpoint/2010/main" val="1924355139"/>
+        <p14:creationId xmlns:p14="http://schemas.microsoft.com/office/powerpoint/2010/main" val="797263180"/>
       </p:ext>
     </p:extLst>
   </p:cSld>
@@ -5090,7 +5090,7 @@
           <p:cNvPr id="1" name="">
             <a:extLst xmlns:a="http://schemas.openxmlformats.org/drawingml/2006/main">
               <a:ext uri="{FF2B5EF4-FFF2-40B4-BE49-F238E27FC236}">
-                <a16:creationId xmlns:a16="http://schemas.microsoft.com/office/drawing/2014/main" id="{10788702-4BA9-456C-9FB1-31F00C4DEB27}"/>
+                <a16:creationId xmlns:a16="http://schemas.microsoft.com/office/drawing/2014/main" id="{0ED13EA2-0119-401D-A212-018CC24AC867}"/>
               </a:ext>
             </a:extLst>
           </p:cNvPr>
@@ -5125,7 +5125,7 @@
           <p:cNvPr id="2" name="kicker-marker">
             <a:extLst xmlns:a="http://schemas.openxmlformats.org/drawingml/2006/main">
               <a:ext uri="{FF2B5EF4-FFF2-40B4-BE49-F238E27FC236}">
-                <a16:creationId xmlns:a16="http://schemas.microsoft.com/office/drawing/2014/main" id="{EEF8ACD8-624E-4C0E-8407-23E53505CE31}"/>
+                <a16:creationId xmlns:a16="http://schemas.microsoft.com/office/drawing/2014/main" id="{9F4A47D4-92B2-4FBE-BB6D-C8E502ADF6B4}"/>
               </a:ext>
             </a:extLst>
           </p:cNvPr>
@@ -5160,7 +5160,7 @@
           <p:cNvPr id="3" name="kicker-label">
             <a:extLst xmlns:a="http://schemas.openxmlformats.org/drawingml/2006/main">
               <a:ext uri="{FF2B5EF4-FFF2-40B4-BE49-F238E27FC236}">
-                <a16:creationId xmlns:a16="http://schemas.microsoft.com/office/drawing/2014/main" id="{EDC204CB-E80C-48B4-AFE8-EC547A0B53E4}"/>
+                <a16:creationId xmlns:a16="http://schemas.microsoft.com/office/drawing/2014/main" id="{A6856841-C7DF-4788-B3F0-1D96279B81C9}"/>
               </a:ext>
             </a:extLst>
           </p:cNvPr>
@@ -5224,7 +5224,7 @@
           <p:cNvPr id="4" name="">
             <a:extLst xmlns:a="http://schemas.openxmlformats.org/drawingml/2006/main">
               <a:ext uri="{FF2B5EF4-FFF2-40B4-BE49-F238E27FC236}">
-                <a16:creationId xmlns:a16="http://schemas.microsoft.com/office/drawing/2014/main" id="{22A93281-D3CB-451E-96BF-79C51403F2C1}"/>
+                <a16:creationId xmlns:a16="http://schemas.microsoft.com/office/drawing/2014/main" id="{D8DA40C9-08FD-47AC-BBB4-D730056B7E2D}"/>
               </a:ext>
             </a:extLst>
           </p:cNvPr>
@@ -5288,7 +5288,7 @@
           <p:cNvPr id="5" name="">
             <a:extLst xmlns:a="http://schemas.openxmlformats.org/drawingml/2006/main">
               <a:ext uri="{FF2B5EF4-FFF2-40B4-BE49-F238E27FC236}">
-                <a16:creationId xmlns:a16="http://schemas.microsoft.com/office/drawing/2014/main" id="{1A9309FC-22C3-47E4-8B85-9758F89F9BB4}"/>
+                <a16:creationId xmlns:a16="http://schemas.microsoft.com/office/drawing/2014/main" id="{8CE9E1CC-ED8F-4007-A31D-324F2232D18E}"/>
               </a:ext>
             </a:extLst>
           </p:cNvPr>
@@ -5323,7 +5323,7 @@
           <p:cNvPr id="6" name="">
             <a:extLst xmlns:a="http://schemas.openxmlformats.org/drawingml/2006/main">
               <a:ext uri="{FF2B5EF4-FFF2-40B4-BE49-F238E27FC236}">
-                <a16:creationId xmlns:a16="http://schemas.microsoft.com/office/drawing/2014/main" id="{1BA68A79-1A19-428B-BFAD-94D35C3F3E26}"/>
+                <a16:creationId xmlns:a16="http://schemas.microsoft.com/office/drawing/2014/main" id="{0AAABD33-9740-4C75-8ED2-6B82818D5402}"/>
               </a:ext>
             </a:extLst>
           </p:cNvPr>
@@ -5387,7 +5387,7 @@
           <p:cNvPr id="7" name="">
             <a:extLst xmlns:a="http://schemas.openxmlformats.org/drawingml/2006/main">
               <a:ext uri="{FF2B5EF4-FFF2-40B4-BE49-F238E27FC236}">
-                <a16:creationId xmlns:a16="http://schemas.microsoft.com/office/drawing/2014/main" id="{5A6DCC5B-7968-4277-9D29-AC39ACFC2503}"/>
+                <a16:creationId xmlns:a16="http://schemas.microsoft.com/office/drawing/2014/main" id="{DCC6D887-3C6F-49B1-BDE5-807FFE62F3AA}"/>
               </a:ext>
             </a:extLst>
           </p:cNvPr>
@@ -5451,7 +5451,7 @@
           <p:cNvPr id="8" name="">
             <a:extLst xmlns:a="http://schemas.openxmlformats.org/drawingml/2006/main">
               <a:ext uri="{FF2B5EF4-FFF2-40B4-BE49-F238E27FC236}">
-                <a16:creationId xmlns:a16="http://schemas.microsoft.com/office/drawing/2014/main" id="{2CE436AE-BF3D-4449-8520-FB0A49D19170}"/>
+                <a16:creationId xmlns:a16="http://schemas.microsoft.com/office/drawing/2014/main" id="{7374FEC4-21FE-4C0B-89AF-D6E0CF2FEEF2}"/>
               </a:ext>
             </a:extLst>
           </p:cNvPr>
@@ -5515,7 +5515,7 @@
           <p:cNvPr id="9" name="">
             <a:extLst xmlns:a="http://schemas.openxmlformats.org/drawingml/2006/main">
               <a:ext uri="{FF2B5EF4-FFF2-40B4-BE49-F238E27FC236}">
-                <a16:creationId xmlns:a16="http://schemas.microsoft.com/office/drawing/2014/main" id="{283C6CD6-EE0B-4739-8DB0-A105AAFF7AC4}"/>
+                <a16:creationId xmlns:a16="http://schemas.microsoft.com/office/drawing/2014/main" id="{A9E371B7-6FAA-4358-8C5C-7D8B2C939AFF}"/>
               </a:ext>
             </a:extLst>
           </p:cNvPr>
@@ -5550,7 +5550,7 @@
           <p:cNvPr id="10" name="">
             <a:extLst xmlns:a="http://schemas.openxmlformats.org/drawingml/2006/main">
               <a:ext uri="{FF2B5EF4-FFF2-40B4-BE49-F238E27FC236}">
-                <a16:creationId xmlns:a16="http://schemas.microsoft.com/office/drawing/2014/main" id="{1377FD6B-F95D-4E03-8CE1-0E9E8ABCA8FE}"/>
+                <a16:creationId xmlns:a16="http://schemas.microsoft.com/office/drawing/2014/main" id="{F973E5A7-3D53-424A-8F78-F80407834534}"/>
               </a:ext>
             </a:extLst>
           </p:cNvPr>
@@ -5585,7 +5585,7 @@
           <p:cNvPr id="11" name="">
             <a:extLst xmlns:a="http://schemas.openxmlformats.org/drawingml/2006/main">
               <a:ext uri="{FF2B5EF4-FFF2-40B4-BE49-F238E27FC236}">
-                <a16:creationId xmlns:a16="http://schemas.microsoft.com/office/drawing/2014/main" id="{23359CC0-65B2-4D76-B7C6-D0680569254B}"/>
+                <a16:creationId xmlns:a16="http://schemas.microsoft.com/office/drawing/2014/main" id="{832D236E-9BA5-43C4-B582-74A621BC0E67}"/>
               </a:ext>
             </a:extLst>
           </p:cNvPr>
@@ -5649,7 +5649,7 @@
           <p:cNvPr id="12" name="">
             <a:extLst xmlns:a="http://schemas.openxmlformats.org/drawingml/2006/main">
               <a:ext uri="{FF2B5EF4-FFF2-40B4-BE49-F238E27FC236}">
-                <a16:creationId xmlns:a16="http://schemas.microsoft.com/office/drawing/2014/main" id="{2BC890A7-AD8A-4004-AF9B-6BAEE3397628}"/>
+                <a16:creationId xmlns:a16="http://schemas.microsoft.com/office/drawing/2014/main" id="{50AF70C2-1535-4453-8ABC-AF44F297067B}"/>
               </a:ext>
             </a:extLst>
           </p:cNvPr>
@@ -5713,7 +5713,7 @@
           <p:cNvPr id="13" name="">
             <a:extLst xmlns:a="http://schemas.openxmlformats.org/drawingml/2006/main">
               <a:ext uri="{FF2B5EF4-FFF2-40B4-BE49-F238E27FC236}">
-                <a16:creationId xmlns:a16="http://schemas.microsoft.com/office/drawing/2014/main" id="{96EF2E39-2A39-4064-AD9D-E61B191F0E29}"/>
+                <a16:creationId xmlns:a16="http://schemas.microsoft.com/office/drawing/2014/main" id="{B58BB810-0875-444B-94C4-D2FCE74DBF84}"/>
               </a:ext>
             </a:extLst>
           </p:cNvPr>
@@ -5748,7 +5748,7 @@
           <p:cNvPr id="14" name="">
             <a:extLst xmlns:a="http://schemas.openxmlformats.org/drawingml/2006/main">
               <a:ext uri="{FF2B5EF4-FFF2-40B4-BE49-F238E27FC236}">
-                <a16:creationId xmlns:a16="http://schemas.microsoft.com/office/drawing/2014/main" id="{4C1F7716-A328-4B54-9851-97EAFDD1CE5A}"/>
+                <a16:creationId xmlns:a16="http://schemas.microsoft.com/office/drawing/2014/main" id="{C82465F0-6B5D-4055-8714-339C2B3A67CA}"/>
               </a:ext>
             </a:extLst>
           </p:cNvPr>
@@ -5760,7 +5760,7 @@
         <p:spPr>
           <a:xfrm xmlns:a="http://schemas.openxmlformats.org/drawingml/2006/main">
             <a:off x="2971800" y="3562350"/>
-            <a:ext cx="1080135" cy="304800"/>
+            <a:ext cx="760095" cy="304800"/>
           </a:xfrm>
           <a:prstGeom xmlns:a="http://schemas.openxmlformats.org/drawingml/2006/main" prst="rect">
             <a:avLst/>
@@ -5783,7 +5783,7 @@
           <p:cNvPr id="15" name="">
             <a:extLst xmlns:a="http://schemas.openxmlformats.org/drawingml/2006/main">
               <a:ext uri="{FF2B5EF4-FFF2-40B4-BE49-F238E27FC236}">
-                <a16:creationId xmlns:a16="http://schemas.microsoft.com/office/drawing/2014/main" id="{37D41934-1036-4EA7-96E0-BFA968683725}"/>
+                <a16:creationId xmlns:a16="http://schemas.microsoft.com/office/drawing/2014/main" id="{4B1ADC59-FDE3-44EC-8F67-BF67FF757ADE}"/>
               </a:ext>
             </a:extLst>
           </p:cNvPr>
@@ -5837,7 +5837,7 @@
                 <a:ea typeface="Aptos"/>
                 <a:cs typeface="Aptos"/>
               </a:rPr>
-              <a:t>0.189</a:t>
+              <a:t>0.133</a:t>
             </a:r>
           </a:p>
         </p:txBody>
@@ -5847,7 +5847,7 @@
           <p:cNvPr id="16" name="">
             <a:extLst xmlns:a="http://schemas.openxmlformats.org/drawingml/2006/main">
               <a:ext uri="{FF2B5EF4-FFF2-40B4-BE49-F238E27FC236}">
-                <a16:creationId xmlns:a16="http://schemas.microsoft.com/office/drawing/2014/main" id="{DA1F11BC-70FE-43F9-8320-43262DC858F6}"/>
+                <a16:creationId xmlns:a16="http://schemas.microsoft.com/office/drawing/2014/main" id="{AE476ED7-3B51-4DFD-AAE8-9A5EA2B1DEA8}"/>
               </a:ext>
             </a:extLst>
           </p:cNvPr>
@@ -5882,7 +5882,7 @@
           <p:cNvPr id="17" name="">
             <a:extLst xmlns:a="http://schemas.openxmlformats.org/drawingml/2006/main">
               <a:ext uri="{FF2B5EF4-FFF2-40B4-BE49-F238E27FC236}">
-                <a16:creationId xmlns:a16="http://schemas.microsoft.com/office/drawing/2014/main" id="{DE57968C-9ABE-45D2-9ED7-61C93C026E90}"/>
+                <a16:creationId xmlns:a16="http://schemas.microsoft.com/office/drawing/2014/main" id="{5C408440-0126-4B99-BCB2-AEE9248B33EA}"/>
               </a:ext>
             </a:extLst>
           </p:cNvPr>
@@ -5946,7 +5946,7 @@
           <p:cNvPr id="18" name="">
             <a:extLst xmlns:a="http://schemas.openxmlformats.org/drawingml/2006/main">
               <a:ext uri="{FF2B5EF4-FFF2-40B4-BE49-F238E27FC236}">
-                <a16:creationId xmlns:a16="http://schemas.microsoft.com/office/drawing/2014/main" id="{32FE43FE-6212-4484-8BDD-A3233C3BA336}"/>
+                <a16:creationId xmlns:a16="http://schemas.microsoft.com/office/drawing/2014/main" id="{3146A3B5-527F-468C-8090-188D98ADBE1F}"/>
               </a:ext>
             </a:extLst>
           </p:cNvPr>
@@ -5981,7 +5981,7 @@
           <p:cNvPr id="19" name="">
             <a:extLst xmlns:a="http://schemas.openxmlformats.org/drawingml/2006/main">
               <a:ext uri="{FF2B5EF4-FFF2-40B4-BE49-F238E27FC236}">
-                <a16:creationId xmlns:a16="http://schemas.microsoft.com/office/drawing/2014/main" id="{2882EC8C-A9F3-4285-B11D-53BAAB768364}"/>
+                <a16:creationId xmlns:a16="http://schemas.microsoft.com/office/drawing/2014/main" id="{3D09F1BB-1714-4255-A499-A4F480B722BF}"/>
               </a:ext>
             </a:extLst>
           </p:cNvPr>
@@ -6045,7 +6045,7 @@
           <p:cNvPr id="20" name="">
             <a:extLst xmlns:a="http://schemas.openxmlformats.org/drawingml/2006/main">
               <a:ext uri="{FF2B5EF4-FFF2-40B4-BE49-F238E27FC236}">
-                <a16:creationId xmlns:a16="http://schemas.microsoft.com/office/drawing/2014/main" id="{C44E5914-FD2A-4E7A-B27E-4F4589D4E663}"/>
+                <a16:creationId xmlns:a16="http://schemas.microsoft.com/office/drawing/2014/main" id="{26A57FB9-A6B2-49CD-9CCA-8E354A277BDC}"/>
               </a:ext>
             </a:extLst>
           </p:cNvPr>
@@ -6080,7 +6080,7 @@
           <p:cNvPr id="21" name="">
             <a:extLst xmlns:a="http://schemas.openxmlformats.org/drawingml/2006/main">
               <a:ext uri="{FF2B5EF4-FFF2-40B4-BE49-F238E27FC236}">
-                <a16:creationId xmlns:a16="http://schemas.microsoft.com/office/drawing/2014/main" id="{E96B65ED-5107-46B8-AFC2-BCA6115A3471}"/>
+                <a16:creationId xmlns:a16="http://schemas.microsoft.com/office/drawing/2014/main" id="{14133D92-D0C9-478C-AD18-584944A51033}"/>
               </a:ext>
             </a:extLst>
           </p:cNvPr>
@@ -6144,7 +6144,7 @@
           <p:cNvPr id="22" name="">
             <a:extLst xmlns:a="http://schemas.openxmlformats.org/drawingml/2006/main">
               <a:ext uri="{FF2B5EF4-FFF2-40B4-BE49-F238E27FC236}">
-                <a16:creationId xmlns:a16="http://schemas.microsoft.com/office/drawing/2014/main" id="{663B2481-E619-4F45-9AE5-0C0C3D3B2550}"/>
+                <a16:creationId xmlns:a16="http://schemas.microsoft.com/office/drawing/2014/main" id="{96D9C75E-4363-44F5-9CBD-397947762013}"/>
               </a:ext>
             </a:extLst>
           </p:cNvPr>
@@ -6179,7 +6179,7 @@
           <p:cNvPr id="23" name="">
             <a:extLst xmlns:a="http://schemas.openxmlformats.org/drawingml/2006/main">
               <a:ext uri="{FF2B5EF4-FFF2-40B4-BE49-F238E27FC236}">
-                <a16:creationId xmlns:a16="http://schemas.microsoft.com/office/drawing/2014/main" id="{33774143-4165-42E4-AA4D-2A54F579D4F8}"/>
+                <a16:creationId xmlns:a16="http://schemas.microsoft.com/office/drawing/2014/main" id="{91BEEAAF-5A30-42DE-B8C6-EC3B859569C1}"/>
               </a:ext>
             </a:extLst>
           </p:cNvPr>
@@ -6243,7 +6243,7 @@
           <p:cNvPr id="24" name="">
             <a:extLst xmlns:a="http://schemas.openxmlformats.org/drawingml/2006/main">
               <a:ext uri="{FF2B5EF4-FFF2-40B4-BE49-F238E27FC236}">
-                <a16:creationId xmlns:a16="http://schemas.microsoft.com/office/drawing/2014/main" id="{7953456B-D375-4DC9-A5E6-F7D302557395}"/>
+                <a16:creationId xmlns:a16="http://schemas.microsoft.com/office/drawing/2014/main" id="{595DE110-E7C0-48F3-889D-3B46CDEBC9E9}"/>
               </a:ext>
             </a:extLst>
           </p:cNvPr>
@@ -6278,7 +6278,7 @@
           <p:cNvPr id="25" name="">
             <a:extLst xmlns:a="http://schemas.openxmlformats.org/drawingml/2006/main">
               <a:ext uri="{FF2B5EF4-FFF2-40B4-BE49-F238E27FC236}">
-                <a16:creationId xmlns:a16="http://schemas.microsoft.com/office/drawing/2014/main" id="{B022F534-6F44-4195-ABC6-6E0F13B5476F}"/>
+                <a16:creationId xmlns:a16="http://schemas.microsoft.com/office/drawing/2014/main" id="{6F56B243-4588-4E4F-995D-C03272EC9763}"/>
               </a:ext>
             </a:extLst>
           </p:cNvPr>
@@ -6342,7 +6342,7 @@
           <p:cNvPr id="26" name="">
             <a:extLst xmlns:a="http://schemas.openxmlformats.org/drawingml/2006/main">
               <a:ext uri="{FF2B5EF4-FFF2-40B4-BE49-F238E27FC236}">
-                <a16:creationId xmlns:a16="http://schemas.microsoft.com/office/drawing/2014/main" id="{9FBCE909-EA7C-423C-B78C-9BD21BBA9F68}"/>
+                <a16:creationId xmlns:a16="http://schemas.microsoft.com/office/drawing/2014/main" id="{D063CAF3-BB03-4200-8F24-D467351C37C1}"/>
               </a:ext>
             </a:extLst>
           </p:cNvPr>
@@ -6419,7 +6419,7 @@
                 <a:ea typeface="Aptos Display"/>
                 <a:cs typeface="Aptos Display"/>
               </a:rPr>
-              <a:t>vs 0.110</a:t>
+              <a:t>vs 0.074</a:t>
             </a:r>
           </a:p>
         </p:txBody>
@@ -6427,7 +6427,7 @@
     </p:spTree>
     <p:extLst>
       <p:ext uri="{BB962C8B-B14F-4D97-AF65-F5344CB8AC3E}">
-        <p14:creationId xmlns:p14="http://schemas.microsoft.com/office/powerpoint/2010/main" val="1886912681"/>
+        <p14:creationId xmlns:p14="http://schemas.microsoft.com/office/powerpoint/2010/main" val="1799492674"/>
       </p:ext>
     </p:extLst>
   </p:cSld>
@@ -6451,7 +6451,7 @@
           <p:cNvPr id="1" name="">
             <a:extLst xmlns:a="http://schemas.openxmlformats.org/drawingml/2006/main">
               <a:ext uri="{FF2B5EF4-FFF2-40B4-BE49-F238E27FC236}">
-                <a16:creationId xmlns:a16="http://schemas.microsoft.com/office/drawing/2014/main" id="{7C6B99EC-AFE3-4242-9B98-6C9B1F8DADD7}"/>
+                <a16:creationId xmlns:a16="http://schemas.microsoft.com/office/drawing/2014/main" id="{7550DAF3-1A7D-40DF-A0C6-05804D5AFCDE}"/>
               </a:ext>
             </a:extLst>
           </p:cNvPr>
@@ -6486,7 +6486,7 @@
           <p:cNvPr id="2" name="kicker-marker">
             <a:extLst xmlns:a="http://schemas.openxmlformats.org/drawingml/2006/main">
               <a:ext uri="{FF2B5EF4-FFF2-40B4-BE49-F238E27FC236}">
-                <a16:creationId xmlns:a16="http://schemas.microsoft.com/office/drawing/2014/main" id="{892DA674-F561-429A-92CF-65D4BAAFCA5E}"/>
+                <a16:creationId xmlns:a16="http://schemas.microsoft.com/office/drawing/2014/main" id="{962AC1BA-CD23-472B-AE85-5DED16669ADF}"/>
               </a:ext>
             </a:extLst>
           </p:cNvPr>
@@ -6521,7 +6521,7 @@
           <p:cNvPr id="3" name="kicker-label">
             <a:extLst xmlns:a="http://schemas.openxmlformats.org/drawingml/2006/main">
               <a:ext uri="{FF2B5EF4-FFF2-40B4-BE49-F238E27FC236}">
-                <a16:creationId xmlns:a16="http://schemas.microsoft.com/office/drawing/2014/main" id="{DD9C36B3-8EFA-433B-9A61-AAF7678F2C98}"/>
+                <a16:creationId xmlns:a16="http://schemas.microsoft.com/office/drawing/2014/main" id="{51925E78-0DA0-42F2-AEB2-525AA9086248}"/>
               </a:ext>
             </a:extLst>
           </p:cNvPr>
@@ -6585,7 +6585,7 @@
           <p:cNvPr id="4" name="">
             <a:extLst xmlns:a="http://schemas.openxmlformats.org/drawingml/2006/main">
               <a:ext uri="{FF2B5EF4-FFF2-40B4-BE49-F238E27FC236}">
-                <a16:creationId xmlns:a16="http://schemas.microsoft.com/office/drawing/2014/main" id="{6BDCDAE4-FCA0-4149-A017-3212040191DA}"/>
+                <a16:creationId xmlns:a16="http://schemas.microsoft.com/office/drawing/2014/main" id="{EB9762F6-DBF2-44E8-B635-9F6C7693CD9F}"/>
               </a:ext>
             </a:extLst>
           </p:cNvPr>
@@ -6649,7 +6649,7 @@
           <p:cNvPr id="5" name="">
             <a:extLst xmlns:a="http://schemas.openxmlformats.org/drawingml/2006/main">
               <a:ext uri="{FF2B5EF4-FFF2-40B4-BE49-F238E27FC236}">
-                <a16:creationId xmlns:a16="http://schemas.microsoft.com/office/drawing/2014/main" id="{6D6A4207-3774-461B-80E6-8088366F3A87}"/>
+                <a16:creationId xmlns:a16="http://schemas.microsoft.com/office/drawing/2014/main" id="{9A1F50C5-7EC6-4915-B476-6C5B4391014E}"/>
               </a:ext>
             </a:extLst>
           </p:cNvPr>
@@ -6684,7 +6684,7 @@
           <p:cNvPr id="6" name="">
             <a:extLst xmlns:a="http://schemas.openxmlformats.org/drawingml/2006/main">
               <a:ext uri="{FF2B5EF4-FFF2-40B4-BE49-F238E27FC236}">
-                <a16:creationId xmlns:a16="http://schemas.microsoft.com/office/drawing/2014/main" id="{C9C5C50B-7358-4723-88FC-95F849C82767}"/>
+                <a16:creationId xmlns:a16="http://schemas.microsoft.com/office/drawing/2014/main" id="{DDFCE75F-333F-4238-A198-ACCC00D10114}"/>
               </a:ext>
             </a:extLst>
           </p:cNvPr>
@@ -6752,13 +6752,13 @@
           <p:nvPr/>
         </p:nvPicPr>
         <p:blipFill>
-          <a:blip xmlns:r="http://schemas.openxmlformats.org/officeDocument/2006/relationships" xmlns:a="http://schemas.openxmlformats.org/drawingml/2006/main" r:embed="R33d2c67180274251"/>
+          <a:blip xmlns:r="http://schemas.openxmlformats.org/officeDocument/2006/relationships" xmlns:a="http://schemas.openxmlformats.org/drawingml/2006/main" r:embed="Rd7fcf8a6860f44ec"/>
           <a:stretch xmlns:a="http://schemas.openxmlformats.org/drawingml/2006/main"/>
         </p:blipFill>
         <p:spPr>
           <a:xfrm xmlns:a="http://schemas.openxmlformats.org/drawingml/2006/main">
-            <a:off x="2201333" y="1714500"/>
-            <a:ext cx="7789333" cy="4381500"/>
+            <a:off x="2959244" y="1714500"/>
+            <a:ext cx="6273511" cy="4381500"/>
           </a:xfrm>
           <a:prstGeom xmlns:a="http://schemas.openxmlformats.org/drawingml/2006/main" prst="rect">
             <a:avLst/>
@@ -6770,7 +6770,7 @@
           <p:cNvPr id="8" name="">
             <a:extLst xmlns:a="http://schemas.openxmlformats.org/drawingml/2006/main">
               <a:ext uri="{FF2B5EF4-FFF2-40B4-BE49-F238E27FC236}">
-                <a16:creationId xmlns:a16="http://schemas.microsoft.com/office/drawing/2014/main" id="{38DCBCE5-80A6-4EB0-A75B-61785D82F13B}"/>
+                <a16:creationId xmlns:a16="http://schemas.microsoft.com/office/drawing/2014/main" id="{367D29DF-705F-47FC-B09D-C270C5370F4E}"/>
               </a:ext>
             </a:extLst>
           </p:cNvPr>
@@ -6803,7 +6803,7 @@
     </p:spTree>
     <p:extLst>
       <p:ext uri="{BB962C8B-B14F-4D97-AF65-F5344CB8AC3E}">
-        <p14:creationId xmlns:p14="http://schemas.microsoft.com/office/powerpoint/2010/main" val="1965664494"/>
+        <p14:creationId xmlns:p14="http://schemas.microsoft.com/office/powerpoint/2010/main" val="1909478249"/>
       </p:ext>
     </p:extLst>
   </p:cSld>
@@ -6827,7 +6827,7 @@
           <p:cNvPr id="1" name="">
             <a:extLst xmlns:a="http://schemas.openxmlformats.org/drawingml/2006/main">
               <a:ext uri="{FF2B5EF4-FFF2-40B4-BE49-F238E27FC236}">
-                <a16:creationId xmlns:a16="http://schemas.microsoft.com/office/drawing/2014/main" id="{A0D93479-1D6F-4E0C-ADBC-0DAA6D168879}"/>
+                <a16:creationId xmlns:a16="http://schemas.microsoft.com/office/drawing/2014/main" id="{32BF6A43-124A-440F-BB4F-3B924F0689EE}"/>
               </a:ext>
             </a:extLst>
           </p:cNvPr>
@@ -6862,7 +6862,7 @@
           <p:cNvPr id="2" name="kicker-marker">
             <a:extLst xmlns:a="http://schemas.openxmlformats.org/drawingml/2006/main">
               <a:ext uri="{FF2B5EF4-FFF2-40B4-BE49-F238E27FC236}">
-                <a16:creationId xmlns:a16="http://schemas.microsoft.com/office/drawing/2014/main" id="{8A1E8CFC-65C5-4D92-94EE-25A2DA54C1D4}"/>
+                <a16:creationId xmlns:a16="http://schemas.microsoft.com/office/drawing/2014/main" id="{E7EAF0E5-9CDA-49E5-8E5A-2D36B8475F8C}"/>
               </a:ext>
             </a:extLst>
           </p:cNvPr>
@@ -6897,7 +6897,7 @@
           <p:cNvPr id="3" name="kicker-label">
             <a:extLst xmlns:a="http://schemas.openxmlformats.org/drawingml/2006/main">
               <a:ext uri="{FF2B5EF4-FFF2-40B4-BE49-F238E27FC236}">
-                <a16:creationId xmlns:a16="http://schemas.microsoft.com/office/drawing/2014/main" id="{C1661BC5-E51C-4A7A-92EB-34B30DAA75E2}"/>
+                <a16:creationId xmlns:a16="http://schemas.microsoft.com/office/drawing/2014/main" id="{B8B963E1-ED44-4655-A6BF-7B69894B9DF2}"/>
               </a:ext>
             </a:extLst>
           </p:cNvPr>
@@ -6961,7 +6961,7 @@
           <p:cNvPr id="4" name="">
             <a:extLst xmlns:a="http://schemas.openxmlformats.org/drawingml/2006/main">
               <a:ext uri="{FF2B5EF4-FFF2-40B4-BE49-F238E27FC236}">
-                <a16:creationId xmlns:a16="http://schemas.microsoft.com/office/drawing/2014/main" id="{517F49F7-D662-4195-B06D-AD7D7EE30C8F}"/>
+                <a16:creationId xmlns:a16="http://schemas.microsoft.com/office/drawing/2014/main" id="{750BB9BA-68DB-4A46-8105-C4E5717EE749}"/>
               </a:ext>
             </a:extLst>
           </p:cNvPr>
@@ -7025,7 +7025,7 @@
           <p:cNvPr id="5" name="">
             <a:extLst xmlns:a="http://schemas.openxmlformats.org/drawingml/2006/main">
               <a:ext uri="{FF2B5EF4-FFF2-40B4-BE49-F238E27FC236}">
-                <a16:creationId xmlns:a16="http://schemas.microsoft.com/office/drawing/2014/main" id="{E5CA7223-7F87-41EE-B0C4-B212C9AD6AF0}"/>
+                <a16:creationId xmlns:a16="http://schemas.microsoft.com/office/drawing/2014/main" id="{1CAE9B3C-4383-4151-A5DD-A97946E4149F}"/>
               </a:ext>
             </a:extLst>
           </p:cNvPr>
@@ -7060,7 +7060,7 @@
           <p:cNvPr id="6" name="">
             <a:extLst xmlns:a="http://schemas.openxmlformats.org/drawingml/2006/main">
               <a:ext uri="{FF2B5EF4-FFF2-40B4-BE49-F238E27FC236}">
-                <a16:creationId xmlns:a16="http://schemas.microsoft.com/office/drawing/2014/main" id="{1718F8A7-3D7D-4812-8851-0D86DBBF6470}"/>
+                <a16:creationId xmlns:a16="http://schemas.microsoft.com/office/drawing/2014/main" id="{B265CEEB-864B-4671-8987-BC58DD7F2EA2}"/>
               </a:ext>
             </a:extLst>
           </p:cNvPr>
@@ -7128,13 +7128,13 @@
           <p:nvPr/>
         </p:nvPicPr>
         <p:blipFill>
-          <a:blip xmlns:r="http://schemas.openxmlformats.org/officeDocument/2006/relationships" xmlns:a="http://schemas.openxmlformats.org/drawingml/2006/main" r:embed="R42bb36011efc400a"/>
+          <a:blip xmlns:r="http://schemas.openxmlformats.org/officeDocument/2006/relationships" xmlns:a="http://schemas.openxmlformats.org/drawingml/2006/main" r:embed="Re59a3f3e6aaf45bf"/>
           <a:stretch xmlns:a="http://schemas.openxmlformats.org/drawingml/2006/main"/>
         </p:blipFill>
         <p:spPr>
           <a:xfrm xmlns:a="http://schemas.openxmlformats.org/drawingml/2006/main">
-            <a:off x="2201333" y="1714500"/>
-            <a:ext cx="7789333" cy="4381500"/>
+            <a:off x="2959244" y="1714500"/>
+            <a:ext cx="6273511" cy="4381500"/>
           </a:xfrm>
           <a:prstGeom xmlns:a="http://schemas.openxmlformats.org/drawingml/2006/main" prst="rect">
             <a:avLst/>
@@ -7146,7 +7146,7 @@
           <p:cNvPr id="8" name="">
             <a:extLst xmlns:a="http://schemas.openxmlformats.org/drawingml/2006/main">
               <a:ext uri="{FF2B5EF4-FFF2-40B4-BE49-F238E27FC236}">
-                <a16:creationId xmlns:a16="http://schemas.microsoft.com/office/drawing/2014/main" id="{693F1090-CA28-45BB-ADE3-E6B56D360A7C}"/>
+                <a16:creationId xmlns:a16="http://schemas.microsoft.com/office/drawing/2014/main" id="{11D309EB-8FAD-476D-9DF2-E18DEFCC7AC9}"/>
               </a:ext>
             </a:extLst>
           </p:cNvPr>
@@ -7179,7 +7179,7 @@
     </p:spTree>
     <p:extLst>
       <p:ext uri="{BB962C8B-B14F-4D97-AF65-F5344CB8AC3E}">
-        <p14:creationId xmlns:p14="http://schemas.microsoft.com/office/powerpoint/2010/main" val="1490616762"/>
+        <p14:creationId xmlns:p14="http://schemas.microsoft.com/office/powerpoint/2010/main" val="1372599957"/>
       </p:ext>
     </p:extLst>
   </p:cSld>
@@ -7203,7 +7203,7 @@
           <p:cNvPr id="1" name="">
             <a:extLst xmlns:a="http://schemas.openxmlformats.org/drawingml/2006/main">
               <a:ext uri="{FF2B5EF4-FFF2-40B4-BE49-F238E27FC236}">
-                <a16:creationId xmlns:a16="http://schemas.microsoft.com/office/drawing/2014/main" id="{DF800DDD-842C-41EF-AEC2-CB8FDB66F2FC}"/>
+                <a16:creationId xmlns:a16="http://schemas.microsoft.com/office/drawing/2014/main" id="{CEF33BD3-DF48-4F3C-8FFA-A149B4C70BEA}"/>
               </a:ext>
             </a:extLst>
           </p:cNvPr>
@@ -7238,7 +7238,7 @@
           <p:cNvPr id="2" name="kicker-marker">
             <a:extLst xmlns:a="http://schemas.openxmlformats.org/drawingml/2006/main">
               <a:ext uri="{FF2B5EF4-FFF2-40B4-BE49-F238E27FC236}">
-                <a16:creationId xmlns:a16="http://schemas.microsoft.com/office/drawing/2014/main" id="{1AB5AE97-D729-4FE5-82FD-72C8CD821EFF}"/>
+                <a16:creationId xmlns:a16="http://schemas.microsoft.com/office/drawing/2014/main" id="{F88EBA2E-661E-4B8A-B3FC-18B2ACCC34E6}"/>
               </a:ext>
             </a:extLst>
           </p:cNvPr>
@@ -7273,7 +7273,7 @@
           <p:cNvPr id="3" name="kicker-label">
             <a:extLst xmlns:a="http://schemas.openxmlformats.org/drawingml/2006/main">
               <a:ext uri="{FF2B5EF4-FFF2-40B4-BE49-F238E27FC236}">
-                <a16:creationId xmlns:a16="http://schemas.microsoft.com/office/drawing/2014/main" id="{C172AE43-2020-4396-9A4E-61B12FB957CA}"/>
+                <a16:creationId xmlns:a16="http://schemas.microsoft.com/office/drawing/2014/main" id="{5B8BA654-BA0A-44B3-B218-F11C7F24143E}"/>
               </a:ext>
             </a:extLst>
           </p:cNvPr>
@@ -7337,7 +7337,7 @@
           <p:cNvPr id="4" name="">
             <a:extLst xmlns:a="http://schemas.openxmlformats.org/drawingml/2006/main">
               <a:ext uri="{FF2B5EF4-FFF2-40B4-BE49-F238E27FC236}">
-                <a16:creationId xmlns:a16="http://schemas.microsoft.com/office/drawing/2014/main" id="{F2168180-09F9-497E-BE38-D882EE294682}"/>
+                <a16:creationId xmlns:a16="http://schemas.microsoft.com/office/drawing/2014/main" id="{11A467EC-CCDA-4C2B-8DE0-CE887A6AB11B}"/>
               </a:ext>
             </a:extLst>
           </p:cNvPr>
@@ -7401,7 +7401,7 @@
           <p:cNvPr id="5" name="">
             <a:extLst xmlns:a="http://schemas.openxmlformats.org/drawingml/2006/main">
               <a:ext uri="{FF2B5EF4-FFF2-40B4-BE49-F238E27FC236}">
-                <a16:creationId xmlns:a16="http://schemas.microsoft.com/office/drawing/2014/main" id="{2B84AA4F-381B-499B-9553-3AB63CB0E673}"/>
+                <a16:creationId xmlns:a16="http://schemas.microsoft.com/office/drawing/2014/main" id="{13305288-BD24-4B95-A071-819472B424EC}"/>
               </a:ext>
             </a:extLst>
           </p:cNvPr>
@@ -7436,7 +7436,7 @@
           <p:cNvPr id="6" name="">
             <a:extLst xmlns:a="http://schemas.openxmlformats.org/drawingml/2006/main">
               <a:ext uri="{FF2B5EF4-FFF2-40B4-BE49-F238E27FC236}">
-                <a16:creationId xmlns:a16="http://schemas.microsoft.com/office/drawing/2014/main" id="{B2279386-6FE2-4537-91D0-0B145D75FF4C}"/>
+                <a16:creationId xmlns:a16="http://schemas.microsoft.com/office/drawing/2014/main" id="{E313DC99-DFBC-441B-B0E6-328BAFD60510}"/>
               </a:ext>
             </a:extLst>
           </p:cNvPr>
@@ -7504,13 +7504,13 @@
           <p:nvPr/>
         </p:nvPicPr>
         <p:blipFill>
-          <a:blip xmlns:r="http://schemas.openxmlformats.org/officeDocument/2006/relationships" xmlns:a="http://schemas.openxmlformats.org/drawingml/2006/main" r:embed="R2172a090b35742bc"/>
+          <a:blip xmlns:r="http://schemas.openxmlformats.org/officeDocument/2006/relationships" xmlns:a="http://schemas.openxmlformats.org/drawingml/2006/main" r:embed="R88c86063b70241f2"/>
           <a:stretch xmlns:a="http://schemas.openxmlformats.org/drawingml/2006/main"/>
         </p:blipFill>
         <p:spPr>
           <a:xfrm xmlns:a="http://schemas.openxmlformats.org/drawingml/2006/main">
-            <a:off x="2201333" y="1714500"/>
-            <a:ext cx="7789333" cy="4381500"/>
+            <a:off x="2959244" y="1714500"/>
+            <a:ext cx="6273511" cy="4381500"/>
           </a:xfrm>
           <a:prstGeom xmlns:a="http://schemas.openxmlformats.org/drawingml/2006/main" prst="rect">
             <a:avLst/>
@@ -7522,7 +7522,7 @@
           <p:cNvPr id="8" name="">
             <a:extLst xmlns:a="http://schemas.openxmlformats.org/drawingml/2006/main">
               <a:ext uri="{FF2B5EF4-FFF2-40B4-BE49-F238E27FC236}">
-                <a16:creationId xmlns:a16="http://schemas.microsoft.com/office/drawing/2014/main" id="{CAB6D656-D060-4EB2-843F-EE529A4489B4}"/>
+                <a16:creationId xmlns:a16="http://schemas.microsoft.com/office/drawing/2014/main" id="{923A627C-E6CD-47CD-A46F-1B21625723EA}"/>
               </a:ext>
             </a:extLst>
           </p:cNvPr>
@@ -7557,7 +7557,7 @@
           <p:cNvPr id="9" name="">
             <a:extLst xmlns:a="http://schemas.openxmlformats.org/drawingml/2006/main">
               <a:ext uri="{FF2B5EF4-FFF2-40B4-BE49-F238E27FC236}">
-                <a16:creationId xmlns:a16="http://schemas.microsoft.com/office/drawing/2014/main" id="{352BD473-F0E7-40A3-8E39-499B609BF13F}"/>
+                <a16:creationId xmlns:a16="http://schemas.microsoft.com/office/drawing/2014/main" id="{C8A527C4-26AF-4546-A84B-59CD0AF7838C}"/>
               </a:ext>
             </a:extLst>
           </p:cNvPr>
@@ -7592,7 +7592,7 @@
           <p:cNvPr id="10" name="">
             <a:extLst xmlns:a="http://schemas.openxmlformats.org/drawingml/2006/main">
               <a:ext uri="{FF2B5EF4-FFF2-40B4-BE49-F238E27FC236}">
-                <a16:creationId xmlns:a16="http://schemas.microsoft.com/office/drawing/2014/main" id="{80976DE6-4562-455D-98B9-1E8280F78A80}"/>
+                <a16:creationId xmlns:a16="http://schemas.microsoft.com/office/drawing/2014/main" id="{C151D58C-3619-4390-87B9-C5484929A911}"/>
               </a:ext>
             </a:extLst>
           </p:cNvPr>
@@ -7654,7 +7654,7 @@
     </p:spTree>
     <p:extLst>
       <p:ext uri="{BB962C8B-B14F-4D97-AF65-F5344CB8AC3E}">
-        <p14:creationId xmlns:p14="http://schemas.microsoft.com/office/powerpoint/2010/main" val="623068945"/>
+        <p14:creationId xmlns:p14="http://schemas.microsoft.com/office/powerpoint/2010/main" val="1520072180"/>
       </p:ext>
     </p:extLst>
   </p:cSld>

</xml_diff>

<commit_message>
Add click-ready browser demo
</commit_message>
<xml_diff>
--- a/docs/synthaml-final-presentation.pptx
+++ b/docs/synthaml-final-presentation.pptx
@@ -2,19 +2,19 @@
 <file path=ppt/presentation.xml><?xml version="1.0" encoding="utf-8"?>
 <p:presentation xmlns:p="http://schemas.openxmlformats.org/presentationml/2006/main">
   <p:sldMasterIdLst>
-    <p:sldMasterId xmlns:r="http://schemas.openxmlformats.org/officeDocument/2006/relationships" id="2147483648" r:id="Rf9075db16f65465d"/>
+    <p:sldMasterId xmlns:r="http://schemas.openxmlformats.org/officeDocument/2006/relationships" id="2147483648" r:id="R452a54dd9dc24f10"/>
   </p:sldMasterIdLst>
   <p:notesMasterIdLst>
-    <p:notesMasterId xmlns:r="http://schemas.openxmlformats.org/officeDocument/2006/relationships" r:id="R7366794b1f2642ed"/>
+    <p:notesMasterId xmlns:r="http://schemas.openxmlformats.org/officeDocument/2006/relationships" r:id="Rd101621330b74438"/>
   </p:notesMasterIdLst>
   <p:sldIdLst>
-    <p:sldId xmlns:r="http://schemas.openxmlformats.org/officeDocument/2006/relationships" id="256" r:id="R11e8d9c39751487c"/>
-    <p:sldId xmlns:r="http://schemas.openxmlformats.org/officeDocument/2006/relationships" id="257" r:id="Rd95e46c953c44fb6"/>
-    <p:sldId xmlns:r="http://schemas.openxmlformats.org/officeDocument/2006/relationships" id="258" r:id="Rcb6e1c68a92d448f"/>
-    <p:sldId xmlns:r="http://schemas.openxmlformats.org/officeDocument/2006/relationships" id="259" r:id="Rf98ed07e3e914e7b"/>
-    <p:sldId xmlns:r="http://schemas.openxmlformats.org/officeDocument/2006/relationships" id="260" r:id="R4f12585061de40ff"/>
-    <p:sldId xmlns:r="http://schemas.openxmlformats.org/officeDocument/2006/relationships" id="261" r:id="R74c331c0f151454f"/>
-    <p:sldId xmlns:r="http://schemas.openxmlformats.org/officeDocument/2006/relationships" id="262" r:id="R6ab3bcc266644c66"/>
+    <p:sldId xmlns:r="http://schemas.openxmlformats.org/officeDocument/2006/relationships" id="256" r:id="R7073b1b554d9458c"/>
+    <p:sldId xmlns:r="http://schemas.openxmlformats.org/officeDocument/2006/relationships" id="257" r:id="Rc528e8270658499e"/>
+    <p:sldId xmlns:r="http://schemas.openxmlformats.org/officeDocument/2006/relationships" id="258" r:id="R1fdf2f2d4412428e"/>
+    <p:sldId xmlns:r="http://schemas.openxmlformats.org/officeDocument/2006/relationships" id="259" r:id="R98d82433c44f4584"/>
+    <p:sldId xmlns:r="http://schemas.openxmlformats.org/officeDocument/2006/relationships" id="260" r:id="R01b6ba7592974ee4"/>
+    <p:sldId xmlns:r="http://schemas.openxmlformats.org/officeDocument/2006/relationships" id="261" r:id="R9a83ae41ffec4f6c"/>
+    <p:sldId xmlns:r="http://schemas.openxmlformats.org/officeDocument/2006/relationships" id="262" r:id="Ra67cb06cd0db4949"/>
   </p:sldIdLst>
   <p:sldSz cx="12192000" cy="6858000"/>
   <p:notesSz cx="6858000" cy="9144000"/>
@@ -957,7 +957,7 @@
   </p:cSld>
   <p:clrMap bg1="lt1" tx1="dk1" bg2="lt2" tx2="dk2" accent1="accent1" accent2="accent2" accent3="accent3" accent4="accent4" accent5="accent5" accent6="accent6" hlink="hlink" folHlink="folHlink"/>
   <p:sldLayoutIdLst>
-    <p:sldLayoutId xmlns:r="http://schemas.openxmlformats.org/officeDocument/2006/relationships" id="2147483649" r:id="R06d429fafe734cb6"/>
+    <p:sldLayoutId xmlns:r="http://schemas.openxmlformats.org/officeDocument/2006/relationships" id="2147483649" r:id="Reed02ee1b92b4089"/>
   </p:sldLayoutIdLst>
   <p:txStyles>
     <p:titleStyle>
@@ -1256,7 +1256,7 @@
           <p:cNvPr id="1" name="">
             <a:extLst xmlns:a="http://schemas.openxmlformats.org/drawingml/2006/main">
               <a:ext uri="{FF2B5EF4-FFF2-40B4-BE49-F238E27FC236}">
-                <a16:creationId xmlns:a16="http://schemas.microsoft.com/office/drawing/2014/main" id="{EAAE4788-7BBE-4510-BFF8-6DAD711DADF5}"/>
+                <a16:creationId xmlns:a16="http://schemas.microsoft.com/office/drawing/2014/main" id="{C11F6431-CA73-4BA4-8F27-189AD3A48612}"/>
               </a:ext>
             </a:extLst>
           </p:cNvPr>
@@ -1291,7 +1291,7 @@
           <p:cNvPr id="2" name="">
             <a:extLst xmlns:a="http://schemas.openxmlformats.org/drawingml/2006/main">
               <a:ext uri="{FF2B5EF4-FFF2-40B4-BE49-F238E27FC236}">
-                <a16:creationId xmlns:a16="http://schemas.microsoft.com/office/drawing/2014/main" id="{A243AC54-A971-449C-AE93-BA79697DBD98}"/>
+                <a16:creationId xmlns:a16="http://schemas.microsoft.com/office/drawing/2014/main" id="{87247148-7971-44AD-B234-E20F3D9C4F5F}"/>
               </a:ext>
             </a:extLst>
           </p:cNvPr>
@@ -1326,7 +1326,7 @@
           <p:cNvPr id="3" name="">
             <a:extLst xmlns:a="http://schemas.openxmlformats.org/drawingml/2006/main">
               <a:ext uri="{FF2B5EF4-FFF2-40B4-BE49-F238E27FC236}">
-                <a16:creationId xmlns:a16="http://schemas.microsoft.com/office/drawing/2014/main" id="{23EB6C8F-079D-4137-A3A8-8A8D04A1C94F}"/>
+                <a16:creationId xmlns:a16="http://schemas.microsoft.com/office/drawing/2014/main" id="{D556A2B6-3159-439E-A7EA-4D28D7D128DC}"/>
               </a:ext>
             </a:extLst>
           </p:cNvPr>
@@ -1390,7 +1390,7 @@
           <p:cNvPr id="4" name="">
             <a:extLst xmlns:a="http://schemas.openxmlformats.org/drawingml/2006/main">
               <a:ext uri="{FF2B5EF4-FFF2-40B4-BE49-F238E27FC236}">
-                <a16:creationId xmlns:a16="http://schemas.microsoft.com/office/drawing/2014/main" id="{5B19EFC8-6033-4283-88AE-9DF3C8AFD15C}"/>
+                <a16:creationId xmlns:a16="http://schemas.microsoft.com/office/drawing/2014/main" id="{FAAFA3B7-C003-4C2B-B775-322F67C1EE19}"/>
               </a:ext>
             </a:extLst>
           </p:cNvPr>
@@ -1454,7 +1454,7 @@
           <p:cNvPr id="5" name="">
             <a:extLst xmlns:a="http://schemas.openxmlformats.org/drawingml/2006/main">
               <a:ext uri="{FF2B5EF4-FFF2-40B4-BE49-F238E27FC236}">
-                <a16:creationId xmlns:a16="http://schemas.microsoft.com/office/drawing/2014/main" id="{C3530E68-CF31-426C-962C-FF1A4FB5224F}"/>
+                <a16:creationId xmlns:a16="http://schemas.microsoft.com/office/drawing/2014/main" id="{ACA85D81-6EB6-4E7B-A2A6-BE6FFC6771B6}"/>
               </a:ext>
             </a:extLst>
           </p:cNvPr>
@@ -1518,7 +1518,7 @@
           <p:cNvPr id="6" name="">
             <a:extLst xmlns:a="http://schemas.openxmlformats.org/drawingml/2006/main">
               <a:ext uri="{FF2B5EF4-FFF2-40B4-BE49-F238E27FC236}">
-                <a16:creationId xmlns:a16="http://schemas.microsoft.com/office/drawing/2014/main" id="{B797A339-7F90-4FC1-9F76-4A2571A687AD}"/>
+                <a16:creationId xmlns:a16="http://schemas.microsoft.com/office/drawing/2014/main" id="{61B135B7-49D4-4561-A0A6-433AB3A8370C}"/>
               </a:ext>
             </a:extLst>
           </p:cNvPr>
@@ -1553,7 +1553,7 @@
           <p:cNvPr id="7" name="">
             <a:extLst xmlns:a="http://schemas.openxmlformats.org/drawingml/2006/main">
               <a:ext uri="{FF2B5EF4-FFF2-40B4-BE49-F238E27FC236}">
-                <a16:creationId xmlns:a16="http://schemas.microsoft.com/office/drawing/2014/main" id="{F90CC83F-9FF3-46A4-93E3-E44D36AA0E98}"/>
+                <a16:creationId xmlns:a16="http://schemas.microsoft.com/office/drawing/2014/main" id="{5E8AE6A9-6AD8-4DA7-A5D7-70E226665CED}"/>
               </a:ext>
             </a:extLst>
           </p:cNvPr>
@@ -1617,7 +1617,7 @@
           <p:cNvPr id="8" name="">
             <a:extLst xmlns:a="http://schemas.openxmlformats.org/drawingml/2006/main">
               <a:ext uri="{FF2B5EF4-FFF2-40B4-BE49-F238E27FC236}">
-                <a16:creationId xmlns:a16="http://schemas.microsoft.com/office/drawing/2014/main" id="{5455CB8B-4B79-4959-BCCC-B0768E08BCB1}"/>
+                <a16:creationId xmlns:a16="http://schemas.microsoft.com/office/drawing/2014/main" id="{163A92B5-18F0-4972-9D4B-08AE89A2B1E8}"/>
               </a:ext>
             </a:extLst>
           </p:cNvPr>
@@ -1681,7 +1681,7 @@
           <p:cNvPr id="9" name="">
             <a:extLst xmlns:a="http://schemas.openxmlformats.org/drawingml/2006/main">
               <a:ext uri="{FF2B5EF4-FFF2-40B4-BE49-F238E27FC236}">
-                <a16:creationId xmlns:a16="http://schemas.microsoft.com/office/drawing/2014/main" id="{35B67680-9792-43CA-8322-036BB7DAE357}"/>
+                <a16:creationId xmlns:a16="http://schemas.microsoft.com/office/drawing/2014/main" id="{3D34F692-3E62-46FD-9621-0F51FF9AF39D}"/>
               </a:ext>
             </a:extLst>
           </p:cNvPr>
@@ -1745,7 +1745,7 @@
           <p:cNvPr id="10" name="">
             <a:extLst xmlns:a="http://schemas.openxmlformats.org/drawingml/2006/main">
               <a:ext uri="{FF2B5EF4-FFF2-40B4-BE49-F238E27FC236}">
-                <a16:creationId xmlns:a16="http://schemas.microsoft.com/office/drawing/2014/main" id="{8CDDDBB2-F445-4873-BCF7-3DC2D7337402}"/>
+                <a16:creationId xmlns:a16="http://schemas.microsoft.com/office/drawing/2014/main" id="{4C52DAE4-4366-426D-9345-2D2EA66250DF}"/>
               </a:ext>
             </a:extLst>
           </p:cNvPr>
@@ -1809,7 +1809,7 @@
           <p:cNvPr id="11" name="">
             <a:extLst xmlns:a="http://schemas.openxmlformats.org/drawingml/2006/main">
               <a:ext uri="{FF2B5EF4-FFF2-40B4-BE49-F238E27FC236}">
-                <a16:creationId xmlns:a16="http://schemas.microsoft.com/office/drawing/2014/main" id="{FABE706C-2661-417E-979D-CCFE9AADB4E3}"/>
+                <a16:creationId xmlns:a16="http://schemas.microsoft.com/office/drawing/2014/main" id="{C61DB2CC-9F3A-4B8D-8771-8D28C9BC2FDF}"/>
               </a:ext>
             </a:extLst>
           </p:cNvPr>
@@ -1873,7 +1873,7 @@
           <p:cNvPr id="12" name="">
             <a:extLst xmlns:a="http://schemas.openxmlformats.org/drawingml/2006/main">
               <a:ext uri="{FF2B5EF4-FFF2-40B4-BE49-F238E27FC236}">
-                <a16:creationId xmlns:a16="http://schemas.microsoft.com/office/drawing/2014/main" id="{87C4FF01-3D3E-439E-BCEE-E35B5BF184FD}"/>
+                <a16:creationId xmlns:a16="http://schemas.microsoft.com/office/drawing/2014/main" id="{99B23077-DBF1-4A00-BC56-AEF1CBD50175}"/>
               </a:ext>
             </a:extLst>
           </p:cNvPr>
@@ -1937,7 +1937,7 @@
           <p:cNvPr id="13" name="">
             <a:extLst xmlns:a="http://schemas.openxmlformats.org/drawingml/2006/main">
               <a:ext uri="{FF2B5EF4-FFF2-40B4-BE49-F238E27FC236}">
-                <a16:creationId xmlns:a16="http://schemas.microsoft.com/office/drawing/2014/main" id="{A60F892E-E723-4A41-9AD8-019A8C430CF3}"/>
+                <a16:creationId xmlns:a16="http://schemas.microsoft.com/office/drawing/2014/main" id="{1799BB6D-DA26-48FD-96C7-19176B190A6A}"/>
               </a:ext>
             </a:extLst>
           </p:cNvPr>
@@ -1972,7 +1972,7 @@
           <p:cNvPr id="14" name="">
             <a:extLst xmlns:a="http://schemas.openxmlformats.org/drawingml/2006/main">
               <a:ext uri="{FF2B5EF4-FFF2-40B4-BE49-F238E27FC236}">
-                <a16:creationId xmlns:a16="http://schemas.microsoft.com/office/drawing/2014/main" id="{95A53FDE-CD7B-4F50-B22D-7862A402A16B}"/>
+                <a16:creationId xmlns:a16="http://schemas.microsoft.com/office/drawing/2014/main" id="{7F6579BE-A891-4DAB-B523-33B10BDB1335}"/>
               </a:ext>
             </a:extLst>
           </p:cNvPr>
@@ -2036,7 +2036,7 @@
           <p:cNvPr id="15" name="">
             <a:extLst xmlns:a="http://schemas.openxmlformats.org/drawingml/2006/main">
               <a:ext uri="{FF2B5EF4-FFF2-40B4-BE49-F238E27FC236}">
-                <a16:creationId xmlns:a16="http://schemas.microsoft.com/office/drawing/2014/main" id="{5308B064-9C9E-4CFB-8F15-C9F4F6246D52}"/>
+                <a16:creationId xmlns:a16="http://schemas.microsoft.com/office/drawing/2014/main" id="{7326CBFF-8247-4DB8-B88F-F0776458A747}"/>
               </a:ext>
             </a:extLst>
           </p:cNvPr>
@@ -2123,19 +2123,19 @@
           <p:cNvPr id="16" name="">
             <a:extLst xmlns:a="http://schemas.openxmlformats.org/drawingml/2006/main">
               <a:ext uri="{FF2B5EF4-FFF2-40B4-BE49-F238E27FC236}">
-                <a16:creationId xmlns:a16="http://schemas.microsoft.com/office/drawing/2014/main" id="{EA63DD07-A2BB-4E5C-B87E-583FC600294F}"/>
-              </a:ext>
-            </a:extLst>
-          </p:cNvPr>
-          <p:cNvSpPr>
-            <a:spLocks xmlns:a="http://schemas.openxmlformats.org/drawingml/2006/main" noGrp="1"/>
-          </p:cNvSpPr>
-          <p:nvPr/>
-        </p:nvSpPr>
-        <p:spPr>
-          <a:xfrm xmlns:a="http://schemas.openxmlformats.org/drawingml/2006/main">
-            <a:off x="723900" y="6096000"/>
-            <a:ext cx="4000500" cy="228600"/>
+                <a16:creationId xmlns:a16="http://schemas.microsoft.com/office/drawing/2014/main" id="{8832A11F-2F8C-45A4-8379-134B355CA6B8}"/>
+              </a:ext>
+            </a:extLst>
+          </p:cNvPr>
+          <p:cNvSpPr>
+            <a:spLocks xmlns:a="http://schemas.openxmlformats.org/drawingml/2006/main" noGrp="1"/>
+          </p:cNvSpPr>
+          <p:nvPr/>
+        </p:nvSpPr>
+        <p:spPr>
+          <a:xfrm xmlns:a="http://schemas.openxmlformats.org/drawingml/2006/main">
+            <a:off x="723900" y="5943600"/>
+            <a:ext cx="4476750" cy="228600"/>
           </a:xfrm>
           <a:prstGeom xmlns:a="http://schemas.openxmlformats.org/drawingml/2006/main" prst="rect">
             <a:avLst/>
@@ -2177,7 +2177,72 @@
                 <a:ea typeface="Aptos"/>
                 <a:cs typeface="Aptos"/>
               </a:rPr>
-              <a:t>2-minute presentation + 1-minute demo</a:t>
+              <a:t>2-minute presentation + 1-minute browser demo</a:t>
+            </a:r>
+          </a:p>
+        </p:txBody>
+      </p:sp>
+      <p:sp>
+        <p:nvSpPr>
+          <p:cNvPr id="17" name="">
+            <a:extLst xmlns:a="http://schemas.openxmlformats.org/drawingml/2006/main">
+              <a:ext uri="{FF2B5EF4-FFF2-40B4-BE49-F238E27FC236}">
+                <a16:creationId xmlns:a16="http://schemas.microsoft.com/office/drawing/2014/main" id="{64763AE2-1C9C-4AEA-9D26-61C54B1FD26F}"/>
+              </a:ext>
+            </a:extLst>
+          </p:cNvPr>
+          <p:cNvSpPr>
+            <a:spLocks xmlns:a="http://schemas.openxmlformats.org/drawingml/2006/main" noGrp="1"/>
+          </p:cNvSpPr>
+          <p:nvPr/>
+        </p:nvSpPr>
+        <p:spPr>
+          <a:xfrm xmlns:a="http://schemas.openxmlformats.org/drawingml/2006/main">
+            <a:off x="723900" y="6191250"/>
+            <a:ext cx="8382000" cy="209550"/>
+          </a:xfrm>
+          <a:prstGeom xmlns:a="http://schemas.openxmlformats.org/drawingml/2006/main" prst="rect">
+            <a:avLst/>
+          </a:prstGeom>
+          <a:solidFill xmlns:a="http://schemas.openxmlformats.org/drawingml/2006/main">
+            <a:srgbClr val="000000">
+              <a:alpha val="0"/>
+            </a:srgbClr>
+          </a:solidFill>
+          <a:ln xmlns:a="http://schemas.openxmlformats.org/drawingml/2006/main" w="0">
+            <a:solidFill>
+              <a:srgbClr val="000000">
+                <a:alpha val="0"/>
+              </a:srgbClr>
+            </a:solidFill>
+            <a:prstDash val="solid"/>
+          </a:ln>
+        </p:spPr>
+        <p:txBody>
+          <a:bodyPr xmlns:a="http://schemas.openxmlformats.org/drawingml/2006/main" lIns="0" tIns="0" rIns="0" bIns="0" anchor="t"/>
+          <a:lstStyle xmlns:a="http://schemas.openxmlformats.org/drawingml/2006/main"/>
+          <a:p xmlns:a="http://schemas.openxmlformats.org/drawingml/2006/main">
+            <a:pPr algn="l">
+              <a:defRPr sz="900" b="0">
+                <a:solidFill>
+                  <a:srgbClr val="D89C27"/>
+                </a:solidFill>
+                <a:latin typeface="Aptos"/>
+                <a:ea typeface="Aptos"/>
+                <a:cs typeface="Aptos"/>
+              </a:defRPr>
+            </a:pPr>
+            <a:r>
+              <a:rPr sz="900" b="0">
+                <a:solidFill>
+                  <a:srgbClr val="D89C27"/>
+                </a:solidFill>
+                <a:latin typeface="Aptos"/>
+                <a:ea typeface="Aptos"/>
+                <a:cs typeface="Aptos"/>
+                <a:hlinkClick xmlns:r="http://schemas.openxmlformats.org/officeDocument/2006/relationships" r:id="rIdSynthAMLDemo"/>
+              </a:rPr>
+              <a:t>https://htmlpreview.github.io/?https://github.com/yq688m3JT/genAI_final/blob/main/docs/demo.html</a:t>
             </a:r>
           </a:p>
         </p:txBody>
@@ -2185,7 +2250,7 @@
     </p:spTree>
     <p:extLst>
       <p:ext uri="{BB962C8B-B14F-4D97-AF65-F5344CB8AC3E}">
-        <p14:creationId xmlns:p14="http://schemas.microsoft.com/office/powerpoint/2010/main" val="1822223100"/>
+        <p14:creationId xmlns:p14="http://schemas.microsoft.com/office/powerpoint/2010/main" val="1629597904"/>
       </p:ext>
     </p:extLst>
   </p:cSld>
@@ -2209,7 +2274,7 @@
           <p:cNvPr id="1" name="">
             <a:extLst xmlns:a="http://schemas.openxmlformats.org/drawingml/2006/main">
               <a:ext uri="{FF2B5EF4-FFF2-40B4-BE49-F238E27FC236}">
-                <a16:creationId xmlns:a16="http://schemas.microsoft.com/office/drawing/2014/main" id="{F8784461-1FA4-45A0-84BA-A04EB717FDC6}"/>
+                <a16:creationId xmlns:a16="http://schemas.microsoft.com/office/drawing/2014/main" id="{BD12FCFD-A299-465B-855D-F2E06015A64C}"/>
               </a:ext>
             </a:extLst>
           </p:cNvPr>
@@ -2244,7 +2309,7 @@
           <p:cNvPr id="2" name="kicker-marker">
             <a:extLst xmlns:a="http://schemas.openxmlformats.org/drawingml/2006/main">
               <a:ext uri="{FF2B5EF4-FFF2-40B4-BE49-F238E27FC236}">
-                <a16:creationId xmlns:a16="http://schemas.microsoft.com/office/drawing/2014/main" id="{597C9AC6-D396-4DBF-8BE2-D90BAFA0207A}"/>
+                <a16:creationId xmlns:a16="http://schemas.microsoft.com/office/drawing/2014/main" id="{C67018B8-9E64-4498-AA5C-9743595D6713}"/>
               </a:ext>
             </a:extLst>
           </p:cNvPr>
@@ -2279,7 +2344,7 @@
           <p:cNvPr id="3" name="kicker-label">
             <a:extLst xmlns:a="http://schemas.openxmlformats.org/drawingml/2006/main">
               <a:ext uri="{FF2B5EF4-FFF2-40B4-BE49-F238E27FC236}">
-                <a16:creationId xmlns:a16="http://schemas.microsoft.com/office/drawing/2014/main" id="{6EAD2A1C-AAD7-4CA7-B310-2FAC551386B1}"/>
+                <a16:creationId xmlns:a16="http://schemas.microsoft.com/office/drawing/2014/main" id="{CF414D0A-82F2-440F-9817-E818AF8DDFAB}"/>
               </a:ext>
             </a:extLst>
           </p:cNvPr>
@@ -2343,7 +2408,7 @@
           <p:cNvPr id="4" name="">
             <a:extLst xmlns:a="http://schemas.openxmlformats.org/drawingml/2006/main">
               <a:ext uri="{FF2B5EF4-FFF2-40B4-BE49-F238E27FC236}">
-                <a16:creationId xmlns:a16="http://schemas.microsoft.com/office/drawing/2014/main" id="{D41E4B94-25AF-4527-ADC9-3175B30833F0}"/>
+                <a16:creationId xmlns:a16="http://schemas.microsoft.com/office/drawing/2014/main" id="{56A4EB11-4A61-48B9-B812-7345884FD2EF}"/>
               </a:ext>
             </a:extLst>
           </p:cNvPr>
@@ -2407,7 +2472,7 @@
           <p:cNvPr id="5" name="">
             <a:extLst xmlns:a="http://schemas.openxmlformats.org/drawingml/2006/main">
               <a:ext uri="{FF2B5EF4-FFF2-40B4-BE49-F238E27FC236}">
-                <a16:creationId xmlns:a16="http://schemas.microsoft.com/office/drawing/2014/main" id="{D8E342B1-00D8-4DA5-B652-723DF8473D69}"/>
+                <a16:creationId xmlns:a16="http://schemas.microsoft.com/office/drawing/2014/main" id="{A4DFABCC-535C-40C6-AD98-E2342074426E}"/>
               </a:ext>
             </a:extLst>
           </p:cNvPr>
@@ -2471,7 +2536,7 @@
           <p:cNvPr id="6" name="">
             <a:extLst xmlns:a="http://schemas.openxmlformats.org/drawingml/2006/main">
               <a:ext uri="{FF2B5EF4-FFF2-40B4-BE49-F238E27FC236}">
-                <a16:creationId xmlns:a16="http://schemas.microsoft.com/office/drawing/2014/main" id="{A751CA0D-D2E2-4DFA-9727-F18994E18E29}"/>
+                <a16:creationId xmlns:a16="http://schemas.microsoft.com/office/drawing/2014/main" id="{73CD1300-CA81-4FB2-A54A-E7C8AEC1DC94}"/>
               </a:ext>
             </a:extLst>
           </p:cNvPr>
@@ -2506,7 +2571,7 @@
           <p:cNvPr id="7" name="">
             <a:extLst xmlns:a="http://schemas.openxmlformats.org/drawingml/2006/main">
               <a:ext uri="{FF2B5EF4-FFF2-40B4-BE49-F238E27FC236}">
-                <a16:creationId xmlns:a16="http://schemas.microsoft.com/office/drawing/2014/main" id="{6E668450-E468-4C45-8F01-B485F41FF0AB}"/>
+                <a16:creationId xmlns:a16="http://schemas.microsoft.com/office/drawing/2014/main" id="{E92598D7-7C89-400E-A5F2-312106320F21}"/>
               </a:ext>
             </a:extLst>
           </p:cNvPr>
@@ -2570,7 +2635,7 @@
           <p:cNvPr id="8" name="">
             <a:extLst xmlns:a="http://schemas.openxmlformats.org/drawingml/2006/main">
               <a:ext uri="{FF2B5EF4-FFF2-40B4-BE49-F238E27FC236}">
-                <a16:creationId xmlns:a16="http://schemas.microsoft.com/office/drawing/2014/main" id="{6EB1FBF4-6ECC-4042-996E-D8BD51F593C9}"/>
+                <a16:creationId xmlns:a16="http://schemas.microsoft.com/office/drawing/2014/main" id="{B5D4B775-FFFF-4402-881D-EF10EDCF5E28}"/>
               </a:ext>
             </a:extLst>
           </p:cNvPr>
@@ -2634,7 +2699,7 @@
           <p:cNvPr id="9" name="">
             <a:extLst xmlns:a="http://schemas.openxmlformats.org/drawingml/2006/main">
               <a:ext uri="{FF2B5EF4-FFF2-40B4-BE49-F238E27FC236}">
-                <a16:creationId xmlns:a16="http://schemas.microsoft.com/office/drawing/2014/main" id="{D252DC6B-7871-410B-A845-3296D57F1F1B}"/>
+                <a16:creationId xmlns:a16="http://schemas.microsoft.com/office/drawing/2014/main" id="{243DFAC6-7E0F-4D11-BE1D-D099F9E093C9}"/>
               </a:ext>
             </a:extLst>
           </p:cNvPr>
@@ -2698,7 +2763,7 @@
           <p:cNvPr id="10" name="">
             <a:extLst xmlns:a="http://schemas.openxmlformats.org/drawingml/2006/main">
               <a:ext uri="{FF2B5EF4-FFF2-40B4-BE49-F238E27FC236}">
-                <a16:creationId xmlns:a16="http://schemas.microsoft.com/office/drawing/2014/main" id="{9B67390B-5ED8-4786-B194-B676D93E3177}"/>
+                <a16:creationId xmlns:a16="http://schemas.microsoft.com/office/drawing/2014/main" id="{DC1AF05A-DADF-4AEE-8557-1B751E724824}"/>
               </a:ext>
             </a:extLst>
           </p:cNvPr>
@@ -2733,7 +2798,7 @@
           <p:cNvPr id="11" name="">
             <a:extLst xmlns:a="http://schemas.openxmlformats.org/drawingml/2006/main">
               <a:ext uri="{FF2B5EF4-FFF2-40B4-BE49-F238E27FC236}">
-                <a16:creationId xmlns:a16="http://schemas.microsoft.com/office/drawing/2014/main" id="{270C31B4-C4CB-44DB-822F-C16713B2BBF7}"/>
+                <a16:creationId xmlns:a16="http://schemas.microsoft.com/office/drawing/2014/main" id="{31223D3E-F8BB-4E18-B4D2-A55C50B7C46E}"/>
               </a:ext>
             </a:extLst>
           </p:cNvPr>
@@ -2768,7 +2833,7 @@
           <p:cNvPr id="12" name="">
             <a:extLst xmlns:a="http://schemas.openxmlformats.org/drawingml/2006/main">
               <a:ext uri="{FF2B5EF4-FFF2-40B4-BE49-F238E27FC236}">
-                <a16:creationId xmlns:a16="http://schemas.microsoft.com/office/drawing/2014/main" id="{C07DFD48-4077-46F6-85E9-144A6DD3D853}"/>
+                <a16:creationId xmlns:a16="http://schemas.microsoft.com/office/drawing/2014/main" id="{E4A53FA3-B9B1-4682-BA2C-9DCA9F614B53}"/>
               </a:ext>
             </a:extLst>
           </p:cNvPr>
@@ -2803,7 +2868,7 @@
           <p:cNvPr id="13" name="">
             <a:extLst xmlns:a="http://schemas.openxmlformats.org/drawingml/2006/main">
               <a:ext uri="{FF2B5EF4-FFF2-40B4-BE49-F238E27FC236}">
-                <a16:creationId xmlns:a16="http://schemas.microsoft.com/office/drawing/2014/main" id="{BFB2E00E-30D7-4502-AEF2-47175908FE55}"/>
+                <a16:creationId xmlns:a16="http://schemas.microsoft.com/office/drawing/2014/main" id="{2B445F89-2580-49F4-9042-B8502465BD55}"/>
               </a:ext>
             </a:extLst>
           </p:cNvPr>
@@ -2867,7 +2932,7 @@
           <p:cNvPr id="14" name="">
             <a:extLst xmlns:a="http://schemas.openxmlformats.org/drawingml/2006/main">
               <a:ext uri="{FF2B5EF4-FFF2-40B4-BE49-F238E27FC236}">
-                <a16:creationId xmlns:a16="http://schemas.microsoft.com/office/drawing/2014/main" id="{E1292E17-F091-42D6-9F50-CA820C0860A0}"/>
+                <a16:creationId xmlns:a16="http://schemas.microsoft.com/office/drawing/2014/main" id="{7828D61B-91B7-456D-9926-64C5418D4E03}"/>
               </a:ext>
             </a:extLst>
           </p:cNvPr>
@@ -2931,7 +2996,7 @@
           <p:cNvPr id="15" name="">
             <a:extLst xmlns:a="http://schemas.openxmlformats.org/drawingml/2006/main">
               <a:ext uri="{FF2B5EF4-FFF2-40B4-BE49-F238E27FC236}">
-                <a16:creationId xmlns:a16="http://schemas.microsoft.com/office/drawing/2014/main" id="{A0A40A22-E153-4342-8367-31E38F7A4C69}"/>
+                <a16:creationId xmlns:a16="http://schemas.microsoft.com/office/drawing/2014/main" id="{A448F15E-47B7-4546-A48F-A30543767D19}"/>
               </a:ext>
             </a:extLst>
           </p:cNvPr>
@@ -2995,7 +3060,7 @@
           <p:cNvPr id="16" name="">
             <a:extLst xmlns:a="http://schemas.openxmlformats.org/drawingml/2006/main">
               <a:ext uri="{FF2B5EF4-FFF2-40B4-BE49-F238E27FC236}">
-                <a16:creationId xmlns:a16="http://schemas.microsoft.com/office/drawing/2014/main" id="{3E4AF0DD-C6D8-4B85-9017-4E6138B7C529}"/>
+                <a16:creationId xmlns:a16="http://schemas.microsoft.com/office/drawing/2014/main" id="{A9645047-24B4-4A98-A75A-D9261051CE39}"/>
               </a:ext>
             </a:extLst>
           </p:cNvPr>
@@ -3030,7 +3095,7 @@
           <p:cNvPr id="17" name="">
             <a:extLst xmlns:a="http://schemas.openxmlformats.org/drawingml/2006/main">
               <a:ext uri="{FF2B5EF4-FFF2-40B4-BE49-F238E27FC236}">
-                <a16:creationId xmlns:a16="http://schemas.microsoft.com/office/drawing/2014/main" id="{8534A143-496E-4863-A90C-0D94A6041AB1}"/>
+                <a16:creationId xmlns:a16="http://schemas.microsoft.com/office/drawing/2014/main" id="{42D66B51-B3E0-4EE3-A93D-97700719099E}"/>
               </a:ext>
             </a:extLst>
           </p:cNvPr>
@@ -3065,7 +3130,7 @@
           <p:cNvPr id="18" name="">
             <a:extLst xmlns:a="http://schemas.openxmlformats.org/drawingml/2006/main">
               <a:ext uri="{FF2B5EF4-FFF2-40B4-BE49-F238E27FC236}">
-                <a16:creationId xmlns:a16="http://schemas.microsoft.com/office/drawing/2014/main" id="{4E6881C6-E553-44F5-BF09-E6B583944044}"/>
+                <a16:creationId xmlns:a16="http://schemas.microsoft.com/office/drawing/2014/main" id="{EADD343E-794F-4A26-B1FD-35A1A2EE867D}"/>
               </a:ext>
             </a:extLst>
           </p:cNvPr>
@@ -3100,7 +3165,7 @@
           <p:cNvPr id="19" name="">
             <a:extLst xmlns:a="http://schemas.openxmlformats.org/drawingml/2006/main">
               <a:ext uri="{FF2B5EF4-FFF2-40B4-BE49-F238E27FC236}">
-                <a16:creationId xmlns:a16="http://schemas.microsoft.com/office/drawing/2014/main" id="{CE7A55AB-9B49-4F9E-8134-D0A275EDED4A}"/>
+                <a16:creationId xmlns:a16="http://schemas.microsoft.com/office/drawing/2014/main" id="{01C0DC76-9011-4EF3-BB4A-999EB4C8DEC4}"/>
               </a:ext>
             </a:extLst>
           </p:cNvPr>
@@ -3164,7 +3229,7 @@
           <p:cNvPr id="20" name="">
             <a:extLst xmlns:a="http://schemas.openxmlformats.org/drawingml/2006/main">
               <a:ext uri="{FF2B5EF4-FFF2-40B4-BE49-F238E27FC236}">
-                <a16:creationId xmlns:a16="http://schemas.microsoft.com/office/drawing/2014/main" id="{084B2571-D12F-4E0A-A3C2-BB2CA51F9541}"/>
+                <a16:creationId xmlns:a16="http://schemas.microsoft.com/office/drawing/2014/main" id="{4479D301-3D39-4F99-9CCC-A9D41AA91960}"/>
               </a:ext>
             </a:extLst>
           </p:cNvPr>
@@ -3228,7 +3293,7 @@
           <p:cNvPr id="21" name="">
             <a:extLst xmlns:a="http://schemas.openxmlformats.org/drawingml/2006/main">
               <a:ext uri="{FF2B5EF4-FFF2-40B4-BE49-F238E27FC236}">
-                <a16:creationId xmlns:a16="http://schemas.microsoft.com/office/drawing/2014/main" id="{9860B8FA-7BBF-45D8-97F7-A360F7D6D177}"/>
+                <a16:creationId xmlns:a16="http://schemas.microsoft.com/office/drawing/2014/main" id="{E2D2EC71-4326-4A9B-98E2-672716173B08}"/>
               </a:ext>
             </a:extLst>
           </p:cNvPr>
@@ -3292,7 +3357,7 @@
           <p:cNvPr id="22" name="">
             <a:extLst xmlns:a="http://schemas.openxmlformats.org/drawingml/2006/main">
               <a:ext uri="{FF2B5EF4-FFF2-40B4-BE49-F238E27FC236}">
-                <a16:creationId xmlns:a16="http://schemas.microsoft.com/office/drawing/2014/main" id="{09F45E3A-9CDE-46EE-B539-F8F20B9220A0}"/>
+                <a16:creationId xmlns:a16="http://schemas.microsoft.com/office/drawing/2014/main" id="{D0CCC9CC-7780-438F-B112-DB7034247546}"/>
               </a:ext>
             </a:extLst>
           </p:cNvPr>
@@ -3325,7 +3390,7 @@
           <p:cNvPr id="23" name="">
             <a:extLst xmlns:a="http://schemas.openxmlformats.org/drawingml/2006/main">
               <a:ext uri="{FF2B5EF4-FFF2-40B4-BE49-F238E27FC236}">
-                <a16:creationId xmlns:a16="http://schemas.microsoft.com/office/drawing/2014/main" id="{E57B4FE9-2924-4FBA-AACB-E6020DDDA109}"/>
+                <a16:creationId xmlns:a16="http://schemas.microsoft.com/office/drawing/2014/main" id="{3C08BD50-B8A1-457A-85FB-CD3F89EB8D01}"/>
               </a:ext>
             </a:extLst>
           </p:cNvPr>
@@ -3389,7 +3454,7 @@
           <p:cNvPr id="24" name="">
             <a:extLst xmlns:a="http://schemas.openxmlformats.org/drawingml/2006/main">
               <a:ext uri="{FF2B5EF4-FFF2-40B4-BE49-F238E27FC236}">
-                <a16:creationId xmlns:a16="http://schemas.microsoft.com/office/drawing/2014/main" id="{FE99F61A-0DF7-42A8-9877-DFE1EA74E784}"/>
+                <a16:creationId xmlns:a16="http://schemas.microsoft.com/office/drawing/2014/main" id="{2338EC48-217F-4DA6-AE35-651BEBD4D018}"/>
               </a:ext>
             </a:extLst>
           </p:cNvPr>
@@ -3476,7 +3541,7 @@
           <p:cNvPr id="25" name="">
             <a:extLst xmlns:a="http://schemas.openxmlformats.org/drawingml/2006/main">
               <a:ext uri="{FF2B5EF4-FFF2-40B4-BE49-F238E27FC236}">
-                <a16:creationId xmlns:a16="http://schemas.microsoft.com/office/drawing/2014/main" id="{4076C7CA-7144-4907-B4FE-B54F8E774F28}"/>
+                <a16:creationId xmlns:a16="http://schemas.microsoft.com/office/drawing/2014/main" id="{9DC3FCEB-16A3-43AD-9994-C4D0A20F4E41}"/>
               </a:ext>
             </a:extLst>
           </p:cNvPr>
@@ -3511,7 +3576,7 @@
           <p:cNvPr id="26" name="">
             <a:extLst xmlns:a="http://schemas.openxmlformats.org/drawingml/2006/main">
               <a:ext uri="{FF2B5EF4-FFF2-40B4-BE49-F238E27FC236}">
-                <a16:creationId xmlns:a16="http://schemas.microsoft.com/office/drawing/2014/main" id="{B6213308-1E61-457F-8523-D89E8A2F37E3}"/>
+                <a16:creationId xmlns:a16="http://schemas.microsoft.com/office/drawing/2014/main" id="{4EC293E9-6B1F-4D83-A2C7-858FF56AFAB4}"/>
               </a:ext>
             </a:extLst>
           </p:cNvPr>
@@ -3573,7 +3638,7 @@
     </p:spTree>
     <p:extLst>
       <p:ext uri="{BB962C8B-B14F-4D97-AF65-F5344CB8AC3E}">
-        <p14:creationId xmlns:p14="http://schemas.microsoft.com/office/powerpoint/2010/main" val="1699724769"/>
+        <p14:creationId xmlns:p14="http://schemas.microsoft.com/office/powerpoint/2010/main" val="2133901943"/>
       </p:ext>
     </p:extLst>
   </p:cSld>
@@ -3597,7 +3662,7 @@
           <p:cNvPr id="1" name="">
             <a:extLst xmlns:a="http://schemas.openxmlformats.org/drawingml/2006/main">
               <a:ext uri="{FF2B5EF4-FFF2-40B4-BE49-F238E27FC236}">
-                <a16:creationId xmlns:a16="http://schemas.microsoft.com/office/drawing/2014/main" id="{CB8AEF2B-0BA1-4B8B-A9D7-D4648473D055}"/>
+                <a16:creationId xmlns:a16="http://schemas.microsoft.com/office/drawing/2014/main" id="{4C266564-A198-46C7-A96A-BFE3CCE4B982}"/>
               </a:ext>
             </a:extLst>
           </p:cNvPr>
@@ -3632,7 +3697,7 @@
           <p:cNvPr id="2" name="kicker-marker">
             <a:extLst xmlns:a="http://schemas.openxmlformats.org/drawingml/2006/main">
               <a:ext uri="{FF2B5EF4-FFF2-40B4-BE49-F238E27FC236}">
-                <a16:creationId xmlns:a16="http://schemas.microsoft.com/office/drawing/2014/main" id="{819E5AB9-D8E7-4940-AFC2-87D3E5B803F0}"/>
+                <a16:creationId xmlns:a16="http://schemas.microsoft.com/office/drawing/2014/main" id="{0198B10E-00AE-47D6-A68F-1D4DEF4B3BCF}"/>
               </a:ext>
             </a:extLst>
           </p:cNvPr>
@@ -3667,7 +3732,7 @@
           <p:cNvPr id="3" name="kicker-label">
             <a:extLst xmlns:a="http://schemas.openxmlformats.org/drawingml/2006/main">
               <a:ext uri="{FF2B5EF4-FFF2-40B4-BE49-F238E27FC236}">
-                <a16:creationId xmlns:a16="http://schemas.microsoft.com/office/drawing/2014/main" id="{25E8E524-A313-4F28-87CC-7BDF4ACEF3A7}"/>
+                <a16:creationId xmlns:a16="http://schemas.microsoft.com/office/drawing/2014/main" id="{7D48C745-66A5-4B28-AF93-3BA29A07E241}"/>
               </a:ext>
             </a:extLst>
           </p:cNvPr>
@@ -3731,7 +3796,7 @@
           <p:cNvPr id="4" name="">
             <a:extLst xmlns:a="http://schemas.openxmlformats.org/drawingml/2006/main">
               <a:ext uri="{FF2B5EF4-FFF2-40B4-BE49-F238E27FC236}">
-                <a16:creationId xmlns:a16="http://schemas.microsoft.com/office/drawing/2014/main" id="{3FF4F2EE-9DD7-47BD-9D67-1FDF8E4D468B}"/>
+                <a16:creationId xmlns:a16="http://schemas.microsoft.com/office/drawing/2014/main" id="{A160CD28-4B71-4656-9F14-661B97A956D1}"/>
               </a:ext>
             </a:extLst>
           </p:cNvPr>
@@ -3795,7 +3860,7 @@
           <p:cNvPr id="5" name="">
             <a:extLst xmlns:a="http://schemas.openxmlformats.org/drawingml/2006/main">
               <a:ext uri="{FF2B5EF4-FFF2-40B4-BE49-F238E27FC236}">
-                <a16:creationId xmlns:a16="http://schemas.microsoft.com/office/drawing/2014/main" id="{B9E7A633-075F-4C82-A288-E201B9CD079D}"/>
+                <a16:creationId xmlns:a16="http://schemas.microsoft.com/office/drawing/2014/main" id="{95BA2513-C0DC-4E92-ABCE-A8A561FD18CE}"/>
               </a:ext>
             </a:extLst>
           </p:cNvPr>
@@ -3830,7 +3895,7 @@
           <p:cNvPr id="6" name="">
             <a:extLst xmlns:a="http://schemas.openxmlformats.org/drawingml/2006/main">
               <a:ext uri="{FF2B5EF4-FFF2-40B4-BE49-F238E27FC236}">
-                <a16:creationId xmlns:a16="http://schemas.microsoft.com/office/drawing/2014/main" id="{F26A5852-0121-4331-BCD3-6B392048E5C0}"/>
+                <a16:creationId xmlns:a16="http://schemas.microsoft.com/office/drawing/2014/main" id="{D08BC09B-357A-4C2B-BB1A-3EE14B04AE06}"/>
               </a:ext>
             </a:extLst>
           </p:cNvPr>
@@ -3894,7 +3959,7 @@
           <p:cNvPr id="7" name="">
             <a:extLst xmlns:a="http://schemas.openxmlformats.org/drawingml/2006/main">
               <a:ext uri="{FF2B5EF4-FFF2-40B4-BE49-F238E27FC236}">
-                <a16:creationId xmlns:a16="http://schemas.microsoft.com/office/drawing/2014/main" id="{870909AE-BFCB-444D-AE36-62EB301E4E6D}"/>
+                <a16:creationId xmlns:a16="http://schemas.microsoft.com/office/drawing/2014/main" id="{1024DF80-E79B-41FE-8CD7-DEF018C9AD6B}"/>
               </a:ext>
             </a:extLst>
           </p:cNvPr>
@@ -3927,7 +3992,7 @@
           <p:cNvPr id="8" name="">
             <a:extLst xmlns:a="http://schemas.openxmlformats.org/drawingml/2006/main">
               <a:ext uri="{FF2B5EF4-FFF2-40B4-BE49-F238E27FC236}">
-                <a16:creationId xmlns:a16="http://schemas.microsoft.com/office/drawing/2014/main" id="{54FB02E0-6C94-4613-B402-E0622C8FD0C6}"/>
+                <a16:creationId xmlns:a16="http://schemas.microsoft.com/office/drawing/2014/main" id="{93F12E5E-5F6C-4A4E-964E-734C62F428A7}"/>
               </a:ext>
             </a:extLst>
           </p:cNvPr>
@@ -3991,7 +4056,7 @@
           <p:cNvPr id="9" name="">
             <a:extLst xmlns:a="http://schemas.openxmlformats.org/drawingml/2006/main">
               <a:ext uri="{FF2B5EF4-FFF2-40B4-BE49-F238E27FC236}">
-                <a16:creationId xmlns:a16="http://schemas.microsoft.com/office/drawing/2014/main" id="{BF20EF37-ED7A-4920-8A68-E0B470BAD23A}"/>
+                <a16:creationId xmlns:a16="http://schemas.microsoft.com/office/drawing/2014/main" id="{F6A8D19A-4E66-498D-ACBC-AF25045A429E}"/>
               </a:ext>
             </a:extLst>
           </p:cNvPr>
@@ -4055,7 +4120,7 @@
           <p:cNvPr id="10" name="">
             <a:extLst xmlns:a="http://schemas.openxmlformats.org/drawingml/2006/main">
               <a:ext uri="{FF2B5EF4-FFF2-40B4-BE49-F238E27FC236}">
-                <a16:creationId xmlns:a16="http://schemas.microsoft.com/office/drawing/2014/main" id="{2F183BB8-B702-4829-9F97-C875D66D2A05}"/>
+                <a16:creationId xmlns:a16="http://schemas.microsoft.com/office/drawing/2014/main" id="{27D32E11-4256-41E2-969E-624C505D3A51}"/>
               </a:ext>
             </a:extLst>
           </p:cNvPr>
@@ -4119,7 +4184,7 @@
           <p:cNvPr id="11" name="">
             <a:extLst xmlns:a="http://schemas.openxmlformats.org/drawingml/2006/main">
               <a:ext uri="{FF2B5EF4-FFF2-40B4-BE49-F238E27FC236}">
-                <a16:creationId xmlns:a16="http://schemas.microsoft.com/office/drawing/2014/main" id="{F900D429-73FA-488B-BFC9-BD0B403B925F}"/>
+                <a16:creationId xmlns:a16="http://schemas.microsoft.com/office/drawing/2014/main" id="{E368E1D7-44C4-4768-8AC8-A90F722998CE}"/>
               </a:ext>
             </a:extLst>
           </p:cNvPr>
@@ -4154,7 +4219,7 @@
           <p:cNvPr id="12" name="">
             <a:extLst xmlns:a="http://schemas.openxmlformats.org/drawingml/2006/main">
               <a:ext uri="{FF2B5EF4-FFF2-40B4-BE49-F238E27FC236}">
-                <a16:creationId xmlns:a16="http://schemas.microsoft.com/office/drawing/2014/main" id="{B7B7DE90-FEC8-46C5-A540-4E0B5D1CDDFF}"/>
+                <a16:creationId xmlns:a16="http://schemas.microsoft.com/office/drawing/2014/main" id="{857562AE-4BFF-45B1-9443-2CAE1F6F84A7}"/>
               </a:ext>
             </a:extLst>
           </p:cNvPr>
@@ -4189,7 +4254,7 @@
           <p:cNvPr id="13" name="">
             <a:extLst xmlns:a="http://schemas.openxmlformats.org/drawingml/2006/main">
               <a:ext uri="{FF2B5EF4-FFF2-40B4-BE49-F238E27FC236}">
-                <a16:creationId xmlns:a16="http://schemas.microsoft.com/office/drawing/2014/main" id="{90A05EFA-C1CA-4CBF-8601-63E32F6C209E}"/>
+                <a16:creationId xmlns:a16="http://schemas.microsoft.com/office/drawing/2014/main" id="{DE1FBEE7-7377-4616-834B-D66F2B079166}"/>
               </a:ext>
             </a:extLst>
           </p:cNvPr>
@@ -4222,7 +4287,7 @@
           <p:cNvPr id="14" name="">
             <a:extLst xmlns:a="http://schemas.openxmlformats.org/drawingml/2006/main">
               <a:ext uri="{FF2B5EF4-FFF2-40B4-BE49-F238E27FC236}">
-                <a16:creationId xmlns:a16="http://schemas.microsoft.com/office/drawing/2014/main" id="{056B04BA-1B9A-4612-980D-E08F629C7CCF}"/>
+                <a16:creationId xmlns:a16="http://schemas.microsoft.com/office/drawing/2014/main" id="{B7966E9B-2FC5-4E70-98A5-80296EFB483D}"/>
               </a:ext>
             </a:extLst>
           </p:cNvPr>
@@ -4286,7 +4351,7 @@
           <p:cNvPr id="15" name="">
             <a:extLst xmlns:a="http://schemas.openxmlformats.org/drawingml/2006/main">
               <a:ext uri="{FF2B5EF4-FFF2-40B4-BE49-F238E27FC236}">
-                <a16:creationId xmlns:a16="http://schemas.microsoft.com/office/drawing/2014/main" id="{8B409F2C-F2F9-45FA-967A-C8997019011C}"/>
+                <a16:creationId xmlns:a16="http://schemas.microsoft.com/office/drawing/2014/main" id="{F47723CA-9137-4387-A6C5-901383C14149}"/>
               </a:ext>
             </a:extLst>
           </p:cNvPr>
@@ -4350,7 +4415,7 @@
           <p:cNvPr id="16" name="">
             <a:extLst xmlns:a="http://schemas.openxmlformats.org/drawingml/2006/main">
               <a:ext uri="{FF2B5EF4-FFF2-40B4-BE49-F238E27FC236}">
-                <a16:creationId xmlns:a16="http://schemas.microsoft.com/office/drawing/2014/main" id="{E5508AA0-11CB-4F2E-B06D-45630A21937A}"/>
+                <a16:creationId xmlns:a16="http://schemas.microsoft.com/office/drawing/2014/main" id="{C589A8C7-2738-4222-8EA4-BB2829091788}"/>
               </a:ext>
             </a:extLst>
           </p:cNvPr>
@@ -4414,7 +4479,7 @@
           <p:cNvPr id="17" name="">
             <a:extLst xmlns:a="http://schemas.openxmlformats.org/drawingml/2006/main">
               <a:ext uri="{FF2B5EF4-FFF2-40B4-BE49-F238E27FC236}">
-                <a16:creationId xmlns:a16="http://schemas.microsoft.com/office/drawing/2014/main" id="{3F671744-00BE-4CF3-B579-7E2E81340AD8}"/>
+                <a16:creationId xmlns:a16="http://schemas.microsoft.com/office/drawing/2014/main" id="{EC74C98D-BFE8-4986-8BEA-82A979FA4C7D}"/>
               </a:ext>
             </a:extLst>
           </p:cNvPr>
@@ -4449,7 +4514,7 @@
           <p:cNvPr id="18" name="">
             <a:extLst xmlns:a="http://schemas.openxmlformats.org/drawingml/2006/main">
               <a:ext uri="{FF2B5EF4-FFF2-40B4-BE49-F238E27FC236}">
-                <a16:creationId xmlns:a16="http://schemas.microsoft.com/office/drawing/2014/main" id="{ACF95708-B27B-47E1-AA41-A202B09E0C1F}"/>
+                <a16:creationId xmlns:a16="http://schemas.microsoft.com/office/drawing/2014/main" id="{D3AC09C9-9B4D-4F6C-944A-83D8E8E3342B}"/>
               </a:ext>
             </a:extLst>
           </p:cNvPr>
@@ -4484,7 +4549,7 @@
           <p:cNvPr id="19" name="">
             <a:extLst xmlns:a="http://schemas.openxmlformats.org/drawingml/2006/main">
               <a:ext uri="{FF2B5EF4-FFF2-40B4-BE49-F238E27FC236}">
-                <a16:creationId xmlns:a16="http://schemas.microsoft.com/office/drawing/2014/main" id="{6286D67A-95E0-4277-A4E6-AA4F581A5C6F}"/>
+                <a16:creationId xmlns:a16="http://schemas.microsoft.com/office/drawing/2014/main" id="{1240B36C-2CA7-47FF-A58A-3463955EA03C}"/>
               </a:ext>
             </a:extLst>
           </p:cNvPr>
@@ -4517,7 +4582,7 @@
           <p:cNvPr id="20" name="">
             <a:extLst xmlns:a="http://schemas.openxmlformats.org/drawingml/2006/main">
               <a:ext uri="{FF2B5EF4-FFF2-40B4-BE49-F238E27FC236}">
-                <a16:creationId xmlns:a16="http://schemas.microsoft.com/office/drawing/2014/main" id="{C64845EE-CA8E-4218-AA2C-9227B6B099BB}"/>
+                <a16:creationId xmlns:a16="http://schemas.microsoft.com/office/drawing/2014/main" id="{45B8D1AD-A092-4802-BFFC-1061E2A503E7}"/>
               </a:ext>
             </a:extLst>
           </p:cNvPr>
@@ -4581,7 +4646,7 @@
           <p:cNvPr id="21" name="">
             <a:extLst xmlns:a="http://schemas.openxmlformats.org/drawingml/2006/main">
               <a:ext uri="{FF2B5EF4-FFF2-40B4-BE49-F238E27FC236}">
-                <a16:creationId xmlns:a16="http://schemas.microsoft.com/office/drawing/2014/main" id="{0C38BE44-218A-4678-806F-134A466683C6}"/>
+                <a16:creationId xmlns:a16="http://schemas.microsoft.com/office/drawing/2014/main" id="{50842E13-AB89-4989-B3D9-5AC34D7FB6FE}"/>
               </a:ext>
             </a:extLst>
           </p:cNvPr>
@@ -4645,7 +4710,7 @@
           <p:cNvPr id="22" name="">
             <a:extLst xmlns:a="http://schemas.openxmlformats.org/drawingml/2006/main">
               <a:ext uri="{FF2B5EF4-FFF2-40B4-BE49-F238E27FC236}">
-                <a16:creationId xmlns:a16="http://schemas.microsoft.com/office/drawing/2014/main" id="{B42FD6CC-60E2-4F5F-A75C-22B097206924}"/>
+                <a16:creationId xmlns:a16="http://schemas.microsoft.com/office/drawing/2014/main" id="{240E48A1-FE60-4EB4-AFD7-2FEF2CCD5789}"/>
               </a:ext>
             </a:extLst>
           </p:cNvPr>
@@ -4709,7 +4774,7 @@
           <p:cNvPr id="23" name="">
             <a:extLst xmlns:a="http://schemas.openxmlformats.org/drawingml/2006/main">
               <a:ext uri="{FF2B5EF4-FFF2-40B4-BE49-F238E27FC236}">
-                <a16:creationId xmlns:a16="http://schemas.microsoft.com/office/drawing/2014/main" id="{1EF63095-4E80-4B41-8121-D0F3F274E57E}"/>
+                <a16:creationId xmlns:a16="http://schemas.microsoft.com/office/drawing/2014/main" id="{48614DCE-7BAB-45FF-B5B8-11BB80F16CC0}"/>
               </a:ext>
             </a:extLst>
           </p:cNvPr>
@@ -4744,7 +4809,7 @@
           <p:cNvPr id="24" name="">
             <a:extLst xmlns:a="http://schemas.openxmlformats.org/drawingml/2006/main">
               <a:ext uri="{FF2B5EF4-FFF2-40B4-BE49-F238E27FC236}">
-                <a16:creationId xmlns:a16="http://schemas.microsoft.com/office/drawing/2014/main" id="{EDD30F11-79A1-42AF-BDA7-182F20D8EB2C}"/>
+                <a16:creationId xmlns:a16="http://schemas.microsoft.com/office/drawing/2014/main" id="{CB2DC128-7D84-4721-8C8A-C3FC9DE49613}"/>
               </a:ext>
             </a:extLst>
           </p:cNvPr>
@@ -4779,7 +4844,7 @@
           <p:cNvPr id="25" name="">
             <a:extLst xmlns:a="http://schemas.openxmlformats.org/drawingml/2006/main">
               <a:ext uri="{FF2B5EF4-FFF2-40B4-BE49-F238E27FC236}">
-                <a16:creationId xmlns:a16="http://schemas.microsoft.com/office/drawing/2014/main" id="{244D8212-F905-4D31-9660-A13F806CE064}"/>
+                <a16:creationId xmlns:a16="http://schemas.microsoft.com/office/drawing/2014/main" id="{D075BD38-1805-404E-AE35-64E4B2FE03F5}"/>
               </a:ext>
             </a:extLst>
           </p:cNvPr>
@@ -4812,7 +4877,7 @@
           <p:cNvPr id="26" name="">
             <a:extLst xmlns:a="http://schemas.openxmlformats.org/drawingml/2006/main">
               <a:ext uri="{FF2B5EF4-FFF2-40B4-BE49-F238E27FC236}">
-                <a16:creationId xmlns:a16="http://schemas.microsoft.com/office/drawing/2014/main" id="{52BFA641-DAD7-4097-81CD-D3D7F57FB982}"/>
+                <a16:creationId xmlns:a16="http://schemas.microsoft.com/office/drawing/2014/main" id="{158288C1-5F96-41CB-A789-60C4E5227364}"/>
               </a:ext>
             </a:extLst>
           </p:cNvPr>
@@ -4876,7 +4941,7 @@
           <p:cNvPr id="27" name="">
             <a:extLst xmlns:a="http://schemas.openxmlformats.org/drawingml/2006/main">
               <a:ext uri="{FF2B5EF4-FFF2-40B4-BE49-F238E27FC236}">
-                <a16:creationId xmlns:a16="http://schemas.microsoft.com/office/drawing/2014/main" id="{2615AA31-B8C0-4E1E-AB80-95AA4E7E8AD0}"/>
+                <a16:creationId xmlns:a16="http://schemas.microsoft.com/office/drawing/2014/main" id="{E472F842-2876-4646-AFAB-CCF80EA53F57}"/>
               </a:ext>
             </a:extLst>
           </p:cNvPr>
@@ -4940,7 +5005,7 @@
           <p:cNvPr id="28" name="">
             <a:extLst xmlns:a="http://schemas.openxmlformats.org/drawingml/2006/main">
               <a:ext uri="{FF2B5EF4-FFF2-40B4-BE49-F238E27FC236}">
-                <a16:creationId xmlns:a16="http://schemas.microsoft.com/office/drawing/2014/main" id="{2A7C0EE2-EA57-4C4B-8462-DD78031EB39D}"/>
+                <a16:creationId xmlns:a16="http://schemas.microsoft.com/office/drawing/2014/main" id="{F2D612F3-8018-4644-9484-D3DAE86DB012}"/>
               </a:ext>
             </a:extLst>
           </p:cNvPr>
@@ -5004,7 +5069,7 @@
           <p:cNvPr id="29" name="">
             <a:extLst xmlns:a="http://schemas.openxmlformats.org/drawingml/2006/main">
               <a:ext uri="{FF2B5EF4-FFF2-40B4-BE49-F238E27FC236}">
-                <a16:creationId xmlns:a16="http://schemas.microsoft.com/office/drawing/2014/main" id="{95201D86-F761-470C-B376-E7D616389336}"/>
+                <a16:creationId xmlns:a16="http://schemas.microsoft.com/office/drawing/2014/main" id="{18ABAE1C-873D-4E2D-A78A-CF4996A975C8}"/>
               </a:ext>
             </a:extLst>
           </p:cNvPr>
@@ -5066,7 +5131,7 @@
     </p:spTree>
     <p:extLst>
       <p:ext uri="{BB962C8B-B14F-4D97-AF65-F5344CB8AC3E}">
-        <p14:creationId xmlns:p14="http://schemas.microsoft.com/office/powerpoint/2010/main" val="797263180"/>
+        <p14:creationId xmlns:p14="http://schemas.microsoft.com/office/powerpoint/2010/main" val="1831984101"/>
       </p:ext>
     </p:extLst>
   </p:cSld>
@@ -5090,7 +5155,7 @@
           <p:cNvPr id="1" name="">
             <a:extLst xmlns:a="http://schemas.openxmlformats.org/drawingml/2006/main">
               <a:ext uri="{FF2B5EF4-FFF2-40B4-BE49-F238E27FC236}">
-                <a16:creationId xmlns:a16="http://schemas.microsoft.com/office/drawing/2014/main" id="{0ED13EA2-0119-401D-A212-018CC24AC867}"/>
+                <a16:creationId xmlns:a16="http://schemas.microsoft.com/office/drawing/2014/main" id="{96628CBB-756C-47C2-B876-05DA0E9747CD}"/>
               </a:ext>
             </a:extLst>
           </p:cNvPr>
@@ -5125,7 +5190,7 @@
           <p:cNvPr id="2" name="kicker-marker">
             <a:extLst xmlns:a="http://schemas.openxmlformats.org/drawingml/2006/main">
               <a:ext uri="{FF2B5EF4-FFF2-40B4-BE49-F238E27FC236}">
-                <a16:creationId xmlns:a16="http://schemas.microsoft.com/office/drawing/2014/main" id="{9F4A47D4-92B2-4FBE-BB6D-C8E502ADF6B4}"/>
+                <a16:creationId xmlns:a16="http://schemas.microsoft.com/office/drawing/2014/main" id="{1D521910-13E1-402C-8253-0269B00AB4DD}"/>
               </a:ext>
             </a:extLst>
           </p:cNvPr>
@@ -5160,7 +5225,7 @@
           <p:cNvPr id="3" name="kicker-label">
             <a:extLst xmlns:a="http://schemas.openxmlformats.org/drawingml/2006/main">
               <a:ext uri="{FF2B5EF4-FFF2-40B4-BE49-F238E27FC236}">
-                <a16:creationId xmlns:a16="http://schemas.microsoft.com/office/drawing/2014/main" id="{A6856841-C7DF-4788-B3F0-1D96279B81C9}"/>
+                <a16:creationId xmlns:a16="http://schemas.microsoft.com/office/drawing/2014/main" id="{835FBF75-1B03-4F95-9756-FDBCA7321B0B}"/>
               </a:ext>
             </a:extLst>
           </p:cNvPr>
@@ -5224,7 +5289,7 @@
           <p:cNvPr id="4" name="">
             <a:extLst xmlns:a="http://schemas.openxmlformats.org/drawingml/2006/main">
               <a:ext uri="{FF2B5EF4-FFF2-40B4-BE49-F238E27FC236}">
-                <a16:creationId xmlns:a16="http://schemas.microsoft.com/office/drawing/2014/main" id="{D8DA40C9-08FD-47AC-BBB4-D730056B7E2D}"/>
+                <a16:creationId xmlns:a16="http://schemas.microsoft.com/office/drawing/2014/main" id="{06933046-58FE-4AA5-ACB9-B2DAC9EF2046}"/>
               </a:ext>
             </a:extLst>
           </p:cNvPr>
@@ -5288,7 +5353,7 @@
           <p:cNvPr id="5" name="">
             <a:extLst xmlns:a="http://schemas.openxmlformats.org/drawingml/2006/main">
               <a:ext uri="{FF2B5EF4-FFF2-40B4-BE49-F238E27FC236}">
-                <a16:creationId xmlns:a16="http://schemas.microsoft.com/office/drawing/2014/main" id="{8CE9E1CC-ED8F-4007-A31D-324F2232D18E}"/>
+                <a16:creationId xmlns:a16="http://schemas.microsoft.com/office/drawing/2014/main" id="{ADD7C837-6D93-45A2-BBD9-1C64D6984057}"/>
               </a:ext>
             </a:extLst>
           </p:cNvPr>
@@ -5323,7 +5388,7 @@
           <p:cNvPr id="6" name="">
             <a:extLst xmlns:a="http://schemas.openxmlformats.org/drawingml/2006/main">
               <a:ext uri="{FF2B5EF4-FFF2-40B4-BE49-F238E27FC236}">
-                <a16:creationId xmlns:a16="http://schemas.microsoft.com/office/drawing/2014/main" id="{0AAABD33-9740-4C75-8ED2-6B82818D5402}"/>
+                <a16:creationId xmlns:a16="http://schemas.microsoft.com/office/drawing/2014/main" id="{73C09832-DACD-4483-A64E-0D67B02EFC65}"/>
               </a:ext>
             </a:extLst>
           </p:cNvPr>
@@ -5387,7 +5452,7 @@
           <p:cNvPr id="7" name="">
             <a:extLst xmlns:a="http://schemas.openxmlformats.org/drawingml/2006/main">
               <a:ext uri="{FF2B5EF4-FFF2-40B4-BE49-F238E27FC236}">
-                <a16:creationId xmlns:a16="http://schemas.microsoft.com/office/drawing/2014/main" id="{DCC6D887-3C6F-49B1-BDE5-807FFE62F3AA}"/>
+                <a16:creationId xmlns:a16="http://schemas.microsoft.com/office/drawing/2014/main" id="{681198B2-4E8E-410F-9934-8C3D908FA60A}"/>
               </a:ext>
             </a:extLst>
           </p:cNvPr>
@@ -5451,7 +5516,7 @@
           <p:cNvPr id="8" name="">
             <a:extLst xmlns:a="http://schemas.openxmlformats.org/drawingml/2006/main">
               <a:ext uri="{FF2B5EF4-FFF2-40B4-BE49-F238E27FC236}">
-                <a16:creationId xmlns:a16="http://schemas.microsoft.com/office/drawing/2014/main" id="{7374FEC4-21FE-4C0B-89AF-D6E0CF2FEEF2}"/>
+                <a16:creationId xmlns:a16="http://schemas.microsoft.com/office/drawing/2014/main" id="{C6FF0B92-02BF-4679-9FDF-46ABF9FFFADC}"/>
               </a:ext>
             </a:extLst>
           </p:cNvPr>
@@ -5515,7 +5580,7 @@
           <p:cNvPr id="9" name="">
             <a:extLst xmlns:a="http://schemas.openxmlformats.org/drawingml/2006/main">
               <a:ext uri="{FF2B5EF4-FFF2-40B4-BE49-F238E27FC236}">
-                <a16:creationId xmlns:a16="http://schemas.microsoft.com/office/drawing/2014/main" id="{A9E371B7-6FAA-4358-8C5C-7D8B2C939AFF}"/>
+                <a16:creationId xmlns:a16="http://schemas.microsoft.com/office/drawing/2014/main" id="{3EBEA270-D0CC-487D-8055-C2370BAD86DD}"/>
               </a:ext>
             </a:extLst>
           </p:cNvPr>
@@ -5550,7 +5615,7 @@
           <p:cNvPr id="10" name="">
             <a:extLst xmlns:a="http://schemas.openxmlformats.org/drawingml/2006/main">
               <a:ext uri="{FF2B5EF4-FFF2-40B4-BE49-F238E27FC236}">
-                <a16:creationId xmlns:a16="http://schemas.microsoft.com/office/drawing/2014/main" id="{F973E5A7-3D53-424A-8F78-F80407834534}"/>
+                <a16:creationId xmlns:a16="http://schemas.microsoft.com/office/drawing/2014/main" id="{975FDB48-3BD5-405E-A3A8-3D693623F1FB}"/>
               </a:ext>
             </a:extLst>
           </p:cNvPr>
@@ -5585,7 +5650,7 @@
           <p:cNvPr id="11" name="">
             <a:extLst xmlns:a="http://schemas.openxmlformats.org/drawingml/2006/main">
               <a:ext uri="{FF2B5EF4-FFF2-40B4-BE49-F238E27FC236}">
-                <a16:creationId xmlns:a16="http://schemas.microsoft.com/office/drawing/2014/main" id="{832D236E-9BA5-43C4-B582-74A621BC0E67}"/>
+                <a16:creationId xmlns:a16="http://schemas.microsoft.com/office/drawing/2014/main" id="{87FAD459-595C-41EB-BDB6-7C0434F04E8D}"/>
               </a:ext>
             </a:extLst>
           </p:cNvPr>
@@ -5649,7 +5714,7 @@
           <p:cNvPr id="12" name="">
             <a:extLst xmlns:a="http://schemas.openxmlformats.org/drawingml/2006/main">
               <a:ext uri="{FF2B5EF4-FFF2-40B4-BE49-F238E27FC236}">
-                <a16:creationId xmlns:a16="http://schemas.microsoft.com/office/drawing/2014/main" id="{50AF70C2-1535-4453-8ABC-AF44F297067B}"/>
+                <a16:creationId xmlns:a16="http://schemas.microsoft.com/office/drawing/2014/main" id="{19C40FDC-A5B3-41FA-893C-B86B6C23EBA2}"/>
               </a:ext>
             </a:extLst>
           </p:cNvPr>
@@ -5713,7 +5778,7 @@
           <p:cNvPr id="13" name="">
             <a:extLst xmlns:a="http://schemas.openxmlformats.org/drawingml/2006/main">
               <a:ext uri="{FF2B5EF4-FFF2-40B4-BE49-F238E27FC236}">
-                <a16:creationId xmlns:a16="http://schemas.microsoft.com/office/drawing/2014/main" id="{B58BB810-0875-444B-94C4-D2FCE74DBF84}"/>
+                <a16:creationId xmlns:a16="http://schemas.microsoft.com/office/drawing/2014/main" id="{656F812B-B58E-49A7-B394-AB1A9C1CABFA}"/>
               </a:ext>
             </a:extLst>
           </p:cNvPr>
@@ -5748,7 +5813,7 @@
           <p:cNvPr id="14" name="">
             <a:extLst xmlns:a="http://schemas.openxmlformats.org/drawingml/2006/main">
               <a:ext uri="{FF2B5EF4-FFF2-40B4-BE49-F238E27FC236}">
-                <a16:creationId xmlns:a16="http://schemas.microsoft.com/office/drawing/2014/main" id="{C82465F0-6B5D-4055-8714-339C2B3A67CA}"/>
+                <a16:creationId xmlns:a16="http://schemas.microsoft.com/office/drawing/2014/main" id="{5E4E202F-685C-404D-9761-3C7EB7E1A8F6}"/>
               </a:ext>
             </a:extLst>
           </p:cNvPr>
@@ -5783,7 +5848,7 @@
           <p:cNvPr id="15" name="">
             <a:extLst xmlns:a="http://schemas.openxmlformats.org/drawingml/2006/main">
               <a:ext uri="{FF2B5EF4-FFF2-40B4-BE49-F238E27FC236}">
-                <a16:creationId xmlns:a16="http://schemas.microsoft.com/office/drawing/2014/main" id="{4B1ADC59-FDE3-44EC-8F67-BF67FF757ADE}"/>
+                <a16:creationId xmlns:a16="http://schemas.microsoft.com/office/drawing/2014/main" id="{DE8221C8-60E6-4A48-8B53-36FB9BF57840}"/>
               </a:ext>
             </a:extLst>
           </p:cNvPr>
@@ -5847,7 +5912,7 @@
           <p:cNvPr id="16" name="">
             <a:extLst xmlns:a="http://schemas.openxmlformats.org/drawingml/2006/main">
               <a:ext uri="{FF2B5EF4-FFF2-40B4-BE49-F238E27FC236}">
-                <a16:creationId xmlns:a16="http://schemas.microsoft.com/office/drawing/2014/main" id="{AE476ED7-3B51-4DFD-AAE8-9A5EA2B1DEA8}"/>
+                <a16:creationId xmlns:a16="http://schemas.microsoft.com/office/drawing/2014/main" id="{D01767BB-B855-438F-A255-920C7F14697F}"/>
               </a:ext>
             </a:extLst>
           </p:cNvPr>
@@ -5882,7 +5947,7 @@
           <p:cNvPr id="17" name="">
             <a:extLst xmlns:a="http://schemas.openxmlformats.org/drawingml/2006/main">
               <a:ext uri="{FF2B5EF4-FFF2-40B4-BE49-F238E27FC236}">
-                <a16:creationId xmlns:a16="http://schemas.microsoft.com/office/drawing/2014/main" id="{5C408440-0126-4B99-BCB2-AEE9248B33EA}"/>
+                <a16:creationId xmlns:a16="http://schemas.microsoft.com/office/drawing/2014/main" id="{6D8BF01A-DCFD-4F54-8D84-4D02170294BD}"/>
               </a:ext>
             </a:extLst>
           </p:cNvPr>
@@ -5946,7 +6011,7 @@
           <p:cNvPr id="18" name="">
             <a:extLst xmlns:a="http://schemas.openxmlformats.org/drawingml/2006/main">
               <a:ext uri="{FF2B5EF4-FFF2-40B4-BE49-F238E27FC236}">
-                <a16:creationId xmlns:a16="http://schemas.microsoft.com/office/drawing/2014/main" id="{3146A3B5-527F-468C-8090-188D98ADBE1F}"/>
+                <a16:creationId xmlns:a16="http://schemas.microsoft.com/office/drawing/2014/main" id="{0C1C89AB-7666-48F7-86BC-773BF23BC161}"/>
               </a:ext>
             </a:extLst>
           </p:cNvPr>
@@ -5981,7 +6046,7 @@
           <p:cNvPr id="19" name="">
             <a:extLst xmlns:a="http://schemas.openxmlformats.org/drawingml/2006/main">
               <a:ext uri="{FF2B5EF4-FFF2-40B4-BE49-F238E27FC236}">
-                <a16:creationId xmlns:a16="http://schemas.microsoft.com/office/drawing/2014/main" id="{3D09F1BB-1714-4255-A499-A4F480B722BF}"/>
+                <a16:creationId xmlns:a16="http://schemas.microsoft.com/office/drawing/2014/main" id="{E6BF35F8-B54C-4CAB-9750-3773B0AB962B}"/>
               </a:ext>
             </a:extLst>
           </p:cNvPr>
@@ -6045,7 +6110,7 @@
           <p:cNvPr id="20" name="">
             <a:extLst xmlns:a="http://schemas.openxmlformats.org/drawingml/2006/main">
               <a:ext uri="{FF2B5EF4-FFF2-40B4-BE49-F238E27FC236}">
-                <a16:creationId xmlns:a16="http://schemas.microsoft.com/office/drawing/2014/main" id="{26A57FB9-A6B2-49CD-9CCA-8E354A277BDC}"/>
+                <a16:creationId xmlns:a16="http://schemas.microsoft.com/office/drawing/2014/main" id="{46697C58-9C5E-44B5-A2F7-B7B6FC05C026}"/>
               </a:ext>
             </a:extLst>
           </p:cNvPr>
@@ -6080,7 +6145,7 @@
           <p:cNvPr id="21" name="">
             <a:extLst xmlns:a="http://schemas.openxmlformats.org/drawingml/2006/main">
               <a:ext uri="{FF2B5EF4-FFF2-40B4-BE49-F238E27FC236}">
-                <a16:creationId xmlns:a16="http://schemas.microsoft.com/office/drawing/2014/main" id="{14133D92-D0C9-478C-AD18-584944A51033}"/>
+                <a16:creationId xmlns:a16="http://schemas.microsoft.com/office/drawing/2014/main" id="{4129D0D3-9B9E-4B79-ACA2-49F02C2A82E9}"/>
               </a:ext>
             </a:extLst>
           </p:cNvPr>
@@ -6144,7 +6209,7 @@
           <p:cNvPr id="22" name="">
             <a:extLst xmlns:a="http://schemas.openxmlformats.org/drawingml/2006/main">
               <a:ext uri="{FF2B5EF4-FFF2-40B4-BE49-F238E27FC236}">
-                <a16:creationId xmlns:a16="http://schemas.microsoft.com/office/drawing/2014/main" id="{96D9C75E-4363-44F5-9CBD-397947762013}"/>
+                <a16:creationId xmlns:a16="http://schemas.microsoft.com/office/drawing/2014/main" id="{151CB81B-D743-44FA-9A4A-7B806B5BE8DA}"/>
               </a:ext>
             </a:extLst>
           </p:cNvPr>
@@ -6179,7 +6244,7 @@
           <p:cNvPr id="23" name="">
             <a:extLst xmlns:a="http://schemas.openxmlformats.org/drawingml/2006/main">
               <a:ext uri="{FF2B5EF4-FFF2-40B4-BE49-F238E27FC236}">
-                <a16:creationId xmlns:a16="http://schemas.microsoft.com/office/drawing/2014/main" id="{91BEEAAF-5A30-42DE-B8C6-EC3B859569C1}"/>
+                <a16:creationId xmlns:a16="http://schemas.microsoft.com/office/drawing/2014/main" id="{72D8FDC4-132B-470A-B829-781450D29FBA}"/>
               </a:ext>
             </a:extLst>
           </p:cNvPr>
@@ -6243,7 +6308,7 @@
           <p:cNvPr id="24" name="">
             <a:extLst xmlns:a="http://schemas.openxmlformats.org/drawingml/2006/main">
               <a:ext uri="{FF2B5EF4-FFF2-40B4-BE49-F238E27FC236}">
-                <a16:creationId xmlns:a16="http://schemas.microsoft.com/office/drawing/2014/main" id="{595DE110-E7C0-48F3-889D-3B46CDEBC9E9}"/>
+                <a16:creationId xmlns:a16="http://schemas.microsoft.com/office/drawing/2014/main" id="{9FFBAA95-1D3A-4B2C-84EF-64A9C23AC39A}"/>
               </a:ext>
             </a:extLst>
           </p:cNvPr>
@@ -6278,7 +6343,7 @@
           <p:cNvPr id="25" name="">
             <a:extLst xmlns:a="http://schemas.openxmlformats.org/drawingml/2006/main">
               <a:ext uri="{FF2B5EF4-FFF2-40B4-BE49-F238E27FC236}">
-                <a16:creationId xmlns:a16="http://schemas.microsoft.com/office/drawing/2014/main" id="{6F56B243-4588-4E4F-995D-C03272EC9763}"/>
+                <a16:creationId xmlns:a16="http://schemas.microsoft.com/office/drawing/2014/main" id="{715E1A74-DA96-4B2C-AC77-67E4A7F65F84}"/>
               </a:ext>
             </a:extLst>
           </p:cNvPr>
@@ -6342,7 +6407,7 @@
           <p:cNvPr id="26" name="">
             <a:extLst xmlns:a="http://schemas.openxmlformats.org/drawingml/2006/main">
               <a:ext uri="{FF2B5EF4-FFF2-40B4-BE49-F238E27FC236}">
-                <a16:creationId xmlns:a16="http://schemas.microsoft.com/office/drawing/2014/main" id="{D063CAF3-BB03-4200-8F24-D467351C37C1}"/>
+                <a16:creationId xmlns:a16="http://schemas.microsoft.com/office/drawing/2014/main" id="{CA02DA4A-8364-4165-9E6C-C7B5C64FC9C3}"/>
               </a:ext>
             </a:extLst>
           </p:cNvPr>
@@ -6427,7 +6492,7 @@
     </p:spTree>
     <p:extLst>
       <p:ext uri="{BB962C8B-B14F-4D97-AF65-F5344CB8AC3E}">
-        <p14:creationId xmlns:p14="http://schemas.microsoft.com/office/powerpoint/2010/main" val="1799492674"/>
+        <p14:creationId xmlns:p14="http://schemas.microsoft.com/office/powerpoint/2010/main" val="1606302106"/>
       </p:ext>
     </p:extLst>
   </p:cSld>
@@ -6451,7 +6516,7 @@
           <p:cNvPr id="1" name="">
             <a:extLst xmlns:a="http://schemas.openxmlformats.org/drawingml/2006/main">
               <a:ext uri="{FF2B5EF4-FFF2-40B4-BE49-F238E27FC236}">
-                <a16:creationId xmlns:a16="http://schemas.microsoft.com/office/drawing/2014/main" id="{7550DAF3-1A7D-40DF-A0C6-05804D5AFCDE}"/>
+                <a16:creationId xmlns:a16="http://schemas.microsoft.com/office/drawing/2014/main" id="{B5784419-1ED7-4623-B7B5-2E3CBCAE2584}"/>
               </a:ext>
             </a:extLst>
           </p:cNvPr>
@@ -6486,7 +6551,7 @@
           <p:cNvPr id="2" name="kicker-marker">
             <a:extLst xmlns:a="http://schemas.openxmlformats.org/drawingml/2006/main">
               <a:ext uri="{FF2B5EF4-FFF2-40B4-BE49-F238E27FC236}">
-                <a16:creationId xmlns:a16="http://schemas.microsoft.com/office/drawing/2014/main" id="{962AC1BA-CD23-472B-AE85-5DED16669ADF}"/>
+                <a16:creationId xmlns:a16="http://schemas.microsoft.com/office/drawing/2014/main" id="{52C770FA-D550-4205-AE61-DB0E4A431435}"/>
               </a:ext>
             </a:extLst>
           </p:cNvPr>
@@ -6521,7 +6586,7 @@
           <p:cNvPr id="3" name="kicker-label">
             <a:extLst xmlns:a="http://schemas.openxmlformats.org/drawingml/2006/main">
               <a:ext uri="{FF2B5EF4-FFF2-40B4-BE49-F238E27FC236}">
-                <a16:creationId xmlns:a16="http://schemas.microsoft.com/office/drawing/2014/main" id="{51925E78-0DA0-42F2-AEB2-525AA9086248}"/>
+                <a16:creationId xmlns:a16="http://schemas.microsoft.com/office/drawing/2014/main" id="{F6788E45-0466-453B-AA6F-5C57021052E2}"/>
               </a:ext>
             </a:extLst>
           </p:cNvPr>
@@ -6585,7 +6650,7 @@
           <p:cNvPr id="4" name="">
             <a:extLst xmlns:a="http://schemas.openxmlformats.org/drawingml/2006/main">
               <a:ext uri="{FF2B5EF4-FFF2-40B4-BE49-F238E27FC236}">
-                <a16:creationId xmlns:a16="http://schemas.microsoft.com/office/drawing/2014/main" id="{EB9762F6-DBF2-44E8-B635-9F6C7693CD9F}"/>
+                <a16:creationId xmlns:a16="http://schemas.microsoft.com/office/drawing/2014/main" id="{FA17F9BE-CADA-4E8B-9DEE-4FE7CBD90F1B}"/>
               </a:ext>
             </a:extLst>
           </p:cNvPr>
@@ -6649,7 +6714,7 @@
           <p:cNvPr id="5" name="">
             <a:extLst xmlns:a="http://schemas.openxmlformats.org/drawingml/2006/main">
               <a:ext uri="{FF2B5EF4-FFF2-40B4-BE49-F238E27FC236}">
-                <a16:creationId xmlns:a16="http://schemas.microsoft.com/office/drawing/2014/main" id="{9A1F50C5-7EC6-4915-B476-6C5B4391014E}"/>
+                <a16:creationId xmlns:a16="http://schemas.microsoft.com/office/drawing/2014/main" id="{5D236FD4-B882-43FC-BB81-EEDBA29CFAEB}"/>
               </a:ext>
             </a:extLst>
           </p:cNvPr>
@@ -6684,7 +6749,7 @@
           <p:cNvPr id="6" name="">
             <a:extLst xmlns:a="http://schemas.openxmlformats.org/drawingml/2006/main">
               <a:ext uri="{FF2B5EF4-FFF2-40B4-BE49-F238E27FC236}">
-                <a16:creationId xmlns:a16="http://schemas.microsoft.com/office/drawing/2014/main" id="{DDFCE75F-333F-4238-A198-ACCC00D10114}"/>
+                <a16:creationId xmlns:a16="http://schemas.microsoft.com/office/drawing/2014/main" id="{E9E07263-DF30-40BC-B273-3E847037750C}"/>
               </a:ext>
             </a:extLst>
           </p:cNvPr>
@@ -6752,7 +6817,7 @@
           <p:nvPr/>
         </p:nvPicPr>
         <p:blipFill>
-          <a:blip xmlns:r="http://schemas.openxmlformats.org/officeDocument/2006/relationships" xmlns:a="http://schemas.openxmlformats.org/drawingml/2006/main" r:embed="Rd7fcf8a6860f44ec"/>
+          <a:blip xmlns:r="http://schemas.openxmlformats.org/officeDocument/2006/relationships" xmlns:a="http://schemas.openxmlformats.org/drawingml/2006/main" r:embed="Rda97980d2844434a"/>
           <a:stretch xmlns:a="http://schemas.openxmlformats.org/drawingml/2006/main"/>
         </p:blipFill>
         <p:spPr>
@@ -6770,7 +6835,7 @@
           <p:cNvPr id="8" name="">
             <a:extLst xmlns:a="http://schemas.openxmlformats.org/drawingml/2006/main">
               <a:ext uri="{FF2B5EF4-FFF2-40B4-BE49-F238E27FC236}">
-                <a16:creationId xmlns:a16="http://schemas.microsoft.com/office/drawing/2014/main" id="{367D29DF-705F-47FC-B09D-C270C5370F4E}"/>
+                <a16:creationId xmlns:a16="http://schemas.microsoft.com/office/drawing/2014/main" id="{6B2E3943-257B-44FC-AF79-736D4C8DB54E}"/>
               </a:ext>
             </a:extLst>
           </p:cNvPr>
@@ -6803,7 +6868,7 @@
     </p:spTree>
     <p:extLst>
       <p:ext uri="{BB962C8B-B14F-4D97-AF65-F5344CB8AC3E}">
-        <p14:creationId xmlns:p14="http://schemas.microsoft.com/office/powerpoint/2010/main" val="1909478249"/>
+        <p14:creationId xmlns:p14="http://schemas.microsoft.com/office/powerpoint/2010/main" val="1000232977"/>
       </p:ext>
     </p:extLst>
   </p:cSld>
@@ -6827,7 +6892,7 @@
           <p:cNvPr id="1" name="">
             <a:extLst xmlns:a="http://schemas.openxmlformats.org/drawingml/2006/main">
               <a:ext uri="{FF2B5EF4-FFF2-40B4-BE49-F238E27FC236}">
-                <a16:creationId xmlns:a16="http://schemas.microsoft.com/office/drawing/2014/main" id="{32BF6A43-124A-440F-BB4F-3B924F0689EE}"/>
+                <a16:creationId xmlns:a16="http://schemas.microsoft.com/office/drawing/2014/main" id="{9BABA187-2379-40F6-946E-693D2A69D7FD}"/>
               </a:ext>
             </a:extLst>
           </p:cNvPr>
@@ -6862,7 +6927,7 @@
           <p:cNvPr id="2" name="kicker-marker">
             <a:extLst xmlns:a="http://schemas.openxmlformats.org/drawingml/2006/main">
               <a:ext uri="{FF2B5EF4-FFF2-40B4-BE49-F238E27FC236}">
-                <a16:creationId xmlns:a16="http://schemas.microsoft.com/office/drawing/2014/main" id="{E7EAF0E5-9CDA-49E5-8E5A-2D36B8475F8C}"/>
+                <a16:creationId xmlns:a16="http://schemas.microsoft.com/office/drawing/2014/main" id="{9D8B1A97-2548-40BE-AE1E-52F72F41F54C}"/>
               </a:ext>
             </a:extLst>
           </p:cNvPr>
@@ -6897,7 +6962,7 @@
           <p:cNvPr id="3" name="kicker-label">
             <a:extLst xmlns:a="http://schemas.openxmlformats.org/drawingml/2006/main">
               <a:ext uri="{FF2B5EF4-FFF2-40B4-BE49-F238E27FC236}">
-                <a16:creationId xmlns:a16="http://schemas.microsoft.com/office/drawing/2014/main" id="{B8B963E1-ED44-4655-A6BF-7B69894B9DF2}"/>
+                <a16:creationId xmlns:a16="http://schemas.microsoft.com/office/drawing/2014/main" id="{3DBC81C4-7DC3-471B-9EEC-94BBDB7FD9DC}"/>
               </a:ext>
             </a:extLst>
           </p:cNvPr>
@@ -6961,7 +7026,7 @@
           <p:cNvPr id="4" name="">
             <a:extLst xmlns:a="http://schemas.openxmlformats.org/drawingml/2006/main">
               <a:ext uri="{FF2B5EF4-FFF2-40B4-BE49-F238E27FC236}">
-                <a16:creationId xmlns:a16="http://schemas.microsoft.com/office/drawing/2014/main" id="{750BB9BA-68DB-4A46-8105-C4E5717EE749}"/>
+                <a16:creationId xmlns:a16="http://schemas.microsoft.com/office/drawing/2014/main" id="{834AA5B5-2077-4EA3-8221-D9B124F14D14}"/>
               </a:ext>
             </a:extLst>
           </p:cNvPr>
@@ -7025,7 +7090,7 @@
           <p:cNvPr id="5" name="">
             <a:extLst xmlns:a="http://schemas.openxmlformats.org/drawingml/2006/main">
               <a:ext uri="{FF2B5EF4-FFF2-40B4-BE49-F238E27FC236}">
-                <a16:creationId xmlns:a16="http://schemas.microsoft.com/office/drawing/2014/main" id="{1CAE9B3C-4383-4151-A5DD-A97946E4149F}"/>
+                <a16:creationId xmlns:a16="http://schemas.microsoft.com/office/drawing/2014/main" id="{ACD3BE9B-D57B-4855-B6CA-6B4BDAE647F2}"/>
               </a:ext>
             </a:extLst>
           </p:cNvPr>
@@ -7060,7 +7125,7 @@
           <p:cNvPr id="6" name="">
             <a:extLst xmlns:a="http://schemas.openxmlformats.org/drawingml/2006/main">
               <a:ext uri="{FF2B5EF4-FFF2-40B4-BE49-F238E27FC236}">
-                <a16:creationId xmlns:a16="http://schemas.microsoft.com/office/drawing/2014/main" id="{B265CEEB-864B-4671-8987-BC58DD7F2EA2}"/>
+                <a16:creationId xmlns:a16="http://schemas.microsoft.com/office/drawing/2014/main" id="{88894815-BC12-4040-8F71-DF31AC9A1B57}"/>
               </a:ext>
             </a:extLst>
           </p:cNvPr>
@@ -7128,7 +7193,7 @@
           <p:nvPr/>
         </p:nvPicPr>
         <p:blipFill>
-          <a:blip xmlns:r="http://schemas.openxmlformats.org/officeDocument/2006/relationships" xmlns:a="http://schemas.openxmlformats.org/drawingml/2006/main" r:embed="Re59a3f3e6aaf45bf"/>
+          <a:blip xmlns:r="http://schemas.openxmlformats.org/officeDocument/2006/relationships" xmlns:a="http://schemas.openxmlformats.org/drawingml/2006/main" r:embed="R8d6e5e069c1c4d93"/>
           <a:stretch xmlns:a="http://schemas.openxmlformats.org/drawingml/2006/main"/>
         </p:blipFill>
         <p:spPr>
@@ -7146,7 +7211,7 @@
           <p:cNvPr id="8" name="">
             <a:extLst xmlns:a="http://schemas.openxmlformats.org/drawingml/2006/main">
               <a:ext uri="{FF2B5EF4-FFF2-40B4-BE49-F238E27FC236}">
-                <a16:creationId xmlns:a16="http://schemas.microsoft.com/office/drawing/2014/main" id="{11D309EB-8FAD-476D-9DF2-E18DEFCC7AC9}"/>
+                <a16:creationId xmlns:a16="http://schemas.microsoft.com/office/drawing/2014/main" id="{704813EE-57D8-4BCB-B615-F29970589627}"/>
               </a:ext>
             </a:extLst>
           </p:cNvPr>
@@ -7179,7 +7244,7 @@
     </p:spTree>
     <p:extLst>
       <p:ext uri="{BB962C8B-B14F-4D97-AF65-F5344CB8AC3E}">
-        <p14:creationId xmlns:p14="http://schemas.microsoft.com/office/powerpoint/2010/main" val="1372599957"/>
+        <p14:creationId xmlns:p14="http://schemas.microsoft.com/office/powerpoint/2010/main" val="1275328335"/>
       </p:ext>
     </p:extLst>
   </p:cSld>
@@ -7203,7 +7268,7 @@
           <p:cNvPr id="1" name="">
             <a:extLst xmlns:a="http://schemas.openxmlformats.org/drawingml/2006/main">
               <a:ext uri="{FF2B5EF4-FFF2-40B4-BE49-F238E27FC236}">
-                <a16:creationId xmlns:a16="http://schemas.microsoft.com/office/drawing/2014/main" id="{CEF33BD3-DF48-4F3C-8FFA-A149B4C70BEA}"/>
+                <a16:creationId xmlns:a16="http://schemas.microsoft.com/office/drawing/2014/main" id="{FC7B0772-3F6E-446A-ADDC-1076C69932FC}"/>
               </a:ext>
             </a:extLst>
           </p:cNvPr>
@@ -7238,7 +7303,7 @@
           <p:cNvPr id="2" name="kicker-marker">
             <a:extLst xmlns:a="http://schemas.openxmlformats.org/drawingml/2006/main">
               <a:ext uri="{FF2B5EF4-FFF2-40B4-BE49-F238E27FC236}">
-                <a16:creationId xmlns:a16="http://schemas.microsoft.com/office/drawing/2014/main" id="{F88EBA2E-661E-4B8A-B3FC-18B2ACCC34E6}"/>
+                <a16:creationId xmlns:a16="http://schemas.microsoft.com/office/drawing/2014/main" id="{9FE4F74C-87D2-4CD5-8BB9-DE02F0F4B82C}"/>
               </a:ext>
             </a:extLst>
           </p:cNvPr>
@@ -7273,7 +7338,7 @@
           <p:cNvPr id="3" name="kicker-label">
             <a:extLst xmlns:a="http://schemas.openxmlformats.org/drawingml/2006/main">
               <a:ext uri="{FF2B5EF4-FFF2-40B4-BE49-F238E27FC236}">
-                <a16:creationId xmlns:a16="http://schemas.microsoft.com/office/drawing/2014/main" id="{5B8BA654-BA0A-44B3-B218-F11C7F24143E}"/>
+                <a16:creationId xmlns:a16="http://schemas.microsoft.com/office/drawing/2014/main" id="{8BF7A3F4-C52B-4FA3-9D23-177F6EEFDF8F}"/>
               </a:ext>
             </a:extLst>
           </p:cNvPr>
@@ -7327,7 +7392,7 @@
                 <a:ea typeface="Aptos"/>
                 <a:cs typeface="Aptos"/>
               </a:rPr>
-              <a:t>UI WALKTHROUGH 3</a:t>
+              <a:t>CLICKABLE BROWSER DEMO</a:t>
             </a:r>
           </a:p>
         </p:txBody>
@@ -7337,7 +7402,7 @@
           <p:cNvPr id="4" name="">
             <a:extLst xmlns:a="http://schemas.openxmlformats.org/drawingml/2006/main">
               <a:ext uri="{FF2B5EF4-FFF2-40B4-BE49-F238E27FC236}">
-                <a16:creationId xmlns:a16="http://schemas.microsoft.com/office/drawing/2014/main" id="{11A467EC-CCDA-4C2B-8DE0-CE887A6AB11B}"/>
+                <a16:creationId xmlns:a16="http://schemas.microsoft.com/office/drawing/2014/main" id="{8FB1388D-D582-46E3-AA5D-B4E87FE62B0E}"/>
               </a:ext>
             </a:extLst>
           </p:cNvPr>
@@ -7391,7 +7456,7 @@
                 <a:ea typeface="Aptos Display"/>
                 <a:cs typeface="Aptos Display"/>
               </a:rPr>
-              <a:t>The export package gives the user guided data, baseline data, and evaluation JSON.</a:t>
+              <a:t>Open the static web demo from the slide, then show intake, data, evaluation, and export.</a:t>
             </a:r>
           </a:p>
         </p:txBody>
@@ -7401,7 +7466,7 @@
           <p:cNvPr id="5" name="">
             <a:extLst xmlns:a="http://schemas.openxmlformats.org/drawingml/2006/main">
               <a:ext uri="{FF2B5EF4-FFF2-40B4-BE49-F238E27FC236}">
-                <a16:creationId xmlns:a16="http://schemas.microsoft.com/office/drawing/2014/main" id="{13305288-BD24-4B95-A071-819472B424EC}"/>
+                <a16:creationId xmlns:a16="http://schemas.microsoft.com/office/drawing/2014/main" id="{349E233A-EF4A-4924-B4F2-0ACE1AEDB666}"/>
               </a:ext>
             </a:extLst>
           </p:cNvPr>
@@ -7436,7 +7501,7 @@
           <p:cNvPr id="6" name="">
             <a:extLst xmlns:a="http://schemas.openxmlformats.org/drawingml/2006/main">
               <a:ext uri="{FF2B5EF4-FFF2-40B4-BE49-F238E27FC236}">
-                <a16:creationId xmlns:a16="http://schemas.microsoft.com/office/drawing/2014/main" id="{E313DC99-DFBC-441B-B0E6-328BAFD60510}"/>
+                <a16:creationId xmlns:a16="http://schemas.microsoft.com/office/drawing/2014/main" id="{3A49AB88-3EDA-4FDA-B626-F43EB4378648}"/>
               </a:ext>
             </a:extLst>
           </p:cNvPr>
@@ -7504,7 +7569,7 @@
           <p:nvPr/>
         </p:nvPicPr>
         <p:blipFill>
-          <a:blip xmlns:r="http://schemas.openxmlformats.org/officeDocument/2006/relationships" xmlns:a="http://schemas.openxmlformats.org/drawingml/2006/main" r:embed="R88c86063b70241f2"/>
+          <a:blip xmlns:r="http://schemas.openxmlformats.org/officeDocument/2006/relationships" xmlns:a="http://schemas.openxmlformats.org/drawingml/2006/main" r:embed="R716c6f24e4904d67"/>
           <a:stretch xmlns:a="http://schemas.openxmlformats.org/drawingml/2006/main"/>
         </p:blipFill>
         <p:spPr>
@@ -7522,7 +7587,7 @@
           <p:cNvPr id="8" name="">
             <a:extLst xmlns:a="http://schemas.openxmlformats.org/drawingml/2006/main">
               <a:ext uri="{FF2B5EF4-FFF2-40B4-BE49-F238E27FC236}">
-                <a16:creationId xmlns:a16="http://schemas.microsoft.com/office/drawing/2014/main" id="{923A627C-E6CD-47CD-A46F-1B21625723EA}"/>
+                <a16:creationId xmlns:a16="http://schemas.microsoft.com/office/drawing/2014/main" id="{5ADEDEFC-E52A-45F0-A2BB-D7528E6A21AC}"/>
               </a:ext>
             </a:extLst>
           </p:cNvPr>
@@ -7557,19 +7622,19 @@
           <p:cNvPr id="9" name="">
             <a:extLst xmlns:a="http://schemas.openxmlformats.org/drawingml/2006/main">
               <a:ext uri="{FF2B5EF4-FFF2-40B4-BE49-F238E27FC236}">
-                <a16:creationId xmlns:a16="http://schemas.microsoft.com/office/drawing/2014/main" id="{C8A527C4-26AF-4546-A84B-59CD0AF7838C}"/>
-              </a:ext>
-            </a:extLst>
-          </p:cNvPr>
-          <p:cNvSpPr>
-            <a:spLocks xmlns:a="http://schemas.openxmlformats.org/drawingml/2006/main" noGrp="1"/>
-          </p:cNvSpPr>
-          <p:nvPr/>
-        </p:nvSpPr>
-        <p:spPr>
-          <a:xfrm xmlns:a="http://schemas.openxmlformats.org/drawingml/2006/main">
-            <a:off x="6496050" y="5657850"/>
-            <a:ext cx="3486150" cy="323850"/>
+                <a16:creationId xmlns:a16="http://schemas.microsoft.com/office/drawing/2014/main" id="{F0C469D2-4D96-4EB1-A575-7ED11B106B1E}"/>
+              </a:ext>
+            </a:extLst>
+          </p:cNvPr>
+          <p:cNvSpPr>
+            <a:spLocks xmlns:a="http://schemas.openxmlformats.org/drawingml/2006/main" noGrp="1"/>
+          </p:cNvSpPr>
+          <p:nvPr/>
+        </p:nvSpPr>
+        <p:spPr>
+          <a:xfrm xmlns:a="http://schemas.openxmlformats.org/drawingml/2006/main">
+            <a:off x="3429000" y="5619750"/>
+            <a:ext cx="5334000" cy="400050"/>
           </a:xfrm>
           <a:prstGeom xmlns:a="http://schemas.openxmlformats.org/drawingml/2006/main" prst="rect">
             <a:avLst/>
@@ -7592,19 +7657,19 @@
           <p:cNvPr id="10" name="">
             <a:extLst xmlns:a="http://schemas.openxmlformats.org/drawingml/2006/main">
               <a:ext uri="{FF2B5EF4-FFF2-40B4-BE49-F238E27FC236}">
-                <a16:creationId xmlns:a16="http://schemas.microsoft.com/office/drawing/2014/main" id="{C151D58C-3619-4390-87B9-C5484929A911}"/>
-              </a:ext>
-            </a:extLst>
-          </p:cNvPr>
-          <p:cNvSpPr>
-            <a:spLocks xmlns:a="http://schemas.openxmlformats.org/drawingml/2006/main" noGrp="1"/>
-          </p:cNvSpPr>
-          <p:nvPr/>
-        </p:nvSpPr>
-        <p:spPr>
-          <a:xfrm xmlns:a="http://schemas.openxmlformats.org/drawingml/2006/main">
-            <a:off x="6705600" y="5724525"/>
-            <a:ext cx="3067050" cy="190500"/>
+                <a16:creationId xmlns:a16="http://schemas.microsoft.com/office/drawing/2014/main" id="{57248916-7792-455B-AD93-4B504DA5A282}"/>
+              </a:ext>
+            </a:extLst>
+          </p:cNvPr>
+          <p:cNvSpPr>
+            <a:spLocks xmlns:a="http://schemas.openxmlformats.org/drawingml/2006/main" noGrp="1"/>
+          </p:cNvSpPr>
+          <p:nvPr/>
+        </p:nvSpPr>
+        <p:spPr>
+          <a:xfrm xmlns:a="http://schemas.openxmlformats.org/drawingml/2006/main">
+            <a:off x="3829050" y="5705475"/>
+            <a:ext cx="4533900" cy="209550"/>
           </a:xfrm>
           <a:prstGeom xmlns:a="http://schemas.openxmlformats.org/drawingml/2006/main" prst="rect">
             <a:avLst/>
@@ -7628,7 +7693,7 @@
           <a:lstStyle xmlns:a="http://schemas.openxmlformats.org/drawingml/2006/main"/>
           <a:p xmlns:a="http://schemas.openxmlformats.org/drawingml/2006/main">
             <a:pPr algn="ctr">
-              <a:defRPr sz="1050" b="1">
+              <a:defRPr sz="1200" b="1">
                 <a:solidFill>
                   <a:srgbClr val="F7F3EA"/>
                 </a:solidFill>
@@ -7638,7 +7703,7 @@
               </a:defRPr>
             </a:pPr>
             <a:r>
-              <a:rPr sz="1050" b="1">
+              <a:rPr sz="1200" b="1">
                 <a:solidFill>
                   <a:srgbClr val="F7F3EA"/>
                 </a:solidFill>
@@ -7646,7 +7711,72 @@
                 <a:ea typeface="Aptos"/>
                 <a:cs typeface="Aptos"/>
               </a:rPr>
-              <a:t>No live app is required during presentation.</a:t>
+              <a:t>CLICK HERE FOR BROWSER DEMO</a:t>
+            </a:r>
+          </a:p>
+        </p:txBody>
+      </p:sp>
+      <p:sp>
+        <p:nvSpPr>
+          <p:cNvPr id="11" name="">
+            <a:extLst xmlns:a="http://schemas.openxmlformats.org/drawingml/2006/main">
+              <a:ext uri="{FF2B5EF4-FFF2-40B4-BE49-F238E27FC236}">
+                <a16:creationId xmlns:a16="http://schemas.microsoft.com/office/drawing/2014/main" id="{22A64085-6A4A-449A-ADB5-2397E4410634}"/>
+              </a:ext>
+            </a:extLst>
+          </p:cNvPr>
+          <p:cNvSpPr>
+            <a:spLocks xmlns:a="http://schemas.openxmlformats.org/drawingml/2006/main" noGrp="1"/>
+          </p:cNvSpPr>
+          <p:nvPr/>
+        </p:nvSpPr>
+        <p:spPr>
+          <a:xfrm xmlns:a="http://schemas.openxmlformats.org/drawingml/2006/main">
+            <a:off x="2219325" y="6115050"/>
+            <a:ext cx="7772400" cy="190500"/>
+          </a:xfrm>
+          <a:prstGeom xmlns:a="http://schemas.openxmlformats.org/drawingml/2006/main" prst="rect">
+            <a:avLst/>
+          </a:prstGeom>
+          <a:solidFill xmlns:a="http://schemas.openxmlformats.org/drawingml/2006/main">
+            <a:srgbClr val="000000">
+              <a:alpha val="0"/>
+            </a:srgbClr>
+          </a:solidFill>
+          <a:ln xmlns:a="http://schemas.openxmlformats.org/drawingml/2006/main" w="0">
+            <a:solidFill>
+              <a:srgbClr val="000000">
+                <a:alpha val="0"/>
+              </a:srgbClr>
+            </a:solidFill>
+            <a:prstDash val="solid"/>
+          </a:ln>
+        </p:spPr>
+        <p:txBody>
+          <a:bodyPr xmlns:a="http://schemas.openxmlformats.org/drawingml/2006/main" lIns="0" tIns="0" rIns="0" bIns="0" anchor="t"/>
+          <a:lstStyle xmlns:a="http://schemas.openxmlformats.org/drawingml/2006/main"/>
+          <a:p xmlns:a="http://schemas.openxmlformats.org/drawingml/2006/main">
+            <a:pPr algn="ctr">
+              <a:defRPr sz="750" b="0">
+                <a:solidFill>
+                  <a:srgbClr val="0E7C66"/>
+                </a:solidFill>
+                <a:latin typeface="Aptos"/>
+                <a:ea typeface="Aptos"/>
+                <a:cs typeface="Aptos"/>
+              </a:defRPr>
+            </a:pPr>
+            <a:r>
+              <a:rPr sz="750" b="0">
+                <a:solidFill>
+                  <a:srgbClr val="0E7C66"/>
+                </a:solidFill>
+                <a:latin typeface="Aptos"/>
+                <a:ea typeface="Aptos"/>
+                <a:cs typeface="Aptos"/>
+                <a:hlinkClick xmlns:r="http://schemas.openxmlformats.org/officeDocument/2006/relationships" r:id="rIdSynthAMLDemo"/>
+              </a:rPr>
+              <a:t>https://htmlpreview.github.io/?https://github.com/yq688m3JT/genAI_final/blob/main/docs/demo.html</a:t>
             </a:r>
           </a:p>
         </p:txBody>
@@ -7654,7 +7784,7 @@
     </p:spTree>
     <p:extLst>
       <p:ext uri="{BB962C8B-B14F-4D97-AF65-F5344CB8AC3E}">
-        <p14:creationId xmlns:p14="http://schemas.microsoft.com/office/powerpoint/2010/main" val="1520072180"/>
+        <p14:creationId xmlns:p14="http://schemas.microsoft.com/office/powerpoint/2010/main" val="1156852326"/>
       </p:ext>
     </p:extLst>
   </p:cSld>

</xml_diff>

<commit_message>
Use verified browser demo link
</commit_message>
<xml_diff>
--- a/docs/synthaml-final-presentation.pptx
+++ b/docs/synthaml-final-presentation.pptx
@@ -2,19 +2,19 @@
 <file path=ppt/presentation.xml><?xml version="1.0" encoding="utf-8"?>
 <p:presentation xmlns:p="http://schemas.openxmlformats.org/presentationml/2006/main">
   <p:sldMasterIdLst>
-    <p:sldMasterId xmlns:r="http://schemas.openxmlformats.org/officeDocument/2006/relationships" id="2147483648" r:id="R452a54dd9dc24f10"/>
+    <p:sldMasterId xmlns:r="http://schemas.openxmlformats.org/officeDocument/2006/relationships" id="2147483648" r:id="R623ef365bf9d4d0b"/>
   </p:sldMasterIdLst>
   <p:notesMasterIdLst>
-    <p:notesMasterId xmlns:r="http://schemas.openxmlformats.org/officeDocument/2006/relationships" r:id="Rd101621330b74438"/>
+    <p:notesMasterId xmlns:r="http://schemas.openxmlformats.org/officeDocument/2006/relationships" r:id="R7566b4dc3791471a"/>
   </p:notesMasterIdLst>
   <p:sldIdLst>
-    <p:sldId xmlns:r="http://schemas.openxmlformats.org/officeDocument/2006/relationships" id="256" r:id="R7073b1b554d9458c"/>
-    <p:sldId xmlns:r="http://schemas.openxmlformats.org/officeDocument/2006/relationships" id="257" r:id="Rc528e8270658499e"/>
-    <p:sldId xmlns:r="http://schemas.openxmlformats.org/officeDocument/2006/relationships" id="258" r:id="R1fdf2f2d4412428e"/>
-    <p:sldId xmlns:r="http://schemas.openxmlformats.org/officeDocument/2006/relationships" id="259" r:id="R98d82433c44f4584"/>
-    <p:sldId xmlns:r="http://schemas.openxmlformats.org/officeDocument/2006/relationships" id="260" r:id="R01b6ba7592974ee4"/>
-    <p:sldId xmlns:r="http://schemas.openxmlformats.org/officeDocument/2006/relationships" id="261" r:id="R9a83ae41ffec4f6c"/>
-    <p:sldId xmlns:r="http://schemas.openxmlformats.org/officeDocument/2006/relationships" id="262" r:id="Ra67cb06cd0db4949"/>
+    <p:sldId xmlns:r="http://schemas.openxmlformats.org/officeDocument/2006/relationships" id="256" r:id="Rf46e9fccef514253"/>
+    <p:sldId xmlns:r="http://schemas.openxmlformats.org/officeDocument/2006/relationships" id="257" r:id="R35aabe660ade452a"/>
+    <p:sldId xmlns:r="http://schemas.openxmlformats.org/officeDocument/2006/relationships" id="258" r:id="Rb4c036d6b7f04c8a"/>
+    <p:sldId xmlns:r="http://schemas.openxmlformats.org/officeDocument/2006/relationships" id="259" r:id="R48f526bf809a4779"/>
+    <p:sldId xmlns:r="http://schemas.openxmlformats.org/officeDocument/2006/relationships" id="260" r:id="R8d21a54c759c422a"/>
+    <p:sldId xmlns:r="http://schemas.openxmlformats.org/officeDocument/2006/relationships" id="261" r:id="R60527e1f13574d82"/>
+    <p:sldId xmlns:r="http://schemas.openxmlformats.org/officeDocument/2006/relationships" id="262" r:id="Ref6929e7b9a04c66"/>
   </p:sldIdLst>
   <p:sldSz cx="12192000" cy="6858000"/>
   <p:notesSz cx="6858000" cy="9144000"/>
@@ -957,7 +957,7 @@
   </p:cSld>
   <p:clrMap bg1="lt1" tx1="dk1" bg2="lt2" tx2="dk2" accent1="accent1" accent2="accent2" accent3="accent3" accent4="accent4" accent5="accent5" accent6="accent6" hlink="hlink" folHlink="folHlink"/>
   <p:sldLayoutIdLst>
-    <p:sldLayoutId xmlns:r="http://schemas.openxmlformats.org/officeDocument/2006/relationships" id="2147483649" r:id="Reed02ee1b92b4089"/>
+    <p:sldLayoutId xmlns:r="http://schemas.openxmlformats.org/officeDocument/2006/relationships" id="2147483649" r:id="R48892e825ab848a8"/>
   </p:sldLayoutIdLst>
   <p:txStyles>
     <p:titleStyle>
@@ -1256,7 +1256,7 @@
           <p:cNvPr id="1" name="">
             <a:extLst xmlns:a="http://schemas.openxmlformats.org/drawingml/2006/main">
               <a:ext uri="{FF2B5EF4-FFF2-40B4-BE49-F238E27FC236}">
-                <a16:creationId xmlns:a16="http://schemas.microsoft.com/office/drawing/2014/main" id="{C11F6431-CA73-4BA4-8F27-189AD3A48612}"/>
+                <a16:creationId xmlns:a16="http://schemas.microsoft.com/office/drawing/2014/main" id="{E0477721-EAAD-4C2D-BF09-806318B9F0A1}"/>
               </a:ext>
             </a:extLst>
           </p:cNvPr>
@@ -1291,7 +1291,7 @@
           <p:cNvPr id="2" name="">
             <a:extLst xmlns:a="http://schemas.openxmlformats.org/drawingml/2006/main">
               <a:ext uri="{FF2B5EF4-FFF2-40B4-BE49-F238E27FC236}">
-                <a16:creationId xmlns:a16="http://schemas.microsoft.com/office/drawing/2014/main" id="{87247148-7971-44AD-B234-E20F3D9C4F5F}"/>
+                <a16:creationId xmlns:a16="http://schemas.microsoft.com/office/drawing/2014/main" id="{69F5A0E7-2225-4B63-8390-DCCB176029EB}"/>
               </a:ext>
             </a:extLst>
           </p:cNvPr>
@@ -1326,7 +1326,7 @@
           <p:cNvPr id="3" name="">
             <a:extLst xmlns:a="http://schemas.openxmlformats.org/drawingml/2006/main">
               <a:ext uri="{FF2B5EF4-FFF2-40B4-BE49-F238E27FC236}">
-                <a16:creationId xmlns:a16="http://schemas.microsoft.com/office/drawing/2014/main" id="{D556A2B6-3159-439E-A7EA-4D28D7D128DC}"/>
+                <a16:creationId xmlns:a16="http://schemas.microsoft.com/office/drawing/2014/main" id="{43B74C9C-6F70-4C11-AD49-818E0E871B2D}"/>
               </a:ext>
             </a:extLst>
           </p:cNvPr>
@@ -1390,7 +1390,7 @@
           <p:cNvPr id="4" name="">
             <a:extLst xmlns:a="http://schemas.openxmlformats.org/drawingml/2006/main">
               <a:ext uri="{FF2B5EF4-FFF2-40B4-BE49-F238E27FC236}">
-                <a16:creationId xmlns:a16="http://schemas.microsoft.com/office/drawing/2014/main" id="{FAAFA3B7-C003-4C2B-B775-322F67C1EE19}"/>
+                <a16:creationId xmlns:a16="http://schemas.microsoft.com/office/drawing/2014/main" id="{64494493-CF71-4AA1-87A6-0EAE896ED4C0}"/>
               </a:ext>
             </a:extLst>
           </p:cNvPr>
@@ -1454,7 +1454,7 @@
           <p:cNvPr id="5" name="">
             <a:extLst xmlns:a="http://schemas.openxmlformats.org/drawingml/2006/main">
               <a:ext uri="{FF2B5EF4-FFF2-40B4-BE49-F238E27FC236}">
-                <a16:creationId xmlns:a16="http://schemas.microsoft.com/office/drawing/2014/main" id="{ACA85D81-6EB6-4E7B-A2A6-BE6FFC6771B6}"/>
+                <a16:creationId xmlns:a16="http://schemas.microsoft.com/office/drawing/2014/main" id="{4BA5FD91-3974-4CE0-92F4-D5F7F7291272}"/>
               </a:ext>
             </a:extLst>
           </p:cNvPr>
@@ -1518,7 +1518,7 @@
           <p:cNvPr id="6" name="">
             <a:extLst xmlns:a="http://schemas.openxmlformats.org/drawingml/2006/main">
               <a:ext uri="{FF2B5EF4-FFF2-40B4-BE49-F238E27FC236}">
-                <a16:creationId xmlns:a16="http://schemas.microsoft.com/office/drawing/2014/main" id="{61B135B7-49D4-4561-A0A6-433AB3A8370C}"/>
+                <a16:creationId xmlns:a16="http://schemas.microsoft.com/office/drawing/2014/main" id="{C1830A20-FA71-4A07-8329-270D67DCAA60}"/>
               </a:ext>
             </a:extLst>
           </p:cNvPr>
@@ -1553,7 +1553,7 @@
           <p:cNvPr id="7" name="">
             <a:extLst xmlns:a="http://schemas.openxmlformats.org/drawingml/2006/main">
               <a:ext uri="{FF2B5EF4-FFF2-40B4-BE49-F238E27FC236}">
-                <a16:creationId xmlns:a16="http://schemas.microsoft.com/office/drawing/2014/main" id="{5E8AE6A9-6AD8-4DA7-A5D7-70E226665CED}"/>
+                <a16:creationId xmlns:a16="http://schemas.microsoft.com/office/drawing/2014/main" id="{5E6D6A68-89C2-4599-870B-F94F26DCCBC4}"/>
               </a:ext>
             </a:extLst>
           </p:cNvPr>
@@ -1617,7 +1617,7 @@
           <p:cNvPr id="8" name="">
             <a:extLst xmlns:a="http://schemas.openxmlformats.org/drawingml/2006/main">
               <a:ext uri="{FF2B5EF4-FFF2-40B4-BE49-F238E27FC236}">
-                <a16:creationId xmlns:a16="http://schemas.microsoft.com/office/drawing/2014/main" id="{163A92B5-18F0-4972-9D4B-08AE89A2B1E8}"/>
+                <a16:creationId xmlns:a16="http://schemas.microsoft.com/office/drawing/2014/main" id="{23D41ED0-1C58-43DC-9FF7-C1097EEEE68A}"/>
               </a:ext>
             </a:extLst>
           </p:cNvPr>
@@ -1681,7 +1681,7 @@
           <p:cNvPr id="9" name="">
             <a:extLst xmlns:a="http://schemas.openxmlformats.org/drawingml/2006/main">
               <a:ext uri="{FF2B5EF4-FFF2-40B4-BE49-F238E27FC236}">
-                <a16:creationId xmlns:a16="http://schemas.microsoft.com/office/drawing/2014/main" id="{3D34F692-3E62-46FD-9621-0F51FF9AF39D}"/>
+                <a16:creationId xmlns:a16="http://schemas.microsoft.com/office/drawing/2014/main" id="{D64FF189-B4A2-4A0B-A217-35BA08D2A3C0}"/>
               </a:ext>
             </a:extLst>
           </p:cNvPr>
@@ -1745,7 +1745,7 @@
           <p:cNvPr id="10" name="">
             <a:extLst xmlns:a="http://schemas.openxmlformats.org/drawingml/2006/main">
               <a:ext uri="{FF2B5EF4-FFF2-40B4-BE49-F238E27FC236}">
-                <a16:creationId xmlns:a16="http://schemas.microsoft.com/office/drawing/2014/main" id="{4C52DAE4-4366-426D-9345-2D2EA66250DF}"/>
+                <a16:creationId xmlns:a16="http://schemas.microsoft.com/office/drawing/2014/main" id="{5EFDF574-DF58-415C-979A-D8C2109ABF9C}"/>
               </a:ext>
             </a:extLst>
           </p:cNvPr>
@@ -1809,7 +1809,7 @@
           <p:cNvPr id="11" name="">
             <a:extLst xmlns:a="http://schemas.openxmlformats.org/drawingml/2006/main">
               <a:ext uri="{FF2B5EF4-FFF2-40B4-BE49-F238E27FC236}">
-                <a16:creationId xmlns:a16="http://schemas.microsoft.com/office/drawing/2014/main" id="{C61DB2CC-9F3A-4B8D-8771-8D28C9BC2FDF}"/>
+                <a16:creationId xmlns:a16="http://schemas.microsoft.com/office/drawing/2014/main" id="{CEFA2E69-AFEA-421E-BA6F-8E08383534E4}"/>
               </a:ext>
             </a:extLst>
           </p:cNvPr>
@@ -1873,7 +1873,7 @@
           <p:cNvPr id="12" name="">
             <a:extLst xmlns:a="http://schemas.openxmlformats.org/drawingml/2006/main">
               <a:ext uri="{FF2B5EF4-FFF2-40B4-BE49-F238E27FC236}">
-                <a16:creationId xmlns:a16="http://schemas.microsoft.com/office/drawing/2014/main" id="{99B23077-DBF1-4A00-BC56-AEF1CBD50175}"/>
+                <a16:creationId xmlns:a16="http://schemas.microsoft.com/office/drawing/2014/main" id="{7FEF107D-890C-410D-B573-BA2F53002303}"/>
               </a:ext>
             </a:extLst>
           </p:cNvPr>
@@ -1937,7 +1937,7 @@
           <p:cNvPr id="13" name="">
             <a:extLst xmlns:a="http://schemas.openxmlformats.org/drawingml/2006/main">
               <a:ext uri="{FF2B5EF4-FFF2-40B4-BE49-F238E27FC236}">
-                <a16:creationId xmlns:a16="http://schemas.microsoft.com/office/drawing/2014/main" id="{1799BB6D-DA26-48FD-96C7-19176B190A6A}"/>
+                <a16:creationId xmlns:a16="http://schemas.microsoft.com/office/drawing/2014/main" id="{52C822E0-F3ED-453A-8074-E0662EE2D3AC}"/>
               </a:ext>
             </a:extLst>
           </p:cNvPr>
@@ -1972,7 +1972,7 @@
           <p:cNvPr id="14" name="">
             <a:extLst xmlns:a="http://schemas.openxmlformats.org/drawingml/2006/main">
               <a:ext uri="{FF2B5EF4-FFF2-40B4-BE49-F238E27FC236}">
-                <a16:creationId xmlns:a16="http://schemas.microsoft.com/office/drawing/2014/main" id="{7F6579BE-A891-4DAB-B523-33B10BDB1335}"/>
+                <a16:creationId xmlns:a16="http://schemas.microsoft.com/office/drawing/2014/main" id="{EE213B6C-DCDF-4294-B3BE-932C724759A6}"/>
               </a:ext>
             </a:extLst>
           </p:cNvPr>
@@ -2036,7 +2036,7 @@
           <p:cNvPr id="15" name="">
             <a:extLst xmlns:a="http://schemas.openxmlformats.org/drawingml/2006/main">
               <a:ext uri="{FF2B5EF4-FFF2-40B4-BE49-F238E27FC236}">
-                <a16:creationId xmlns:a16="http://schemas.microsoft.com/office/drawing/2014/main" id="{7326CBFF-8247-4DB8-B88F-F0776458A747}"/>
+                <a16:creationId xmlns:a16="http://schemas.microsoft.com/office/drawing/2014/main" id="{9298379F-4507-4F17-ABD0-D08E6F82BC28}"/>
               </a:ext>
             </a:extLst>
           </p:cNvPr>
@@ -2123,7 +2123,7 @@
           <p:cNvPr id="16" name="">
             <a:extLst xmlns:a="http://schemas.openxmlformats.org/drawingml/2006/main">
               <a:ext uri="{FF2B5EF4-FFF2-40B4-BE49-F238E27FC236}">
-                <a16:creationId xmlns:a16="http://schemas.microsoft.com/office/drawing/2014/main" id="{8832A11F-2F8C-45A4-8379-134B355CA6B8}"/>
+                <a16:creationId xmlns:a16="http://schemas.microsoft.com/office/drawing/2014/main" id="{DBA28AB8-774D-44CC-9881-DC430FFC66FE}"/>
               </a:ext>
             </a:extLst>
           </p:cNvPr>
@@ -2187,7 +2187,7 @@
           <p:cNvPr id="17" name="">
             <a:extLst xmlns:a="http://schemas.openxmlformats.org/drawingml/2006/main">
               <a:ext uri="{FF2B5EF4-FFF2-40B4-BE49-F238E27FC236}">
-                <a16:creationId xmlns:a16="http://schemas.microsoft.com/office/drawing/2014/main" id="{64763AE2-1C9C-4AEA-9D26-61C54B1FD26F}"/>
+                <a16:creationId xmlns:a16="http://schemas.microsoft.com/office/drawing/2014/main" id="{BE7A343A-AB93-4FB7-B82D-7DB98DBA0660}"/>
               </a:ext>
             </a:extLst>
           </p:cNvPr>
@@ -2242,7 +2242,7 @@
                 <a:cs typeface="Aptos"/>
                 <a:hlinkClick xmlns:r="http://schemas.openxmlformats.org/officeDocument/2006/relationships" r:id="rIdSynthAMLDemo"/>
               </a:rPr>
-              <a:t>https://htmlpreview.github.io/?https://github.com/yq688m3JT/genAI_final/blob/main/docs/demo.html</a:t>
+              <a:t>https://rawcdn.githack.com/yq688m3JT/genAI_final/872e7a818159bc1c1262f42e682d39331a8cc98a/docs/demo.html</a:t>
             </a:r>
           </a:p>
         </p:txBody>
@@ -2250,7 +2250,7 @@
     </p:spTree>
     <p:extLst>
       <p:ext uri="{BB962C8B-B14F-4D97-AF65-F5344CB8AC3E}">
-        <p14:creationId xmlns:p14="http://schemas.microsoft.com/office/powerpoint/2010/main" val="1629597904"/>
+        <p14:creationId xmlns:p14="http://schemas.microsoft.com/office/powerpoint/2010/main" val="153298427"/>
       </p:ext>
     </p:extLst>
   </p:cSld>
@@ -2274,7 +2274,7 @@
           <p:cNvPr id="1" name="">
             <a:extLst xmlns:a="http://schemas.openxmlformats.org/drawingml/2006/main">
               <a:ext uri="{FF2B5EF4-FFF2-40B4-BE49-F238E27FC236}">
-                <a16:creationId xmlns:a16="http://schemas.microsoft.com/office/drawing/2014/main" id="{BD12FCFD-A299-465B-855D-F2E06015A64C}"/>
+                <a16:creationId xmlns:a16="http://schemas.microsoft.com/office/drawing/2014/main" id="{B785E289-C7FA-41C3-B192-11C17DEE2C8F}"/>
               </a:ext>
             </a:extLst>
           </p:cNvPr>
@@ -2309,7 +2309,7 @@
           <p:cNvPr id="2" name="kicker-marker">
             <a:extLst xmlns:a="http://schemas.openxmlformats.org/drawingml/2006/main">
               <a:ext uri="{FF2B5EF4-FFF2-40B4-BE49-F238E27FC236}">
-                <a16:creationId xmlns:a16="http://schemas.microsoft.com/office/drawing/2014/main" id="{C67018B8-9E64-4498-AA5C-9743595D6713}"/>
+                <a16:creationId xmlns:a16="http://schemas.microsoft.com/office/drawing/2014/main" id="{7513A27B-0F36-440A-BCC3-DBE2E3F77D5A}"/>
               </a:ext>
             </a:extLst>
           </p:cNvPr>
@@ -2344,7 +2344,7 @@
           <p:cNvPr id="3" name="kicker-label">
             <a:extLst xmlns:a="http://schemas.openxmlformats.org/drawingml/2006/main">
               <a:ext uri="{FF2B5EF4-FFF2-40B4-BE49-F238E27FC236}">
-                <a16:creationId xmlns:a16="http://schemas.microsoft.com/office/drawing/2014/main" id="{CF414D0A-82F2-440F-9817-E818AF8DDFAB}"/>
+                <a16:creationId xmlns:a16="http://schemas.microsoft.com/office/drawing/2014/main" id="{B91E513A-8A78-4CB7-9BDE-D981AFFE23F4}"/>
               </a:ext>
             </a:extLst>
           </p:cNvPr>
@@ -2408,7 +2408,7 @@
           <p:cNvPr id="4" name="">
             <a:extLst xmlns:a="http://schemas.openxmlformats.org/drawingml/2006/main">
               <a:ext uri="{FF2B5EF4-FFF2-40B4-BE49-F238E27FC236}">
-                <a16:creationId xmlns:a16="http://schemas.microsoft.com/office/drawing/2014/main" id="{56A4EB11-4A61-48B9-B812-7345884FD2EF}"/>
+                <a16:creationId xmlns:a16="http://schemas.microsoft.com/office/drawing/2014/main" id="{205D873D-D353-4A14-BDD1-D8FD6AD964C1}"/>
               </a:ext>
             </a:extLst>
           </p:cNvPr>
@@ -2472,7 +2472,7 @@
           <p:cNvPr id="5" name="">
             <a:extLst xmlns:a="http://schemas.openxmlformats.org/drawingml/2006/main">
               <a:ext uri="{FF2B5EF4-FFF2-40B4-BE49-F238E27FC236}">
-                <a16:creationId xmlns:a16="http://schemas.microsoft.com/office/drawing/2014/main" id="{A4DFABCC-535C-40C6-AD98-E2342074426E}"/>
+                <a16:creationId xmlns:a16="http://schemas.microsoft.com/office/drawing/2014/main" id="{24B6E575-F06E-40C4-8E3B-3702EB800D74}"/>
               </a:ext>
             </a:extLst>
           </p:cNvPr>
@@ -2536,7 +2536,7 @@
           <p:cNvPr id="6" name="">
             <a:extLst xmlns:a="http://schemas.openxmlformats.org/drawingml/2006/main">
               <a:ext uri="{FF2B5EF4-FFF2-40B4-BE49-F238E27FC236}">
-                <a16:creationId xmlns:a16="http://schemas.microsoft.com/office/drawing/2014/main" id="{73CD1300-CA81-4FB2-A54A-E7C8AEC1DC94}"/>
+                <a16:creationId xmlns:a16="http://schemas.microsoft.com/office/drawing/2014/main" id="{925307F3-C25B-4FB8-AA3B-1BDFE425C2A3}"/>
               </a:ext>
             </a:extLst>
           </p:cNvPr>
@@ -2571,7 +2571,7 @@
           <p:cNvPr id="7" name="">
             <a:extLst xmlns:a="http://schemas.openxmlformats.org/drawingml/2006/main">
               <a:ext uri="{FF2B5EF4-FFF2-40B4-BE49-F238E27FC236}">
-                <a16:creationId xmlns:a16="http://schemas.microsoft.com/office/drawing/2014/main" id="{E92598D7-7C89-400E-A5F2-312106320F21}"/>
+                <a16:creationId xmlns:a16="http://schemas.microsoft.com/office/drawing/2014/main" id="{0DE57C81-9FF0-404E-A44F-F3CCF2DA85BB}"/>
               </a:ext>
             </a:extLst>
           </p:cNvPr>
@@ -2635,7 +2635,7 @@
           <p:cNvPr id="8" name="">
             <a:extLst xmlns:a="http://schemas.openxmlformats.org/drawingml/2006/main">
               <a:ext uri="{FF2B5EF4-FFF2-40B4-BE49-F238E27FC236}">
-                <a16:creationId xmlns:a16="http://schemas.microsoft.com/office/drawing/2014/main" id="{B5D4B775-FFFF-4402-881D-EF10EDCF5E28}"/>
+                <a16:creationId xmlns:a16="http://schemas.microsoft.com/office/drawing/2014/main" id="{F8A3CA73-0A4B-4620-859B-69B080BBC485}"/>
               </a:ext>
             </a:extLst>
           </p:cNvPr>
@@ -2699,7 +2699,7 @@
           <p:cNvPr id="9" name="">
             <a:extLst xmlns:a="http://schemas.openxmlformats.org/drawingml/2006/main">
               <a:ext uri="{FF2B5EF4-FFF2-40B4-BE49-F238E27FC236}">
-                <a16:creationId xmlns:a16="http://schemas.microsoft.com/office/drawing/2014/main" id="{243DFAC6-7E0F-4D11-BE1D-D099F9E093C9}"/>
+                <a16:creationId xmlns:a16="http://schemas.microsoft.com/office/drawing/2014/main" id="{A52C40CC-2B77-4E12-9151-708D572217E3}"/>
               </a:ext>
             </a:extLst>
           </p:cNvPr>
@@ -2763,7 +2763,7 @@
           <p:cNvPr id="10" name="">
             <a:extLst xmlns:a="http://schemas.openxmlformats.org/drawingml/2006/main">
               <a:ext uri="{FF2B5EF4-FFF2-40B4-BE49-F238E27FC236}">
-                <a16:creationId xmlns:a16="http://schemas.microsoft.com/office/drawing/2014/main" id="{DC1AF05A-DADF-4AEE-8557-1B751E724824}"/>
+                <a16:creationId xmlns:a16="http://schemas.microsoft.com/office/drawing/2014/main" id="{F5401472-B9D1-46CA-BC3C-942E1FAFCABF}"/>
               </a:ext>
             </a:extLst>
           </p:cNvPr>
@@ -2798,7 +2798,7 @@
           <p:cNvPr id="11" name="">
             <a:extLst xmlns:a="http://schemas.openxmlformats.org/drawingml/2006/main">
               <a:ext uri="{FF2B5EF4-FFF2-40B4-BE49-F238E27FC236}">
-                <a16:creationId xmlns:a16="http://schemas.microsoft.com/office/drawing/2014/main" id="{31223D3E-F8BB-4E18-B4D2-A55C50B7C46E}"/>
+                <a16:creationId xmlns:a16="http://schemas.microsoft.com/office/drawing/2014/main" id="{B0C07E84-665A-40FF-B5ED-AC4B3E036811}"/>
               </a:ext>
             </a:extLst>
           </p:cNvPr>
@@ -2833,7 +2833,7 @@
           <p:cNvPr id="12" name="">
             <a:extLst xmlns:a="http://schemas.openxmlformats.org/drawingml/2006/main">
               <a:ext uri="{FF2B5EF4-FFF2-40B4-BE49-F238E27FC236}">
-                <a16:creationId xmlns:a16="http://schemas.microsoft.com/office/drawing/2014/main" id="{E4A53FA3-B9B1-4682-BA2C-9DCA9F614B53}"/>
+                <a16:creationId xmlns:a16="http://schemas.microsoft.com/office/drawing/2014/main" id="{19CC7363-0E9F-47AE-BAB6-C5FF2C4E0E42}"/>
               </a:ext>
             </a:extLst>
           </p:cNvPr>
@@ -2868,7 +2868,7 @@
           <p:cNvPr id="13" name="">
             <a:extLst xmlns:a="http://schemas.openxmlformats.org/drawingml/2006/main">
               <a:ext uri="{FF2B5EF4-FFF2-40B4-BE49-F238E27FC236}">
-                <a16:creationId xmlns:a16="http://schemas.microsoft.com/office/drawing/2014/main" id="{2B445F89-2580-49F4-9042-B8502465BD55}"/>
+                <a16:creationId xmlns:a16="http://schemas.microsoft.com/office/drawing/2014/main" id="{A0ABB2E4-7BF6-450B-B5D6-2104BBD41D38}"/>
               </a:ext>
             </a:extLst>
           </p:cNvPr>
@@ -2932,7 +2932,7 @@
           <p:cNvPr id="14" name="">
             <a:extLst xmlns:a="http://schemas.openxmlformats.org/drawingml/2006/main">
               <a:ext uri="{FF2B5EF4-FFF2-40B4-BE49-F238E27FC236}">
-                <a16:creationId xmlns:a16="http://schemas.microsoft.com/office/drawing/2014/main" id="{7828D61B-91B7-456D-9926-64C5418D4E03}"/>
+                <a16:creationId xmlns:a16="http://schemas.microsoft.com/office/drawing/2014/main" id="{B405065C-A0B9-4D14-8424-8C423D2E599B}"/>
               </a:ext>
             </a:extLst>
           </p:cNvPr>
@@ -2996,7 +2996,7 @@
           <p:cNvPr id="15" name="">
             <a:extLst xmlns:a="http://schemas.openxmlformats.org/drawingml/2006/main">
               <a:ext uri="{FF2B5EF4-FFF2-40B4-BE49-F238E27FC236}">
-                <a16:creationId xmlns:a16="http://schemas.microsoft.com/office/drawing/2014/main" id="{A448F15E-47B7-4546-A48F-A30543767D19}"/>
+                <a16:creationId xmlns:a16="http://schemas.microsoft.com/office/drawing/2014/main" id="{71743D55-B9C8-4000-ABA8-A2FAADBCC9B8}"/>
               </a:ext>
             </a:extLst>
           </p:cNvPr>
@@ -3060,7 +3060,7 @@
           <p:cNvPr id="16" name="">
             <a:extLst xmlns:a="http://schemas.openxmlformats.org/drawingml/2006/main">
               <a:ext uri="{FF2B5EF4-FFF2-40B4-BE49-F238E27FC236}">
-                <a16:creationId xmlns:a16="http://schemas.microsoft.com/office/drawing/2014/main" id="{A9645047-24B4-4A98-A75A-D9261051CE39}"/>
+                <a16:creationId xmlns:a16="http://schemas.microsoft.com/office/drawing/2014/main" id="{CD1CB61E-3A9E-4E78-9474-9F4FA3F0B806}"/>
               </a:ext>
             </a:extLst>
           </p:cNvPr>
@@ -3095,7 +3095,7 @@
           <p:cNvPr id="17" name="">
             <a:extLst xmlns:a="http://schemas.openxmlformats.org/drawingml/2006/main">
               <a:ext uri="{FF2B5EF4-FFF2-40B4-BE49-F238E27FC236}">
-                <a16:creationId xmlns:a16="http://schemas.microsoft.com/office/drawing/2014/main" id="{42D66B51-B3E0-4EE3-A93D-97700719099E}"/>
+                <a16:creationId xmlns:a16="http://schemas.microsoft.com/office/drawing/2014/main" id="{10BBD483-5B94-491E-A000-3B559D0F5845}"/>
               </a:ext>
             </a:extLst>
           </p:cNvPr>
@@ -3130,7 +3130,7 @@
           <p:cNvPr id="18" name="">
             <a:extLst xmlns:a="http://schemas.openxmlformats.org/drawingml/2006/main">
               <a:ext uri="{FF2B5EF4-FFF2-40B4-BE49-F238E27FC236}">
-                <a16:creationId xmlns:a16="http://schemas.microsoft.com/office/drawing/2014/main" id="{EADD343E-794F-4A26-B1FD-35A1A2EE867D}"/>
+                <a16:creationId xmlns:a16="http://schemas.microsoft.com/office/drawing/2014/main" id="{AB99AF66-EB32-4EB1-A375-A4D79C2585D9}"/>
               </a:ext>
             </a:extLst>
           </p:cNvPr>
@@ -3165,7 +3165,7 @@
           <p:cNvPr id="19" name="">
             <a:extLst xmlns:a="http://schemas.openxmlformats.org/drawingml/2006/main">
               <a:ext uri="{FF2B5EF4-FFF2-40B4-BE49-F238E27FC236}">
-                <a16:creationId xmlns:a16="http://schemas.microsoft.com/office/drawing/2014/main" id="{01C0DC76-9011-4EF3-BB4A-999EB4C8DEC4}"/>
+                <a16:creationId xmlns:a16="http://schemas.microsoft.com/office/drawing/2014/main" id="{10074DFB-7D24-425F-9B94-8181DBB09533}"/>
               </a:ext>
             </a:extLst>
           </p:cNvPr>
@@ -3229,7 +3229,7 @@
           <p:cNvPr id="20" name="">
             <a:extLst xmlns:a="http://schemas.openxmlformats.org/drawingml/2006/main">
               <a:ext uri="{FF2B5EF4-FFF2-40B4-BE49-F238E27FC236}">
-                <a16:creationId xmlns:a16="http://schemas.microsoft.com/office/drawing/2014/main" id="{4479D301-3D39-4F99-9CCC-A9D41AA91960}"/>
+                <a16:creationId xmlns:a16="http://schemas.microsoft.com/office/drawing/2014/main" id="{8394E22A-22AC-4C80-8656-3B55C7B59D2A}"/>
               </a:ext>
             </a:extLst>
           </p:cNvPr>
@@ -3293,7 +3293,7 @@
           <p:cNvPr id="21" name="">
             <a:extLst xmlns:a="http://schemas.openxmlformats.org/drawingml/2006/main">
               <a:ext uri="{FF2B5EF4-FFF2-40B4-BE49-F238E27FC236}">
-                <a16:creationId xmlns:a16="http://schemas.microsoft.com/office/drawing/2014/main" id="{E2D2EC71-4326-4A9B-98E2-672716173B08}"/>
+                <a16:creationId xmlns:a16="http://schemas.microsoft.com/office/drawing/2014/main" id="{325A3CFD-C4CD-4E7D-8636-695A38FD3326}"/>
               </a:ext>
             </a:extLst>
           </p:cNvPr>
@@ -3357,7 +3357,7 @@
           <p:cNvPr id="22" name="">
             <a:extLst xmlns:a="http://schemas.openxmlformats.org/drawingml/2006/main">
               <a:ext uri="{FF2B5EF4-FFF2-40B4-BE49-F238E27FC236}">
-                <a16:creationId xmlns:a16="http://schemas.microsoft.com/office/drawing/2014/main" id="{D0CCC9CC-7780-438F-B112-DB7034247546}"/>
+                <a16:creationId xmlns:a16="http://schemas.microsoft.com/office/drawing/2014/main" id="{26CC1147-7F91-443B-9A54-371717E0DE05}"/>
               </a:ext>
             </a:extLst>
           </p:cNvPr>
@@ -3390,7 +3390,7 @@
           <p:cNvPr id="23" name="">
             <a:extLst xmlns:a="http://schemas.openxmlformats.org/drawingml/2006/main">
               <a:ext uri="{FF2B5EF4-FFF2-40B4-BE49-F238E27FC236}">
-                <a16:creationId xmlns:a16="http://schemas.microsoft.com/office/drawing/2014/main" id="{3C08BD50-B8A1-457A-85FB-CD3F89EB8D01}"/>
+                <a16:creationId xmlns:a16="http://schemas.microsoft.com/office/drawing/2014/main" id="{2B83E111-2CE4-4539-9331-A6A7E394BBEA}"/>
               </a:ext>
             </a:extLst>
           </p:cNvPr>
@@ -3454,7 +3454,7 @@
           <p:cNvPr id="24" name="">
             <a:extLst xmlns:a="http://schemas.openxmlformats.org/drawingml/2006/main">
               <a:ext uri="{FF2B5EF4-FFF2-40B4-BE49-F238E27FC236}">
-                <a16:creationId xmlns:a16="http://schemas.microsoft.com/office/drawing/2014/main" id="{2338EC48-217F-4DA6-AE35-651BEBD4D018}"/>
+                <a16:creationId xmlns:a16="http://schemas.microsoft.com/office/drawing/2014/main" id="{BF4E4537-3B12-4563-B20C-7FC28E150622}"/>
               </a:ext>
             </a:extLst>
           </p:cNvPr>
@@ -3541,7 +3541,7 @@
           <p:cNvPr id="25" name="">
             <a:extLst xmlns:a="http://schemas.openxmlformats.org/drawingml/2006/main">
               <a:ext uri="{FF2B5EF4-FFF2-40B4-BE49-F238E27FC236}">
-                <a16:creationId xmlns:a16="http://schemas.microsoft.com/office/drawing/2014/main" id="{9DC3FCEB-16A3-43AD-9994-C4D0A20F4E41}"/>
+                <a16:creationId xmlns:a16="http://schemas.microsoft.com/office/drawing/2014/main" id="{94B29E4A-A285-435A-8AD4-247F29E93046}"/>
               </a:ext>
             </a:extLst>
           </p:cNvPr>
@@ -3576,7 +3576,7 @@
           <p:cNvPr id="26" name="">
             <a:extLst xmlns:a="http://schemas.openxmlformats.org/drawingml/2006/main">
               <a:ext uri="{FF2B5EF4-FFF2-40B4-BE49-F238E27FC236}">
-                <a16:creationId xmlns:a16="http://schemas.microsoft.com/office/drawing/2014/main" id="{4EC293E9-6B1F-4D83-A2C7-858FF56AFAB4}"/>
+                <a16:creationId xmlns:a16="http://schemas.microsoft.com/office/drawing/2014/main" id="{0AEDFC2D-B83B-442C-88AE-9378C6A7955C}"/>
               </a:ext>
             </a:extLst>
           </p:cNvPr>
@@ -3638,7 +3638,7 @@
     </p:spTree>
     <p:extLst>
       <p:ext uri="{BB962C8B-B14F-4D97-AF65-F5344CB8AC3E}">
-        <p14:creationId xmlns:p14="http://schemas.microsoft.com/office/powerpoint/2010/main" val="2133901943"/>
+        <p14:creationId xmlns:p14="http://schemas.microsoft.com/office/powerpoint/2010/main" val="1136980627"/>
       </p:ext>
     </p:extLst>
   </p:cSld>
@@ -3662,7 +3662,7 @@
           <p:cNvPr id="1" name="">
             <a:extLst xmlns:a="http://schemas.openxmlformats.org/drawingml/2006/main">
               <a:ext uri="{FF2B5EF4-FFF2-40B4-BE49-F238E27FC236}">
-                <a16:creationId xmlns:a16="http://schemas.microsoft.com/office/drawing/2014/main" id="{4C266564-A198-46C7-A96A-BFE3CCE4B982}"/>
+                <a16:creationId xmlns:a16="http://schemas.microsoft.com/office/drawing/2014/main" id="{EE2BE4BF-96D1-4F4C-BDBF-D665413DC27E}"/>
               </a:ext>
             </a:extLst>
           </p:cNvPr>
@@ -3697,7 +3697,7 @@
           <p:cNvPr id="2" name="kicker-marker">
             <a:extLst xmlns:a="http://schemas.openxmlformats.org/drawingml/2006/main">
               <a:ext uri="{FF2B5EF4-FFF2-40B4-BE49-F238E27FC236}">
-                <a16:creationId xmlns:a16="http://schemas.microsoft.com/office/drawing/2014/main" id="{0198B10E-00AE-47D6-A68F-1D4DEF4B3BCF}"/>
+                <a16:creationId xmlns:a16="http://schemas.microsoft.com/office/drawing/2014/main" id="{ADB71A31-8C8B-40BE-B766-903EF1D92A1E}"/>
               </a:ext>
             </a:extLst>
           </p:cNvPr>
@@ -3732,7 +3732,7 @@
           <p:cNvPr id="3" name="kicker-label">
             <a:extLst xmlns:a="http://schemas.openxmlformats.org/drawingml/2006/main">
               <a:ext uri="{FF2B5EF4-FFF2-40B4-BE49-F238E27FC236}">
-                <a16:creationId xmlns:a16="http://schemas.microsoft.com/office/drawing/2014/main" id="{7D48C745-66A5-4B28-AF93-3BA29A07E241}"/>
+                <a16:creationId xmlns:a16="http://schemas.microsoft.com/office/drawing/2014/main" id="{FD97AA8B-797A-493D-AF85-AE94C3EA2750}"/>
               </a:ext>
             </a:extLst>
           </p:cNvPr>
@@ -3796,7 +3796,7 @@
           <p:cNvPr id="4" name="">
             <a:extLst xmlns:a="http://schemas.openxmlformats.org/drawingml/2006/main">
               <a:ext uri="{FF2B5EF4-FFF2-40B4-BE49-F238E27FC236}">
-                <a16:creationId xmlns:a16="http://schemas.microsoft.com/office/drawing/2014/main" id="{A160CD28-4B71-4656-9F14-661B97A956D1}"/>
+                <a16:creationId xmlns:a16="http://schemas.microsoft.com/office/drawing/2014/main" id="{210260D9-EBD3-4A86-A77F-064106CE25CC}"/>
               </a:ext>
             </a:extLst>
           </p:cNvPr>
@@ -3860,7 +3860,7 @@
           <p:cNvPr id="5" name="">
             <a:extLst xmlns:a="http://schemas.openxmlformats.org/drawingml/2006/main">
               <a:ext uri="{FF2B5EF4-FFF2-40B4-BE49-F238E27FC236}">
-                <a16:creationId xmlns:a16="http://schemas.microsoft.com/office/drawing/2014/main" id="{95BA2513-C0DC-4E92-ABCE-A8A561FD18CE}"/>
+                <a16:creationId xmlns:a16="http://schemas.microsoft.com/office/drawing/2014/main" id="{B6812461-5EA2-4727-93B3-4008A93AC074}"/>
               </a:ext>
             </a:extLst>
           </p:cNvPr>
@@ -3895,7 +3895,7 @@
           <p:cNvPr id="6" name="">
             <a:extLst xmlns:a="http://schemas.openxmlformats.org/drawingml/2006/main">
               <a:ext uri="{FF2B5EF4-FFF2-40B4-BE49-F238E27FC236}">
-                <a16:creationId xmlns:a16="http://schemas.microsoft.com/office/drawing/2014/main" id="{D08BC09B-357A-4C2B-BB1A-3EE14B04AE06}"/>
+                <a16:creationId xmlns:a16="http://schemas.microsoft.com/office/drawing/2014/main" id="{F67D074F-1395-40F1-8A55-CDADFCB27E8F}"/>
               </a:ext>
             </a:extLst>
           </p:cNvPr>
@@ -3959,7 +3959,7 @@
           <p:cNvPr id="7" name="">
             <a:extLst xmlns:a="http://schemas.openxmlformats.org/drawingml/2006/main">
               <a:ext uri="{FF2B5EF4-FFF2-40B4-BE49-F238E27FC236}">
-                <a16:creationId xmlns:a16="http://schemas.microsoft.com/office/drawing/2014/main" id="{1024DF80-E79B-41FE-8CD7-DEF018C9AD6B}"/>
+                <a16:creationId xmlns:a16="http://schemas.microsoft.com/office/drawing/2014/main" id="{6C037B64-50CB-44D5-8B62-B69DC6B7AFDF}"/>
               </a:ext>
             </a:extLst>
           </p:cNvPr>
@@ -3992,7 +3992,7 @@
           <p:cNvPr id="8" name="">
             <a:extLst xmlns:a="http://schemas.openxmlformats.org/drawingml/2006/main">
               <a:ext uri="{FF2B5EF4-FFF2-40B4-BE49-F238E27FC236}">
-                <a16:creationId xmlns:a16="http://schemas.microsoft.com/office/drawing/2014/main" id="{93F12E5E-5F6C-4A4E-964E-734C62F428A7}"/>
+                <a16:creationId xmlns:a16="http://schemas.microsoft.com/office/drawing/2014/main" id="{48559DD7-3E2F-466C-BDB2-F5D01F88EE00}"/>
               </a:ext>
             </a:extLst>
           </p:cNvPr>
@@ -4056,7 +4056,7 @@
           <p:cNvPr id="9" name="">
             <a:extLst xmlns:a="http://schemas.openxmlformats.org/drawingml/2006/main">
               <a:ext uri="{FF2B5EF4-FFF2-40B4-BE49-F238E27FC236}">
-                <a16:creationId xmlns:a16="http://schemas.microsoft.com/office/drawing/2014/main" id="{F6A8D19A-4E66-498D-ACBC-AF25045A429E}"/>
+                <a16:creationId xmlns:a16="http://schemas.microsoft.com/office/drawing/2014/main" id="{912AD942-D518-45BB-BC3A-CB42E13165FE}"/>
               </a:ext>
             </a:extLst>
           </p:cNvPr>
@@ -4120,7 +4120,7 @@
           <p:cNvPr id="10" name="">
             <a:extLst xmlns:a="http://schemas.openxmlformats.org/drawingml/2006/main">
               <a:ext uri="{FF2B5EF4-FFF2-40B4-BE49-F238E27FC236}">
-                <a16:creationId xmlns:a16="http://schemas.microsoft.com/office/drawing/2014/main" id="{27D32E11-4256-41E2-969E-624C505D3A51}"/>
+                <a16:creationId xmlns:a16="http://schemas.microsoft.com/office/drawing/2014/main" id="{7E970B98-62A7-4484-B717-14829767236F}"/>
               </a:ext>
             </a:extLst>
           </p:cNvPr>
@@ -4184,7 +4184,7 @@
           <p:cNvPr id="11" name="">
             <a:extLst xmlns:a="http://schemas.openxmlformats.org/drawingml/2006/main">
               <a:ext uri="{FF2B5EF4-FFF2-40B4-BE49-F238E27FC236}">
-                <a16:creationId xmlns:a16="http://schemas.microsoft.com/office/drawing/2014/main" id="{E368E1D7-44C4-4768-8AC8-A90F722998CE}"/>
+                <a16:creationId xmlns:a16="http://schemas.microsoft.com/office/drawing/2014/main" id="{FA17E937-8209-44CA-A9D6-0700B40DB841}"/>
               </a:ext>
             </a:extLst>
           </p:cNvPr>
@@ -4219,7 +4219,7 @@
           <p:cNvPr id="12" name="">
             <a:extLst xmlns:a="http://schemas.openxmlformats.org/drawingml/2006/main">
               <a:ext uri="{FF2B5EF4-FFF2-40B4-BE49-F238E27FC236}">
-                <a16:creationId xmlns:a16="http://schemas.microsoft.com/office/drawing/2014/main" id="{857562AE-4BFF-45B1-9443-2CAE1F6F84A7}"/>
+                <a16:creationId xmlns:a16="http://schemas.microsoft.com/office/drawing/2014/main" id="{72A68936-B66E-4E61-A58F-9AA9D287D521}"/>
               </a:ext>
             </a:extLst>
           </p:cNvPr>
@@ -4254,7 +4254,7 @@
           <p:cNvPr id="13" name="">
             <a:extLst xmlns:a="http://schemas.openxmlformats.org/drawingml/2006/main">
               <a:ext uri="{FF2B5EF4-FFF2-40B4-BE49-F238E27FC236}">
-                <a16:creationId xmlns:a16="http://schemas.microsoft.com/office/drawing/2014/main" id="{DE1FBEE7-7377-4616-834B-D66F2B079166}"/>
+                <a16:creationId xmlns:a16="http://schemas.microsoft.com/office/drawing/2014/main" id="{A37700FF-223A-4473-9A3D-7D8B2A5CE186}"/>
               </a:ext>
             </a:extLst>
           </p:cNvPr>
@@ -4287,7 +4287,7 @@
           <p:cNvPr id="14" name="">
             <a:extLst xmlns:a="http://schemas.openxmlformats.org/drawingml/2006/main">
               <a:ext uri="{FF2B5EF4-FFF2-40B4-BE49-F238E27FC236}">
-                <a16:creationId xmlns:a16="http://schemas.microsoft.com/office/drawing/2014/main" id="{B7966E9B-2FC5-4E70-98A5-80296EFB483D}"/>
+                <a16:creationId xmlns:a16="http://schemas.microsoft.com/office/drawing/2014/main" id="{D16DC9FA-C47C-4C8C-97F2-18C1CF76CAC9}"/>
               </a:ext>
             </a:extLst>
           </p:cNvPr>
@@ -4351,7 +4351,7 @@
           <p:cNvPr id="15" name="">
             <a:extLst xmlns:a="http://schemas.openxmlformats.org/drawingml/2006/main">
               <a:ext uri="{FF2B5EF4-FFF2-40B4-BE49-F238E27FC236}">
-                <a16:creationId xmlns:a16="http://schemas.microsoft.com/office/drawing/2014/main" id="{F47723CA-9137-4387-A6C5-901383C14149}"/>
+                <a16:creationId xmlns:a16="http://schemas.microsoft.com/office/drawing/2014/main" id="{6D8D9E3C-1298-49C2-8103-00498D0984D0}"/>
               </a:ext>
             </a:extLst>
           </p:cNvPr>
@@ -4415,7 +4415,7 @@
           <p:cNvPr id="16" name="">
             <a:extLst xmlns:a="http://schemas.openxmlformats.org/drawingml/2006/main">
               <a:ext uri="{FF2B5EF4-FFF2-40B4-BE49-F238E27FC236}">
-                <a16:creationId xmlns:a16="http://schemas.microsoft.com/office/drawing/2014/main" id="{C589A8C7-2738-4222-8EA4-BB2829091788}"/>
+                <a16:creationId xmlns:a16="http://schemas.microsoft.com/office/drawing/2014/main" id="{52C55521-D0E7-4521-A54D-EEDBF710EB9E}"/>
               </a:ext>
             </a:extLst>
           </p:cNvPr>
@@ -4479,7 +4479,7 @@
           <p:cNvPr id="17" name="">
             <a:extLst xmlns:a="http://schemas.openxmlformats.org/drawingml/2006/main">
               <a:ext uri="{FF2B5EF4-FFF2-40B4-BE49-F238E27FC236}">
-                <a16:creationId xmlns:a16="http://schemas.microsoft.com/office/drawing/2014/main" id="{EC74C98D-BFE8-4986-8BEA-82A979FA4C7D}"/>
+                <a16:creationId xmlns:a16="http://schemas.microsoft.com/office/drawing/2014/main" id="{8F2CCFF5-D86A-469F-99FB-F146FF33E442}"/>
               </a:ext>
             </a:extLst>
           </p:cNvPr>
@@ -4514,7 +4514,7 @@
           <p:cNvPr id="18" name="">
             <a:extLst xmlns:a="http://schemas.openxmlformats.org/drawingml/2006/main">
               <a:ext uri="{FF2B5EF4-FFF2-40B4-BE49-F238E27FC236}">
-                <a16:creationId xmlns:a16="http://schemas.microsoft.com/office/drawing/2014/main" id="{D3AC09C9-9B4D-4F6C-944A-83D8E8E3342B}"/>
+                <a16:creationId xmlns:a16="http://schemas.microsoft.com/office/drawing/2014/main" id="{0E8A912A-0B64-4881-8BD2-0334B1EE7476}"/>
               </a:ext>
             </a:extLst>
           </p:cNvPr>
@@ -4549,7 +4549,7 @@
           <p:cNvPr id="19" name="">
             <a:extLst xmlns:a="http://schemas.openxmlformats.org/drawingml/2006/main">
               <a:ext uri="{FF2B5EF4-FFF2-40B4-BE49-F238E27FC236}">
-                <a16:creationId xmlns:a16="http://schemas.microsoft.com/office/drawing/2014/main" id="{1240B36C-2CA7-47FF-A58A-3463955EA03C}"/>
+                <a16:creationId xmlns:a16="http://schemas.microsoft.com/office/drawing/2014/main" id="{698EC0B3-EEE8-4ECB-A99D-93F6447728BD}"/>
               </a:ext>
             </a:extLst>
           </p:cNvPr>
@@ -4582,7 +4582,7 @@
           <p:cNvPr id="20" name="">
             <a:extLst xmlns:a="http://schemas.openxmlformats.org/drawingml/2006/main">
               <a:ext uri="{FF2B5EF4-FFF2-40B4-BE49-F238E27FC236}">
-                <a16:creationId xmlns:a16="http://schemas.microsoft.com/office/drawing/2014/main" id="{45B8D1AD-A092-4802-BFFC-1061E2A503E7}"/>
+                <a16:creationId xmlns:a16="http://schemas.microsoft.com/office/drawing/2014/main" id="{15AFC32A-B416-49DF-87C4-CD1D81570025}"/>
               </a:ext>
             </a:extLst>
           </p:cNvPr>
@@ -4646,7 +4646,7 @@
           <p:cNvPr id="21" name="">
             <a:extLst xmlns:a="http://schemas.openxmlformats.org/drawingml/2006/main">
               <a:ext uri="{FF2B5EF4-FFF2-40B4-BE49-F238E27FC236}">
-                <a16:creationId xmlns:a16="http://schemas.microsoft.com/office/drawing/2014/main" id="{50842E13-AB89-4989-B3D9-5AC34D7FB6FE}"/>
+                <a16:creationId xmlns:a16="http://schemas.microsoft.com/office/drawing/2014/main" id="{EED25484-E225-46F7-AB4A-097E35AC233A}"/>
               </a:ext>
             </a:extLst>
           </p:cNvPr>
@@ -4710,7 +4710,7 @@
           <p:cNvPr id="22" name="">
             <a:extLst xmlns:a="http://schemas.openxmlformats.org/drawingml/2006/main">
               <a:ext uri="{FF2B5EF4-FFF2-40B4-BE49-F238E27FC236}">
-                <a16:creationId xmlns:a16="http://schemas.microsoft.com/office/drawing/2014/main" id="{240E48A1-FE60-4EB4-AFD7-2FEF2CCD5789}"/>
+                <a16:creationId xmlns:a16="http://schemas.microsoft.com/office/drawing/2014/main" id="{7DCAD4E3-B1BA-4812-A940-57C37093401D}"/>
               </a:ext>
             </a:extLst>
           </p:cNvPr>
@@ -4774,7 +4774,7 @@
           <p:cNvPr id="23" name="">
             <a:extLst xmlns:a="http://schemas.openxmlformats.org/drawingml/2006/main">
               <a:ext uri="{FF2B5EF4-FFF2-40B4-BE49-F238E27FC236}">
-                <a16:creationId xmlns:a16="http://schemas.microsoft.com/office/drawing/2014/main" id="{48614DCE-7BAB-45FF-B5B8-11BB80F16CC0}"/>
+                <a16:creationId xmlns:a16="http://schemas.microsoft.com/office/drawing/2014/main" id="{FE321DAE-7023-40B0-929B-13675D2B5F2F}"/>
               </a:ext>
             </a:extLst>
           </p:cNvPr>
@@ -4809,7 +4809,7 @@
           <p:cNvPr id="24" name="">
             <a:extLst xmlns:a="http://schemas.openxmlformats.org/drawingml/2006/main">
               <a:ext uri="{FF2B5EF4-FFF2-40B4-BE49-F238E27FC236}">
-                <a16:creationId xmlns:a16="http://schemas.microsoft.com/office/drawing/2014/main" id="{CB2DC128-7D84-4721-8C8A-C3FC9DE49613}"/>
+                <a16:creationId xmlns:a16="http://schemas.microsoft.com/office/drawing/2014/main" id="{526A227D-A3AD-4F30-9C9E-508733DD745A}"/>
               </a:ext>
             </a:extLst>
           </p:cNvPr>
@@ -4844,7 +4844,7 @@
           <p:cNvPr id="25" name="">
             <a:extLst xmlns:a="http://schemas.openxmlformats.org/drawingml/2006/main">
               <a:ext uri="{FF2B5EF4-FFF2-40B4-BE49-F238E27FC236}">
-                <a16:creationId xmlns:a16="http://schemas.microsoft.com/office/drawing/2014/main" id="{D075BD38-1805-404E-AE35-64E4B2FE03F5}"/>
+                <a16:creationId xmlns:a16="http://schemas.microsoft.com/office/drawing/2014/main" id="{667FDFBB-B15F-4400-B459-64C8F529B1A6}"/>
               </a:ext>
             </a:extLst>
           </p:cNvPr>
@@ -4877,7 +4877,7 @@
           <p:cNvPr id="26" name="">
             <a:extLst xmlns:a="http://schemas.openxmlformats.org/drawingml/2006/main">
               <a:ext uri="{FF2B5EF4-FFF2-40B4-BE49-F238E27FC236}">
-                <a16:creationId xmlns:a16="http://schemas.microsoft.com/office/drawing/2014/main" id="{158288C1-5F96-41CB-A789-60C4E5227364}"/>
+                <a16:creationId xmlns:a16="http://schemas.microsoft.com/office/drawing/2014/main" id="{252F9771-F0BC-48A8-BDAC-91AB3A30A0E8}"/>
               </a:ext>
             </a:extLst>
           </p:cNvPr>
@@ -4941,7 +4941,7 @@
           <p:cNvPr id="27" name="">
             <a:extLst xmlns:a="http://schemas.openxmlformats.org/drawingml/2006/main">
               <a:ext uri="{FF2B5EF4-FFF2-40B4-BE49-F238E27FC236}">
-                <a16:creationId xmlns:a16="http://schemas.microsoft.com/office/drawing/2014/main" id="{E472F842-2876-4646-AFAB-CCF80EA53F57}"/>
+                <a16:creationId xmlns:a16="http://schemas.microsoft.com/office/drawing/2014/main" id="{4A7BE824-0B9C-452B-A229-F2E557BAD090}"/>
               </a:ext>
             </a:extLst>
           </p:cNvPr>
@@ -5005,7 +5005,7 @@
           <p:cNvPr id="28" name="">
             <a:extLst xmlns:a="http://schemas.openxmlformats.org/drawingml/2006/main">
               <a:ext uri="{FF2B5EF4-FFF2-40B4-BE49-F238E27FC236}">
-                <a16:creationId xmlns:a16="http://schemas.microsoft.com/office/drawing/2014/main" id="{F2D612F3-8018-4644-9484-D3DAE86DB012}"/>
+                <a16:creationId xmlns:a16="http://schemas.microsoft.com/office/drawing/2014/main" id="{7F87F06A-10FE-42F0-983A-1EC8C1C4C2AA}"/>
               </a:ext>
             </a:extLst>
           </p:cNvPr>
@@ -5069,7 +5069,7 @@
           <p:cNvPr id="29" name="">
             <a:extLst xmlns:a="http://schemas.openxmlformats.org/drawingml/2006/main">
               <a:ext uri="{FF2B5EF4-FFF2-40B4-BE49-F238E27FC236}">
-                <a16:creationId xmlns:a16="http://schemas.microsoft.com/office/drawing/2014/main" id="{18ABAE1C-873D-4E2D-A78A-CF4996A975C8}"/>
+                <a16:creationId xmlns:a16="http://schemas.microsoft.com/office/drawing/2014/main" id="{060BDE2E-DA07-4CD7-93A7-05B3E8E9ADBA}"/>
               </a:ext>
             </a:extLst>
           </p:cNvPr>
@@ -5131,7 +5131,7 @@
     </p:spTree>
     <p:extLst>
       <p:ext uri="{BB962C8B-B14F-4D97-AF65-F5344CB8AC3E}">
-        <p14:creationId xmlns:p14="http://schemas.microsoft.com/office/powerpoint/2010/main" val="1831984101"/>
+        <p14:creationId xmlns:p14="http://schemas.microsoft.com/office/powerpoint/2010/main" val="1708224861"/>
       </p:ext>
     </p:extLst>
   </p:cSld>
@@ -5155,7 +5155,7 @@
           <p:cNvPr id="1" name="">
             <a:extLst xmlns:a="http://schemas.openxmlformats.org/drawingml/2006/main">
               <a:ext uri="{FF2B5EF4-FFF2-40B4-BE49-F238E27FC236}">
-                <a16:creationId xmlns:a16="http://schemas.microsoft.com/office/drawing/2014/main" id="{96628CBB-756C-47C2-B876-05DA0E9747CD}"/>
+                <a16:creationId xmlns:a16="http://schemas.microsoft.com/office/drawing/2014/main" id="{18CB9FB9-3017-4C96-AE14-BDBF0C0B24EF}"/>
               </a:ext>
             </a:extLst>
           </p:cNvPr>
@@ -5190,7 +5190,7 @@
           <p:cNvPr id="2" name="kicker-marker">
             <a:extLst xmlns:a="http://schemas.openxmlformats.org/drawingml/2006/main">
               <a:ext uri="{FF2B5EF4-FFF2-40B4-BE49-F238E27FC236}">
-                <a16:creationId xmlns:a16="http://schemas.microsoft.com/office/drawing/2014/main" id="{1D521910-13E1-402C-8253-0269B00AB4DD}"/>
+                <a16:creationId xmlns:a16="http://schemas.microsoft.com/office/drawing/2014/main" id="{CA2D92EE-B15E-4D1F-9F85-ED75BCC7109D}"/>
               </a:ext>
             </a:extLst>
           </p:cNvPr>
@@ -5225,7 +5225,7 @@
           <p:cNvPr id="3" name="kicker-label">
             <a:extLst xmlns:a="http://schemas.openxmlformats.org/drawingml/2006/main">
               <a:ext uri="{FF2B5EF4-FFF2-40B4-BE49-F238E27FC236}">
-                <a16:creationId xmlns:a16="http://schemas.microsoft.com/office/drawing/2014/main" id="{835FBF75-1B03-4F95-9756-FDBCA7321B0B}"/>
+                <a16:creationId xmlns:a16="http://schemas.microsoft.com/office/drawing/2014/main" id="{F88B2FCC-9AD6-4A2A-B0FD-383717C525A8}"/>
               </a:ext>
             </a:extLst>
           </p:cNvPr>
@@ -5289,7 +5289,7 @@
           <p:cNvPr id="4" name="">
             <a:extLst xmlns:a="http://schemas.openxmlformats.org/drawingml/2006/main">
               <a:ext uri="{FF2B5EF4-FFF2-40B4-BE49-F238E27FC236}">
-                <a16:creationId xmlns:a16="http://schemas.microsoft.com/office/drawing/2014/main" id="{06933046-58FE-4AA5-ACB9-B2DAC9EF2046}"/>
+                <a16:creationId xmlns:a16="http://schemas.microsoft.com/office/drawing/2014/main" id="{85817ADC-3CAA-4359-B447-A762899962E5}"/>
               </a:ext>
             </a:extLst>
           </p:cNvPr>
@@ -5353,7 +5353,7 @@
           <p:cNvPr id="5" name="">
             <a:extLst xmlns:a="http://schemas.openxmlformats.org/drawingml/2006/main">
               <a:ext uri="{FF2B5EF4-FFF2-40B4-BE49-F238E27FC236}">
-                <a16:creationId xmlns:a16="http://schemas.microsoft.com/office/drawing/2014/main" id="{ADD7C837-6D93-45A2-BBD9-1C64D6984057}"/>
+                <a16:creationId xmlns:a16="http://schemas.microsoft.com/office/drawing/2014/main" id="{82D59901-D979-4850-93AB-E3372919CC71}"/>
               </a:ext>
             </a:extLst>
           </p:cNvPr>
@@ -5388,7 +5388,7 @@
           <p:cNvPr id="6" name="">
             <a:extLst xmlns:a="http://schemas.openxmlformats.org/drawingml/2006/main">
               <a:ext uri="{FF2B5EF4-FFF2-40B4-BE49-F238E27FC236}">
-                <a16:creationId xmlns:a16="http://schemas.microsoft.com/office/drawing/2014/main" id="{73C09832-DACD-4483-A64E-0D67B02EFC65}"/>
+                <a16:creationId xmlns:a16="http://schemas.microsoft.com/office/drawing/2014/main" id="{2C69A23C-089E-4DE4-830F-F625F9F240AD}"/>
               </a:ext>
             </a:extLst>
           </p:cNvPr>
@@ -5452,7 +5452,7 @@
           <p:cNvPr id="7" name="">
             <a:extLst xmlns:a="http://schemas.openxmlformats.org/drawingml/2006/main">
               <a:ext uri="{FF2B5EF4-FFF2-40B4-BE49-F238E27FC236}">
-                <a16:creationId xmlns:a16="http://schemas.microsoft.com/office/drawing/2014/main" id="{681198B2-4E8E-410F-9934-8C3D908FA60A}"/>
+                <a16:creationId xmlns:a16="http://schemas.microsoft.com/office/drawing/2014/main" id="{22A2BA67-3294-43E8-901B-D6083836F48B}"/>
               </a:ext>
             </a:extLst>
           </p:cNvPr>
@@ -5516,7 +5516,7 @@
           <p:cNvPr id="8" name="">
             <a:extLst xmlns:a="http://schemas.openxmlformats.org/drawingml/2006/main">
               <a:ext uri="{FF2B5EF4-FFF2-40B4-BE49-F238E27FC236}">
-                <a16:creationId xmlns:a16="http://schemas.microsoft.com/office/drawing/2014/main" id="{C6FF0B92-02BF-4679-9FDF-46ABF9FFFADC}"/>
+                <a16:creationId xmlns:a16="http://schemas.microsoft.com/office/drawing/2014/main" id="{BF06559E-D18F-44AF-AD6C-F7A501DD6C72}"/>
               </a:ext>
             </a:extLst>
           </p:cNvPr>
@@ -5580,7 +5580,7 @@
           <p:cNvPr id="9" name="">
             <a:extLst xmlns:a="http://schemas.openxmlformats.org/drawingml/2006/main">
               <a:ext uri="{FF2B5EF4-FFF2-40B4-BE49-F238E27FC236}">
-                <a16:creationId xmlns:a16="http://schemas.microsoft.com/office/drawing/2014/main" id="{3EBEA270-D0CC-487D-8055-C2370BAD86DD}"/>
+                <a16:creationId xmlns:a16="http://schemas.microsoft.com/office/drawing/2014/main" id="{D78763CD-F40D-4FB8-BFAA-52C9CDC60792}"/>
               </a:ext>
             </a:extLst>
           </p:cNvPr>
@@ -5615,7 +5615,7 @@
           <p:cNvPr id="10" name="">
             <a:extLst xmlns:a="http://schemas.openxmlformats.org/drawingml/2006/main">
               <a:ext uri="{FF2B5EF4-FFF2-40B4-BE49-F238E27FC236}">
-                <a16:creationId xmlns:a16="http://schemas.microsoft.com/office/drawing/2014/main" id="{975FDB48-3BD5-405E-A3A8-3D693623F1FB}"/>
+                <a16:creationId xmlns:a16="http://schemas.microsoft.com/office/drawing/2014/main" id="{1E13E664-62E3-49EA-8BF8-984FB1E36D03}"/>
               </a:ext>
             </a:extLst>
           </p:cNvPr>
@@ -5650,7 +5650,7 @@
           <p:cNvPr id="11" name="">
             <a:extLst xmlns:a="http://schemas.openxmlformats.org/drawingml/2006/main">
               <a:ext uri="{FF2B5EF4-FFF2-40B4-BE49-F238E27FC236}">
-                <a16:creationId xmlns:a16="http://schemas.microsoft.com/office/drawing/2014/main" id="{87FAD459-595C-41EB-BDB6-7C0434F04E8D}"/>
+                <a16:creationId xmlns:a16="http://schemas.microsoft.com/office/drawing/2014/main" id="{016DC045-7449-480C-9D9E-93180584F84B}"/>
               </a:ext>
             </a:extLst>
           </p:cNvPr>
@@ -5714,7 +5714,7 @@
           <p:cNvPr id="12" name="">
             <a:extLst xmlns:a="http://schemas.openxmlformats.org/drawingml/2006/main">
               <a:ext uri="{FF2B5EF4-FFF2-40B4-BE49-F238E27FC236}">
-                <a16:creationId xmlns:a16="http://schemas.microsoft.com/office/drawing/2014/main" id="{19C40FDC-A5B3-41FA-893C-B86B6C23EBA2}"/>
+                <a16:creationId xmlns:a16="http://schemas.microsoft.com/office/drawing/2014/main" id="{6414E326-3298-40B5-846D-1B9126F2B942}"/>
               </a:ext>
             </a:extLst>
           </p:cNvPr>
@@ -5778,7 +5778,7 @@
           <p:cNvPr id="13" name="">
             <a:extLst xmlns:a="http://schemas.openxmlformats.org/drawingml/2006/main">
               <a:ext uri="{FF2B5EF4-FFF2-40B4-BE49-F238E27FC236}">
-                <a16:creationId xmlns:a16="http://schemas.microsoft.com/office/drawing/2014/main" id="{656F812B-B58E-49A7-B394-AB1A9C1CABFA}"/>
+                <a16:creationId xmlns:a16="http://schemas.microsoft.com/office/drawing/2014/main" id="{0C67ECA2-ABBD-48CA-BA63-F71D331E8B10}"/>
               </a:ext>
             </a:extLst>
           </p:cNvPr>
@@ -5813,7 +5813,7 @@
           <p:cNvPr id="14" name="">
             <a:extLst xmlns:a="http://schemas.openxmlformats.org/drawingml/2006/main">
               <a:ext uri="{FF2B5EF4-FFF2-40B4-BE49-F238E27FC236}">
-                <a16:creationId xmlns:a16="http://schemas.microsoft.com/office/drawing/2014/main" id="{5E4E202F-685C-404D-9761-3C7EB7E1A8F6}"/>
+                <a16:creationId xmlns:a16="http://schemas.microsoft.com/office/drawing/2014/main" id="{C09D9DB9-B703-4D42-9D26-B7344351AB83}"/>
               </a:ext>
             </a:extLst>
           </p:cNvPr>
@@ -5848,7 +5848,7 @@
           <p:cNvPr id="15" name="">
             <a:extLst xmlns:a="http://schemas.openxmlformats.org/drawingml/2006/main">
               <a:ext uri="{FF2B5EF4-FFF2-40B4-BE49-F238E27FC236}">
-                <a16:creationId xmlns:a16="http://schemas.microsoft.com/office/drawing/2014/main" id="{DE8221C8-60E6-4A48-8B53-36FB9BF57840}"/>
+                <a16:creationId xmlns:a16="http://schemas.microsoft.com/office/drawing/2014/main" id="{2250E80C-B93B-4BEB-A9AD-0A26FE50BBFD}"/>
               </a:ext>
             </a:extLst>
           </p:cNvPr>
@@ -5912,7 +5912,7 @@
           <p:cNvPr id="16" name="">
             <a:extLst xmlns:a="http://schemas.openxmlformats.org/drawingml/2006/main">
               <a:ext uri="{FF2B5EF4-FFF2-40B4-BE49-F238E27FC236}">
-                <a16:creationId xmlns:a16="http://schemas.microsoft.com/office/drawing/2014/main" id="{D01767BB-B855-438F-A255-920C7F14697F}"/>
+                <a16:creationId xmlns:a16="http://schemas.microsoft.com/office/drawing/2014/main" id="{4AE806E7-9299-4EF6-8EDE-DE23842387C1}"/>
               </a:ext>
             </a:extLst>
           </p:cNvPr>
@@ -5947,7 +5947,7 @@
           <p:cNvPr id="17" name="">
             <a:extLst xmlns:a="http://schemas.openxmlformats.org/drawingml/2006/main">
               <a:ext uri="{FF2B5EF4-FFF2-40B4-BE49-F238E27FC236}">
-                <a16:creationId xmlns:a16="http://schemas.microsoft.com/office/drawing/2014/main" id="{6D8BF01A-DCFD-4F54-8D84-4D02170294BD}"/>
+                <a16:creationId xmlns:a16="http://schemas.microsoft.com/office/drawing/2014/main" id="{4CE32BE3-71FB-4AB0-A9A3-1E307DFDC89F}"/>
               </a:ext>
             </a:extLst>
           </p:cNvPr>
@@ -6011,7 +6011,7 @@
           <p:cNvPr id="18" name="">
             <a:extLst xmlns:a="http://schemas.openxmlformats.org/drawingml/2006/main">
               <a:ext uri="{FF2B5EF4-FFF2-40B4-BE49-F238E27FC236}">
-                <a16:creationId xmlns:a16="http://schemas.microsoft.com/office/drawing/2014/main" id="{0C1C89AB-7666-48F7-86BC-773BF23BC161}"/>
+                <a16:creationId xmlns:a16="http://schemas.microsoft.com/office/drawing/2014/main" id="{C7CAF845-70B5-45DE-9994-2024AE123CAA}"/>
               </a:ext>
             </a:extLst>
           </p:cNvPr>
@@ -6046,7 +6046,7 @@
           <p:cNvPr id="19" name="">
             <a:extLst xmlns:a="http://schemas.openxmlformats.org/drawingml/2006/main">
               <a:ext uri="{FF2B5EF4-FFF2-40B4-BE49-F238E27FC236}">
-                <a16:creationId xmlns:a16="http://schemas.microsoft.com/office/drawing/2014/main" id="{E6BF35F8-B54C-4CAB-9750-3773B0AB962B}"/>
+                <a16:creationId xmlns:a16="http://schemas.microsoft.com/office/drawing/2014/main" id="{C4C695AF-0C0F-4ADD-93BD-F2B92B7B705C}"/>
               </a:ext>
             </a:extLst>
           </p:cNvPr>
@@ -6110,7 +6110,7 @@
           <p:cNvPr id="20" name="">
             <a:extLst xmlns:a="http://schemas.openxmlformats.org/drawingml/2006/main">
               <a:ext uri="{FF2B5EF4-FFF2-40B4-BE49-F238E27FC236}">
-                <a16:creationId xmlns:a16="http://schemas.microsoft.com/office/drawing/2014/main" id="{46697C58-9C5E-44B5-A2F7-B7B6FC05C026}"/>
+                <a16:creationId xmlns:a16="http://schemas.microsoft.com/office/drawing/2014/main" id="{CF7DB035-1C4D-4E5A-B8F9-324D152A53A8}"/>
               </a:ext>
             </a:extLst>
           </p:cNvPr>
@@ -6145,7 +6145,7 @@
           <p:cNvPr id="21" name="">
             <a:extLst xmlns:a="http://schemas.openxmlformats.org/drawingml/2006/main">
               <a:ext uri="{FF2B5EF4-FFF2-40B4-BE49-F238E27FC236}">
-                <a16:creationId xmlns:a16="http://schemas.microsoft.com/office/drawing/2014/main" id="{4129D0D3-9B9E-4B79-ACA2-49F02C2A82E9}"/>
+                <a16:creationId xmlns:a16="http://schemas.microsoft.com/office/drawing/2014/main" id="{5CA997CA-D926-45AA-B8D0-2665DDBFE3DA}"/>
               </a:ext>
             </a:extLst>
           </p:cNvPr>
@@ -6209,7 +6209,7 @@
           <p:cNvPr id="22" name="">
             <a:extLst xmlns:a="http://schemas.openxmlformats.org/drawingml/2006/main">
               <a:ext uri="{FF2B5EF4-FFF2-40B4-BE49-F238E27FC236}">
-                <a16:creationId xmlns:a16="http://schemas.microsoft.com/office/drawing/2014/main" id="{151CB81B-D743-44FA-9A4A-7B806B5BE8DA}"/>
+                <a16:creationId xmlns:a16="http://schemas.microsoft.com/office/drawing/2014/main" id="{F4EF40D7-4BB7-4734-857B-3F199601EF23}"/>
               </a:ext>
             </a:extLst>
           </p:cNvPr>
@@ -6244,7 +6244,7 @@
           <p:cNvPr id="23" name="">
             <a:extLst xmlns:a="http://schemas.openxmlformats.org/drawingml/2006/main">
               <a:ext uri="{FF2B5EF4-FFF2-40B4-BE49-F238E27FC236}">
-                <a16:creationId xmlns:a16="http://schemas.microsoft.com/office/drawing/2014/main" id="{72D8FDC4-132B-470A-B829-781450D29FBA}"/>
+                <a16:creationId xmlns:a16="http://schemas.microsoft.com/office/drawing/2014/main" id="{C7AE6EE1-45F3-4BEA-AB24-3E453EFC47BC}"/>
               </a:ext>
             </a:extLst>
           </p:cNvPr>
@@ -6308,7 +6308,7 @@
           <p:cNvPr id="24" name="">
             <a:extLst xmlns:a="http://schemas.openxmlformats.org/drawingml/2006/main">
               <a:ext uri="{FF2B5EF4-FFF2-40B4-BE49-F238E27FC236}">
-                <a16:creationId xmlns:a16="http://schemas.microsoft.com/office/drawing/2014/main" id="{9FFBAA95-1D3A-4B2C-84EF-64A9C23AC39A}"/>
+                <a16:creationId xmlns:a16="http://schemas.microsoft.com/office/drawing/2014/main" id="{2D62F1ED-7E8E-4896-9F7A-F271296993AB}"/>
               </a:ext>
             </a:extLst>
           </p:cNvPr>
@@ -6343,7 +6343,7 @@
           <p:cNvPr id="25" name="">
             <a:extLst xmlns:a="http://schemas.openxmlformats.org/drawingml/2006/main">
               <a:ext uri="{FF2B5EF4-FFF2-40B4-BE49-F238E27FC236}">
-                <a16:creationId xmlns:a16="http://schemas.microsoft.com/office/drawing/2014/main" id="{715E1A74-DA96-4B2C-AC77-67E4A7F65F84}"/>
+                <a16:creationId xmlns:a16="http://schemas.microsoft.com/office/drawing/2014/main" id="{434F11EE-D7EB-4A05-AE23-7665EAA6A262}"/>
               </a:ext>
             </a:extLst>
           </p:cNvPr>
@@ -6407,7 +6407,7 @@
           <p:cNvPr id="26" name="">
             <a:extLst xmlns:a="http://schemas.openxmlformats.org/drawingml/2006/main">
               <a:ext uri="{FF2B5EF4-FFF2-40B4-BE49-F238E27FC236}">
-                <a16:creationId xmlns:a16="http://schemas.microsoft.com/office/drawing/2014/main" id="{CA02DA4A-8364-4165-9E6C-C7B5C64FC9C3}"/>
+                <a16:creationId xmlns:a16="http://schemas.microsoft.com/office/drawing/2014/main" id="{8B25AC5B-EFEF-4475-8391-EAB68D51F4D1}"/>
               </a:ext>
             </a:extLst>
           </p:cNvPr>
@@ -6492,7 +6492,7 @@
     </p:spTree>
     <p:extLst>
       <p:ext uri="{BB962C8B-B14F-4D97-AF65-F5344CB8AC3E}">
-        <p14:creationId xmlns:p14="http://schemas.microsoft.com/office/powerpoint/2010/main" val="1606302106"/>
+        <p14:creationId xmlns:p14="http://schemas.microsoft.com/office/powerpoint/2010/main" val="979011384"/>
       </p:ext>
     </p:extLst>
   </p:cSld>
@@ -6516,7 +6516,7 @@
           <p:cNvPr id="1" name="">
             <a:extLst xmlns:a="http://schemas.openxmlformats.org/drawingml/2006/main">
               <a:ext uri="{FF2B5EF4-FFF2-40B4-BE49-F238E27FC236}">
-                <a16:creationId xmlns:a16="http://schemas.microsoft.com/office/drawing/2014/main" id="{B5784419-1ED7-4623-B7B5-2E3CBCAE2584}"/>
+                <a16:creationId xmlns:a16="http://schemas.microsoft.com/office/drawing/2014/main" id="{88790F8C-FCAA-4446-A395-BB3675EAA449}"/>
               </a:ext>
             </a:extLst>
           </p:cNvPr>
@@ -6551,7 +6551,7 @@
           <p:cNvPr id="2" name="kicker-marker">
             <a:extLst xmlns:a="http://schemas.openxmlformats.org/drawingml/2006/main">
               <a:ext uri="{FF2B5EF4-FFF2-40B4-BE49-F238E27FC236}">
-                <a16:creationId xmlns:a16="http://schemas.microsoft.com/office/drawing/2014/main" id="{52C770FA-D550-4205-AE61-DB0E4A431435}"/>
+                <a16:creationId xmlns:a16="http://schemas.microsoft.com/office/drawing/2014/main" id="{74F330BD-1522-4422-8A70-BC20D197BC59}"/>
               </a:ext>
             </a:extLst>
           </p:cNvPr>
@@ -6586,7 +6586,7 @@
           <p:cNvPr id="3" name="kicker-label">
             <a:extLst xmlns:a="http://schemas.openxmlformats.org/drawingml/2006/main">
               <a:ext uri="{FF2B5EF4-FFF2-40B4-BE49-F238E27FC236}">
-                <a16:creationId xmlns:a16="http://schemas.microsoft.com/office/drawing/2014/main" id="{F6788E45-0466-453B-AA6F-5C57021052E2}"/>
+                <a16:creationId xmlns:a16="http://schemas.microsoft.com/office/drawing/2014/main" id="{31BC324C-887C-442D-9528-EDB10B8AE04D}"/>
               </a:ext>
             </a:extLst>
           </p:cNvPr>
@@ -6650,7 +6650,7 @@
           <p:cNvPr id="4" name="">
             <a:extLst xmlns:a="http://schemas.openxmlformats.org/drawingml/2006/main">
               <a:ext uri="{FF2B5EF4-FFF2-40B4-BE49-F238E27FC236}">
-                <a16:creationId xmlns:a16="http://schemas.microsoft.com/office/drawing/2014/main" id="{FA17F9BE-CADA-4E8B-9DEE-4FE7CBD90F1B}"/>
+                <a16:creationId xmlns:a16="http://schemas.microsoft.com/office/drawing/2014/main" id="{A817CC4E-0461-458B-A93B-589231306FF4}"/>
               </a:ext>
             </a:extLst>
           </p:cNvPr>
@@ -6714,7 +6714,7 @@
           <p:cNvPr id="5" name="">
             <a:extLst xmlns:a="http://schemas.openxmlformats.org/drawingml/2006/main">
               <a:ext uri="{FF2B5EF4-FFF2-40B4-BE49-F238E27FC236}">
-                <a16:creationId xmlns:a16="http://schemas.microsoft.com/office/drawing/2014/main" id="{5D236FD4-B882-43FC-BB81-EEDBA29CFAEB}"/>
+                <a16:creationId xmlns:a16="http://schemas.microsoft.com/office/drawing/2014/main" id="{B618BED1-033B-4E51-9F32-6B05B65A2111}"/>
               </a:ext>
             </a:extLst>
           </p:cNvPr>
@@ -6749,7 +6749,7 @@
           <p:cNvPr id="6" name="">
             <a:extLst xmlns:a="http://schemas.openxmlformats.org/drawingml/2006/main">
               <a:ext uri="{FF2B5EF4-FFF2-40B4-BE49-F238E27FC236}">
-                <a16:creationId xmlns:a16="http://schemas.microsoft.com/office/drawing/2014/main" id="{E9E07263-DF30-40BC-B273-3E847037750C}"/>
+                <a16:creationId xmlns:a16="http://schemas.microsoft.com/office/drawing/2014/main" id="{21FF9969-4E6A-4C57-A2DA-3F7568793A68}"/>
               </a:ext>
             </a:extLst>
           </p:cNvPr>
@@ -6817,7 +6817,7 @@
           <p:nvPr/>
         </p:nvPicPr>
         <p:blipFill>
-          <a:blip xmlns:r="http://schemas.openxmlformats.org/officeDocument/2006/relationships" xmlns:a="http://schemas.openxmlformats.org/drawingml/2006/main" r:embed="Rda97980d2844434a"/>
+          <a:blip xmlns:r="http://schemas.openxmlformats.org/officeDocument/2006/relationships" xmlns:a="http://schemas.openxmlformats.org/drawingml/2006/main" r:embed="Rfce1567997484d35"/>
           <a:stretch xmlns:a="http://schemas.openxmlformats.org/drawingml/2006/main"/>
         </p:blipFill>
         <p:spPr>
@@ -6835,7 +6835,7 @@
           <p:cNvPr id="8" name="">
             <a:extLst xmlns:a="http://schemas.openxmlformats.org/drawingml/2006/main">
               <a:ext uri="{FF2B5EF4-FFF2-40B4-BE49-F238E27FC236}">
-                <a16:creationId xmlns:a16="http://schemas.microsoft.com/office/drawing/2014/main" id="{6B2E3943-257B-44FC-AF79-736D4C8DB54E}"/>
+                <a16:creationId xmlns:a16="http://schemas.microsoft.com/office/drawing/2014/main" id="{404030CC-0643-4C63-92EB-B13C51AB617D}"/>
               </a:ext>
             </a:extLst>
           </p:cNvPr>
@@ -6868,7 +6868,7 @@
     </p:spTree>
     <p:extLst>
       <p:ext uri="{BB962C8B-B14F-4D97-AF65-F5344CB8AC3E}">
-        <p14:creationId xmlns:p14="http://schemas.microsoft.com/office/powerpoint/2010/main" val="1000232977"/>
+        <p14:creationId xmlns:p14="http://schemas.microsoft.com/office/powerpoint/2010/main" val="303199899"/>
       </p:ext>
     </p:extLst>
   </p:cSld>
@@ -6892,7 +6892,7 @@
           <p:cNvPr id="1" name="">
             <a:extLst xmlns:a="http://schemas.openxmlformats.org/drawingml/2006/main">
               <a:ext uri="{FF2B5EF4-FFF2-40B4-BE49-F238E27FC236}">
-                <a16:creationId xmlns:a16="http://schemas.microsoft.com/office/drawing/2014/main" id="{9BABA187-2379-40F6-946E-693D2A69D7FD}"/>
+                <a16:creationId xmlns:a16="http://schemas.microsoft.com/office/drawing/2014/main" id="{AF210BD2-87AF-4E7B-923F-B79D40453D49}"/>
               </a:ext>
             </a:extLst>
           </p:cNvPr>
@@ -6927,7 +6927,7 @@
           <p:cNvPr id="2" name="kicker-marker">
             <a:extLst xmlns:a="http://schemas.openxmlformats.org/drawingml/2006/main">
               <a:ext uri="{FF2B5EF4-FFF2-40B4-BE49-F238E27FC236}">
-                <a16:creationId xmlns:a16="http://schemas.microsoft.com/office/drawing/2014/main" id="{9D8B1A97-2548-40BE-AE1E-52F72F41F54C}"/>
+                <a16:creationId xmlns:a16="http://schemas.microsoft.com/office/drawing/2014/main" id="{FF69E1E8-5D48-411F-B5D9-F412E6646ED2}"/>
               </a:ext>
             </a:extLst>
           </p:cNvPr>
@@ -6962,7 +6962,7 @@
           <p:cNvPr id="3" name="kicker-label">
             <a:extLst xmlns:a="http://schemas.openxmlformats.org/drawingml/2006/main">
               <a:ext uri="{FF2B5EF4-FFF2-40B4-BE49-F238E27FC236}">
-                <a16:creationId xmlns:a16="http://schemas.microsoft.com/office/drawing/2014/main" id="{3DBC81C4-7DC3-471B-9EEC-94BBDB7FD9DC}"/>
+                <a16:creationId xmlns:a16="http://schemas.microsoft.com/office/drawing/2014/main" id="{AA31CEF7-373D-4FA1-8DE0-0350ED176288}"/>
               </a:ext>
             </a:extLst>
           </p:cNvPr>
@@ -7026,7 +7026,7 @@
           <p:cNvPr id="4" name="">
             <a:extLst xmlns:a="http://schemas.openxmlformats.org/drawingml/2006/main">
               <a:ext uri="{FF2B5EF4-FFF2-40B4-BE49-F238E27FC236}">
-                <a16:creationId xmlns:a16="http://schemas.microsoft.com/office/drawing/2014/main" id="{834AA5B5-2077-4EA3-8221-D9B124F14D14}"/>
+                <a16:creationId xmlns:a16="http://schemas.microsoft.com/office/drawing/2014/main" id="{D792C74A-2905-4719-8E7F-9051A68F0B80}"/>
               </a:ext>
             </a:extLst>
           </p:cNvPr>
@@ -7090,7 +7090,7 @@
           <p:cNvPr id="5" name="">
             <a:extLst xmlns:a="http://schemas.openxmlformats.org/drawingml/2006/main">
               <a:ext uri="{FF2B5EF4-FFF2-40B4-BE49-F238E27FC236}">
-                <a16:creationId xmlns:a16="http://schemas.microsoft.com/office/drawing/2014/main" id="{ACD3BE9B-D57B-4855-B6CA-6B4BDAE647F2}"/>
+                <a16:creationId xmlns:a16="http://schemas.microsoft.com/office/drawing/2014/main" id="{DDF9A62F-CB1E-43F1-B75B-116E89B5DC07}"/>
               </a:ext>
             </a:extLst>
           </p:cNvPr>
@@ -7125,7 +7125,7 @@
           <p:cNvPr id="6" name="">
             <a:extLst xmlns:a="http://schemas.openxmlformats.org/drawingml/2006/main">
               <a:ext uri="{FF2B5EF4-FFF2-40B4-BE49-F238E27FC236}">
-                <a16:creationId xmlns:a16="http://schemas.microsoft.com/office/drawing/2014/main" id="{88894815-BC12-4040-8F71-DF31AC9A1B57}"/>
+                <a16:creationId xmlns:a16="http://schemas.microsoft.com/office/drawing/2014/main" id="{3F350F3C-7AB0-47D5-B188-D3635B23303D}"/>
               </a:ext>
             </a:extLst>
           </p:cNvPr>
@@ -7193,7 +7193,7 @@
           <p:nvPr/>
         </p:nvPicPr>
         <p:blipFill>
-          <a:blip xmlns:r="http://schemas.openxmlformats.org/officeDocument/2006/relationships" xmlns:a="http://schemas.openxmlformats.org/drawingml/2006/main" r:embed="R8d6e5e069c1c4d93"/>
+          <a:blip xmlns:r="http://schemas.openxmlformats.org/officeDocument/2006/relationships" xmlns:a="http://schemas.openxmlformats.org/drawingml/2006/main" r:embed="R10276c710fe04a29"/>
           <a:stretch xmlns:a="http://schemas.openxmlformats.org/drawingml/2006/main"/>
         </p:blipFill>
         <p:spPr>
@@ -7211,7 +7211,7 @@
           <p:cNvPr id="8" name="">
             <a:extLst xmlns:a="http://schemas.openxmlformats.org/drawingml/2006/main">
               <a:ext uri="{FF2B5EF4-FFF2-40B4-BE49-F238E27FC236}">
-                <a16:creationId xmlns:a16="http://schemas.microsoft.com/office/drawing/2014/main" id="{704813EE-57D8-4BCB-B615-F29970589627}"/>
+                <a16:creationId xmlns:a16="http://schemas.microsoft.com/office/drawing/2014/main" id="{B2DE191B-6106-4F72-B9F4-054D6DFD9BFF}"/>
               </a:ext>
             </a:extLst>
           </p:cNvPr>
@@ -7244,7 +7244,7 @@
     </p:spTree>
     <p:extLst>
       <p:ext uri="{BB962C8B-B14F-4D97-AF65-F5344CB8AC3E}">
-        <p14:creationId xmlns:p14="http://schemas.microsoft.com/office/powerpoint/2010/main" val="1275328335"/>
+        <p14:creationId xmlns:p14="http://schemas.microsoft.com/office/powerpoint/2010/main" val="9048913"/>
       </p:ext>
     </p:extLst>
   </p:cSld>
@@ -7268,7 +7268,7 @@
           <p:cNvPr id="1" name="">
             <a:extLst xmlns:a="http://schemas.openxmlformats.org/drawingml/2006/main">
               <a:ext uri="{FF2B5EF4-FFF2-40B4-BE49-F238E27FC236}">
-                <a16:creationId xmlns:a16="http://schemas.microsoft.com/office/drawing/2014/main" id="{FC7B0772-3F6E-446A-ADDC-1076C69932FC}"/>
+                <a16:creationId xmlns:a16="http://schemas.microsoft.com/office/drawing/2014/main" id="{0230F915-419A-4F7E-9BFC-97959A8DAEB2}"/>
               </a:ext>
             </a:extLst>
           </p:cNvPr>
@@ -7303,7 +7303,7 @@
           <p:cNvPr id="2" name="kicker-marker">
             <a:extLst xmlns:a="http://schemas.openxmlformats.org/drawingml/2006/main">
               <a:ext uri="{FF2B5EF4-FFF2-40B4-BE49-F238E27FC236}">
-                <a16:creationId xmlns:a16="http://schemas.microsoft.com/office/drawing/2014/main" id="{9FE4F74C-87D2-4CD5-8BB9-DE02F0F4B82C}"/>
+                <a16:creationId xmlns:a16="http://schemas.microsoft.com/office/drawing/2014/main" id="{08CD2B7B-D991-4C18-AFF1-7D95FF65106C}"/>
               </a:ext>
             </a:extLst>
           </p:cNvPr>
@@ -7338,7 +7338,7 @@
           <p:cNvPr id="3" name="kicker-label">
             <a:extLst xmlns:a="http://schemas.openxmlformats.org/drawingml/2006/main">
               <a:ext uri="{FF2B5EF4-FFF2-40B4-BE49-F238E27FC236}">
-                <a16:creationId xmlns:a16="http://schemas.microsoft.com/office/drawing/2014/main" id="{8BF7A3F4-C52B-4FA3-9D23-177F6EEFDF8F}"/>
+                <a16:creationId xmlns:a16="http://schemas.microsoft.com/office/drawing/2014/main" id="{42E58165-FA6A-463C-9144-98ED9DD4F067}"/>
               </a:ext>
             </a:extLst>
           </p:cNvPr>
@@ -7402,7 +7402,7 @@
           <p:cNvPr id="4" name="">
             <a:extLst xmlns:a="http://schemas.openxmlformats.org/drawingml/2006/main">
               <a:ext uri="{FF2B5EF4-FFF2-40B4-BE49-F238E27FC236}">
-                <a16:creationId xmlns:a16="http://schemas.microsoft.com/office/drawing/2014/main" id="{8FB1388D-D582-46E3-AA5D-B4E87FE62B0E}"/>
+                <a16:creationId xmlns:a16="http://schemas.microsoft.com/office/drawing/2014/main" id="{3201206E-A8DB-4590-8211-F40F0D194919}"/>
               </a:ext>
             </a:extLst>
           </p:cNvPr>
@@ -7466,7 +7466,7 @@
           <p:cNvPr id="5" name="">
             <a:extLst xmlns:a="http://schemas.openxmlformats.org/drawingml/2006/main">
               <a:ext uri="{FF2B5EF4-FFF2-40B4-BE49-F238E27FC236}">
-                <a16:creationId xmlns:a16="http://schemas.microsoft.com/office/drawing/2014/main" id="{349E233A-EF4A-4924-B4F2-0ACE1AEDB666}"/>
+                <a16:creationId xmlns:a16="http://schemas.microsoft.com/office/drawing/2014/main" id="{76D11E98-5775-4A09-B743-5BA6087B8171}"/>
               </a:ext>
             </a:extLst>
           </p:cNvPr>
@@ -7501,7 +7501,7 @@
           <p:cNvPr id="6" name="">
             <a:extLst xmlns:a="http://schemas.openxmlformats.org/drawingml/2006/main">
               <a:ext uri="{FF2B5EF4-FFF2-40B4-BE49-F238E27FC236}">
-                <a16:creationId xmlns:a16="http://schemas.microsoft.com/office/drawing/2014/main" id="{3A49AB88-3EDA-4FDA-B626-F43EB4378648}"/>
+                <a16:creationId xmlns:a16="http://schemas.microsoft.com/office/drawing/2014/main" id="{5E244B83-443A-409C-93D5-1F5BDC915E83}"/>
               </a:ext>
             </a:extLst>
           </p:cNvPr>
@@ -7569,7 +7569,7 @@
           <p:nvPr/>
         </p:nvPicPr>
         <p:blipFill>
-          <a:blip xmlns:r="http://schemas.openxmlformats.org/officeDocument/2006/relationships" xmlns:a="http://schemas.openxmlformats.org/drawingml/2006/main" r:embed="R716c6f24e4904d67"/>
+          <a:blip xmlns:r="http://schemas.openxmlformats.org/officeDocument/2006/relationships" xmlns:a="http://schemas.openxmlformats.org/drawingml/2006/main" r:embed="Rcf1b041fd3be434f"/>
           <a:stretch xmlns:a="http://schemas.openxmlformats.org/drawingml/2006/main"/>
         </p:blipFill>
         <p:spPr>
@@ -7587,7 +7587,7 @@
           <p:cNvPr id="8" name="">
             <a:extLst xmlns:a="http://schemas.openxmlformats.org/drawingml/2006/main">
               <a:ext uri="{FF2B5EF4-FFF2-40B4-BE49-F238E27FC236}">
-                <a16:creationId xmlns:a16="http://schemas.microsoft.com/office/drawing/2014/main" id="{5ADEDEFC-E52A-45F0-A2BB-D7528E6A21AC}"/>
+                <a16:creationId xmlns:a16="http://schemas.microsoft.com/office/drawing/2014/main" id="{C780D99A-32CD-44F6-85FA-E00E1209C6AA}"/>
               </a:ext>
             </a:extLst>
           </p:cNvPr>
@@ -7622,7 +7622,7 @@
           <p:cNvPr id="9" name="">
             <a:extLst xmlns:a="http://schemas.openxmlformats.org/drawingml/2006/main">
               <a:ext uri="{FF2B5EF4-FFF2-40B4-BE49-F238E27FC236}">
-                <a16:creationId xmlns:a16="http://schemas.microsoft.com/office/drawing/2014/main" id="{F0C469D2-4D96-4EB1-A575-7ED11B106B1E}"/>
+                <a16:creationId xmlns:a16="http://schemas.microsoft.com/office/drawing/2014/main" id="{F663162C-51E2-4D02-9DD7-7743FA6430C4}"/>
               </a:ext>
             </a:extLst>
           </p:cNvPr>
@@ -7657,7 +7657,7 @@
           <p:cNvPr id="10" name="">
             <a:extLst xmlns:a="http://schemas.openxmlformats.org/drawingml/2006/main">
               <a:ext uri="{FF2B5EF4-FFF2-40B4-BE49-F238E27FC236}">
-                <a16:creationId xmlns:a16="http://schemas.microsoft.com/office/drawing/2014/main" id="{57248916-7792-455B-AD93-4B504DA5A282}"/>
+                <a16:creationId xmlns:a16="http://schemas.microsoft.com/office/drawing/2014/main" id="{1A32F6E5-CE6F-48C0-9BB8-F84FDFEF3FE5}"/>
               </a:ext>
             </a:extLst>
           </p:cNvPr>
@@ -7721,7 +7721,7 @@
           <p:cNvPr id="11" name="">
             <a:extLst xmlns:a="http://schemas.openxmlformats.org/drawingml/2006/main">
               <a:ext uri="{FF2B5EF4-FFF2-40B4-BE49-F238E27FC236}">
-                <a16:creationId xmlns:a16="http://schemas.microsoft.com/office/drawing/2014/main" id="{22A64085-6A4A-449A-ADB5-2397E4410634}"/>
+                <a16:creationId xmlns:a16="http://schemas.microsoft.com/office/drawing/2014/main" id="{45959944-DA98-44D3-840E-A610925843F8}"/>
               </a:ext>
             </a:extLst>
           </p:cNvPr>
@@ -7776,7 +7776,7 @@
                 <a:cs typeface="Aptos"/>
                 <a:hlinkClick xmlns:r="http://schemas.openxmlformats.org/officeDocument/2006/relationships" r:id="rIdSynthAMLDemo"/>
               </a:rPr>
-              <a:t>https://htmlpreview.github.io/?https://github.com/yq688m3JT/genAI_final/blob/main/docs/demo.html</a:t>
+              <a:t>https://rawcdn.githack.com/yq688m3JT/genAI_final/872e7a818159bc1c1262f42e682d39331a8cc98a/docs/demo.html</a:t>
             </a:r>
           </a:p>
         </p:txBody>
@@ -7784,7 +7784,7 @@
     </p:spTree>
     <p:extLst>
       <p:ext uri="{BB962C8B-B14F-4D97-AF65-F5344CB8AC3E}">
-        <p14:creationId xmlns:p14="http://schemas.microsoft.com/office/powerpoint/2010/main" val="1156852326"/>
+        <p14:creationId xmlns:p14="http://schemas.microsoft.com/office/powerpoint/2010/main" val="1118697119"/>
       </p:ext>
     </p:extLst>
   </p:cSld>

</xml_diff>

<commit_message>
Redesign browser demo as workbench
</commit_message>
<xml_diff>
--- a/docs/synthaml-final-presentation.pptx
+++ b/docs/synthaml-final-presentation.pptx
@@ -2,19 +2,19 @@
 <file path=ppt/presentation.xml><?xml version="1.0" encoding="utf-8"?>
 <p:presentation xmlns:p="http://schemas.openxmlformats.org/presentationml/2006/main">
   <p:sldMasterIdLst>
-    <p:sldMasterId xmlns:r="http://schemas.openxmlformats.org/officeDocument/2006/relationships" id="2147483648" r:id="R623ef365bf9d4d0b"/>
+    <p:sldMasterId xmlns:r="http://schemas.openxmlformats.org/officeDocument/2006/relationships" id="2147483648" r:id="Rdaf3b76fcf25482f"/>
   </p:sldMasterIdLst>
   <p:notesMasterIdLst>
-    <p:notesMasterId xmlns:r="http://schemas.openxmlformats.org/officeDocument/2006/relationships" r:id="R7566b4dc3791471a"/>
+    <p:notesMasterId xmlns:r="http://schemas.openxmlformats.org/officeDocument/2006/relationships" r:id="R34b64ec6f1054dde"/>
   </p:notesMasterIdLst>
   <p:sldIdLst>
-    <p:sldId xmlns:r="http://schemas.openxmlformats.org/officeDocument/2006/relationships" id="256" r:id="Rf46e9fccef514253"/>
-    <p:sldId xmlns:r="http://schemas.openxmlformats.org/officeDocument/2006/relationships" id="257" r:id="R35aabe660ade452a"/>
-    <p:sldId xmlns:r="http://schemas.openxmlformats.org/officeDocument/2006/relationships" id="258" r:id="Rb4c036d6b7f04c8a"/>
-    <p:sldId xmlns:r="http://schemas.openxmlformats.org/officeDocument/2006/relationships" id="259" r:id="R48f526bf809a4779"/>
-    <p:sldId xmlns:r="http://schemas.openxmlformats.org/officeDocument/2006/relationships" id="260" r:id="R8d21a54c759c422a"/>
-    <p:sldId xmlns:r="http://schemas.openxmlformats.org/officeDocument/2006/relationships" id="261" r:id="R60527e1f13574d82"/>
-    <p:sldId xmlns:r="http://schemas.openxmlformats.org/officeDocument/2006/relationships" id="262" r:id="Ref6929e7b9a04c66"/>
+    <p:sldId xmlns:r="http://schemas.openxmlformats.org/officeDocument/2006/relationships" id="256" r:id="R69ec8c8d93a243a1"/>
+    <p:sldId xmlns:r="http://schemas.openxmlformats.org/officeDocument/2006/relationships" id="257" r:id="R46b68bf3d5de4f02"/>
+    <p:sldId xmlns:r="http://schemas.openxmlformats.org/officeDocument/2006/relationships" id="258" r:id="R2485c6ec249045c6"/>
+    <p:sldId xmlns:r="http://schemas.openxmlformats.org/officeDocument/2006/relationships" id="259" r:id="R22fc314cc5274e27"/>
+    <p:sldId xmlns:r="http://schemas.openxmlformats.org/officeDocument/2006/relationships" id="260" r:id="R2d03f7430c3c43cb"/>
+    <p:sldId xmlns:r="http://schemas.openxmlformats.org/officeDocument/2006/relationships" id="261" r:id="Rab9ac60ef1994e61"/>
+    <p:sldId xmlns:r="http://schemas.openxmlformats.org/officeDocument/2006/relationships" id="262" r:id="R5825f9e650e8495e"/>
   </p:sldIdLst>
   <p:sldSz cx="12192000" cy="6858000"/>
   <p:notesSz cx="6858000" cy="9144000"/>
@@ -957,7 +957,7 @@
   </p:cSld>
   <p:clrMap bg1="lt1" tx1="dk1" bg2="lt2" tx2="dk2" accent1="accent1" accent2="accent2" accent3="accent3" accent4="accent4" accent5="accent5" accent6="accent6" hlink="hlink" folHlink="folHlink"/>
   <p:sldLayoutIdLst>
-    <p:sldLayoutId xmlns:r="http://schemas.openxmlformats.org/officeDocument/2006/relationships" id="2147483649" r:id="R48892e825ab848a8"/>
+    <p:sldLayoutId xmlns:r="http://schemas.openxmlformats.org/officeDocument/2006/relationships" id="2147483649" r:id="Rcc8b9e6e978d4566"/>
   </p:sldLayoutIdLst>
   <p:txStyles>
     <p:titleStyle>
@@ -1256,7 +1256,7 @@
           <p:cNvPr id="1" name="">
             <a:extLst xmlns:a="http://schemas.openxmlformats.org/drawingml/2006/main">
               <a:ext uri="{FF2B5EF4-FFF2-40B4-BE49-F238E27FC236}">
-                <a16:creationId xmlns:a16="http://schemas.microsoft.com/office/drawing/2014/main" id="{E0477721-EAAD-4C2D-BF09-806318B9F0A1}"/>
+                <a16:creationId xmlns:a16="http://schemas.microsoft.com/office/drawing/2014/main" id="{F0BF3C0E-D631-4995-8F67-287F7D258883}"/>
               </a:ext>
             </a:extLst>
           </p:cNvPr>
@@ -1291,7 +1291,7 @@
           <p:cNvPr id="2" name="">
             <a:extLst xmlns:a="http://schemas.openxmlformats.org/drawingml/2006/main">
               <a:ext uri="{FF2B5EF4-FFF2-40B4-BE49-F238E27FC236}">
-                <a16:creationId xmlns:a16="http://schemas.microsoft.com/office/drawing/2014/main" id="{69F5A0E7-2225-4B63-8390-DCCB176029EB}"/>
+                <a16:creationId xmlns:a16="http://schemas.microsoft.com/office/drawing/2014/main" id="{2807F877-4227-456E-B5A6-4D1194886905}"/>
               </a:ext>
             </a:extLst>
           </p:cNvPr>
@@ -1326,7 +1326,7 @@
           <p:cNvPr id="3" name="">
             <a:extLst xmlns:a="http://schemas.openxmlformats.org/drawingml/2006/main">
               <a:ext uri="{FF2B5EF4-FFF2-40B4-BE49-F238E27FC236}">
-                <a16:creationId xmlns:a16="http://schemas.microsoft.com/office/drawing/2014/main" id="{43B74C9C-6F70-4C11-AD49-818E0E871B2D}"/>
+                <a16:creationId xmlns:a16="http://schemas.microsoft.com/office/drawing/2014/main" id="{164E92CF-E436-46E6-B071-B6BC50E0B895}"/>
               </a:ext>
             </a:extLst>
           </p:cNvPr>
@@ -1390,7 +1390,7 @@
           <p:cNvPr id="4" name="">
             <a:extLst xmlns:a="http://schemas.openxmlformats.org/drawingml/2006/main">
               <a:ext uri="{FF2B5EF4-FFF2-40B4-BE49-F238E27FC236}">
-                <a16:creationId xmlns:a16="http://schemas.microsoft.com/office/drawing/2014/main" id="{64494493-CF71-4AA1-87A6-0EAE896ED4C0}"/>
+                <a16:creationId xmlns:a16="http://schemas.microsoft.com/office/drawing/2014/main" id="{0070C72F-6737-436B-9D3D-03B2E2351FD9}"/>
               </a:ext>
             </a:extLst>
           </p:cNvPr>
@@ -1454,7 +1454,7 @@
           <p:cNvPr id="5" name="">
             <a:extLst xmlns:a="http://schemas.openxmlformats.org/drawingml/2006/main">
               <a:ext uri="{FF2B5EF4-FFF2-40B4-BE49-F238E27FC236}">
-                <a16:creationId xmlns:a16="http://schemas.microsoft.com/office/drawing/2014/main" id="{4BA5FD91-3974-4CE0-92F4-D5F7F7291272}"/>
+                <a16:creationId xmlns:a16="http://schemas.microsoft.com/office/drawing/2014/main" id="{F9CF7C04-A14D-4653-8E32-C0B28A5DAA06}"/>
               </a:ext>
             </a:extLst>
           </p:cNvPr>
@@ -1518,7 +1518,7 @@
           <p:cNvPr id="6" name="">
             <a:extLst xmlns:a="http://schemas.openxmlformats.org/drawingml/2006/main">
               <a:ext uri="{FF2B5EF4-FFF2-40B4-BE49-F238E27FC236}">
-                <a16:creationId xmlns:a16="http://schemas.microsoft.com/office/drawing/2014/main" id="{C1830A20-FA71-4A07-8329-270D67DCAA60}"/>
+                <a16:creationId xmlns:a16="http://schemas.microsoft.com/office/drawing/2014/main" id="{726DC522-0D3A-4EAF-89C2-C7D8D660DE0A}"/>
               </a:ext>
             </a:extLst>
           </p:cNvPr>
@@ -1553,7 +1553,7 @@
           <p:cNvPr id="7" name="">
             <a:extLst xmlns:a="http://schemas.openxmlformats.org/drawingml/2006/main">
               <a:ext uri="{FF2B5EF4-FFF2-40B4-BE49-F238E27FC236}">
-                <a16:creationId xmlns:a16="http://schemas.microsoft.com/office/drawing/2014/main" id="{5E6D6A68-89C2-4599-870B-F94F26DCCBC4}"/>
+                <a16:creationId xmlns:a16="http://schemas.microsoft.com/office/drawing/2014/main" id="{FF666F64-7C58-458C-A68A-180D5C124917}"/>
               </a:ext>
             </a:extLst>
           </p:cNvPr>
@@ -1617,7 +1617,7 @@
           <p:cNvPr id="8" name="">
             <a:extLst xmlns:a="http://schemas.openxmlformats.org/drawingml/2006/main">
               <a:ext uri="{FF2B5EF4-FFF2-40B4-BE49-F238E27FC236}">
-                <a16:creationId xmlns:a16="http://schemas.microsoft.com/office/drawing/2014/main" id="{23D41ED0-1C58-43DC-9FF7-C1097EEEE68A}"/>
+                <a16:creationId xmlns:a16="http://schemas.microsoft.com/office/drawing/2014/main" id="{9F66BDC2-D00E-4144-ABAA-70248C8D9D88}"/>
               </a:ext>
             </a:extLst>
           </p:cNvPr>
@@ -1681,7 +1681,7 @@
           <p:cNvPr id="9" name="">
             <a:extLst xmlns:a="http://schemas.openxmlformats.org/drawingml/2006/main">
               <a:ext uri="{FF2B5EF4-FFF2-40B4-BE49-F238E27FC236}">
-                <a16:creationId xmlns:a16="http://schemas.microsoft.com/office/drawing/2014/main" id="{D64FF189-B4A2-4A0B-A217-35BA08D2A3C0}"/>
+                <a16:creationId xmlns:a16="http://schemas.microsoft.com/office/drawing/2014/main" id="{6164E661-453D-431C-94AA-24633BD3D8CD}"/>
               </a:ext>
             </a:extLst>
           </p:cNvPr>
@@ -1745,7 +1745,7 @@
           <p:cNvPr id="10" name="">
             <a:extLst xmlns:a="http://schemas.openxmlformats.org/drawingml/2006/main">
               <a:ext uri="{FF2B5EF4-FFF2-40B4-BE49-F238E27FC236}">
-                <a16:creationId xmlns:a16="http://schemas.microsoft.com/office/drawing/2014/main" id="{5EFDF574-DF58-415C-979A-D8C2109ABF9C}"/>
+                <a16:creationId xmlns:a16="http://schemas.microsoft.com/office/drawing/2014/main" id="{FA387EA6-3451-45E6-9442-801FA578DAD5}"/>
               </a:ext>
             </a:extLst>
           </p:cNvPr>
@@ -1809,7 +1809,7 @@
           <p:cNvPr id="11" name="">
             <a:extLst xmlns:a="http://schemas.openxmlformats.org/drawingml/2006/main">
               <a:ext uri="{FF2B5EF4-FFF2-40B4-BE49-F238E27FC236}">
-                <a16:creationId xmlns:a16="http://schemas.microsoft.com/office/drawing/2014/main" id="{CEFA2E69-AFEA-421E-BA6F-8E08383534E4}"/>
+                <a16:creationId xmlns:a16="http://schemas.microsoft.com/office/drawing/2014/main" id="{F372170F-A434-4752-B26A-5C106BE6102A}"/>
               </a:ext>
             </a:extLst>
           </p:cNvPr>
@@ -1873,7 +1873,7 @@
           <p:cNvPr id="12" name="">
             <a:extLst xmlns:a="http://schemas.openxmlformats.org/drawingml/2006/main">
               <a:ext uri="{FF2B5EF4-FFF2-40B4-BE49-F238E27FC236}">
-                <a16:creationId xmlns:a16="http://schemas.microsoft.com/office/drawing/2014/main" id="{7FEF107D-890C-410D-B573-BA2F53002303}"/>
+                <a16:creationId xmlns:a16="http://schemas.microsoft.com/office/drawing/2014/main" id="{0086C406-7CCD-4337-9ABB-666980B6A205}"/>
               </a:ext>
             </a:extLst>
           </p:cNvPr>
@@ -1937,7 +1937,7 @@
           <p:cNvPr id="13" name="">
             <a:extLst xmlns:a="http://schemas.openxmlformats.org/drawingml/2006/main">
               <a:ext uri="{FF2B5EF4-FFF2-40B4-BE49-F238E27FC236}">
-                <a16:creationId xmlns:a16="http://schemas.microsoft.com/office/drawing/2014/main" id="{52C822E0-F3ED-453A-8074-E0662EE2D3AC}"/>
+                <a16:creationId xmlns:a16="http://schemas.microsoft.com/office/drawing/2014/main" id="{B12477C8-83FF-4695-96BB-29AEE6A64C7E}"/>
               </a:ext>
             </a:extLst>
           </p:cNvPr>
@@ -1972,7 +1972,7 @@
           <p:cNvPr id="14" name="">
             <a:extLst xmlns:a="http://schemas.openxmlformats.org/drawingml/2006/main">
               <a:ext uri="{FF2B5EF4-FFF2-40B4-BE49-F238E27FC236}">
-                <a16:creationId xmlns:a16="http://schemas.microsoft.com/office/drawing/2014/main" id="{EE213B6C-DCDF-4294-B3BE-932C724759A6}"/>
+                <a16:creationId xmlns:a16="http://schemas.microsoft.com/office/drawing/2014/main" id="{C328182B-37D5-470C-97FF-122C042BB8EE}"/>
               </a:ext>
             </a:extLst>
           </p:cNvPr>
@@ -2036,7 +2036,7 @@
           <p:cNvPr id="15" name="">
             <a:extLst xmlns:a="http://schemas.openxmlformats.org/drawingml/2006/main">
               <a:ext uri="{FF2B5EF4-FFF2-40B4-BE49-F238E27FC236}">
-                <a16:creationId xmlns:a16="http://schemas.microsoft.com/office/drawing/2014/main" id="{9298379F-4507-4F17-ABD0-D08E6F82BC28}"/>
+                <a16:creationId xmlns:a16="http://schemas.microsoft.com/office/drawing/2014/main" id="{98FC9B98-FE9B-4948-BF1E-5EBC0DC70B69}"/>
               </a:ext>
             </a:extLst>
           </p:cNvPr>
@@ -2123,7 +2123,7 @@
           <p:cNvPr id="16" name="">
             <a:extLst xmlns:a="http://schemas.openxmlformats.org/drawingml/2006/main">
               <a:ext uri="{FF2B5EF4-FFF2-40B4-BE49-F238E27FC236}">
-                <a16:creationId xmlns:a16="http://schemas.microsoft.com/office/drawing/2014/main" id="{DBA28AB8-774D-44CC-9881-DC430FFC66FE}"/>
+                <a16:creationId xmlns:a16="http://schemas.microsoft.com/office/drawing/2014/main" id="{A289986D-D693-4234-85B4-1CEC3BC98D25}"/>
               </a:ext>
             </a:extLst>
           </p:cNvPr>
@@ -2187,7 +2187,7 @@
           <p:cNvPr id="17" name="">
             <a:extLst xmlns:a="http://schemas.openxmlformats.org/drawingml/2006/main">
               <a:ext uri="{FF2B5EF4-FFF2-40B4-BE49-F238E27FC236}">
-                <a16:creationId xmlns:a16="http://schemas.microsoft.com/office/drawing/2014/main" id="{BE7A343A-AB93-4FB7-B82D-7DB98DBA0660}"/>
+                <a16:creationId xmlns:a16="http://schemas.microsoft.com/office/drawing/2014/main" id="{5A9A666B-559C-47A1-BDF2-14B35F75A42E}"/>
               </a:ext>
             </a:extLst>
           </p:cNvPr>
@@ -2242,7 +2242,7 @@
                 <a:cs typeface="Aptos"/>
                 <a:hlinkClick xmlns:r="http://schemas.openxmlformats.org/officeDocument/2006/relationships" r:id="rIdSynthAMLDemo"/>
               </a:rPr>
-              <a:t>https://rawcdn.githack.com/yq688m3JT/genAI_final/872e7a818159bc1c1262f42e682d39331a8cc98a/docs/demo.html</a:t>
+              <a:t>https://raw.githack.com/yq688m3JT/genAI_final/main/docs/demo.html</a:t>
             </a:r>
           </a:p>
         </p:txBody>
@@ -2250,7 +2250,7 @@
     </p:spTree>
     <p:extLst>
       <p:ext uri="{BB962C8B-B14F-4D97-AF65-F5344CB8AC3E}">
-        <p14:creationId xmlns:p14="http://schemas.microsoft.com/office/powerpoint/2010/main" val="153298427"/>
+        <p14:creationId xmlns:p14="http://schemas.microsoft.com/office/powerpoint/2010/main" val="780130654"/>
       </p:ext>
     </p:extLst>
   </p:cSld>
@@ -2274,7 +2274,7 @@
           <p:cNvPr id="1" name="">
             <a:extLst xmlns:a="http://schemas.openxmlformats.org/drawingml/2006/main">
               <a:ext uri="{FF2B5EF4-FFF2-40B4-BE49-F238E27FC236}">
-                <a16:creationId xmlns:a16="http://schemas.microsoft.com/office/drawing/2014/main" id="{B785E289-C7FA-41C3-B192-11C17DEE2C8F}"/>
+                <a16:creationId xmlns:a16="http://schemas.microsoft.com/office/drawing/2014/main" id="{8C3FA446-FF5E-462C-82A8-6082884A9355}"/>
               </a:ext>
             </a:extLst>
           </p:cNvPr>
@@ -2309,7 +2309,7 @@
           <p:cNvPr id="2" name="kicker-marker">
             <a:extLst xmlns:a="http://schemas.openxmlformats.org/drawingml/2006/main">
               <a:ext uri="{FF2B5EF4-FFF2-40B4-BE49-F238E27FC236}">
-                <a16:creationId xmlns:a16="http://schemas.microsoft.com/office/drawing/2014/main" id="{7513A27B-0F36-440A-BCC3-DBE2E3F77D5A}"/>
+                <a16:creationId xmlns:a16="http://schemas.microsoft.com/office/drawing/2014/main" id="{729CB8FA-196B-494E-937F-DABAEC88A8DD}"/>
               </a:ext>
             </a:extLst>
           </p:cNvPr>
@@ -2344,7 +2344,7 @@
           <p:cNvPr id="3" name="kicker-label">
             <a:extLst xmlns:a="http://schemas.openxmlformats.org/drawingml/2006/main">
               <a:ext uri="{FF2B5EF4-FFF2-40B4-BE49-F238E27FC236}">
-                <a16:creationId xmlns:a16="http://schemas.microsoft.com/office/drawing/2014/main" id="{B91E513A-8A78-4CB7-9BDE-D981AFFE23F4}"/>
+                <a16:creationId xmlns:a16="http://schemas.microsoft.com/office/drawing/2014/main" id="{BE73D080-ABC6-4AC1-9064-D7EFD990A076}"/>
               </a:ext>
             </a:extLst>
           </p:cNvPr>
@@ -2408,7 +2408,7 @@
           <p:cNvPr id="4" name="">
             <a:extLst xmlns:a="http://schemas.openxmlformats.org/drawingml/2006/main">
               <a:ext uri="{FF2B5EF4-FFF2-40B4-BE49-F238E27FC236}">
-                <a16:creationId xmlns:a16="http://schemas.microsoft.com/office/drawing/2014/main" id="{205D873D-D353-4A14-BDD1-D8FD6AD964C1}"/>
+                <a16:creationId xmlns:a16="http://schemas.microsoft.com/office/drawing/2014/main" id="{F75F9250-2276-4FE7-87E0-FD6F59FAB929}"/>
               </a:ext>
             </a:extLst>
           </p:cNvPr>
@@ -2472,7 +2472,7 @@
           <p:cNvPr id="5" name="">
             <a:extLst xmlns:a="http://schemas.openxmlformats.org/drawingml/2006/main">
               <a:ext uri="{FF2B5EF4-FFF2-40B4-BE49-F238E27FC236}">
-                <a16:creationId xmlns:a16="http://schemas.microsoft.com/office/drawing/2014/main" id="{24B6E575-F06E-40C4-8E3B-3702EB800D74}"/>
+                <a16:creationId xmlns:a16="http://schemas.microsoft.com/office/drawing/2014/main" id="{47C90833-BF1A-4CF7-9EBB-A524A37F3938}"/>
               </a:ext>
             </a:extLst>
           </p:cNvPr>
@@ -2536,7 +2536,7 @@
           <p:cNvPr id="6" name="">
             <a:extLst xmlns:a="http://schemas.openxmlformats.org/drawingml/2006/main">
               <a:ext uri="{FF2B5EF4-FFF2-40B4-BE49-F238E27FC236}">
-                <a16:creationId xmlns:a16="http://schemas.microsoft.com/office/drawing/2014/main" id="{925307F3-C25B-4FB8-AA3B-1BDFE425C2A3}"/>
+                <a16:creationId xmlns:a16="http://schemas.microsoft.com/office/drawing/2014/main" id="{AAE00DAA-11EC-4295-8511-DC9C078865EB}"/>
               </a:ext>
             </a:extLst>
           </p:cNvPr>
@@ -2571,7 +2571,7 @@
           <p:cNvPr id="7" name="">
             <a:extLst xmlns:a="http://schemas.openxmlformats.org/drawingml/2006/main">
               <a:ext uri="{FF2B5EF4-FFF2-40B4-BE49-F238E27FC236}">
-                <a16:creationId xmlns:a16="http://schemas.microsoft.com/office/drawing/2014/main" id="{0DE57C81-9FF0-404E-A44F-F3CCF2DA85BB}"/>
+                <a16:creationId xmlns:a16="http://schemas.microsoft.com/office/drawing/2014/main" id="{13308823-1CEC-4D68-B8DE-5AFD25B28462}"/>
               </a:ext>
             </a:extLst>
           </p:cNvPr>
@@ -2635,7 +2635,7 @@
           <p:cNvPr id="8" name="">
             <a:extLst xmlns:a="http://schemas.openxmlformats.org/drawingml/2006/main">
               <a:ext uri="{FF2B5EF4-FFF2-40B4-BE49-F238E27FC236}">
-                <a16:creationId xmlns:a16="http://schemas.microsoft.com/office/drawing/2014/main" id="{F8A3CA73-0A4B-4620-859B-69B080BBC485}"/>
+                <a16:creationId xmlns:a16="http://schemas.microsoft.com/office/drawing/2014/main" id="{AC0EDCFD-5B2A-4269-9A21-073E6AB56791}"/>
               </a:ext>
             </a:extLst>
           </p:cNvPr>
@@ -2699,7 +2699,7 @@
           <p:cNvPr id="9" name="">
             <a:extLst xmlns:a="http://schemas.openxmlformats.org/drawingml/2006/main">
               <a:ext uri="{FF2B5EF4-FFF2-40B4-BE49-F238E27FC236}">
-                <a16:creationId xmlns:a16="http://schemas.microsoft.com/office/drawing/2014/main" id="{A52C40CC-2B77-4E12-9151-708D572217E3}"/>
+                <a16:creationId xmlns:a16="http://schemas.microsoft.com/office/drawing/2014/main" id="{EBBD3CE9-645E-4E51-BC57-07A997D2D1A5}"/>
               </a:ext>
             </a:extLst>
           </p:cNvPr>
@@ -2763,7 +2763,7 @@
           <p:cNvPr id="10" name="">
             <a:extLst xmlns:a="http://schemas.openxmlformats.org/drawingml/2006/main">
               <a:ext uri="{FF2B5EF4-FFF2-40B4-BE49-F238E27FC236}">
-                <a16:creationId xmlns:a16="http://schemas.microsoft.com/office/drawing/2014/main" id="{F5401472-B9D1-46CA-BC3C-942E1FAFCABF}"/>
+                <a16:creationId xmlns:a16="http://schemas.microsoft.com/office/drawing/2014/main" id="{FA1FB678-4324-4157-AF48-CCC764602D22}"/>
               </a:ext>
             </a:extLst>
           </p:cNvPr>
@@ -2798,7 +2798,7 @@
           <p:cNvPr id="11" name="">
             <a:extLst xmlns:a="http://schemas.openxmlformats.org/drawingml/2006/main">
               <a:ext uri="{FF2B5EF4-FFF2-40B4-BE49-F238E27FC236}">
-                <a16:creationId xmlns:a16="http://schemas.microsoft.com/office/drawing/2014/main" id="{B0C07E84-665A-40FF-B5ED-AC4B3E036811}"/>
+                <a16:creationId xmlns:a16="http://schemas.microsoft.com/office/drawing/2014/main" id="{7C4324FA-5055-4CE7-98F2-98E8E1155382}"/>
               </a:ext>
             </a:extLst>
           </p:cNvPr>
@@ -2833,7 +2833,7 @@
           <p:cNvPr id="12" name="">
             <a:extLst xmlns:a="http://schemas.openxmlformats.org/drawingml/2006/main">
               <a:ext uri="{FF2B5EF4-FFF2-40B4-BE49-F238E27FC236}">
-                <a16:creationId xmlns:a16="http://schemas.microsoft.com/office/drawing/2014/main" id="{19CC7363-0E9F-47AE-BAB6-C5FF2C4E0E42}"/>
+                <a16:creationId xmlns:a16="http://schemas.microsoft.com/office/drawing/2014/main" id="{0841FC36-92D5-4281-A465-BBDE3ABC155F}"/>
               </a:ext>
             </a:extLst>
           </p:cNvPr>
@@ -2868,7 +2868,7 @@
           <p:cNvPr id="13" name="">
             <a:extLst xmlns:a="http://schemas.openxmlformats.org/drawingml/2006/main">
               <a:ext uri="{FF2B5EF4-FFF2-40B4-BE49-F238E27FC236}">
-                <a16:creationId xmlns:a16="http://schemas.microsoft.com/office/drawing/2014/main" id="{A0ABB2E4-7BF6-450B-B5D6-2104BBD41D38}"/>
+                <a16:creationId xmlns:a16="http://schemas.microsoft.com/office/drawing/2014/main" id="{0A1A0CC9-3C26-4190-89A1-270FF7387DF7}"/>
               </a:ext>
             </a:extLst>
           </p:cNvPr>
@@ -2932,7 +2932,7 @@
           <p:cNvPr id="14" name="">
             <a:extLst xmlns:a="http://schemas.openxmlformats.org/drawingml/2006/main">
               <a:ext uri="{FF2B5EF4-FFF2-40B4-BE49-F238E27FC236}">
-                <a16:creationId xmlns:a16="http://schemas.microsoft.com/office/drawing/2014/main" id="{B405065C-A0B9-4D14-8424-8C423D2E599B}"/>
+                <a16:creationId xmlns:a16="http://schemas.microsoft.com/office/drawing/2014/main" id="{5CFE1FC4-4397-42AB-9012-3B2DB5A0FA47}"/>
               </a:ext>
             </a:extLst>
           </p:cNvPr>
@@ -2996,7 +2996,7 @@
           <p:cNvPr id="15" name="">
             <a:extLst xmlns:a="http://schemas.openxmlformats.org/drawingml/2006/main">
               <a:ext uri="{FF2B5EF4-FFF2-40B4-BE49-F238E27FC236}">
-                <a16:creationId xmlns:a16="http://schemas.microsoft.com/office/drawing/2014/main" id="{71743D55-B9C8-4000-ABA8-A2FAADBCC9B8}"/>
+                <a16:creationId xmlns:a16="http://schemas.microsoft.com/office/drawing/2014/main" id="{A977A768-6305-4EA0-B07E-9C97D106DAE9}"/>
               </a:ext>
             </a:extLst>
           </p:cNvPr>
@@ -3060,7 +3060,7 @@
           <p:cNvPr id="16" name="">
             <a:extLst xmlns:a="http://schemas.openxmlformats.org/drawingml/2006/main">
               <a:ext uri="{FF2B5EF4-FFF2-40B4-BE49-F238E27FC236}">
-                <a16:creationId xmlns:a16="http://schemas.microsoft.com/office/drawing/2014/main" id="{CD1CB61E-3A9E-4E78-9474-9F4FA3F0B806}"/>
+                <a16:creationId xmlns:a16="http://schemas.microsoft.com/office/drawing/2014/main" id="{045DC6D4-51C3-4FA7-93AA-6E68ACAFA2A7}"/>
               </a:ext>
             </a:extLst>
           </p:cNvPr>
@@ -3095,7 +3095,7 @@
           <p:cNvPr id="17" name="">
             <a:extLst xmlns:a="http://schemas.openxmlformats.org/drawingml/2006/main">
               <a:ext uri="{FF2B5EF4-FFF2-40B4-BE49-F238E27FC236}">
-                <a16:creationId xmlns:a16="http://schemas.microsoft.com/office/drawing/2014/main" id="{10BBD483-5B94-491E-A000-3B559D0F5845}"/>
+                <a16:creationId xmlns:a16="http://schemas.microsoft.com/office/drawing/2014/main" id="{65C3A02A-C4F9-47D6-9C90-8B3C6897EE73}"/>
               </a:ext>
             </a:extLst>
           </p:cNvPr>
@@ -3130,7 +3130,7 @@
           <p:cNvPr id="18" name="">
             <a:extLst xmlns:a="http://schemas.openxmlformats.org/drawingml/2006/main">
               <a:ext uri="{FF2B5EF4-FFF2-40B4-BE49-F238E27FC236}">
-                <a16:creationId xmlns:a16="http://schemas.microsoft.com/office/drawing/2014/main" id="{AB99AF66-EB32-4EB1-A375-A4D79C2585D9}"/>
+                <a16:creationId xmlns:a16="http://schemas.microsoft.com/office/drawing/2014/main" id="{C0A10D4A-6383-493C-A525-655DE0F58408}"/>
               </a:ext>
             </a:extLst>
           </p:cNvPr>
@@ -3165,7 +3165,7 @@
           <p:cNvPr id="19" name="">
             <a:extLst xmlns:a="http://schemas.openxmlformats.org/drawingml/2006/main">
               <a:ext uri="{FF2B5EF4-FFF2-40B4-BE49-F238E27FC236}">
-                <a16:creationId xmlns:a16="http://schemas.microsoft.com/office/drawing/2014/main" id="{10074DFB-7D24-425F-9B94-8181DBB09533}"/>
+                <a16:creationId xmlns:a16="http://schemas.microsoft.com/office/drawing/2014/main" id="{0FAE7663-E19F-435E-AE3C-B058104A55D7}"/>
               </a:ext>
             </a:extLst>
           </p:cNvPr>
@@ -3229,7 +3229,7 @@
           <p:cNvPr id="20" name="">
             <a:extLst xmlns:a="http://schemas.openxmlformats.org/drawingml/2006/main">
               <a:ext uri="{FF2B5EF4-FFF2-40B4-BE49-F238E27FC236}">
-                <a16:creationId xmlns:a16="http://schemas.microsoft.com/office/drawing/2014/main" id="{8394E22A-22AC-4C80-8656-3B55C7B59D2A}"/>
+                <a16:creationId xmlns:a16="http://schemas.microsoft.com/office/drawing/2014/main" id="{D51B6B4D-A906-4C19-BEBF-9D6F7552A700}"/>
               </a:ext>
             </a:extLst>
           </p:cNvPr>
@@ -3293,7 +3293,7 @@
           <p:cNvPr id="21" name="">
             <a:extLst xmlns:a="http://schemas.openxmlformats.org/drawingml/2006/main">
               <a:ext uri="{FF2B5EF4-FFF2-40B4-BE49-F238E27FC236}">
-                <a16:creationId xmlns:a16="http://schemas.microsoft.com/office/drawing/2014/main" id="{325A3CFD-C4CD-4E7D-8636-695A38FD3326}"/>
+                <a16:creationId xmlns:a16="http://schemas.microsoft.com/office/drawing/2014/main" id="{45D651EE-B32C-4DDF-A1F2-EA4EECBBBE9B}"/>
               </a:ext>
             </a:extLst>
           </p:cNvPr>
@@ -3357,7 +3357,7 @@
           <p:cNvPr id="22" name="">
             <a:extLst xmlns:a="http://schemas.openxmlformats.org/drawingml/2006/main">
               <a:ext uri="{FF2B5EF4-FFF2-40B4-BE49-F238E27FC236}">
-                <a16:creationId xmlns:a16="http://schemas.microsoft.com/office/drawing/2014/main" id="{26CC1147-7F91-443B-9A54-371717E0DE05}"/>
+                <a16:creationId xmlns:a16="http://schemas.microsoft.com/office/drawing/2014/main" id="{7636A15F-2E4E-4840-9532-51E6ED8405D6}"/>
               </a:ext>
             </a:extLst>
           </p:cNvPr>
@@ -3390,7 +3390,7 @@
           <p:cNvPr id="23" name="">
             <a:extLst xmlns:a="http://schemas.openxmlformats.org/drawingml/2006/main">
               <a:ext uri="{FF2B5EF4-FFF2-40B4-BE49-F238E27FC236}">
-                <a16:creationId xmlns:a16="http://schemas.microsoft.com/office/drawing/2014/main" id="{2B83E111-2CE4-4539-9331-A6A7E394BBEA}"/>
+                <a16:creationId xmlns:a16="http://schemas.microsoft.com/office/drawing/2014/main" id="{78B6C1F8-0F34-40F3-BBF8-9EC562CE0142}"/>
               </a:ext>
             </a:extLst>
           </p:cNvPr>
@@ -3454,7 +3454,7 @@
           <p:cNvPr id="24" name="">
             <a:extLst xmlns:a="http://schemas.openxmlformats.org/drawingml/2006/main">
               <a:ext uri="{FF2B5EF4-FFF2-40B4-BE49-F238E27FC236}">
-                <a16:creationId xmlns:a16="http://schemas.microsoft.com/office/drawing/2014/main" id="{BF4E4537-3B12-4563-B20C-7FC28E150622}"/>
+                <a16:creationId xmlns:a16="http://schemas.microsoft.com/office/drawing/2014/main" id="{BC6AC918-9BA9-45E7-84D5-F7DA89B4AB52}"/>
               </a:ext>
             </a:extLst>
           </p:cNvPr>
@@ -3541,7 +3541,7 @@
           <p:cNvPr id="25" name="">
             <a:extLst xmlns:a="http://schemas.openxmlformats.org/drawingml/2006/main">
               <a:ext uri="{FF2B5EF4-FFF2-40B4-BE49-F238E27FC236}">
-                <a16:creationId xmlns:a16="http://schemas.microsoft.com/office/drawing/2014/main" id="{94B29E4A-A285-435A-8AD4-247F29E93046}"/>
+                <a16:creationId xmlns:a16="http://schemas.microsoft.com/office/drawing/2014/main" id="{CF9E8736-852B-4BD8-88F7-38EE9F6FBBE5}"/>
               </a:ext>
             </a:extLst>
           </p:cNvPr>
@@ -3576,7 +3576,7 @@
           <p:cNvPr id="26" name="">
             <a:extLst xmlns:a="http://schemas.openxmlformats.org/drawingml/2006/main">
               <a:ext uri="{FF2B5EF4-FFF2-40B4-BE49-F238E27FC236}">
-                <a16:creationId xmlns:a16="http://schemas.microsoft.com/office/drawing/2014/main" id="{0AEDFC2D-B83B-442C-88AE-9378C6A7955C}"/>
+                <a16:creationId xmlns:a16="http://schemas.microsoft.com/office/drawing/2014/main" id="{19ED7AAB-BB39-493F-8106-F657E02EB2B2}"/>
               </a:ext>
             </a:extLst>
           </p:cNvPr>
@@ -3638,7 +3638,7 @@
     </p:spTree>
     <p:extLst>
       <p:ext uri="{BB962C8B-B14F-4D97-AF65-F5344CB8AC3E}">
-        <p14:creationId xmlns:p14="http://schemas.microsoft.com/office/powerpoint/2010/main" val="1136980627"/>
+        <p14:creationId xmlns:p14="http://schemas.microsoft.com/office/powerpoint/2010/main" val="1010771440"/>
       </p:ext>
     </p:extLst>
   </p:cSld>
@@ -3662,7 +3662,7 @@
           <p:cNvPr id="1" name="">
             <a:extLst xmlns:a="http://schemas.openxmlformats.org/drawingml/2006/main">
               <a:ext uri="{FF2B5EF4-FFF2-40B4-BE49-F238E27FC236}">
-                <a16:creationId xmlns:a16="http://schemas.microsoft.com/office/drawing/2014/main" id="{EE2BE4BF-96D1-4F4C-BDBF-D665413DC27E}"/>
+                <a16:creationId xmlns:a16="http://schemas.microsoft.com/office/drawing/2014/main" id="{8024F21F-E8B3-4B88-B73B-3AD53CCDF21D}"/>
               </a:ext>
             </a:extLst>
           </p:cNvPr>
@@ -3697,7 +3697,7 @@
           <p:cNvPr id="2" name="kicker-marker">
             <a:extLst xmlns:a="http://schemas.openxmlformats.org/drawingml/2006/main">
               <a:ext uri="{FF2B5EF4-FFF2-40B4-BE49-F238E27FC236}">
-                <a16:creationId xmlns:a16="http://schemas.microsoft.com/office/drawing/2014/main" id="{ADB71A31-8C8B-40BE-B766-903EF1D92A1E}"/>
+                <a16:creationId xmlns:a16="http://schemas.microsoft.com/office/drawing/2014/main" id="{53D8D7A7-9112-462A-AE9F-CDD415E0B8BC}"/>
               </a:ext>
             </a:extLst>
           </p:cNvPr>
@@ -3732,7 +3732,7 @@
           <p:cNvPr id="3" name="kicker-label">
             <a:extLst xmlns:a="http://schemas.openxmlformats.org/drawingml/2006/main">
               <a:ext uri="{FF2B5EF4-FFF2-40B4-BE49-F238E27FC236}">
-                <a16:creationId xmlns:a16="http://schemas.microsoft.com/office/drawing/2014/main" id="{FD97AA8B-797A-493D-AF85-AE94C3EA2750}"/>
+                <a16:creationId xmlns:a16="http://schemas.microsoft.com/office/drawing/2014/main" id="{EADDB09D-72C7-4E3E-9649-1D4E1587D279}"/>
               </a:ext>
             </a:extLst>
           </p:cNvPr>
@@ -3796,7 +3796,7 @@
           <p:cNvPr id="4" name="">
             <a:extLst xmlns:a="http://schemas.openxmlformats.org/drawingml/2006/main">
               <a:ext uri="{FF2B5EF4-FFF2-40B4-BE49-F238E27FC236}">
-                <a16:creationId xmlns:a16="http://schemas.microsoft.com/office/drawing/2014/main" id="{210260D9-EBD3-4A86-A77F-064106CE25CC}"/>
+                <a16:creationId xmlns:a16="http://schemas.microsoft.com/office/drawing/2014/main" id="{3FB6E05C-E85B-4515-A8AD-B62934AF4D85}"/>
               </a:ext>
             </a:extLst>
           </p:cNvPr>
@@ -3860,7 +3860,7 @@
           <p:cNvPr id="5" name="">
             <a:extLst xmlns:a="http://schemas.openxmlformats.org/drawingml/2006/main">
               <a:ext uri="{FF2B5EF4-FFF2-40B4-BE49-F238E27FC236}">
-                <a16:creationId xmlns:a16="http://schemas.microsoft.com/office/drawing/2014/main" id="{B6812461-5EA2-4727-93B3-4008A93AC074}"/>
+                <a16:creationId xmlns:a16="http://schemas.microsoft.com/office/drawing/2014/main" id="{E6C21EF7-26BD-465F-BD1B-B585D2E8247C}"/>
               </a:ext>
             </a:extLst>
           </p:cNvPr>
@@ -3895,7 +3895,7 @@
           <p:cNvPr id="6" name="">
             <a:extLst xmlns:a="http://schemas.openxmlformats.org/drawingml/2006/main">
               <a:ext uri="{FF2B5EF4-FFF2-40B4-BE49-F238E27FC236}">
-                <a16:creationId xmlns:a16="http://schemas.microsoft.com/office/drawing/2014/main" id="{F67D074F-1395-40F1-8A55-CDADFCB27E8F}"/>
+                <a16:creationId xmlns:a16="http://schemas.microsoft.com/office/drawing/2014/main" id="{77A1BE6A-CA5D-4963-9A6A-FBE35C70B450}"/>
               </a:ext>
             </a:extLst>
           </p:cNvPr>
@@ -3959,7 +3959,7 @@
           <p:cNvPr id="7" name="">
             <a:extLst xmlns:a="http://schemas.openxmlformats.org/drawingml/2006/main">
               <a:ext uri="{FF2B5EF4-FFF2-40B4-BE49-F238E27FC236}">
-                <a16:creationId xmlns:a16="http://schemas.microsoft.com/office/drawing/2014/main" id="{6C037B64-50CB-44D5-8B62-B69DC6B7AFDF}"/>
+                <a16:creationId xmlns:a16="http://schemas.microsoft.com/office/drawing/2014/main" id="{B9436D4C-2F2A-4DD8-B71B-3F20218C3BB0}"/>
               </a:ext>
             </a:extLst>
           </p:cNvPr>
@@ -3992,7 +3992,7 @@
           <p:cNvPr id="8" name="">
             <a:extLst xmlns:a="http://schemas.openxmlformats.org/drawingml/2006/main">
               <a:ext uri="{FF2B5EF4-FFF2-40B4-BE49-F238E27FC236}">
-                <a16:creationId xmlns:a16="http://schemas.microsoft.com/office/drawing/2014/main" id="{48559DD7-3E2F-466C-BDB2-F5D01F88EE00}"/>
+                <a16:creationId xmlns:a16="http://schemas.microsoft.com/office/drawing/2014/main" id="{62A4A815-8CA8-4DD6-B0FA-B37240F68153}"/>
               </a:ext>
             </a:extLst>
           </p:cNvPr>
@@ -4056,7 +4056,7 @@
           <p:cNvPr id="9" name="">
             <a:extLst xmlns:a="http://schemas.openxmlformats.org/drawingml/2006/main">
               <a:ext uri="{FF2B5EF4-FFF2-40B4-BE49-F238E27FC236}">
-                <a16:creationId xmlns:a16="http://schemas.microsoft.com/office/drawing/2014/main" id="{912AD942-D518-45BB-BC3A-CB42E13165FE}"/>
+                <a16:creationId xmlns:a16="http://schemas.microsoft.com/office/drawing/2014/main" id="{4BD8DE36-C337-49B3-ADCE-5B10133DDFDE}"/>
               </a:ext>
             </a:extLst>
           </p:cNvPr>
@@ -4120,7 +4120,7 @@
           <p:cNvPr id="10" name="">
             <a:extLst xmlns:a="http://schemas.openxmlformats.org/drawingml/2006/main">
               <a:ext uri="{FF2B5EF4-FFF2-40B4-BE49-F238E27FC236}">
-                <a16:creationId xmlns:a16="http://schemas.microsoft.com/office/drawing/2014/main" id="{7E970B98-62A7-4484-B717-14829767236F}"/>
+                <a16:creationId xmlns:a16="http://schemas.microsoft.com/office/drawing/2014/main" id="{6B0F5E95-F1CC-4DE4-B841-EE3C0254E302}"/>
               </a:ext>
             </a:extLst>
           </p:cNvPr>
@@ -4184,7 +4184,7 @@
           <p:cNvPr id="11" name="">
             <a:extLst xmlns:a="http://schemas.openxmlformats.org/drawingml/2006/main">
               <a:ext uri="{FF2B5EF4-FFF2-40B4-BE49-F238E27FC236}">
-                <a16:creationId xmlns:a16="http://schemas.microsoft.com/office/drawing/2014/main" id="{FA17E937-8209-44CA-A9D6-0700B40DB841}"/>
+                <a16:creationId xmlns:a16="http://schemas.microsoft.com/office/drawing/2014/main" id="{81E417D5-9E0C-4A99-B383-3FFF291B09B1}"/>
               </a:ext>
             </a:extLst>
           </p:cNvPr>
@@ -4219,7 +4219,7 @@
           <p:cNvPr id="12" name="">
             <a:extLst xmlns:a="http://schemas.openxmlformats.org/drawingml/2006/main">
               <a:ext uri="{FF2B5EF4-FFF2-40B4-BE49-F238E27FC236}">
-                <a16:creationId xmlns:a16="http://schemas.microsoft.com/office/drawing/2014/main" id="{72A68936-B66E-4E61-A58F-9AA9D287D521}"/>
+                <a16:creationId xmlns:a16="http://schemas.microsoft.com/office/drawing/2014/main" id="{9F3A4CD1-9586-4FBD-9215-CA09D104215E}"/>
               </a:ext>
             </a:extLst>
           </p:cNvPr>
@@ -4254,7 +4254,7 @@
           <p:cNvPr id="13" name="">
             <a:extLst xmlns:a="http://schemas.openxmlformats.org/drawingml/2006/main">
               <a:ext uri="{FF2B5EF4-FFF2-40B4-BE49-F238E27FC236}">
-                <a16:creationId xmlns:a16="http://schemas.microsoft.com/office/drawing/2014/main" id="{A37700FF-223A-4473-9A3D-7D8B2A5CE186}"/>
+                <a16:creationId xmlns:a16="http://schemas.microsoft.com/office/drawing/2014/main" id="{68BF4E9E-4CD9-417F-8630-755E3238C21A}"/>
               </a:ext>
             </a:extLst>
           </p:cNvPr>
@@ -4287,7 +4287,7 @@
           <p:cNvPr id="14" name="">
             <a:extLst xmlns:a="http://schemas.openxmlformats.org/drawingml/2006/main">
               <a:ext uri="{FF2B5EF4-FFF2-40B4-BE49-F238E27FC236}">
-                <a16:creationId xmlns:a16="http://schemas.microsoft.com/office/drawing/2014/main" id="{D16DC9FA-C47C-4C8C-97F2-18C1CF76CAC9}"/>
+                <a16:creationId xmlns:a16="http://schemas.microsoft.com/office/drawing/2014/main" id="{4B96359F-0CEF-4180-85E6-641DCD5930A8}"/>
               </a:ext>
             </a:extLst>
           </p:cNvPr>
@@ -4351,7 +4351,7 @@
           <p:cNvPr id="15" name="">
             <a:extLst xmlns:a="http://schemas.openxmlformats.org/drawingml/2006/main">
               <a:ext uri="{FF2B5EF4-FFF2-40B4-BE49-F238E27FC236}">
-                <a16:creationId xmlns:a16="http://schemas.microsoft.com/office/drawing/2014/main" id="{6D8D9E3C-1298-49C2-8103-00498D0984D0}"/>
+                <a16:creationId xmlns:a16="http://schemas.microsoft.com/office/drawing/2014/main" id="{2012ACA9-9AE8-40DB-94E7-EF99DD8500C4}"/>
               </a:ext>
             </a:extLst>
           </p:cNvPr>
@@ -4415,7 +4415,7 @@
           <p:cNvPr id="16" name="">
             <a:extLst xmlns:a="http://schemas.openxmlformats.org/drawingml/2006/main">
               <a:ext uri="{FF2B5EF4-FFF2-40B4-BE49-F238E27FC236}">
-                <a16:creationId xmlns:a16="http://schemas.microsoft.com/office/drawing/2014/main" id="{52C55521-D0E7-4521-A54D-EEDBF710EB9E}"/>
+                <a16:creationId xmlns:a16="http://schemas.microsoft.com/office/drawing/2014/main" id="{40726757-C5D4-475F-A601-D1C0E426703E}"/>
               </a:ext>
             </a:extLst>
           </p:cNvPr>
@@ -4479,7 +4479,7 @@
           <p:cNvPr id="17" name="">
             <a:extLst xmlns:a="http://schemas.openxmlformats.org/drawingml/2006/main">
               <a:ext uri="{FF2B5EF4-FFF2-40B4-BE49-F238E27FC236}">
-                <a16:creationId xmlns:a16="http://schemas.microsoft.com/office/drawing/2014/main" id="{8F2CCFF5-D86A-469F-99FB-F146FF33E442}"/>
+                <a16:creationId xmlns:a16="http://schemas.microsoft.com/office/drawing/2014/main" id="{27A88CCD-6D2C-4AB6-BF56-394C0D05C945}"/>
               </a:ext>
             </a:extLst>
           </p:cNvPr>
@@ -4514,7 +4514,7 @@
           <p:cNvPr id="18" name="">
             <a:extLst xmlns:a="http://schemas.openxmlformats.org/drawingml/2006/main">
               <a:ext uri="{FF2B5EF4-FFF2-40B4-BE49-F238E27FC236}">
-                <a16:creationId xmlns:a16="http://schemas.microsoft.com/office/drawing/2014/main" id="{0E8A912A-0B64-4881-8BD2-0334B1EE7476}"/>
+                <a16:creationId xmlns:a16="http://schemas.microsoft.com/office/drawing/2014/main" id="{35DA29D6-BDB4-4FE3-A1E7-9C057E5D6A16}"/>
               </a:ext>
             </a:extLst>
           </p:cNvPr>
@@ -4549,7 +4549,7 @@
           <p:cNvPr id="19" name="">
             <a:extLst xmlns:a="http://schemas.openxmlformats.org/drawingml/2006/main">
               <a:ext uri="{FF2B5EF4-FFF2-40B4-BE49-F238E27FC236}">
-                <a16:creationId xmlns:a16="http://schemas.microsoft.com/office/drawing/2014/main" id="{698EC0B3-EEE8-4ECB-A99D-93F6447728BD}"/>
+                <a16:creationId xmlns:a16="http://schemas.microsoft.com/office/drawing/2014/main" id="{480571B7-ECA4-4B8D-A029-7483201BB5DD}"/>
               </a:ext>
             </a:extLst>
           </p:cNvPr>
@@ -4582,7 +4582,7 @@
           <p:cNvPr id="20" name="">
             <a:extLst xmlns:a="http://schemas.openxmlformats.org/drawingml/2006/main">
               <a:ext uri="{FF2B5EF4-FFF2-40B4-BE49-F238E27FC236}">
-                <a16:creationId xmlns:a16="http://schemas.microsoft.com/office/drawing/2014/main" id="{15AFC32A-B416-49DF-87C4-CD1D81570025}"/>
+                <a16:creationId xmlns:a16="http://schemas.microsoft.com/office/drawing/2014/main" id="{E980DC0E-A832-419D-BE90-FA115745CA76}"/>
               </a:ext>
             </a:extLst>
           </p:cNvPr>
@@ -4646,7 +4646,7 @@
           <p:cNvPr id="21" name="">
             <a:extLst xmlns:a="http://schemas.openxmlformats.org/drawingml/2006/main">
               <a:ext uri="{FF2B5EF4-FFF2-40B4-BE49-F238E27FC236}">
-                <a16:creationId xmlns:a16="http://schemas.microsoft.com/office/drawing/2014/main" id="{EED25484-E225-46F7-AB4A-097E35AC233A}"/>
+                <a16:creationId xmlns:a16="http://schemas.microsoft.com/office/drawing/2014/main" id="{1EC3C9F2-D149-4A95-B622-93203BBD35C3}"/>
               </a:ext>
             </a:extLst>
           </p:cNvPr>
@@ -4710,7 +4710,7 @@
           <p:cNvPr id="22" name="">
             <a:extLst xmlns:a="http://schemas.openxmlformats.org/drawingml/2006/main">
               <a:ext uri="{FF2B5EF4-FFF2-40B4-BE49-F238E27FC236}">
-                <a16:creationId xmlns:a16="http://schemas.microsoft.com/office/drawing/2014/main" id="{7DCAD4E3-B1BA-4812-A940-57C37093401D}"/>
+                <a16:creationId xmlns:a16="http://schemas.microsoft.com/office/drawing/2014/main" id="{6DEE656A-322B-4DE9-A9F0-5731A394300E}"/>
               </a:ext>
             </a:extLst>
           </p:cNvPr>
@@ -4774,7 +4774,7 @@
           <p:cNvPr id="23" name="">
             <a:extLst xmlns:a="http://schemas.openxmlformats.org/drawingml/2006/main">
               <a:ext uri="{FF2B5EF4-FFF2-40B4-BE49-F238E27FC236}">
-                <a16:creationId xmlns:a16="http://schemas.microsoft.com/office/drawing/2014/main" id="{FE321DAE-7023-40B0-929B-13675D2B5F2F}"/>
+                <a16:creationId xmlns:a16="http://schemas.microsoft.com/office/drawing/2014/main" id="{84578F41-103F-4205-9ABF-8A59285C3DB7}"/>
               </a:ext>
             </a:extLst>
           </p:cNvPr>
@@ -4809,7 +4809,7 @@
           <p:cNvPr id="24" name="">
             <a:extLst xmlns:a="http://schemas.openxmlformats.org/drawingml/2006/main">
               <a:ext uri="{FF2B5EF4-FFF2-40B4-BE49-F238E27FC236}">
-                <a16:creationId xmlns:a16="http://schemas.microsoft.com/office/drawing/2014/main" id="{526A227D-A3AD-4F30-9C9E-508733DD745A}"/>
+                <a16:creationId xmlns:a16="http://schemas.microsoft.com/office/drawing/2014/main" id="{806B02A5-2265-4F6F-8243-AF813DD03975}"/>
               </a:ext>
             </a:extLst>
           </p:cNvPr>
@@ -4844,7 +4844,7 @@
           <p:cNvPr id="25" name="">
             <a:extLst xmlns:a="http://schemas.openxmlformats.org/drawingml/2006/main">
               <a:ext uri="{FF2B5EF4-FFF2-40B4-BE49-F238E27FC236}">
-                <a16:creationId xmlns:a16="http://schemas.microsoft.com/office/drawing/2014/main" id="{667FDFBB-B15F-4400-B459-64C8F529B1A6}"/>
+                <a16:creationId xmlns:a16="http://schemas.microsoft.com/office/drawing/2014/main" id="{3F1B78BA-3CF2-42B5-BD3F-C1D52A88C8A0}"/>
               </a:ext>
             </a:extLst>
           </p:cNvPr>
@@ -4877,7 +4877,7 @@
           <p:cNvPr id="26" name="">
             <a:extLst xmlns:a="http://schemas.openxmlformats.org/drawingml/2006/main">
               <a:ext uri="{FF2B5EF4-FFF2-40B4-BE49-F238E27FC236}">
-                <a16:creationId xmlns:a16="http://schemas.microsoft.com/office/drawing/2014/main" id="{252F9771-F0BC-48A8-BDAC-91AB3A30A0E8}"/>
+                <a16:creationId xmlns:a16="http://schemas.microsoft.com/office/drawing/2014/main" id="{30886695-2269-4875-B3F9-E067978E3A2A}"/>
               </a:ext>
             </a:extLst>
           </p:cNvPr>
@@ -4941,7 +4941,7 @@
           <p:cNvPr id="27" name="">
             <a:extLst xmlns:a="http://schemas.openxmlformats.org/drawingml/2006/main">
               <a:ext uri="{FF2B5EF4-FFF2-40B4-BE49-F238E27FC236}">
-                <a16:creationId xmlns:a16="http://schemas.microsoft.com/office/drawing/2014/main" id="{4A7BE824-0B9C-452B-A229-F2E557BAD090}"/>
+                <a16:creationId xmlns:a16="http://schemas.microsoft.com/office/drawing/2014/main" id="{93E9FE89-D6AE-41DB-91C5-971524E55650}"/>
               </a:ext>
             </a:extLst>
           </p:cNvPr>
@@ -5005,7 +5005,7 @@
           <p:cNvPr id="28" name="">
             <a:extLst xmlns:a="http://schemas.openxmlformats.org/drawingml/2006/main">
               <a:ext uri="{FF2B5EF4-FFF2-40B4-BE49-F238E27FC236}">
-                <a16:creationId xmlns:a16="http://schemas.microsoft.com/office/drawing/2014/main" id="{7F87F06A-10FE-42F0-983A-1EC8C1C4C2AA}"/>
+                <a16:creationId xmlns:a16="http://schemas.microsoft.com/office/drawing/2014/main" id="{FEF490F7-E674-43E4-8FBA-3D2028FC2E45}"/>
               </a:ext>
             </a:extLst>
           </p:cNvPr>
@@ -5069,7 +5069,7 @@
           <p:cNvPr id="29" name="">
             <a:extLst xmlns:a="http://schemas.openxmlformats.org/drawingml/2006/main">
               <a:ext uri="{FF2B5EF4-FFF2-40B4-BE49-F238E27FC236}">
-                <a16:creationId xmlns:a16="http://schemas.microsoft.com/office/drawing/2014/main" id="{060BDE2E-DA07-4CD7-93A7-05B3E8E9ADBA}"/>
+                <a16:creationId xmlns:a16="http://schemas.microsoft.com/office/drawing/2014/main" id="{4ABE55AA-CBEA-4C52-A7B3-CC1F5872685D}"/>
               </a:ext>
             </a:extLst>
           </p:cNvPr>
@@ -5131,7 +5131,7 @@
     </p:spTree>
     <p:extLst>
       <p:ext uri="{BB962C8B-B14F-4D97-AF65-F5344CB8AC3E}">
-        <p14:creationId xmlns:p14="http://schemas.microsoft.com/office/powerpoint/2010/main" val="1708224861"/>
+        <p14:creationId xmlns:p14="http://schemas.microsoft.com/office/powerpoint/2010/main" val="544708708"/>
       </p:ext>
     </p:extLst>
   </p:cSld>
@@ -5155,7 +5155,7 @@
           <p:cNvPr id="1" name="">
             <a:extLst xmlns:a="http://schemas.openxmlformats.org/drawingml/2006/main">
               <a:ext uri="{FF2B5EF4-FFF2-40B4-BE49-F238E27FC236}">
-                <a16:creationId xmlns:a16="http://schemas.microsoft.com/office/drawing/2014/main" id="{18CB9FB9-3017-4C96-AE14-BDBF0C0B24EF}"/>
+                <a16:creationId xmlns:a16="http://schemas.microsoft.com/office/drawing/2014/main" id="{F3816DFD-5A2B-4750-8A5C-95D204B26278}"/>
               </a:ext>
             </a:extLst>
           </p:cNvPr>
@@ -5190,7 +5190,7 @@
           <p:cNvPr id="2" name="kicker-marker">
             <a:extLst xmlns:a="http://schemas.openxmlformats.org/drawingml/2006/main">
               <a:ext uri="{FF2B5EF4-FFF2-40B4-BE49-F238E27FC236}">
-                <a16:creationId xmlns:a16="http://schemas.microsoft.com/office/drawing/2014/main" id="{CA2D92EE-B15E-4D1F-9F85-ED75BCC7109D}"/>
+                <a16:creationId xmlns:a16="http://schemas.microsoft.com/office/drawing/2014/main" id="{BD498633-C650-4661-A182-4C593E431640}"/>
               </a:ext>
             </a:extLst>
           </p:cNvPr>
@@ -5225,7 +5225,7 @@
           <p:cNvPr id="3" name="kicker-label">
             <a:extLst xmlns:a="http://schemas.openxmlformats.org/drawingml/2006/main">
               <a:ext uri="{FF2B5EF4-FFF2-40B4-BE49-F238E27FC236}">
-                <a16:creationId xmlns:a16="http://schemas.microsoft.com/office/drawing/2014/main" id="{F88B2FCC-9AD6-4A2A-B0FD-383717C525A8}"/>
+                <a16:creationId xmlns:a16="http://schemas.microsoft.com/office/drawing/2014/main" id="{BB4F3389-CAC9-4AB3-8B51-9C01916AEF0F}"/>
               </a:ext>
             </a:extLst>
           </p:cNvPr>
@@ -5289,7 +5289,7 @@
           <p:cNvPr id="4" name="">
             <a:extLst xmlns:a="http://schemas.openxmlformats.org/drawingml/2006/main">
               <a:ext uri="{FF2B5EF4-FFF2-40B4-BE49-F238E27FC236}">
-                <a16:creationId xmlns:a16="http://schemas.microsoft.com/office/drawing/2014/main" id="{85817ADC-3CAA-4359-B447-A762899962E5}"/>
+                <a16:creationId xmlns:a16="http://schemas.microsoft.com/office/drawing/2014/main" id="{5ADCE9F5-DD02-4F31-9A3D-B41894F8364B}"/>
               </a:ext>
             </a:extLst>
           </p:cNvPr>
@@ -5353,7 +5353,7 @@
           <p:cNvPr id="5" name="">
             <a:extLst xmlns:a="http://schemas.openxmlformats.org/drawingml/2006/main">
               <a:ext uri="{FF2B5EF4-FFF2-40B4-BE49-F238E27FC236}">
-                <a16:creationId xmlns:a16="http://schemas.microsoft.com/office/drawing/2014/main" id="{82D59901-D979-4850-93AB-E3372919CC71}"/>
+                <a16:creationId xmlns:a16="http://schemas.microsoft.com/office/drawing/2014/main" id="{8A2F6C8C-610B-4003-BF5F-97974C9FF4BF}"/>
               </a:ext>
             </a:extLst>
           </p:cNvPr>
@@ -5388,7 +5388,7 @@
           <p:cNvPr id="6" name="">
             <a:extLst xmlns:a="http://schemas.openxmlformats.org/drawingml/2006/main">
               <a:ext uri="{FF2B5EF4-FFF2-40B4-BE49-F238E27FC236}">
-                <a16:creationId xmlns:a16="http://schemas.microsoft.com/office/drawing/2014/main" id="{2C69A23C-089E-4DE4-830F-F625F9F240AD}"/>
+                <a16:creationId xmlns:a16="http://schemas.microsoft.com/office/drawing/2014/main" id="{1DD0BCF9-A32B-4032-8B48-0363221E8D98}"/>
               </a:ext>
             </a:extLst>
           </p:cNvPr>
@@ -5452,7 +5452,7 @@
           <p:cNvPr id="7" name="">
             <a:extLst xmlns:a="http://schemas.openxmlformats.org/drawingml/2006/main">
               <a:ext uri="{FF2B5EF4-FFF2-40B4-BE49-F238E27FC236}">
-                <a16:creationId xmlns:a16="http://schemas.microsoft.com/office/drawing/2014/main" id="{22A2BA67-3294-43E8-901B-D6083836F48B}"/>
+                <a16:creationId xmlns:a16="http://schemas.microsoft.com/office/drawing/2014/main" id="{1B674A24-E276-4237-9C26-F05EBA549C33}"/>
               </a:ext>
             </a:extLst>
           </p:cNvPr>
@@ -5516,7 +5516,7 @@
           <p:cNvPr id="8" name="">
             <a:extLst xmlns:a="http://schemas.openxmlformats.org/drawingml/2006/main">
               <a:ext uri="{FF2B5EF4-FFF2-40B4-BE49-F238E27FC236}">
-                <a16:creationId xmlns:a16="http://schemas.microsoft.com/office/drawing/2014/main" id="{BF06559E-D18F-44AF-AD6C-F7A501DD6C72}"/>
+                <a16:creationId xmlns:a16="http://schemas.microsoft.com/office/drawing/2014/main" id="{1753ADAD-EFA0-4F92-939F-B554833AB6BD}"/>
               </a:ext>
             </a:extLst>
           </p:cNvPr>
@@ -5580,7 +5580,7 @@
           <p:cNvPr id="9" name="">
             <a:extLst xmlns:a="http://schemas.openxmlformats.org/drawingml/2006/main">
               <a:ext uri="{FF2B5EF4-FFF2-40B4-BE49-F238E27FC236}">
-                <a16:creationId xmlns:a16="http://schemas.microsoft.com/office/drawing/2014/main" id="{D78763CD-F40D-4FB8-BFAA-52C9CDC60792}"/>
+                <a16:creationId xmlns:a16="http://schemas.microsoft.com/office/drawing/2014/main" id="{30C18514-F2BA-48A4-990C-52C422576669}"/>
               </a:ext>
             </a:extLst>
           </p:cNvPr>
@@ -5615,7 +5615,7 @@
           <p:cNvPr id="10" name="">
             <a:extLst xmlns:a="http://schemas.openxmlformats.org/drawingml/2006/main">
               <a:ext uri="{FF2B5EF4-FFF2-40B4-BE49-F238E27FC236}">
-                <a16:creationId xmlns:a16="http://schemas.microsoft.com/office/drawing/2014/main" id="{1E13E664-62E3-49EA-8BF8-984FB1E36D03}"/>
+                <a16:creationId xmlns:a16="http://schemas.microsoft.com/office/drawing/2014/main" id="{3B92F629-4CAB-4EE0-81C9-2869D4124BD1}"/>
               </a:ext>
             </a:extLst>
           </p:cNvPr>
@@ -5650,7 +5650,7 @@
           <p:cNvPr id="11" name="">
             <a:extLst xmlns:a="http://schemas.openxmlformats.org/drawingml/2006/main">
               <a:ext uri="{FF2B5EF4-FFF2-40B4-BE49-F238E27FC236}">
-                <a16:creationId xmlns:a16="http://schemas.microsoft.com/office/drawing/2014/main" id="{016DC045-7449-480C-9D9E-93180584F84B}"/>
+                <a16:creationId xmlns:a16="http://schemas.microsoft.com/office/drawing/2014/main" id="{3363B197-474C-48F8-B279-8639EDA4157D}"/>
               </a:ext>
             </a:extLst>
           </p:cNvPr>
@@ -5714,7 +5714,7 @@
           <p:cNvPr id="12" name="">
             <a:extLst xmlns:a="http://schemas.openxmlformats.org/drawingml/2006/main">
               <a:ext uri="{FF2B5EF4-FFF2-40B4-BE49-F238E27FC236}">
-                <a16:creationId xmlns:a16="http://schemas.microsoft.com/office/drawing/2014/main" id="{6414E326-3298-40B5-846D-1B9126F2B942}"/>
+                <a16:creationId xmlns:a16="http://schemas.microsoft.com/office/drawing/2014/main" id="{0E91A1F9-6844-4429-9FF8-E6C7F63F2714}"/>
               </a:ext>
             </a:extLst>
           </p:cNvPr>
@@ -5778,7 +5778,7 @@
           <p:cNvPr id="13" name="">
             <a:extLst xmlns:a="http://schemas.openxmlformats.org/drawingml/2006/main">
               <a:ext uri="{FF2B5EF4-FFF2-40B4-BE49-F238E27FC236}">
-                <a16:creationId xmlns:a16="http://schemas.microsoft.com/office/drawing/2014/main" id="{0C67ECA2-ABBD-48CA-BA63-F71D331E8B10}"/>
+                <a16:creationId xmlns:a16="http://schemas.microsoft.com/office/drawing/2014/main" id="{26DD0DDA-97EC-49FD-B665-D83CAC3D0C1B}"/>
               </a:ext>
             </a:extLst>
           </p:cNvPr>
@@ -5813,7 +5813,7 @@
           <p:cNvPr id="14" name="">
             <a:extLst xmlns:a="http://schemas.openxmlformats.org/drawingml/2006/main">
               <a:ext uri="{FF2B5EF4-FFF2-40B4-BE49-F238E27FC236}">
-                <a16:creationId xmlns:a16="http://schemas.microsoft.com/office/drawing/2014/main" id="{C09D9DB9-B703-4D42-9D26-B7344351AB83}"/>
+                <a16:creationId xmlns:a16="http://schemas.microsoft.com/office/drawing/2014/main" id="{1EEF5281-C79F-4DA9-95D6-B7A3A48F6004}"/>
               </a:ext>
             </a:extLst>
           </p:cNvPr>
@@ -5848,7 +5848,7 @@
           <p:cNvPr id="15" name="">
             <a:extLst xmlns:a="http://schemas.openxmlformats.org/drawingml/2006/main">
               <a:ext uri="{FF2B5EF4-FFF2-40B4-BE49-F238E27FC236}">
-                <a16:creationId xmlns:a16="http://schemas.microsoft.com/office/drawing/2014/main" id="{2250E80C-B93B-4BEB-A9AD-0A26FE50BBFD}"/>
+                <a16:creationId xmlns:a16="http://schemas.microsoft.com/office/drawing/2014/main" id="{C3DD7A68-23CD-47AC-BE7E-5E4D9C57E502}"/>
               </a:ext>
             </a:extLst>
           </p:cNvPr>
@@ -5912,7 +5912,7 @@
           <p:cNvPr id="16" name="">
             <a:extLst xmlns:a="http://schemas.openxmlformats.org/drawingml/2006/main">
               <a:ext uri="{FF2B5EF4-FFF2-40B4-BE49-F238E27FC236}">
-                <a16:creationId xmlns:a16="http://schemas.microsoft.com/office/drawing/2014/main" id="{4AE806E7-9299-4EF6-8EDE-DE23842387C1}"/>
+                <a16:creationId xmlns:a16="http://schemas.microsoft.com/office/drawing/2014/main" id="{4F622E0E-3BC9-4DD4-8B89-BAAAA37A7E24}"/>
               </a:ext>
             </a:extLst>
           </p:cNvPr>
@@ -5947,7 +5947,7 @@
           <p:cNvPr id="17" name="">
             <a:extLst xmlns:a="http://schemas.openxmlformats.org/drawingml/2006/main">
               <a:ext uri="{FF2B5EF4-FFF2-40B4-BE49-F238E27FC236}">
-                <a16:creationId xmlns:a16="http://schemas.microsoft.com/office/drawing/2014/main" id="{4CE32BE3-71FB-4AB0-A9A3-1E307DFDC89F}"/>
+                <a16:creationId xmlns:a16="http://schemas.microsoft.com/office/drawing/2014/main" id="{9BD2C12A-6784-4780-9C4F-FB2C69BEA5A3}"/>
               </a:ext>
             </a:extLst>
           </p:cNvPr>
@@ -6011,7 +6011,7 @@
           <p:cNvPr id="18" name="">
             <a:extLst xmlns:a="http://schemas.openxmlformats.org/drawingml/2006/main">
               <a:ext uri="{FF2B5EF4-FFF2-40B4-BE49-F238E27FC236}">
-                <a16:creationId xmlns:a16="http://schemas.microsoft.com/office/drawing/2014/main" id="{C7CAF845-70B5-45DE-9994-2024AE123CAA}"/>
+                <a16:creationId xmlns:a16="http://schemas.microsoft.com/office/drawing/2014/main" id="{B0C50847-79CB-4AE4-B25D-458904ECECC4}"/>
               </a:ext>
             </a:extLst>
           </p:cNvPr>
@@ -6046,7 +6046,7 @@
           <p:cNvPr id="19" name="">
             <a:extLst xmlns:a="http://schemas.openxmlformats.org/drawingml/2006/main">
               <a:ext uri="{FF2B5EF4-FFF2-40B4-BE49-F238E27FC236}">
-                <a16:creationId xmlns:a16="http://schemas.microsoft.com/office/drawing/2014/main" id="{C4C695AF-0C0F-4ADD-93BD-F2B92B7B705C}"/>
+                <a16:creationId xmlns:a16="http://schemas.microsoft.com/office/drawing/2014/main" id="{AA80B0D5-00AF-40C0-BE34-6593FA84136D}"/>
               </a:ext>
             </a:extLst>
           </p:cNvPr>
@@ -6110,7 +6110,7 @@
           <p:cNvPr id="20" name="">
             <a:extLst xmlns:a="http://schemas.openxmlformats.org/drawingml/2006/main">
               <a:ext uri="{FF2B5EF4-FFF2-40B4-BE49-F238E27FC236}">
-                <a16:creationId xmlns:a16="http://schemas.microsoft.com/office/drawing/2014/main" id="{CF7DB035-1C4D-4E5A-B8F9-324D152A53A8}"/>
+                <a16:creationId xmlns:a16="http://schemas.microsoft.com/office/drawing/2014/main" id="{F99603C0-DB0B-44A9-BF63-BA45558AE573}"/>
               </a:ext>
             </a:extLst>
           </p:cNvPr>
@@ -6145,7 +6145,7 @@
           <p:cNvPr id="21" name="">
             <a:extLst xmlns:a="http://schemas.openxmlformats.org/drawingml/2006/main">
               <a:ext uri="{FF2B5EF4-FFF2-40B4-BE49-F238E27FC236}">
-                <a16:creationId xmlns:a16="http://schemas.microsoft.com/office/drawing/2014/main" id="{5CA997CA-D926-45AA-B8D0-2665DDBFE3DA}"/>
+                <a16:creationId xmlns:a16="http://schemas.microsoft.com/office/drawing/2014/main" id="{933D4377-438B-44D8-A977-95281F5E2725}"/>
               </a:ext>
             </a:extLst>
           </p:cNvPr>
@@ -6209,7 +6209,7 @@
           <p:cNvPr id="22" name="">
             <a:extLst xmlns:a="http://schemas.openxmlformats.org/drawingml/2006/main">
               <a:ext uri="{FF2B5EF4-FFF2-40B4-BE49-F238E27FC236}">
-                <a16:creationId xmlns:a16="http://schemas.microsoft.com/office/drawing/2014/main" id="{F4EF40D7-4BB7-4734-857B-3F199601EF23}"/>
+                <a16:creationId xmlns:a16="http://schemas.microsoft.com/office/drawing/2014/main" id="{835E8642-CFB1-4DE6-B423-3A92AC465596}"/>
               </a:ext>
             </a:extLst>
           </p:cNvPr>
@@ -6244,7 +6244,7 @@
           <p:cNvPr id="23" name="">
             <a:extLst xmlns:a="http://schemas.openxmlformats.org/drawingml/2006/main">
               <a:ext uri="{FF2B5EF4-FFF2-40B4-BE49-F238E27FC236}">
-                <a16:creationId xmlns:a16="http://schemas.microsoft.com/office/drawing/2014/main" id="{C7AE6EE1-45F3-4BEA-AB24-3E453EFC47BC}"/>
+                <a16:creationId xmlns:a16="http://schemas.microsoft.com/office/drawing/2014/main" id="{FE073F80-5448-4CFF-A383-1B7F3A0D60C5}"/>
               </a:ext>
             </a:extLst>
           </p:cNvPr>
@@ -6308,7 +6308,7 @@
           <p:cNvPr id="24" name="">
             <a:extLst xmlns:a="http://schemas.openxmlformats.org/drawingml/2006/main">
               <a:ext uri="{FF2B5EF4-FFF2-40B4-BE49-F238E27FC236}">
-                <a16:creationId xmlns:a16="http://schemas.microsoft.com/office/drawing/2014/main" id="{2D62F1ED-7E8E-4896-9F7A-F271296993AB}"/>
+                <a16:creationId xmlns:a16="http://schemas.microsoft.com/office/drawing/2014/main" id="{D451F19E-FDF0-42BA-9119-75112D959FB0}"/>
               </a:ext>
             </a:extLst>
           </p:cNvPr>
@@ -6343,7 +6343,7 @@
           <p:cNvPr id="25" name="">
             <a:extLst xmlns:a="http://schemas.openxmlformats.org/drawingml/2006/main">
               <a:ext uri="{FF2B5EF4-FFF2-40B4-BE49-F238E27FC236}">
-                <a16:creationId xmlns:a16="http://schemas.microsoft.com/office/drawing/2014/main" id="{434F11EE-D7EB-4A05-AE23-7665EAA6A262}"/>
+                <a16:creationId xmlns:a16="http://schemas.microsoft.com/office/drawing/2014/main" id="{55111A45-C365-4AC6-A47E-0207F5AEB635}"/>
               </a:ext>
             </a:extLst>
           </p:cNvPr>
@@ -6407,7 +6407,7 @@
           <p:cNvPr id="26" name="">
             <a:extLst xmlns:a="http://schemas.openxmlformats.org/drawingml/2006/main">
               <a:ext uri="{FF2B5EF4-FFF2-40B4-BE49-F238E27FC236}">
-                <a16:creationId xmlns:a16="http://schemas.microsoft.com/office/drawing/2014/main" id="{8B25AC5B-EFEF-4475-8391-EAB68D51F4D1}"/>
+                <a16:creationId xmlns:a16="http://schemas.microsoft.com/office/drawing/2014/main" id="{C5B63EBF-6611-463F-8B85-C6C0ADDA3C03}"/>
               </a:ext>
             </a:extLst>
           </p:cNvPr>
@@ -6492,7 +6492,7 @@
     </p:spTree>
     <p:extLst>
       <p:ext uri="{BB962C8B-B14F-4D97-AF65-F5344CB8AC3E}">
-        <p14:creationId xmlns:p14="http://schemas.microsoft.com/office/powerpoint/2010/main" val="979011384"/>
+        <p14:creationId xmlns:p14="http://schemas.microsoft.com/office/powerpoint/2010/main" val="1792961260"/>
       </p:ext>
     </p:extLst>
   </p:cSld>
@@ -6516,7 +6516,7 @@
           <p:cNvPr id="1" name="">
             <a:extLst xmlns:a="http://schemas.openxmlformats.org/drawingml/2006/main">
               <a:ext uri="{FF2B5EF4-FFF2-40B4-BE49-F238E27FC236}">
-                <a16:creationId xmlns:a16="http://schemas.microsoft.com/office/drawing/2014/main" id="{88790F8C-FCAA-4446-A395-BB3675EAA449}"/>
+                <a16:creationId xmlns:a16="http://schemas.microsoft.com/office/drawing/2014/main" id="{CAB9691B-2B3B-40EA-A679-4AEA72C171E5}"/>
               </a:ext>
             </a:extLst>
           </p:cNvPr>
@@ -6551,7 +6551,7 @@
           <p:cNvPr id="2" name="kicker-marker">
             <a:extLst xmlns:a="http://schemas.openxmlformats.org/drawingml/2006/main">
               <a:ext uri="{FF2B5EF4-FFF2-40B4-BE49-F238E27FC236}">
-                <a16:creationId xmlns:a16="http://schemas.microsoft.com/office/drawing/2014/main" id="{74F330BD-1522-4422-8A70-BC20D197BC59}"/>
+                <a16:creationId xmlns:a16="http://schemas.microsoft.com/office/drawing/2014/main" id="{ABA804BB-C2DC-42DA-A24C-388685A58796}"/>
               </a:ext>
             </a:extLst>
           </p:cNvPr>
@@ -6586,7 +6586,7 @@
           <p:cNvPr id="3" name="kicker-label">
             <a:extLst xmlns:a="http://schemas.openxmlformats.org/drawingml/2006/main">
               <a:ext uri="{FF2B5EF4-FFF2-40B4-BE49-F238E27FC236}">
-                <a16:creationId xmlns:a16="http://schemas.microsoft.com/office/drawing/2014/main" id="{31BC324C-887C-442D-9528-EDB10B8AE04D}"/>
+                <a16:creationId xmlns:a16="http://schemas.microsoft.com/office/drawing/2014/main" id="{0A0FCD88-B225-4097-AD36-0F38069E700E}"/>
               </a:ext>
             </a:extLst>
           </p:cNvPr>
@@ -6650,7 +6650,7 @@
           <p:cNvPr id="4" name="">
             <a:extLst xmlns:a="http://schemas.openxmlformats.org/drawingml/2006/main">
               <a:ext uri="{FF2B5EF4-FFF2-40B4-BE49-F238E27FC236}">
-                <a16:creationId xmlns:a16="http://schemas.microsoft.com/office/drawing/2014/main" id="{A817CC4E-0461-458B-A93B-589231306FF4}"/>
+                <a16:creationId xmlns:a16="http://schemas.microsoft.com/office/drawing/2014/main" id="{1C9F3808-9600-4D3C-BD95-8BBD196F40BF}"/>
               </a:ext>
             </a:extLst>
           </p:cNvPr>
@@ -6714,7 +6714,7 @@
           <p:cNvPr id="5" name="">
             <a:extLst xmlns:a="http://schemas.openxmlformats.org/drawingml/2006/main">
               <a:ext uri="{FF2B5EF4-FFF2-40B4-BE49-F238E27FC236}">
-                <a16:creationId xmlns:a16="http://schemas.microsoft.com/office/drawing/2014/main" id="{B618BED1-033B-4E51-9F32-6B05B65A2111}"/>
+                <a16:creationId xmlns:a16="http://schemas.microsoft.com/office/drawing/2014/main" id="{F286F07B-3CB1-4F30-8299-6C64BCF4BCB7}"/>
               </a:ext>
             </a:extLst>
           </p:cNvPr>
@@ -6749,7 +6749,7 @@
           <p:cNvPr id="6" name="">
             <a:extLst xmlns:a="http://schemas.openxmlformats.org/drawingml/2006/main">
               <a:ext uri="{FF2B5EF4-FFF2-40B4-BE49-F238E27FC236}">
-                <a16:creationId xmlns:a16="http://schemas.microsoft.com/office/drawing/2014/main" id="{21FF9969-4E6A-4C57-A2DA-3F7568793A68}"/>
+                <a16:creationId xmlns:a16="http://schemas.microsoft.com/office/drawing/2014/main" id="{32B4C210-8ED7-4C0F-A20E-5828EF5A41DE}"/>
               </a:ext>
             </a:extLst>
           </p:cNvPr>
@@ -6817,7 +6817,7 @@
           <p:nvPr/>
         </p:nvPicPr>
         <p:blipFill>
-          <a:blip xmlns:r="http://schemas.openxmlformats.org/officeDocument/2006/relationships" xmlns:a="http://schemas.openxmlformats.org/drawingml/2006/main" r:embed="Rfce1567997484d35"/>
+          <a:blip xmlns:r="http://schemas.openxmlformats.org/officeDocument/2006/relationships" xmlns:a="http://schemas.openxmlformats.org/drawingml/2006/main" r:embed="Rf745ef44a0c048a1"/>
           <a:stretch xmlns:a="http://schemas.openxmlformats.org/drawingml/2006/main"/>
         </p:blipFill>
         <p:spPr>
@@ -6835,7 +6835,7 @@
           <p:cNvPr id="8" name="">
             <a:extLst xmlns:a="http://schemas.openxmlformats.org/drawingml/2006/main">
               <a:ext uri="{FF2B5EF4-FFF2-40B4-BE49-F238E27FC236}">
-                <a16:creationId xmlns:a16="http://schemas.microsoft.com/office/drawing/2014/main" id="{404030CC-0643-4C63-92EB-B13C51AB617D}"/>
+                <a16:creationId xmlns:a16="http://schemas.microsoft.com/office/drawing/2014/main" id="{F80E6954-18C2-4309-8E9F-7B6F4BADD9F7}"/>
               </a:ext>
             </a:extLst>
           </p:cNvPr>
@@ -6868,7 +6868,7 @@
     </p:spTree>
     <p:extLst>
       <p:ext uri="{BB962C8B-B14F-4D97-AF65-F5344CB8AC3E}">
-        <p14:creationId xmlns:p14="http://schemas.microsoft.com/office/powerpoint/2010/main" val="303199899"/>
+        <p14:creationId xmlns:p14="http://schemas.microsoft.com/office/powerpoint/2010/main" val="1016807403"/>
       </p:ext>
     </p:extLst>
   </p:cSld>
@@ -6892,7 +6892,7 @@
           <p:cNvPr id="1" name="">
             <a:extLst xmlns:a="http://schemas.openxmlformats.org/drawingml/2006/main">
               <a:ext uri="{FF2B5EF4-FFF2-40B4-BE49-F238E27FC236}">
-                <a16:creationId xmlns:a16="http://schemas.microsoft.com/office/drawing/2014/main" id="{AF210BD2-87AF-4E7B-923F-B79D40453D49}"/>
+                <a16:creationId xmlns:a16="http://schemas.microsoft.com/office/drawing/2014/main" id="{272A7FA1-6E6A-4205-8402-79FDBA043CC6}"/>
               </a:ext>
             </a:extLst>
           </p:cNvPr>
@@ -6927,7 +6927,7 @@
           <p:cNvPr id="2" name="kicker-marker">
             <a:extLst xmlns:a="http://schemas.openxmlformats.org/drawingml/2006/main">
               <a:ext uri="{FF2B5EF4-FFF2-40B4-BE49-F238E27FC236}">
-                <a16:creationId xmlns:a16="http://schemas.microsoft.com/office/drawing/2014/main" id="{FF69E1E8-5D48-411F-B5D9-F412E6646ED2}"/>
+                <a16:creationId xmlns:a16="http://schemas.microsoft.com/office/drawing/2014/main" id="{AB99CEBB-5D58-4675-A14A-164AF2B4EA1F}"/>
               </a:ext>
             </a:extLst>
           </p:cNvPr>
@@ -6962,7 +6962,7 @@
           <p:cNvPr id="3" name="kicker-label">
             <a:extLst xmlns:a="http://schemas.openxmlformats.org/drawingml/2006/main">
               <a:ext uri="{FF2B5EF4-FFF2-40B4-BE49-F238E27FC236}">
-                <a16:creationId xmlns:a16="http://schemas.microsoft.com/office/drawing/2014/main" id="{AA31CEF7-373D-4FA1-8DE0-0350ED176288}"/>
+                <a16:creationId xmlns:a16="http://schemas.microsoft.com/office/drawing/2014/main" id="{15E4C833-D87A-431F-A39E-FBBC44A97344}"/>
               </a:ext>
             </a:extLst>
           </p:cNvPr>
@@ -7026,7 +7026,7 @@
           <p:cNvPr id="4" name="">
             <a:extLst xmlns:a="http://schemas.openxmlformats.org/drawingml/2006/main">
               <a:ext uri="{FF2B5EF4-FFF2-40B4-BE49-F238E27FC236}">
-                <a16:creationId xmlns:a16="http://schemas.microsoft.com/office/drawing/2014/main" id="{D792C74A-2905-4719-8E7F-9051A68F0B80}"/>
+                <a16:creationId xmlns:a16="http://schemas.microsoft.com/office/drawing/2014/main" id="{B67334C6-3868-40B2-9844-80CC159C8E3A}"/>
               </a:ext>
             </a:extLst>
           </p:cNvPr>
@@ -7090,7 +7090,7 @@
           <p:cNvPr id="5" name="">
             <a:extLst xmlns:a="http://schemas.openxmlformats.org/drawingml/2006/main">
               <a:ext uri="{FF2B5EF4-FFF2-40B4-BE49-F238E27FC236}">
-                <a16:creationId xmlns:a16="http://schemas.microsoft.com/office/drawing/2014/main" id="{DDF9A62F-CB1E-43F1-B75B-116E89B5DC07}"/>
+                <a16:creationId xmlns:a16="http://schemas.microsoft.com/office/drawing/2014/main" id="{27C81F29-7534-43F6-BB39-DC5CD333EB31}"/>
               </a:ext>
             </a:extLst>
           </p:cNvPr>
@@ -7125,7 +7125,7 @@
           <p:cNvPr id="6" name="">
             <a:extLst xmlns:a="http://schemas.openxmlformats.org/drawingml/2006/main">
               <a:ext uri="{FF2B5EF4-FFF2-40B4-BE49-F238E27FC236}">
-                <a16:creationId xmlns:a16="http://schemas.microsoft.com/office/drawing/2014/main" id="{3F350F3C-7AB0-47D5-B188-D3635B23303D}"/>
+                <a16:creationId xmlns:a16="http://schemas.microsoft.com/office/drawing/2014/main" id="{C3E6249F-1DF0-4082-AE6F-9C6FF010A2B3}"/>
               </a:ext>
             </a:extLst>
           </p:cNvPr>
@@ -7193,7 +7193,7 @@
           <p:nvPr/>
         </p:nvPicPr>
         <p:blipFill>
-          <a:blip xmlns:r="http://schemas.openxmlformats.org/officeDocument/2006/relationships" xmlns:a="http://schemas.openxmlformats.org/drawingml/2006/main" r:embed="R10276c710fe04a29"/>
+          <a:blip xmlns:r="http://schemas.openxmlformats.org/officeDocument/2006/relationships" xmlns:a="http://schemas.openxmlformats.org/drawingml/2006/main" r:embed="R4d778113298c4041"/>
           <a:stretch xmlns:a="http://schemas.openxmlformats.org/drawingml/2006/main"/>
         </p:blipFill>
         <p:spPr>
@@ -7211,7 +7211,7 @@
           <p:cNvPr id="8" name="">
             <a:extLst xmlns:a="http://schemas.openxmlformats.org/drawingml/2006/main">
               <a:ext uri="{FF2B5EF4-FFF2-40B4-BE49-F238E27FC236}">
-                <a16:creationId xmlns:a16="http://schemas.microsoft.com/office/drawing/2014/main" id="{B2DE191B-6106-4F72-B9F4-054D6DFD9BFF}"/>
+                <a16:creationId xmlns:a16="http://schemas.microsoft.com/office/drawing/2014/main" id="{56A5B6EE-4496-4913-B8AE-05E1D2999923}"/>
               </a:ext>
             </a:extLst>
           </p:cNvPr>
@@ -7244,7 +7244,7 @@
     </p:spTree>
     <p:extLst>
       <p:ext uri="{BB962C8B-B14F-4D97-AF65-F5344CB8AC3E}">
-        <p14:creationId xmlns:p14="http://schemas.microsoft.com/office/powerpoint/2010/main" val="9048913"/>
+        <p14:creationId xmlns:p14="http://schemas.microsoft.com/office/powerpoint/2010/main" val="461677467"/>
       </p:ext>
     </p:extLst>
   </p:cSld>
@@ -7268,7 +7268,7 @@
           <p:cNvPr id="1" name="">
             <a:extLst xmlns:a="http://schemas.openxmlformats.org/drawingml/2006/main">
               <a:ext uri="{FF2B5EF4-FFF2-40B4-BE49-F238E27FC236}">
-                <a16:creationId xmlns:a16="http://schemas.microsoft.com/office/drawing/2014/main" id="{0230F915-419A-4F7E-9BFC-97959A8DAEB2}"/>
+                <a16:creationId xmlns:a16="http://schemas.microsoft.com/office/drawing/2014/main" id="{E33BA71E-EC98-43BA-BDDC-83849BFEEC0B}"/>
               </a:ext>
             </a:extLst>
           </p:cNvPr>
@@ -7303,7 +7303,7 @@
           <p:cNvPr id="2" name="kicker-marker">
             <a:extLst xmlns:a="http://schemas.openxmlformats.org/drawingml/2006/main">
               <a:ext uri="{FF2B5EF4-FFF2-40B4-BE49-F238E27FC236}">
-                <a16:creationId xmlns:a16="http://schemas.microsoft.com/office/drawing/2014/main" id="{08CD2B7B-D991-4C18-AFF1-7D95FF65106C}"/>
+                <a16:creationId xmlns:a16="http://schemas.microsoft.com/office/drawing/2014/main" id="{29FF781A-CE7C-4224-9DB8-6AEDCD3523FB}"/>
               </a:ext>
             </a:extLst>
           </p:cNvPr>
@@ -7338,7 +7338,7 @@
           <p:cNvPr id="3" name="kicker-label">
             <a:extLst xmlns:a="http://schemas.openxmlformats.org/drawingml/2006/main">
               <a:ext uri="{FF2B5EF4-FFF2-40B4-BE49-F238E27FC236}">
-                <a16:creationId xmlns:a16="http://schemas.microsoft.com/office/drawing/2014/main" id="{42E58165-FA6A-463C-9144-98ED9DD4F067}"/>
+                <a16:creationId xmlns:a16="http://schemas.microsoft.com/office/drawing/2014/main" id="{101265D5-21BE-499D-9F6F-67F1AD498E71}"/>
               </a:ext>
             </a:extLst>
           </p:cNvPr>
@@ -7402,7 +7402,7 @@
           <p:cNvPr id="4" name="">
             <a:extLst xmlns:a="http://schemas.openxmlformats.org/drawingml/2006/main">
               <a:ext uri="{FF2B5EF4-FFF2-40B4-BE49-F238E27FC236}">
-                <a16:creationId xmlns:a16="http://schemas.microsoft.com/office/drawing/2014/main" id="{3201206E-A8DB-4590-8211-F40F0D194919}"/>
+                <a16:creationId xmlns:a16="http://schemas.microsoft.com/office/drawing/2014/main" id="{1431728E-92C6-4B79-BB55-26ADD5D97CE9}"/>
               </a:ext>
             </a:extLst>
           </p:cNvPr>
@@ -7466,7 +7466,7 @@
           <p:cNvPr id="5" name="">
             <a:extLst xmlns:a="http://schemas.openxmlformats.org/drawingml/2006/main">
               <a:ext uri="{FF2B5EF4-FFF2-40B4-BE49-F238E27FC236}">
-                <a16:creationId xmlns:a16="http://schemas.microsoft.com/office/drawing/2014/main" id="{76D11E98-5775-4A09-B743-5BA6087B8171}"/>
+                <a16:creationId xmlns:a16="http://schemas.microsoft.com/office/drawing/2014/main" id="{D480E1BC-5BC9-4875-9FF9-C9E735BF874A}"/>
               </a:ext>
             </a:extLst>
           </p:cNvPr>
@@ -7501,7 +7501,7 @@
           <p:cNvPr id="6" name="">
             <a:extLst xmlns:a="http://schemas.openxmlformats.org/drawingml/2006/main">
               <a:ext uri="{FF2B5EF4-FFF2-40B4-BE49-F238E27FC236}">
-                <a16:creationId xmlns:a16="http://schemas.microsoft.com/office/drawing/2014/main" id="{5E244B83-443A-409C-93D5-1F5BDC915E83}"/>
+                <a16:creationId xmlns:a16="http://schemas.microsoft.com/office/drawing/2014/main" id="{50428B3F-2105-4D77-89DC-CCBD84D320A4}"/>
               </a:ext>
             </a:extLst>
           </p:cNvPr>
@@ -7569,7 +7569,7 @@
           <p:nvPr/>
         </p:nvPicPr>
         <p:blipFill>
-          <a:blip xmlns:r="http://schemas.openxmlformats.org/officeDocument/2006/relationships" xmlns:a="http://schemas.openxmlformats.org/drawingml/2006/main" r:embed="Rcf1b041fd3be434f"/>
+          <a:blip xmlns:r="http://schemas.openxmlformats.org/officeDocument/2006/relationships" xmlns:a="http://schemas.openxmlformats.org/drawingml/2006/main" r:embed="R1fe24bdea7f84634"/>
           <a:stretch xmlns:a="http://schemas.openxmlformats.org/drawingml/2006/main"/>
         </p:blipFill>
         <p:spPr>
@@ -7587,7 +7587,7 @@
           <p:cNvPr id="8" name="">
             <a:extLst xmlns:a="http://schemas.openxmlformats.org/drawingml/2006/main">
               <a:ext uri="{FF2B5EF4-FFF2-40B4-BE49-F238E27FC236}">
-                <a16:creationId xmlns:a16="http://schemas.microsoft.com/office/drawing/2014/main" id="{C780D99A-32CD-44F6-85FA-E00E1209C6AA}"/>
+                <a16:creationId xmlns:a16="http://schemas.microsoft.com/office/drawing/2014/main" id="{97B41657-82E7-4848-B5CF-1B3048C7BCD1}"/>
               </a:ext>
             </a:extLst>
           </p:cNvPr>
@@ -7622,7 +7622,7 @@
           <p:cNvPr id="9" name="">
             <a:extLst xmlns:a="http://schemas.openxmlformats.org/drawingml/2006/main">
               <a:ext uri="{FF2B5EF4-FFF2-40B4-BE49-F238E27FC236}">
-                <a16:creationId xmlns:a16="http://schemas.microsoft.com/office/drawing/2014/main" id="{F663162C-51E2-4D02-9DD7-7743FA6430C4}"/>
+                <a16:creationId xmlns:a16="http://schemas.microsoft.com/office/drawing/2014/main" id="{47990A92-67FB-4CA9-9926-89FCE10DDE84}"/>
               </a:ext>
             </a:extLst>
           </p:cNvPr>
@@ -7657,7 +7657,7 @@
           <p:cNvPr id="10" name="">
             <a:extLst xmlns:a="http://schemas.openxmlformats.org/drawingml/2006/main">
               <a:ext uri="{FF2B5EF4-FFF2-40B4-BE49-F238E27FC236}">
-                <a16:creationId xmlns:a16="http://schemas.microsoft.com/office/drawing/2014/main" id="{1A32F6E5-CE6F-48C0-9BB8-F84FDFEF3FE5}"/>
+                <a16:creationId xmlns:a16="http://schemas.microsoft.com/office/drawing/2014/main" id="{96493EE1-236B-411E-9E97-5802AEF560ED}"/>
               </a:ext>
             </a:extLst>
           </p:cNvPr>
@@ -7721,7 +7721,7 @@
           <p:cNvPr id="11" name="">
             <a:extLst xmlns:a="http://schemas.openxmlformats.org/drawingml/2006/main">
               <a:ext uri="{FF2B5EF4-FFF2-40B4-BE49-F238E27FC236}">
-                <a16:creationId xmlns:a16="http://schemas.microsoft.com/office/drawing/2014/main" id="{45959944-DA98-44D3-840E-A610925843F8}"/>
+                <a16:creationId xmlns:a16="http://schemas.microsoft.com/office/drawing/2014/main" id="{1D3916F5-3FA6-46B2-A390-CFFD180A2841}"/>
               </a:ext>
             </a:extLst>
           </p:cNvPr>
@@ -7776,7 +7776,7 @@
                 <a:cs typeface="Aptos"/>
                 <a:hlinkClick xmlns:r="http://schemas.openxmlformats.org/officeDocument/2006/relationships" r:id="rIdSynthAMLDemo"/>
               </a:rPr>
-              <a:t>https://rawcdn.githack.com/yq688m3JT/genAI_final/872e7a818159bc1c1262f42e682d39331a8cc98a/docs/demo.html</a:t>
+              <a:t>https://raw.githack.com/yq688m3JT/genAI_final/main/docs/demo.html</a:t>
             </a:r>
           </a:p>
         </p:txBody>
@@ -7784,7 +7784,7 @@
     </p:spTree>
     <p:extLst>
       <p:ext uri="{BB962C8B-B14F-4D97-AF65-F5344CB8AC3E}">
-        <p14:creationId xmlns:p14="http://schemas.microsoft.com/office/powerpoint/2010/main" val="1118697119"/>
+        <p14:creationId xmlns:p14="http://schemas.microsoft.com/office/powerpoint/2010/main" val="2009338272"/>
       </p:ext>
     </p:extLst>
   </p:cSld>

</xml_diff>

<commit_message>
Pin redesigned demo link
</commit_message>
<xml_diff>
--- a/docs/synthaml-final-presentation.pptx
+++ b/docs/synthaml-final-presentation.pptx
@@ -2,19 +2,19 @@
 <file path=ppt/presentation.xml><?xml version="1.0" encoding="utf-8"?>
 <p:presentation xmlns:p="http://schemas.openxmlformats.org/presentationml/2006/main">
   <p:sldMasterIdLst>
-    <p:sldMasterId xmlns:r="http://schemas.openxmlformats.org/officeDocument/2006/relationships" id="2147483648" r:id="Rdaf3b76fcf25482f"/>
+    <p:sldMasterId xmlns:r="http://schemas.openxmlformats.org/officeDocument/2006/relationships" id="2147483648" r:id="R8e6f890fa9384593"/>
   </p:sldMasterIdLst>
   <p:notesMasterIdLst>
-    <p:notesMasterId xmlns:r="http://schemas.openxmlformats.org/officeDocument/2006/relationships" r:id="R34b64ec6f1054dde"/>
+    <p:notesMasterId xmlns:r="http://schemas.openxmlformats.org/officeDocument/2006/relationships" r:id="Rf25671dfc2394762"/>
   </p:notesMasterIdLst>
   <p:sldIdLst>
-    <p:sldId xmlns:r="http://schemas.openxmlformats.org/officeDocument/2006/relationships" id="256" r:id="R69ec8c8d93a243a1"/>
-    <p:sldId xmlns:r="http://schemas.openxmlformats.org/officeDocument/2006/relationships" id="257" r:id="R46b68bf3d5de4f02"/>
-    <p:sldId xmlns:r="http://schemas.openxmlformats.org/officeDocument/2006/relationships" id="258" r:id="R2485c6ec249045c6"/>
-    <p:sldId xmlns:r="http://schemas.openxmlformats.org/officeDocument/2006/relationships" id="259" r:id="R22fc314cc5274e27"/>
-    <p:sldId xmlns:r="http://schemas.openxmlformats.org/officeDocument/2006/relationships" id="260" r:id="R2d03f7430c3c43cb"/>
-    <p:sldId xmlns:r="http://schemas.openxmlformats.org/officeDocument/2006/relationships" id="261" r:id="Rab9ac60ef1994e61"/>
-    <p:sldId xmlns:r="http://schemas.openxmlformats.org/officeDocument/2006/relationships" id="262" r:id="R5825f9e650e8495e"/>
+    <p:sldId xmlns:r="http://schemas.openxmlformats.org/officeDocument/2006/relationships" id="256" r:id="R0035b99a207b424e"/>
+    <p:sldId xmlns:r="http://schemas.openxmlformats.org/officeDocument/2006/relationships" id="257" r:id="R6d1187d171d24fac"/>
+    <p:sldId xmlns:r="http://schemas.openxmlformats.org/officeDocument/2006/relationships" id="258" r:id="R6cabef28a90d42aa"/>
+    <p:sldId xmlns:r="http://schemas.openxmlformats.org/officeDocument/2006/relationships" id="259" r:id="R29add05c989c48f1"/>
+    <p:sldId xmlns:r="http://schemas.openxmlformats.org/officeDocument/2006/relationships" id="260" r:id="R28af71680ed7411a"/>
+    <p:sldId xmlns:r="http://schemas.openxmlformats.org/officeDocument/2006/relationships" id="261" r:id="R5a865afc304d4ebb"/>
+    <p:sldId xmlns:r="http://schemas.openxmlformats.org/officeDocument/2006/relationships" id="262" r:id="Rb7309ce35f53464d"/>
   </p:sldIdLst>
   <p:sldSz cx="12192000" cy="6858000"/>
   <p:notesSz cx="6858000" cy="9144000"/>
@@ -957,7 +957,7 @@
   </p:cSld>
   <p:clrMap bg1="lt1" tx1="dk1" bg2="lt2" tx2="dk2" accent1="accent1" accent2="accent2" accent3="accent3" accent4="accent4" accent5="accent5" accent6="accent6" hlink="hlink" folHlink="folHlink"/>
   <p:sldLayoutIdLst>
-    <p:sldLayoutId xmlns:r="http://schemas.openxmlformats.org/officeDocument/2006/relationships" id="2147483649" r:id="Rcc8b9e6e978d4566"/>
+    <p:sldLayoutId xmlns:r="http://schemas.openxmlformats.org/officeDocument/2006/relationships" id="2147483649" r:id="Rabd232a2580f446c"/>
   </p:sldLayoutIdLst>
   <p:txStyles>
     <p:titleStyle>
@@ -1256,7 +1256,7 @@
           <p:cNvPr id="1" name="">
             <a:extLst xmlns:a="http://schemas.openxmlformats.org/drawingml/2006/main">
               <a:ext uri="{FF2B5EF4-FFF2-40B4-BE49-F238E27FC236}">
-                <a16:creationId xmlns:a16="http://schemas.microsoft.com/office/drawing/2014/main" id="{F0BF3C0E-D631-4995-8F67-287F7D258883}"/>
+                <a16:creationId xmlns:a16="http://schemas.microsoft.com/office/drawing/2014/main" id="{F981DB7D-1D5F-4DF4-92C5-370E013B0220}"/>
               </a:ext>
             </a:extLst>
           </p:cNvPr>
@@ -1291,7 +1291,7 @@
           <p:cNvPr id="2" name="">
             <a:extLst xmlns:a="http://schemas.openxmlformats.org/drawingml/2006/main">
               <a:ext uri="{FF2B5EF4-FFF2-40B4-BE49-F238E27FC236}">
-                <a16:creationId xmlns:a16="http://schemas.microsoft.com/office/drawing/2014/main" id="{2807F877-4227-456E-B5A6-4D1194886905}"/>
+                <a16:creationId xmlns:a16="http://schemas.microsoft.com/office/drawing/2014/main" id="{82780ABF-7F90-49B0-967D-B75F0CF1E651}"/>
               </a:ext>
             </a:extLst>
           </p:cNvPr>
@@ -1326,7 +1326,7 @@
           <p:cNvPr id="3" name="">
             <a:extLst xmlns:a="http://schemas.openxmlformats.org/drawingml/2006/main">
               <a:ext uri="{FF2B5EF4-FFF2-40B4-BE49-F238E27FC236}">
-                <a16:creationId xmlns:a16="http://schemas.microsoft.com/office/drawing/2014/main" id="{164E92CF-E436-46E6-B071-B6BC50E0B895}"/>
+                <a16:creationId xmlns:a16="http://schemas.microsoft.com/office/drawing/2014/main" id="{BF0466D0-6A31-4F0B-97EE-9368E5FABA35}"/>
               </a:ext>
             </a:extLst>
           </p:cNvPr>
@@ -1390,7 +1390,7 @@
           <p:cNvPr id="4" name="">
             <a:extLst xmlns:a="http://schemas.openxmlformats.org/drawingml/2006/main">
               <a:ext uri="{FF2B5EF4-FFF2-40B4-BE49-F238E27FC236}">
-                <a16:creationId xmlns:a16="http://schemas.microsoft.com/office/drawing/2014/main" id="{0070C72F-6737-436B-9D3D-03B2E2351FD9}"/>
+                <a16:creationId xmlns:a16="http://schemas.microsoft.com/office/drawing/2014/main" id="{E954C99D-E8FC-4497-90FE-5FDDC18B572B}"/>
               </a:ext>
             </a:extLst>
           </p:cNvPr>
@@ -1454,7 +1454,7 @@
           <p:cNvPr id="5" name="">
             <a:extLst xmlns:a="http://schemas.openxmlformats.org/drawingml/2006/main">
               <a:ext uri="{FF2B5EF4-FFF2-40B4-BE49-F238E27FC236}">
-                <a16:creationId xmlns:a16="http://schemas.microsoft.com/office/drawing/2014/main" id="{F9CF7C04-A14D-4653-8E32-C0B28A5DAA06}"/>
+                <a16:creationId xmlns:a16="http://schemas.microsoft.com/office/drawing/2014/main" id="{ABCF14BE-BC60-4167-B8CC-1232F9AB6C67}"/>
               </a:ext>
             </a:extLst>
           </p:cNvPr>
@@ -1518,7 +1518,7 @@
           <p:cNvPr id="6" name="">
             <a:extLst xmlns:a="http://schemas.openxmlformats.org/drawingml/2006/main">
               <a:ext uri="{FF2B5EF4-FFF2-40B4-BE49-F238E27FC236}">
-                <a16:creationId xmlns:a16="http://schemas.microsoft.com/office/drawing/2014/main" id="{726DC522-0D3A-4EAF-89C2-C7D8D660DE0A}"/>
+                <a16:creationId xmlns:a16="http://schemas.microsoft.com/office/drawing/2014/main" id="{B1611404-81CB-46A3-BBE5-924AD03B0358}"/>
               </a:ext>
             </a:extLst>
           </p:cNvPr>
@@ -1553,7 +1553,7 @@
           <p:cNvPr id="7" name="">
             <a:extLst xmlns:a="http://schemas.openxmlformats.org/drawingml/2006/main">
               <a:ext uri="{FF2B5EF4-FFF2-40B4-BE49-F238E27FC236}">
-                <a16:creationId xmlns:a16="http://schemas.microsoft.com/office/drawing/2014/main" id="{FF666F64-7C58-458C-A68A-180D5C124917}"/>
+                <a16:creationId xmlns:a16="http://schemas.microsoft.com/office/drawing/2014/main" id="{2CB203FC-64F0-4C07-AEB8-4E8E76BABD2C}"/>
               </a:ext>
             </a:extLst>
           </p:cNvPr>
@@ -1617,7 +1617,7 @@
           <p:cNvPr id="8" name="">
             <a:extLst xmlns:a="http://schemas.openxmlformats.org/drawingml/2006/main">
               <a:ext uri="{FF2B5EF4-FFF2-40B4-BE49-F238E27FC236}">
-                <a16:creationId xmlns:a16="http://schemas.microsoft.com/office/drawing/2014/main" id="{9F66BDC2-D00E-4144-ABAA-70248C8D9D88}"/>
+                <a16:creationId xmlns:a16="http://schemas.microsoft.com/office/drawing/2014/main" id="{4245871D-66A4-4056-9FA9-8EB7AF0D7497}"/>
               </a:ext>
             </a:extLst>
           </p:cNvPr>
@@ -1681,7 +1681,7 @@
           <p:cNvPr id="9" name="">
             <a:extLst xmlns:a="http://schemas.openxmlformats.org/drawingml/2006/main">
               <a:ext uri="{FF2B5EF4-FFF2-40B4-BE49-F238E27FC236}">
-                <a16:creationId xmlns:a16="http://schemas.microsoft.com/office/drawing/2014/main" id="{6164E661-453D-431C-94AA-24633BD3D8CD}"/>
+                <a16:creationId xmlns:a16="http://schemas.microsoft.com/office/drawing/2014/main" id="{6DD26684-9984-48FD-B120-1C265C0FD520}"/>
               </a:ext>
             </a:extLst>
           </p:cNvPr>
@@ -1745,7 +1745,7 @@
           <p:cNvPr id="10" name="">
             <a:extLst xmlns:a="http://schemas.openxmlformats.org/drawingml/2006/main">
               <a:ext uri="{FF2B5EF4-FFF2-40B4-BE49-F238E27FC236}">
-                <a16:creationId xmlns:a16="http://schemas.microsoft.com/office/drawing/2014/main" id="{FA387EA6-3451-45E6-9442-801FA578DAD5}"/>
+                <a16:creationId xmlns:a16="http://schemas.microsoft.com/office/drawing/2014/main" id="{F20366DA-2B04-4C19-97F0-D5FF6640180D}"/>
               </a:ext>
             </a:extLst>
           </p:cNvPr>
@@ -1809,7 +1809,7 @@
           <p:cNvPr id="11" name="">
             <a:extLst xmlns:a="http://schemas.openxmlformats.org/drawingml/2006/main">
               <a:ext uri="{FF2B5EF4-FFF2-40B4-BE49-F238E27FC236}">
-                <a16:creationId xmlns:a16="http://schemas.microsoft.com/office/drawing/2014/main" id="{F372170F-A434-4752-B26A-5C106BE6102A}"/>
+                <a16:creationId xmlns:a16="http://schemas.microsoft.com/office/drawing/2014/main" id="{1FAB1572-47E2-45BE-860D-405F9D3601A5}"/>
               </a:ext>
             </a:extLst>
           </p:cNvPr>
@@ -1873,7 +1873,7 @@
           <p:cNvPr id="12" name="">
             <a:extLst xmlns:a="http://schemas.openxmlformats.org/drawingml/2006/main">
               <a:ext uri="{FF2B5EF4-FFF2-40B4-BE49-F238E27FC236}">
-                <a16:creationId xmlns:a16="http://schemas.microsoft.com/office/drawing/2014/main" id="{0086C406-7CCD-4337-9ABB-666980B6A205}"/>
+                <a16:creationId xmlns:a16="http://schemas.microsoft.com/office/drawing/2014/main" id="{A9C11B7E-144D-4288-84D6-B5ADD49C1E4A}"/>
               </a:ext>
             </a:extLst>
           </p:cNvPr>
@@ -1937,7 +1937,7 @@
           <p:cNvPr id="13" name="">
             <a:extLst xmlns:a="http://schemas.openxmlformats.org/drawingml/2006/main">
               <a:ext uri="{FF2B5EF4-FFF2-40B4-BE49-F238E27FC236}">
-                <a16:creationId xmlns:a16="http://schemas.microsoft.com/office/drawing/2014/main" id="{B12477C8-83FF-4695-96BB-29AEE6A64C7E}"/>
+                <a16:creationId xmlns:a16="http://schemas.microsoft.com/office/drawing/2014/main" id="{1DA9E195-0C82-4B50-B710-BB30D673065E}"/>
               </a:ext>
             </a:extLst>
           </p:cNvPr>
@@ -1972,7 +1972,7 @@
           <p:cNvPr id="14" name="">
             <a:extLst xmlns:a="http://schemas.openxmlformats.org/drawingml/2006/main">
               <a:ext uri="{FF2B5EF4-FFF2-40B4-BE49-F238E27FC236}">
-                <a16:creationId xmlns:a16="http://schemas.microsoft.com/office/drawing/2014/main" id="{C328182B-37D5-470C-97FF-122C042BB8EE}"/>
+                <a16:creationId xmlns:a16="http://schemas.microsoft.com/office/drawing/2014/main" id="{D527F463-001A-4AFC-AAB7-D13E63E6F98D}"/>
               </a:ext>
             </a:extLst>
           </p:cNvPr>
@@ -2036,7 +2036,7 @@
           <p:cNvPr id="15" name="">
             <a:extLst xmlns:a="http://schemas.openxmlformats.org/drawingml/2006/main">
               <a:ext uri="{FF2B5EF4-FFF2-40B4-BE49-F238E27FC236}">
-                <a16:creationId xmlns:a16="http://schemas.microsoft.com/office/drawing/2014/main" id="{98FC9B98-FE9B-4948-BF1E-5EBC0DC70B69}"/>
+                <a16:creationId xmlns:a16="http://schemas.microsoft.com/office/drawing/2014/main" id="{55EB7BA5-F160-4D5F-9A9D-7E9AA4112EDC}"/>
               </a:ext>
             </a:extLst>
           </p:cNvPr>
@@ -2123,7 +2123,7 @@
           <p:cNvPr id="16" name="">
             <a:extLst xmlns:a="http://schemas.openxmlformats.org/drawingml/2006/main">
               <a:ext uri="{FF2B5EF4-FFF2-40B4-BE49-F238E27FC236}">
-                <a16:creationId xmlns:a16="http://schemas.microsoft.com/office/drawing/2014/main" id="{A289986D-D693-4234-85B4-1CEC3BC98D25}"/>
+                <a16:creationId xmlns:a16="http://schemas.microsoft.com/office/drawing/2014/main" id="{ECD002EA-92C8-4715-9A79-EC8B33E89AE3}"/>
               </a:ext>
             </a:extLst>
           </p:cNvPr>
@@ -2187,7 +2187,7 @@
           <p:cNvPr id="17" name="">
             <a:extLst xmlns:a="http://schemas.openxmlformats.org/drawingml/2006/main">
               <a:ext uri="{FF2B5EF4-FFF2-40B4-BE49-F238E27FC236}">
-                <a16:creationId xmlns:a16="http://schemas.microsoft.com/office/drawing/2014/main" id="{5A9A666B-559C-47A1-BDF2-14B35F75A42E}"/>
+                <a16:creationId xmlns:a16="http://schemas.microsoft.com/office/drawing/2014/main" id="{585013F2-6466-46C4-8905-62C85F73EAD7}"/>
               </a:ext>
             </a:extLst>
           </p:cNvPr>
@@ -2242,7 +2242,7 @@
                 <a:cs typeface="Aptos"/>
                 <a:hlinkClick xmlns:r="http://schemas.openxmlformats.org/officeDocument/2006/relationships" r:id="rIdSynthAMLDemo"/>
               </a:rPr>
-              <a:t>https://raw.githack.com/yq688m3JT/genAI_final/main/docs/demo.html</a:t>
+              <a:t>https://rawcdn.githack.com/yq688m3JT/genAI_final/fa4ed4cc3ab6dd13d10fa40e40ec5e6036816755/docs/demo.html</a:t>
             </a:r>
           </a:p>
         </p:txBody>
@@ -2250,7 +2250,7 @@
     </p:spTree>
     <p:extLst>
       <p:ext uri="{BB962C8B-B14F-4D97-AF65-F5344CB8AC3E}">
-        <p14:creationId xmlns:p14="http://schemas.microsoft.com/office/powerpoint/2010/main" val="780130654"/>
+        <p14:creationId xmlns:p14="http://schemas.microsoft.com/office/powerpoint/2010/main" val="1129252769"/>
       </p:ext>
     </p:extLst>
   </p:cSld>
@@ -2274,7 +2274,7 @@
           <p:cNvPr id="1" name="">
             <a:extLst xmlns:a="http://schemas.openxmlformats.org/drawingml/2006/main">
               <a:ext uri="{FF2B5EF4-FFF2-40B4-BE49-F238E27FC236}">
-                <a16:creationId xmlns:a16="http://schemas.microsoft.com/office/drawing/2014/main" id="{8C3FA446-FF5E-462C-82A8-6082884A9355}"/>
+                <a16:creationId xmlns:a16="http://schemas.microsoft.com/office/drawing/2014/main" id="{34E32C5F-0E66-4E2F-8DC6-316DB7287E50}"/>
               </a:ext>
             </a:extLst>
           </p:cNvPr>
@@ -2309,7 +2309,7 @@
           <p:cNvPr id="2" name="kicker-marker">
             <a:extLst xmlns:a="http://schemas.openxmlformats.org/drawingml/2006/main">
               <a:ext uri="{FF2B5EF4-FFF2-40B4-BE49-F238E27FC236}">
-                <a16:creationId xmlns:a16="http://schemas.microsoft.com/office/drawing/2014/main" id="{729CB8FA-196B-494E-937F-DABAEC88A8DD}"/>
+                <a16:creationId xmlns:a16="http://schemas.microsoft.com/office/drawing/2014/main" id="{24890243-982F-400A-ADEB-DCE1EE4775F1}"/>
               </a:ext>
             </a:extLst>
           </p:cNvPr>
@@ -2344,7 +2344,7 @@
           <p:cNvPr id="3" name="kicker-label">
             <a:extLst xmlns:a="http://schemas.openxmlformats.org/drawingml/2006/main">
               <a:ext uri="{FF2B5EF4-FFF2-40B4-BE49-F238E27FC236}">
-                <a16:creationId xmlns:a16="http://schemas.microsoft.com/office/drawing/2014/main" id="{BE73D080-ABC6-4AC1-9064-D7EFD990A076}"/>
+                <a16:creationId xmlns:a16="http://schemas.microsoft.com/office/drawing/2014/main" id="{7374A4DD-443B-4BFE-BA2D-F9A9915D9DA3}"/>
               </a:ext>
             </a:extLst>
           </p:cNvPr>
@@ -2408,7 +2408,7 @@
           <p:cNvPr id="4" name="">
             <a:extLst xmlns:a="http://schemas.openxmlformats.org/drawingml/2006/main">
               <a:ext uri="{FF2B5EF4-FFF2-40B4-BE49-F238E27FC236}">
-                <a16:creationId xmlns:a16="http://schemas.microsoft.com/office/drawing/2014/main" id="{F75F9250-2276-4FE7-87E0-FD6F59FAB929}"/>
+                <a16:creationId xmlns:a16="http://schemas.microsoft.com/office/drawing/2014/main" id="{70E44901-93E9-4702-B4B5-EDE234B5F102}"/>
               </a:ext>
             </a:extLst>
           </p:cNvPr>
@@ -2472,7 +2472,7 @@
           <p:cNvPr id="5" name="">
             <a:extLst xmlns:a="http://schemas.openxmlformats.org/drawingml/2006/main">
               <a:ext uri="{FF2B5EF4-FFF2-40B4-BE49-F238E27FC236}">
-                <a16:creationId xmlns:a16="http://schemas.microsoft.com/office/drawing/2014/main" id="{47C90833-BF1A-4CF7-9EBB-A524A37F3938}"/>
+                <a16:creationId xmlns:a16="http://schemas.microsoft.com/office/drawing/2014/main" id="{183543D3-F7AF-46AF-AE66-8951887A285A}"/>
               </a:ext>
             </a:extLst>
           </p:cNvPr>
@@ -2536,7 +2536,7 @@
           <p:cNvPr id="6" name="">
             <a:extLst xmlns:a="http://schemas.openxmlformats.org/drawingml/2006/main">
               <a:ext uri="{FF2B5EF4-FFF2-40B4-BE49-F238E27FC236}">
-                <a16:creationId xmlns:a16="http://schemas.microsoft.com/office/drawing/2014/main" id="{AAE00DAA-11EC-4295-8511-DC9C078865EB}"/>
+                <a16:creationId xmlns:a16="http://schemas.microsoft.com/office/drawing/2014/main" id="{FAA79666-0880-4D11-994D-496F056C4AE8}"/>
               </a:ext>
             </a:extLst>
           </p:cNvPr>
@@ -2571,7 +2571,7 @@
           <p:cNvPr id="7" name="">
             <a:extLst xmlns:a="http://schemas.openxmlformats.org/drawingml/2006/main">
               <a:ext uri="{FF2B5EF4-FFF2-40B4-BE49-F238E27FC236}">
-                <a16:creationId xmlns:a16="http://schemas.microsoft.com/office/drawing/2014/main" id="{13308823-1CEC-4D68-B8DE-5AFD25B28462}"/>
+                <a16:creationId xmlns:a16="http://schemas.microsoft.com/office/drawing/2014/main" id="{1B587A9B-73C9-4859-B2EA-1E228DADEEF7}"/>
               </a:ext>
             </a:extLst>
           </p:cNvPr>
@@ -2635,7 +2635,7 @@
           <p:cNvPr id="8" name="">
             <a:extLst xmlns:a="http://schemas.openxmlformats.org/drawingml/2006/main">
               <a:ext uri="{FF2B5EF4-FFF2-40B4-BE49-F238E27FC236}">
-                <a16:creationId xmlns:a16="http://schemas.microsoft.com/office/drawing/2014/main" id="{AC0EDCFD-5B2A-4269-9A21-073E6AB56791}"/>
+                <a16:creationId xmlns:a16="http://schemas.microsoft.com/office/drawing/2014/main" id="{0C6B1AB3-39DD-4951-A8DA-E4E71D712A97}"/>
               </a:ext>
             </a:extLst>
           </p:cNvPr>
@@ -2699,7 +2699,7 @@
           <p:cNvPr id="9" name="">
             <a:extLst xmlns:a="http://schemas.openxmlformats.org/drawingml/2006/main">
               <a:ext uri="{FF2B5EF4-FFF2-40B4-BE49-F238E27FC236}">
-                <a16:creationId xmlns:a16="http://schemas.microsoft.com/office/drawing/2014/main" id="{EBBD3CE9-645E-4E51-BC57-07A997D2D1A5}"/>
+                <a16:creationId xmlns:a16="http://schemas.microsoft.com/office/drawing/2014/main" id="{90095367-0FE4-4C03-9321-DED37D67E276}"/>
               </a:ext>
             </a:extLst>
           </p:cNvPr>
@@ -2763,7 +2763,7 @@
           <p:cNvPr id="10" name="">
             <a:extLst xmlns:a="http://schemas.openxmlformats.org/drawingml/2006/main">
               <a:ext uri="{FF2B5EF4-FFF2-40B4-BE49-F238E27FC236}">
-                <a16:creationId xmlns:a16="http://schemas.microsoft.com/office/drawing/2014/main" id="{FA1FB678-4324-4157-AF48-CCC764602D22}"/>
+                <a16:creationId xmlns:a16="http://schemas.microsoft.com/office/drawing/2014/main" id="{90B18DDC-FF28-45D8-A298-C172639A58C7}"/>
               </a:ext>
             </a:extLst>
           </p:cNvPr>
@@ -2798,7 +2798,7 @@
           <p:cNvPr id="11" name="">
             <a:extLst xmlns:a="http://schemas.openxmlformats.org/drawingml/2006/main">
               <a:ext uri="{FF2B5EF4-FFF2-40B4-BE49-F238E27FC236}">
-                <a16:creationId xmlns:a16="http://schemas.microsoft.com/office/drawing/2014/main" id="{7C4324FA-5055-4CE7-98F2-98E8E1155382}"/>
+                <a16:creationId xmlns:a16="http://schemas.microsoft.com/office/drawing/2014/main" id="{0EC270B0-256E-40D1-BFDC-7872B2D06E3C}"/>
               </a:ext>
             </a:extLst>
           </p:cNvPr>
@@ -2833,7 +2833,7 @@
           <p:cNvPr id="12" name="">
             <a:extLst xmlns:a="http://schemas.openxmlformats.org/drawingml/2006/main">
               <a:ext uri="{FF2B5EF4-FFF2-40B4-BE49-F238E27FC236}">
-                <a16:creationId xmlns:a16="http://schemas.microsoft.com/office/drawing/2014/main" id="{0841FC36-92D5-4281-A465-BBDE3ABC155F}"/>
+                <a16:creationId xmlns:a16="http://schemas.microsoft.com/office/drawing/2014/main" id="{BB5B6AE1-FE6B-4E9E-A8E3-8102071DF223}"/>
               </a:ext>
             </a:extLst>
           </p:cNvPr>
@@ -2868,7 +2868,7 @@
           <p:cNvPr id="13" name="">
             <a:extLst xmlns:a="http://schemas.openxmlformats.org/drawingml/2006/main">
               <a:ext uri="{FF2B5EF4-FFF2-40B4-BE49-F238E27FC236}">
-                <a16:creationId xmlns:a16="http://schemas.microsoft.com/office/drawing/2014/main" id="{0A1A0CC9-3C26-4190-89A1-270FF7387DF7}"/>
+                <a16:creationId xmlns:a16="http://schemas.microsoft.com/office/drawing/2014/main" id="{024D14EF-0FA1-4B46-B4A3-A359D8C09083}"/>
               </a:ext>
             </a:extLst>
           </p:cNvPr>
@@ -2932,7 +2932,7 @@
           <p:cNvPr id="14" name="">
             <a:extLst xmlns:a="http://schemas.openxmlformats.org/drawingml/2006/main">
               <a:ext uri="{FF2B5EF4-FFF2-40B4-BE49-F238E27FC236}">
-                <a16:creationId xmlns:a16="http://schemas.microsoft.com/office/drawing/2014/main" id="{5CFE1FC4-4397-42AB-9012-3B2DB5A0FA47}"/>
+                <a16:creationId xmlns:a16="http://schemas.microsoft.com/office/drawing/2014/main" id="{0990225C-947B-416B-B0DA-42238B1973BA}"/>
               </a:ext>
             </a:extLst>
           </p:cNvPr>
@@ -2996,7 +2996,7 @@
           <p:cNvPr id="15" name="">
             <a:extLst xmlns:a="http://schemas.openxmlformats.org/drawingml/2006/main">
               <a:ext uri="{FF2B5EF4-FFF2-40B4-BE49-F238E27FC236}">
-                <a16:creationId xmlns:a16="http://schemas.microsoft.com/office/drawing/2014/main" id="{A977A768-6305-4EA0-B07E-9C97D106DAE9}"/>
+                <a16:creationId xmlns:a16="http://schemas.microsoft.com/office/drawing/2014/main" id="{4A07DF90-5B4D-4E25-998E-4610BB992D1D}"/>
               </a:ext>
             </a:extLst>
           </p:cNvPr>
@@ -3060,7 +3060,7 @@
           <p:cNvPr id="16" name="">
             <a:extLst xmlns:a="http://schemas.openxmlformats.org/drawingml/2006/main">
               <a:ext uri="{FF2B5EF4-FFF2-40B4-BE49-F238E27FC236}">
-                <a16:creationId xmlns:a16="http://schemas.microsoft.com/office/drawing/2014/main" id="{045DC6D4-51C3-4FA7-93AA-6E68ACAFA2A7}"/>
+                <a16:creationId xmlns:a16="http://schemas.microsoft.com/office/drawing/2014/main" id="{E7E563FD-AC51-490B-92FC-3567C1A2EDD8}"/>
               </a:ext>
             </a:extLst>
           </p:cNvPr>
@@ -3095,7 +3095,7 @@
           <p:cNvPr id="17" name="">
             <a:extLst xmlns:a="http://schemas.openxmlformats.org/drawingml/2006/main">
               <a:ext uri="{FF2B5EF4-FFF2-40B4-BE49-F238E27FC236}">
-                <a16:creationId xmlns:a16="http://schemas.microsoft.com/office/drawing/2014/main" id="{65C3A02A-C4F9-47D6-9C90-8B3C6897EE73}"/>
+                <a16:creationId xmlns:a16="http://schemas.microsoft.com/office/drawing/2014/main" id="{51616A21-0C0C-4EDE-BC90-9A905C792FC6}"/>
               </a:ext>
             </a:extLst>
           </p:cNvPr>
@@ -3130,7 +3130,7 @@
           <p:cNvPr id="18" name="">
             <a:extLst xmlns:a="http://schemas.openxmlformats.org/drawingml/2006/main">
               <a:ext uri="{FF2B5EF4-FFF2-40B4-BE49-F238E27FC236}">
-                <a16:creationId xmlns:a16="http://schemas.microsoft.com/office/drawing/2014/main" id="{C0A10D4A-6383-493C-A525-655DE0F58408}"/>
+                <a16:creationId xmlns:a16="http://schemas.microsoft.com/office/drawing/2014/main" id="{F9DF37B5-9E99-4F17-AD2E-488F8B624ED1}"/>
               </a:ext>
             </a:extLst>
           </p:cNvPr>
@@ -3165,7 +3165,7 @@
           <p:cNvPr id="19" name="">
             <a:extLst xmlns:a="http://schemas.openxmlformats.org/drawingml/2006/main">
               <a:ext uri="{FF2B5EF4-FFF2-40B4-BE49-F238E27FC236}">
-                <a16:creationId xmlns:a16="http://schemas.microsoft.com/office/drawing/2014/main" id="{0FAE7663-E19F-435E-AE3C-B058104A55D7}"/>
+                <a16:creationId xmlns:a16="http://schemas.microsoft.com/office/drawing/2014/main" id="{00B2CF9C-6201-4F47-816A-6E872AA88CE3}"/>
               </a:ext>
             </a:extLst>
           </p:cNvPr>
@@ -3229,7 +3229,7 @@
           <p:cNvPr id="20" name="">
             <a:extLst xmlns:a="http://schemas.openxmlformats.org/drawingml/2006/main">
               <a:ext uri="{FF2B5EF4-FFF2-40B4-BE49-F238E27FC236}">
-                <a16:creationId xmlns:a16="http://schemas.microsoft.com/office/drawing/2014/main" id="{D51B6B4D-A906-4C19-BEBF-9D6F7552A700}"/>
+                <a16:creationId xmlns:a16="http://schemas.microsoft.com/office/drawing/2014/main" id="{953DE2CB-F19C-4BF0-95FE-FA78D5DA48CD}"/>
               </a:ext>
             </a:extLst>
           </p:cNvPr>
@@ -3293,7 +3293,7 @@
           <p:cNvPr id="21" name="">
             <a:extLst xmlns:a="http://schemas.openxmlformats.org/drawingml/2006/main">
               <a:ext uri="{FF2B5EF4-FFF2-40B4-BE49-F238E27FC236}">
-                <a16:creationId xmlns:a16="http://schemas.microsoft.com/office/drawing/2014/main" id="{45D651EE-B32C-4DDF-A1F2-EA4EECBBBE9B}"/>
+                <a16:creationId xmlns:a16="http://schemas.microsoft.com/office/drawing/2014/main" id="{E12FC0B6-1FBD-4572-B2DB-0E17F5E157D0}"/>
               </a:ext>
             </a:extLst>
           </p:cNvPr>
@@ -3357,7 +3357,7 @@
           <p:cNvPr id="22" name="">
             <a:extLst xmlns:a="http://schemas.openxmlformats.org/drawingml/2006/main">
               <a:ext uri="{FF2B5EF4-FFF2-40B4-BE49-F238E27FC236}">
-                <a16:creationId xmlns:a16="http://schemas.microsoft.com/office/drawing/2014/main" id="{7636A15F-2E4E-4840-9532-51E6ED8405D6}"/>
+                <a16:creationId xmlns:a16="http://schemas.microsoft.com/office/drawing/2014/main" id="{EE5DE240-C489-46F3-B0EF-CEF4061E32E2}"/>
               </a:ext>
             </a:extLst>
           </p:cNvPr>
@@ -3390,7 +3390,7 @@
           <p:cNvPr id="23" name="">
             <a:extLst xmlns:a="http://schemas.openxmlformats.org/drawingml/2006/main">
               <a:ext uri="{FF2B5EF4-FFF2-40B4-BE49-F238E27FC236}">
-                <a16:creationId xmlns:a16="http://schemas.microsoft.com/office/drawing/2014/main" id="{78B6C1F8-0F34-40F3-BBF8-9EC562CE0142}"/>
+                <a16:creationId xmlns:a16="http://schemas.microsoft.com/office/drawing/2014/main" id="{E48C3DCD-8CB5-40B2-AEB6-1CCCBC783199}"/>
               </a:ext>
             </a:extLst>
           </p:cNvPr>
@@ -3454,7 +3454,7 @@
           <p:cNvPr id="24" name="">
             <a:extLst xmlns:a="http://schemas.openxmlformats.org/drawingml/2006/main">
               <a:ext uri="{FF2B5EF4-FFF2-40B4-BE49-F238E27FC236}">
-                <a16:creationId xmlns:a16="http://schemas.microsoft.com/office/drawing/2014/main" id="{BC6AC918-9BA9-45E7-84D5-F7DA89B4AB52}"/>
+                <a16:creationId xmlns:a16="http://schemas.microsoft.com/office/drawing/2014/main" id="{49B0F4BC-AA6E-4F5B-96CE-0876ACBA0199}"/>
               </a:ext>
             </a:extLst>
           </p:cNvPr>
@@ -3541,7 +3541,7 @@
           <p:cNvPr id="25" name="">
             <a:extLst xmlns:a="http://schemas.openxmlformats.org/drawingml/2006/main">
               <a:ext uri="{FF2B5EF4-FFF2-40B4-BE49-F238E27FC236}">
-                <a16:creationId xmlns:a16="http://schemas.microsoft.com/office/drawing/2014/main" id="{CF9E8736-852B-4BD8-88F7-38EE9F6FBBE5}"/>
+                <a16:creationId xmlns:a16="http://schemas.microsoft.com/office/drawing/2014/main" id="{DC0102ED-E817-4398-AEA4-B9DDB6A4EAF9}"/>
               </a:ext>
             </a:extLst>
           </p:cNvPr>
@@ -3576,7 +3576,7 @@
           <p:cNvPr id="26" name="">
             <a:extLst xmlns:a="http://schemas.openxmlformats.org/drawingml/2006/main">
               <a:ext uri="{FF2B5EF4-FFF2-40B4-BE49-F238E27FC236}">
-                <a16:creationId xmlns:a16="http://schemas.microsoft.com/office/drawing/2014/main" id="{19ED7AAB-BB39-493F-8106-F657E02EB2B2}"/>
+                <a16:creationId xmlns:a16="http://schemas.microsoft.com/office/drawing/2014/main" id="{593F76DC-A6D0-489A-BA89-66C1EDCA2563}"/>
               </a:ext>
             </a:extLst>
           </p:cNvPr>
@@ -3638,7 +3638,7 @@
     </p:spTree>
     <p:extLst>
       <p:ext uri="{BB962C8B-B14F-4D97-AF65-F5344CB8AC3E}">
-        <p14:creationId xmlns:p14="http://schemas.microsoft.com/office/powerpoint/2010/main" val="1010771440"/>
+        <p14:creationId xmlns:p14="http://schemas.microsoft.com/office/powerpoint/2010/main" val="1191850723"/>
       </p:ext>
     </p:extLst>
   </p:cSld>
@@ -3662,7 +3662,7 @@
           <p:cNvPr id="1" name="">
             <a:extLst xmlns:a="http://schemas.openxmlformats.org/drawingml/2006/main">
               <a:ext uri="{FF2B5EF4-FFF2-40B4-BE49-F238E27FC236}">
-                <a16:creationId xmlns:a16="http://schemas.microsoft.com/office/drawing/2014/main" id="{8024F21F-E8B3-4B88-B73B-3AD53CCDF21D}"/>
+                <a16:creationId xmlns:a16="http://schemas.microsoft.com/office/drawing/2014/main" id="{2D2942A7-5D91-44CB-9E3A-BD7DB24BFD8C}"/>
               </a:ext>
             </a:extLst>
           </p:cNvPr>
@@ -3697,7 +3697,7 @@
           <p:cNvPr id="2" name="kicker-marker">
             <a:extLst xmlns:a="http://schemas.openxmlformats.org/drawingml/2006/main">
               <a:ext uri="{FF2B5EF4-FFF2-40B4-BE49-F238E27FC236}">
-                <a16:creationId xmlns:a16="http://schemas.microsoft.com/office/drawing/2014/main" id="{53D8D7A7-9112-462A-AE9F-CDD415E0B8BC}"/>
+                <a16:creationId xmlns:a16="http://schemas.microsoft.com/office/drawing/2014/main" id="{B03F0EDB-D57A-4A76-A6AC-F0ECF2DA0928}"/>
               </a:ext>
             </a:extLst>
           </p:cNvPr>
@@ -3732,7 +3732,7 @@
           <p:cNvPr id="3" name="kicker-label">
             <a:extLst xmlns:a="http://schemas.openxmlformats.org/drawingml/2006/main">
               <a:ext uri="{FF2B5EF4-FFF2-40B4-BE49-F238E27FC236}">
-                <a16:creationId xmlns:a16="http://schemas.microsoft.com/office/drawing/2014/main" id="{EADDB09D-72C7-4E3E-9649-1D4E1587D279}"/>
+                <a16:creationId xmlns:a16="http://schemas.microsoft.com/office/drawing/2014/main" id="{698E0811-3F78-4449-BBD9-6DD6C606CC24}"/>
               </a:ext>
             </a:extLst>
           </p:cNvPr>
@@ -3796,7 +3796,7 @@
           <p:cNvPr id="4" name="">
             <a:extLst xmlns:a="http://schemas.openxmlformats.org/drawingml/2006/main">
               <a:ext uri="{FF2B5EF4-FFF2-40B4-BE49-F238E27FC236}">
-                <a16:creationId xmlns:a16="http://schemas.microsoft.com/office/drawing/2014/main" id="{3FB6E05C-E85B-4515-A8AD-B62934AF4D85}"/>
+                <a16:creationId xmlns:a16="http://schemas.microsoft.com/office/drawing/2014/main" id="{AA3FDE8B-8C75-45BB-A35E-21FA858125AD}"/>
               </a:ext>
             </a:extLst>
           </p:cNvPr>
@@ -3860,7 +3860,7 @@
           <p:cNvPr id="5" name="">
             <a:extLst xmlns:a="http://schemas.openxmlformats.org/drawingml/2006/main">
               <a:ext uri="{FF2B5EF4-FFF2-40B4-BE49-F238E27FC236}">
-                <a16:creationId xmlns:a16="http://schemas.microsoft.com/office/drawing/2014/main" id="{E6C21EF7-26BD-465F-BD1B-B585D2E8247C}"/>
+                <a16:creationId xmlns:a16="http://schemas.microsoft.com/office/drawing/2014/main" id="{304813D6-C725-492C-98B5-667C244B1602}"/>
               </a:ext>
             </a:extLst>
           </p:cNvPr>
@@ -3895,7 +3895,7 @@
           <p:cNvPr id="6" name="">
             <a:extLst xmlns:a="http://schemas.openxmlformats.org/drawingml/2006/main">
               <a:ext uri="{FF2B5EF4-FFF2-40B4-BE49-F238E27FC236}">
-                <a16:creationId xmlns:a16="http://schemas.microsoft.com/office/drawing/2014/main" id="{77A1BE6A-CA5D-4963-9A6A-FBE35C70B450}"/>
+                <a16:creationId xmlns:a16="http://schemas.microsoft.com/office/drawing/2014/main" id="{8E5BA9DC-431F-4281-B5C6-FB7F42F816F9}"/>
               </a:ext>
             </a:extLst>
           </p:cNvPr>
@@ -3959,7 +3959,7 @@
           <p:cNvPr id="7" name="">
             <a:extLst xmlns:a="http://schemas.openxmlformats.org/drawingml/2006/main">
               <a:ext uri="{FF2B5EF4-FFF2-40B4-BE49-F238E27FC236}">
-                <a16:creationId xmlns:a16="http://schemas.microsoft.com/office/drawing/2014/main" id="{B9436D4C-2F2A-4DD8-B71B-3F20218C3BB0}"/>
+                <a16:creationId xmlns:a16="http://schemas.microsoft.com/office/drawing/2014/main" id="{E38AF221-C954-4375-A861-8CF3DBAD442D}"/>
               </a:ext>
             </a:extLst>
           </p:cNvPr>
@@ -3992,7 +3992,7 @@
           <p:cNvPr id="8" name="">
             <a:extLst xmlns:a="http://schemas.openxmlformats.org/drawingml/2006/main">
               <a:ext uri="{FF2B5EF4-FFF2-40B4-BE49-F238E27FC236}">
-                <a16:creationId xmlns:a16="http://schemas.microsoft.com/office/drawing/2014/main" id="{62A4A815-8CA8-4DD6-B0FA-B37240F68153}"/>
+                <a16:creationId xmlns:a16="http://schemas.microsoft.com/office/drawing/2014/main" id="{120B0903-7A16-45B3-9D14-5BBD36903580}"/>
               </a:ext>
             </a:extLst>
           </p:cNvPr>
@@ -4056,7 +4056,7 @@
           <p:cNvPr id="9" name="">
             <a:extLst xmlns:a="http://schemas.openxmlformats.org/drawingml/2006/main">
               <a:ext uri="{FF2B5EF4-FFF2-40B4-BE49-F238E27FC236}">
-                <a16:creationId xmlns:a16="http://schemas.microsoft.com/office/drawing/2014/main" id="{4BD8DE36-C337-49B3-ADCE-5B10133DDFDE}"/>
+                <a16:creationId xmlns:a16="http://schemas.microsoft.com/office/drawing/2014/main" id="{4F1BE1D7-AFE7-4422-89FA-01243C6C146C}"/>
               </a:ext>
             </a:extLst>
           </p:cNvPr>
@@ -4120,7 +4120,7 @@
           <p:cNvPr id="10" name="">
             <a:extLst xmlns:a="http://schemas.openxmlformats.org/drawingml/2006/main">
               <a:ext uri="{FF2B5EF4-FFF2-40B4-BE49-F238E27FC236}">
-                <a16:creationId xmlns:a16="http://schemas.microsoft.com/office/drawing/2014/main" id="{6B0F5E95-F1CC-4DE4-B841-EE3C0254E302}"/>
+                <a16:creationId xmlns:a16="http://schemas.microsoft.com/office/drawing/2014/main" id="{91F35C37-5413-478D-9492-8B1C800FAE75}"/>
               </a:ext>
             </a:extLst>
           </p:cNvPr>
@@ -4184,7 +4184,7 @@
           <p:cNvPr id="11" name="">
             <a:extLst xmlns:a="http://schemas.openxmlformats.org/drawingml/2006/main">
               <a:ext uri="{FF2B5EF4-FFF2-40B4-BE49-F238E27FC236}">
-                <a16:creationId xmlns:a16="http://schemas.microsoft.com/office/drawing/2014/main" id="{81E417D5-9E0C-4A99-B383-3FFF291B09B1}"/>
+                <a16:creationId xmlns:a16="http://schemas.microsoft.com/office/drawing/2014/main" id="{DE2F2FDA-1331-456D-8A86-96CBD745AE22}"/>
               </a:ext>
             </a:extLst>
           </p:cNvPr>
@@ -4219,7 +4219,7 @@
           <p:cNvPr id="12" name="">
             <a:extLst xmlns:a="http://schemas.openxmlformats.org/drawingml/2006/main">
               <a:ext uri="{FF2B5EF4-FFF2-40B4-BE49-F238E27FC236}">
-                <a16:creationId xmlns:a16="http://schemas.microsoft.com/office/drawing/2014/main" id="{9F3A4CD1-9586-4FBD-9215-CA09D104215E}"/>
+                <a16:creationId xmlns:a16="http://schemas.microsoft.com/office/drawing/2014/main" id="{C77B7205-CB2E-44CF-8089-D01814178CE1}"/>
               </a:ext>
             </a:extLst>
           </p:cNvPr>
@@ -4254,7 +4254,7 @@
           <p:cNvPr id="13" name="">
             <a:extLst xmlns:a="http://schemas.openxmlformats.org/drawingml/2006/main">
               <a:ext uri="{FF2B5EF4-FFF2-40B4-BE49-F238E27FC236}">
-                <a16:creationId xmlns:a16="http://schemas.microsoft.com/office/drawing/2014/main" id="{68BF4E9E-4CD9-417F-8630-755E3238C21A}"/>
+                <a16:creationId xmlns:a16="http://schemas.microsoft.com/office/drawing/2014/main" id="{C60A5104-F844-4C3A-A720-12CEB22BA4F5}"/>
               </a:ext>
             </a:extLst>
           </p:cNvPr>
@@ -4287,7 +4287,7 @@
           <p:cNvPr id="14" name="">
             <a:extLst xmlns:a="http://schemas.openxmlformats.org/drawingml/2006/main">
               <a:ext uri="{FF2B5EF4-FFF2-40B4-BE49-F238E27FC236}">
-                <a16:creationId xmlns:a16="http://schemas.microsoft.com/office/drawing/2014/main" id="{4B96359F-0CEF-4180-85E6-641DCD5930A8}"/>
+                <a16:creationId xmlns:a16="http://schemas.microsoft.com/office/drawing/2014/main" id="{C79AF021-31B4-4BAF-A8CE-47FA7BC45920}"/>
               </a:ext>
             </a:extLst>
           </p:cNvPr>
@@ -4351,7 +4351,7 @@
           <p:cNvPr id="15" name="">
             <a:extLst xmlns:a="http://schemas.openxmlformats.org/drawingml/2006/main">
               <a:ext uri="{FF2B5EF4-FFF2-40B4-BE49-F238E27FC236}">
-                <a16:creationId xmlns:a16="http://schemas.microsoft.com/office/drawing/2014/main" id="{2012ACA9-9AE8-40DB-94E7-EF99DD8500C4}"/>
+                <a16:creationId xmlns:a16="http://schemas.microsoft.com/office/drawing/2014/main" id="{5BCF6330-815A-4866-BA66-1DFD3BD2270E}"/>
               </a:ext>
             </a:extLst>
           </p:cNvPr>
@@ -4415,7 +4415,7 @@
           <p:cNvPr id="16" name="">
             <a:extLst xmlns:a="http://schemas.openxmlformats.org/drawingml/2006/main">
               <a:ext uri="{FF2B5EF4-FFF2-40B4-BE49-F238E27FC236}">
-                <a16:creationId xmlns:a16="http://schemas.microsoft.com/office/drawing/2014/main" id="{40726757-C5D4-475F-A601-D1C0E426703E}"/>
+                <a16:creationId xmlns:a16="http://schemas.microsoft.com/office/drawing/2014/main" id="{5C47B86F-BF91-44CA-81E0-F546E62945FB}"/>
               </a:ext>
             </a:extLst>
           </p:cNvPr>
@@ -4479,7 +4479,7 @@
           <p:cNvPr id="17" name="">
             <a:extLst xmlns:a="http://schemas.openxmlformats.org/drawingml/2006/main">
               <a:ext uri="{FF2B5EF4-FFF2-40B4-BE49-F238E27FC236}">
-                <a16:creationId xmlns:a16="http://schemas.microsoft.com/office/drawing/2014/main" id="{27A88CCD-6D2C-4AB6-BF56-394C0D05C945}"/>
+                <a16:creationId xmlns:a16="http://schemas.microsoft.com/office/drawing/2014/main" id="{6158891B-231E-49AE-BEF9-43D62EF42A9C}"/>
               </a:ext>
             </a:extLst>
           </p:cNvPr>
@@ -4514,7 +4514,7 @@
           <p:cNvPr id="18" name="">
             <a:extLst xmlns:a="http://schemas.openxmlformats.org/drawingml/2006/main">
               <a:ext uri="{FF2B5EF4-FFF2-40B4-BE49-F238E27FC236}">
-                <a16:creationId xmlns:a16="http://schemas.microsoft.com/office/drawing/2014/main" id="{35DA29D6-BDB4-4FE3-A1E7-9C057E5D6A16}"/>
+                <a16:creationId xmlns:a16="http://schemas.microsoft.com/office/drawing/2014/main" id="{F289B166-CFB3-4ABB-8FAE-1A271D029815}"/>
               </a:ext>
             </a:extLst>
           </p:cNvPr>
@@ -4549,7 +4549,7 @@
           <p:cNvPr id="19" name="">
             <a:extLst xmlns:a="http://schemas.openxmlformats.org/drawingml/2006/main">
               <a:ext uri="{FF2B5EF4-FFF2-40B4-BE49-F238E27FC236}">
-                <a16:creationId xmlns:a16="http://schemas.microsoft.com/office/drawing/2014/main" id="{480571B7-ECA4-4B8D-A029-7483201BB5DD}"/>
+                <a16:creationId xmlns:a16="http://schemas.microsoft.com/office/drawing/2014/main" id="{88A989A3-BFE1-4AAE-B5D5-DF90AA959CBD}"/>
               </a:ext>
             </a:extLst>
           </p:cNvPr>
@@ -4582,7 +4582,7 @@
           <p:cNvPr id="20" name="">
             <a:extLst xmlns:a="http://schemas.openxmlformats.org/drawingml/2006/main">
               <a:ext uri="{FF2B5EF4-FFF2-40B4-BE49-F238E27FC236}">
-                <a16:creationId xmlns:a16="http://schemas.microsoft.com/office/drawing/2014/main" id="{E980DC0E-A832-419D-BE90-FA115745CA76}"/>
+                <a16:creationId xmlns:a16="http://schemas.microsoft.com/office/drawing/2014/main" id="{DCBFA746-A4E4-49D5-B851-CA124BC7FA74}"/>
               </a:ext>
             </a:extLst>
           </p:cNvPr>
@@ -4646,7 +4646,7 @@
           <p:cNvPr id="21" name="">
             <a:extLst xmlns:a="http://schemas.openxmlformats.org/drawingml/2006/main">
               <a:ext uri="{FF2B5EF4-FFF2-40B4-BE49-F238E27FC236}">
-                <a16:creationId xmlns:a16="http://schemas.microsoft.com/office/drawing/2014/main" id="{1EC3C9F2-D149-4A95-B622-93203BBD35C3}"/>
+                <a16:creationId xmlns:a16="http://schemas.microsoft.com/office/drawing/2014/main" id="{4F338FD1-AF6F-4F65-8E54-5BED2B6179D4}"/>
               </a:ext>
             </a:extLst>
           </p:cNvPr>
@@ -4710,7 +4710,7 @@
           <p:cNvPr id="22" name="">
             <a:extLst xmlns:a="http://schemas.openxmlformats.org/drawingml/2006/main">
               <a:ext uri="{FF2B5EF4-FFF2-40B4-BE49-F238E27FC236}">
-                <a16:creationId xmlns:a16="http://schemas.microsoft.com/office/drawing/2014/main" id="{6DEE656A-322B-4DE9-A9F0-5731A394300E}"/>
+                <a16:creationId xmlns:a16="http://schemas.microsoft.com/office/drawing/2014/main" id="{176433B6-53DA-4AA3-AE92-4727153436E9}"/>
               </a:ext>
             </a:extLst>
           </p:cNvPr>
@@ -4774,7 +4774,7 @@
           <p:cNvPr id="23" name="">
             <a:extLst xmlns:a="http://schemas.openxmlformats.org/drawingml/2006/main">
               <a:ext uri="{FF2B5EF4-FFF2-40B4-BE49-F238E27FC236}">
-                <a16:creationId xmlns:a16="http://schemas.microsoft.com/office/drawing/2014/main" id="{84578F41-103F-4205-9ABF-8A59285C3DB7}"/>
+                <a16:creationId xmlns:a16="http://schemas.microsoft.com/office/drawing/2014/main" id="{2F4DFFD0-F385-47C8-9A9E-8F8003942F07}"/>
               </a:ext>
             </a:extLst>
           </p:cNvPr>
@@ -4809,7 +4809,7 @@
           <p:cNvPr id="24" name="">
             <a:extLst xmlns:a="http://schemas.openxmlformats.org/drawingml/2006/main">
               <a:ext uri="{FF2B5EF4-FFF2-40B4-BE49-F238E27FC236}">
-                <a16:creationId xmlns:a16="http://schemas.microsoft.com/office/drawing/2014/main" id="{806B02A5-2265-4F6F-8243-AF813DD03975}"/>
+                <a16:creationId xmlns:a16="http://schemas.microsoft.com/office/drawing/2014/main" id="{1E6F386A-5B58-444C-B3EB-E0DA4BF7D265}"/>
               </a:ext>
             </a:extLst>
           </p:cNvPr>
@@ -4844,7 +4844,7 @@
           <p:cNvPr id="25" name="">
             <a:extLst xmlns:a="http://schemas.openxmlformats.org/drawingml/2006/main">
               <a:ext uri="{FF2B5EF4-FFF2-40B4-BE49-F238E27FC236}">
-                <a16:creationId xmlns:a16="http://schemas.microsoft.com/office/drawing/2014/main" id="{3F1B78BA-3CF2-42B5-BD3F-C1D52A88C8A0}"/>
+                <a16:creationId xmlns:a16="http://schemas.microsoft.com/office/drawing/2014/main" id="{74F300ED-DCB5-4A06-B63F-4C53658BCACC}"/>
               </a:ext>
             </a:extLst>
           </p:cNvPr>
@@ -4877,7 +4877,7 @@
           <p:cNvPr id="26" name="">
             <a:extLst xmlns:a="http://schemas.openxmlformats.org/drawingml/2006/main">
               <a:ext uri="{FF2B5EF4-FFF2-40B4-BE49-F238E27FC236}">
-                <a16:creationId xmlns:a16="http://schemas.microsoft.com/office/drawing/2014/main" id="{30886695-2269-4875-B3F9-E067978E3A2A}"/>
+                <a16:creationId xmlns:a16="http://schemas.microsoft.com/office/drawing/2014/main" id="{683834FA-4E5D-4DDB-BB85-2CB383F35A4F}"/>
               </a:ext>
             </a:extLst>
           </p:cNvPr>
@@ -4941,7 +4941,7 @@
           <p:cNvPr id="27" name="">
             <a:extLst xmlns:a="http://schemas.openxmlformats.org/drawingml/2006/main">
               <a:ext uri="{FF2B5EF4-FFF2-40B4-BE49-F238E27FC236}">
-                <a16:creationId xmlns:a16="http://schemas.microsoft.com/office/drawing/2014/main" id="{93E9FE89-D6AE-41DB-91C5-971524E55650}"/>
+                <a16:creationId xmlns:a16="http://schemas.microsoft.com/office/drawing/2014/main" id="{EB050B2B-3CC1-4965-9A05-E2238475A169}"/>
               </a:ext>
             </a:extLst>
           </p:cNvPr>
@@ -5005,7 +5005,7 @@
           <p:cNvPr id="28" name="">
             <a:extLst xmlns:a="http://schemas.openxmlformats.org/drawingml/2006/main">
               <a:ext uri="{FF2B5EF4-FFF2-40B4-BE49-F238E27FC236}">
-                <a16:creationId xmlns:a16="http://schemas.microsoft.com/office/drawing/2014/main" id="{FEF490F7-E674-43E4-8FBA-3D2028FC2E45}"/>
+                <a16:creationId xmlns:a16="http://schemas.microsoft.com/office/drawing/2014/main" id="{28258C98-98FA-40D7-B517-60E9746FFC12}"/>
               </a:ext>
             </a:extLst>
           </p:cNvPr>
@@ -5069,7 +5069,7 @@
           <p:cNvPr id="29" name="">
             <a:extLst xmlns:a="http://schemas.openxmlformats.org/drawingml/2006/main">
               <a:ext uri="{FF2B5EF4-FFF2-40B4-BE49-F238E27FC236}">
-                <a16:creationId xmlns:a16="http://schemas.microsoft.com/office/drawing/2014/main" id="{4ABE55AA-CBEA-4C52-A7B3-CC1F5872685D}"/>
+                <a16:creationId xmlns:a16="http://schemas.microsoft.com/office/drawing/2014/main" id="{F6FAD033-C1A7-4594-BBD3-11DBEBFF8643}"/>
               </a:ext>
             </a:extLst>
           </p:cNvPr>
@@ -5131,7 +5131,7 @@
     </p:spTree>
     <p:extLst>
       <p:ext uri="{BB962C8B-B14F-4D97-AF65-F5344CB8AC3E}">
-        <p14:creationId xmlns:p14="http://schemas.microsoft.com/office/powerpoint/2010/main" val="544708708"/>
+        <p14:creationId xmlns:p14="http://schemas.microsoft.com/office/powerpoint/2010/main" val="761770065"/>
       </p:ext>
     </p:extLst>
   </p:cSld>
@@ -5155,7 +5155,7 @@
           <p:cNvPr id="1" name="">
             <a:extLst xmlns:a="http://schemas.openxmlformats.org/drawingml/2006/main">
               <a:ext uri="{FF2B5EF4-FFF2-40B4-BE49-F238E27FC236}">
-                <a16:creationId xmlns:a16="http://schemas.microsoft.com/office/drawing/2014/main" id="{F3816DFD-5A2B-4750-8A5C-95D204B26278}"/>
+                <a16:creationId xmlns:a16="http://schemas.microsoft.com/office/drawing/2014/main" id="{2F228816-C0F8-4B9E-80B0-F8FC484FD850}"/>
               </a:ext>
             </a:extLst>
           </p:cNvPr>
@@ -5190,7 +5190,7 @@
           <p:cNvPr id="2" name="kicker-marker">
             <a:extLst xmlns:a="http://schemas.openxmlformats.org/drawingml/2006/main">
               <a:ext uri="{FF2B5EF4-FFF2-40B4-BE49-F238E27FC236}">
-                <a16:creationId xmlns:a16="http://schemas.microsoft.com/office/drawing/2014/main" id="{BD498633-C650-4661-A182-4C593E431640}"/>
+                <a16:creationId xmlns:a16="http://schemas.microsoft.com/office/drawing/2014/main" id="{F2F940B0-A1B7-4C53-9C02-AF429FFD4A16}"/>
               </a:ext>
             </a:extLst>
           </p:cNvPr>
@@ -5225,7 +5225,7 @@
           <p:cNvPr id="3" name="kicker-label">
             <a:extLst xmlns:a="http://schemas.openxmlformats.org/drawingml/2006/main">
               <a:ext uri="{FF2B5EF4-FFF2-40B4-BE49-F238E27FC236}">
-                <a16:creationId xmlns:a16="http://schemas.microsoft.com/office/drawing/2014/main" id="{BB4F3389-CAC9-4AB3-8B51-9C01916AEF0F}"/>
+                <a16:creationId xmlns:a16="http://schemas.microsoft.com/office/drawing/2014/main" id="{9DEA610D-70A2-41A3-8E4E-89D37DE0266C}"/>
               </a:ext>
             </a:extLst>
           </p:cNvPr>
@@ -5289,7 +5289,7 @@
           <p:cNvPr id="4" name="">
             <a:extLst xmlns:a="http://schemas.openxmlformats.org/drawingml/2006/main">
               <a:ext uri="{FF2B5EF4-FFF2-40B4-BE49-F238E27FC236}">
-                <a16:creationId xmlns:a16="http://schemas.microsoft.com/office/drawing/2014/main" id="{5ADCE9F5-DD02-4F31-9A3D-B41894F8364B}"/>
+                <a16:creationId xmlns:a16="http://schemas.microsoft.com/office/drawing/2014/main" id="{B8A1A6D2-29D3-4FA0-BF5E-3C2608683F40}"/>
               </a:ext>
             </a:extLst>
           </p:cNvPr>
@@ -5353,7 +5353,7 @@
           <p:cNvPr id="5" name="">
             <a:extLst xmlns:a="http://schemas.openxmlformats.org/drawingml/2006/main">
               <a:ext uri="{FF2B5EF4-FFF2-40B4-BE49-F238E27FC236}">
-                <a16:creationId xmlns:a16="http://schemas.microsoft.com/office/drawing/2014/main" id="{8A2F6C8C-610B-4003-BF5F-97974C9FF4BF}"/>
+                <a16:creationId xmlns:a16="http://schemas.microsoft.com/office/drawing/2014/main" id="{2CE76947-2F4A-44B7-A392-9EC4AD38593A}"/>
               </a:ext>
             </a:extLst>
           </p:cNvPr>
@@ -5388,7 +5388,7 @@
           <p:cNvPr id="6" name="">
             <a:extLst xmlns:a="http://schemas.openxmlformats.org/drawingml/2006/main">
               <a:ext uri="{FF2B5EF4-FFF2-40B4-BE49-F238E27FC236}">
-                <a16:creationId xmlns:a16="http://schemas.microsoft.com/office/drawing/2014/main" id="{1DD0BCF9-A32B-4032-8B48-0363221E8D98}"/>
+                <a16:creationId xmlns:a16="http://schemas.microsoft.com/office/drawing/2014/main" id="{16122CB7-875A-4ABC-B762-36AD766B0163}"/>
               </a:ext>
             </a:extLst>
           </p:cNvPr>
@@ -5452,7 +5452,7 @@
           <p:cNvPr id="7" name="">
             <a:extLst xmlns:a="http://schemas.openxmlformats.org/drawingml/2006/main">
               <a:ext uri="{FF2B5EF4-FFF2-40B4-BE49-F238E27FC236}">
-                <a16:creationId xmlns:a16="http://schemas.microsoft.com/office/drawing/2014/main" id="{1B674A24-E276-4237-9C26-F05EBA549C33}"/>
+                <a16:creationId xmlns:a16="http://schemas.microsoft.com/office/drawing/2014/main" id="{292E2E31-24C4-441B-AD81-011E844A511F}"/>
               </a:ext>
             </a:extLst>
           </p:cNvPr>
@@ -5516,7 +5516,7 @@
           <p:cNvPr id="8" name="">
             <a:extLst xmlns:a="http://schemas.openxmlformats.org/drawingml/2006/main">
               <a:ext uri="{FF2B5EF4-FFF2-40B4-BE49-F238E27FC236}">
-                <a16:creationId xmlns:a16="http://schemas.microsoft.com/office/drawing/2014/main" id="{1753ADAD-EFA0-4F92-939F-B554833AB6BD}"/>
+                <a16:creationId xmlns:a16="http://schemas.microsoft.com/office/drawing/2014/main" id="{A325BDE1-C025-440A-AD4F-72D13A2E51A3}"/>
               </a:ext>
             </a:extLst>
           </p:cNvPr>
@@ -5580,7 +5580,7 @@
           <p:cNvPr id="9" name="">
             <a:extLst xmlns:a="http://schemas.openxmlformats.org/drawingml/2006/main">
               <a:ext uri="{FF2B5EF4-FFF2-40B4-BE49-F238E27FC236}">
-                <a16:creationId xmlns:a16="http://schemas.microsoft.com/office/drawing/2014/main" id="{30C18514-F2BA-48A4-990C-52C422576669}"/>
+                <a16:creationId xmlns:a16="http://schemas.microsoft.com/office/drawing/2014/main" id="{660C4A3A-6063-4853-BD20-0B167C7182F6}"/>
               </a:ext>
             </a:extLst>
           </p:cNvPr>
@@ -5615,7 +5615,7 @@
           <p:cNvPr id="10" name="">
             <a:extLst xmlns:a="http://schemas.openxmlformats.org/drawingml/2006/main">
               <a:ext uri="{FF2B5EF4-FFF2-40B4-BE49-F238E27FC236}">
-                <a16:creationId xmlns:a16="http://schemas.microsoft.com/office/drawing/2014/main" id="{3B92F629-4CAB-4EE0-81C9-2869D4124BD1}"/>
+                <a16:creationId xmlns:a16="http://schemas.microsoft.com/office/drawing/2014/main" id="{C458299C-C3F9-4946-A3EE-BF93473F3FC9}"/>
               </a:ext>
             </a:extLst>
           </p:cNvPr>
@@ -5650,7 +5650,7 @@
           <p:cNvPr id="11" name="">
             <a:extLst xmlns:a="http://schemas.openxmlformats.org/drawingml/2006/main">
               <a:ext uri="{FF2B5EF4-FFF2-40B4-BE49-F238E27FC236}">
-                <a16:creationId xmlns:a16="http://schemas.microsoft.com/office/drawing/2014/main" id="{3363B197-474C-48F8-B279-8639EDA4157D}"/>
+                <a16:creationId xmlns:a16="http://schemas.microsoft.com/office/drawing/2014/main" id="{6C5021B3-CF14-4A23-80E5-284D2D730E2B}"/>
               </a:ext>
             </a:extLst>
           </p:cNvPr>
@@ -5714,7 +5714,7 @@
           <p:cNvPr id="12" name="">
             <a:extLst xmlns:a="http://schemas.openxmlformats.org/drawingml/2006/main">
               <a:ext uri="{FF2B5EF4-FFF2-40B4-BE49-F238E27FC236}">
-                <a16:creationId xmlns:a16="http://schemas.microsoft.com/office/drawing/2014/main" id="{0E91A1F9-6844-4429-9FF8-E6C7F63F2714}"/>
+                <a16:creationId xmlns:a16="http://schemas.microsoft.com/office/drawing/2014/main" id="{B37692B5-165C-4EBD-B746-102C3AC46ADE}"/>
               </a:ext>
             </a:extLst>
           </p:cNvPr>
@@ -5778,7 +5778,7 @@
           <p:cNvPr id="13" name="">
             <a:extLst xmlns:a="http://schemas.openxmlformats.org/drawingml/2006/main">
               <a:ext uri="{FF2B5EF4-FFF2-40B4-BE49-F238E27FC236}">
-                <a16:creationId xmlns:a16="http://schemas.microsoft.com/office/drawing/2014/main" id="{26DD0DDA-97EC-49FD-B665-D83CAC3D0C1B}"/>
+                <a16:creationId xmlns:a16="http://schemas.microsoft.com/office/drawing/2014/main" id="{4BACE1E4-5FA0-4451-A4A1-9DBF3E53A8F4}"/>
               </a:ext>
             </a:extLst>
           </p:cNvPr>
@@ -5813,7 +5813,7 @@
           <p:cNvPr id="14" name="">
             <a:extLst xmlns:a="http://schemas.openxmlformats.org/drawingml/2006/main">
               <a:ext uri="{FF2B5EF4-FFF2-40B4-BE49-F238E27FC236}">
-                <a16:creationId xmlns:a16="http://schemas.microsoft.com/office/drawing/2014/main" id="{1EEF5281-C79F-4DA9-95D6-B7A3A48F6004}"/>
+                <a16:creationId xmlns:a16="http://schemas.microsoft.com/office/drawing/2014/main" id="{EC3C961E-A454-492A-BA91-E387E96FAA6F}"/>
               </a:ext>
             </a:extLst>
           </p:cNvPr>
@@ -5848,7 +5848,7 @@
           <p:cNvPr id="15" name="">
             <a:extLst xmlns:a="http://schemas.openxmlformats.org/drawingml/2006/main">
               <a:ext uri="{FF2B5EF4-FFF2-40B4-BE49-F238E27FC236}">
-                <a16:creationId xmlns:a16="http://schemas.microsoft.com/office/drawing/2014/main" id="{C3DD7A68-23CD-47AC-BE7E-5E4D9C57E502}"/>
+                <a16:creationId xmlns:a16="http://schemas.microsoft.com/office/drawing/2014/main" id="{F8DE807C-DF17-4453-9E19-D2B4EE3A1554}"/>
               </a:ext>
             </a:extLst>
           </p:cNvPr>
@@ -5912,7 +5912,7 @@
           <p:cNvPr id="16" name="">
             <a:extLst xmlns:a="http://schemas.openxmlformats.org/drawingml/2006/main">
               <a:ext uri="{FF2B5EF4-FFF2-40B4-BE49-F238E27FC236}">
-                <a16:creationId xmlns:a16="http://schemas.microsoft.com/office/drawing/2014/main" id="{4F622E0E-3BC9-4DD4-8B89-BAAAA37A7E24}"/>
+                <a16:creationId xmlns:a16="http://schemas.microsoft.com/office/drawing/2014/main" id="{9F6F930F-5F88-4456-AB7C-63B361481B6B}"/>
               </a:ext>
             </a:extLst>
           </p:cNvPr>
@@ -5947,7 +5947,7 @@
           <p:cNvPr id="17" name="">
             <a:extLst xmlns:a="http://schemas.openxmlformats.org/drawingml/2006/main">
               <a:ext uri="{FF2B5EF4-FFF2-40B4-BE49-F238E27FC236}">
-                <a16:creationId xmlns:a16="http://schemas.microsoft.com/office/drawing/2014/main" id="{9BD2C12A-6784-4780-9C4F-FB2C69BEA5A3}"/>
+                <a16:creationId xmlns:a16="http://schemas.microsoft.com/office/drawing/2014/main" id="{E4667241-FBF6-45E9-8351-DA787F7B16A2}"/>
               </a:ext>
             </a:extLst>
           </p:cNvPr>
@@ -6011,7 +6011,7 @@
           <p:cNvPr id="18" name="">
             <a:extLst xmlns:a="http://schemas.openxmlformats.org/drawingml/2006/main">
               <a:ext uri="{FF2B5EF4-FFF2-40B4-BE49-F238E27FC236}">
-                <a16:creationId xmlns:a16="http://schemas.microsoft.com/office/drawing/2014/main" id="{B0C50847-79CB-4AE4-B25D-458904ECECC4}"/>
+                <a16:creationId xmlns:a16="http://schemas.microsoft.com/office/drawing/2014/main" id="{5A689B89-8808-4A85-BF3F-EE2B9AA8BE09}"/>
               </a:ext>
             </a:extLst>
           </p:cNvPr>
@@ -6046,7 +6046,7 @@
           <p:cNvPr id="19" name="">
             <a:extLst xmlns:a="http://schemas.openxmlformats.org/drawingml/2006/main">
               <a:ext uri="{FF2B5EF4-FFF2-40B4-BE49-F238E27FC236}">
-                <a16:creationId xmlns:a16="http://schemas.microsoft.com/office/drawing/2014/main" id="{AA80B0D5-00AF-40C0-BE34-6593FA84136D}"/>
+                <a16:creationId xmlns:a16="http://schemas.microsoft.com/office/drawing/2014/main" id="{4F230C86-359B-4620-86FD-5C3347E2A26C}"/>
               </a:ext>
             </a:extLst>
           </p:cNvPr>
@@ -6110,7 +6110,7 @@
           <p:cNvPr id="20" name="">
             <a:extLst xmlns:a="http://schemas.openxmlformats.org/drawingml/2006/main">
               <a:ext uri="{FF2B5EF4-FFF2-40B4-BE49-F238E27FC236}">
-                <a16:creationId xmlns:a16="http://schemas.microsoft.com/office/drawing/2014/main" id="{F99603C0-DB0B-44A9-BF63-BA45558AE573}"/>
+                <a16:creationId xmlns:a16="http://schemas.microsoft.com/office/drawing/2014/main" id="{1D84D4C2-732F-4A6B-ADCB-7563C48AB3D5}"/>
               </a:ext>
             </a:extLst>
           </p:cNvPr>
@@ -6145,7 +6145,7 @@
           <p:cNvPr id="21" name="">
             <a:extLst xmlns:a="http://schemas.openxmlformats.org/drawingml/2006/main">
               <a:ext uri="{FF2B5EF4-FFF2-40B4-BE49-F238E27FC236}">
-                <a16:creationId xmlns:a16="http://schemas.microsoft.com/office/drawing/2014/main" id="{933D4377-438B-44D8-A977-95281F5E2725}"/>
+                <a16:creationId xmlns:a16="http://schemas.microsoft.com/office/drawing/2014/main" id="{C9D43B53-23E5-4E53-8563-2637A7A06F0B}"/>
               </a:ext>
             </a:extLst>
           </p:cNvPr>
@@ -6209,7 +6209,7 @@
           <p:cNvPr id="22" name="">
             <a:extLst xmlns:a="http://schemas.openxmlformats.org/drawingml/2006/main">
               <a:ext uri="{FF2B5EF4-FFF2-40B4-BE49-F238E27FC236}">
-                <a16:creationId xmlns:a16="http://schemas.microsoft.com/office/drawing/2014/main" id="{835E8642-CFB1-4DE6-B423-3A92AC465596}"/>
+                <a16:creationId xmlns:a16="http://schemas.microsoft.com/office/drawing/2014/main" id="{DC2A2930-ED65-4295-9EF9-F412751FA5E7}"/>
               </a:ext>
             </a:extLst>
           </p:cNvPr>
@@ -6244,7 +6244,7 @@
           <p:cNvPr id="23" name="">
             <a:extLst xmlns:a="http://schemas.openxmlformats.org/drawingml/2006/main">
               <a:ext uri="{FF2B5EF4-FFF2-40B4-BE49-F238E27FC236}">
-                <a16:creationId xmlns:a16="http://schemas.microsoft.com/office/drawing/2014/main" id="{FE073F80-5448-4CFF-A383-1B7F3A0D60C5}"/>
+                <a16:creationId xmlns:a16="http://schemas.microsoft.com/office/drawing/2014/main" id="{12AB8936-97B7-4D34-9D90-92E76CCA954D}"/>
               </a:ext>
             </a:extLst>
           </p:cNvPr>
@@ -6308,7 +6308,7 @@
           <p:cNvPr id="24" name="">
             <a:extLst xmlns:a="http://schemas.openxmlformats.org/drawingml/2006/main">
               <a:ext uri="{FF2B5EF4-FFF2-40B4-BE49-F238E27FC236}">
-                <a16:creationId xmlns:a16="http://schemas.microsoft.com/office/drawing/2014/main" id="{D451F19E-FDF0-42BA-9119-75112D959FB0}"/>
+                <a16:creationId xmlns:a16="http://schemas.microsoft.com/office/drawing/2014/main" id="{59A9D98D-237E-4EFE-BC91-26A160BA09C4}"/>
               </a:ext>
             </a:extLst>
           </p:cNvPr>
@@ -6343,7 +6343,7 @@
           <p:cNvPr id="25" name="">
             <a:extLst xmlns:a="http://schemas.openxmlformats.org/drawingml/2006/main">
               <a:ext uri="{FF2B5EF4-FFF2-40B4-BE49-F238E27FC236}">
-                <a16:creationId xmlns:a16="http://schemas.microsoft.com/office/drawing/2014/main" id="{55111A45-C365-4AC6-A47E-0207F5AEB635}"/>
+                <a16:creationId xmlns:a16="http://schemas.microsoft.com/office/drawing/2014/main" id="{657E04A4-5063-47AD-AC42-69F42A3EE438}"/>
               </a:ext>
             </a:extLst>
           </p:cNvPr>
@@ -6407,7 +6407,7 @@
           <p:cNvPr id="26" name="">
             <a:extLst xmlns:a="http://schemas.openxmlformats.org/drawingml/2006/main">
               <a:ext uri="{FF2B5EF4-FFF2-40B4-BE49-F238E27FC236}">
-                <a16:creationId xmlns:a16="http://schemas.microsoft.com/office/drawing/2014/main" id="{C5B63EBF-6611-463F-8B85-C6C0ADDA3C03}"/>
+                <a16:creationId xmlns:a16="http://schemas.microsoft.com/office/drawing/2014/main" id="{56B306DF-9B76-4EDB-A059-4EBD22C35038}"/>
               </a:ext>
             </a:extLst>
           </p:cNvPr>
@@ -6492,7 +6492,7 @@
     </p:spTree>
     <p:extLst>
       <p:ext uri="{BB962C8B-B14F-4D97-AF65-F5344CB8AC3E}">
-        <p14:creationId xmlns:p14="http://schemas.microsoft.com/office/powerpoint/2010/main" val="1792961260"/>
+        <p14:creationId xmlns:p14="http://schemas.microsoft.com/office/powerpoint/2010/main" val="1710507550"/>
       </p:ext>
     </p:extLst>
   </p:cSld>
@@ -6516,7 +6516,7 @@
           <p:cNvPr id="1" name="">
             <a:extLst xmlns:a="http://schemas.openxmlformats.org/drawingml/2006/main">
               <a:ext uri="{FF2B5EF4-FFF2-40B4-BE49-F238E27FC236}">
-                <a16:creationId xmlns:a16="http://schemas.microsoft.com/office/drawing/2014/main" id="{CAB9691B-2B3B-40EA-A679-4AEA72C171E5}"/>
+                <a16:creationId xmlns:a16="http://schemas.microsoft.com/office/drawing/2014/main" id="{4B2F5B95-C758-4950-BFCC-94CC8EF914E3}"/>
               </a:ext>
             </a:extLst>
           </p:cNvPr>
@@ -6551,7 +6551,7 @@
           <p:cNvPr id="2" name="kicker-marker">
             <a:extLst xmlns:a="http://schemas.openxmlformats.org/drawingml/2006/main">
               <a:ext uri="{FF2B5EF4-FFF2-40B4-BE49-F238E27FC236}">
-                <a16:creationId xmlns:a16="http://schemas.microsoft.com/office/drawing/2014/main" id="{ABA804BB-C2DC-42DA-A24C-388685A58796}"/>
+                <a16:creationId xmlns:a16="http://schemas.microsoft.com/office/drawing/2014/main" id="{9AFE4CEA-0E5C-47EF-81C2-C9609048E6BB}"/>
               </a:ext>
             </a:extLst>
           </p:cNvPr>
@@ -6586,7 +6586,7 @@
           <p:cNvPr id="3" name="kicker-label">
             <a:extLst xmlns:a="http://schemas.openxmlformats.org/drawingml/2006/main">
               <a:ext uri="{FF2B5EF4-FFF2-40B4-BE49-F238E27FC236}">
-                <a16:creationId xmlns:a16="http://schemas.microsoft.com/office/drawing/2014/main" id="{0A0FCD88-B225-4097-AD36-0F38069E700E}"/>
+                <a16:creationId xmlns:a16="http://schemas.microsoft.com/office/drawing/2014/main" id="{919CD75A-347F-469F-8BBC-49A8C588C1A0}"/>
               </a:ext>
             </a:extLst>
           </p:cNvPr>
@@ -6650,7 +6650,7 @@
           <p:cNvPr id="4" name="">
             <a:extLst xmlns:a="http://schemas.openxmlformats.org/drawingml/2006/main">
               <a:ext uri="{FF2B5EF4-FFF2-40B4-BE49-F238E27FC236}">
-                <a16:creationId xmlns:a16="http://schemas.microsoft.com/office/drawing/2014/main" id="{1C9F3808-9600-4D3C-BD95-8BBD196F40BF}"/>
+                <a16:creationId xmlns:a16="http://schemas.microsoft.com/office/drawing/2014/main" id="{B878E681-8F7B-4B9B-A46B-CDFE8126A78B}"/>
               </a:ext>
             </a:extLst>
           </p:cNvPr>
@@ -6714,7 +6714,7 @@
           <p:cNvPr id="5" name="">
             <a:extLst xmlns:a="http://schemas.openxmlformats.org/drawingml/2006/main">
               <a:ext uri="{FF2B5EF4-FFF2-40B4-BE49-F238E27FC236}">
-                <a16:creationId xmlns:a16="http://schemas.microsoft.com/office/drawing/2014/main" id="{F286F07B-3CB1-4F30-8299-6C64BCF4BCB7}"/>
+                <a16:creationId xmlns:a16="http://schemas.microsoft.com/office/drawing/2014/main" id="{584E0F91-77F9-4E83-8DD3-BE6BB1473010}"/>
               </a:ext>
             </a:extLst>
           </p:cNvPr>
@@ -6749,7 +6749,7 @@
           <p:cNvPr id="6" name="">
             <a:extLst xmlns:a="http://schemas.openxmlformats.org/drawingml/2006/main">
               <a:ext uri="{FF2B5EF4-FFF2-40B4-BE49-F238E27FC236}">
-                <a16:creationId xmlns:a16="http://schemas.microsoft.com/office/drawing/2014/main" id="{32B4C210-8ED7-4C0F-A20E-5828EF5A41DE}"/>
+                <a16:creationId xmlns:a16="http://schemas.microsoft.com/office/drawing/2014/main" id="{A23E87E1-061A-4BA0-A8D6-6386BCEF5D15}"/>
               </a:ext>
             </a:extLst>
           </p:cNvPr>
@@ -6817,7 +6817,7 @@
           <p:nvPr/>
         </p:nvPicPr>
         <p:blipFill>
-          <a:blip xmlns:r="http://schemas.openxmlformats.org/officeDocument/2006/relationships" xmlns:a="http://schemas.openxmlformats.org/drawingml/2006/main" r:embed="Rf745ef44a0c048a1"/>
+          <a:blip xmlns:r="http://schemas.openxmlformats.org/officeDocument/2006/relationships" xmlns:a="http://schemas.openxmlformats.org/drawingml/2006/main" r:embed="Ra35b5d37a0c74524"/>
           <a:stretch xmlns:a="http://schemas.openxmlformats.org/drawingml/2006/main"/>
         </p:blipFill>
         <p:spPr>
@@ -6835,7 +6835,7 @@
           <p:cNvPr id="8" name="">
             <a:extLst xmlns:a="http://schemas.openxmlformats.org/drawingml/2006/main">
               <a:ext uri="{FF2B5EF4-FFF2-40B4-BE49-F238E27FC236}">
-                <a16:creationId xmlns:a16="http://schemas.microsoft.com/office/drawing/2014/main" id="{F80E6954-18C2-4309-8E9F-7B6F4BADD9F7}"/>
+                <a16:creationId xmlns:a16="http://schemas.microsoft.com/office/drawing/2014/main" id="{6384B585-5A7E-4616-989E-1886EFF55129}"/>
               </a:ext>
             </a:extLst>
           </p:cNvPr>
@@ -6868,7 +6868,7 @@
     </p:spTree>
     <p:extLst>
       <p:ext uri="{BB962C8B-B14F-4D97-AF65-F5344CB8AC3E}">
-        <p14:creationId xmlns:p14="http://schemas.microsoft.com/office/powerpoint/2010/main" val="1016807403"/>
+        <p14:creationId xmlns:p14="http://schemas.microsoft.com/office/powerpoint/2010/main" val="1139477270"/>
       </p:ext>
     </p:extLst>
   </p:cSld>
@@ -6892,7 +6892,7 @@
           <p:cNvPr id="1" name="">
             <a:extLst xmlns:a="http://schemas.openxmlformats.org/drawingml/2006/main">
               <a:ext uri="{FF2B5EF4-FFF2-40B4-BE49-F238E27FC236}">
-                <a16:creationId xmlns:a16="http://schemas.microsoft.com/office/drawing/2014/main" id="{272A7FA1-6E6A-4205-8402-79FDBA043CC6}"/>
+                <a16:creationId xmlns:a16="http://schemas.microsoft.com/office/drawing/2014/main" id="{99223DB3-143B-4762-9C6D-F27639D8AD5C}"/>
               </a:ext>
             </a:extLst>
           </p:cNvPr>
@@ -6927,7 +6927,7 @@
           <p:cNvPr id="2" name="kicker-marker">
             <a:extLst xmlns:a="http://schemas.openxmlformats.org/drawingml/2006/main">
               <a:ext uri="{FF2B5EF4-FFF2-40B4-BE49-F238E27FC236}">
-                <a16:creationId xmlns:a16="http://schemas.microsoft.com/office/drawing/2014/main" id="{AB99CEBB-5D58-4675-A14A-164AF2B4EA1F}"/>
+                <a16:creationId xmlns:a16="http://schemas.microsoft.com/office/drawing/2014/main" id="{7C16F9A2-BA9D-4577-AF1F-5DDEA54C2323}"/>
               </a:ext>
             </a:extLst>
           </p:cNvPr>
@@ -6962,7 +6962,7 @@
           <p:cNvPr id="3" name="kicker-label">
             <a:extLst xmlns:a="http://schemas.openxmlformats.org/drawingml/2006/main">
               <a:ext uri="{FF2B5EF4-FFF2-40B4-BE49-F238E27FC236}">
-                <a16:creationId xmlns:a16="http://schemas.microsoft.com/office/drawing/2014/main" id="{15E4C833-D87A-431F-A39E-FBBC44A97344}"/>
+                <a16:creationId xmlns:a16="http://schemas.microsoft.com/office/drawing/2014/main" id="{899CB4BA-F29F-48C2-A123-E105B826C0C7}"/>
               </a:ext>
             </a:extLst>
           </p:cNvPr>
@@ -7026,7 +7026,7 @@
           <p:cNvPr id="4" name="">
             <a:extLst xmlns:a="http://schemas.openxmlformats.org/drawingml/2006/main">
               <a:ext uri="{FF2B5EF4-FFF2-40B4-BE49-F238E27FC236}">
-                <a16:creationId xmlns:a16="http://schemas.microsoft.com/office/drawing/2014/main" id="{B67334C6-3868-40B2-9844-80CC159C8E3A}"/>
+                <a16:creationId xmlns:a16="http://schemas.microsoft.com/office/drawing/2014/main" id="{2A83B115-6710-418A-94CA-851CD24985D9}"/>
               </a:ext>
             </a:extLst>
           </p:cNvPr>
@@ -7090,7 +7090,7 @@
           <p:cNvPr id="5" name="">
             <a:extLst xmlns:a="http://schemas.openxmlformats.org/drawingml/2006/main">
               <a:ext uri="{FF2B5EF4-FFF2-40B4-BE49-F238E27FC236}">
-                <a16:creationId xmlns:a16="http://schemas.microsoft.com/office/drawing/2014/main" id="{27C81F29-7534-43F6-BB39-DC5CD333EB31}"/>
+                <a16:creationId xmlns:a16="http://schemas.microsoft.com/office/drawing/2014/main" id="{BF74DEFA-10D8-4EAC-91E0-9411CFF48972}"/>
               </a:ext>
             </a:extLst>
           </p:cNvPr>
@@ -7125,7 +7125,7 @@
           <p:cNvPr id="6" name="">
             <a:extLst xmlns:a="http://schemas.openxmlformats.org/drawingml/2006/main">
               <a:ext uri="{FF2B5EF4-FFF2-40B4-BE49-F238E27FC236}">
-                <a16:creationId xmlns:a16="http://schemas.microsoft.com/office/drawing/2014/main" id="{C3E6249F-1DF0-4082-AE6F-9C6FF010A2B3}"/>
+                <a16:creationId xmlns:a16="http://schemas.microsoft.com/office/drawing/2014/main" id="{08A54436-D023-4835-A9A8-BF703E122705}"/>
               </a:ext>
             </a:extLst>
           </p:cNvPr>
@@ -7193,7 +7193,7 @@
           <p:nvPr/>
         </p:nvPicPr>
         <p:blipFill>
-          <a:blip xmlns:r="http://schemas.openxmlformats.org/officeDocument/2006/relationships" xmlns:a="http://schemas.openxmlformats.org/drawingml/2006/main" r:embed="R4d778113298c4041"/>
+          <a:blip xmlns:r="http://schemas.openxmlformats.org/officeDocument/2006/relationships" xmlns:a="http://schemas.openxmlformats.org/drawingml/2006/main" r:embed="Reba701fc9b234190"/>
           <a:stretch xmlns:a="http://schemas.openxmlformats.org/drawingml/2006/main"/>
         </p:blipFill>
         <p:spPr>
@@ -7211,7 +7211,7 @@
           <p:cNvPr id="8" name="">
             <a:extLst xmlns:a="http://schemas.openxmlformats.org/drawingml/2006/main">
               <a:ext uri="{FF2B5EF4-FFF2-40B4-BE49-F238E27FC236}">
-                <a16:creationId xmlns:a16="http://schemas.microsoft.com/office/drawing/2014/main" id="{56A5B6EE-4496-4913-B8AE-05E1D2999923}"/>
+                <a16:creationId xmlns:a16="http://schemas.microsoft.com/office/drawing/2014/main" id="{A9998FA5-29E6-4DF6-B9FC-05DEB03C4B11}"/>
               </a:ext>
             </a:extLst>
           </p:cNvPr>
@@ -7244,7 +7244,7 @@
     </p:spTree>
     <p:extLst>
       <p:ext uri="{BB962C8B-B14F-4D97-AF65-F5344CB8AC3E}">
-        <p14:creationId xmlns:p14="http://schemas.microsoft.com/office/powerpoint/2010/main" val="461677467"/>
+        <p14:creationId xmlns:p14="http://schemas.microsoft.com/office/powerpoint/2010/main" val="47362633"/>
       </p:ext>
     </p:extLst>
   </p:cSld>
@@ -7268,7 +7268,7 @@
           <p:cNvPr id="1" name="">
             <a:extLst xmlns:a="http://schemas.openxmlformats.org/drawingml/2006/main">
               <a:ext uri="{FF2B5EF4-FFF2-40B4-BE49-F238E27FC236}">
-                <a16:creationId xmlns:a16="http://schemas.microsoft.com/office/drawing/2014/main" id="{E33BA71E-EC98-43BA-BDDC-83849BFEEC0B}"/>
+                <a16:creationId xmlns:a16="http://schemas.microsoft.com/office/drawing/2014/main" id="{E2A92CDD-AC1A-4068-B011-386E00CA9279}"/>
               </a:ext>
             </a:extLst>
           </p:cNvPr>
@@ -7303,7 +7303,7 @@
           <p:cNvPr id="2" name="kicker-marker">
             <a:extLst xmlns:a="http://schemas.openxmlformats.org/drawingml/2006/main">
               <a:ext uri="{FF2B5EF4-FFF2-40B4-BE49-F238E27FC236}">
-                <a16:creationId xmlns:a16="http://schemas.microsoft.com/office/drawing/2014/main" id="{29FF781A-CE7C-4224-9DB8-6AEDCD3523FB}"/>
+                <a16:creationId xmlns:a16="http://schemas.microsoft.com/office/drawing/2014/main" id="{0F5D6597-123A-4E82-A59F-08DA1F89D069}"/>
               </a:ext>
             </a:extLst>
           </p:cNvPr>
@@ -7338,7 +7338,7 @@
           <p:cNvPr id="3" name="kicker-label">
             <a:extLst xmlns:a="http://schemas.openxmlformats.org/drawingml/2006/main">
               <a:ext uri="{FF2B5EF4-FFF2-40B4-BE49-F238E27FC236}">
-                <a16:creationId xmlns:a16="http://schemas.microsoft.com/office/drawing/2014/main" id="{101265D5-21BE-499D-9F6F-67F1AD498E71}"/>
+                <a16:creationId xmlns:a16="http://schemas.microsoft.com/office/drawing/2014/main" id="{D2D999D6-109C-4351-AEAC-0219A2AC2894}"/>
               </a:ext>
             </a:extLst>
           </p:cNvPr>
@@ -7402,7 +7402,7 @@
           <p:cNvPr id="4" name="">
             <a:extLst xmlns:a="http://schemas.openxmlformats.org/drawingml/2006/main">
               <a:ext uri="{FF2B5EF4-FFF2-40B4-BE49-F238E27FC236}">
-                <a16:creationId xmlns:a16="http://schemas.microsoft.com/office/drawing/2014/main" id="{1431728E-92C6-4B79-BB55-26ADD5D97CE9}"/>
+                <a16:creationId xmlns:a16="http://schemas.microsoft.com/office/drawing/2014/main" id="{291C176D-31A4-4947-957A-EE670EF4015F}"/>
               </a:ext>
             </a:extLst>
           </p:cNvPr>
@@ -7466,7 +7466,7 @@
           <p:cNvPr id="5" name="">
             <a:extLst xmlns:a="http://schemas.openxmlformats.org/drawingml/2006/main">
               <a:ext uri="{FF2B5EF4-FFF2-40B4-BE49-F238E27FC236}">
-                <a16:creationId xmlns:a16="http://schemas.microsoft.com/office/drawing/2014/main" id="{D480E1BC-5BC9-4875-9FF9-C9E735BF874A}"/>
+                <a16:creationId xmlns:a16="http://schemas.microsoft.com/office/drawing/2014/main" id="{536804E3-7D3C-48BB-9708-1BCCC4804D2F}"/>
               </a:ext>
             </a:extLst>
           </p:cNvPr>
@@ -7501,7 +7501,7 @@
           <p:cNvPr id="6" name="">
             <a:extLst xmlns:a="http://schemas.openxmlformats.org/drawingml/2006/main">
               <a:ext uri="{FF2B5EF4-FFF2-40B4-BE49-F238E27FC236}">
-                <a16:creationId xmlns:a16="http://schemas.microsoft.com/office/drawing/2014/main" id="{50428B3F-2105-4D77-89DC-CCBD84D320A4}"/>
+                <a16:creationId xmlns:a16="http://schemas.microsoft.com/office/drawing/2014/main" id="{777BF879-E279-4EFC-9830-A2663E226F2D}"/>
               </a:ext>
             </a:extLst>
           </p:cNvPr>
@@ -7569,7 +7569,7 @@
           <p:nvPr/>
         </p:nvPicPr>
         <p:blipFill>
-          <a:blip xmlns:r="http://schemas.openxmlformats.org/officeDocument/2006/relationships" xmlns:a="http://schemas.openxmlformats.org/drawingml/2006/main" r:embed="R1fe24bdea7f84634"/>
+          <a:blip xmlns:r="http://schemas.openxmlformats.org/officeDocument/2006/relationships" xmlns:a="http://schemas.openxmlformats.org/drawingml/2006/main" r:embed="Rece9d1c75e994668"/>
           <a:stretch xmlns:a="http://schemas.openxmlformats.org/drawingml/2006/main"/>
         </p:blipFill>
         <p:spPr>
@@ -7587,7 +7587,7 @@
           <p:cNvPr id="8" name="">
             <a:extLst xmlns:a="http://schemas.openxmlformats.org/drawingml/2006/main">
               <a:ext uri="{FF2B5EF4-FFF2-40B4-BE49-F238E27FC236}">
-                <a16:creationId xmlns:a16="http://schemas.microsoft.com/office/drawing/2014/main" id="{97B41657-82E7-4848-B5CF-1B3048C7BCD1}"/>
+                <a16:creationId xmlns:a16="http://schemas.microsoft.com/office/drawing/2014/main" id="{60F0060E-8087-414C-B8CC-CCB449D02828}"/>
               </a:ext>
             </a:extLst>
           </p:cNvPr>
@@ -7622,7 +7622,7 @@
           <p:cNvPr id="9" name="">
             <a:extLst xmlns:a="http://schemas.openxmlformats.org/drawingml/2006/main">
               <a:ext uri="{FF2B5EF4-FFF2-40B4-BE49-F238E27FC236}">
-                <a16:creationId xmlns:a16="http://schemas.microsoft.com/office/drawing/2014/main" id="{47990A92-67FB-4CA9-9926-89FCE10DDE84}"/>
+                <a16:creationId xmlns:a16="http://schemas.microsoft.com/office/drawing/2014/main" id="{A49F219D-DD58-4230-B6AC-766FFEAE41E6}"/>
               </a:ext>
             </a:extLst>
           </p:cNvPr>
@@ -7657,7 +7657,7 @@
           <p:cNvPr id="10" name="">
             <a:extLst xmlns:a="http://schemas.openxmlformats.org/drawingml/2006/main">
               <a:ext uri="{FF2B5EF4-FFF2-40B4-BE49-F238E27FC236}">
-                <a16:creationId xmlns:a16="http://schemas.microsoft.com/office/drawing/2014/main" id="{96493EE1-236B-411E-9E97-5802AEF560ED}"/>
+                <a16:creationId xmlns:a16="http://schemas.microsoft.com/office/drawing/2014/main" id="{BE40CBAD-CEEC-4FFA-A0C4-AB7EDC93FC32}"/>
               </a:ext>
             </a:extLst>
           </p:cNvPr>
@@ -7721,7 +7721,7 @@
           <p:cNvPr id="11" name="">
             <a:extLst xmlns:a="http://schemas.openxmlformats.org/drawingml/2006/main">
               <a:ext uri="{FF2B5EF4-FFF2-40B4-BE49-F238E27FC236}">
-                <a16:creationId xmlns:a16="http://schemas.microsoft.com/office/drawing/2014/main" id="{1D3916F5-3FA6-46B2-A390-CFFD180A2841}"/>
+                <a16:creationId xmlns:a16="http://schemas.microsoft.com/office/drawing/2014/main" id="{0CD298F0-C435-4AAB-9B7F-7F1B0408AB46}"/>
               </a:ext>
             </a:extLst>
           </p:cNvPr>
@@ -7776,7 +7776,7 @@
                 <a:cs typeface="Aptos"/>
                 <a:hlinkClick xmlns:r="http://schemas.openxmlformats.org/officeDocument/2006/relationships" r:id="rIdSynthAMLDemo"/>
               </a:rPr>
-              <a:t>https://raw.githack.com/yq688m3JT/genAI_final/main/docs/demo.html</a:t>
+              <a:t>https://rawcdn.githack.com/yq688m3JT/genAI_final/fa4ed4cc3ab6dd13d10fa40e40ec5e6036816755/docs/demo.html</a:t>
             </a:r>
           </a:p>
         </p:txBody>
@@ -7784,7 +7784,7 @@
     </p:spTree>
     <p:extLst>
       <p:ext uri="{BB962C8B-B14F-4D97-AF65-F5344CB8AC3E}">
-        <p14:creationId xmlns:p14="http://schemas.microsoft.com/office/powerpoint/2010/main" val="2009338272"/>
+        <p14:creationId xmlns:p14="http://schemas.microsoft.com/office/powerpoint/2010/main" val="1281509914"/>
       </p:ext>
     </p:extLst>
   </p:cSld>

</xml_diff>

<commit_message>
Pin provider-neutral demo link
</commit_message>
<xml_diff>
--- a/docs/synthaml-final-presentation.pptx
+++ b/docs/synthaml-final-presentation.pptx
@@ -2,19 +2,19 @@
 <file path=ppt/presentation.xml><?xml version="1.0" encoding="utf-8"?>
 <p:presentation xmlns:p="http://schemas.openxmlformats.org/presentationml/2006/main">
   <p:sldMasterIdLst>
-    <p:sldMasterId xmlns:r="http://schemas.openxmlformats.org/officeDocument/2006/relationships" id="2147483648" r:id="R8e6f890fa9384593"/>
+    <p:sldMasterId xmlns:r="http://schemas.openxmlformats.org/officeDocument/2006/relationships" id="2147483648" r:id="R676618f2ed544caf"/>
   </p:sldMasterIdLst>
   <p:notesMasterIdLst>
-    <p:notesMasterId xmlns:r="http://schemas.openxmlformats.org/officeDocument/2006/relationships" r:id="Rf25671dfc2394762"/>
+    <p:notesMasterId xmlns:r="http://schemas.openxmlformats.org/officeDocument/2006/relationships" r:id="R7451d07de85d404d"/>
   </p:notesMasterIdLst>
   <p:sldIdLst>
-    <p:sldId xmlns:r="http://schemas.openxmlformats.org/officeDocument/2006/relationships" id="256" r:id="R0035b99a207b424e"/>
-    <p:sldId xmlns:r="http://schemas.openxmlformats.org/officeDocument/2006/relationships" id="257" r:id="R6d1187d171d24fac"/>
-    <p:sldId xmlns:r="http://schemas.openxmlformats.org/officeDocument/2006/relationships" id="258" r:id="R6cabef28a90d42aa"/>
-    <p:sldId xmlns:r="http://schemas.openxmlformats.org/officeDocument/2006/relationships" id="259" r:id="R29add05c989c48f1"/>
-    <p:sldId xmlns:r="http://schemas.openxmlformats.org/officeDocument/2006/relationships" id="260" r:id="R28af71680ed7411a"/>
-    <p:sldId xmlns:r="http://schemas.openxmlformats.org/officeDocument/2006/relationships" id="261" r:id="R5a865afc304d4ebb"/>
-    <p:sldId xmlns:r="http://schemas.openxmlformats.org/officeDocument/2006/relationships" id="262" r:id="Rb7309ce35f53464d"/>
+    <p:sldId xmlns:r="http://schemas.openxmlformats.org/officeDocument/2006/relationships" id="256" r:id="R5d3dff96ee844a69"/>
+    <p:sldId xmlns:r="http://schemas.openxmlformats.org/officeDocument/2006/relationships" id="257" r:id="Rc08bb64295724935"/>
+    <p:sldId xmlns:r="http://schemas.openxmlformats.org/officeDocument/2006/relationships" id="258" r:id="Rcb298f6f67cd45ee"/>
+    <p:sldId xmlns:r="http://schemas.openxmlformats.org/officeDocument/2006/relationships" id="259" r:id="R3fdd5ed9ba6e4da8"/>
+    <p:sldId xmlns:r="http://schemas.openxmlformats.org/officeDocument/2006/relationships" id="260" r:id="R38eff184b63644dc"/>
+    <p:sldId xmlns:r="http://schemas.openxmlformats.org/officeDocument/2006/relationships" id="261" r:id="R243fecb820044f4f"/>
+    <p:sldId xmlns:r="http://schemas.openxmlformats.org/officeDocument/2006/relationships" id="262" r:id="Ra84ff06708ae4fb2"/>
   </p:sldIdLst>
   <p:sldSz cx="12192000" cy="6858000"/>
   <p:notesSz cx="6858000" cy="9144000"/>
@@ -957,7 +957,7 @@
   </p:cSld>
   <p:clrMap bg1="lt1" tx1="dk1" bg2="lt2" tx2="dk2" accent1="accent1" accent2="accent2" accent3="accent3" accent4="accent4" accent5="accent5" accent6="accent6" hlink="hlink" folHlink="folHlink"/>
   <p:sldLayoutIdLst>
-    <p:sldLayoutId xmlns:r="http://schemas.openxmlformats.org/officeDocument/2006/relationships" id="2147483649" r:id="Rabd232a2580f446c"/>
+    <p:sldLayoutId xmlns:r="http://schemas.openxmlformats.org/officeDocument/2006/relationships" id="2147483649" r:id="Rbfb9e5eff8d849ca"/>
   </p:sldLayoutIdLst>
   <p:txStyles>
     <p:titleStyle>
@@ -1256,7 +1256,7 @@
           <p:cNvPr id="1" name="">
             <a:extLst xmlns:a="http://schemas.openxmlformats.org/drawingml/2006/main">
               <a:ext uri="{FF2B5EF4-FFF2-40B4-BE49-F238E27FC236}">
-                <a16:creationId xmlns:a16="http://schemas.microsoft.com/office/drawing/2014/main" id="{F981DB7D-1D5F-4DF4-92C5-370E013B0220}"/>
+                <a16:creationId xmlns:a16="http://schemas.microsoft.com/office/drawing/2014/main" id="{FB71E7F6-4E29-45D1-BE89-28B59992DEBE}"/>
               </a:ext>
             </a:extLst>
           </p:cNvPr>
@@ -1291,7 +1291,7 @@
           <p:cNvPr id="2" name="">
             <a:extLst xmlns:a="http://schemas.openxmlformats.org/drawingml/2006/main">
               <a:ext uri="{FF2B5EF4-FFF2-40B4-BE49-F238E27FC236}">
-                <a16:creationId xmlns:a16="http://schemas.microsoft.com/office/drawing/2014/main" id="{82780ABF-7F90-49B0-967D-B75F0CF1E651}"/>
+                <a16:creationId xmlns:a16="http://schemas.microsoft.com/office/drawing/2014/main" id="{63C637B8-DAB7-4C9D-9F6C-2C721F1409FA}"/>
               </a:ext>
             </a:extLst>
           </p:cNvPr>
@@ -1326,7 +1326,7 @@
           <p:cNvPr id="3" name="">
             <a:extLst xmlns:a="http://schemas.openxmlformats.org/drawingml/2006/main">
               <a:ext uri="{FF2B5EF4-FFF2-40B4-BE49-F238E27FC236}">
-                <a16:creationId xmlns:a16="http://schemas.microsoft.com/office/drawing/2014/main" id="{BF0466D0-6A31-4F0B-97EE-9368E5FABA35}"/>
+                <a16:creationId xmlns:a16="http://schemas.microsoft.com/office/drawing/2014/main" id="{F3726672-2857-4E9D-85FE-8A22E2BA8559}"/>
               </a:ext>
             </a:extLst>
           </p:cNvPr>
@@ -1390,7 +1390,7 @@
           <p:cNvPr id="4" name="">
             <a:extLst xmlns:a="http://schemas.openxmlformats.org/drawingml/2006/main">
               <a:ext uri="{FF2B5EF4-FFF2-40B4-BE49-F238E27FC236}">
-                <a16:creationId xmlns:a16="http://schemas.microsoft.com/office/drawing/2014/main" id="{E954C99D-E8FC-4497-90FE-5FDDC18B572B}"/>
+                <a16:creationId xmlns:a16="http://schemas.microsoft.com/office/drawing/2014/main" id="{B62B1546-6FC9-4F25-BD71-BF6DD7837ECA}"/>
               </a:ext>
             </a:extLst>
           </p:cNvPr>
@@ -1454,7 +1454,7 @@
           <p:cNvPr id="5" name="">
             <a:extLst xmlns:a="http://schemas.openxmlformats.org/drawingml/2006/main">
               <a:ext uri="{FF2B5EF4-FFF2-40B4-BE49-F238E27FC236}">
-                <a16:creationId xmlns:a16="http://schemas.microsoft.com/office/drawing/2014/main" id="{ABCF14BE-BC60-4167-B8CC-1232F9AB6C67}"/>
+                <a16:creationId xmlns:a16="http://schemas.microsoft.com/office/drawing/2014/main" id="{B48A0A71-9251-407A-9D03-605CF81FE9CC}"/>
               </a:ext>
             </a:extLst>
           </p:cNvPr>
@@ -1518,7 +1518,7 @@
           <p:cNvPr id="6" name="">
             <a:extLst xmlns:a="http://schemas.openxmlformats.org/drawingml/2006/main">
               <a:ext uri="{FF2B5EF4-FFF2-40B4-BE49-F238E27FC236}">
-                <a16:creationId xmlns:a16="http://schemas.microsoft.com/office/drawing/2014/main" id="{B1611404-81CB-46A3-BBE5-924AD03B0358}"/>
+                <a16:creationId xmlns:a16="http://schemas.microsoft.com/office/drawing/2014/main" id="{94F05287-7A9E-4609-BADB-2FEED5DA5230}"/>
               </a:ext>
             </a:extLst>
           </p:cNvPr>
@@ -1553,7 +1553,7 @@
           <p:cNvPr id="7" name="">
             <a:extLst xmlns:a="http://schemas.openxmlformats.org/drawingml/2006/main">
               <a:ext uri="{FF2B5EF4-FFF2-40B4-BE49-F238E27FC236}">
-                <a16:creationId xmlns:a16="http://schemas.microsoft.com/office/drawing/2014/main" id="{2CB203FC-64F0-4C07-AEB8-4E8E76BABD2C}"/>
+                <a16:creationId xmlns:a16="http://schemas.microsoft.com/office/drawing/2014/main" id="{4D090D51-1963-4811-BCC6-295D1A456E15}"/>
               </a:ext>
             </a:extLst>
           </p:cNvPr>
@@ -1617,7 +1617,7 @@
           <p:cNvPr id="8" name="">
             <a:extLst xmlns:a="http://schemas.openxmlformats.org/drawingml/2006/main">
               <a:ext uri="{FF2B5EF4-FFF2-40B4-BE49-F238E27FC236}">
-                <a16:creationId xmlns:a16="http://schemas.microsoft.com/office/drawing/2014/main" id="{4245871D-66A4-4056-9FA9-8EB7AF0D7497}"/>
+                <a16:creationId xmlns:a16="http://schemas.microsoft.com/office/drawing/2014/main" id="{8306F00A-323C-44A0-955A-529C3B0A3381}"/>
               </a:ext>
             </a:extLst>
           </p:cNvPr>
@@ -1681,7 +1681,7 @@
           <p:cNvPr id="9" name="">
             <a:extLst xmlns:a="http://schemas.openxmlformats.org/drawingml/2006/main">
               <a:ext uri="{FF2B5EF4-FFF2-40B4-BE49-F238E27FC236}">
-                <a16:creationId xmlns:a16="http://schemas.microsoft.com/office/drawing/2014/main" id="{6DD26684-9984-48FD-B120-1C265C0FD520}"/>
+                <a16:creationId xmlns:a16="http://schemas.microsoft.com/office/drawing/2014/main" id="{2C793AFE-A6A3-4465-BEEE-39E1CE29C57D}"/>
               </a:ext>
             </a:extLst>
           </p:cNvPr>
@@ -1745,7 +1745,7 @@
           <p:cNvPr id="10" name="">
             <a:extLst xmlns:a="http://schemas.openxmlformats.org/drawingml/2006/main">
               <a:ext uri="{FF2B5EF4-FFF2-40B4-BE49-F238E27FC236}">
-                <a16:creationId xmlns:a16="http://schemas.microsoft.com/office/drawing/2014/main" id="{F20366DA-2B04-4C19-97F0-D5FF6640180D}"/>
+                <a16:creationId xmlns:a16="http://schemas.microsoft.com/office/drawing/2014/main" id="{5407FBDD-F5A4-4A70-A80D-C0CF5B5681F1}"/>
               </a:ext>
             </a:extLst>
           </p:cNvPr>
@@ -1809,7 +1809,7 @@
           <p:cNvPr id="11" name="">
             <a:extLst xmlns:a="http://schemas.openxmlformats.org/drawingml/2006/main">
               <a:ext uri="{FF2B5EF4-FFF2-40B4-BE49-F238E27FC236}">
-                <a16:creationId xmlns:a16="http://schemas.microsoft.com/office/drawing/2014/main" id="{1FAB1572-47E2-45BE-860D-405F9D3601A5}"/>
+                <a16:creationId xmlns:a16="http://schemas.microsoft.com/office/drawing/2014/main" id="{81514B6C-9A2C-494A-B511-AC077B884407}"/>
               </a:ext>
             </a:extLst>
           </p:cNvPr>
@@ -1873,7 +1873,7 @@
           <p:cNvPr id="12" name="">
             <a:extLst xmlns:a="http://schemas.openxmlformats.org/drawingml/2006/main">
               <a:ext uri="{FF2B5EF4-FFF2-40B4-BE49-F238E27FC236}">
-                <a16:creationId xmlns:a16="http://schemas.microsoft.com/office/drawing/2014/main" id="{A9C11B7E-144D-4288-84D6-B5ADD49C1E4A}"/>
+                <a16:creationId xmlns:a16="http://schemas.microsoft.com/office/drawing/2014/main" id="{66C7CFB0-FC0D-497F-AA3C-E1A6F982D764}"/>
               </a:ext>
             </a:extLst>
           </p:cNvPr>
@@ -1937,7 +1937,7 @@
           <p:cNvPr id="13" name="">
             <a:extLst xmlns:a="http://schemas.openxmlformats.org/drawingml/2006/main">
               <a:ext uri="{FF2B5EF4-FFF2-40B4-BE49-F238E27FC236}">
-                <a16:creationId xmlns:a16="http://schemas.microsoft.com/office/drawing/2014/main" id="{1DA9E195-0C82-4B50-B710-BB30D673065E}"/>
+                <a16:creationId xmlns:a16="http://schemas.microsoft.com/office/drawing/2014/main" id="{23A71A04-7A43-4085-B50F-E9467243264C}"/>
               </a:ext>
             </a:extLst>
           </p:cNvPr>
@@ -1972,7 +1972,7 @@
           <p:cNvPr id="14" name="">
             <a:extLst xmlns:a="http://schemas.openxmlformats.org/drawingml/2006/main">
               <a:ext uri="{FF2B5EF4-FFF2-40B4-BE49-F238E27FC236}">
-                <a16:creationId xmlns:a16="http://schemas.microsoft.com/office/drawing/2014/main" id="{D527F463-001A-4AFC-AAB7-D13E63E6F98D}"/>
+                <a16:creationId xmlns:a16="http://schemas.microsoft.com/office/drawing/2014/main" id="{51F48236-9EB8-4417-931C-090140CC97CD}"/>
               </a:ext>
             </a:extLst>
           </p:cNvPr>
@@ -2036,7 +2036,7 @@
           <p:cNvPr id="15" name="">
             <a:extLst xmlns:a="http://schemas.openxmlformats.org/drawingml/2006/main">
               <a:ext uri="{FF2B5EF4-FFF2-40B4-BE49-F238E27FC236}">
-                <a16:creationId xmlns:a16="http://schemas.microsoft.com/office/drawing/2014/main" id="{55EB7BA5-F160-4D5F-9A9D-7E9AA4112EDC}"/>
+                <a16:creationId xmlns:a16="http://schemas.microsoft.com/office/drawing/2014/main" id="{3EA9E8D5-3240-4A30-9DF0-FFCE286EEF19}"/>
               </a:ext>
             </a:extLst>
           </p:cNvPr>
@@ -2123,7 +2123,7 @@
           <p:cNvPr id="16" name="">
             <a:extLst xmlns:a="http://schemas.openxmlformats.org/drawingml/2006/main">
               <a:ext uri="{FF2B5EF4-FFF2-40B4-BE49-F238E27FC236}">
-                <a16:creationId xmlns:a16="http://schemas.microsoft.com/office/drawing/2014/main" id="{ECD002EA-92C8-4715-9A79-EC8B33E89AE3}"/>
+                <a16:creationId xmlns:a16="http://schemas.microsoft.com/office/drawing/2014/main" id="{4D6ADF97-7BD4-4846-A75C-DA167B7FE318}"/>
               </a:ext>
             </a:extLst>
           </p:cNvPr>
@@ -2187,7 +2187,7 @@
           <p:cNvPr id="17" name="">
             <a:extLst xmlns:a="http://schemas.openxmlformats.org/drawingml/2006/main">
               <a:ext uri="{FF2B5EF4-FFF2-40B4-BE49-F238E27FC236}">
-                <a16:creationId xmlns:a16="http://schemas.microsoft.com/office/drawing/2014/main" id="{585013F2-6466-46C4-8905-62C85F73EAD7}"/>
+                <a16:creationId xmlns:a16="http://schemas.microsoft.com/office/drawing/2014/main" id="{0F9B52D9-B122-49A3-8571-729F83ECC3C2}"/>
               </a:ext>
             </a:extLst>
           </p:cNvPr>
@@ -2242,7 +2242,7 @@
                 <a:cs typeface="Aptos"/>
                 <a:hlinkClick xmlns:r="http://schemas.openxmlformats.org/officeDocument/2006/relationships" r:id="rIdSynthAMLDemo"/>
               </a:rPr>
-              <a:t>https://rawcdn.githack.com/yq688m3JT/genAI_final/fa4ed4cc3ab6dd13d10fa40e40ec5e6036816755/docs/demo.html</a:t>
+              <a:t>https://rawcdn.githack.com/yq688m3JT/genAI_final/ae9c84ea574e9f8c48c84f1863ce82f77ea4f24e/docs/demo.html</a:t>
             </a:r>
           </a:p>
         </p:txBody>
@@ -2250,7 +2250,7 @@
     </p:spTree>
     <p:extLst>
       <p:ext uri="{BB962C8B-B14F-4D97-AF65-F5344CB8AC3E}">
-        <p14:creationId xmlns:p14="http://schemas.microsoft.com/office/powerpoint/2010/main" val="1129252769"/>
+        <p14:creationId xmlns:p14="http://schemas.microsoft.com/office/powerpoint/2010/main" val="1259413584"/>
       </p:ext>
     </p:extLst>
   </p:cSld>
@@ -2274,7 +2274,7 @@
           <p:cNvPr id="1" name="">
             <a:extLst xmlns:a="http://schemas.openxmlformats.org/drawingml/2006/main">
               <a:ext uri="{FF2B5EF4-FFF2-40B4-BE49-F238E27FC236}">
-                <a16:creationId xmlns:a16="http://schemas.microsoft.com/office/drawing/2014/main" id="{34E32C5F-0E66-4E2F-8DC6-316DB7287E50}"/>
+                <a16:creationId xmlns:a16="http://schemas.microsoft.com/office/drawing/2014/main" id="{76CBF4F4-7D39-4F40-B99C-ED3FE90D951F}"/>
               </a:ext>
             </a:extLst>
           </p:cNvPr>
@@ -2309,7 +2309,7 @@
           <p:cNvPr id="2" name="kicker-marker">
             <a:extLst xmlns:a="http://schemas.openxmlformats.org/drawingml/2006/main">
               <a:ext uri="{FF2B5EF4-FFF2-40B4-BE49-F238E27FC236}">
-                <a16:creationId xmlns:a16="http://schemas.microsoft.com/office/drawing/2014/main" id="{24890243-982F-400A-ADEB-DCE1EE4775F1}"/>
+                <a16:creationId xmlns:a16="http://schemas.microsoft.com/office/drawing/2014/main" id="{F466C01F-4722-4E65-8DA4-70539AAD7409}"/>
               </a:ext>
             </a:extLst>
           </p:cNvPr>
@@ -2344,7 +2344,7 @@
           <p:cNvPr id="3" name="kicker-label">
             <a:extLst xmlns:a="http://schemas.openxmlformats.org/drawingml/2006/main">
               <a:ext uri="{FF2B5EF4-FFF2-40B4-BE49-F238E27FC236}">
-                <a16:creationId xmlns:a16="http://schemas.microsoft.com/office/drawing/2014/main" id="{7374A4DD-443B-4BFE-BA2D-F9A9915D9DA3}"/>
+                <a16:creationId xmlns:a16="http://schemas.microsoft.com/office/drawing/2014/main" id="{AD833B03-1DFA-47F0-902F-89F5839D500C}"/>
               </a:ext>
             </a:extLst>
           </p:cNvPr>
@@ -2408,7 +2408,7 @@
           <p:cNvPr id="4" name="">
             <a:extLst xmlns:a="http://schemas.openxmlformats.org/drawingml/2006/main">
               <a:ext uri="{FF2B5EF4-FFF2-40B4-BE49-F238E27FC236}">
-                <a16:creationId xmlns:a16="http://schemas.microsoft.com/office/drawing/2014/main" id="{70E44901-93E9-4702-B4B5-EDE234B5F102}"/>
+                <a16:creationId xmlns:a16="http://schemas.microsoft.com/office/drawing/2014/main" id="{7AAFC6D5-75B8-4E6E-B569-73766CD23650}"/>
               </a:ext>
             </a:extLst>
           </p:cNvPr>
@@ -2472,7 +2472,7 @@
           <p:cNvPr id="5" name="">
             <a:extLst xmlns:a="http://schemas.openxmlformats.org/drawingml/2006/main">
               <a:ext uri="{FF2B5EF4-FFF2-40B4-BE49-F238E27FC236}">
-                <a16:creationId xmlns:a16="http://schemas.microsoft.com/office/drawing/2014/main" id="{183543D3-F7AF-46AF-AE66-8951887A285A}"/>
+                <a16:creationId xmlns:a16="http://schemas.microsoft.com/office/drawing/2014/main" id="{CA3B5DC9-EC4E-4BFC-827A-97B265D29FC8}"/>
               </a:ext>
             </a:extLst>
           </p:cNvPr>
@@ -2536,7 +2536,7 @@
           <p:cNvPr id="6" name="">
             <a:extLst xmlns:a="http://schemas.openxmlformats.org/drawingml/2006/main">
               <a:ext uri="{FF2B5EF4-FFF2-40B4-BE49-F238E27FC236}">
-                <a16:creationId xmlns:a16="http://schemas.microsoft.com/office/drawing/2014/main" id="{FAA79666-0880-4D11-994D-496F056C4AE8}"/>
+                <a16:creationId xmlns:a16="http://schemas.microsoft.com/office/drawing/2014/main" id="{433F5385-E52A-44DD-858B-217D04984C70}"/>
               </a:ext>
             </a:extLst>
           </p:cNvPr>
@@ -2571,7 +2571,7 @@
           <p:cNvPr id="7" name="">
             <a:extLst xmlns:a="http://schemas.openxmlformats.org/drawingml/2006/main">
               <a:ext uri="{FF2B5EF4-FFF2-40B4-BE49-F238E27FC236}">
-                <a16:creationId xmlns:a16="http://schemas.microsoft.com/office/drawing/2014/main" id="{1B587A9B-73C9-4859-B2EA-1E228DADEEF7}"/>
+                <a16:creationId xmlns:a16="http://schemas.microsoft.com/office/drawing/2014/main" id="{2E98F08E-7A5F-4B70-86C4-8630724AD7E3}"/>
               </a:ext>
             </a:extLst>
           </p:cNvPr>
@@ -2635,7 +2635,7 @@
           <p:cNvPr id="8" name="">
             <a:extLst xmlns:a="http://schemas.openxmlformats.org/drawingml/2006/main">
               <a:ext uri="{FF2B5EF4-FFF2-40B4-BE49-F238E27FC236}">
-                <a16:creationId xmlns:a16="http://schemas.microsoft.com/office/drawing/2014/main" id="{0C6B1AB3-39DD-4951-A8DA-E4E71D712A97}"/>
+                <a16:creationId xmlns:a16="http://schemas.microsoft.com/office/drawing/2014/main" id="{85B9CB79-5ACA-43B0-B1B3-BA2230851E4D}"/>
               </a:ext>
             </a:extLst>
           </p:cNvPr>
@@ -2699,7 +2699,7 @@
           <p:cNvPr id="9" name="">
             <a:extLst xmlns:a="http://schemas.openxmlformats.org/drawingml/2006/main">
               <a:ext uri="{FF2B5EF4-FFF2-40B4-BE49-F238E27FC236}">
-                <a16:creationId xmlns:a16="http://schemas.microsoft.com/office/drawing/2014/main" id="{90095367-0FE4-4C03-9321-DED37D67E276}"/>
+                <a16:creationId xmlns:a16="http://schemas.microsoft.com/office/drawing/2014/main" id="{0F45E3F3-3D20-4269-908C-1B8D33A93CE8}"/>
               </a:ext>
             </a:extLst>
           </p:cNvPr>
@@ -2763,7 +2763,7 @@
           <p:cNvPr id="10" name="">
             <a:extLst xmlns:a="http://schemas.openxmlformats.org/drawingml/2006/main">
               <a:ext uri="{FF2B5EF4-FFF2-40B4-BE49-F238E27FC236}">
-                <a16:creationId xmlns:a16="http://schemas.microsoft.com/office/drawing/2014/main" id="{90B18DDC-FF28-45D8-A298-C172639A58C7}"/>
+                <a16:creationId xmlns:a16="http://schemas.microsoft.com/office/drawing/2014/main" id="{2A565697-2595-4559-821E-8913C3F783BD}"/>
               </a:ext>
             </a:extLst>
           </p:cNvPr>
@@ -2798,7 +2798,7 @@
           <p:cNvPr id="11" name="">
             <a:extLst xmlns:a="http://schemas.openxmlformats.org/drawingml/2006/main">
               <a:ext uri="{FF2B5EF4-FFF2-40B4-BE49-F238E27FC236}">
-                <a16:creationId xmlns:a16="http://schemas.microsoft.com/office/drawing/2014/main" id="{0EC270B0-256E-40D1-BFDC-7872B2D06E3C}"/>
+                <a16:creationId xmlns:a16="http://schemas.microsoft.com/office/drawing/2014/main" id="{56BDABBF-EA44-460E-9BC9-7910E7157743}"/>
               </a:ext>
             </a:extLst>
           </p:cNvPr>
@@ -2833,7 +2833,7 @@
           <p:cNvPr id="12" name="">
             <a:extLst xmlns:a="http://schemas.openxmlformats.org/drawingml/2006/main">
               <a:ext uri="{FF2B5EF4-FFF2-40B4-BE49-F238E27FC236}">
-                <a16:creationId xmlns:a16="http://schemas.microsoft.com/office/drawing/2014/main" id="{BB5B6AE1-FE6B-4E9E-A8E3-8102071DF223}"/>
+                <a16:creationId xmlns:a16="http://schemas.microsoft.com/office/drawing/2014/main" id="{E19F4CD3-19C4-46DF-9FB0-CF0881C7B7FD}"/>
               </a:ext>
             </a:extLst>
           </p:cNvPr>
@@ -2868,7 +2868,7 @@
           <p:cNvPr id="13" name="">
             <a:extLst xmlns:a="http://schemas.openxmlformats.org/drawingml/2006/main">
               <a:ext uri="{FF2B5EF4-FFF2-40B4-BE49-F238E27FC236}">
-                <a16:creationId xmlns:a16="http://schemas.microsoft.com/office/drawing/2014/main" id="{024D14EF-0FA1-4B46-B4A3-A359D8C09083}"/>
+                <a16:creationId xmlns:a16="http://schemas.microsoft.com/office/drawing/2014/main" id="{A188F70B-B15D-4B2A-967D-8B35B89C224F}"/>
               </a:ext>
             </a:extLst>
           </p:cNvPr>
@@ -2932,7 +2932,7 @@
           <p:cNvPr id="14" name="">
             <a:extLst xmlns:a="http://schemas.openxmlformats.org/drawingml/2006/main">
               <a:ext uri="{FF2B5EF4-FFF2-40B4-BE49-F238E27FC236}">
-                <a16:creationId xmlns:a16="http://schemas.microsoft.com/office/drawing/2014/main" id="{0990225C-947B-416B-B0DA-42238B1973BA}"/>
+                <a16:creationId xmlns:a16="http://schemas.microsoft.com/office/drawing/2014/main" id="{00F710BC-894A-4626-A871-FD15FA2A74FF}"/>
               </a:ext>
             </a:extLst>
           </p:cNvPr>
@@ -2996,7 +2996,7 @@
           <p:cNvPr id="15" name="">
             <a:extLst xmlns:a="http://schemas.openxmlformats.org/drawingml/2006/main">
               <a:ext uri="{FF2B5EF4-FFF2-40B4-BE49-F238E27FC236}">
-                <a16:creationId xmlns:a16="http://schemas.microsoft.com/office/drawing/2014/main" id="{4A07DF90-5B4D-4E25-998E-4610BB992D1D}"/>
+                <a16:creationId xmlns:a16="http://schemas.microsoft.com/office/drawing/2014/main" id="{ACE931D3-8BA2-4283-873F-8A3774E415B6}"/>
               </a:ext>
             </a:extLst>
           </p:cNvPr>
@@ -3060,7 +3060,7 @@
           <p:cNvPr id="16" name="">
             <a:extLst xmlns:a="http://schemas.openxmlformats.org/drawingml/2006/main">
               <a:ext uri="{FF2B5EF4-FFF2-40B4-BE49-F238E27FC236}">
-                <a16:creationId xmlns:a16="http://schemas.microsoft.com/office/drawing/2014/main" id="{E7E563FD-AC51-490B-92FC-3567C1A2EDD8}"/>
+                <a16:creationId xmlns:a16="http://schemas.microsoft.com/office/drawing/2014/main" id="{3CAD00B8-191B-42D2-9BAC-6832BDE6675D}"/>
               </a:ext>
             </a:extLst>
           </p:cNvPr>
@@ -3095,7 +3095,7 @@
           <p:cNvPr id="17" name="">
             <a:extLst xmlns:a="http://schemas.openxmlformats.org/drawingml/2006/main">
               <a:ext uri="{FF2B5EF4-FFF2-40B4-BE49-F238E27FC236}">
-                <a16:creationId xmlns:a16="http://schemas.microsoft.com/office/drawing/2014/main" id="{51616A21-0C0C-4EDE-BC90-9A905C792FC6}"/>
+                <a16:creationId xmlns:a16="http://schemas.microsoft.com/office/drawing/2014/main" id="{E875090C-6182-4B04-84BF-DCEFD24138A9}"/>
               </a:ext>
             </a:extLst>
           </p:cNvPr>
@@ -3130,7 +3130,7 @@
           <p:cNvPr id="18" name="">
             <a:extLst xmlns:a="http://schemas.openxmlformats.org/drawingml/2006/main">
               <a:ext uri="{FF2B5EF4-FFF2-40B4-BE49-F238E27FC236}">
-                <a16:creationId xmlns:a16="http://schemas.microsoft.com/office/drawing/2014/main" id="{F9DF37B5-9E99-4F17-AD2E-488F8B624ED1}"/>
+                <a16:creationId xmlns:a16="http://schemas.microsoft.com/office/drawing/2014/main" id="{27F27BF8-C6E1-4C6F-972B-7DEBD39F5F21}"/>
               </a:ext>
             </a:extLst>
           </p:cNvPr>
@@ -3165,7 +3165,7 @@
           <p:cNvPr id="19" name="">
             <a:extLst xmlns:a="http://schemas.openxmlformats.org/drawingml/2006/main">
               <a:ext uri="{FF2B5EF4-FFF2-40B4-BE49-F238E27FC236}">
-                <a16:creationId xmlns:a16="http://schemas.microsoft.com/office/drawing/2014/main" id="{00B2CF9C-6201-4F47-816A-6E872AA88CE3}"/>
+                <a16:creationId xmlns:a16="http://schemas.microsoft.com/office/drawing/2014/main" id="{E8A36923-1978-4208-978D-DB6750CF1F0D}"/>
               </a:ext>
             </a:extLst>
           </p:cNvPr>
@@ -3229,7 +3229,7 @@
           <p:cNvPr id="20" name="">
             <a:extLst xmlns:a="http://schemas.openxmlformats.org/drawingml/2006/main">
               <a:ext uri="{FF2B5EF4-FFF2-40B4-BE49-F238E27FC236}">
-                <a16:creationId xmlns:a16="http://schemas.microsoft.com/office/drawing/2014/main" id="{953DE2CB-F19C-4BF0-95FE-FA78D5DA48CD}"/>
+                <a16:creationId xmlns:a16="http://schemas.microsoft.com/office/drawing/2014/main" id="{D7C62010-CA4C-467F-99FC-84EE40B0415A}"/>
               </a:ext>
             </a:extLst>
           </p:cNvPr>
@@ -3293,7 +3293,7 @@
           <p:cNvPr id="21" name="">
             <a:extLst xmlns:a="http://schemas.openxmlformats.org/drawingml/2006/main">
               <a:ext uri="{FF2B5EF4-FFF2-40B4-BE49-F238E27FC236}">
-                <a16:creationId xmlns:a16="http://schemas.microsoft.com/office/drawing/2014/main" id="{E12FC0B6-1FBD-4572-B2DB-0E17F5E157D0}"/>
+                <a16:creationId xmlns:a16="http://schemas.microsoft.com/office/drawing/2014/main" id="{B3C204B2-BC18-4A32-8A2E-3C7E7A7874C3}"/>
               </a:ext>
             </a:extLst>
           </p:cNvPr>
@@ -3357,7 +3357,7 @@
           <p:cNvPr id="22" name="">
             <a:extLst xmlns:a="http://schemas.openxmlformats.org/drawingml/2006/main">
               <a:ext uri="{FF2B5EF4-FFF2-40B4-BE49-F238E27FC236}">
-                <a16:creationId xmlns:a16="http://schemas.microsoft.com/office/drawing/2014/main" id="{EE5DE240-C489-46F3-B0EF-CEF4061E32E2}"/>
+                <a16:creationId xmlns:a16="http://schemas.microsoft.com/office/drawing/2014/main" id="{B392513F-104B-4FCC-93A6-4888B81EA992}"/>
               </a:ext>
             </a:extLst>
           </p:cNvPr>
@@ -3390,7 +3390,7 @@
           <p:cNvPr id="23" name="">
             <a:extLst xmlns:a="http://schemas.openxmlformats.org/drawingml/2006/main">
               <a:ext uri="{FF2B5EF4-FFF2-40B4-BE49-F238E27FC236}">
-                <a16:creationId xmlns:a16="http://schemas.microsoft.com/office/drawing/2014/main" id="{E48C3DCD-8CB5-40B2-AEB6-1CCCBC783199}"/>
+                <a16:creationId xmlns:a16="http://schemas.microsoft.com/office/drawing/2014/main" id="{D392FF56-C9DD-4076-8DD1-D24DAA92FFCF}"/>
               </a:ext>
             </a:extLst>
           </p:cNvPr>
@@ -3454,7 +3454,7 @@
           <p:cNvPr id="24" name="">
             <a:extLst xmlns:a="http://schemas.openxmlformats.org/drawingml/2006/main">
               <a:ext uri="{FF2B5EF4-FFF2-40B4-BE49-F238E27FC236}">
-                <a16:creationId xmlns:a16="http://schemas.microsoft.com/office/drawing/2014/main" id="{49B0F4BC-AA6E-4F5B-96CE-0876ACBA0199}"/>
+                <a16:creationId xmlns:a16="http://schemas.microsoft.com/office/drawing/2014/main" id="{AF99906B-B699-45A7-BA42-EB950A223084}"/>
               </a:ext>
             </a:extLst>
           </p:cNvPr>
@@ -3541,7 +3541,7 @@
           <p:cNvPr id="25" name="">
             <a:extLst xmlns:a="http://schemas.openxmlformats.org/drawingml/2006/main">
               <a:ext uri="{FF2B5EF4-FFF2-40B4-BE49-F238E27FC236}">
-                <a16:creationId xmlns:a16="http://schemas.microsoft.com/office/drawing/2014/main" id="{DC0102ED-E817-4398-AEA4-B9DDB6A4EAF9}"/>
+                <a16:creationId xmlns:a16="http://schemas.microsoft.com/office/drawing/2014/main" id="{BA80A5C1-38B3-44BC-80FC-0BEF5B1C669D}"/>
               </a:ext>
             </a:extLst>
           </p:cNvPr>
@@ -3576,7 +3576,7 @@
           <p:cNvPr id="26" name="">
             <a:extLst xmlns:a="http://schemas.openxmlformats.org/drawingml/2006/main">
               <a:ext uri="{FF2B5EF4-FFF2-40B4-BE49-F238E27FC236}">
-                <a16:creationId xmlns:a16="http://schemas.microsoft.com/office/drawing/2014/main" id="{593F76DC-A6D0-489A-BA89-66C1EDCA2563}"/>
+                <a16:creationId xmlns:a16="http://schemas.microsoft.com/office/drawing/2014/main" id="{F1F69856-023D-416D-9905-26D8E97C1394}"/>
               </a:ext>
             </a:extLst>
           </p:cNvPr>
@@ -3638,7 +3638,7 @@
     </p:spTree>
     <p:extLst>
       <p:ext uri="{BB962C8B-B14F-4D97-AF65-F5344CB8AC3E}">
-        <p14:creationId xmlns:p14="http://schemas.microsoft.com/office/powerpoint/2010/main" val="1191850723"/>
+        <p14:creationId xmlns:p14="http://schemas.microsoft.com/office/powerpoint/2010/main" val="1884487304"/>
       </p:ext>
     </p:extLst>
   </p:cSld>
@@ -3662,7 +3662,7 @@
           <p:cNvPr id="1" name="">
             <a:extLst xmlns:a="http://schemas.openxmlformats.org/drawingml/2006/main">
               <a:ext uri="{FF2B5EF4-FFF2-40B4-BE49-F238E27FC236}">
-                <a16:creationId xmlns:a16="http://schemas.microsoft.com/office/drawing/2014/main" id="{2D2942A7-5D91-44CB-9E3A-BD7DB24BFD8C}"/>
+                <a16:creationId xmlns:a16="http://schemas.microsoft.com/office/drawing/2014/main" id="{F4E84A65-6FE9-4A08-A014-47027E087AFD}"/>
               </a:ext>
             </a:extLst>
           </p:cNvPr>
@@ -3697,7 +3697,7 @@
           <p:cNvPr id="2" name="kicker-marker">
             <a:extLst xmlns:a="http://schemas.openxmlformats.org/drawingml/2006/main">
               <a:ext uri="{FF2B5EF4-FFF2-40B4-BE49-F238E27FC236}">
-                <a16:creationId xmlns:a16="http://schemas.microsoft.com/office/drawing/2014/main" id="{B03F0EDB-D57A-4A76-A6AC-F0ECF2DA0928}"/>
+                <a16:creationId xmlns:a16="http://schemas.microsoft.com/office/drawing/2014/main" id="{D7A6C209-CFFF-4748-B095-8ED86ADF26AD}"/>
               </a:ext>
             </a:extLst>
           </p:cNvPr>
@@ -3732,7 +3732,7 @@
           <p:cNvPr id="3" name="kicker-label">
             <a:extLst xmlns:a="http://schemas.openxmlformats.org/drawingml/2006/main">
               <a:ext uri="{FF2B5EF4-FFF2-40B4-BE49-F238E27FC236}">
-                <a16:creationId xmlns:a16="http://schemas.microsoft.com/office/drawing/2014/main" id="{698E0811-3F78-4449-BBD9-6DD6C606CC24}"/>
+                <a16:creationId xmlns:a16="http://schemas.microsoft.com/office/drawing/2014/main" id="{A185F3B5-2C5A-461D-AA78-AF866DE72E60}"/>
               </a:ext>
             </a:extLst>
           </p:cNvPr>
@@ -3796,7 +3796,7 @@
           <p:cNvPr id="4" name="">
             <a:extLst xmlns:a="http://schemas.openxmlformats.org/drawingml/2006/main">
               <a:ext uri="{FF2B5EF4-FFF2-40B4-BE49-F238E27FC236}">
-                <a16:creationId xmlns:a16="http://schemas.microsoft.com/office/drawing/2014/main" id="{AA3FDE8B-8C75-45BB-A35E-21FA858125AD}"/>
+                <a16:creationId xmlns:a16="http://schemas.microsoft.com/office/drawing/2014/main" id="{CC8455FF-73B5-4A61-9614-52ADCBDB7754}"/>
               </a:ext>
             </a:extLst>
           </p:cNvPr>
@@ -3860,7 +3860,7 @@
           <p:cNvPr id="5" name="">
             <a:extLst xmlns:a="http://schemas.openxmlformats.org/drawingml/2006/main">
               <a:ext uri="{FF2B5EF4-FFF2-40B4-BE49-F238E27FC236}">
-                <a16:creationId xmlns:a16="http://schemas.microsoft.com/office/drawing/2014/main" id="{304813D6-C725-492C-98B5-667C244B1602}"/>
+                <a16:creationId xmlns:a16="http://schemas.microsoft.com/office/drawing/2014/main" id="{576C3261-9FAA-420F-BE63-3E111BBC66F0}"/>
               </a:ext>
             </a:extLst>
           </p:cNvPr>
@@ -3895,7 +3895,7 @@
           <p:cNvPr id="6" name="">
             <a:extLst xmlns:a="http://schemas.openxmlformats.org/drawingml/2006/main">
               <a:ext uri="{FF2B5EF4-FFF2-40B4-BE49-F238E27FC236}">
-                <a16:creationId xmlns:a16="http://schemas.microsoft.com/office/drawing/2014/main" id="{8E5BA9DC-431F-4281-B5C6-FB7F42F816F9}"/>
+                <a16:creationId xmlns:a16="http://schemas.microsoft.com/office/drawing/2014/main" id="{87CC508B-3704-475F-9041-E47E69380CBC}"/>
               </a:ext>
             </a:extLst>
           </p:cNvPr>
@@ -3959,7 +3959,7 @@
           <p:cNvPr id="7" name="">
             <a:extLst xmlns:a="http://schemas.openxmlformats.org/drawingml/2006/main">
               <a:ext uri="{FF2B5EF4-FFF2-40B4-BE49-F238E27FC236}">
-                <a16:creationId xmlns:a16="http://schemas.microsoft.com/office/drawing/2014/main" id="{E38AF221-C954-4375-A861-8CF3DBAD442D}"/>
+                <a16:creationId xmlns:a16="http://schemas.microsoft.com/office/drawing/2014/main" id="{0789115F-F3AD-46CA-9A8F-2954AC41635D}"/>
               </a:ext>
             </a:extLst>
           </p:cNvPr>
@@ -3992,7 +3992,7 @@
           <p:cNvPr id="8" name="">
             <a:extLst xmlns:a="http://schemas.openxmlformats.org/drawingml/2006/main">
               <a:ext uri="{FF2B5EF4-FFF2-40B4-BE49-F238E27FC236}">
-                <a16:creationId xmlns:a16="http://schemas.microsoft.com/office/drawing/2014/main" id="{120B0903-7A16-45B3-9D14-5BBD36903580}"/>
+                <a16:creationId xmlns:a16="http://schemas.microsoft.com/office/drawing/2014/main" id="{E2E24AAA-386C-404E-B917-D5E59D4348C9}"/>
               </a:ext>
             </a:extLst>
           </p:cNvPr>
@@ -4056,7 +4056,7 @@
           <p:cNvPr id="9" name="">
             <a:extLst xmlns:a="http://schemas.openxmlformats.org/drawingml/2006/main">
               <a:ext uri="{FF2B5EF4-FFF2-40B4-BE49-F238E27FC236}">
-                <a16:creationId xmlns:a16="http://schemas.microsoft.com/office/drawing/2014/main" id="{4F1BE1D7-AFE7-4422-89FA-01243C6C146C}"/>
+                <a16:creationId xmlns:a16="http://schemas.microsoft.com/office/drawing/2014/main" id="{B25A4D30-2990-4696-9431-5B04229C185E}"/>
               </a:ext>
             </a:extLst>
           </p:cNvPr>
@@ -4120,7 +4120,7 @@
           <p:cNvPr id="10" name="">
             <a:extLst xmlns:a="http://schemas.openxmlformats.org/drawingml/2006/main">
               <a:ext uri="{FF2B5EF4-FFF2-40B4-BE49-F238E27FC236}">
-                <a16:creationId xmlns:a16="http://schemas.microsoft.com/office/drawing/2014/main" id="{91F35C37-5413-478D-9492-8B1C800FAE75}"/>
+                <a16:creationId xmlns:a16="http://schemas.microsoft.com/office/drawing/2014/main" id="{BCC474E2-03AF-43F0-89A9-201C3B9AC2A8}"/>
               </a:ext>
             </a:extLst>
           </p:cNvPr>
@@ -4184,7 +4184,7 @@
           <p:cNvPr id="11" name="">
             <a:extLst xmlns:a="http://schemas.openxmlformats.org/drawingml/2006/main">
               <a:ext uri="{FF2B5EF4-FFF2-40B4-BE49-F238E27FC236}">
-                <a16:creationId xmlns:a16="http://schemas.microsoft.com/office/drawing/2014/main" id="{DE2F2FDA-1331-456D-8A86-96CBD745AE22}"/>
+                <a16:creationId xmlns:a16="http://schemas.microsoft.com/office/drawing/2014/main" id="{FECB9B3F-8312-4AA8-9E5D-D02E368B73A3}"/>
               </a:ext>
             </a:extLst>
           </p:cNvPr>
@@ -4219,7 +4219,7 @@
           <p:cNvPr id="12" name="">
             <a:extLst xmlns:a="http://schemas.openxmlformats.org/drawingml/2006/main">
               <a:ext uri="{FF2B5EF4-FFF2-40B4-BE49-F238E27FC236}">
-                <a16:creationId xmlns:a16="http://schemas.microsoft.com/office/drawing/2014/main" id="{C77B7205-CB2E-44CF-8089-D01814178CE1}"/>
+                <a16:creationId xmlns:a16="http://schemas.microsoft.com/office/drawing/2014/main" id="{818F9D34-F41C-47CF-B216-18B9A0F063F2}"/>
               </a:ext>
             </a:extLst>
           </p:cNvPr>
@@ -4254,7 +4254,7 @@
           <p:cNvPr id="13" name="">
             <a:extLst xmlns:a="http://schemas.openxmlformats.org/drawingml/2006/main">
               <a:ext uri="{FF2B5EF4-FFF2-40B4-BE49-F238E27FC236}">
-                <a16:creationId xmlns:a16="http://schemas.microsoft.com/office/drawing/2014/main" id="{C60A5104-F844-4C3A-A720-12CEB22BA4F5}"/>
+                <a16:creationId xmlns:a16="http://schemas.microsoft.com/office/drawing/2014/main" id="{67D7C71F-8C59-4F49-A7B5-CC74FB44A175}"/>
               </a:ext>
             </a:extLst>
           </p:cNvPr>
@@ -4287,7 +4287,7 @@
           <p:cNvPr id="14" name="">
             <a:extLst xmlns:a="http://schemas.openxmlformats.org/drawingml/2006/main">
               <a:ext uri="{FF2B5EF4-FFF2-40B4-BE49-F238E27FC236}">
-                <a16:creationId xmlns:a16="http://schemas.microsoft.com/office/drawing/2014/main" id="{C79AF021-31B4-4BAF-A8CE-47FA7BC45920}"/>
+                <a16:creationId xmlns:a16="http://schemas.microsoft.com/office/drawing/2014/main" id="{BF5F4B46-7A89-42CA-B8A3-25572100B539}"/>
               </a:ext>
             </a:extLst>
           </p:cNvPr>
@@ -4351,7 +4351,7 @@
           <p:cNvPr id="15" name="">
             <a:extLst xmlns:a="http://schemas.openxmlformats.org/drawingml/2006/main">
               <a:ext uri="{FF2B5EF4-FFF2-40B4-BE49-F238E27FC236}">
-                <a16:creationId xmlns:a16="http://schemas.microsoft.com/office/drawing/2014/main" id="{5BCF6330-815A-4866-BA66-1DFD3BD2270E}"/>
+                <a16:creationId xmlns:a16="http://schemas.microsoft.com/office/drawing/2014/main" id="{90E1F34D-0F2E-46AC-B094-C4E9D3B21EDB}"/>
               </a:ext>
             </a:extLst>
           </p:cNvPr>
@@ -4415,7 +4415,7 @@
           <p:cNvPr id="16" name="">
             <a:extLst xmlns:a="http://schemas.openxmlformats.org/drawingml/2006/main">
               <a:ext uri="{FF2B5EF4-FFF2-40B4-BE49-F238E27FC236}">
-                <a16:creationId xmlns:a16="http://schemas.microsoft.com/office/drawing/2014/main" id="{5C47B86F-BF91-44CA-81E0-F546E62945FB}"/>
+                <a16:creationId xmlns:a16="http://schemas.microsoft.com/office/drawing/2014/main" id="{26A6FB04-ACFC-4CAB-A693-D07DE22D3791}"/>
               </a:ext>
             </a:extLst>
           </p:cNvPr>
@@ -4479,7 +4479,7 @@
           <p:cNvPr id="17" name="">
             <a:extLst xmlns:a="http://schemas.openxmlformats.org/drawingml/2006/main">
               <a:ext uri="{FF2B5EF4-FFF2-40B4-BE49-F238E27FC236}">
-                <a16:creationId xmlns:a16="http://schemas.microsoft.com/office/drawing/2014/main" id="{6158891B-231E-49AE-BEF9-43D62EF42A9C}"/>
+                <a16:creationId xmlns:a16="http://schemas.microsoft.com/office/drawing/2014/main" id="{EDFD6E56-4705-44A3-B776-14FBBD16D6CF}"/>
               </a:ext>
             </a:extLst>
           </p:cNvPr>
@@ -4514,7 +4514,7 @@
           <p:cNvPr id="18" name="">
             <a:extLst xmlns:a="http://schemas.openxmlformats.org/drawingml/2006/main">
               <a:ext uri="{FF2B5EF4-FFF2-40B4-BE49-F238E27FC236}">
-                <a16:creationId xmlns:a16="http://schemas.microsoft.com/office/drawing/2014/main" id="{F289B166-CFB3-4ABB-8FAE-1A271D029815}"/>
+                <a16:creationId xmlns:a16="http://schemas.microsoft.com/office/drawing/2014/main" id="{E0DA1BC4-BD21-4406-9D07-322F4A49F7E8}"/>
               </a:ext>
             </a:extLst>
           </p:cNvPr>
@@ -4549,7 +4549,7 @@
           <p:cNvPr id="19" name="">
             <a:extLst xmlns:a="http://schemas.openxmlformats.org/drawingml/2006/main">
               <a:ext uri="{FF2B5EF4-FFF2-40B4-BE49-F238E27FC236}">
-                <a16:creationId xmlns:a16="http://schemas.microsoft.com/office/drawing/2014/main" id="{88A989A3-BFE1-4AAE-B5D5-DF90AA959CBD}"/>
+                <a16:creationId xmlns:a16="http://schemas.microsoft.com/office/drawing/2014/main" id="{D0AF59AE-A71D-47D2-8E4C-0708C7CBBFF6}"/>
               </a:ext>
             </a:extLst>
           </p:cNvPr>
@@ -4582,7 +4582,7 @@
           <p:cNvPr id="20" name="">
             <a:extLst xmlns:a="http://schemas.openxmlformats.org/drawingml/2006/main">
               <a:ext uri="{FF2B5EF4-FFF2-40B4-BE49-F238E27FC236}">
-                <a16:creationId xmlns:a16="http://schemas.microsoft.com/office/drawing/2014/main" id="{DCBFA746-A4E4-49D5-B851-CA124BC7FA74}"/>
+                <a16:creationId xmlns:a16="http://schemas.microsoft.com/office/drawing/2014/main" id="{3A2C30A5-41D4-4136-8694-B13FEE4AE1D3}"/>
               </a:ext>
             </a:extLst>
           </p:cNvPr>
@@ -4646,7 +4646,7 @@
           <p:cNvPr id="21" name="">
             <a:extLst xmlns:a="http://schemas.openxmlformats.org/drawingml/2006/main">
               <a:ext uri="{FF2B5EF4-FFF2-40B4-BE49-F238E27FC236}">
-                <a16:creationId xmlns:a16="http://schemas.microsoft.com/office/drawing/2014/main" id="{4F338FD1-AF6F-4F65-8E54-5BED2B6179D4}"/>
+                <a16:creationId xmlns:a16="http://schemas.microsoft.com/office/drawing/2014/main" id="{B8CE4715-9F2B-45EE-9361-067FC3A52CF8}"/>
               </a:ext>
             </a:extLst>
           </p:cNvPr>
@@ -4710,7 +4710,7 @@
           <p:cNvPr id="22" name="">
             <a:extLst xmlns:a="http://schemas.openxmlformats.org/drawingml/2006/main">
               <a:ext uri="{FF2B5EF4-FFF2-40B4-BE49-F238E27FC236}">
-                <a16:creationId xmlns:a16="http://schemas.microsoft.com/office/drawing/2014/main" id="{176433B6-53DA-4AA3-AE92-4727153436E9}"/>
+                <a16:creationId xmlns:a16="http://schemas.microsoft.com/office/drawing/2014/main" id="{C5CC51FC-F4C1-4480-BDA3-135AC54B895C}"/>
               </a:ext>
             </a:extLst>
           </p:cNvPr>
@@ -4774,7 +4774,7 @@
           <p:cNvPr id="23" name="">
             <a:extLst xmlns:a="http://schemas.openxmlformats.org/drawingml/2006/main">
               <a:ext uri="{FF2B5EF4-FFF2-40B4-BE49-F238E27FC236}">
-                <a16:creationId xmlns:a16="http://schemas.microsoft.com/office/drawing/2014/main" id="{2F4DFFD0-F385-47C8-9A9E-8F8003942F07}"/>
+                <a16:creationId xmlns:a16="http://schemas.microsoft.com/office/drawing/2014/main" id="{B9E04A1D-499E-495D-9CE7-5F5400DA23E0}"/>
               </a:ext>
             </a:extLst>
           </p:cNvPr>
@@ -4809,7 +4809,7 @@
           <p:cNvPr id="24" name="">
             <a:extLst xmlns:a="http://schemas.openxmlformats.org/drawingml/2006/main">
               <a:ext uri="{FF2B5EF4-FFF2-40B4-BE49-F238E27FC236}">
-                <a16:creationId xmlns:a16="http://schemas.microsoft.com/office/drawing/2014/main" id="{1E6F386A-5B58-444C-B3EB-E0DA4BF7D265}"/>
+                <a16:creationId xmlns:a16="http://schemas.microsoft.com/office/drawing/2014/main" id="{2BCC3AAE-FFDB-48B2-BD23-C6BB2F63BFB4}"/>
               </a:ext>
             </a:extLst>
           </p:cNvPr>
@@ -4844,7 +4844,7 @@
           <p:cNvPr id="25" name="">
             <a:extLst xmlns:a="http://schemas.openxmlformats.org/drawingml/2006/main">
               <a:ext uri="{FF2B5EF4-FFF2-40B4-BE49-F238E27FC236}">
-                <a16:creationId xmlns:a16="http://schemas.microsoft.com/office/drawing/2014/main" id="{74F300ED-DCB5-4A06-B63F-4C53658BCACC}"/>
+                <a16:creationId xmlns:a16="http://schemas.microsoft.com/office/drawing/2014/main" id="{70FB71C8-3332-4E82-8180-78DE1850831B}"/>
               </a:ext>
             </a:extLst>
           </p:cNvPr>
@@ -4877,7 +4877,7 @@
           <p:cNvPr id="26" name="">
             <a:extLst xmlns:a="http://schemas.openxmlformats.org/drawingml/2006/main">
               <a:ext uri="{FF2B5EF4-FFF2-40B4-BE49-F238E27FC236}">
-                <a16:creationId xmlns:a16="http://schemas.microsoft.com/office/drawing/2014/main" id="{683834FA-4E5D-4DDB-BB85-2CB383F35A4F}"/>
+                <a16:creationId xmlns:a16="http://schemas.microsoft.com/office/drawing/2014/main" id="{2A1E3C9D-44B2-4F67-AD30-A9C25BA91529}"/>
               </a:ext>
             </a:extLst>
           </p:cNvPr>
@@ -4941,7 +4941,7 @@
           <p:cNvPr id="27" name="">
             <a:extLst xmlns:a="http://schemas.openxmlformats.org/drawingml/2006/main">
               <a:ext uri="{FF2B5EF4-FFF2-40B4-BE49-F238E27FC236}">
-                <a16:creationId xmlns:a16="http://schemas.microsoft.com/office/drawing/2014/main" id="{EB050B2B-3CC1-4965-9A05-E2238475A169}"/>
+                <a16:creationId xmlns:a16="http://schemas.microsoft.com/office/drawing/2014/main" id="{1497E88F-B01D-4741-8832-EBB3BDA88326}"/>
               </a:ext>
             </a:extLst>
           </p:cNvPr>
@@ -5005,7 +5005,7 @@
           <p:cNvPr id="28" name="">
             <a:extLst xmlns:a="http://schemas.openxmlformats.org/drawingml/2006/main">
               <a:ext uri="{FF2B5EF4-FFF2-40B4-BE49-F238E27FC236}">
-                <a16:creationId xmlns:a16="http://schemas.microsoft.com/office/drawing/2014/main" id="{28258C98-98FA-40D7-B517-60E9746FFC12}"/>
+                <a16:creationId xmlns:a16="http://schemas.microsoft.com/office/drawing/2014/main" id="{9294193E-9809-45A1-961F-D68D24318436}"/>
               </a:ext>
             </a:extLst>
           </p:cNvPr>
@@ -5069,7 +5069,7 @@
           <p:cNvPr id="29" name="">
             <a:extLst xmlns:a="http://schemas.openxmlformats.org/drawingml/2006/main">
               <a:ext uri="{FF2B5EF4-FFF2-40B4-BE49-F238E27FC236}">
-                <a16:creationId xmlns:a16="http://schemas.microsoft.com/office/drawing/2014/main" id="{F6FAD033-C1A7-4594-BBD3-11DBEBFF8643}"/>
+                <a16:creationId xmlns:a16="http://schemas.microsoft.com/office/drawing/2014/main" id="{9F68A898-9EE2-451C-9FE0-4BC7E160BA7B}"/>
               </a:ext>
             </a:extLst>
           </p:cNvPr>
@@ -5131,7 +5131,7 @@
     </p:spTree>
     <p:extLst>
       <p:ext uri="{BB962C8B-B14F-4D97-AF65-F5344CB8AC3E}">
-        <p14:creationId xmlns:p14="http://schemas.microsoft.com/office/powerpoint/2010/main" val="761770065"/>
+        <p14:creationId xmlns:p14="http://schemas.microsoft.com/office/powerpoint/2010/main" val="1651815857"/>
       </p:ext>
     </p:extLst>
   </p:cSld>
@@ -5155,7 +5155,7 @@
           <p:cNvPr id="1" name="">
             <a:extLst xmlns:a="http://schemas.openxmlformats.org/drawingml/2006/main">
               <a:ext uri="{FF2B5EF4-FFF2-40B4-BE49-F238E27FC236}">
-                <a16:creationId xmlns:a16="http://schemas.microsoft.com/office/drawing/2014/main" id="{2F228816-C0F8-4B9E-80B0-F8FC484FD850}"/>
+                <a16:creationId xmlns:a16="http://schemas.microsoft.com/office/drawing/2014/main" id="{6C07750A-B41F-4BBB-96B5-7E491DD0A040}"/>
               </a:ext>
             </a:extLst>
           </p:cNvPr>
@@ -5190,7 +5190,7 @@
           <p:cNvPr id="2" name="kicker-marker">
             <a:extLst xmlns:a="http://schemas.openxmlformats.org/drawingml/2006/main">
               <a:ext uri="{FF2B5EF4-FFF2-40B4-BE49-F238E27FC236}">
-                <a16:creationId xmlns:a16="http://schemas.microsoft.com/office/drawing/2014/main" id="{F2F940B0-A1B7-4C53-9C02-AF429FFD4A16}"/>
+                <a16:creationId xmlns:a16="http://schemas.microsoft.com/office/drawing/2014/main" id="{35EAE529-7ACD-40A0-8FCA-A0194B11A151}"/>
               </a:ext>
             </a:extLst>
           </p:cNvPr>
@@ -5225,7 +5225,7 @@
           <p:cNvPr id="3" name="kicker-label">
             <a:extLst xmlns:a="http://schemas.openxmlformats.org/drawingml/2006/main">
               <a:ext uri="{FF2B5EF4-FFF2-40B4-BE49-F238E27FC236}">
-                <a16:creationId xmlns:a16="http://schemas.microsoft.com/office/drawing/2014/main" id="{9DEA610D-70A2-41A3-8E4E-89D37DE0266C}"/>
+                <a16:creationId xmlns:a16="http://schemas.microsoft.com/office/drawing/2014/main" id="{AB4BCF8C-012B-4953-BB1C-77080CE1F537}"/>
               </a:ext>
             </a:extLst>
           </p:cNvPr>
@@ -5289,7 +5289,7 @@
           <p:cNvPr id="4" name="">
             <a:extLst xmlns:a="http://schemas.openxmlformats.org/drawingml/2006/main">
               <a:ext uri="{FF2B5EF4-FFF2-40B4-BE49-F238E27FC236}">
-                <a16:creationId xmlns:a16="http://schemas.microsoft.com/office/drawing/2014/main" id="{B8A1A6D2-29D3-4FA0-BF5E-3C2608683F40}"/>
+                <a16:creationId xmlns:a16="http://schemas.microsoft.com/office/drawing/2014/main" id="{F9B12C39-75BB-473E-A86F-F211ADB90A15}"/>
               </a:ext>
             </a:extLst>
           </p:cNvPr>
@@ -5353,7 +5353,7 @@
           <p:cNvPr id="5" name="">
             <a:extLst xmlns:a="http://schemas.openxmlformats.org/drawingml/2006/main">
               <a:ext uri="{FF2B5EF4-FFF2-40B4-BE49-F238E27FC236}">
-                <a16:creationId xmlns:a16="http://schemas.microsoft.com/office/drawing/2014/main" id="{2CE76947-2F4A-44B7-A392-9EC4AD38593A}"/>
+                <a16:creationId xmlns:a16="http://schemas.microsoft.com/office/drawing/2014/main" id="{EF3CC9FA-B87C-4D83-8030-E523B382E7B3}"/>
               </a:ext>
             </a:extLst>
           </p:cNvPr>
@@ -5388,7 +5388,7 @@
           <p:cNvPr id="6" name="">
             <a:extLst xmlns:a="http://schemas.openxmlformats.org/drawingml/2006/main">
               <a:ext uri="{FF2B5EF4-FFF2-40B4-BE49-F238E27FC236}">
-                <a16:creationId xmlns:a16="http://schemas.microsoft.com/office/drawing/2014/main" id="{16122CB7-875A-4ABC-B762-36AD766B0163}"/>
+                <a16:creationId xmlns:a16="http://schemas.microsoft.com/office/drawing/2014/main" id="{F42CD34D-0743-4FB4-AA9A-43C05159A96E}"/>
               </a:ext>
             </a:extLst>
           </p:cNvPr>
@@ -5452,7 +5452,7 @@
           <p:cNvPr id="7" name="">
             <a:extLst xmlns:a="http://schemas.openxmlformats.org/drawingml/2006/main">
               <a:ext uri="{FF2B5EF4-FFF2-40B4-BE49-F238E27FC236}">
-                <a16:creationId xmlns:a16="http://schemas.microsoft.com/office/drawing/2014/main" id="{292E2E31-24C4-441B-AD81-011E844A511F}"/>
+                <a16:creationId xmlns:a16="http://schemas.microsoft.com/office/drawing/2014/main" id="{04996182-F896-4D6E-9A26-77178223936B}"/>
               </a:ext>
             </a:extLst>
           </p:cNvPr>
@@ -5516,7 +5516,7 @@
           <p:cNvPr id="8" name="">
             <a:extLst xmlns:a="http://schemas.openxmlformats.org/drawingml/2006/main">
               <a:ext uri="{FF2B5EF4-FFF2-40B4-BE49-F238E27FC236}">
-                <a16:creationId xmlns:a16="http://schemas.microsoft.com/office/drawing/2014/main" id="{A325BDE1-C025-440A-AD4F-72D13A2E51A3}"/>
+                <a16:creationId xmlns:a16="http://schemas.microsoft.com/office/drawing/2014/main" id="{AB68084B-AFD8-447C-94BE-1AB00245470C}"/>
               </a:ext>
             </a:extLst>
           </p:cNvPr>
@@ -5580,7 +5580,7 @@
           <p:cNvPr id="9" name="">
             <a:extLst xmlns:a="http://schemas.openxmlformats.org/drawingml/2006/main">
               <a:ext uri="{FF2B5EF4-FFF2-40B4-BE49-F238E27FC236}">
-                <a16:creationId xmlns:a16="http://schemas.microsoft.com/office/drawing/2014/main" id="{660C4A3A-6063-4853-BD20-0B167C7182F6}"/>
+                <a16:creationId xmlns:a16="http://schemas.microsoft.com/office/drawing/2014/main" id="{BB87FE9F-0CBF-46B6-AB73-B22754999493}"/>
               </a:ext>
             </a:extLst>
           </p:cNvPr>
@@ -5615,7 +5615,7 @@
           <p:cNvPr id="10" name="">
             <a:extLst xmlns:a="http://schemas.openxmlformats.org/drawingml/2006/main">
               <a:ext uri="{FF2B5EF4-FFF2-40B4-BE49-F238E27FC236}">
-                <a16:creationId xmlns:a16="http://schemas.microsoft.com/office/drawing/2014/main" id="{C458299C-C3F9-4946-A3EE-BF93473F3FC9}"/>
+                <a16:creationId xmlns:a16="http://schemas.microsoft.com/office/drawing/2014/main" id="{DC954A6D-7F09-40FC-9267-B64A8A07371F}"/>
               </a:ext>
             </a:extLst>
           </p:cNvPr>
@@ -5650,7 +5650,7 @@
           <p:cNvPr id="11" name="">
             <a:extLst xmlns:a="http://schemas.openxmlformats.org/drawingml/2006/main">
               <a:ext uri="{FF2B5EF4-FFF2-40B4-BE49-F238E27FC236}">
-                <a16:creationId xmlns:a16="http://schemas.microsoft.com/office/drawing/2014/main" id="{6C5021B3-CF14-4A23-80E5-284D2D730E2B}"/>
+                <a16:creationId xmlns:a16="http://schemas.microsoft.com/office/drawing/2014/main" id="{DC5683BD-BD9F-42D0-A649-ADD9D27FDE69}"/>
               </a:ext>
             </a:extLst>
           </p:cNvPr>
@@ -5714,7 +5714,7 @@
           <p:cNvPr id="12" name="">
             <a:extLst xmlns:a="http://schemas.openxmlformats.org/drawingml/2006/main">
               <a:ext uri="{FF2B5EF4-FFF2-40B4-BE49-F238E27FC236}">
-                <a16:creationId xmlns:a16="http://schemas.microsoft.com/office/drawing/2014/main" id="{B37692B5-165C-4EBD-B746-102C3AC46ADE}"/>
+                <a16:creationId xmlns:a16="http://schemas.microsoft.com/office/drawing/2014/main" id="{42D6FBCE-89E9-4D88-84D1-D6EF54422105}"/>
               </a:ext>
             </a:extLst>
           </p:cNvPr>
@@ -5778,7 +5778,7 @@
           <p:cNvPr id="13" name="">
             <a:extLst xmlns:a="http://schemas.openxmlformats.org/drawingml/2006/main">
               <a:ext uri="{FF2B5EF4-FFF2-40B4-BE49-F238E27FC236}">
-                <a16:creationId xmlns:a16="http://schemas.microsoft.com/office/drawing/2014/main" id="{4BACE1E4-5FA0-4451-A4A1-9DBF3E53A8F4}"/>
+                <a16:creationId xmlns:a16="http://schemas.microsoft.com/office/drawing/2014/main" id="{4A42FE9B-CA2F-4558-8ABA-FBEEC8FAF0F0}"/>
               </a:ext>
             </a:extLst>
           </p:cNvPr>
@@ -5813,7 +5813,7 @@
           <p:cNvPr id="14" name="">
             <a:extLst xmlns:a="http://schemas.openxmlformats.org/drawingml/2006/main">
               <a:ext uri="{FF2B5EF4-FFF2-40B4-BE49-F238E27FC236}">
-                <a16:creationId xmlns:a16="http://schemas.microsoft.com/office/drawing/2014/main" id="{EC3C961E-A454-492A-BA91-E387E96FAA6F}"/>
+                <a16:creationId xmlns:a16="http://schemas.microsoft.com/office/drawing/2014/main" id="{CB9929FE-74A8-4D97-9C84-32C7E089D563}"/>
               </a:ext>
             </a:extLst>
           </p:cNvPr>
@@ -5848,7 +5848,7 @@
           <p:cNvPr id="15" name="">
             <a:extLst xmlns:a="http://schemas.openxmlformats.org/drawingml/2006/main">
               <a:ext uri="{FF2B5EF4-FFF2-40B4-BE49-F238E27FC236}">
-                <a16:creationId xmlns:a16="http://schemas.microsoft.com/office/drawing/2014/main" id="{F8DE807C-DF17-4453-9E19-D2B4EE3A1554}"/>
+                <a16:creationId xmlns:a16="http://schemas.microsoft.com/office/drawing/2014/main" id="{F6DFE626-81B5-4855-930B-B28FDE265EB9}"/>
               </a:ext>
             </a:extLst>
           </p:cNvPr>
@@ -5912,7 +5912,7 @@
           <p:cNvPr id="16" name="">
             <a:extLst xmlns:a="http://schemas.openxmlformats.org/drawingml/2006/main">
               <a:ext uri="{FF2B5EF4-FFF2-40B4-BE49-F238E27FC236}">
-                <a16:creationId xmlns:a16="http://schemas.microsoft.com/office/drawing/2014/main" id="{9F6F930F-5F88-4456-AB7C-63B361481B6B}"/>
+                <a16:creationId xmlns:a16="http://schemas.microsoft.com/office/drawing/2014/main" id="{C932A0AB-6E18-4A83-B974-0EC4548D402E}"/>
               </a:ext>
             </a:extLst>
           </p:cNvPr>
@@ -5947,7 +5947,7 @@
           <p:cNvPr id="17" name="">
             <a:extLst xmlns:a="http://schemas.openxmlformats.org/drawingml/2006/main">
               <a:ext uri="{FF2B5EF4-FFF2-40B4-BE49-F238E27FC236}">
-                <a16:creationId xmlns:a16="http://schemas.microsoft.com/office/drawing/2014/main" id="{E4667241-FBF6-45E9-8351-DA787F7B16A2}"/>
+                <a16:creationId xmlns:a16="http://schemas.microsoft.com/office/drawing/2014/main" id="{AD71736A-CE7C-4660-AF24-5CEFA14A9A3D}"/>
               </a:ext>
             </a:extLst>
           </p:cNvPr>
@@ -6011,7 +6011,7 @@
           <p:cNvPr id="18" name="">
             <a:extLst xmlns:a="http://schemas.openxmlformats.org/drawingml/2006/main">
               <a:ext uri="{FF2B5EF4-FFF2-40B4-BE49-F238E27FC236}">
-                <a16:creationId xmlns:a16="http://schemas.microsoft.com/office/drawing/2014/main" id="{5A689B89-8808-4A85-BF3F-EE2B9AA8BE09}"/>
+                <a16:creationId xmlns:a16="http://schemas.microsoft.com/office/drawing/2014/main" id="{F1407938-B7E2-48D5-A278-A2FF2EC72A93}"/>
               </a:ext>
             </a:extLst>
           </p:cNvPr>
@@ -6046,7 +6046,7 @@
           <p:cNvPr id="19" name="">
             <a:extLst xmlns:a="http://schemas.openxmlformats.org/drawingml/2006/main">
               <a:ext uri="{FF2B5EF4-FFF2-40B4-BE49-F238E27FC236}">
-                <a16:creationId xmlns:a16="http://schemas.microsoft.com/office/drawing/2014/main" id="{4F230C86-359B-4620-86FD-5C3347E2A26C}"/>
+                <a16:creationId xmlns:a16="http://schemas.microsoft.com/office/drawing/2014/main" id="{7597D884-6B8F-4286-AE6F-A6609EE36987}"/>
               </a:ext>
             </a:extLst>
           </p:cNvPr>
@@ -6110,7 +6110,7 @@
           <p:cNvPr id="20" name="">
             <a:extLst xmlns:a="http://schemas.openxmlformats.org/drawingml/2006/main">
               <a:ext uri="{FF2B5EF4-FFF2-40B4-BE49-F238E27FC236}">
-                <a16:creationId xmlns:a16="http://schemas.microsoft.com/office/drawing/2014/main" id="{1D84D4C2-732F-4A6B-ADCB-7563C48AB3D5}"/>
+                <a16:creationId xmlns:a16="http://schemas.microsoft.com/office/drawing/2014/main" id="{25FA30AA-495F-4EB4-B7B3-06D90DD77701}"/>
               </a:ext>
             </a:extLst>
           </p:cNvPr>
@@ -6145,7 +6145,7 @@
           <p:cNvPr id="21" name="">
             <a:extLst xmlns:a="http://schemas.openxmlformats.org/drawingml/2006/main">
               <a:ext uri="{FF2B5EF4-FFF2-40B4-BE49-F238E27FC236}">
-                <a16:creationId xmlns:a16="http://schemas.microsoft.com/office/drawing/2014/main" id="{C9D43B53-23E5-4E53-8563-2637A7A06F0B}"/>
+                <a16:creationId xmlns:a16="http://schemas.microsoft.com/office/drawing/2014/main" id="{F439A0C3-8B6F-4AEC-ACAB-D051811F916F}"/>
               </a:ext>
             </a:extLst>
           </p:cNvPr>
@@ -6209,7 +6209,7 @@
           <p:cNvPr id="22" name="">
             <a:extLst xmlns:a="http://schemas.openxmlformats.org/drawingml/2006/main">
               <a:ext uri="{FF2B5EF4-FFF2-40B4-BE49-F238E27FC236}">
-                <a16:creationId xmlns:a16="http://schemas.microsoft.com/office/drawing/2014/main" id="{DC2A2930-ED65-4295-9EF9-F412751FA5E7}"/>
+                <a16:creationId xmlns:a16="http://schemas.microsoft.com/office/drawing/2014/main" id="{E74448CD-DAC7-44D1-A5F7-B66FBEF87783}"/>
               </a:ext>
             </a:extLst>
           </p:cNvPr>
@@ -6244,7 +6244,7 @@
           <p:cNvPr id="23" name="">
             <a:extLst xmlns:a="http://schemas.openxmlformats.org/drawingml/2006/main">
               <a:ext uri="{FF2B5EF4-FFF2-40B4-BE49-F238E27FC236}">
-                <a16:creationId xmlns:a16="http://schemas.microsoft.com/office/drawing/2014/main" id="{12AB8936-97B7-4D34-9D90-92E76CCA954D}"/>
+                <a16:creationId xmlns:a16="http://schemas.microsoft.com/office/drawing/2014/main" id="{834F1CE9-13C3-4ECC-8662-24E97A900E68}"/>
               </a:ext>
             </a:extLst>
           </p:cNvPr>
@@ -6308,7 +6308,7 @@
           <p:cNvPr id="24" name="">
             <a:extLst xmlns:a="http://schemas.openxmlformats.org/drawingml/2006/main">
               <a:ext uri="{FF2B5EF4-FFF2-40B4-BE49-F238E27FC236}">
-                <a16:creationId xmlns:a16="http://schemas.microsoft.com/office/drawing/2014/main" id="{59A9D98D-237E-4EFE-BC91-26A160BA09C4}"/>
+                <a16:creationId xmlns:a16="http://schemas.microsoft.com/office/drawing/2014/main" id="{F98328E0-77D8-4D2B-8361-43DFFD8AEEC7}"/>
               </a:ext>
             </a:extLst>
           </p:cNvPr>
@@ -6343,7 +6343,7 @@
           <p:cNvPr id="25" name="">
             <a:extLst xmlns:a="http://schemas.openxmlformats.org/drawingml/2006/main">
               <a:ext uri="{FF2B5EF4-FFF2-40B4-BE49-F238E27FC236}">
-                <a16:creationId xmlns:a16="http://schemas.microsoft.com/office/drawing/2014/main" id="{657E04A4-5063-47AD-AC42-69F42A3EE438}"/>
+                <a16:creationId xmlns:a16="http://schemas.microsoft.com/office/drawing/2014/main" id="{00AB0EB1-8A0E-4AC9-AB83-196DE5134907}"/>
               </a:ext>
             </a:extLst>
           </p:cNvPr>
@@ -6407,7 +6407,7 @@
           <p:cNvPr id="26" name="">
             <a:extLst xmlns:a="http://schemas.openxmlformats.org/drawingml/2006/main">
               <a:ext uri="{FF2B5EF4-FFF2-40B4-BE49-F238E27FC236}">
-                <a16:creationId xmlns:a16="http://schemas.microsoft.com/office/drawing/2014/main" id="{56B306DF-9B76-4EDB-A059-4EBD22C35038}"/>
+                <a16:creationId xmlns:a16="http://schemas.microsoft.com/office/drawing/2014/main" id="{74D575B3-0FB3-4AAD-81CA-6A7F80197978}"/>
               </a:ext>
             </a:extLst>
           </p:cNvPr>
@@ -6492,7 +6492,7 @@
     </p:spTree>
     <p:extLst>
       <p:ext uri="{BB962C8B-B14F-4D97-AF65-F5344CB8AC3E}">
-        <p14:creationId xmlns:p14="http://schemas.microsoft.com/office/powerpoint/2010/main" val="1710507550"/>
+        <p14:creationId xmlns:p14="http://schemas.microsoft.com/office/powerpoint/2010/main" val="1029438046"/>
       </p:ext>
     </p:extLst>
   </p:cSld>
@@ -6516,7 +6516,7 @@
           <p:cNvPr id="1" name="">
             <a:extLst xmlns:a="http://schemas.openxmlformats.org/drawingml/2006/main">
               <a:ext uri="{FF2B5EF4-FFF2-40B4-BE49-F238E27FC236}">
-                <a16:creationId xmlns:a16="http://schemas.microsoft.com/office/drawing/2014/main" id="{4B2F5B95-C758-4950-BFCC-94CC8EF914E3}"/>
+                <a16:creationId xmlns:a16="http://schemas.microsoft.com/office/drawing/2014/main" id="{FE87A255-1E39-4FC4-B338-D17ECFBF0189}"/>
               </a:ext>
             </a:extLst>
           </p:cNvPr>
@@ -6551,7 +6551,7 @@
           <p:cNvPr id="2" name="kicker-marker">
             <a:extLst xmlns:a="http://schemas.openxmlformats.org/drawingml/2006/main">
               <a:ext uri="{FF2B5EF4-FFF2-40B4-BE49-F238E27FC236}">
-                <a16:creationId xmlns:a16="http://schemas.microsoft.com/office/drawing/2014/main" id="{9AFE4CEA-0E5C-47EF-81C2-C9609048E6BB}"/>
+                <a16:creationId xmlns:a16="http://schemas.microsoft.com/office/drawing/2014/main" id="{FCF7A947-715D-408E-804F-C9D9B1C13CBB}"/>
               </a:ext>
             </a:extLst>
           </p:cNvPr>
@@ -6586,7 +6586,7 @@
           <p:cNvPr id="3" name="kicker-label">
             <a:extLst xmlns:a="http://schemas.openxmlformats.org/drawingml/2006/main">
               <a:ext uri="{FF2B5EF4-FFF2-40B4-BE49-F238E27FC236}">
-                <a16:creationId xmlns:a16="http://schemas.microsoft.com/office/drawing/2014/main" id="{919CD75A-347F-469F-8BBC-49A8C588C1A0}"/>
+                <a16:creationId xmlns:a16="http://schemas.microsoft.com/office/drawing/2014/main" id="{C8E68089-99ED-4644-9480-8BB4C5084DDC}"/>
               </a:ext>
             </a:extLst>
           </p:cNvPr>
@@ -6650,7 +6650,7 @@
           <p:cNvPr id="4" name="">
             <a:extLst xmlns:a="http://schemas.openxmlformats.org/drawingml/2006/main">
               <a:ext uri="{FF2B5EF4-FFF2-40B4-BE49-F238E27FC236}">
-                <a16:creationId xmlns:a16="http://schemas.microsoft.com/office/drawing/2014/main" id="{B878E681-8F7B-4B9B-A46B-CDFE8126A78B}"/>
+                <a16:creationId xmlns:a16="http://schemas.microsoft.com/office/drawing/2014/main" id="{36B8220A-5CFF-4762-9E1C-A2AF1E66D2C6}"/>
               </a:ext>
             </a:extLst>
           </p:cNvPr>
@@ -6714,7 +6714,7 @@
           <p:cNvPr id="5" name="">
             <a:extLst xmlns:a="http://schemas.openxmlformats.org/drawingml/2006/main">
               <a:ext uri="{FF2B5EF4-FFF2-40B4-BE49-F238E27FC236}">
-                <a16:creationId xmlns:a16="http://schemas.microsoft.com/office/drawing/2014/main" id="{584E0F91-77F9-4E83-8DD3-BE6BB1473010}"/>
+                <a16:creationId xmlns:a16="http://schemas.microsoft.com/office/drawing/2014/main" id="{AD47E282-A905-4A20-A398-9BB28A62260D}"/>
               </a:ext>
             </a:extLst>
           </p:cNvPr>
@@ -6749,7 +6749,7 @@
           <p:cNvPr id="6" name="">
             <a:extLst xmlns:a="http://schemas.openxmlformats.org/drawingml/2006/main">
               <a:ext uri="{FF2B5EF4-FFF2-40B4-BE49-F238E27FC236}">
-                <a16:creationId xmlns:a16="http://schemas.microsoft.com/office/drawing/2014/main" id="{A23E87E1-061A-4BA0-A8D6-6386BCEF5D15}"/>
+                <a16:creationId xmlns:a16="http://schemas.microsoft.com/office/drawing/2014/main" id="{1316EB68-D33C-4789-B7E9-130D1E95C460}"/>
               </a:ext>
             </a:extLst>
           </p:cNvPr>
@@ -6817,7 +6817,7 @@
           <p:nvPr/>
         </p:nvPicPr>
         <p:blipFill>
-          <a:blip xmlns:r="http://schemas.openxmlformats.org/officeDocument/2006/relationships" xmlns:a="http://schemas.openxmlformats.org/drawingml/2006/main" r:embed="Ra35b5d37a0c74524"/>
+          <a:blip xmlns:r="http://schemas.openxmlformats.org/officeDocument/2006/relationships" xmlns:a="http://schemas.openxmlformats.org/drawingml/2006/main" r:embed="R86eeed0b4e3b476a"/>
           <a:stretch xmlns:a="http://schemas.openxmlformats.org/drawingml/2006/main"/>
         </p:blipFill>
         <p:spPr>
@@ -6835,7 +6835,7 @@
           <p:cNvPr id="8" name="">
             <a:extLst xmlns:a="http://schemas.openxmlformats.org/drawingml/2006/main">
               <a:ext uri="{FF2B5EF4-FFF2-40B4-BE49-F238E27FC236}">
-                <a16:creationId xmlns:a16="http://schemas.microsoft.com/office/drawing/2014/main" id="{6384B585-5A7E-4616-989E-1886EFF55129}"/>
+                <a16:creationId xmlns:a16="http://schemas.microsoft.com/office/drawing/2014/main" id="{6FD9D9E2-CE7F-4BCA-B202-4502C0C9AA7B}"/>
               </a:ext>
             </a:extLst>
           </p:cNvPr>
@@ -6868,7 +6868,7 @@
     </p:spTree>
     <p:extLst>
       <p:ext uri="{BB962C8B-B14F-4D97-AF65-F5344CB8AC3E}">
-        <p14:creationId xmlns:p14="http://schemas.microsoft.com/office/powerpoint/2010/main" val="1139477270"/>
+        <p14:creationId xmlns:p14="http://schemas.microsoft.com/office/powerpoint/2010/main" val="307588250"/>
       </p:ext>
     </p:extLst>
   </p:cSld>
@@ -6892,7 +6892,7 @@
           <p:cNvPr id="1" name="">
             <a:extLst xmlns:a="http://schemas.openxmlformats.org/drawingml/2006/main">
               <a:ext uri="{FF2B5EF4-FFF2-40B4-BE49-F238E27FC236}">
-                <a16:creationId xmlns:a16="http://schemas.microsoft.com/office/drawing/2014/main" id="{99223DB3-143B-4762-9C6D-F27639D8AD5C}"/>
+                <a16:creationId xmlns:a16="http://schemas.microsoft.com/office/drawing/2014/main" id="{FC8DFC5A-172E-4C89-89B1-675F0C09F9A7}"/>
               </a:ext>
             </a:extLst>
           </p:cNvPr>
@@ -6927,7 +6927,7 @@
           <p:cNvPr id="2" name="kicker-marker">
             <a:extLst xmlns:a="http://schemas.openxmlformats.org/drawingml/2006/main">
               <a:ext uri="{FF2B5EF4-FFF2-40B4-BE49-F238E27FC236}">
-                <a16:creationId xmlns:a16="http://schemas.microsoft.com/office/drawing/2014/main" id="{7C16F9A2-BA9D-4577-AF1F-5DDEA54C2323}"/>
+                <a16:creationId xmlns:a16="http://schemas.microsoft.com/office/drawing/2014/main" id="{878205F5-423D-49D3-B984-C12D8A94F64C}"/>
               </a:ext>
             </a:extLst>
           </p:cNvPr>
@@ -6962,7 +6962,7 @@
           <p:cNvPr id="3" name="kicker-label">
             <a:extLst xmlns:a="http://schemas.openxmlformats.org/drawingml/2006/main">
               <a:ext uri="{FF2B5EF4-FFF2-40B4-BE49-F238E27FC236}">
-                <a16:creationId xmlns:a16="http://schemas.microsoft.com/office/drawing/2014/main" id="{899CB4BA-F29F-48C2-A123-E105B826C0C7}"/>
+                <a16:creationId xmlns:a16="http://schemas.microsoft.com/office/drawing/2014/main" id="{0E007019-3134-4828-8CFB-9C712E432D35}"/>
               </a:ext>
             </a:extLst>
           </p:cNvPr>
@@ -7026,7 +7026,7 @@
           <p:cNvPr id="4" name="">
             <a:extLst xmlns:a="http://schemas.openxmlformats.org/drawingml/2006/main">
               <a:ext uri="{FF2B5EF4-FFF2-40B4-BE49-F238E27FC236}">
-                <a16:creationId xmlns:a16="http://schemas.microsoft.com/office/drawing/2014/main" id="{2A83B115-6710-418A-94CA-851CD24985D9}"/>
+                <a16:creationId xmlns:a16="http://schemas.microsoft.com/office/drawing/2014/main" id="{26A8AE47-827C-4806-96C5-21D30303AD1A}"/>
               </a:ext>
             </a:extLst>
           </p:cNvPr>
@@ -7090,7 +7090,7 @@
           <p:cNvPr id="5" name="">
             <a:extLst xmlns:a="http://schemas.openxmlformats.org/drawingml/2006/main">
               <a:ext uri="{FF2B5EF4-FFF2-40B4-BE49-F238E27FC236}">
-                <a16:creationId xmlns:a16="http://schemas.microsoft.com/office/drawing/2014/main" id="{BF74DEFA-10D8-4EAC-91E0-9411CFF48972}"/>
+                <a16:creationId xmlns:a16="http://schemas.microsoft.com/office/drawing/2014/main" id="{35A37D47-F34B-45F4-A0E2-3C00FC6D8D4B}"/>
               </a:ext>
             </a:extLst>
           </p:cNvPr>
@@ -7125,7 +7125,7 @@
           <p:cNvPr id="6" name="">
             <a:extLst xmlns:a="http://schemas.openxmlformats.org/drawingml/2006/main">
               <a:ext uri="{FF2B5EF4-FFF2-40B4-BE49-F238E27FC236}">
-                <a16:creationId xmlns:a16="http://schemas.microsoft.com/office/drawing/2014/main" id="{08A54436-D023-4835-A9A8-BF703E122705}"/>
+                <a16:creationId xmlns:a16="http://schemas.microsoft.com/office/drawing/2014/main" id="{BFEEF676-E37F-4AB4-8B74-DD076C1E6619}"/>
               </a:ext>
             </a:extLst>
           </p:cNvPr>
@@ -7193,7 +7193,7 @@
           <p:nvPr/>
         </p:nvPicPr>
         <p:blipFill>
-          <a:blip xmlns:r="http://schemas.openxmlformats.org/officeDocument/2006/relationships" xmlns:a="http://schemas.openxmlformats.org/drawingml/2006/main" r:embed="Reba701fc9b234190"/>
+          <a:blip xmlns:r="http://schemas.openxmlformats.org/officeDocument/2006/relationships" xmlns:a="http://schemas.openxmlformats.org/drawingml/2006/main" r:embed="R1c43f98be2454e48"/>
           <a:stretch xmlns:a="http://schemas.openxmlformats.org/drawingml/2006/main"/>
         </p:blipFill>
         <p:spPr>
@@ -7211,7 +7211,7 @@
           <p:cNvPr id="8" name="">
             <a:extLst xmlns:a="http://schemas.openxmlformats.org/drawingml/2006/main">
               <a:ext uri="{FF2B5EF4-FFF2-40B4-BE49-F238E27FC236}">
-                <a16:creationId xmlns:a16="http://schemas.microsoft.com/office/drawing/2014/main" id="{A9998FA5-29E6-4DF6-B9FC-05DEB03C4B11}"/>
+                <a16:creationId xmlns:a16="http://schemas.microsoft.com/office/drawing/2014/main" id="{9CBC782F-6C0A-43B9-9F81-96C6C0EAA92B}"/>
               </a:ext>
             </a:extLst>
           </p:cNvPr>
@@ -7244,7 +7244,7 @@
     </p:spTree>
     <p:extLst>
       <p:ext uri="{BB962C8B-B14F-4D97-AF65-F5344CB8AC3E}">
-        <p14:creationId xmlns:p14="http://schemas.microsoft.com/office/powerpoint/2010/main" val="47362633"/>
+        <p14:creationId xmlns:p14="http://schemas.microsoft.com/office/powerpoint/2010/main" val="2118961569"/>
       </p:ext>
     </p:extLst>
   </p:cSld>
@@ -7268,7 +7268,7 @@
           <p:cNvPr id="1" name="">
             <a:extLst xmlns:a="http://schemas.openxmlformats.org/drawingml/2006/main">
               <a:ext uri="{FF2B5EF4-FFF2-40B4-BE49-F238E27FC236}">
-                <a16:creationId xmlns:a16="http://schemas.microsoft.com/office/drawing/2014/main" id="{E2A92CDD-AC1A-4068-B011-386E00CA9279}"/>
+                <a16:creationId xmlns:a16="http://schemas.microsoft.com/office/drawing/2014/main" id="{CD85A629-B903-4E3B-A1FD-26F2AA0E928B}"/>
               </a:ext>
             </a:extLst>
           </p:cNvPr>
@@ -7303,7 +7303,7 @@
           <p:cNvPr id="2" name="kicker-marker">
             <a:extLst xmlns:a="http://schemas.openxmlformats.org/drawingml/2006/main">
               <a:ext uri="{FF2B5EF4-FFF2-40B4-BE49-F238E27FC236}">
-                <a16:creationId xmlns:a16="http://schemas.microsoft.com/office/drawing/2014/main" id="{0F5D6597-123A-4E82-A59F-08DA1F89D069}"/>
+                <a16:creationId xmlns:a16="http://schemas.microsoft.com/office/drawing/2014/main" id="{4B7C0DE6-D5F3-41CA-81D7-5309A2AEFFB6}"/>
               </a:ext>
             </a:extLst>
           </p:cNvPr>
@@ -7338,7 +7338,7 @@
           <p:cNvPr id="3" name="kicker-label">
             <a:extLst xmlns:a="http://schemas.openxmlformats.org/drawingml/2006/main">
               <a:ext uri="{FF2B5EF4-FFF2-40B4-BE49-F238E27FC236}">
-                <a16:creationId xmlns:a16="http://schemas.microsoft.com/office/drawing/2014/main" id="{D2D999D6-109C-4351-AEAC-0219A2AC2894}"/>
+                <a16:creationId xmlns:a16="http://schemas.microsoft.com/office/drawing/2014/main" id="{DDC023E5-5E43-4661-BB55-CFA3367CBB73}"/>
               </a:ext>
             </a:extLst>
           </p:cNvPr>
@@ -7402,7 +7402,7 @@
           <p:cNvPr id="4" name="">
             <a:extLst xmlns:a="http://schemas.openxmlformats.org/drawingml/2006/main">
               <a:ext uri="{FF2B5EF4-FFF2-40B4-BE49-F238E27FC236}">
-                <a16:creationId xmlns:a16="http://schemas.microsoft.com/office/drawing/2014/main" id="{291C176D-31A4-4947-957A-EE670EF4015F}"/>
+                <a16:creationId xmlns:a16="http://schemas.microsoft.com/office/drawing/2014/main" id="{DB512E21-E118-48D9-89E4-023BEC339C23}"/>
               </a:ext>
             </a:extLst>
           </p:cNvPr>
@@ -7466,7 +7466,7 @@
           <p:cNvPr id="5" name="">
             <a:extLst xmlns:a="http://schemas.openxmlformats.org/drawingml/2006/main">
               <a:ext uri="{FF2B5EF4-FFF2-40B4-BE49-F238E27FC236}">
-                <a16:creationId xmlns:a16="http://schemas.microsoft.com/office/drawing/2014/main" id="{536804E3-7D3C-48BB-9708-1BCCC4804D2F}"/>
+                <a16:creationId xmlns:a16="http://schemas.microsoft.com/office/drawing/2014/main" id="{C0B0218A-8DFB-4E7F-AEC5-156979D891C0}"/>
               </a:ext>
             </a:extLst>
           </p:cNvPr>
@@ -7501,7 +7501,7 @@
           <p:cNvPr id="6" name="">
             <a:extLst xmlns:a="http://schemas.openxmlformats.org/drawingml/2006/main">
               <a:ext uri="{FF2B5EF4-FFF2-40B4-BE49-F238E27FC236}">
-                <a16:creationId xmlns:a16="http://schemas.microsoft.com/office/drawing/2014/main" id="{777BF879-E279-4EFC-9830-A2663E226F2D}"/>
+                <a16:creationId xmlns:a16="http://schemas.microsoft.com/office/drawing/2014/main" id="{00FF2F59-A492-4C11-B894-F067386E8098}"/>
               </a:ext>
             </a:extLst>
           </p:cNvPr>
@@ -7569,7 +7569,7 @@
           <p:nvPr/>
         </p:nvPicPr>
         <p:blipFill>
-          <a:blip xmlns:r="http://schemas.openxmlformats.org/officeDocument/2006/relationships" xmlns:a="http://schemas.openxmlformats.org/drawingml/2006/main" r:embed="Rece9d1c75e994668"/>
+          <a:blip xmlns:r="http://schemas.openxmlformats.org/officeDocument/2006/relationships" xmlns:a="http://schemas.openxmlformats.org/drawingml/2006/main" r:embed="Rbb4658029b1f4955"/>
           <a:stretch xmlns:a="http://schemas.openxmlformats.org/drawingml/2006/main"/>
         </p:blipFill>
         <p:spPr>
@@ -7587,7 +7587,7 @@
           <p:cNvPr id="8" name="">
             <a:extLst xmlns:a="http://schemas.openxmlformats.org/drawingml/2006/main">
               <a:ext uri="{FF2B5EF4-FFF2-40B4-BE49-F238E27FC236}">
-                <a16:creationId xmlns:a16="http://schemas.microsoft.com/office/drawing/2014/main" id="{60F0060E-8087-414C-B8CC-CCB449D02828}"/>
+                <a16:creationId xmlns:a16="http://schemas.microsoft.com/office/drawing/2014/main" id="{8C196E01-A26D-412B-B186-3DAD7DE2C9C2}"/>
               </a:ext>
             </a:extLst>
           </p:cNvPr>
@@ -7622,7 +7622,7 @@
           <p:cNvPr id="9" name="">
             <a:extLst xmlns:a="http://schemas.openxmlformats.org/drawingml/2006/main">
               <a:ext uri="{FF2B5EF4-FFF2-40B4-BE49-F238E27FC236}">
-                <a16:creationId xmlns:a16="http://schemas.microsoft.com/office/drawing/2014/main" id="{A49F219D-DD58-4230-B6AC-766FFEAE41E6}"/>
+                <a16:creationId xmlns:a16="http://schemas.microsoft.com/office/drawing/2014/main" id="{5311B018-AD46-4756-98AE-5D29978FE873}"/>
               </a:ext>
             </a:extLst>
           </p:cNvPr>
@@ -7657,7 +7657,7 @@
           <p:cNvPr id="10" name="">
             <a:extLst xmlns:a="http://schemas.openxmlformats.org/drawingml/2006/main">
               <a:ext uri="{FF2B5EF4-FFF2-40B4-BE49-F238E27FC236}">
-                <a16:creationId xmlns:a16="http://schemas.microsoft.com/office/drawing/2014/main" id="{BE40CBAD-CEEC-4FFA-A0C4-AB7EDC93FC32}"/>
+                <a16:creationId xmlns:a16="http://schemas.microsoft.com/office/drawing/2014/main" id="{E28BCEBF-AA0F-485B-803F-18AAD4BEB97C}"/>
               </a:ext>
             </a:extLst>
           </p:cNvPr>
@@ -7721,7 +7721,7 @@
           <p:cNvPr id="11" name="">
             <a:extLst xmlns:a="http://schemas.openxmlformats.org/drawingml/2006/main">
               <a:ext uri="{FF2B5EF4-FFF2-40B4-BE49-F238E27FC236}">
-                <a16:creationId xmlns:a16="http://schemas.microsoft.com/office/drawing/2014/main" id="{0CD298F0-C435-4AAB-9B7F-7F1B0408AB46}"/>
+                <a16:creationId xmlns:a16="http://schemas.microsoft.com/office/drawing/2014/main" id="{045E2C48-158D-4EBF-8848-96DCDDEC4FB7}"/>
               </a:ext>
             </a:extLst>
           </p:cNvPr>
@@ -7776,7 +7776,7 @@
                 <a:cs typeface="Aptos"/>
                 <a:hlinkClick xmlns:r="http://schemas.openxmlformats.org/officeDocument/2006/relationships" r:id="rIdSynthAMLDemo"/>
               </a:rPr>
-              <a:t>https://rawcdn.githack.com/yq688m3JT/genAI_final/fa4ed4cc3ab6dd13d10fa40e40ec5e6036816755/docs/demo.html</a:t>
+              <a:t>https://rawcdn.githack.com/yq688m3JT/genAI_final/ae9c84ea574e9f8c48c84f1863ce82f77ea4f24e/docs/demo.html</a:t>
             </a:r>
           </a:p>
         </p:txBody>
@@ -7784,7 +7784,7 @@
     </p:spTree>
     <p:extLst>
       <p:ext uri="{BB962C8B-B14F-4D97-AF65-F5344CB8AC3E}">
-        <p14:creationId xmlns:p14="http://schemas.microsoft.com/office/powerpoint/2010/main" val="1281509914"/>
+        <p14:creationId xmlns:p14="http://schemas.microsoft.com/office/powerpoint/2010/main" val="51217630"/>
       </p:ext>
     </p:extLst>
   </p:cSld>

</xml_diff>

<commit_message>
Use verified provider-neutral demo link
</commit_message>
<xml_diff>
--- a/docs/synthaml-final-presentation.pptx
+++ b/docs/synthaml-final-presentation.pptx
@@ -2,19 +2,19 @@
 <file path=ppt/presentation.xml><?xml version="1.0" encoding="utf-8"?>
 <p:presentation xmlns:p="http://schemas.openxmlformats.org/presentationml/2006/main">
   <p:sldMasterIdLst>
-    <p:sldMasterId xmlns:r="http://schemas.openxmlformats.org/officeDocument/2006/relationships" id="2147483648" r:id="R676618f2ed544caf"/>
+    <p:sldMasterId xmlns:r="http://schemas.openxmlformats.org/officeDocument/2006/relationships" id="2147483648" r:id="R71a4390f428a4c65"/>
   </p:sldMasterIdLst>
   <p:notesMasterIdLst>
-    <p:notesMasterId xmlns:r="http://schemas.openxmlformats.org/officeDocument/2006/relationships" r:id="R7451d07de85d404d"/>
+    <p:notesMasterId xmlns:r="http://schemas.openxmlformats.org/officeDocument/2006/relationships" r:id="R81e22df8ee9f4bd4"/>
   </p:notesMasterIdLst>
   <p:sldIdLst>
-    <p:sldId xmlns:r="http://schemas.openxmlformats.org/officeDocument/2006/relationships" id="256" r:id="R5d3dff96ee844a69"/>
-    <p:sldId xmlns:r="http://schemas.openxmlformats.org/officeDocument/2006/relationships" id="257" r:id="Rc08bb64295724935"/>
-    <p:sldId xmlns:r="http://schemas.openxmlformats.org/officeDocument/2006/relationships" id="258" r:id="Rcb298f6f67cd45ee"/>
-    <p:sldId xmlns:r="http://schemas.openxmlformats.org/officeDocument/2006/relationships" id="259" r:id="R3fdd5ed9ba6e4da8"/>
-    <p:sldId xmlns:r="http://schemas.openxmlformats.org/officeDocument/2006/relationships" id="260" r:id="R38eff184b63644dc"/>
-    <p:sldId xmlns:r="http://schemas.openxmlformats.org/officeDocument/2006/relationships" id="261" r:id="R243fecb820044f4f"/>
-    <p:sldId xmlns:r="http://schemas.openxmlformats.org/officeDocument/2006/relationships" id="262" r:id="Ra84ff06708ae4fb2"/>
+    <p:sldId xmlns:r="http://schemas.openxmlformats.org/officeDocument/2006/relationships" id="256" r:id="Race3df6aa8b04633"/>
+    <p:sldId xmlns:r="http://schemas.openxmlformats.org/officeDocument/2006/relationships" id="257" r:id="R12498c26eb544bf8"/>
+    <p:sldId xmlns:r="http://schemas.openxmlformats.org/officeDocument/2006/relationships" id="258" r:id="R1dc6af62d7ad4969"/>
+    <p:sldId xmlns:r="http://schemas.openxmlformats.org/officeDocument/2006/relationships" id="259" r:id="Rfd203ee9ef1a40f4"/>
+    <p:sldId xmlns:r="http://schemas.openxmlformats.org/officeDocument/2006/relationships" id="260" r:id="Rc88bbad68cc748a2"/>
+    <p:sldId xmlns:r="http://schemas.openxmlformats.org/officeDocument/2006/relationships" id="261" r:id="Rea5bd50138b54e40"/>
+    <p:sldId xmlns:r="http://schemas.openxmlformats.org/officeDocument/2006/relationships" id="262" r:id="Rb63e02b0a9db468a"/>
   </p:sldIdLst>
   <p:sldSz cx="12192000" cy="6858000"/>
   <p:notesSz cx="6858000" cy="9144000"/>
@@ -957,7 +957,7 @@
   </p:cSld>
   <p:clrMap bg1="lt1" tx1="dk1" bg2="lt2" tx2="dk2" accent1="accent1" accent2="accent2" accent3="accent3" accent4="accent4" accent5="accent5" accent6="accent6" hlink="hlink" folHlink="folHlink"/>
   <p:sldLayoutIdLst>
-    <p:sldLayoutId xmlns:r="http://schemas.openxmlformats.org/officeDocument/2006/relationships" id="2147483649" r:id="Rbfb9e5eff8d849ca"/>
+    <p:sldLayoutId xmlns:r="http://schemas.openxmlformats.org/officeDocument/2006/relationships" id="2147483649" r:id="R69bd17f494fe4ce3"/>
   </p:sldLayoutIdLst>
   <p:txStyles>
     <p:titleStyle>
@@ -1256,7 +1256,7 @@
           <p:cNvPr id="1" name="">
             <a:extLst xmlns:a="http://schemas.openxmlformats.org/drawingml/2006/main">
               <a:ext uri="{FF2B5EF4-FFF2-40B4-BE49-F238E27FC236}">
-                <a16:creationId xmlns:a16="http://schemas.microsoft.com/office/drawing/2014/main" id="{FB71E7F6-4E29-45D1-BE89-28B59992DEBE}"/>
+                <a16:creationId xmlns:a16="http://schemas.microsoft.com/office/drawing/2014/main" id="{8CA75212-C959-495C-A4BA-3FF06CBF5029}"/>
               </a:ext>
             </a:extLst>
           </p:cNvPr>
@@ -1291,7 +1291,7 @@
           <p:cNvPr id="2" name="">
             <a:extLst xmlns:a="http://schemas.openxmlformats.org/drawingml/2006/main">
               <a:ext uri="{FF2B5EF4-FFF2-40B4-BE49-F238E27FC236}">
-                <a16:creationId xmlns:a16="http://schemas.microsoft.com/office/drawing/2014/main" id="{63C637B8-DAB7-4C9D-9F6C-2C721F1409FA}"/>
+                <a16:creationId xmlns:a16="http://schemas.microsoft.com/office/drawing/2014/main" id="{19BD1D39-F9C3-47A8-82BD-A9EC18A64BC9}"/>
               </a:ext>
             </a:extLst>
           </p:cNvPr>
@@ -1326,7 +1326,7 @@
           <p:cNvPr id="3" name="">
             <a:extLst xmlns:a="http://schemas.openxmlformats.org/drawingml/2006/main">
               <a:ext uri="{FF2B5EF4-FFF2-40B4-BE49-F238E27FC236}">
-                <a16:creationId xmlns:a16="http://schemas.microsoft.com/office/drawing/2014/main" id="{F3726672-2857-4E9D-85FE-8A22E2BA8559}"/>
+                <a16:creationId xmlns:a16="http://schemas.microsoft.com/office/drawing/2014/main" id="{9B724D6F-A28C-4E6F-8D70-B363880E25A9}"/>
               </a:ext>
             </a:extLst>
           </p:cNvPr>
@@ -1390,7 +1390,7 @@
           <p:cNvPr id="4" name="">
             <a:extLst xmlns:a="http://schemas.openxmlformats.org/drawingml/2006/main">
               <a:ext uri="{FF2B5EF4-FFF2-40B4-BE49-F238E27FC236}">
-                <a16:creationId xmlns:a16="http://schemas.microsoft.com/office/drawing/2014/main" id="{B62B1546-6FC9-4F25-BD71-BF6DD7837ECA}"/>
+                <a16:creationId xmlns:a16="http://schemas.microsoft.com/office/drawing/2014/main" id="{C3FCD9E7-8B5A-4851-A0FE-8F1B3B6AF865}"/>
               </a:ext>
             </a:extLst>
           </p:cNvPr>
@@ -1454,7 +1454,7 @@
           <p:cNvPr id="5" name="">
             <a:extLst xmlns:a="http://schemas.openxmlformats.org/drawingml/2006/main">
               <a:ext uri="{FF2B5EF4-FFF2-40B4-BE49-F238E27FC236}">
-                <a16:creationId xmlns:a16="http://schemas.microsoft.com/office/drawing/2014/main" id="{B48A0A71-9251-407A-9D03-605CF81FE9CC}"/>
+                <a16:creationId xmlns:a16="http://schemas.microsoft.com/office/drawing/2014/main" id="{B172D1C9-28D8-4447-A7B2-66C16D1B108E}"/>
               </a:ext>
             </a:extLst>
           </p:cNvPr>
@@ -1518,7 +1518,7 @@
           <p:cNvPr id="6" name="">
             <a:extLst xmlns:a="http://schemas.openxmlformats.org/drawingml/2006/main">
               <a:ext uri="{FF2B5EF4-FFF2-40B4-BE49-F238E27FC236}">
-                <a16:creationId xmlns:a16="http://schemas.microsoft.com/office/drawing/2014/main" id="{94F05287-7A9E-4609-BADB-2FEED5DA5230}"/>
+                <a16:creationId xmlns:a16="http://schemas.microsoft.com/office/drawing/2014/main" id="{CA8FC23B-6771-40C7-B19D-CD6F286938C8}"/>
               </a:ext>
             </a:extLst>
           </p:cNvPr>
@@ -1553,7 +1553,7 @@
           <p:cNvPr id="7" name="">
             <a:extLst xmlns:a="http://schemas.openxmlformats.org/drawingml/2006/main">
               <a:ext uri="{FF2B5EF4-FFF2-40B4-BE49-F238E27FC236}">
-                <a16:creationId xmlns:a16="http://schemas.microsoft.com/office/drawing/2014/main" id="{4D090D51-1963-4811-BCC6-295D1A456E15}"/>
+                <a16:creationId xmlns:a16="http://schemas.microsoft.com/office/drawing/2014/main" id="{FAFAEF81-651B-4CDA-881E-126486DF311A}"/>
               </a:ext>
             </a:extLst>
           </p:cNvPr>
@@ -1617,7 +1617,7 @@
           <p:cNvPr id="8" name="">
             <a:extLst xmlns:a="http://schemas.openxmlformats.org/drawingml/2006/main">
               <a:ext uri="{FF2B5EF4-FFF2-40B4-BE49-F238E27FC236}">
-                <a16:creationId xmlns:a16="http://schemas.microsoft.com/office/drawing/2014/main" id="{8306F00A-323C-44A0-955A-529C3B0A3381}"/>
+                <a16:creationId xmlns:a16="http://schemas.microsoft.com/office/drawing/2014/main" id="{C52C7766-19A5-467D-96A4-E92A44D38B0A}"/>
               </a:ext>
             </a:extLst>
           </p:cNvPr>
@@ -1681,7 +1681,7 @@
           <p:cNvPr id="9" name="">
             <a:extLst xmlns:a="http://schemas.openxmlformats.org/drawingml/2006/main">
               <a:ext uri="{FF2B5EF4-FFF2-40B4-BE49-F238E27FC236}">
-                <a16:creationId xmlns:a16="http://schemas.microsoft.com/office/drawing/2014/main" id="{2C793AFE-A6A3-4465-BEEE-39E1CE29C57D}"/>
+                <a16:creationId xmlns:a16="http://schemas.microsoft.com/office/drawing/2014/main" id="{4BDE4BF2-ECA5-487E-B223-5803942AC1D1}"/>
               </a:ext>
             </a:extLst>
           </p:cNvPr>
@@ -1745,7 +1745,7 @@
           <p:cNvPr id="10" name="">
             <a:extLst xmlns:a="http://schemas.openxmlformats.org/drawingml/2006/main">
               <a:ext uri="{FF2B5EF4-FFF2-40B4-BE49-F238E27FC236}">
-                <a16:creationId xmlns:a16="http://schemas.microsoft.com/office/drawing/2014/main" id="{5407FBDD-F5A4-4A70-A80D-C0CF5B5681F1}"/>
+                <a16:creationId xmlns:a16="http://schemas.microsoft.com/office/drawing/2014/main" id="{EA47B0F5-D497-49F1-AE6B-68EF7FB695BF}"/>
               </a:ext>
             </a:extLst>
           </p:cNvPr>
@@ -1809,7 +1809,7 @@
           <p:cNvPr id="11" name="">
             <a:extLst xmlns:a="http://schemas.openxmlformats.org/drawingml/2006/main">
               <a:ext uri="{FF2B5EF4-FFF2-40B4-BE49-F238E27FC236}">
-                <a16:creationId xmlns:a16="http://schemas.microsoft.com/office/drawing/2014/main" id="{81514B6C-9A2C-494A-B511-AC077B884407}"/>
+                <a16:creationId xmlns:a16="http://schemas.microsoft.com/office/drawing/2014/main" id="{804A1E72-C5BB-4265-BEC9-F050E613BBDB}"/>
               </a:ext>
             </a:extLst>
           </p:cNvPr>
@@ -1873,7 +1873,7 @@
           <p:cNvPr id="12" name="">
             <a:extLst xmlns:a="http://schemas.openxmlformats.org/drawingml/2006/main">
               <a:ext uri="{FF2B5EF4-FFF2-40B4-BE49-F238E27FC236}">
-                <a16:creationId xmlns:a16="http://schemas.microsoft.com/office/drawing/2014/main" id="{66C7CFB0-FC0D-497F-AA3C-E1A6F982D764}"/>
+                <a16:creationId xmlns:a16="http://schemas.microsoft.com/office/drawing/2014/main" id="{A403817F-B063-49FE-B0CC-EC01DA254F8D}"/>
               </a:ext>
             </a:extLst>
           </p:cNvPr>
@@ -1937,7 +1937,7 @@
           <p:cNvPr id="13" name="">
             <a:extLst xmlns:a="http://schemas.openxmlformats.org/drawingml/2006/main">
               <a:ext uri="{FF2B5EF4-FFF2-40B4-BE49-F238E27FC236}">
-                <a16:creationId xmlns:a16="http://schemas.microsoft.com/office/drawing/2014/main" id="{23A71A04-7A43-4085-B50F-E9467243264C}"/>
+                <a16:creationId xmlns:a16="http://schemas.microsoft.com/office/drawing/2014/main" id="{8A6211C8-76D1-43D3-A89B-86EEF0B53C1C}"/>
               </a:ext>
             </a:extLst>
           </p:cNvPr>
@@ -1972,7 +1972,7 @@
           <p:cNvPr id="14" name="">
             <a:extLst xmlns:a="http://schemas.openxmlformats.org/drawingml/2006/main">
               <a:ext uri="{FF2B5EF4-FFF2-40B4-BE49-F238E27FC236}">
-                <a16:creationId xmlns:a16="http://schemas.microsoft.com/office/drawing/2014/main" id="{51F48236-9EB8-4417-931C-090140CC97CD}"/>
+                <a16:creationId xmlns:a16="http://schemas.microsoft.com/office/drawing/2014/main" id="{5D75E9D0-9AAE-4EAF-9C8B-82498C5E7BBD}"/>
               </a:ext>
             </a:extLst>
           </p:cNvPr>
@@ -2036,7 +2036,7 @@
           <p:cNvPr id="15" name="">
             <a:extLst xmlns:a="http://schemas.openxmlformats.org/drawingml/2006/main">
               <a:ext uri="{FF2B5EF4-FFF2-40B4-BE49-F238E27FC236}">
-                <a16:creationId xmlns:a16="http://schemas.microsoft.com/office/drawing/2014/main" id="{3EA9E8D5-3240-4A30-9DF0-FFCE286EEF19}"/>
+                <a16:creationId xmlns:a16="http://schemas.microsoft.com/office/drawing/2014/main" id="{77126ECF-1B0B-4637-88C1-C2427BB25364}"/>
               </a:ext>
             </a:extLst>
           </p:cNvPr>
@@ -2123,7 +2123,7 @@
           <p:cNvPr id="16" name="">
             <a:extLst xmlns:a="http://schemas.openxmlformats.org/drawingml/2006/main">
               <a:ext uri="{FF2B5EF4-FFF2-40B4-BE49-F238E27FC236}">
-                <a16:creationId xmlns:a16="http://schemas.microsoft.com/office/drawing/2014/main" id="{4D6ADF97-7BD4-4846-A75C-DA167B7FE318}"/>
+                <a16:creationId xmlns:a16="http://schemas.microsoft.com/office/drawing/2014/main" id="{D63BF923-14AF-4014-A70A-7F0B047BFC31}"/>
               </a:ext>
             </a:extLst>
           </p:cNvPr>
@@ -2187,7 +2187,7 @@
           <p:cNvPr id="17" name="">
             <a:extLst xmlns:a="http://schemas.openxmlformats.org/drawingml/2006/main">
               <a:ext uri="{FF2B5EF4-FFF2-40B4-BE49-F238E27FC236}">
-                <a16:creationId xmlns:a16="http://schemas.microsoft.com/office/drawing/2014/main" id="{0F9B52D9-B122-49A3-8571-729F83ECC3C2}"/>
+                <a16:creationId xmlns:a16="http://schemas.microsoft.com/office/drawing/2014/main" id="{98F03467-7368-4D7A-A78E-6532F6B7EA6C}"/>
               </a:ext>
             </a:extLst>
           </p:cNvPr>
@@ -2242,7 +2242,7 @@
                 <a:cs typeface="Aptos"/>
                 <a:hlinkClick xmlns:r="http://schemas.openxmlformats.org/officeDocument/2006/relationships" r:id="rIdSynthAMLDemo"/>
               </a:rPr>
-              <a:t>https://rawcdn.githack.com/yq688m3JT/genAI_final/ae9c84ea574e9f8c48c84f1863ce82f77ea4f24e/docs/demo.html</a:t>
+              <a:t>https://raw.githack.com/yq688m3JT/genAI_final/ae9c84ea574e9f8c48c84f1863ce82f77ea4f24e/docs/demo.html</a:t>
             </a:r>
           </a:p>
         </p:txBody>
@@ -2250,7 +2250,7 @@
     </p:spTree>
     <p:extLst>
       <p:ext uri="{BB962C8B-B14F-4D97-AF65-F5344CB8AC3E}">
-        <p14:creationId xmlns:p14="http://schemas.microsoft.com/office/powerpoint/2010/main" val="1259413584"/>
+        <p14:creationId xmlns:p14="http://schemas.microsoft.com/office/powerpoint/2010/main" val="2052793352"/>
       </p:ext>
     </p:extLst>
   </p:cSld>
@@ -2274,7 +2274,7 @@
           <p:cNvPr id="1" name="">
             <a:extLst xmlns:a="http://schemas.openxmlformats.org/drawingml/2006/main">
               <a:ext uri="{FF2B5EF4-FFF2-40B4-BE49-F238E27FC236}">
-                <a16:creationId xmlns:a16="http://schemas.microsoft.com/office/drawing/2014/main" id="{76CBF4F4-7D39-4F40-B99C-ED3FE90D951F}"/>
+                <a16:creationId xmlns:a16="http://schemas.microsoft.com/office/drawing/2014/main" id="{0EF2FBDB-BE25-4348-BF83-5E19A22E5D32}"/>
               </a:ext>
             </a:extLst>
           </p:cNvPr>
@@ -2309,7 +2309,7 @@
           <p:cNvPr id="2" name="kicker-marker">
             <a:extLst xmlns:a="http://schemas.openxmlformats.org/drawingml/2006/main">
               <a:ext uri="{FF2B5EF4-FFF2-40B4-BE49-F238E27FC236}">
-                <a16:creationId xmlns:a16="http://schemas.microsoft.com/office/drawing/2014/main" id="{F466C01F-4722-4E65-8DA4-70539AAD7409}"/>
+                <a16:creationId xmlns:a16="http://schemas.microsoft.com/office/drawing/2014/main" id="{29C2ADAA-99F7-4541-8824-C6D1E0926BC5}"/>
               </a:ext>
             </a:extLst>
           </p:cNvPr>
@@ -2344,7 +2344,7 @@
           <p:cNvPr id="3" name="kicker-label">
             <a:extLst xmlns:a="http://schemas.openxmlformats.org/drawingml/2006/main">
               <a:ext uri="{FF2B5EF4-FFF2-40B4-BE49-F238E27FC236}">
-                <a16:creationId xmlns:a16="http://schemas.microsoft.com/office/drawing/2014/main" id="{AD833B03-1DFA-47F0-902F-89F5839D500C}"/>
+                <a16:creationId xmlns:a16="http://schemas.microsoft.com/office/drawing/2014/main" id="{A2E1B26B-1176-4021-B233-ACAF1B22CA17}"/>
               </a:ext>
             </a:extLst>
           </p:cNvPr>
@@ -2408,7 +2408,7 @@
           <p:cNvPr id="4" name="">
             <a:extLst xmlns:a="http://schemas.openxmlformats.org/drawingml/2006/main">
               <a:ext uri="{FF2B5EF4-FFF2-40B4-BE49-F238E27FC236}">
-                <a16:creationId xmlns:a16="http://schemas.microsoft.com/office/drawing/2014/main" id="{7AAFC6D5-75B8-4E6E-B569-73766CD23650}"/>
+                <a16:creationId xmlns:a16="http://schemas.microsoft.com/office/drawing/2014/main" id="{50BF3BD3-9DBB-4D6C-BAFA-68ED059E3FA5}"/>
               </a:ext>
             </a:extLst>
           </p:cNvPr>
@@ -2472,7 +2472,7 @@
           <p:cNvPr id="5" name="">
             <a:extLst xmlns:a="http://schemas.openxmlformats.org/drawingml/2006/main">
               <a:ext uri="{FF2B5EF4-FFF2-40B4-BE49-F238E27FC236}">
-                <a16:creationId xmlns:a16="http://schemas.microsoft.com/office/drawing/2014/main" id="{CA3B5DC9-EC4E-4BFC-827A-97B265D29FC8}"/>
+                <a16:creationId xmlns:a16="http://schemas.microsoft.com/office/drawing/2014/main" id="{D6076945-E09E-49A3-89F9-84077BFEEF9E}"/>
               </a:ext>
             </a:extLst>
           </p:cNvPr>
@@ -2536,7 +2536,7 @@
           <p:cNvPr id="6" name="">
             <a:extLst xmlns:a="http://schemas.openxmlformats.org/drawingml/2006/main">
               <a:ext uri="{FF2B5EF4-FFF2-40B4-BE49-F238E27FC236}">
-                <a16:creationId xmlns:a16="http://schemas.microsoft.com/office/drawing/2014/main" id="{433F5385-E52A-44DD-858B-217D04984C70}"/>
+                <a16:creationId xmlns:a16="http://schemas.microsoft.com/office/drawing/2014/main" id="{F4211E6C-B5D9-4B20-8335-6D28B74E0C11}"/>
               </a:ext>
             </a:extLst>
           </p:cNvPr>
@@ -2571,7 +2571,7 @@
           <p:cNvPr id="7" name="">
             <a:extLst xmlns:a="http://schemas.openxmlformats.org/drawingml/2006/main">
               <a:ext uri="{FF2B5EF4-FFF2-40B4-BE49-F238E27FC236}">
-                <a16:creationId xmlns:a16="http://schemas.microsoft.com/office/drawing/2014/main" id="{2E98F08E-7A5F-4B70-86C4-8630724AD7E3}"/>
+                <a16:creationId xmlns:a16="http://schemas.microsoft.com/office/drawing/2014/main" id="{1971FC4E-AFBB-4F50-9C0D-02931CAAB987}"/>
               </a:ext>
             </a:extLst>
           </p:cNvPr>
@@ -2635,7 +2635,7 @@
           <p:cNvPr id="8" name="">
             <a:extLst xmlns:a="http://schemas.openxmlformats.org/drawingml/2006/main">
               <a:ext uri="{FF2B5EF4-FFF2-40B4-BE49-F238E27FC236}">
-                <a16:creationId xmlns:a16="http://schemas.microsoft.com/office/drawing/2014/main" id="{85B9CB79-5ACA-43B0-B1B3-BA2230851E4D}"/>
+                <a16:creationId xmlns:a16="http://schemas.microsoft.com/office/drawing/2014/main" id="{867586C9-BEEE-43A7-9872-0F2B09FDC2C8}"/>
               </a:ext>
             </a:extLst>
           </p:cNvPr>
@@ -2699,7 +2699,7 @@
           <p:cNvPr id="9" name="">
             <a:extLst xmlns:a="http://schemas.openxmlformats.org/drawingml/2006/main">
               <a:ext uri="{FF2B5EF4-FFF2-40B4-BE49-F238E27FC236}">
-                <a16:creationId xmlns:a16="http://schemas.microsoft.com/office/drawing/2014/main" id="{0F45E3F3-3D20-4269-908C-1B8D33A93CE8}"/>
+                <a16:creationId xmlns:a16="http://schemas.microsoft.com/office/drawing/2014/main" id="{0AC35967-2AD7-494F-A79B-6B2500BE9F11}"/>
               </a:ext>
             </a:extLst>
           </p:cNvPr>
@@ -2763,7 +2763,7 @@
           <p:cNvPr id="10" name="">
             <a:extLst xmlns:a="http://schemas.openxmlformats.org/drawingml/2006/main">
               <a:ext uri="{FF2B5EF4-FFF2-40B4-BE49-F238E27FC236}">
-                <a16:creationId xmlns:a16="http://schemas.microsoft.com/office/drawing/2014/main" id="{2A565697-2595-4559-821E-8913C3F783BD}"/>
+                <a16:creationId xmlns:a16="http://schemas.microsoft.com/office/drawing/2014/main" id="{0C63A22A-836B-481E-8D23-B862D8C5587C}"/>
               </a:ext>
             </a:extLst>
           </p:cNvPr>
@@ -2798,7 +2798,7 @@
           <p:cNvPr id="11" name="">
             <a:extLst xmlns:a="http://schemas.openxmlformats.org/drawingml/2006/main">
               <a:ext uri="{FF2B5EF4-FFF2-40B4-BE49-F238E27FC236}">
-                <a16:creationId xmlns:a16="http://schemas.microsoft.com/office/drawing/2014/main" id="{56BDABBF-EA44-460E-9BC9-7910E7157743}"/>
+                <a16:creationId xmlns:a16="http://schemas.microsoft.com/office/drawing/2014/main" id="{1998C3D6-BB65-47F8-A51D-03CCA81337F5}"/>
               </a:ext>
             </a:extLst>
           </p:cNvPr>
@@ -2833,7 +2833,7 @@
           <p:cNvPr id="12" name="">
             <a:extLst xmlns:a="http://schemas.openxmlformats.org/drawingml/2006/main">
               <a:ext uri="{FF2B5EF4-FFF2-40B4-BE49-F238E27FC236}">
-                <a16:creationId xmlns:a16="http://schemas.microsoft.com/office/drawing/2014/main" id="{E19F4CD3-19C4-46DF-9FB0-CF0881C7B7FD}"/>
+                <a16:creationId xmlns:a16="http://schemas.microsoft.com/office/drawing/2014/main" id="{50F028C7-111C-439D-9A02-48C21646F554}"/>
               </a:ext>
             </a:extLst>
           </p:cNvPr>
@@ -2868,7 +2868,7 @@
           <p:cNvPr id="13" name="">
             <a:extLst xmlns:a="http://schemas.openxmlformats.org/drawingml/2006/main">
               <a:ext uri="{FF2B5EF4-FFF2-40B4-BE49-F238E27FC236}">
-                <a16:creationId xmlns:a16="http://schemas.microsoft.com/office/drawing/2014/main" id="{A188F70B-B15D-4B2A-967D-8B35B89C224F}"/>
+                <a16:creationId xmlns:a16="http://schemas.microsoft.com/office/drawing/2014/main" id="{AA5E433C-FD00-4BBA-AC6D-8E690BB5652D}"/>
               </a:ext>
             </a:extLst>
           </p:cNvPr>
@@ -2932,7 +2932,7 @@
           <p:cNvPr id="14" name="">
             <a:extLst xmlns:a="http://schemas.openxmlformats.org/drawingml/2006/main">
               <a:ext uri="{FF2B5EF4-FFF2-40B4-BE49-F238E27FC236}">
-                <a16:creationId xmlns:a16="http://schemas.microsoft.com/office/drawing/2014/main" id="{00F710BC-894A-4626-A871-FD15FA2A74FF}"/>
+                <a16:creationId xmlns:a16="http://schemas.microsoft.com/office/drawing/2014/main" id="{8F139907-0756-4ACB-946F-4C28CF794E92}"/>
               </a:ext>
             </a:extLst>
           </p:cNvPr>
@@ -2996,7 +2996,7 @@
           <p:cNvPr id="15" name="">
             <a:extLst xmlns:a="http://schemas.openxmlformats.org/drawingml/2006/main">
               <a:ext uri="{FF2B5EF4-FFF2-40B4-BE49-F238E27FC236}">
-                <a16:creationId xmlns:a16="http://schemas.microsoft.com/office/drawing/2014/main" id="{ACE931D3-8BA2-4283-873F-8A3774E415B6}"/>
+                <a16:creationId xmlns:a16="http://schemas.microsoft.com/office/drawing/2014/main" id="{98BD5356-1861-40EC-972A-297297A500D3}"/>
               </a:ext>
             </a:extLst>
           </p:cNvPr>
@@ -3060,7 +3060,7 @@
           <p:cNvPr id="16" name="">
             <a:extLst xmlns:a="http://schemas.openxmlformats.org/drawingml/2006/main">
               <a:ext uri="{FF2B5EF4-FFF2-40B4-BE49-F238E27FC236}">
-                <a16:creationId xmlns:a16="http://schemas.microsoft.com/office/drawing/2014/main" id="{3CAD00B8-191B-42D2-9BAC-6832BDE6675D}"/>
+                <a16:creationId xmlns:a16="http://schemas.microsoft.com/office/drawing/2014/main" id="{087E61CA-1B89-44B7-BD3A-287F4DBA2E79}"/>
               </a:ext>
             </a:extLst>
           </p:cNvPr>
@@ -3095,7 +3095,7 @@
           <p:cNvPr id="17" name="">
             <a:extLst xmlns:a="http://schemas.openxmlformats.org/drawingml/2006/main">
               <a:ext uri="{FF2B5EF4-FFF2-40B4-BE49-F238E27FC236}">
-                <a16:creationId xmlns:a16="http://schemas.microsoft.com/office/drawing/2014/main" id="{E875090C-6182-4B04-84BF-DCEFD24138A9}"/>
+                <a16:creationId xmlns:a16="http://schemas.microsoft.com/office/drawing/2014/main" id="{B0D14AFF-5A73-479B-A92F-941FBD47A067}"/>
               </a:ext>
             </a:extLst>
           </p:cNvPr>
@@ -3130,7 +3130,7 @@
           <p:cNvPr id="18" name="">
             <a:extLst xmlns:a="http://schemas.openxmlformats.org/drawingml/2006/main">
               <a:ext uri="{FF2B5EF4-FFF2-40B4-BE49-F238E27FC236}">
-                <a16:creationId xmlns:a16="http://schemas.microsoft.com/office/drawing/2014/main" id="{27F27BF8-C6E1-4C6F-972B-7DEBD39F5F21}"/>
+                <a16:creationId xmlns:a16="http://schemas.microsoft.com/office/drawing/2014/main" id="{AC1EC2AD-965F-41D2-B4F6-FDB1F8B12ED9}"/>
               </a:ext>
             </a:extLst>
           </p:cNvPr>
@@ -3165,7 +3165,7 @@
           <p:cNvPr id="19" name="">
             <a:extLst xmlns:a="http://schemas.openxmlformats.org/drawingml/2006/main">
               <a:ext uri="{FF2B5EF4-FFF2-40B4-BE49-F238E27FC236}">
-                <a16:creationId xmlns:a16="http://schemas.microsoft.com/office/drawing/2014/main" id="{E8A36923-1978-4208-978D-DB6750CF1F0D}"/>
+                <a16:creationId xmlns:a16="http://schemas.microsoft.com/office/drawing/2014/main" id="{59E2D736-4FBF-4824-A6A6-F15180790B6F}"/>
               </a:ext>
             </a:extLst>
           </p:cNvPr>
@@ -3229,7 +3229,7 @@
           <p:cNvPr id="20" name="">
             <a:extLst xmlns:a="http://schemas.openxmlformats.org/drawingml/2006/main">
               <a:ext uri="{FF2B5EF4-FFF2-40B4-BE49-F238E27FC236}">
-                <a16:creationId xmlns:a16="http://schemas.microsoft.com/office/drawing/2014/main" id="{D7C62010-CA4C-467F-99FC-84EE40B0415A}"/>
+                <a16:creationId xmlns:a16="http://schemas.microsoft.com/office/drawing/2014/main" id="{495A4CD4-BC24-45FC-9849-F2ECD5DD24FC}"/>
               </a:ext>
             </a:extLst>
           </p:cNvPr>
@@ -3293,7 +3293,7 @@
           <p:cNvPr id="21" name="">
             <a:extLst xmlns:a="http://schemas.openxmlformats.org/drawingml/2006/main">
               <a:ext uri="{FF2B5EF4-FFF2-40B4-BE49-F238E27FC236}">
-                <a16:creationId xmlns:a16="http://schemas.microsoft.com/office/drawing/2014/main" id="{B3C204B2-BC18-4A32-8A2E-3C7E7A7874C3}"/>
+                <a16:creationId xmlns:a16="http://schemas.microsoft.com/office/drawing/2014/main" id="{3A741A71-111A-41FB-9E3A-643A88E7EB57}"/>
               </a:ext>
             </a:extLst>
           </p:cNvPr>
@@ -3357,7 +3357,7 @@
           <p:cNvPr id="22" name="">
             <a:extLst xmlns:a="http://schemas.openxmlformats.org/drawingml/2006/main">
               <a:ext uri="{FF2B5EF4-FFF2-40B4-BE49-F238E27FC236}">
-                <a16:creationId xmlns:a16="http://schemas.microsoft.com/office/drawing/2014/main" id="{B392513F-104B-4FCC-93A6-4888B81EA992}"/>
+                <a16:creationId xmlns:a16="http://schemas.microsoft.com/office/drawing/2014/main" id="{7935C923-0FC8-4A38-B253-8C671FD55A9C}"/>
               </a:ext>
             </a:extLst>
           </p:cNvPr>
@@ -3390,7 +3390,7 @@
           <p:cNvPr id="23" name="">
             <a:extLst xmlns:a="http://schemas.openxmlformats.org/drawingml/2006/main">
               <a:ext uri="{FF2B5EF4-FFF2-40B4-BE49-F238E27FC236}">
-                <a16:creationId xmlns:a16="http://schemas.microsoft.com/office/drawing/2014/main" id="{D392FF56-C9DD-4076-8DD1-D24DAA92FFCF}"/>
+                <a16:creationId xmlns:a16="http://schemas.microsoft.com/office/drawing/2014/main" id="{2386F769-4B40-43E9-9CB0-601AF2A2DD1E}"/>
               </a:ext>
             </a:extLst>
           </p:cNvPr>
@@ -3454,7 +3454,7 @@
           <p:cNvPr id="24" name="">
             <a:extLst xmlns:a="http://schemas.openxmlformats.org/drawingml/2006/main">
               <a:ext uri="{FF2B5EF4-FFF2-40B4-BE49-F238E27FC236}">
-                <a16:creationId xmlns:a16="http://schemas.microsoft.com/office/drawing/2014/main" id="{AF99906B-B699-45A7-BA42-EB950A223084}"/>
+                <a16:creationId xmlns:a16="http://schemas.microsoft.com/office/drawing/2014/main" id="{E4570C2F-268C-41B2-B8A1-7DA3793190CE}"/>
               </a:ext>
             </a:extLst>
           </p:cNvPr>
@@ -3541,7 +3541,7 @@
           <p:cNvPr id="25" name="">
             <a:extLst xmlns:a="http://schemas.openxmlformats.org/drawingml/2006/main">
               <a:ext uri="{FF2B5EF4-FFF2-40B4-BE49-F238E27FC236}">
-                <a16:creationId xmlns:a16="http://schemas.microsoft.com/office/drawing/2014/main" id="{BA80A5C1-38B3-44BC-80FC-0BEF5B1C669D}"/>
+                <a16:creationId xmlns:a16="http://schemas.microsoft.com/office/drawing/2014/main" id="{529F6F10-6019-4871-A0A3-BBFAADA9ECA8}"/>
               </a:ext>
             </a:extLst>
           </p:cNvPr>
@@ -3576,7 +3576,7 @@
           <p:cNvPr id="26" name="">
             <a:extLst xmlns:a="http://schemas.openxmlformats.org/drawingml/2006/main">
               <a:ext uri="{FF2B5EF4-FFF2-40B4-BE49-F238E27FC236}">
-                <a16:creationId xmlns:a16="http://schemas.microsoft.com/office/drawing/2014/main" id="{F1F69856-023D-416D-9905-26D8E97C1394}"/>
+                <a16:creationId xmlns:a16="http://schemas.microsoft.com/office/drawing/2014/main" id="{BF7714A8-8BE2-4130-A99D-3D675E33654B}"/>
               </a:ext>
             </a:extLst>
           </p:cNvPr>
@@ -3638,7 +3638,7 @@
     </p:spTree>
     <p:extLst>
       <p:ext uri="{BB962C8B-B14F-4D97-AF65-F5344CB8AC3E}">
-        <p14:creationId xmlns:p14="http://schemas.microsoft.com/office/powerpoint/2010/main" val="1884487304"/>
+        <p14:creationId xmlns:p14="http://schemas.microsoft.com/office/powerpoint/2010/main" val="744843546"/>
       </p:ext>
     </p:extLst>
   </p:cSld>
@@ -3662,7 +3662,7 @@
           <p:cNvPr id="1" name="">
             <a:extLst xmlns:a="http://schemas.openxmlformats.org/drawingml/2006/main">
               <a:ext uri="{FF2B5EF4-FFF2-40B4-BE49-F238E27FC236}">
-                <a16:creationId xmlns:a16="http://schemas.microsoft.com/office/drawing/2014/main" id="{F4E84A65-6FE9-4A08-A014-47027E087AFD}"/>
+                <a16:creationId xmlns:a16="http://schemas.microsoft.com/office/drawing/2014/main" id="{6787A30B-7110-4E72-8E65-E0DEB9CBB728}"/>
               </a:ext>
             </a:extLst>
           </p:cNvPr>
@@ -3697,7 +3697,7 @@
           <p:cNvPr id="2" name="kicker-marker">
             <a:extLst xmlns:a="http://schemas.openxmlformats.org/drawingml/2006/main">
               <a:ext uri="{FF2B5EF4-FFF2-40B4-BE49-F238E27FC236}">
-                <a16:creationId xmlns:a16="http://schemas.microsoft.com/office/drawing/2014/main" id="{D7A6C209-CFFF-4748-B095-8ED86ADF26AD}"/>
+                <a16:creationId xmlns:a16="http://schemas.microsoft.com/office/drawing/2014/main" id="{A6C3EE51-1359-46CE-A5FD-CFDB80AA5244}"/>
               </a:ext>
             </a:extLst>
           </p:cNvPr>
@@ -3732,7 +3732,7 @@
           <p:cNvPr id="3" name="kicker-label">
             <a:extLst xmlns:a="http://schemas.openxmlformats.org/drawingml/2006/main">
               <a:ext uri="{FF2B5EF4-FFF2-40B4-BE49-F238E27FC236}">
-                <a16:creationId xmlns:a16="http://schemas.microsoft.com/office/drawing/2014/main" id="{A185F3B5-2C5A-461D-AA78-AF866DE72E60}"/>
+                <a16:creationId xmlns:a16="http://schemas.microsoft.com/office/drawing/2014/main" id="{9D08F4C7-470F-4FE8-9291-68DDFD12D2A7}"/>
               </a:ext>
             </a:extLst>
           </p:cNvPr>
@@ -3796,7 +3796,7 @@
           <p:cNvPr id="4" name="">
             <a:extLst xmlns:a="http://schemas.openxmlformats.org/drawingml/2006/main">
               <a:ext uri="{FF2B5EF4-FFF2-40B4-BE49-F238E27FC236}">
-                <a16:creationId xmlns:a16="http://schemas.microsoft.com/office/drawing/2014/main" id="{CC8455FF-73B5-4A61-9614-52ADCBDB7754}"/>
+                <a16:creationId xmlns:a16="http://schemas.microsoft.com/office/drawing/2014/main" id="{F77F98F8-4F26-4BAA-A749-3D9FD76C5036}"/>
               </a:ext>
             </a:extLst>
           </p:cNvPr>
@@ -3860,7 +3860,7 @@
           <p:cNvPr id="5" name="">
             <a:extLst xmlns:a="http://schemas.openxmlformats.org/drawingml/2006/main">
               <a:ext uri="{FF2B5EF4-FFF2-40B4-BE49-F238E27FC236}">
-                <a16:creationId xmlns:a16="http://schemas.microsoft.com/office/drawing/2014/main" id="{576C3261-9FAA-420F-BE63-3E111BBC66F0}"/>
+                <a16:creationId xmlns:a16="http://schemas.microsoft.com/office/drawing/2014/main" id="{5F6DD5C4-FD2A-43B7-9C5E-9D521B01EC4F}"/>
               </a:ext>
             </a:extLst>
           </p:cNvPr>
@@ -3895,7 +3895,7 @@
           <p:cNvPr id="6" name="">
             <a:extLst xmlns:a="http://schemas.openxmlformats.org/drawingml/2006/main">
               <a:ext uri="{FF2B5EF4-FFF2-40B4-BE49-F238E27FC236}">
-                <a16:creationId xmlns:a16="http://schemas.microsoft.com/office/drawing/2014/main" id="{87CC508B-3704-475F-9041-E47E69380CBC}"/>
+                <a16:creationId xmlns:a16="http://schemas.microsoft.com/office/drawing/2014/main" id="{8982DF7E-BABB-4A40-BDDF-FD88AFC5D772}"/>
               </a:ext>
             </a:extLst>
           </p:cNvPr>
@@ -3959,7 +3959,7 @@
           <p:cNvPr id="7" name="">
             <a:extLst xmlns:a="http://schemas.openxmlformats.org/drawingml/2006/main">
               <a:ext uri="{FF2B5EF4-FFF2-40B4-BE49-F238E27FC236}">
-                <a16:creationId xmlns:a16="http://schemas.microsoft.com/office/drawing/2014/main" id="{0789115F-F3AD-46CA-9A8F-2954AC41635D}"/>
+                <a16:creationId xmlns:a16="http://schemas.microsoft.com/office/drawing/2014/main" id="{83526692-DBE0-4468-967D-F4C48AF79D34}"/>
               </a:ext>
             </a:extLst>
           </p:cNvPr>
@@ -3992,7 +3992,7 @@
           <p:cNvPr id="8" name="">
             <a:extLst xmlns:a="http://schemas.openxmlformats.org/drawingml/2006/main">
               <a:ext uri="{FF2B5EF4-FFF2-40B4-BE49-F238E27FC236}">
-                <a16:creationId xmlns:a16="http://schemas.microsoft.com/office/drawing/2014/main" id="{E2E24AAA-386C-404E-B917-D5E59D4348C9}"/>
+                <a16:creationId xmlns:a16="http://schemas.microsoft.com/office/drawing/2014/main" id="{4A8F09A6-20E5-48BC-B201-FFB2D78D7407}"/>
               </a:ext>
             </a:extLst>
           </p:cNvPr>
@@ -4056,7 +4056,7 @@
           <p:cNvPr id="9" name="">
             <a:extLst xmlns:a="http://schemas.openxmlformats.org/drawingml/2006/main">
               <a:ext uri="{FF2B5EF4-FFF2-40B4-BE49-F238E27FC236}">
-                <a16:creationId xmlns:a16="http://schemas.microsoft.com/office/drawing/2014/main" id="{B25A4D30-2990-4696-9431-5B04229C185E}"/>
+                <a16:creationId xmlns:a16="http://schemas.microsoft.com/office/drawing/2014/main" id="{D9068EF6-1BE5-4E0A-B794-7D7233A93423}"/>
               </a:ext>
             </a:extLst>
           </p:cNvPr>
@@ -4120,7 +4120,7 @@
           <p:cNvPr id="10" name="">
             <a:extLst xmlns:a="http://schemas.openxmlformats.org/drawingml/2006/main">
               <a:ext uri="{FF2B5EF4-FFF2-40B4-BE49-F238E27FC236}">
-                <a16:creationId xmlns:a16="http://schemas.microsoft.com/office/drawing/2014/main" id="{BCC474E2-03AF-43F0-89A9-201C3B9AC2A8}"/>
+                <a16:creationId xmlns:a16="http://schemas.microsoft.com/office/drawing/2014/main" id="{13AD5A5D-EF02-4686-AF1A-5384697B3CB1}"/>
               </a:ext>
             </a:extLst>
           </p:cNvPr>
@@ -4184,7 +4184,7 @@
           <p:cNvPr id="11" name="">
             <a:extLst xmlns:a="http://schemas.openxmlformats.org/drawingml/2006/main">
               <a:ext uri="{FF2B5EF4-FFF2-40B4-BE49-F238E27FC236}">
-                <a16:creationId xmlns:a16="http://schemas.microsoft.com/office/drawing/2014/main" id="{FECB9B3F-8312-4AA8-9E5D-D02E368B73A3}"/>
+                <a16:creationId xmlns:a16="http://schemas.microsoft.com/office/drawing/2014/main" id="{8D172ED4-845A-4ED2-AA40-459348010749}"/>
               </a:ext>
             </a:extLst>
           </p:cNvPr>
@@ -4219,7 +4219,7 @@
           <p:cNvPr id="12" name="">
             <a:extLst xmlns:a="http://schemas.openxmlformats.org/drawingml/2006/main">
               <a:ext uri="{FF2B5EF4-FFF2-40B4-BE49-F238E27FC236}">
-                <a16:creationId xmlns:a16="http://schemas.microsoft.com/office/drawing/2014/main" id="{818F9D34-F41C-47CF-B216-18B9A0F063F2}"/>
+                <a16:creationId xmlns:a16="http://schemas.microsoft.com/office/drawing/2014/main" id="{FA694019-B844-4F2D-A656-6316A5971848}"/>
               </a:ext>
             </a:extLst>
           </p:cNvPr>
@@ -4254,7 +4254,7 @@
           <p:cNvPr id="13" name="">
             <a:extLst xmlns:a="http://schemas.openxmlformats.org/drawingml/2006/main">
               <a:ext uri="{FF2B5EF4-FFF2-40B4-BE49-F238E27FC236}">
-                <a16:creationId xmlns:a16="http://schemas.microsoft.com/office/drawing/2014/main" id="{67D7C71F-8C59-4F49-A7B5-CC74FB44A175}"/>
+                <a16:creationId xmlns:a16="http://schemas.microsoft.com/office/drawing/2014/main" id="{C11C2A09-C718-4081-9B8F-A413CEE32212}"/>
               </a:ext>
             </a:extLst>
           </p:cNvPr>
@@ -4287,7 +4287,7 @@
           <p:cNvPr id="14" name="">
             <a:extLst xmlns:a="http://schemas.openxmlformats.org/drawingml/2006/main">
               <a:ext uri="{FF2B5EF4-FFF2-40B4-BE49-F238E27FC236}">
-                <a16:creationId xmlns:a16="http://schemas.microsoft.com/office/drawing/2014/main" id="{BF5F4B46-7A89-42CA-B8A3-25572100B539}"/>
+                <a16:creationId xmlns:a16="http://schemas.microsoft.com/office/drawing/2014/main" id="{CFDB6361-03F7-48F2-8607-AD2CD8ED3AA0}"/>
               </a:ext>
             </a:extLst>
           </p:cNvPr>
@@ -4351,7 +4351,7 @@
           <p:cNvPr id="15" name="">
             <a:extLst xmlns:a="http://schemas.openxmlformats.org/drawingml/2006/main">
               <a:ext uri="{FF2B5EF4-FFF2-40B4-BE49-F238E27FC236}">
-                <a16:creationId xmlns:a16="http://schemas.microsoft.com/office/drawing/2014/main" id="{90E1F34D-0F2E-46AC-B094-C4E9D3B21EDB}"/>
+                <a16:creationId xmlns:a16="http://schemas.microsoft.com/office/drawing/2014/main" id="{455C8299-C279-4A38-9CF8-2FD07F445EC4}"/>
               </a:ext>
             </a:extLst>
           </p:cNvPr>
@@ -4415,7 +4415,7 @@
           <p:cNvPr id="16" name="">
             <a:extLst xmlns:a="http://schemas.openxmlformats.org/drawingml/2006/main">
               <a:ext uri="{FF2B5EF4-FFF2-40B4-BE49-F238E27FC236}">
-                <a16:creationId xmlns:a16="http://schemas.microsoft.com/office/drawing/2014/main" id="{26A6FB04-ACFC-4CAB-A693-D07DE22D3791}"/>
+                <a16:creationId xmlns:a16="http://schemas.microsoft.com/office/drawing/2014/main" id="{E4C8755B-AD43-4389-BD0E-BC2E9121F34C}"/>
               </a:ext>
             </a:extLst>
           </p:cNvPr>
@@ -4479,7 +4479,7 @@
           <p:cNvPr id="17" name="">
             <a:extLst xmlns:a="http://schemas.openxmlformats.org/drawingml/2006/main">
               <a:ext uri="{FF2B5EF4-FFF2-40B4-BE49-F238E27FC236}">
-                <a16:creationId xmlns:a16="http://schemas.microsoft.com/office/drawing/2014/main" id="{EDFD6E56-4705-44A3-B776-14FBBD16D6CF}"/>
+                <a16:creationId xmlns:a16="http://schemas.microsoft.com/office/drawing/2014/main" id="{5FE0C2CC-080E-4A8B-A8E9-8264A4CC045D}"/>
               </a:ext>
             </a:extLst>
           </p:cNvPr>
@@ -4514,7 +4514,7 @@
           <p:cNvPr id="18" name="">
             <a:extLst xmlns:a="http://schemas.openxmlformats.org/drawingml/2006/main">
               <a:ext uri="{FF2B5EF4-FFF2-40B4-BE49-F238E27FC236}">
-                <a16:creationId xmlns:a16="http://schemas.microsoft.com/office/drawing/2014/main" id="{E0DA1BC4-BD21-4406-9D07-322F4A49F7E8}"/>
+                <a16:creationId xmlns:a16="http://schemas.microsoft.com/office/drawing/2014/main" id="{B2DE596A-2E6D-462B-8236-4EA4B01E12EF}"/>
               </a:ext>
             </a:extLst>
           </p:cNvPr>
@@ -4549,7 +4549,7 @@
           <p:cNvPr id="19" name="">
             <a:extLst xmlns:a="http://schemas.openxmlformats.org/drawingml/2006/main">
               <a:ext uri="{FF2B5EF4-FFF2-40B4-BE49-F238E27FC236}">
-                <a16:creationId xmlns:a16="http://schemas.microsoft.com/office/drawing/2014/main" id="{D0AF59AE-A71D-47D2-8E4C-0708C7CBBFF6}"/>
+                <a16:creationId xmlns:a16="http://schemas.microsoft.com/office/drawing/2014/main" id="{4BBC857C-9006-4714-AB85-1350F89C7FC8}"/>
               </a:ext>
             </a:extLst>
           </p:cNvPr>
@@ -4582,7 +4582,7 @@
           <p:cNvPr id="20" name="">
             <a:extLst xmlns:a="http://schemas.openxmlformats.org/drawingml/2006/main">
               <a:ext uri="{FF2B5EF4-FFF2-40B4-BE49-F238E27FC236}">
-                <a16:creationId xmlns:a16="http://schemas.microsoft.com/office/drawing/2014/main" id="{3A2C30A5-41D4-4136-8694-B13FEE4AE1D3}"/>
+                <a16:creationId xmlns:a16="http://schemas.microsoft.com/office/drawing/2014/main" id="{D4A6A206-C6EB-44DD-A3B1-309A46D1E8B2}"/>
               </a:ext>
             </a:extLst>
           </p:cNvPr>
@@ -4646,7 +4646,7 @@
           <p:cNvPr id="21" name="">
             <a:extLst xmlns:a="http://schemas.openxmlformats.org/drawingml/2006/main">
               <a:ext uri="{FF2B5EF4-FFF2-40B4-BE49-F238E27FC236}">
-                <a16:creationId xmlns:a16="http://schemas.microsoft.com/office/drawing/2014/main" id="{B8CE4715-9F2B-45EE-9361-067FC3A52CF8}"/>
+                <a16:creationId xmlns:a16="http://schemas.microsoft.com/office/drawing/2014/main" id="{A1242647-118D-48AB-93CC-4121ACF2FF24}"/>
               </a:ext>
             </a:extLst>
           </p:cNvPr>
@@ -4710,7 +4710,7 @@
           <p:cNvPr id="22" name="">
             <a:extLst xmlns:a="http://schemas.openxmlformats.org/drawingml/2006/main">
               <a:ext uri="{FF2B5EF4-FFF2-40B4-BE49-F238E27FC236}">
-                <a16:creationId xmlns:a16="http://schemas.microsoft.com/office/drawing/2014/main" id="{C5CC51FC-F4C1-4480-BDA3-135AC54B895C}"/>
+                <a16:creationId xmlns:a16="http://schemas.microsoft.com/office/drawing/2014/main" id="{B0A89CC8-6B72-4BB8-A616-AF4AF6A57503}"/>
               </a:ext>
             </a:extLst>
           </p:cNvPr>
@@ -4774,7 +4774,7 @@
           <p:cNvPr id="23" name="">
             <a:extLst xmlns:a="http://schemas.openxmlformats.org/drawingml/2006/main">
               <a:ext uri="{FF2B5EF4-FFF2-40B4-BE49-F238E27FC236}">
-                <a16:creationId xmlns:a16="http://schemas.microsoft.com/office/drawing/2014/main" id="{B9E04A1D-499E-495D-9CE7-5F5400DA23E0}"/>
+                <a16:creationId xmlns:a16="http://schemas.microsoft.com/office/drawing/2014/main" id="{44BCF1F3-ECEE-42F8-90D3-7A5F67F2E2FF}"/>
               </a:ext>
             </a:extLst>
           </p:cNvPr>
@@ -4809,7 +4809,7 @@
           <p:cNvPr id="24" name="">
             <a:extLst xmlns:a="http://schemas.openxmlformats.org/drawingml/2006/main">
               <a:ext uri="{FF2B5EF4-FFF2-40B4-BE49-F238E27FC236}">
-                <a16:creationId xmlns:a16="http://schemas.microsoft.com/office/drawing/2014/main" id="{2BCC3AAE-FFDB-48B2-BD23-C6BB2F63BFB4}"/>
+                <a16:creationId xmlns:a16="http://schemas.microsoft.com/office/drawing/2014/main" id="{64297642-C041-4C62-B015-1E7312EBB830}"/>
               </a:ext>
             </a:extLst>
           </p:cNvPr>
@@ -4844,7 +4844,7 @@
           <p:cNvPr id="25" name="">
             <a:extLst xmlns:a="http://schemas.openxmlformats.org/drawingml/2006/main">
               <a:ext uri="{FF2B5EF4-FFF2-40B4-BE49-F238E27FC236}">
-                <a16:creationId xmlns:a16="http://schemas.microsoft.com/office/drawing/2014/main" id="{70FB71C8-3332-4E82-8180-78DE1850831B}"/>
+                <a16:creationId xmlns:a16="http://schemas.microsoft.com/office/drawing/2014/main" id="{D25F16F8-F8EB-49F9-ADD5-1BE0BE5A4474}"/>
               </a:ext>
             </a:extLst>
           </p:cNvPr>
@@ -4877,7 +4877,7 @@
           <p:cNvPr id="26" name="">
             <a:extLst xmlns:a="http://schemas.openxmlformats.org/drawingml/2006/main">
               <a:ext uri="{FF2B5EF4-FFF2-40B4-BE49-F238E27FC236}">
-                <a16:creationId xmlns:a16="http://schemas.microsoft.com/office/drawing/2014/main" id="{2A1E3C9D-44B2-4F67-AD30-A9C25BA91529}"/>
+                <a16:creationId xmlns:a16="http://schemas.microsoft.com/office/drawing/2014/main" id="{DE08A834-DC01-4EAE-B526-60F757A63E50}"/>
               </a:ext>
             </a:extLst>
           </p:cNvPr>
@@ -4941,7 +4941,7 @@
           <p:cNvPr id="27" name="">
             <a:extLst xmlns:a="http://schemas.openxmlformats.org/drawingml/2006/main">
               <a:ext uri="{FF2B5EF4-FFF2-40B4-BE49-F238E27FC236}">
-                <a16:creationId xmlns:a16="http://schemas.microsoft.com/office/drawing/2014/main" id="{1497E88F-B01D-4741-8832-EBB3BDA88326}"/>
+                <a16:creationId xmlns:a16="http://schemas.microsoft.com/office/drawing/2014/main" id="{2E0033C7-D703-4E50-BCD0-6D3285812A7A}"/>
               </a:ext>
             </a:extLst>
           </p:cNvPr>
@@ -5005,7 +5005,7 @@
           <p:cNvPr id="28" name="">
             <a:extLst xmlns:a="http://schemas.openxmlformats.org/drawingml/2006/main">
               <a:ext uri="{FF2B5EF4-FFF2-40B4-BE49-F238E27FC236}">
-                <a16:creationId xmlns:a16="http://schemas.microsoft.com/office/drawing/2014/main" id="{9294193E-9809-45A1-961F-D68D24318436}"/>
+                <a16:creationId xmlns:a16="http://schemas.microsoft.com/office/drawing/2014/main" id="{F9423DB8-8B39-4BF5-AD68-7D8B024D3AFD}"/>
               </a:ext>
             </a:extLst>
           </p:cNvPr>
@@ -5069,7 +5069,7 @@
           <p:cNvPr id="29" name="">
             <a:extLst xmlns:a="http://schemas.openxmlformats.org/drawingml/2006/main">
               <a:ext uri="{FF2B5EF4-FFF2-40B4-BE49-F238E27FC236}">
-                <a16:creationId xmlns:a16="http://schemas.microsoft.com/office/drawing/2014/main" id="{9F68A898-9EE2-451C-9FE0-4BC7E160BA7B}"/>
+                <a16:creationId xmlns:a16="http://schemas.microsoft.com/office/drawing/2014/main" id="{C560F69F-87E4-4A17-96E9-3D6187DFD6BC}"/>
               </a:ext>
             </a:extLst>
           </p:cNvPr>
@@ -5131,7 +5131,7 @@
     </p:spTree>
     <p:extLst>
       <p:ext uri="{BB962C8B-B14F-4D97-AF65-F5344CB8AC3E}">
-        <p14:creationId xmlns:p14="http://schemas.microsoft.com/office/powerpoint/2010/main" val="1651815857"/>
+        <p14:creationId xmlns:p14="http://schemas.microsoft.com/office/powerpoint/2010/main" val="2067541337"/>
       </p:ext>
     </p:extLst>
   </p:cSld>
@@ -5155,7 +5155,7 @@
           <p:cNvPr id="1" name="">
             <a:extLst xmlns:a="http://schemas.openxmlformats.org/drawingml/2006/main">
               <a:ext uri="{FF2B5EF4-FFF2-40B4-BE49-F238E27FC236}">
-                <a16:creationId xmlns:a16="http://schemas.microsoft.com/office/drawing/2014/main" id="{6C07750A-B41F-4BBB-96B5-7E491DD0A040}"/>
+                <a16:creationId xmlns:a16="http://schemas.microsoft.com/office/drawing/2014/main" id="{2CF56CB9-2285-45CF-A02A-26E6AD563147}"/>
               </a:ext>
             </a:extLst>
           </p:cNvPr>
@@ -5190,7 +5190,7 @@
           <p:cNvPr id="2" name="kicker-marker">
             <a:extLst xmlns:a="http://schemas.openxmlformats.org/drawingml/2006/main">
               <a:ext uri="{FF2B5EF4-FFF2-40B4-BE49-F238E27FC236}">
-                <a16:creationId xmlns:a16="http://schemas.microsoft.com/office/drawing/2014/main" id="{35EAE529-7ACD-40A0-8FCA-A0194B11A151}"/>
+                <a16:creationId xmlns:a16="http://schemas.microsoft.com/office/drawing/2014/main" id="{8FCB9C84-4B86-4C6D-811F-77E16F2DFCD4}"/>
               </a:ext>
             </a:extLst>
           </p:cNvPr>
@@ -5225,7 +5225,7 @@
           <p:cNvPr id="3" name="kicker-label">
             <a:extLst xmlns:a="http://schemas.openxmlformats.org/drawingml/2006/main">
               <a:ext uri="{FF2B5EF4-FFF2-40B4-BE49-F238E27FC236}">
-                <a16:creationId xmlns:a16="http://schemas.microsoft.com/office/drawing/2014/main" id="{AB4BCF8C-012B-4953-BB1C-77080CE1F537}"/>
+                <a16:creationId xmlns:a16="http://schemas.microsoft.com/office/drawing/2014/main" id="{B4FC2954-CB1A-45C4-A8C7-E99143FC7BFD}"/>
               </a:ext>
             </a:extLst>
           </p:cNvPr>
@@ -5289,7 +5289,7 @@
           <p:cNvPr id="4" name="">
             <a:extLst xmlns:a="http://schemas.openxmlformats.org/drawingml/2006/main">
               <a:ext uri="{FF2B5EF4-FFF2-40B4-BE49-F238E27FC236}">
-                <a16:creationId xmlns:a16="http://schemas.microsoft.com/office/drawing/2014/main" id="{F9B12C39-75BB-473E-A86F-F211ADB90A15}"/>
+                <a16:creationId xmlns:a16="http://schemas.microsoft.com/office/drawing/2014/main" id="{63D94A82-3C2C-4098-A01D-83C8126E0B62}"/>
               </a:ext>
             </a:extLst>
           </p:cNvPr>
@@ -5353,7 +5353,7 @@
           <p:cNvPr id="5" name="">
             <a:extLst xmlns:a="http://schemas.openxmlformats.org/drawingml/2006/main">
               <a:ext uri="{FF2B5EF4-FFF2-40B4-BE49-F238E27FC236}">
-                <a16:creationId xmlns:a16="http://schemas.microsoft.com/office/drawing/2014/main" id="{EF3CC9FA-B87C-4D83-8030-E523B382E7B3}"/>
+                <a16:creationId xmlns:a16="http://schemas.microsoft.com/office/drawing/2014/main" id="{C41163D8-667F-40E0-A613-F99E4610A3AD}"/>
               </a:ext>
             </a:extLst>
           </p:cNvPr>
@@ -5388,7 +5388,7 @@
           <p:cNvPr id="6" name="">
             <a:extLst xmlns:a="http://schemas.openxmlformats.org/drawingml/2006/main">
               <a:ext uri="{FF2B5EF4-FFF2-40B4-BE49-F238E27FC236}">
-                <a16:creationId xmlns:a16="http://schemas.microsoft.com/office/drawing/2014/main" id="{F42CD34D-0743-4FB4-AA9A-43C05159A96E}"/>
+                <a16:creationId xmlns:a16="http://schemas.microsoft.com/office/drawing/2014/main" id="{505D67DC-7709-4FB4-9945-B18A9FA0836A}"/>
               </a:ext>
             </a:extLst>
           </p:cNvPr>
@@ -5452,7 +5452,7 @@
           <p:cNvPr id="7" name="">
             <a:extLst xmlns:a="http://schemas.openxmlformats.org/drawingml/2006/main">
               <a:ext uri="{FF2B5EF4-FFF2-40B4-BE49-F238E27FC236}">
-                <a16:creationId xmlns:a16="http://schemas.microsoft.com/office/drawing/2014/main" id="{04996182-F896-4D6E-9A26-77178223936B}"/>
+                <a16:creationId xmlns:a16="http://schemas.microsoft.com/office/drawing/2014/main" id="{ED6913AF-9E01-4A36-9FCC-9119818D0708}"/>
               </a:ext>
             </a:extLst>
           </p:cNvPr>
@@ -5516,7 +5516,7 @@
           <p:cNvPr id="8" name="">
             <a:extLst xmlns:a="http://schemas.openxmlformats.org/drawingml/2006/main">
               <a:ext uri="{FF2B5EF4-FFF2-40B4-BE49-F238E27FC236}">
-                <a16:creationId xmlns:a16="http://schemas.microsoft.com/office/drawing/2014/main" id="{AB68084B-AFD8-447C-94BE-1AB00245470C}"/>
+                <a16:creationId xmlns:a16="http://schemas.microsoft.com/office/drawing/2014/main" id="{F23BA2A6-2EFD-4E37-972F-0E6C0F5B5356}"/>
               </a:ext>
             </a:extLst>
           </p:cNvPr>
@@ -5580,7 +5580,7 @@
           <p:cNvPr id="9" name="">
             <a:extLst xmlns:a="http://schemas.openxmlformats.org/drawingml/2006/main">
               <a:ext uri="{FF2B5EF4-FFF2-40B4-BE49-F238E27FC236}">
-                <a16:creationId xmlns:a16="http://schemas.microsoft.com/office/drawing/2014/main" id="{BB87FE9F-0CBF-46B6-AB73-B22754999493}"/>
+                <a16:creationId xmlns:a16="http://schemas.microsoft.com/office/drawing/2014/main" id="{40C9B550-F5CE-43AF-811B-9F9C5E2213C5}"/>
               </a:ext>
             </a:extLst>
           </p:cNvPr>
@@ -5615,7 +5615,7 @@
           <p:cNvPr id="10" name="">
             <a:extLst xmlns:a="http://schemas.openxmlformats.org/drawingml/2006/main">
               <a:ext uri="{FF2B5EF4-FFF2-40B4-BE49-F238E27FC236}">
-                <a16:creationId xmlns:a16="http://schemas.microsoft.com/office/drawing/2014/main" id="{DC954A6D-7F09-40FC-9267-B64A8A07371F}"/>
+                <a16:creationId xmlns:a16="http://schemas.microsoft.com/office/drawing/2014/main" id="{05BE9298-34D2-4657-AFC0-461159F53102}"/>
               </a:ext>
             </a:extLst>
           </p:cNvPr>
@@ -5650,7 +5650,7 @@
           <p:cNvPr id="11" name="">
             <a:extLst xmlns:a="http://schemas.openxmlformats.org/drawingml/2006/main">
               <a:ext uri="{FF2B5EF4-FFF2-40B4-BE49-F238E27FC236}">
-                <a16:creationId xmlns:a16="http://schemas.microsoft.com/office/drawing/2014/main" id="{DC5683BD-BD9F-42D0-A649-ADD9D27FDE69}"/>
+                <a16:creationId xmlns:a16="http://schemas.microsoft.com/office/drawing/2014/main" id="{37BD4C6F-6385-4E12-94A0-417547371F21}"/>
               </a:ext>
             </a:extLst>
           </p:cNvPr>
@@ -5714,7 +5714,7 @@
           <p:cNvPr id="12" name="">
             <a:extLst xmlns:a="http://schemas.openxmlformats.org/drawingml/2006/main">
               <a:ext uri="{FF2B5EF4-FFF2-40B4-BE49-F238E27FC236}">
-                <a16:creationId xmlns:a16="http://schemas.microsoft.com/office/drawing/2014/main" id="{42D6FBCE-89E9-4D88-84D1-D6EF54422105}"/>
+                <a16:creationId xmlns:a16="http://schemas.microsoft.com/office/drawing/2014/main" id="{224B1F7E-E7DD-4A63-9604-08383D7235C6}"/>
               </a:ext>
             </a:extLst>
           </p:cNvPr>
@@ -5778,7 +5778,7 @@
           <p:cNvPr id="13" name="">
             <a:extLst xmlns:a="http://schemas.openxmlformats.org/drawingml/2006/main">
               <a:ext uri="{FF2B5EF4-FFF2-40B4-BE49-F238E27FC236}">
-                <a16:creationId xmlns:a16="http://schemas.microsoft.com/office/drawing/2014/main" id="{4A42FE9B-CA2F-4558-8ABA-FBEEC8FAF0F0}"/>
+                <a16:creationId xmlns:a16="http://schemas.microsoft.com/office/drawing/2014/main" id="{A9706B98-9551-440A-8741-89685D2BE073}"/>
               </a:ext>
             </a:extLst>
           </p:cNvPr>
@@ -5813,7 +5813,7 @@
           <p:cNvPr id="14" name="">
             <a:extLst xmlns:a="http://schemas.openxmlformats.org/drawingml/2006/main">
               <a:ext uri="{FF2B5EF4-FFF2-40B4-BE49-F238E27FC236}">
-                <a16:creationId xmlns:a16="http://schemas.microsoft.com/office/drawing/2014/main" id="{CB9929FE-74A8-4D97-9C84-32C7E089D563}"/>
+                <a16:creationId xmlns:a16="http://schemas.microsoft.com/office/drawing/2014/main" id="{60A081BD-50C7-404A-A2F8-8FEA7874607D}"/>
               </a:ext>
             </a:extLst>
           </p:cNvPr>
@@ -5848,7 +5848,7 @@
           <p:cNvPr id="15" name="">
             <a:extLst xmlns:a="http://schemas.openxmlformats.org/drawingml/2006/main">
               <a:ext uri="{FF2B5EF4-FFF2-40B4-BE49-F238E27FC236}">
-                <a16:creationId xmlns:a16="http://schemas.microsoft.com/office/drawing/2014/main" id="{F6DFE626-81B5-4855-930B-B28FDE265EB9}"/>
+                <a16:creationId xmlns:a16="http://schemas.microsoft.com/office/drawing/2014/main" id="{66F5E445-022B-4556-BEF1-2B487FDCF438}"/>
               </a:ext>
             </a:extLst>
           </p:cNvPr>
@@ -5912,7 +5912,7 @@
           <p:cNvPr id="16" name="">
             <a:extLst xmlns:a="http://schemas.openxmlformats.org/drawingml/2006/main">
               <a:ext uri="{FF2B5EF4-FFF2-40B4-BE49-F238E27FC236}">
-                <a16:creationId xmlns:a16="http://schemas.microsoft.com/office/drawing/2014/main" id="{C932A0AB-6E18-4A83-B974-0EC4548D402E}"/>
+                <a16:creationId xmlns:a16="http://schemas.microsoft.com/office/drawing/2014/main" id="{688EDBE5-47C8-474E-8B00-AE97D9A8EBB8}"/>
               </a:ext>
             </a:extLst>
           </p:cNvPr>
@@ -5947,7 +5947,7 @@
           <p:cNvPr id="17" name="">
             <a:extLst xmlns:a="http://schemas.openxmlformats.org/drawingml/2006/main">
               <a:ext uri="{FF2B5EF4-FFF2-40B4-BE49-F238E27FC236}">
-                <a16:creationId xmlns:a16="http://schemas.microsoft.com/office/drawing/2014/main" id="{AD71736A-CE7C-4660-AF24-5CEFA14A9A3D}"/>
+                <a16:creationId xmlns:a16="http://schemas.microsoft.com/office/drawing/2014/main" id="{88270756-45E0-485C-9CC9-70F8CB505E7D}"/>
               </a:ext>
             </a:extLst>
           </p:cNvPr>
@@ -6011,7 +6011,7 @@
           <p:cNvPr id="18" name="">
             <a:extLst xmlns:a="http://schemas.openxmlformats.org/drawingml/2006/main">
               <a:ext uri="{FF2B5EF4-FFF2-40B4-BE49-F238E27FC236}">
-                <a16:creationId xmlns:a16="http://schemas.microsoft.com/office/drawing/2014/main" id="{F1407938-B7E2-48D5-A278-A2FF2EC72A93}"/>
+                <a16:creationId xmlns:a16="http://schemas.microsoft.com/office/drawing/2014/main" id="{1253FFED-AA61-47FE-AB15-A528A4951512}"/>
               </a:ext>
             </a:extLst>
           </p:cNvPr>
@@ -6046,7 +6046,7 @@
           <p:cNvPr id="19" name="">
             <a:extLst xmlns:a="http://schemas.openxmlformats.org/drawingml/2006/main">
               <a:ext uri="{FF2B5EF4-FFF2-40B4-BE49-F238E27FC236}">
-                <a16:creationId xmlns:a16="http://schemas.microsoft.com/office/drawing/2014/main" id="{7597D884-6B8F-4286-AE6F-A6609EE36987}"/>
+                <a16:creationId xmlns:a16="http://schemas.microsoft.com/office/drawing/2014/main" id="{9F27384B-4D52-475F-B258-FAC61D5D3C64}"/>
               </a:ext>
             </a:extLst>
           </p:cNvPr>
@@ -6110,7 +6110,7 @@
           <p:cNvPr id="20" name="">
             <a:extLst xmlns:a="http://schemas.openxmlformats.org/drawingml/2006/main">
               <a:ext uri="{FF2B5EF4-FFF2-40B4-BE49-F238E27FC236}">
-                <a16:creationId xmlns:a16="http://schemas.microsoft.com/office/drawing/2014/main" id="{25FA30AA-495F-4EB4-B7B3-06D90DD77701}"/>
+                <a16:creationId xmlns:a16="http://schemas.microsoft.com/office/drawing/2014/main" id="{57DA5D5F-9ECA-4872-8D90-353CDE54FB9A}"/>
               </a:ext>
             </a:extLst>
           </p:cNvPr>
@@ -6145,7 +6145,7 @@
           <p:cNvPr id="21" name="">
             <a:extLst xmlns:a="http://schemas.openxmlformats.org/drawingml/2006/main">
               <a:ext uri="{FF2B5EF4-FFF2-40B4-BE49-F238E27FC236}">
-                <a16:creationId xmlns:a16="http://schemas.microsoft.com/office/drawing/2014/main" id="{F439A0C3-8B6F-4AEC-ACAB-D051811F916F}"/>
+                <a16:creationId xmlns:a16="http://schemas.microsoft.com/office/drawing/2014/main" id="{1F6B10A7-CF4C-493E-A886-9DFA6A8DB0C4}"/>
               </a:ext>
             </a:extLst>
           </p:cNvPr>
@@ -6209,7 +6209,7 @@
           <p:cNvPr id="22" name="">
             <a:extLst xmlns:a="http://schemas.openxmlformats.org/drawingml/2006/main">
               <a:ext uri="{FF2B5EF4-FFF2-40B4-BE49-F238E27FC236}">
-                <a16:creationId xmlns:a16="http://schemas.microsoft.com/office/drawing/2014/main" id="{E74448CD-DAC7-44D1-A5F7-B66FBEF87783}"/>
+                <a16:creationId xmlns:a16="http://schemas.microsoft.com/office/drawing/2014/main" id="{07CDBA71-8721-46E8-AC63-9EF3A51EE48C}"/>
               </a:ext>
             </a:extLst>
           </p:cNvPr>
@@ -6244,7 +6244,7 @@
           <p:cNvPr id="23" name="">
             <a:extLst xmlns:a="http://schemas.openxmlformats.org/drawingml/2006/main">
               <a:ext uri="{FF2B5EF4-FFF2-40B4-BE49-F238E27FC236}">
-                <a16:creationId xmlns:a16="http://schemas.microsoft.com/office/drawing/2014/main" id="{834F1CE9-13C3-4ECC-8662-24E97A900E68}"/>
+                <a16:creationId xmlns:a16="http://schemas.microsoft.com/office/drawing/2014/main" id="{CB94D556-D0AE-4ACC-9802-FFB528F643DB}"/>
               </a:ext>
             </a:extLst>
           </p:cNvPr>
@@ -6308,7 +6308,7 @@
           <p:cNvPr id="24" name="">
             <a:extLst xmlns:a="http://schemas.openxmlformats.org/drawingml/2006/main">
               <a:ext uri="{FF2B5EF4-FFF2-40B4-BE49-F238E27FC236}">
-                <a16:creationId xmlns:a16="http://schemas.microsoft.com/office/drawing/2014/main" id="{F98328E0-77D8-4D2B-8361-43DFFD8AEEC7}"/>
+                <a16:creationId xmlns:a16="http://schemas.microsoft.com/office/drawing/2014/main" id="{5CE23D59-9A02-46D8-9353-06E06036126A}"/>
               </a:ext>
             </a:extLst>
           </p:cNvPr>
@@ -6343,7 +6343,7 @@
           <p:cNvPr id="25" name="">
             <a:extLst xmlns:a="http://schemas.openxmlformats.org/drawingml/2006/main">
               <a:ext uri="{FF2B5EF4-FFF2-40B4-BE49-F238E27FC236}">
-                <a16:creationId xmlns:a16="http://schemas.microsoft.com/office/drawing/2014/main" id="{00AB0EB1-8A0E-4AC9-AB83-196DE5134907}"/>
+                <a16:creationId xmlns:a16="http://schemas.microsoft.com/office/drawing/2014/main" id="{F5A39B43-872C-4302-8C6C-0FB8B7147ACB}"/>
               </a:ext>
             </a:extLst>
           </p:cNvPr>
@@ -6407,7 +6407,7 @@
           <p:cNvPr id="26" name="">
             <a:extLst xmlns:a="http://schemas.openxmlformats.org/drawingml/2006/main">
               <a:ext uri="{FF2B5EF4-FFF2-40B4-BE49-F238E27FC236}">
-                <a16:creationId xmlns:a16="http://schemas.microsoft.com/office/drawing/2014/main" id="{74D575B3-0FB3-4AAD-81CA-6A7F80197978}"/>
+                <a16:creationId xmlns:a16="http://schemas.microsoft.com/office/drawing/2014/main" id="{6BE76B2A-183E-47FF-8302-9B5C422BD02D}"/>
               </a:ext>
             </a:extLst>
           </p:cNvPr>
@@ -6492,7 +6492,7 @@
     </p:spTree>
     <p:extLst>
       <p:ext uri="{BB962C8B-B14F-4D97-AF65-F5344CB8AC3E}">
-        <p14:creationId xmlns:p14="http://schemas.microsoft.com/office/powerpoint/2010/main" val="1029438046"/>
+        <p14:creationId xmlns:p14="http://schemas.microsoft.com/office/powerpoint/2010/main" val="1551880213"/>
       </p:ext>
     </p:extLst>
   </p:cSld>
@@ -6516,7 +6516,7 @@
           <p:cNvPr id="1" name="">
             <a:extLst xmlns:a="http://schemas.openxmlformats.org/drawingml/2006/main">
               <a:ext uri="{FF2B5EF4-FFF2-40B4-BE49-F238E27FC236}">
-                <a16:creationId xmlns:a16="http://schemas.microsoft.com/office/drawing/2014/main" id="{FE87A255-1E39-4FC4-B338-D17ECFBF0189}"/>
+                <a16:creationId xmlns:a16="http://schemas.microsoft.com/office/drawing/2014/main" id="{18224E7C-0167-47DA-B58E-4F0EC2385FA6}"/>
               </a:ext>
             </a:extLst>
           </p:cNvPr>
@@ -6551,7 +6551,7 @@
           <p:cNvPr id="2" name="kicker-marker">
             <a:extLst xmlns:a="http://schemas.openxmlformats.org/drawingml/2006/main">
               <a:ext uri="{FF2B5EF4-FFF2-40B4-BE49-F238E27FC236}">
-                <a16:creationId xmlns:a16="http://schemas.microsoft.com/office/drawing/2014/main" id="{FCF7A947-715D-408E-804F-C9D9B1C13CBB}"/>
+                <a16:creationId xmlns:a16="http://schemas.microsoft.com/office/drawing/2014/main" id="{4A56B77C-09C8-49FB-83B1-5AA03C0D0BD7}"/>
               </a:ext>
             </a:extLst>
           </p:cNvPr>
@@ -6586,7 +6586,7 @@
           <p:cNvPr id="3" name="kicker-label">
             <a:extLst xmlns:a="http://schemas.openxmlformats.org/drawingml/2006/main">
               <a:ext uri="{FF2B5EF4-FFF2-40B4-BE49-F238E27FC236}">
-                <a16:creationId xmlns:a16="http://schemas.microsoft.com/office/drawing/2014/main" id="{C8E68089-99ED-4644-9480-8BB4C5084DDC}"/>
+                <a16:creationId xmlns:a16="http://schemas.microsoft.com/office/drawing/2014/main" id="{27E74AC0-3F51-49C8-B718-0974675C5742}"/>
               </a:ext>
             </a:extLst>
           </p:cNvPr>
@@ -6650,7 +6650,7 @@
           <p:cNvPr id="4" name="">
             <a:extLst xmlns:a="http://schemas.openxmlformats.org/drawingml/2006/main">
               <a:ext uri="{FF2B5EF4-FFF2-40B4-BE49-F238E27FC236}">
-                <a16:creationId xmlns:a16="http://schemas.microsoft.com/office/drawing/2014/main" id="{36B8220A-5CFF-4762-9E1C-A2AF1E66D2C6}"/>
+                <a16:creationId xmlns:a16="http://schemas.microsoft.com/office/drawing/2014/main" id="{3E7900B6-1F70-4FB3-B790-17AA662D3D22}"/>
               </a:ext>
             </a:extLst>
           </p:cNvPr>
@@ -6714,7 +6714,7 @@
           <p:cNvPr id="5" name="">
             <a:extLst xmlns:a="http://schemas.openxmlformats.org/drawingml/2006/main">
               <a:ext uri="{FF2B5EF4-FFF2-40B4-BE49-F238E27FC236}">
-                <a16:creationId xmlns:a16="http://schemas.microsoft.com/office/drawing/2014/main" id="{AD47E282-A905-4A20-A398-9BB28A62260D}"/>
+                <a16:creationId xmlns:a16="http://schemas.microsoft.com/office/drawing/2014/main" id="{3EB3DDA9-435F-4034-BA9B-93A7CA7A02C4}"/>
               </a:ext>
             </a:extLst>
           </p:cNvPr>
@@ -6749,7 +6749,7 @@
           <p:cNvPr id="6" name="">
             <a:extLst xmlns:a="http://schemas.openxmlformats.org/drawingml/2006/main">
               <a:ext uri="{FF2B5EF4-FFF2-40B4-BE49-F238E27FC236}">
-                <a16:creationId xmlns:a16="http://schemas.microsoft.com/office/drawing/2014/main" id="{1316EB68-D33C-4789-B7E9-130D1E95C460}"/>
+                <a16:creationId xmlns:a16="http://schemas.microsoft.com/office/drawing/2014/main" id="{398D62CB-D8A3-44FC-85A6-3007554E2752}"/>
               </a:ext>
             </a:extLst>
           </p:cNvPr>
@@ -6817,7 +6817,7 @@
           <p:nvPr/>
         </p:nvPicPr>
         <p:blipFill>
-          <a:blip xmlns:r="http://schemas.openxmlformats.org/officeDocument/2006/relationships" xmlns:a="http://schemas.openxmlformats.org/drawingml/2006/main" r:embed="R86eeed0b4e3b476a"/>
+          <a:blip xmlns:r="http://schemas.openxmlformats.org/officeDocument/2006/relationships" xmlns:a="http://schemas.openxmlformats.org/drawingml/2006/main" r:embed="R5884ccb16819452c"/>
           <a:stretch xmlns:a="http://schemas.openxmlformats.org/drawingml/2006/main"/>
         </p:blipFill>
         <p:spPr>
@@ -6835,7 +6835,7 @@
           <p:cNvPr id="8" name="">
             <a:extLst xmlns:a="http://schemas.openxmlformats.org/drawingml/2006/main">
               <a:ext uri="{FF2B5EF4-FFF2-40B4-BE49-F238E27FC236}">
-                <a16:creationId xmlns:a16="http://schemas.microsoft.com/office/drawing/2014/main" id="{6FD9D9E2-CE7F-4BCA-B202-4502C0C9AA7B}"/>
+                <a16:creationId xmlns:a16="http://schemas.microsoft.com/office/drawing/2014/main" id="{55B80702-B01B-4C9E-9C66-8B1EAF41F4F0}"/>
               </a:ext>
             </a:extLst>
           </p:cNvPr>
@@ -6868,7 +6868,7 @@
     </p:spTree>
     <p:extLst>
       <p:ext uri="{BB962C8B-B14F-4D97-AF65-F5344CB8AC3E}">
-        <p14:creationId xmlns:p14="http://schemas.microsoft.com/office/powerpoint/2010/main" val="307588250"/>
+        <p14:creationId xmlns:p14="http://schemas.microsoft.com/office/powerpoint/2010/main" val="1403264745"/>
       </p:ext>
     </p:extLst>
   </p:cSld>
@@ -6892,7 +6892,7 @@
           <p:cNvPr id="1" name="">
             <a:extLst xmlns:a="http://schemas.openxmlformats.org/drawingml/2006/main">
               <a:ext uri="{FF2B5EF4-FFF2-40B4-BE49-F238E27FC236}">
-                <a16:creationId xmlns:a16="http://schemas.microsoft.com/office/drawing/2014/main" id="{FC8DFC5A-172E-4C89-89B1-675F0C09F9A7}"/>
+                <a16:creationId xmlns:a16="http://schemas.microsoft.com/office/drawing/2014/main" id="{A8BF77F5-70D7-45C8-A76B-CDC1049922D1}"/>
               </a:ext>
             </a:extLst>
           </p:cNvPr>
@@ -6927,7 +6927,7 @@
           <p:cNvPr id="2" name="kicker-marker">
             <a:extLst xmlns:a="http://schemas.openxmlformats.org/drawingml/2006/main">
               <a:ext uri="{FF2B5EF4-FFF2-40B4-BE49-F238E27FC236}">
-                <a16:creationId xmlns:a16="http://schemas.microsoft.com/office/drawing/2014/main" id="{878205F5-423D-49D3-B984-C12D8A94F64C}"/>
+                <a16:creationId xmlns:a16="http://schemas.microsoft.com/office/drawing/2014/main" id="{ED3AD4AF-ADB7-4936-8C8D-48BA7E21DA18}"/>
               </a:ext>
             </a:extLst>
           </p:cNvPr>
@@ -6962,7 +6962,7 @@
           <p:cNvPr id="3" name="kicker-label">
             <a:extLst xmlns:a="http://schemas.openxmlformats.org/drawingml/2006/main">
               <a:ext uri="{FF2B5EF4-FFF2-40B4-BE49-F238E27FC236}">
-                <a16:creationId xmlns:a16="http://schemas.microsoft.com/office/drawing/2014/main" id="{0E007019-3134-4828-8CFB-9C712E432D35}"/>
+                <a16:creationId xmlns:a16="http://schemas.microsoft.com/office/drawing/2014/main" id="{835DA3EC-71FB-4979-BC4D-9FCB3E8351D2}"/>
               </a:ext>
             </a:extLst>
           </p:cNvPr>
@@ -7026,7 +7026,7 @@
           <p:cNvPr id="4" name="">
             <a:extLst xmlns:a="http://schemas.openxmlformats.org/drawingml/2006/main">
               <a:ext uri="{FF2B5EF4-FFF2-40B4-BE49-F238E27FC236}">
-                <a16:creationId xmlns:a16="http://schemas.microsoft.com/office/drawing/2014/main" id="{26A8AE47-827C-4806-96C5-21D30303AD1A}"/>
+                <a16:creationId xmlns:a16="http://schemas.microsoft.com/office/drawing/2014/main" id="{BC4E9576-952A-4899-8112-4009056CA339}"/>
               </a:ext>
             </a:extLst>
           </p:cNvPr>
@@ -7090,7 +7090,7 @@
           <p:cNvPr id="5" name="">
             <a:extLst xmlns:a="http://schemas.openxmlformats.org/drawingml/2006/main">
               <a:ext uri="{FF2B5EF4-FFF2-40B4-BE49-F238E27FC236}">
-                <a16:creationId xmlns:a16="http://schemas.microsoft.com/office/drawing/2014/main" id="{35A37D47-F34B-45F4-A0E2-3C00FC6D8D4B}"/>
+                <a16:creationId xmlns:a16="http://schemas.microsoft.com/office/drawing/2014/main" id="{A9AC5543-4F5E-4A83-93C9-A85D55B63779}"/>
               </a:ext>
             </a:extLst>
           </p:cNvPr>
@@ -7125,7 +7125,7 @@
           <p:cNvPr id="6" name="">
             <a:extLst xmlns:a="http://schemas.openxmlformats.org/drawingml/2006/main">
               <a:ext uri="{FF2B5EF4-FFF2-40B4-BE49-F238E27FC236}">
-                <a16:creationId xmlns:a16="http://schemas.microsoft.com/office/drawing/2014/main" id="{BFEEF676-E37F-4AB4-8B74-DD076C1E6619}"/>
+                <a16:creationId xmlns:a16="http://schemas.microsoft.com/office/drawing/2014/main" id="{180FAACC-66FD-471D-A162-A776A1C5456C}"/>
               </a:ext>
             </a:extLst>
           </p:cNvPr>
@@ -7193,7 +7193,7 @@
           <p:nvPr/>
         </p:nvPicPr>
         <p:blipFill>
-          <a:blip xmlns:r="http://schemas.openxmlformats.org/officeDocument/2006/relationships" xmlns:a="http://schemas.openxmlformats.org/drawingml/2006/main" r:embed="R1c43f98be2454e48"/>
+          <a:blip xmlns:r="http://schemas.openxmlformats.org/officeDocument/2006/relationships" xmlns:a="http://schemas.openxmlformats.org/drawingml/2006/main" r:embed="R1a83b971b76f4418"/>
           <a:stretch xmlns:a="http://schemas.openxmlformats.org/drawingml/2006/main"/>
         </p:blipFill>
         <p:spPr>
@@ -7211,7 +7211,7 @@
           <p:cNvPr id="8" name="">
             <a:extLst xmlns:a="http://schemas.openxmlformats.org/drawingml/2006/main">
               <a:ext uri="{FF2B5EF4-FFF2-40B4-BE49-F238E27FC236}">
-                <a16:creationId xmlns:a16="http://schemas.microsoft.com/office/drawing/2014/main" id="{9CBC782F-6C0A-43B9-9F81-96C6C0EAA92B}"/>
+                <a16:creationId xmlns:a16="http://schemas.microsoft.com/office/drawing/2014/main" id="{A136A1EA-D5F3-4752-B05B-04ED04379C45}"/>
               </a:ext>
             </a:extLst>
           </p:cNvPr>
@@ -7244,7 +7244,7 @@
     </p:spTree>
     <p:extLst>
       <p:ext uri="{BB962C8B-B14F-4D97-AF65-F5344CB8AC3E}">
-        <p14:creationId xmlns:p14="http://schemas.microsoft.com/office/powerpoint/2010/main" val="2118961569"/>
+        <p14:creationId xmlns:p14="http://schemas.microsoft.com/office/powerpoint/2010/main" val="1223509133"/>
       </p:ext>
     </p:extLst>
   </p:cSld>
@@ -7268,7 +7268,7 @@
           <p:cNvPr id="1" name="">
             <a:extLst xmlns:a="http://schemas.openxmlformats.org/drawingml/2006/main">
               <a:ext uri="{FF2B5EF4-FFF2-40B4-BE49-F238E27FC236}">
-                <a16:creationId xmlns:a16="http://schemas.microsoft.com/office/drawing/2014/main" id="{CD85A629-B903-4E3B-A1FD-26F2AA0E928B}"/>
+                <a16:creationId xmlns:a16="http://schemas.microsoft.com/office/drawing/2014/main" id="{2B83D669-00FF-4A25-A242-8D768F3EA6EF}"/>
               </a:ext>
             </a:extLst>
           </p:cNvPr>
@@ -7303,7 +7303,7 @@
           <p:cNvPr id="2" name="kicker-marker">
             <a:extLst xmlns:a="http://schemas.openxmlformats.org/drawingml/2006/main">
               <a:ext uri="{FF2B5EF4-FFF2-40B4-BE49-F238E27FC236}">
-                <a16:creationId xmlns:a16="http://schemas.microsoft.com/office/drawing/2014/main" id="{4B7C0DE6-D5F3-41CA-81D7-5309A2AEFFB6}"/>
+                <a16:creationId xmlns:a16="http://schemas.microsoft.com/office/drawing/2014/main" id="{9EAD8F88-0F51-47D6-9928-71FBE48468D4}"/>
               </a:ext>
             </a:extLst>
           </p:cNvPr>
@@ -7338,7 +7338,7 @@
           <p:cNvPr id="3" name="kicker-label">
             <a:extLst xmlns:a="http://schemas.openxmlformats.org/drawingml/2006/main">
               <a:ext uri="{FF2B5EF4-FFF2-40B4-BE49-F238E27FC236}">
-                <a16:creationId xmlns:a16="http://schemas.microsoft.com/office/drawing/2014/main" id="{DDC023E5-5E43-4661-BB55-CFA3367CBB73}"/>
+                <a16:creationId xmlns:a16="http://schemas.microsoft.com/office/drawing/2014/main" id="{BF0262BD-1E5E-4129-8DF9-886AAB7FB4FD}"/>
               </a:ext>
             </a:extLst>
           </p:cNvPr>
@@ -7402,7 +7402,7 @@
           <p:cNvPr id="4" name="">
             <a:extLst xmlns:a="http://schemas.openxmlformats.org/drawingml/2006/main">
               <a:ext uri="{FF2B5EF4-FFF2-40B4-BE49-F238E27FC236}">
-                <a16:creationId xmlns:a16="http://schemas.microsoft.com/office/drawing/2014/main" id="{DB512E21-E118-48D9-89E4-023BEC339C23}"/>
+                <a16:creationId xmlns:a16="http://schemas.microsoft.com/office/drawing/2014/main" id="{50B55E4F-F76E-477C-B7DB-882571B4324E}"/>
               </a:ext>
             </a:extLst>
           </p:cNvPr>
@@ -7466,7 +7466,7 @@
           <p:cNvPr id="5" name="">
             <a:extLst xmlns:a="http://schemas.openxmlformats.org/drawingml/2006/main">
               <a:ext uri="{FF2B5EF4-FFF2-40B4-BE49-F238E27FC236}">
-                <a16:creationId xmlns:a16="http://schemas.microsoft.com/office/drawing/2014/main" id="{C0B0218A-8DFB-4E7F-AEC5-156979D891C0}"/>
+                <a16:creationId xmlns:a16="http://schemas.microsoft.com/office/drawing/2014/main" id="{774B63BC-CF78-420A-942D-7612D75457DA}"/>
               </a:ext>
             </a:extLst>
           </p:cNvPr>
@@ -7501,7 +7501,7 @@
           <p:cNvPr id="6" name="">
             <a:extLst xmlns:a="http://schemas.openxmlformats.org/drawingml/2006/main">
               <a:ext uri="{FF2B5EF4-FFF2-40B4-BE49-F238E27FC236}">
-                <a16:creationId xmlns:a16="http://schemas.microsoft.com/office/drawing/2014/main" id="{00FF2F59-A492-4C11-B894-F067386E8098}"/>
+                <a16:creationId xmlns:a16="http://schemas.microsoft.com/office/drawing/2014/main" id="{02F19FC6-FEE1-4365-9C26-771698698F91}"/>
               </a:ext>
             </a:extLst>
           </p:cNvPr>
@@ -7569,7 +7569,7 @@
           <p:nvPr/>
         </p:nvPicPr>
         <p:blipFill>
-          <a:blip xmlns:r="http://schemas.openxmlformats.org/officeDocument/2006/relationships" xmlns:a="http://schemas.openxmlformats.org/drawingml/2006/main" r:embed="Rbb4658029b1f4955"/>
+          <a:blip xmlns:r="http://schemas.openxmlformats.org/officeDocument/2006/relationships" xmlns:a="http://schemas.openxmlformats.org/drawingml/2006/main" r:embed="R3e99a8175f6b4330"/>
           <a:stretch xmlns:a="http://schemas.openxmlformats.org/drawingml/2006/main"/>
         </p:blipFill>
         <p:spPr>
@@ -7587,7 +7587,7 @@
           <p:cNvPr id="8" name="">
             <a:extLst xmlns:a="http://schemas.openxmlformats.org/drawingml/2006/main">
               <a:ext uri="{FF2B5EF4-FFF2-40B4-BE49-F238E27FC236}">
-                <a16:creationId xmlns:a16="http://schemas.microsoft.com/office/drawing/2014/main" id="{8C196E01-A26D-412B-B186-3DAD7DE2C9C2}"/>
+                <a16:creationId xmlns:a16="http://schemas.microsoft.com/office/drawing/2014/main" id="{E6FE33EC-7F36-4A6A-B3BA-E1334863AB73}"/>
               </a:ext>
             </a:extLst>
           </p:cNvPr>
@@ -7622,7 +7622,7 @@
           <p:cNvPr id="9" name="">
             <a:extLst xmlns:a="http://schemas.openxmlformats.org/drawingml/2006/main">
               <a:ext uri="{FF2B5EF4-FFF2-40B4-BE49-F238E27FC236}">
-                <a16:creationId xmlns:a16="http://schemas.microsoft.com/office/drawing/2014/main" id="{5311B018-AD46-4756-98AE-5D29978FE873}"/>
+                <a16:creationId xmlns:a16="http://schemas.microsoft.com/office/drawing/2014/main" id="{A070E0D3-EC72-4BE0-A1AD-998F49264145}"/>
               </a:ext>
             </a:extLst>
           </p:cNvPr>
@@ -7657,7 +7657,7 @@
           <p:cNvPr id="10" name="">
             <a:extLst xmlns:a="http://schemas.openxmlformats.org/drawingml/2006/main">
               <a:ext uri="{FF2B5EF4-FFF2-40B4-BE49-F238E27FC236}">
-                <a16:creationId xmlns:a16="http://schemas.microsoft.com/office/drawing/2014/main" id="{E28BCEBF-AA0F-485B-803F-18AAD4BEB97C}"/>
+                <a16:creationId xmlns:a16="http://schemas.microsoft.com/office/drawing/2014/main" id="{1FD70D16-67E1-4213-9146-D74B45908DAF}"/>
               </a:ext>
             </a:extLst>
           </p:cNvPr>
@@ -7721,7 +7721,7 @@
           <p:cNvPr id="11" name="">
             <a:extLst xmlns:a="http://schemas.openxmlformats.org/drawingml/2006/main">
               <a:ext uri="{FF2B5EF4-FFF2-40B4-BE49-F238E27FC236}">
-                <a16:creationId xmlns:a16="http://schemas.microsoft.com/office/drawing/2014/main" id="{045E2C48-158D-4EBF-8848-96DCDDEC4FB7}"/>
+                <a16:creationId xmlns:a16="http://schemas.microsoft.com/office/drawing/2014/main" id="{C416040C-98B0-4CD5-B94D-846CB32117AE}"/>
               </a:ext>
             </a:extLst>
           </p:cNvPr>
@@ -7776,7 +7776,7 @@
                 <a:cs typeface="Aptos"/>
                 <a:hlinkClick xmlns:r="http://schemas.openxmlformats.org/officeDocument/2006/relationships" r:id="rIdSynthAMLDemo"/>
               </a:rPr>
-              <a:t>https://rawcdn.githack.com/yq688m3JT/genAI_final/ae9c84ea574e9f8c48c84f1863ce82f77ea4f24e/docs/demo.html</a:t>
+              <a:t>https://raw.githack.com/yq688m3JT/genAI_final/ae9c84ea574e9f8c48c84f1863ce82f77ea4f24e/docs/demo.html</a:t>
             </a:r>
           </a:p>
         </p:txBody>
@@ -7784,7 +7784,7 @@
     </p:spTree>
     <p:extLst>
       <p:ext uri="{BB962C8B-B14F-4D97-AF65-F5344CB8AC3E}">
-        <p14:creationId xmlns:p14="http://schemas.microsoft.com/office/powerpoint/2010/main" val="51217630"/>
+        <p14:creationId xmlns:p14="http://schemas.microsoft.com/office/powerpoint/2010/main" val="1354282647"/>
       </p:ext>
     </p:extLst>
   </p:cSld>

</xml_diff>

<commit_message>
Refine presentation workflow framing
</commit_message>
<xml_diff>
--- a/docs/synthaml-final-presentation.pptx
+++ b/docs/synthaml-final-presentation.pptx
@@ -2,19 +2,19 @@
 <file path=ppt/presentation.xml><?xml version="1.0" encoding="utf-8"?>
 <p:presentation xmlns:p="http://schemas.openxmlformats.org/presentationml/2006/main">
   <p:sldMasterIdLst>
-    <p:sldMasterId xmlns:r="http://schemas.openxmlformats.org/officeDocument/2006/relationships" id="2147483648" r:id="R71a4390f428a4c65"/>
+    <p:sldMasterId xmlns:r="http://schemas.openxmlformats.org/officeDocument/2006/relationships" id="2147483648" r:id="R3a2fce655f4f4826"/>
   </p:sldMasterIdLst>
   <p:notesMasterIdLst>
-    <p:notesMasterId xmlns:r="http://schemas.openxmlformats.org/officeDocument/2006/relationships" r:id="R81e22df8ee9f4bd4"/>
+    <p:notesMasterId xmlns:r="http://schemas.openxmlformats.org/officeDocument/2006/relationships" r:id="R305f9166c38f47bb"/>
   </p:notesMasterIdLst>
   <p:sldIdLst>
-    <p:sldId xmlns:r="http://schemas.openxmlformats.org/officeDocument/2006/relationships" id="256" r:id="Race3df6aa8b04633"/>
-    <p:sldId xmlns:r="http://schemas.openxmlformats.org/officeDocument/2006/relationships" id="257" r:id="R12498c26eb544bf8"/>
-    <p:sldId xmlns:r="http://schemas.openxmlformats.org/officeDocument/2006/relationships" id="258" r:id="R1dc6af62d7ad4969"/>
-    <p:sldId xmlns:r="http://schemas.openxmlformats.org/officeDocument/2006/relationships" id="259" r:id="Rfd203ee9ef1a40f4"/>
-    <p:sldId xmlns:r="http://schemas.openxmlformats.org/officeDocument/2006/relationships" id="260" r:id="Rc88bbad68cc748a2"/>
-    <p:sldId xmlns:r="http://schemas.openxmlformats.org/officeDocument/2006/relationships" id="261" r:id="Rea5bd50138b54e40"/>
-    <p:sldId xmlns:r="http://schemas.openxmlformats.org/officeDocument/2006/relationships" id="262" r:id="Rb63e02b0a9db468a"/>
+    <p:sldId xmlns:r="http://schemas.openxmlformats.org/officeDocument/2006/relationships" id="256" r:id="R89e760b3261941b7"/>
+    <p:sldId xmlns:r="http://schemas.openxmlformats.org/officeDocument/2006/relationships" id="257" r:id="Re2ce619c0fb14d01"/>
+    <p:sldId xmlns:r="http://schemas.openxmlformats.org/officeDocument/2006/relationships" id="258" r:id="R802e3841f913462a"/>
+    <p:sldId xmlns:r="http://schemas.openxmlformats.org/officeDocument/2006/relationships" id="259" r:id="R98d1f3b385784555"/>
+    <p:sldId xmlns:r="http://schemas.openxmlformats.org/officeDocument/2006/relationships" id="260" r:id="Rd40b4e84048f41ba"/>
+    <p:sldId xmlns:r="http://schemas.openxmlformats.org/officeDocument/2006/relationships" id="261" r:id="Rbf01955847564b69"/>
+    <p:sldId xmlns:r="http://schemas.openxmlformats.org/officeDocument/2006/relationships" id="262" r:id="Re667ac80bce74e35"/>
   </p:sldIdLst>
   <p:sldSz cx="12192000" cy="6858000"/>
   <p:notesSz cx="6858000" cy="9144000"/>
@@ -957,7 +957,7 @@
   </p:cSld>
   <p:clrMap bg1="lt1" tx1="dk1" bg2="lt2" tx2="dk2" accent1="accent1" accent2="accent2" accent3="accent3" accent4="accent4" accent5="accent5" accent6="accent6" hlink="hlink" folHlink="folHlink"/>
   <p:sldLayoutIdLst>
-    <p:sldLayoutId xmlns:r="http://schemas.openxmlformats.org/officeDocument/2006/relationships" id="2147483649" r:id="R69bd17f494fe4ce3"/>
+    <p:sldLayoutId xmlns:r="http://schemas.openxmlformats.org/officeDocument/2006/relationships" id="2147483649" r:id="R3c71c3e4e21b454e"/>
   </p:sldLayoutIdLst>
   <p:txStyles>
     <p:titleStyle>
@@ -1256,7 +1256,7 @@
           <p:cNvPr id="1" name="">
             <a:extLst xmlns:a="http://schemas.openxmlformats.org/drawingml/2006/main">
               <a:ext uri="{FF2B5EF4-FFF2-40B4-BE49-F238E27FC236}">
-                <a16:creationId xmlns:a16="http://schemas.microsoft.com/office/drawing/2014/main" id="{8CA75212-C959-495C-A4BA-3FF06CBF5029}"/>
+                <a16:creationId xmlns:a16="http://schemas.microsoft.com/office/drawing/2014/main" id="{39CAB9FB-387D-47DF-95CF-2EF8D93D6922}"/>
               </a:ext>
             </a:extLst>
           </p:cNvPr>
@@ -1291,7 +1291,7 @@
           <p:cNvPr id="2" name="">
             <a:extLst xmlns:a="http://schemas.openxmlformats.org/drawingml/2006/main">
               <a:ext uri="{FF2B5EF4-FFF2-40B4-BE49-F238E27FC236}">
-                <a16:creationId xmlns:a16="http://schemas.microsoft.com/office/drawing/2014/main" id="{19BD1D39-F9C3-47A8-82BD-A9EC18A64BC9}"/>
+                <a16:creationId xmlns:a16="http://schemas.microsoft.com/office/drawing/2014/main" id="{CF47CC68-88BE-4A45-9AF0-09FFA886E5AD}"/>
               </a:ext>
             </a:extLst>
           </p:cNvPr>
@@ -1326,7 +1326,7 @@
           <p:cNvPr id="3" name="">
             <a:extLst xmlns:a="http://schemas.openxmlformats.org/drawingml/2006/main">
               <a:ext uri="{FF2B5EF4-FFF2-40B4-BE49-F238E27FC236}">
-                <a16:creationId xmlns:a16="http://schemas.microsoft.com/office/drawing/2014/main" id="{9B724D6F-A28C-4E6F-8D70-B363880E25A9}"/>
+                <a16:creationId xmlns:a16="http://schemas.microsoft.com/office/drawing/2014/main" id="{CB624444-27DC-4FCE-A755-174F11EC28B7}"/>
               </a:ext>
             </a:extLst>
           </p:cNvPr>
@@ -1390,7 +1390,7 @@
           <p:cNvPr id="4" name="">
             <a:extLst xmlns:a="http://schemas.openxmlformats.org/drawingml/2006/main">
               <a:ext uri="{FF2B5EF4-FFF2-40B4-BE49-F238E27FC236}">
-                <a16:creationId xmlns:a16="http://schemas.microsoft.com/office/drawing/2014/main" id="{C3FCD9E7-8B5A-4851-A0FE-8F1B3B6AF865}"/>
+                <a16:creationId xmlns:a16="http://schemas.microsoft.com/office/drawing/2014/main" id="{7379FE1D-C1A6-4614-801A-7C2C6C586BA3}"/>
               </a:ext>
             </a:extLst>
           </p:cNvPr>
@@ -1454,7 +1454,7 @@
           <p:cNvPr id="5" name="">
             <a:extLst xmlns:a="http://schemas.openxmlformats.org/drawingml/2006/main">
               <a:ext uri="{FF2B5EF4-FFF2-40B4-BE49-F238E27FC236}">
-                <a16:creationId xmlns:a16="http://schemas.microsoft.com/office/drawing/2014/main" id="{B172D1C9-28D8-4447-A7B2-66C16D1B108E}"/>
+                <a16:creationId xmlns:a16="http://schemas.microsoft.com/office/drawing/2014/main" id="{5167B0EE-0DD1-41FB-A91B-2453B98CF36D}"/>
               </a:ext>
             </a:extLst>
           </p:cNvPr>
@@ -1508,7 +1508,7 @@
                 <a:ea typeface="Aptos"/>
                 <a:cs typeface="Aptos"/>
               </a:rPr>
-              <a:t>A commercial-style GenAI workbench for turning AML typology warnings into synthetic transaction test data.</a:t>
+              <a:t>A focused GenAI workflow for the AML data cold-start: from typology warning to reviewed model QA package.</a:t>
             </a:r>
           </a:p>
         </p:txBody>
@@ -1518,7 +1518,7 @@
           <p:cNvPr id="6" name="">
             <a:extLst xmlns:a="http://schemas.openxmlformats.org/drawingml/2006/main">
               <a:ext uri="{FF2B5EF4-FFF2-40B4-BE49-F238E27FC236}">
-                <a16:creationId xmlns:a16="http://schemas.microsoft.com/office/drawing/2014/main" id="{CA8FC23B-6771-40C7-B19D-CD6F286938C8}"/>
+                <a16:creationId xmlns:a16="http://schemas.microsoft.com/office/drawing/2014/main" id="{C3957CFE-9626-4E85-A2BC-723FFA1E0E5C}"/>
               </a:ext>
             </a:extLst>
           </p:cNvPr>
@@ -1553,7 +1553,7 @@
           <p:cNvPr id="7" name="">
             <a:extLst xmlns:a="http://schemas.openxmlformats.org/drawingml/2006/main">
               <a:ext uri="{FF2B5EF4-FFF2-40B4-BE49-F238E27FC236}">
-                <a16:creationId xmlns:a16="http://schemas.microsoft.com/office/drawing/2014/main" id="{FAFAEF81-651B-4CDA-881E-126486DF311A}"/>
+                <a16:creationId xmlns:a16="http://schemas.microsoft.com/office/drawing/2014/main" id="{6B56629B-CE6E-41B5-ABC0-2DCBCE5B3A19}"/>
               </a:ext>
             </a:extLst>
           </p:cNvPr>
@@ -1617,7 +1617,7 @@
           <p:cNvPr id="8" name="">
             <a:extLst xmlns:a="http://schemas.openxmlformats.org/drawingml/2006/main">
               <a:ext uri="{FF2B5EF4-FFF2-40B4-BE49-F238E27FC236}">
-                <a16:creationId xmlns:a16="http://schemas.microsoft.com/office/drawing/2014/main" id="{C52C7766-19A5-467D-96A4-E92A44D38B0A}"/>
+                <a16:creationId xmlns:a16="http://schemas.microsoft.com/office/drawing/2014/main" id="{2CC43EF4-4084-480D-852D-85196DF2650C}"/>
               </a:ext>
             </a:extLst>
           </p:cNvPr>
@@ -1681,7 +1681,7 @@
           <p:cNvPr id="9" name="">
             <a:extLst xmlns:a="http://schemas.openxmlformats.org/drawingml/2006/main">
               <a:ext uri="{FF2B5EF4-FFF2-40B4-BE49-F238E27FC236}">
-                <a16:creationId xmlns:a16="http://schemas.microsoft.com/office/drawing/2014/main" id="{4BDE4BF2-ECA5-487E-B223-5803942AC1D1}"/>
+                <a16:creationId xmlns:a16="http://schemas.microsoft.com/office/drawing/2014/main" id="{E7EE1238-4585-4AC2-825D-5EEC3759DFBB}"/>
               </a:ext>
             </a:extLst>
           </p:cNvPr>
@@ -1745,7 +1745,7 @@
           <p:cNvPr id="10" name="">
             <a:extLst xmlns:a="http://schemas.openxmlformats.org/drawingml/2006/main">
               <a:ext uri="{FF2B5EF4-FFF2-40B4-BE49-F238E27FC236}">
-                <a16:creationId xmlns:a16="http://schemas.microsoft.com/office/drawing/2014/main" id="{EA47B0F5-D497-49F1-AE6B-68EF7FB695BF}"/>
+                <a16:creationId xmlns:a16="http://schemas.microsoft.com/office/drawing/2014/main" id="{05809DA0-A7B1-4AF3-82B9-046AD0F57A01}"/>
               </a:ext>
             </a:extLst>
           </p:cNvPr>
@@ -1799,7 +1799,7 @@
                 <a:ea typeface="Aptos"/>
                 <a:cs typeface="Aptos"/>
               </a:rPr>
-              <a:t>Typology intake to QA export</a:t>
+              <a:t>Warning to QA package</a:t>
             </a:r>
           </a:p>
         </p:txBody>
@@ -1809,7 +1809,7 @@
           <p:cNvPr id="11" name="">
             <a:extLst xmlns:a="http://schemas.openxmlformats.org/drawingml/2006/main">
               <a:ext uri="{FF2B5EF4-FFF2-40B4-BE49-F238E27FC236}">
-                <a16:creationId xmlns:a16="http://schemas.microsoft.com/office/drawing/2014/main" id="{804A1E72-C5BB-4265-BEC9-F050E613BBDB}"/>
+                <a16:creationId xmlns:a16="http://schemas.microsoft.com/office/drawing/2014/main" id="{46E84EB7-0711-4588-9454-0210484C3824}"/>
               </a:ext>
             </a:extLst>
           </p:cNvPr>
@@ -1873,7 +1873,7 @@
           <p:cNvPr id="12" name="">
             <a:extLst xmlns:a="http://schemas.openxmlformats.org/drawingml/2006/main">
               <a:ext uri="{FF2B5EF4-FFF2-40B4-BE49-F238E27FC236}">
-                <a16:creationId xmlns:a16="http://schemas.microsoft.com/office/drawing/2014/main" id="{A403817F-B063-49FE-B0CC-EC01DA254F8D}"/>
+                <a16:creationId xmlns:a16="http://schemas.microsoft.com/office/drawing/2014/main" id="{64F98802-3882-42E0-8826-6073603EB6C9}"/>
               </a:ext>
             </a:extLst>
           </p:cNvPr>
@@ -1937,7 +1937,7 @@
           <p:cNvPr id="13" name="">
             <a:extLst xmlns:a="http://schemas.openxmlformats.org/drawingml/2006/main">
               <a:ext uri="{FF2B5EF4-FFF2-40B4-BE49-F238E27FC236}">
-                <a16:creationId xmlns:a16="http://schemas.microsoft.com/office/drawing/2014/main" id="{8A6211C8-76D1-43D3-A89B-86EEF0B53C1C}"/>
+                <a16:creationId xmlns:a16="http://schemas.microsoft.com/office/drawing/2014/main" id="{7A85C393-5C8B-4A98-AA4F-44E55BF8042B}"/>
               </a:ext>
             </a:extLst>
           </p:cNvPr>
@@ -1972,7 +1972,7 @@
           <p:cNvPr id="14" name="">
             <a:extLst xmlns:a="http://schemas.openxmlformats.org/drawingml/2006/main">
               <a:ext uri="{FF2B5EF4-FFF2-40B4-BE49-F238E27FC236}">
-                <a16:creationId xmlns:a16="http://schemas.microsoft.com/office/drawing/2014/main" id="{5D75E9D0-9AAE-4EAF-9C8B-82498C5E7BBD}"/>
+                <a16:creationId xmlns:a16="http://schemas.microsoft.com/office/drawing/2014/main" id="{2ADAE7FF-ABA8-4039-9EDE-86DC90C9AA85}"/>
               </a:ext>
             </a:extLst>
           </p:cNvPr>
@@ -2036,7 +2036,7 @@
           <p:cNvPr id="15" name="">
             <a:extLst xmlns:a="http://schemas.openxmlformats.org/drawingml/2006/main">
               <a:ext uri="{FF2B5EF4-FFF2-40B4-BE49-F238E27FC236}">
-                <a16:creationId xmlns:a16="http://schemas.microsoft.com/office/drawing/2014/main" id="{77126ECF-1B0B-4637-88C1-C2427BB25364}"/>
+                <a16:creationId xmlns:a16="http://schemas.microsoft.com/office/drawing/2014/main" id="{A950BCBC-0DE0-40C3-BA33-EA904F836108}"/>
               </a:ext>
             </a:extLst>
           </p:cNvPr>
@@ -2123,7 +2123,7 @@
           <p:cNvPr id="16" name="">
             <a:extLst xmlns:a="http://schemas.openxmlformats.org/drawingml/2006/main">
               <a:ext uri="{FF2B5EF4-FFF2-40B4-BE49-F238E27FC236}">
-                <a16:creationId xmlns:a16="http://schemas.microsoft.com/office/drawing/2014/main" id="{D63BF923-14AF-4014-A70A-7F0B047BFC31}"/>
+                <a16:creationId xmlns:a16="http://schemas.microsoft.com/office/drawing/2014/main" id="{36E6BAE1-5F2E-41BF-A411-A3EC56A81F39}"/>
               </a:ext>
             </a:extLst>
           </p:cNvPr>
@@ -2187,7 +2187,7 @@
           <p:cNvPr id="17" name="">
             <a:extLst xmlns:a="http://schemas.openxmlformats.org/drawingml/2006/main">
               <a:ext uri="{FF2B5EF4-FFF2-40B4-BE49-F238E27FC236}">
-                <a16:creationId xmlns:a16="http://schemas.microsoft.com/office/drawing/2014/main" id="{98F03467-7368-4D7A-A78E-6532F6B7EA6C}"/>
+                <a16:creationId xmlns:a16="http://schemas.microsoft.com/office/drawing/2014/main" id="{AE23D9EB-B24B-4321-B6D6-D890868D7742}"/>
               </a:ext>
             </a:extLst>
           </p:cNvPr>
@@ -2250,7 +2250,7 @@
     </p:spTree>
     <p:extLst>
       <p:ext uri="{BB962C8B-B14F-4D97-AF65-F5344CB8AC3E}">
-        <p14:creationId xmlns:p14="http://schemas.microsoft.com/office/powerpoint/2010/main" val="2052793352"/>
+        <p14:creationId xmlns:p14="http://schemas.microsoft.com/office/powerpoint/2010/main" val="1442319251"/>
       </p:ext>
     </p:extLst>
   </p:cSld>
@@ -2274,7 +2274,7 @@
           <p:cNvPr id="1" name="">
             <a:extLst xmlns:a="http://schemas.openxmlformats.org/drawingml/2006/main">
               <a:ext uri="{FF2B5EF4-FFF2-40B4-BE49-F238E27FC236}">
-                <a16:creationId xmlns:a16="http://schemas.microsoft.com/office/drawing/2014/main" id="{0EF2FBDB-BE25-4348-BF83-5E19A22E5D32}"/>
+                <a16:creationId xmlns:a16="http://schemas.microsoft.com/office/drawing/2014/main" id="{5AA3739A-ADFE-4021-9EA0-1F35BC43A3A6}"/>
               </a:ext>
             </a:extLst>
           </p:cNvPr>
@@ -2309,7 +2309,7 @@
           <p:cNvPr id="2" name="kicker-marker">
             <a:extLst xmlns:a="http://schemas.openxmlformats.org/drawingml/2006/main">
               <a:ext uri="{FF2B5EF4-FFF2-40B4-BE49-F238E27FC236}">
-                <a16:creationId xmlns:a16="http://schemas.microsoft.com/office/drawing/2014/main" id="{29C2ADAA-99F7-4541-8824-C6D1E0926BC5}"/>
+                <a16:creationId xmlns:a16="http://schemas.microsoft.com/office/drawing/2014/main" id="{F212126D-5C70-45D8-BC37-D556259F7F8F}"/>
               </a:ext>
             </a:extLst>
           </p:cNvPr>
@@ -2344,7 +2344,7 @@
           <p:cNvPr id="3" name="kicker-label">
             <a:extLst xmlns:a="http://schemas.openxmlformats.org/drawingml/2006/main">
               <a:ext uri="{FF2B5EF4-FFF2-40B4-BE49-F238E27FC236}">
-                <a16:creationId xmlns:a16="http://schemas.microsoft.com/office/drawing/2014/main" id="{A2E1B26B-1176-4021-B233-ACAF1B22CA17}"/>
+                <a16:creationId xmlns:a16="http://schemas.microsoft.com/office/drawing/2014/main" id="{AB291D75-651D-49C1-81A2-C04F3F2C97A0}"/>
               </a:ext>
             </a:extLst>
           </p:cNvPr>
@@ -2408,7 +2408,7 @@
           <p:cNvPr id="4" name="">
             <a:extLst xmlns:a="http://schemas.openxmlformats.org/drawingml/2006/main">
               <a:ext uri="{FF2B5EF4-FFF2-40B4-BE49-F238E27FC236}">
-                <a16:creationId xmlns:a16="http://schemas.microsoft.com/office/drawing/2014/main" id="{50BF3BD3-9DBB-4D6C-BAFA-68ED059E3FA5}"/>
+                <a16:creationId xmlns:a16="http://schemas.microsoft.com/office/drawing/2014/main" id="{B0B981B8-F286-4957-8172-0AA47014EB78}"/>
               </a:ext>
             </a:extLst>
           </p:cNvPr>
@@ -2462,7 +2462,7 @@
                 <a:ea typeface="Aptos Display"/>
                 <a:cs typeface="Aptos Display"/>
               </a:rPr>
-              <a:t>New AML typologies create a data cold start before models can learn the pattern.</a:t>
+              <a:t>AML teams need to test new laundering patterns before real labeled cases exist.</a:t>
             </a:r>
           </a:p>
         </p:txBody>
@@ -2472,7 +2472,7 @@
           <p:cNvPr id="5" name="">
             <a:extLst xmlns:a="http://schemas.openxmlformats.org/drawingml/2006/main">
               <a:ext uri="{FF2B5EF4-FFF2-40B4-BE49-F238E27FC236}">
-                <a16:creationId xmlns:a16="http://schemas.microsoft.com/office/drawing/2014/main" id="{D6076945-E09E-49A3-89F9-84077BFEEF9E}"/>
+                <a16:creationId xmlns:a16="http://schemas.microsoft.com/office/drawing/2014/main" id="{D92F87F2-DE5F-4515-B1FD-10CA5A933F3C}"/>
               </a:ext>
             </a:extLst>
           </p:cNvPr>
@@ -2526,7 +2526,7 @@
                 <a:ea typeface="Aptos"/>
                 <a:cs typeface="Aptos"/>
               </a:rPr>
-              <a:t>Target user: AML algorithm engineers and compliance data scientists at cross-border payment firms.</a:t>
+              <a:t>Target user: AML algorithm engineers and compliance data scientists responsible for model QA at banks or cross-border payment firms.</a:t>
             </a:r>
           </a:p>
         </p:txBody>
@@ -2536,7 +2536,7 @@
           <p:cNvPr id="6" name="">
             <a:extLst xmlns:a="http://schemas.openxmlformats.org/drawingml/2006/main">
               <a:ext uri="{FF2B5EF4-FFF2-40B4-BE49-F238E27FC236}">
-                <a16:creationId xmlns:a16="http://schemas.microsoft.com/office/drawing/2014/main" id="{F4211E6C-B5D9-4B20-8335-6D28B74E0C11}"/>
+                <a16:creationId xmlns:a16="http://schemas.microsoft.com/office/drawing/2014/main" id="{6592A430-BEED-49EC-9A67-F44A12A9A644}"/>
               </a:ext>
             </a:extLst>
           </p:cNvPr>
@@ -2571,7 +2571,7 @@
           <p:cNvPr id="7" name="">
             <a:extLst xmlns:a="http://schemas.openxmlformats.org/drawingml/2006/main">
               <a:ext uri="{FF2B5EF4-FFF2-40B4-BE49-F238E27FC236}">
-                <a16:creationId xmlns:a16="http://schemas.microsoft.com/office/drawing/2014/main" id="{1971FC4E-AFBB-4F50-9C0D-02931CAAB987}"/>
+                <a16:creationId xmlns:a16="http://schemas.microsoft.com/office/drawing/2014/main" id="{2616D5A6-997B-4135-B05F-DCD9B1E01F05}"/>
               </a:ext>
             </a:extLst>
           </p:cNvPr>
@@ -2635,7 +2635,7 @@
           <p:cNvPr id="8" name="">
             <a:extLst xmlns:a="http://schemas.openxmlformats.org/drawingml/2006/main">
               <a:ext uri="{FF2B5EF4-FFF2-40B4-BE49-F238E27FC236}">
-                <a16:creationId xmlns:a16="http://schemas.microsoft.com/office/drawing/2014/main" id="{867586C9-BEEE-43A7-9872-0F2B09FDC2C8}"/>
+                <a16:creationId xmlns:a16="http://schemas.microsoft.com/office/drawing/2014/main" id="{0233AF46-9205-496C-B1D8-85D6BE5769E5}"/>
               </a:ext>
             </a:extLst>
           </p:cNvPr>
@@ -2689,7 +2689,7 @@
                 <a:ea typeface="Aptos"/>
                 <a:cs typeface="Aptos"/>
               </a:rPr>
-              <a:t>Regulator warning</a:t>
+              <a:t>New warning</a:t>
             </a:r>
           </a:p>
         </p:txBody>
@@ -2699,7 +2699,7 @@
           <p:cNvPr id="9" name="">
             <a:extLst xmlns:a="http://schemas.openxmlformats.org/drawingml/2006/main">
               <a:ext uri="{FF2B5EF4-FFF2-40B4-BE49-F238E27FC236}">
-                <a16:creationId xmlns:a16="http://schemas.microsoft.com/office/drawing/2014/main" id="{0AC35967-2AD7-494F-A79B-6B2500BE9F11}"/>
+                <a16:creationId xmlns:a16="http://schemas.microsoft.com/office/drawing/2014/main" id="{8ADFD8B2-C4BF-4160-99F6-9866C5A836BD}"/>
               </a:ext>
             </a:extLst>
           </p:cNvPr>
@@ -2753,7 +2753,7 @@
                 <a:ea typeface="Aptos"/>
                 <a:cs typeface="Aptos"/>
               </a:rPr>
-              <a:t>A prose report describes a new shell-company trade pattern.</a:t>
+              <a:t>A regulator describes a shell-company trade pattern in prose.</a:t>
             </a:r>
           </a:p>
         </p:txBody>
@@ -2763,7 +2763,7 @@
           <p:cNvPr id="10" name="">
             <a:extLst xmlns:a="http://schemas.openxmlformats.org/drawingml/2006/main">
               <a:ext uri="{FF2B5EF4-FFF2-40B4-BE49-F238E27FC236}">
-                <a16:creationId xmlns:a16="http://schemas.microsoft.com/office/drawing/2014/main" id="{0C63A22A-836B-481E-8D23-B862D8C5587C}"/>
+                <a16:creationId xmlns:a16="http://schemas.microsoft.com/office/drawing/2014/main" id="{D6E96F76-380C-46B5-87CE-C5B627081ED9}"/>
               </a:ext>
             </a:extLst>
           </p:cNvPr>
@@ -2798,7 +2798,7 @@
           <p:cNvPr id="11" name="">
             <a:extLst xmlns:a="http://schemas.openxmlformats.org/drawingml/2006/main">
               <a:ext uri="{FF2B5EF4-FFF2-40B4-BE49-F238E27FC236}">
-                <a16:creationId xmlns:a16="http://schemas.microsoft.com/office/drawing/2014/main" id="{1998C3D6-BB65-47F8-A51D-03CCA81337F5}"/>
+                <a16:creationId xmlns:a16="http://schemas.microsoft.com/office/drawing/2014/main" id="{5BD173DF-8191-4261-A1C2-D8B5A2F5502B}"/>
               </a:ext>
             </a:extLst>
           </p:cNvPr>
@@ -2833,7 +2833,7 @@
           <p:cNvPr id="12" name="">
             <a:extLst xmlns:a="http://schemas.openxmlformats.org/drawingml/2006/main">
               <a:ext uri="{FF2B5EF4-FFF2-40B4-BE49-F238E27FC236}">
-                <a16:creationId xmlns:a16="http://schemas.microsoft.com/office/drawing/2014/main" id="{50F028C7-111C-439D-9A02-48C21646F554}"/>
+                <a16:creationId xmlns:a16="http://schemas.microsoft.com/office/drawing/2014/main" id="{7DD1AFD4-BF4B-45BB-8033-AE8C7B3920AF}"/>
               </a:ext>
             </a:extLst>
           </p:cNvPr>
@@ -2868,7 +2868,7 @@
           <p:cNvPr id="13" name="">
             <a:extLst xmlns:a="http://schemas.openxmlformats.org/drawingml/2006/main">
               <a:ext uri="{FF2B5EF4-FFF2-40B4-BE49-F238E27FC236}">
-                <a16:creationId xmlns:a16="http://schemas.microsoft.com/office/drawing/2014/main" id="{AA5E433C-FD00-4BBA-AC6D-8E690BB5652D}"/>
+                <a16:creationId xmlns:a16="http://schemas.microsoft.com/office/drawing/2014/main" id="{91BECE90-0660-4EE5-BCDE-3E2F3E52D7CD}"/>
               </a:ext>
             </a:extLst>
           </p:cNvPr>
@@ -2932,7 +2932,7 @@
           <p:cNvPr id="14" name="">
             <a:extLst xmlns:a="http://schemas.openxmlformats.org/drawingml/2006/main">
               <a:ext uri="{FF2B5EF4-FFF2-40B4-BE49-F238E27FC236}">
-                <a16:creationId xmlns:a16="http://schemas.microsoft.com/office/drawing/2014/main" id="{8F139907-0756-4ACB-946F-4C28CF794E92}"/>
+                <a16:creationId xmlns:a16="http://schemas.microsoft.com/office/drawing/2014/main" id="{79203AAA-1FEA-4327-8D2B-44A642AD920E}"/>
               </a:ext>
             </a:extLst>
           </p:cNvPr>
@@ -2986,7 +2986,7 @@
                 <a:ea typeface="Aptos"/>
                 <a:cs typeface="Aptos"/>
               </a:rPr>
-              <a:t>No labels yet</a:t>
+              <a:t>No labels</a:t>
             </a:r>
           </a:p>
         </p:txBody>
@@ -2996,7 +2996,7 @@
           <p:cNvPr id="15" name="">
             <a:extLst xmlns:a="http://schemas.openxmlformats.org/drawingml/2006/main">
               <a:ext uri="{FF2B5EF4-FFF2-40B4-BE49-F238E27FC236}">
-                <a16:creationId xmlns:a16="http://schemas.microsoft.com/office/drawing/2014/main" id="{98BD5356-1861-40EC-972A-297297A500D3}"/>
+                <a16:creationId xmlns:a16="http://schemas.microsoft.com/office/drawing/2014/main" id="{DFEE2614-7874-4C12-8283-351D0C830142}"/>
               </a:ext>
             </a:extLst>
           </p:cNvPr>
@@ -3050,7 +3050,7 @@
                 <a:ea typeface="Aptos"/>
                 <a:cs typeface="Aptos"/>
               </a:rPr>
-              <a:t>The bank has no historical examples for the typology.</a:t>
+              <a:t>The model team cannot train or test on cases it has not seen.</a:t>
             </a:r>
           </a:p>
         </p:txBody>
@@ -3060,7 +3060,7 @@
           <p:cNvPr id="16" name="">
             <a:extLst xmlns:a="http://schemas.openxmlformats.org/drawingml/2006/main">
               <a:ext uri="{FF2B5EF4-FFF2-40B4-BE49-F238E27FC236}">
-                <a16:creationId xmlns:a16="http://schemas.microsoft.com/office/drawing/2014/main" id="{087E61CA-1B89-44B7-BD3A-287F4DBA2E79}"/>
+                <a16:creationId xmlns:a16="http://schemas.microsoft.com/office/drawing/2014/main" id="{2FA4D1D5-B0A3-4086-ADD3-67FB2C22FEB5}"/>
               </a:ext>
             </a:extLst>
           </p:cNvPr>
@@ -3095,7 +3095,7 @@
           <p:cNvPr id="17" name="">
             <a:extLst xmlns:a="http://schemas.openxmlformats.org/drawingml/2006/main">
               <a:ext uri="{FF2B5EF4-FFF2-40B4-BE49-F238E27FC236}">
-                <a16:creationId xmlns:a16="http://schemas.microsoft.com/office/drawing/2014/main" id="{B0D14AFF-5A73-479B-A92F-941FBD47A067}"/>
+                <a16:creationId xmlns:a16="http://schemas.microsoft.com/office/drawing/2014/main" id="{A2A095E8-09A8-4BB7-AA3C-F2AAE9FA3F29}"/>
               </a:ext>
             </a:extLst>
           </p:cNvPr>
@@ -3130,7 +3130,7 @@
           <p:cNvPr id="18" name="">
             <a:extLst xmlns:a="http://schemas.openxmlformats.org/drawingml/2006/main">
               <a:ext uri="{FF2B5EF4-FFF2-40B4-BE49-F238E27FC236}">
-                <a16:creationId xmlns:a16="http://schemas.microsoft.com/office/drawing/2014/main" id="{AC1EC2AD-965F-41D2-B4F6-FDB1F8B12ED9}"/>
+                <a16:creationId xmlns:a16="http://schemas.microsoft.com/office/drawing/2014/main" id="{9F9E0F82-BABA-4E47-809B-4AF461320A79}"/>
               </a:ext>
             </a:extLst>
           </p:cNvPr>
@@ -3165,7 +3165,7 @@
           <p:cNvPr id="19" name="">
             <a:extLst xmlns:a="http://schemas.openxmlformats.org/drawingml/2006/main">
               <a:ext uri="{FF2B5EF4-FFF2-40B4-BE49-F238E27FC236}">
-                <a16:creationId xmlns:a16="http://schemas.microsoft.com/office/drawing/2014/main" id="{59E2D736-4FBF-4824-A6A6-F15180790B6F}"/>
+                <a16:creationId xmlns:a16="http://schemas.microsoft.com/office/drawing/2014/main" id="{0BF7089A-B0F4-47AB-B7EF-FE060604A20C}"/>
               </a:ext>
             </a:extLst>
           </p:cNvPr>
@@ -3229,7 +3229,7 @@
           <p:cNvPr id="20" name="">
             <a:extLst xmlns:a="http://schemas.openxmlformats.org/drawingml/2006/main">
               <a:ext uri="{FF2B5EF4-FFF2-40B4-BE49-F238E27FC236}">
-                <a16:creationId xmlns:a16="http://schemas.microsoft.com/office/drawing/2014/main" id="{495A4CD4-BC24-45FC-9849-F2ECD5DD24FC}"/>
+                <a16:creationId xmlns:a16="http://schemas.microsoft.com/office/drawing/2014/main" id="{4272A77A-DCD0-4CE5-9615-1869457BE1AB}"/>
               </a:ext>
             </a:extLst>
           </p:cNvPr>
@@ -3283,7 +3283,7 @@
                 <a:ea typeface="Aptos"/>
                 <a:cs typeface="Aptos"/>
               </a:rPr>
-              <a:t>Model blind spot</a:t>
+              <a:t>Blind spot</a:t>
             </a:r>
           </a:p>
         </p:txBody>
@@ -3293,7 +3293,7 @@
           <p:cNvPr id="21" name="">
             <a:extLst xmlns:a="http://schemas.openxmlformats.org/drawingml/2006/main">
               <a:ext uri="{FF2B5EF4-FFF2-40B4-BE49-F238E27FC236}">
-                <a16:creationId xmlns:a16="http://schemas.microsoft.com/office/drawing/2014/main" id="{3A741A71-111A-41FB-9E3A-643A88E7EB57}"/>
+                <a16:creationId xmlns:a16="http://schemas.microsoft.com/office/drawing/2014/main" id="{CB098091-0065-41D9-AE38-3707E9B0DC9B}"/>
               </a:ext>
             </a:extLst>
           </p:cNvPr>
@@ -3347,7 +3347,7 @@
                 <a:ea typeface="Aptos"/>
                 <a:cs typeface="Aptos"/>
               </a:rPr>
-              <a:t>Threshold rules miss behavior spread across a transaction chain.</a:t>
+              <a:t>Simple amount rules miss behavior distributed across a chain.</a:t>
             </a:r>
           </a:p>
         </p:txBody>
@@ -3357,7 +3357,7 @@
           <p:cNvPr id="22" name="">
             <a:extLst xmlns:a="http://schemas.openxmlformats.org/drawingml/2006/main">
               <a:ext uri="{FF2B5EF4-FFF2-40B4-BE49-F238E27FC236}">
-                <a16:creationId xmlns:a16="http://schemas.microsoft.com/office/drawing/2014/main" id="{7935C923-0FC8-4A38-B253-8C671FD55A9C}"/>
+                <a16:creationId xmlns:a16="http://schemas.microsoft.com/office/drawing/2014/main" id="{B9B20DC0-2520-4FF7-BFE8-C082F4A2A750}"/>
               </a:ext>
             </a:extLst>
           </p:cNvPr>
@@ -3390,7 +3390,7 @@
           <p:cNvPr id="23" name="">
             <a:extLst xmlns:a="http://schemas.openxmlformats.org/drawingml/2006/main">
               <a:ext uri="{FF2B5EF4-FFF2-40B4-BE49-F238E27FC236}">
-                <a16:creationId xmlns:a16="http://schemas.microsoft.com/office/drawing/2014/main" id="{2386F769-4B40-43E9-9CB0-601AF2A2DD1E}"/>
+                <a16:creationId xmlns:a16="http://schemas.microsoft.com/office/drawing/2014/main" id="{B3942341-7038-44F9-981F-3656B8D9CCA4}"/>
               </a:ext>
             </a:extLst>
           </p:cNvPr>
@@ -3454,7 +3454,7 @@
           <p:cNvPr id="24" name="">
             <a:extLst xmlns:a="http://schemas.openxmlformats.org/drawingml/2006/main">
               <a:ext uri="{FF2B5EF4-FFF2-40B4-BE49-F238E27FC236}">
-                <a16:creationId xmlns:a16="http://schemas.microsoft.com/office/drawing/2014/main" id="{E4570C2F-268C-41B2-B8A1-7DA3793190CE}"/>
+                <a16:creationId xmlns:a16="http://schemas.microsoft.com/office/drawing/2014/main" id="{304190EE-6DBE-405E-98F0-2B6881B9F8B1}"/>
               </a:ext>
             </a:extLst>
           </p:cNvPr>
@@ -3508,7 +3508,7 @@
                 <a:ea typeface="Aptos Display"/>
                 <a:cs typeface="Aptos Display"/>
               </a:rPr>
-              <a:t>days,</a:t>
+              <a:t>reviewed</a:t>
             </a:r>
           </a:p>
           <a:p xmlns:a="http://schemas.openxmlformats.org/drawingml/2006/main">
@@ -3531,7 +3531,7 @@
                 <a:ea typeface="Aptos Display"/>
                 <a:cs typeface="Aptos Display"/>
               </a:rPr>
-              <a:t>not months</a:t>
+              <a:t>same day</a:t>
             </a:r>
           </a:p>
         </p:txBody>
@@ -3541,7 +3541,7 @@
           <p:cNvPr id="25" name="">
             <a:extLst xmlns:a="http://schemas.openxmlformats.org/drawingml/2006/main">
               <a:ext uri="{FF2B5EF4-FFF2-40B4-BE49-F238E27FC236}">
-                <a16:creationId xmlns:a16="http://schemas.microsoft.com/office/drawing/2014/main" id="{529F6F10-6019-4871-A0A3-BBFAADA9ECA8}"/>
+                <a16:creationId xmlns:a16="http://schemas.microsoft.com/office/drawing/2014/main" id="{61EE42A3-E8B2-42DC-BB54-C577627691CD}"/>
               </a:ext>
             </a:extLst>
           </p:cNvPr>
@@ -3576,7 +3576,7 @@
           <p:cNvPr id="26" name="">
             <a:extLst xmlns:a="http://schemas.openxmlformats.org/drawingml/2006/main">
               <a:ext uri="{FF2B5EF4-FFF2-40B4-BE49-F238E27FC236}">
-                <a16:creationId xmlns:a16="http://schemas.microsoft.com/office/drawing/2014/main" id="{BF7714A8-8BE2-4130-A99D-3D675E33654B}"/>
+                <a16:creationId xmlns:a16="http://schemas.microsoft.com/office/drawing/2014/main" id="{019F47C6-5978-4EE9-A562-51915D4BDE25}"/>
               </a:ext>
             </a:extLst>
           </p:cNvPr>
@@ -3638,7 +3638,7 @@
     </p:spTree>
     <p:extLst>
       <p:ext uri="{BB962C8B-B14F-4D97-AF65-F5344CB8AC3E}">
-        <p14:creationId xmlns:p14="http://schemas.microsoft.com/office/powerpoint/2010/main" val="744843546"/>
+        <p14:creationId xmlns:p14="http://schemas.microsoft.com/office/powerpoint/2010/main" val="452683369"/>
       </p:ext>
     </p:extLst>
   </p:cSld>
@@ -3662,7 +3662,7 @@
           <p:cNvPr id="1" name="">
             <a:extLst xmlns:a="http://schemas.openxmlformats.org/drawingml/2006/main">
               <a:ext uri="{FF2B5EF4-FFF2-40B4-BE49-F238E27FC236}">
-                <a16:creationId xmlns:a16="http://schemas.microsoft.com/office/drawing/2014/main" id="{6787A30B-7110-4E72-8E65-E0DEB9CBB728}"/>
+                <a16:creationId xmlns:a16="http://schemas.microsoft.com/office/drawing/2014/main" id="{F181F354-4ED8-411D-A63E-13F7CFF7AC17}"/>
               </a:ext>
             </a:extLst>
           </p:cNvPr>
@@ -3697,7 +3697,7 @@
           <p:cNvPr id="2" name="kicker-marker">
             <a:extLst xmlns:a="http://schemas.openxmlformats.org/drawingml/2006/main">
               <a:ext uri="{FF2B5EF4-FFF2-40B4-BE49-F238E27FC236}">
-                <a16:creationId xmlns:a16="http://schemas.microsoft.com/office/drawing/2014/main" id="{A6C3EE51-1359-46CE-A5FD-CFDB80AA5244}"/>
+                <a16:creationId xmlns:a16="http://schemas.microsoft.com/office/drawing/2014/main" id="{B7138D3A-9BCC-4F4F-9AD1-58744BB2151B}"/>
               </a:ext>
             </a:extLst>
           </p:cNvPr>
@@ -3732,7 +3732,7 @@
           <p:cNvPr id="3" name="kicker-label">
             <a:extLst xmlns:a="http://schemas.openxmlformats.org/drawingml/2006/main">
               <a:ext uri="{FF2B5EF4-FFF2-40B4-BE49-F238E27FC236}">
-                <a16:creationId xmlns:a16="http://schemas.microsoft.com/office/drawing/2014/main" id="{9D08F4C7-470F-4FE8-9291-68DDFD12D2A7}"/>
+                <a16:creationId xmlns:a16="http://schemas.microsoft.com/office/drawing/2014/main" id="{6855E705-17EB-445B-902B-95A441BFF666}"/>
               </a:ext>
             </a:extLst>
           </p:cNvPr>
@@ -3786,7 +3786,7 @@
                 <a:ea typeface="Aptos"/>
                 <a:cs typeface="Aptos"/>
               </a:rPr>
-              <a:t>SOLUTION</a:t>
+              <a:t>APPLICATION WORKFLOW</a:t>
             </a:r>
           </a:p>
         </p:txBody>
@@ -3796,7 +3796,7 @@
           <p:cNvPr id="4" name="">
             <a:extLst xmlns:a="http://schemas.openxmlformats.org/drawingml/2006/main">
               <a:ext uri="{FF2B5EF4-FFF2-40B4-BE49-F238E27FC236}">
-                <a16:creationId xmlns:a16="http://schemas.microsoft.com/office/drawing/2014/main" id="{F77F98F8-4F26-4BAA-A749-3D9FD76C5036}"/>
+                <a16:creationId xmlns:a16="http://schemas.microsoft.com/office/drawing/2014/main" id="{CF7E0C9B-E2DD-44BC-BC4E-7335D9EDF0BC}"/>
               </a:ext>
             </a:extLst>
           </p:cNvPr>
@@ -3850,7 +3850,7 @@
                 <a:ea typeface="Aptos Display"/>
                 <a:cs typeface="Aptos Display"/>
               </a:rPr>
-              <a:t>SynthAML converts a warning into structured constraints, then into labeled synthetic chains.</a:t>
+              <a:t>SynthAML supports the full handoff from compliance prose to model QA artifacts.</a:t>
             </a:r>
           </a:p>
         </p:txBody>
@@ -3860,7 +3860,7 @@
           <p:cNvPr id="5" name="">
             <a:extLst xmlns:a="http://schemas.openxmlformats.org/drawingml/2006/main">
               <a:ext uri="{FF2B5EF4-FFF2-40B4-BE49-F238E27FC236}">
-                <a16:creationId xmlns:a16="http://schemas.microsoft.com/office/drawing/2014/main" id="{5F6DD5C4-FD2A-43B7-9C5E-9D521B01EC4F}"/>
+                <a16:creationId xmlns:a16="http://schemas.microsoft.com/office/drawing/2014/main" id="{30900884-D585-4CFF-B650-ADB5E9260BD6}"/>
               </a:ext>
             </a:extLst>
           </p:cNvPr>
@@ -3895,7 +3895,7 @@
           <p:cNvPr id="6" name="">
             <a:extLst xmlns:a="http://schemas.openxmlformats.org/drawingml/2006/main">
               <a:ext uri="{FF2B5EF4-FFF2-40B4-BE49-F238E27FC236}">
-                <a16:creationId xmlns:a16="http://schemas.microsoft.com/office/drawing/2014/main" id="{8982DF7E-BABB-4A40-BDDF-FD88AFC5D772}"/>
+                <a16:creationId xmlns:a16="http://schemas.microsoft.com/office/drawing/2014/main" id="{0105046F-D003-404D-9217-1FDD00538105}"/>
               </a:ext>
             </a:extLst>
           </p:cNvPr>
@@ -3959,7 +3959,7 @@
           <p:cNvPr id="7" name="">
             <a:extLst xmlns:a="http://schemas.openxmlformats.org/drawingml/2006/main">
               <a:ext uri="{FF2B5EF4-FFF2-40B4-BE49-F238E27FC236}">
-                <a16:creationId xmlns:a16="http://schemas.microsoft.com/office/drawing/2014/main" id="{83526692-DBE0-4468-967D-F4C48AF79D34}"/>
+                <a16:creationId xmlns:a16="http://schemas.microsoft.com/office/drawing/2014/main" id="{7668BE2D-8056-41E8-889C-3053FE0B08E4}"/>
               </a:ext>
             </a:extLst>
           </p:cNvPr>
@@ -3992,7 +3992,7 @@
           <p:cNvPr id="8" name="">
             <a:extLst xmlns:a="http://schemas.openxmlformats.org/drawingml/2006/main">
               <a:ext uri="{FF2B5EF4-FFF2-40B4-BE49-F238E27FC236}">
-                <a16:creationId xmlns:a16="http://schemas.microsoft.com/office/drawing/2014/main" id="{4A8F09A6-20E5-48BC-B201-FFB2D78D7407}"/>
+                <a16:creationId xmlns:a16="http://schemas.microsoft.com/office/drawing/2014/main" id="{C700AB5E-AE4C-40A4-BE6D-F5103BDE5918}"/>
               </a:ext>
             </a:extLst>
           </p:cNvPr>
@@ -4056,7 +4056,7 @@
           <p:cNvPr id="9" name="">
             <a:extLst xmlns:a="http://schemas.openxmlformats.org/drawingml/2006/main">
               <a:ext uri="{FF2B5EF4-FFF2-40B4-BE49-F238E27FC236}">
-                <a16:creationId xmlns:a16="http://schemas.microsoft.com/office/drawing/2014/main" id="{D9068EF6-1BE5-4E0A-B794-7D7233A93423}"/>
+                <a16:creationId xmlns:a16="http://schemas.microsoft.com/office/drawing/2014/main" id="{9AFA27B1-0211-4C93-980A-6C5095AED6D5}"/>
               </a:ext>
             </a:extLst>
           </p:cNvPr>
@@ -4110,7 +4110,7 @@
                 <a:ea typeface="Aptos"/>
                 <a:cs typeface="Aptos"/>
               </a:rPr>
-              <a:t>Paste warning</a:t>
+              <a:t>Ingest</a:t>
             </a:r>
           </a:p>
         </p:txBody>
@@ -4120,7 +4120,7 @@
           <p:cNvPr id="10" name="">
             <a:extLst xmlns:a="http://schemas.openxmlformats.org/drawingml/2006/main">
               <a:ext uri="{FF2B5EF4-FFF2-40B4-BE49-F238E27FC236}">
-                <a16:creationId xmlns:a16="http://schemas.microsoft.com/office/drawing/2014/main" id="{13AD5A5D-EF02-4686-AF1A-5384697B3CB1}"/>
+                <a16:creationId xmlns:a16="http://schemas.microsoft.com/office/drawing/2014/main" id="{908791C8-FFF9-4ADE-98AF-7B5C10249347}"/>
               </a:ext>
             </a:extLst>
           </p:cNvPr>
@@ -4174,7 +4174,7 @@
                 <a:ea typeface="Aptos"/>
                 <a:cs typeface="Aptos"/>
               </a:rPr>
-              <a:t>Regulatory prose or short case description</a:t>
+              <a:t>Import alert text from a feed, case queue, memo, or knowledge base</a:t>
             </a:r>
           </a:p>
         </p:txBody>
@@ -4184,7 +4184,7 @@
           <p:cNvPr id="11" name="">
             <a:extLst xmlns:a="http://schemas.openxmlformats.org/drawingml/2006/main">
               <a:ext uri="{FF2B5EF4-FFF2-40B4-BE49-F238E27FC236}">
-                <a16:creationId xmlns:a16="http://schemas.microsoft.com/office/drawing/2014/main" id="{8D172ED4-845A-4ED2-AA40-459348010749}"/>
+                <a16:creationId xmlns:a16="http://schemas.microsoft.com/office/drawing/2014/main" id="{FDD50E75-0C79-4B42-8EB6-883106C22FF3}"/>
               </a:ext>
             </a:extLst>
           </p:cNvPr>
@@ -4219,7 +4219,7 @@
           <p:cNvPr id="12" name="">
             <a:extLst xmlns:a="http://schemas.openxmlformats.org/drawingml/2006/main">
               <a:ext uri="{FF2B5EF4-FFF2-40B4-BE49-F238E27FC236}">
-                <a16:creationId xmlns:a16="http://schemas.microsoft.com/office/drawing/2014/main" id="{FA694019-B844-4F2D-A656-6316A5971848}"/>
+                <a16:creationId xmlns:a16="http://schemas.microsoft.com/office/drawing/2014/main" id="{56EE2556-BCFB-42B9-96AE-AEDA8E987D8E}"/>
               </a:ext>
             </a:extLst>
           </p:cNvPr>
@@ -4254,7 +4254,7 @@
           <p:cNvPr id="13" name="">
             <a:extLst xmlns:a="http://schemas.openxmlformats.org/drawingml/2006/main">
               <a:ext uri="{FF2B5EF4-FFF2-40B4-BE49-F238E27FC236}">
-                <a16:creationId xmlns:a16="http://schemas.microsoft.com/office/drawing/2014/main" id="{C11C2A09-C718-4081-9B8F-A413CEE32212}"/>
+                <a16:creationId xmlns:a16="http://schemas.microsoft.com/office/drawing/2014/main" id="{E4BD0452-3BFF-4712-A058-10DB449DBB08}"/>
               </a:ext>
             </a:extLst>
           </p:cNvPr>
@@ -4287,7 +4287,7 @@
           <p:cNvPr id="14" name="">
             <a:extLst xmlns:a="http://schemas.openxmlformats.org/drawingml/2006/main">
               <a:ext uri="{FF2B5EF4-FFF2-40B4-BE49-F238E27FC236}">
-                <a16:creationId xmlns:a16="http://schemas.microsoft.com/office/drawing/2014/main" id="{CFDB6361-03F7-48F2-8607-AD2CD8ED3AA0}"/>
+                <a16:creationId xmlns:a16="http://schemas.microsoft.com/office/drawing/2014/main" id="{354A4F9B-821D-40A2-861E-EC55A6AACAB5}"/>
               </a:ext>
             </a:extLst>
           </p:cNvPr>
@@ -4351,7 +4351,7 @@
           <p:cNvPr id="15" name="">
             <a:extLst xmlns:a="http://schemas.openxmlformats.org/drawingml/2006/main">
               <a:ext uri="{FF2B5EF4-FFF2-40B4-BE49-F238E27FC236}">
-                <a16:creationId xmlns:a16="http://schemas.microsoft.com/office/drawing/2014/main" id="{455C8299-C279-4A38-9CF8-2FD07F445EC4}"/>
+                <a16:creationId xmlns:a16="http://schemas.microsoft.com/office/drawing/2014/main" id="{69B1511B-AB7F-483C-98A6-BE3DF6004AEC}"/>
               </a:ext>
             </a:extLst>
           </p:cNvPr>
@@ -4405,7 +4405,7 @@
                 <a:ea typeface="Aptos"/>
                 <a:cs typeface="Aptos"/>
               </a:rPr>
-              <a:t>Extract typology</a:t>
+              <a:t>Review</a:t>
             </a:r>
           </a:p>
         </p:txBody>
@@ -4415,7 +4415,7 @@
           <p:cNvPr id="16" name="">
             <a:extLst xmlns:a="http://schemas.openxmlformats.org/drawingml/2006/main">
               <a:ext uri="{FF2B5EF4-FFF2-40B4-BE49-F238E27FC236}">
-                <a16:creationId xmlns:a16="http://schemas.microsoft.com/office/drawing/2014/main" id="{E4C8755B-AD43-4389-BD0E-BC2E9121F34C}"/>
+                <a16:creationId xmlns:a16="http://schemas.microsoft.com/office/drawing/2014/main" id="{B448A222-B977-4B7F-A0A1-6CE9B5F397B2}"/>
               </a:ext>
             </a:extLst>
           </p:cNvPr>
@@ -4469,7 +4469,7 @@
                 <a:ea typeface="Aptos"/>
                 <a:cs typeface="Aptos"/>
               </a:rPr>
-              <a:t>Industry, regions, amount range, timing, narratives</a:t>
+              <a:t>Approve extracted regions, timing, narratives, and methods</a:t>
             </a:r>
           </a:p>
         </p:txBody>
@@ -4479,7 +4479,7 @@
           <p:cNvPr id="17" name="">
             <a:extLst xmlns:a="http://schemas.openxmlformats.org/drawingml/2006/main">
               <a:ext uri="{FF2B5EF4-FFF2-40B4-BE49-F238E27FC236}">
-                <a16:creationId xmlns:a16="http://schemas.microsoft.com/office/drawing/2014/main" id="{5FE0C2CC-080E-4A8B-A8E9-8264A4CC045D}"/>
+                <a16:creationId xmlns:a16="http://schemas.microsoft.com/office/drawing/2014/main" id="{DF3FE2F2-F91B-4E52-BB91-10CF9CDCB95E}"/>
               </a:ext>
             </a:extLst>
           </p:cNvPr>
@@ -4514,7 +4514,7 @@
           <p:cNvPr id="18" name="">
             <a:extLst xmlns:a="http://schemas.openxmlformats.org/drawingml/2006/main">
               <a:ext uri="{FF2B5EF4-FFF2-40B4-BE49-F238E27FC236}">
-                <a16:creationId xmlns:a16="http://schemas.microsoft.com/office/drawing/2014/main" id="{B2DE596A-2E6D-462B-8236-4EA4B01E12EF}"/>
+                <a16:creationId xmlns:a16="http://schemas.microsoft.com/office/drawing/2014/main" id="{7A639F42-EB4F-41E2-B182-16955B3CE4D2}"/>
               </a:ext>
             </a:extLst>
           </p:cNvPr>
@@ -4549,7 +4549,7 @@
           <p:cNvPr id="19" name="">
             <a:extLst xmlns:a="http://schemas.openxmlformats.org/drawingml/2006/main">
               <a:ext uri="{FF2B5EF4-FFF2-40B4-BE49-F238E27FC236}">
-                <a16:creationId xmlns:a16="http://schemas.microsoft.com/office/drawing/2014/main" id="{4BBC857C-9006-4714-AB85-1350F89C7FC8}"/>
+                <a16:creationId xmlns:a16="http://schemas.microsoft.com/office/drawing/2014/main" id="{A263C8C5-555C-41B1-AFFD-4A5E6B6D25E0}"/>
               </a:ext>
             </a:extLst>
           </p:cNvPr>
@@ -4582,7 +4582,7 @@
           <p:cNvPr id="20" name="">
             <a:extLst xmlns:a="http://schemas.openxmlformats.org/drawingml/2006/main">
               <a:ext uri="{FF2B5EF4-FFF2-40B4-BE49-F238E27FC236}">
-                <a16:creationId xmlns:a16="http://schemas.microsoft.com/office/drawing/2014/main" id="{D4A6A206-C6EB-44DD-A3B1-309A46D1E8B2}"/>
+                <a16:creationId xmlns:a16="http://schemas.microsoft.com/office/drawing/2014/main" id="{394A1ED9-5D05-456C-9FA5-764EA333C761}"/>
               </a:ext>
             </a:extLst>
           </p:cNvPr>
@@ -4646,7 +4646,7 @@
           <p:cNvPr id="21" name="">
             <a:extLst xmlns:a="http://schemas.openxmlformats.org/drawingml/2006/main">
               <a:ext uri="{FF2B5EF4-FFF2-40B4-BE49-F238E27FC236}">
-                <a16:creationId xmlns:a16="http://schemas.microsoft.com/office/drawing/2014/main" id="{A1242647-118D-48AB-93CC-4121ACF2FF24}"/>
+                <a16:creationId xmlns:a16="http://schemas.microsoft.com/office/drawing/2014/main" id="{8327D020-E942-4EF0-A41C-38AD6ECCF629}"/>
               </a:ext>
             </a:extLst>
           </p:cNvPr>
@@ -4700,7 +4700,7 @@
                 <a:ea typeface="Aptos"/>
                 <a:cs typeface="Aptos"/>
               </a:rPr>
-              <a:t>Generate chains</a:t>
+              <a:t>Generate</a:t>
             </a:r>
           </a:p>
         </p:txBody>
@@ -4710,7 +4710,7 @@
           <p:cNvPr id="22" name="">
             <a:extLst xmlns:a="http://schemas.openxmlformats.org/drawingml/2006/main">
               <a:ext uri="{FF2B5EF4-FFF2-40B4-BE49-F238E27FC236}">
-                <a16:creationId xmlns:a16="http://schemas.microsoft.com/office/drawing/2014/main" id="{B0A89CC8-6B72-4BB8-A616-AF4AF6A57503}"/>
+                <a16:creationId xmlns:a16="http://schemas.microsoft.com/office/drawing/2014/main" id="{ED9EC9C9-4D25-4A35-90D0-566BCD471E5B}"/>
               </a:ext>
             </a:extLst>
           </p:cNvPr>
@@ -4764,7 +4764,7 @@
                 <a:ea typeface="Aptos"/>
                 <a:cs typeface="Aptos"/>
               </a:rPr>
-              <a:t>Funding transfer plus rapid split payments with noise</a:t>
+              <a:t>Create normal traffic plus suspicious multi-step chains</a:t>
             </a:r>
           </a:p>
         </p:txBody>
@@ -4774,7 +4774,7 @@
           <p:cNvPr id="23" name="">
             <a:extLst xmlns:a="http://schemas.openxmlformats.org/drawingml/2006/main">
               <a:ext uri="{FF2B5EF4-FFF2-40B4-BE49-F238E27FC236}">
-                <a16:creationId xmlns:a16="http://schemas.microsoft.com/office/drawing/2014/main" id="{44BCF1F3-ECEE-42F8-90D3-7A5F67F2E2FF}"/>
+                <a16:creationId xmlns:a16="http://schemas.microsoft.com/office/drawing/2014/main" id="{01A5F604-E3DC-453E-8D48-D60B190EED5E}"/>
               </a:ext>
             </a:extLst>
           </p:cNvPr>
@@ -4809,7 +4809,7 @@
           <p:cNvPr id="24" name="">
             <a:extLst xmlns:a="http://schemas.openxmlformats.org/drawingml/2006/main">
               <a:ext uri="{FF2B5EF4-FFF2-40B4-BE49-F238E27FC236}">
-                <a16:creationId xmlns:a16="http://schemas.microsoft.com/office/drawing/2014/main" id="{64297642-C041-4C62-B015-1E7312EBB830}"/>
+                <a16:creationId xmlns:a16="http://schemas.microsoft.com/office/drawing/2014/main" id="{366E6F1D-AAA6-45EB-A653-FE402BA936FB}"/>
               </a:ext>
             </a:extLst>
           </p:cNvPr>
@@ -4844,7 +4844,7 @@
           <p:cNvPr id="25" name="">
             <a:extLst xmlns:a="http://schemas.openxmlformats.org/drawingml/2006/main">
               <a:ext uri="{FF2B5EF4-FFF2-40B4-BE49-F238E27FC236}">
-                <a16:creationId xmlns:a16="http://schemas.microsoft.com/office/drawing/2014/main" id="{D25F16F8-F8EB-49F9-ADD5-1BE0BE5A4474}"/>
+                <a16:creationId xmlns:a16="http://schemas.microsoft.com/office/drawing/2014/main" id="{8188FAE9-D7A0-404E-8D4C-D1151ABD28C8}"/>
               </a:ext>
             </a:extLst>
           </p:cNvPr>
@@ -4877,7 +4877,7 @@
           <p:cNvPr id="26" name="">
             <a:extLst xmlns:a="http://schemas.openxmlformats.org/drawingml/2006/main">
               <a:ext uri="{FF2B5EF4-FFF2-40B4-BE49-F238E27FC236}">
-                <a16:creationId xmlns:a16="http://schemas.microsoft.com/office/drawing/2014/main" id="{DE08A834-DC01-4EAE-B526-60F757A63E50}"/>
+                <a16:creationId xmlns:a16="http://schemas.microsoft.com/office/drawing/2014/main" id="{F8C9B0D2-2538-45A2-87E0-31DA6B6DDD89}"/>
               </a:ext>
             </a:extLst>
           </p:cNvPr>
@@ -4941,7 +4941,7 @@
           <p:cNvPr id="27" name="">
             <a:extLst xmlns:a="http://schemas.openxmlformats.org/drawingml/2006/main">
               <a:ext uri="{FF2B5EF4-FFF2-40B4-BE49-F238E27FC236}">
-                <a16:creationId xmlns:a16="http://schemas.microsoft.com/office/drawing/2014/main" id="{2E0033C7-D703-4E50-BCD0-6D3285812A7A}"/>
+                <a16:creationId xmlns:a16="http://schemas.microsoft.com/office/drawing/2014/main" id="{C3317E09-D4F5-4D3E-A86D-E6B86C158CBF}"/>
               </a:ext>
             </a:extLst>
           </p:cNvPr>
@@ -4995,7 +4995,7 @@
                 <a:ea typeface="Aptos"/>
                 <a:cs typeface="Aptos"/>
               </a:rPr>
-              <a:t>Export results</a:t>
+              <a:t>Evaluate</a:t>
             </a:r>
           </a:p>
         </p:txBody>
@@ -5005,7 +5005,7 @@
           <p:cNvPr id="28" name="">
             <a:extLst xmlns:a="http://schemas.openxmlformats.org/drawingml/2006/main">
               <a:ext uri="{FF2B5EF4-FFF2-40B4-BE49-F238E27FC236}">
-                <a16:creationId xmlns:a16="http://schemas.microsoft.com/office/drawing/2014/main" id="{F9423DB8-8B39-4BF5-AD68-7D8B024D3AFD}"/>
+                <a16:creationId xmlns:a16="http://schemas.microsoft.com/office/drawing/2014/main" id="{D5EA6621-21A4-4A57-9171-96E437B86F90}"/>
               </a:ext>
             </a:extLst>
           </p:cNvPr>
@@ -5059,7 +5059,7 @@
                 <a:ea typeface="Aptos"/>
                 <a:cs typeface="Aptos"/>
               </a:rPr>
-              <a:t>Conservation checks, baseline comparison, CSV</a:t>
+              <a:t>Compare guided data against a simpler baseline</a:t>
             </a:r>
           </a:p>
         </p:txBody>
@@ -5069,7 +5069,7 @@
           <p:cNvPr id="29" name="">
             <a:extLst xmlns:a="http://schemas.openxmlformats.org/drawingml/2006/main">
               <a:ext uri="{FF2B5EF4-FFF2-40B4-BE49-F238E27FC236}">
-                <a16:creationId xmlns:a16="http://schemas.microsoft.com/office/drawing/2014/main" id="{C560F69F-87E4-4A17-96E9-3D6187DFD6BC}"/>
+                <a16:creationId xmlns:a16="http://schemas.microsoft.com/office/drawing/2014/main" id="{426A6BBB-3FA2-4659-9036-B1A96AB825E7}"/>
               </a:ext>
             </a:extLst>
           </p:cNvPr>
@@ -5123,7 +5123,7 @@
                 <a:ea typeface="Aptos"/>
                 <a:cs typeface="Aptos"/>
               </a:rPr>
-              <a:t>Design choice: the GenAI step is the translation from unstructured compliance prose into structured generation constraints. A deterministic fallback keeps grading reproducible without an API key.</a:t>
+              <a:t>Design choice: GenAI is used only where it helps most: translating unstructured compliance language into structured, reviewable generation constraints. The reviewer stays in control before export.</a:t>
             </a:r>
           </a:p>
         </p:txBody>
@@ -5131,7 +5131,7 @@
     </p:spTree>
     <p:extLst>
       <p:ext uri="{BB962C8B-B14F-4D97-AF65-F5344CB8AC3E}">
-        <p14:creationId xmlns:p14="http://schemas.microsoft.com/office/powerpoint/2010/main" val="2067541337"/>
+        <p14:creationId xmlns:p14="http://schemas.microsoft.com/office/powerpoint/2010/main" val="934295792"/>
       </p:ext>
     </p:extLst>
   </p:cSld>
@@ -5155,7 +5155,7 @@
           <p:cNvPr id="1" name="">
             <a:extLst xmlns:a="http://schemas.openxmlformats.org/drawingml/2006/main">
               <a:ext uri="{FF2B5EF4-FFF2-40B4-BE49-F238E27FC236}">
-                <a16:creationId xmlns:a16="http://schemas.microsoft.com/office/drawing/2014/main" id="{2CF56CB9-2285-45CF-A02A-26E6AD563147}"/>
+                <a16:creationId xmlns:a16="http://schemas.microsoft.com/office/drawing/2014/main" id="{B2BE1245-BACD-4A8D-973E-192D6B7E30EE}"/>
               </a:ext>
             </a:extLst>
           </p:cNvPr>
@@ -5190,7 +5190,7 @@
           <p:cNvPr id="2" name="kicker-marker">
             <a:extLst xmlns:a="http://schemas.openxmlformats.org/drawingml/2006/main">
               <a:ext uri="{FF2B5EF4-FFF2-40B4-BE49-F238E27FC236}">
-                <a16:creationId xmlns:a16="http://schemas.microsoft.com/office/drawing/2014/main" id="{8FCB9C84-4B86-4C6D-811F-77E16F2DFCD4}"/>
+                <a16:creationId xmlns:a16="http://schemas.microsoft.com/office/drawing/2014/main" id="{6E13CC13-8F09-4BD4-9EC2-3A1ADB3D254F}"/>
               </a:ext>
             </a:extLst>
           </p:cNvPr>
@@ -5225,7 +5225,7 @@
           <p:cNvPr id="3" name="kicker-label">
             <a:extLst xmlns:a="http://schemas.openxmlformats.org/drawingml/2006/main">
               <a:ext uri="{FF2B5EF4-FFF2-40B4-BE49-F238E27FC236}">
-                <a16:creationId xmlns:a16="http://schemas.microsoft.com/office/drawing/2014/main" id="{B4FC2954-CB1A-45C4-A8C7-E99143FC7BFD}"/>
+                <a16:creationId xmlns:a16="http://schemas.microsoft.com/office/drawing/2014/main" id="{41A433B7-592C-4C73-BF26-0CC3558565C1}"/>
               </a:ext>
             </a:extLst>
           </p:cNvPr>
@@ -5289,7 +5289,7 @@
           <p:cNvPr id="4" name="">
             <a:extLst xmlns:a="http://schemas.openxmlformats.org/drawingml/2006/main">
               <a:ext uri="{FF2B5EF4-FFF2-40B4-BE49-F238E27FC236}">
-                <a16:creationId xmlns:a16="http://schemas.microsoft.com/office/drawing/2014/main" id="{63D94A82-3C2C-4098-A01D-83C8126E0B62}"/>
+                <a16:creationId xmlns:a16="http://schemas.microsoft.com/office/drawing/2014/main" id="{01740EB0-70D8-447D-98E3-FE1D44C4466D}"/>
               </a:ext>
             </a:extLst>
           </p:cNvPr>
@@ -5343,7 +5343,7 @@
                 <a:ea typeface="Aptos Display"/>
                 <a:cs typeface="Aptos Display"/>
               </a:rPr>
-              <a:t>Guided chain-style training data beat the threshold baseline on hidden typology recall.</a:t>
+              <a:t>The baseline comparison asks whether GenAI adds value beyond a cheap rule workflow.</a:t>
             </a:r>
           </a:p>
         </p:txBody>
@@ -5353,7 +5353,7 @@
           <p:cNvPr id="5" name="">
             <a:extLst xmlns:a="http://schemas.openxmlformats.org/drawingml/2006/main">
               <a:ext uri="{FF2B5EF4-FFF2-40B4-BE49-F238E27FC236}">
-                <a16:creationId xmlns:a16="http://schemas.microsoft.com/office/drawing/2014/main" id="{C41163D8-667F-40E0-A613-F99E4610A3AD}"/>
+                <a16:creationId xmlns:a16="http://schemas.microsoft.com/office/drawing/2014/main" id="{21EB796B-8EBD-4045-A11C-1F94933266F7}"/>
               </a:ext>
             </a:extLst>
           </p:cNvPr>
@@ -5388,7 +5388,7 @@
           <p:cNvPr id="6" name="">
             <a:extLst xmlns:a="http://schemas.openxmlformats.org/drawingml/2006/main">
               <a:ext uri="{FF2B5EF4-FFF2-40B4-BE49-F238E27FC236}">
-                <a16:creationId xmlns:a16="http://schemas.microsoft.com/office/drawing/2014/main" id="{505D67DC-7709-4FB4-9945-B18A9FA0836A}"/>
+                <a16:creationId xmlns:a16="http://schemas.microsoft.com/office/drawing/2014/main" id="{72D73175-3C16-4290-8727-C15A2CCAA258}"/>
               </a:ext>
             </a:extLst>
           </p:cNvPr>
@@ -5452,7 +5452,7 @@
           <p:cNvPr id="7" name="">
             <a:extLst xmlns:a="http://schemas.openxmlformats.org/drawingml/2006/main">
               <a:ext uri="{FF2B5EF4-FFF2-40B4-BE49-F238E27FC236}">
-                <a16:creationId xmlns:a16="http://schemas.microsoft.com/office/drawing/2014/main" id="{ED6913AF-9E01-4A36-9FCC-9119818D0708}"/>
+                <a16:creationId xmlns:a16="http://schemas.microsoft.com/office/drawing/2014/main" id="{DA0E727C-726C-4A46-926D-C805E8121B7F}"/>
               </a:ext>
             </a:extLst>
           </p:cNvPr>
@@ -5516,7 +5516,7 @@
           <p:cNvPr id="8" name="">
             <a:extLst xmlns:a="http://schemas.openxmlformats.org/drawingml/2006/main">
               <a:ext uri="{FF2B5EF4-FFF2-40B4-BE49-F238E27FC236}">
-                <a16:creationId xmlns:a16="http://schemas.microsoft.com/office/drawing/2014/main" id="{F23BA2A6-2EFD-4E37-972F-0E6C0F5B5356}"/>
+                <a16:creationId xmlns:a16="http://schemas.microsoft.com/office/drawing/2014/main" id="{6F139AAB-3250-4FD2-A31B-D8C161A821A9}"/>
               </a:ext>
             </a:extLst>
           </p:cNvPr>
@@ -5580,7 +5580,7 @@
           <p:cNvPr id="9" name="">
             <a:extLst xmlns:a="http://schemas.openxmlformats.org/drawingml/2006/main">
               <a:ext uri="{FF2B5EF4-FFF2-40B4-BE49-F238E27FC236}">
-                <a16:creationId xmlns:a16="http://schemas.microsoft.com/office/drawing/2014/main" id="{40C9B550-F5CE-43AF-811B-9F9C5E2213C5}"/>
+                <a16:creationId xmlns:a16="http://schemas.microsoft.com/office/drawing/2014/main" id="{79FE3C4D-B660-46DC-BBA7-7F605A7B465D}"/>
               </a:ext>
             </a:extLst>
           </p:cNvPr>
@@ -5615,7 +5615,7 @@
           <p:cNvPr id="10" name="">
             <a:extLst xmlns:a="http://schemas.openxmlformats.org/drawingml/2006/main">
               <a:ext uri="{FF2B5EF4-FFF2-40B4-BE49-F238E27FC236}">
-                <a16:creationId xmlns:a16="http://schemas.microsoft.com/office/drawing/2014/main" id="{05BE9298-34D2-4657-AFC0-461159F53102}"/>
+                <a16:creationId xmlns:a16="http://schemas.microsoft.com/office/drawing/2014/main" id="{4A9599FB-27F3-4923-B61C-B58BDA64EDF3}"/>
               </a:ext>
             </a:extLst>
           </p:cNvPr>
@@ -5650,7 +5650,7 @@
           <p:cNvPr id="11" name="">
             <a:extLst xmlns:a="http://schemas.openxmlformats.org/drawingml/2006/main">
               <a:ext uri="{FF2B5EF4-FFF2-40B4-BE49-F238E27FC236}">
-                <a16:creationId xmlns:a16="http://schemas.microsoft.com/office/drawing/2014/main" id="{37BD4C6F-6385-4E12-94A0-417547371F21}"/>
+                <a16:creationId xmlns:a16="http://schemas.microsoft.com/office/drawing/2014/main" id="{50655B1E-5492-4E9E-8E93-669105E8D91B}"/>
               </a:ext>
             </a:extLst>
           </p:cNvPr>
@@ -5714,7 +5714,7 @@
           <p:cNvPr id="12" name="">
             <a:extLst xmlns:a="http://schemas.openxmlformats.org/drawingml/2006/main">
               <a:ext uri="{FF2B5EF4-FFF2-40B4-BE49-F238E27FC236}">
-                <a16:creationId xmlns:a16="http://schemas.microsoft.com/office/drawing/2014/main" id="{224B1F7E-E7DD-4A63-9604-08383D7235C6}"/>
+                <a16:creationId xmlns:a16="http://schemas.microsoft.com/office/drawing/2014/main" id="{60FCBFBC-ABE3-4FD9-9568-D62A24438F9D}"/>
               </a:ext>
             </a:extLst>
           </p:cNvPr>
@@ -5778,7 +5778,7 @@
           <p:cNvPr id="13" name="">
             <a:extLst xmlns:a="http://schemas.openxmlformats.org/drawingml/2006/main">
               <a:ext uri="{FF2B5EF4-FFF2-40B4-BE49-F238E27FC236}">
-                <a16:creationId xmlns:a16="http://schemas.microsoft.com/office/drawing/2014/main" id="{A9706B98-9551-440A-8741-89685D2BE073}"/>
+                <a16:creationId xmlns:a16="http://schemas.microsoft.com/office/drawing/2014/main" id="{4B8A091E-C27D-4958-96FA-B781A913152C}"/>
               </a:ext>
             </a:extLst>
           </p:cNvPr>
@@ -5813,7 +5813,7 @@
           <p:cNvPr id="14" name="">
             <a:extLst xmlns:a="http://schemas.openxmlformats.org/drawingml/2006/main">
               <a:ext uri="{FF2B5EF4-FFF2-40B4-BE49-F238E27FC236}">
-                <a16:creationId xmlns:a16="http://schemas.microsoft.com/office/drawing/2014/main" id="{60A081BD-50C7-404A-A2F8-8FEA7874607D}"/>
+                <a16:creationId xmlns:a16="http://schemas.microsoft.com/office/drawing/2014/main" id="{628CF341-0C78-4C3E-874B-D06196C530A4}"/>
               </a:ext>
             </a:extLst>
           </p:cNvPr>
@@ -5848,7 +5848,7 @@
           <p:cNvPr id="15" name="">
             <a:extLst xmlns:a="http://schemas.openxmlformats.org/drawingml/2006/main">
               <a:ext uri="{FF2B5EF4-FFF2-40B4-BE49-F238E27FC236}">
-                <a16:creationId xmlns:a16="http://schemas.microsoft.com/office/drawing/2014/main" id="{66F5E445-022B-4556-BEF1-2B487FDCF438}"/>
+                <a16:creationId xmlns:a16="http://schemas.microsoft.com/office/drawing/2014/main" id="{596D4C13-05C7-4E25-BC0B-4B15623908CB}"/>
               </a:ext>
             </a:extLst>
           </p:cNvPr>
@@ -5912,7 +5912,7 @@
           <p:cNvPr id="16" name="">
             <a:extLst xmlns:a="http://schemas.openxmlformats.org/drawingml/2006/main">
               <a:ext uri="{FF2B5EF4-FFF2-40B4-BE49-F238E27FC236}">
-                <a16:creationId xmlns:a16="http://schemas.microsoft.com/office/drawing/2014/main" id="{688EDBE5-47C8-474E-8B00-AE97D9A8EBB8}"/>
+                <a16:creationId xmlns:a16="http://schemas.microsoft.com/office/drawing/2014/main" id="{BA08E6BD-827B-4F97-AA3F-2CC1B71B7C41}"/>
               </a:ext>
             </a:extLst>
           </p:cNvPr>
@@ -5947,7 +5947,7 @@
           <p:cNvPr id="17" name="">
             <a:extLst xmlns:a="http://schemas.openxmlformats.org/drawingml/2006/main">
               <a:ext uri="{FF2B5EF4-FFF2-40B4-BE49-F238E27FC236}">
-                <a16:creationId xmlns:a16="http://schemas.microsoft.com/office/drawing/2014/main" id="{88270756-45E0-485C-9CC9-70F8CB505E7D}"/>
+                <a16:creationId xmlns:a16="http://schemas.microsoft.com/office/drawing/2014/main" id="{8446D8DF-4B27-481E-8D37-850A6564ED6C}"/>
               </a:ext>
             </a:extLst>
           </p:cNvPr>
@@ -6011,7 +6011,7 @@
           <p:cNvPr id="18" name="">
             <a:extLst xmlns:a="http://schemas.openxmlformats.org/drawingml/2006/main">
               <a:ext uri="{FF2B5EF4-FFF2-40B4-BE49-F238E27FC236}">
-                <a16:creationId xmlns:a16="http://schemas.microsoft.com/office/drawing/2014/main" id="{1253FFED-AA61-47FE-AB15-A528A4951512}"/>
+                <a16:creationId xmlns:a16="http://schemas.microsoft.com/office/drawing/2014/main" id="{A9D87533-D78B-4255-AC70-1C50E9F60FCD}"/>
               </a:ext>
             </a:extLst>
           </p:cNvPr>
@@ -6046,7 +6046,7 @@
           <p:cNvPr id="19" name="">
             <a:extLst xmlns:a="http://schemas.openxmlformats.org/drawingml/2006/main">
               <a:ext uri="{FF2B5EF4-FFF2-40B4-BE49-F238E27FC236}">
-                <a16:creationId xmlns:a16="http://schemas.microsoft.com/office/drawing/2014/main" id="{9F27384B-4D52-475F-B258-FAC61D5D3C64}"/>
+                <a16:creationId xmlns:a16="http://schemas.microsoft.com/office/drawing/2014/main" id="{ADB03A06-2316-4DAC-B6D3-A89D6931E05C}"/>
               </a:ext>
             </a:extLst>
           </p:cNvPr>
@@ -6110,7 +6110,7 @@
           <p:cNvPr id="20" name="">
             <a:extLst xmlns:a="http://schemas.openxmlformats.org/drawingml/2006/main">
               <a:ext uri="{FF2B5EF4-FFF2-40B4-BE49-F238E27FC236}">
-                <a16:creationId xmlns:a16="http://schemas.microsoft.com/office/drawing/2014/main" id="{57DA5D5F-9ECA-4872-8D90-353CDE54FB9A}"/>
+                <a16:creationId xmlns:a16="http://schemas.microsoft.com/office/drawing/2014/main" id="{4A5D0077-6124-4508-8934-565AE6418CF6}"/>
               </a:ext>
             </a:extLst>
           </p:cNvPr>
@@ -6145,7 +6145,7 @@
           <p:cNvPr id="21" name="">
             <a:extLst xmlns:a="http://schemas.openxmlformats.org/drawingml/2006/main">
               <a:ext uri="{FF2B5EF4-FFF2-40B4-BE49-F238E27FC236}">
-                <a16:creationId xmlns:a16="http://schemas.microsoft.com/office/drawing/2014/main" id="{1F6B10A7-CF4C-493E-A886-9DFA6A8DB0C4}"/>
+                <a16:creationId xmlns:a16="http://schemas.microsoft.com/office/drawing/2014/main" id="{646B758D-8E7D-4391-ADBA-114DB3CEAF5D}"/>
               </a:ext>
             </a:extLst>
           </p:cNvPr>
@@ -6209,7 +6209,7 @@
           <p:cNvPr id="22" name="">
             <a:extLst xmlns:a="http://schemas.openxmlformats.org/drawingml/2006/main">
               <a:ext uri="{FF2B5EF4-FFF2-40B4-BE49-F238E27FC236}">
-                <a16:creationId xmlns:a16="http://schemas.microsoft.com/office/drawing/2014/main" id="{07CDBA71-8721-46E8-AC63-9EF3A51EE48C}"/>
+                <a16:creationId xmlns:a16="http://schemas.microsoft.com/office/drawing/2014/main" id="{9608245C-093B-43F5-BD69-7260E20BEC29}"/>
               </a:ext>
             </a:extLst>
           </p:cNvPr>
@@ -6244,7 +6244,7 @@
           <p:cNvPr id="23" name="">
             <a:extLst xmlns:a="http://schemas.openxmlformats.org/drawingml/2006/main">
               <a:ext uri="{FF2B5EF4-FFF2-40B4-BE49-F238E27FC236}">
-                <a16:creationId xmlns:a16="http://schemas.microsoft.com/office/drawing/2014/main" id="{CB94D556-D0AE-4ACC-9802-FFB528F643DB}"/>
+                <a16:creationId xmlns:a16="http://schemas.microsoft.com/office/drawing/2014/main" id="{E63AB773-9955-4EDD-AC8D-700F83A248EE}"/>
               </a:ext>
             </a:extLst>
           </p:cNvPr>
@@ -6308,7 +6308,7 @@
           <p:cNvPr id="24" name="">
             <a:extLst xmlns:a="http://schemas.openxmlformats.org/drawingml/2006/main">
               <a:ext uri="{FF2B5EF4-FFF2-40B4-BE49-F238E27FC236}">
-                <a16:creationId xmlns:a16="http://schemas.microsoft.com/office/drawing/2014/main" id="{5CE23D59-9A02-46D8-9353-06E06036126A}"/>
+                <a16:creationId xmlns:a16="http://schemas.microsoft.com/office/drawing/2014/main" id="{1548BA40-EDD9-4619-A399-869F7F05AAC1}"/>
               </a:ext>
             </a:extLst>
           </p:cNvPr>
@@ -6343,7 +6343,7 @@
           <p:cNvPr id="25" name="">
             <a:extLst xmlns:a="http://schemas.openxmlformats.org/drawingml/2006/main">
               <a:ext uri="{FF2B5EF4-FFF2-40B4-BE49-F238E27FC236}">
-                <a16:creationId xmlns:a16="http://schemas.microsoft.com/office/drawing/2014/main" id="{F5A39B43-872C-4302-8C6C-0FB8B7147ACB}"/>
+                <a16:creationId xmlns:a16="http://schemas.microsoft.com/office/drawing/2014/main" id="{C5439CE2-01F1-4E70-ABEF-8EFE733590CC}"/>
               </a:ext>
             </a:extLst>
           </p:cNvPr>
@@ -6407,7 +6407,7 @@
           <p:cNvPr id="26" name="">
             <a:extLst xmlns:a="http://schemas.openxmlformats.org/drawingml/2006/main">
               <a:ext uri="{FF2B5EF4-FFF2-40B4-BE49-F238E27FC236}">
-                <a16:creationId xmlns:a16="http://schemas.microsoft.com/office/drawing/2014/main" id="{6BE76B2A-183E-47FF-8302-9B5C422BD02D}"/>
+                <a16:creationId xmlns:a16="http://schemas.microsoft.com/office/drawing/2014/main" id="{8D151B6F-1B48-4F2F-9EB3-696DE49FD4FA}"/>
               </a:ext>
             </a:extLst>
           </p:cNvPr>
@@ -6492,7 +6492,7 @@
     </p:spTree>
     <p:extLst>
       <p:ext uri="{BB962C8B-B14F-4D97-AF65-F5344CB8AC3E}">
-        <p14:creationId xmlns:p14="http://schemas.microsoft.com/office/powerpoint/2010/main" val="1551880213"/>
+        <p14:creationId xmlns:p14="http://schemas.microsoft.com/office/powerpoint/2010/main" val="1239936456"/>
       </p:ext>
     </p:extLst>
   </p:cSld>
@@ -6516,7 +6516,7 @@
           <p:cNvPr id="1" name="">
             <a:extLst xmlns:a="http://schemas.openxmlformats.org/drawingml/2006/main">
               <a:ext uri="{FF2B5EF4-FFF2-40B4-BE49-F238E27FC236}">
-                <a16:creationId xmlns:a16="http://schemas.microsoft.com/office/drawing/2014/main" id="{18224E7C-0167-47DA-B58E-4F0EC2385FA6}"/>
+                <a16:creationId xmlns:a16="http://schemas.microsoft.com/office/drawing/2014/main" id="{3CBACB7B-F72A-491E-9166-6ED69A1F5CF6}"/>
               </a:ext>
             </a:extLst>
           </p:cNvPr>
@@ -6551,7 +6551,7 @@
           <p:cNvPr id="2" name="kicker-marker">
             <a:extLst xmlns:a="http://schemas.openxmlformats.org/drawingml/2006/main">
               <a:ext uri="{FF2B5EF4-FFF2-40B4-BE49-F238E27FC236}">
-                <a16:creationId xmlns:a16="http://schemas.microsoft.com/office/drawing/2014/main" id="{4A56B77C-09C8-49FB-83B1-5AA03C0D0BD7}"/>
+                <a16:creationId xmlns:a16="http://schemas.microsoft.com/office/drawing/2014/main" id="{4482D665-5F47-42C4-9253-8BD5447C8282}"/>
               </a:ext>
             </a:extLst>
           </p:cNvPr>
@@ -6586,7 +6586,7 @@
           <p:cNvPr id="3" name="kicker-label">
             <a:extLst xmlns:a="http://schemas.openxmlformats.org/drawingml/2006/main">
               <a:ext uri="{FF2B5EF4-FFF2-40B4-BE49-F238E27FC236}">
-                <a16:creationId xmlns:a16="http://schemas.microsoft.com/office/drawing/2014/main" id="{27E74AC0-3F51-49C8-B718-0974675C5742}"/>
+                <a16:creationId xmlns:a16="http://schemas.microsoft.com/office/drawing/2014/main" id="{4C397154-36EC-488E-95A4-26CCB6C4374C}"/>
               </a:ext>
             </a:extLst>
           </p:cNvPr>
@@ -6640,7 +6640,7 @@
                 <a:ea typeface="Aptos"/>
                 <a:cs typeface="Aptos"/>
               </a:rPr>
-              <a:t>UI WALKTHROUGH 1</a:t>
+              <a:t>WHY THIS WORKFLOW MATTERS</a:t>
             </a:r>
           </a:p>
         </p:txBody>
@@ -6650,7 +6650,7 @@
           <p:cNvPr id="4" name="">
             <a:extLst xmlns:a="http://schemas.openxmlformats.org/drawingml/2006/main">
               <a:ext uri="{FF2B5EF4-FFF2-40B4-BE49-F238E27FC236}">
-                <a16:creationId xmlns:a16="http://schemas.microsoft.com/office/drawing/2014/main" id="{3E7900B6-1F70-4FB3-B790-17AA662D3D22}"/>
+                <a16:creationId xmlns:a16="http://schemas.microsoft.com/office/drawing/2014/main" id="{BEFA377D-E548-4E06-A754-BE47564D8C9C}"/>
               </a:ext>
             </a:extLst>
           </p:cNvPr>
@@ -6704,7 +6704,7 @@
                 <a:ea typeface="Aptos Display"/>
                 <a:cs typeface="Aptos Display"/>
               </a:rPr>
-              <a:t>The reviewer starts by pasting a warning and checking the extracted scenario brief.</a:t>
+              <a:t>The real bottleneck is not generating rows. It is turning vague typology language into testable model behavior.</a:t>
             </a:r>
           </a:p>
         </p:txBody>
@@ -6714,7 +6714,7 @@
           <p:cNvPr id="5" name="">
             <a:extLst xmlns:a="http://schemas.openxmlformats.org/drawingml/2006/main">
               <a:ext uri="{FF2B5EF4-FFF2-40B4-BE49-F238E27FC236}">
-                <a16:creationId xmlns:a16="http://schemas.microsoft.com/office/drawing/2014/main" id="{3EB3DDA9-435F-4034-BA9B-93A7CA7A02C4}"/>
+                <a16:creationId xmlns:a16="http://schemas.microsoft.com/office/drawing/2014/main" id="{6BB0CE36-DEDE-48C0-A7C9-DDB0C57A13B6}"/>
               </a:ext>
             </a:extLst>
           </p:cNvPr>
@@ -6749,7 +6749,7 @@
           <p:cNvPr id="6" name="">
             <a:extLst xmlns:a="http://schemas.openxmlformats.org/drawingml/2006/main">
               <a:ext uri="{FF2B5EF4-FFF2-40B4-BE49-F238E27FC236}">
-                <a16:creationId xmlns:a16="http://schemas.microsoft.com/office/drawing/2014/main" id="{398D62CB-D8A3-44FC-85A6-3007554E2752}"/>
+                <a16:creationId xmlns:a16="http://schemas.microsoft.com/office/drawing/2014/main" id="{7DAB4931-3DE6-4BB5-9AB2-3E8E64976EBA}"/>
               </a:ext>
             </a:extLst>
           </p:cNvPr>
@@ -6808,46 +6808,59 @@
           </a:p>
         </p:txBody>
       </p:sp>
-      <p:pic>
-        <p:nvPicPr>
-          <p:cNvPr id="7" name=""/>
-          <p:cNvPicPr>
-            <a:picLocks xmlns:a="http://schemas.openxmlformats.org/drawingml/2006/main" noChangeAspect="1"/>
-          </p:cNvPicPr>
-          <p:nvPr/>
-        </p:nvPicPr>
-        <p:blipFill>
-          <a:blip xmlns:r="http://schemas.openxmlformats.org/officeDocument/2006/relationships" xmlns:a="http://schemas.openxmlformats.org/drawingml/2006/main" r:embed="R5884ccb16819452c"/>
-          <a:stretch xmlns:a="http://schemas.openxmlformats.org/drawingml/2006/main"/>
-        </p:blipFill>
-        <p:spPr>
-          <a:xfrm xmlns:a="http://schemas.openxmlformats.org/drawingml/2006/main">
-            <a:off x="2959244" y="1714500"/>
-            <a:ext cx="6273511" cy="4381500"/>
-          </a:xfrm>
-          <a:prstGeom xmlns:a="http://schemas.openxmlformats.org/drawingml/2006/main" prst="rect">
-            <a:avLst/>
-          </a:prstGeom>
-        </p:spPr>
-      </p:pic>
+      <p:sp>
+        <p:nvSpPr>
+          <p:cNvPr id="7" name="">
+            <a:extLst xmlns:a="http://schemas.openxmlformats.org/drawingml/2006/main">
+              <a:ext uri="{FF2B5EF4-FFF2-40B4-BE49-F238E27FC236}">
+                <a16:creationId xmlns:a16="http://schemas.microsoft.com/office/drawing/2014/main" id="{B9A35539-50E3-4706-AD51-E423B13F5CA8}"/>
+              </a:ext>
+            </a:extLst>
+          </p:cNvPr>
+          <p:cNvSpPr>
+            <a:spLocks xmlns:a="http://schemas.openxmlformats.org/drawingml/2006/main" noGrp="1"/>
+          </p:cNvSpPr>
+          <p:nvPr/>
+        </p:nvSpPr>
+        <p:spPr>
+          <a:xfrm xmlns:a="http://schemas.openxmlformats.org/drawingml/2006/main">
+            <a:off x="857250" y="1962150"/>
+            <a:ext cx="609600" cy="609600"/>
+          </a:xfrm>
+          <a:prstGeom xmlns:a="http://schemas.openxmlformats.org/drawingml/2006/main" prst="rect">
+            <a:avLst/>
+          </a:prstGeom>
+          <a:solidFill xmlns:a="http://schemas.openxmlformats.org/drawingml/2006/main">
+            <a:srgbClr val="14213D"/>
+          </a:solidFill>
+          <a:ln xmlns:a="http://schemas.openxmlformats.org/drawingml/2006/main" w="0">
+            <a:solidFill>
+              <a:srgbClr val="000000">
+                <a:alpha val="0"/>
+              </a:srgbClr>
+            </a:solidFill>
+            <a:prstDash val="solid"/>
+          </a:ln>
+        </p:spPr>
+      </p:sp>
       <p:sp>
         <p:nvSpPr>
           <p:cNvPr id="8" name="">
             <a:extLst xmlns:a="http://schemas.openxmlformats.org/drawingml/2006/main">
               <a:ext uri="{FF2B5EF4-FFF2-40B4-BE49-F238E27FC236}">
-                <a16:creationId xmlns:a16="http://schemas.microsoft.com/office/drawing/2014/main" id="{55B80702-B01B-4C9E-9C66-8B1EAF41F4F0}"/>
-              </a:ext>
-            </a:extLst>
-          </p:cNvPr>
-          <p:cNvSpPr>
-            <a:spLocks xmlns:a="http://schemas.openxmlformats.org/drawingml/2006/main" noGrp="1"/>
-          </p:cNvSpPr>
-          <p:nvPr/>
-        </p:nvSpPr>
-        <p:spPr>
-          <a:xfrm xmlns:a="http://schemas.openxmlformats.org/drawingml/2006/main">
-            <a:off x="2200275" y="1714500"/>
-            <a:ext cx="7791450" cy="4381500"/>
+                <a16:creationId xmlns:a16="http://schemas.microsoft.com/office/drawing/2014/main" id="{688A7DE2-151E-4D68-8407-2A07FEEEF360}"/>
+              </a:ext>
+            </a:extLst>
+          </p:cNvPr>
+          <p:cNvSpPr>
+            <a:spLocks xmlns:a="http://schemas.openxmlformats.org/drawingml/2006/main" noGrp="1"/>
+          </p:cNvSpPr>
+          <p:nvPr/>
+        </p:nvSpPr>
+        <p:spPr>
+          <a:xfrm xmlns:a="http://schemas.openxmlformats.org/drawingml/2006/main">
+            <a:off x="1028700" y="2095500"/>
+            <a:ext cx="266700" cy="304800"/>
           </a:xfrm>
           <a:prstGeom xmlns:a="http://schemas.openxmlformats.org/drawingml/2006/main" prst="rect">
             <a:avLst/>
@@ -6857,18 +6870,726 @@
               <a:alpha val="0"/>
             </a:srgbClr>
           </a:solidFill>
+          <a:ln xmlns:a="http://schemas.openxmlformats.org/drawingml/2006/main" w="0">
+            <a:solidFill>
+              <a:srgbClr val="000000">
+                <a:alpha val="0"/>
+              </a:srgbClr>
+            </a:solidFill>
+            <a:prstDash val="solid"/>
+          </a:ln>
+        </p:spPr>
+        <p:txBody>
+          <a:bodyPr xmlns:a="http://schemas.openxmlformats.org/drawingml/2006/main" lIns="0" tIns="0" rIns="0" bIns="0" anchor="t"/>
+          <a:lstStyle xmlns:a="http://schemas.openxmlformats.org/drawingml/2006/main"/>
+          <a:p xmlns:a="http://schemas.openxmlformats.org/drawingml/2006/main">
+            <a:pPr algn="ctr">
+              <a:defRPr sz="1875" b="1">
+                <a:solidFill>
+                  <a:srgbClr val="F7F3EA"/>
+                </a:solidFill>
+                <a:latin typeface="Aptos"/>
+                <a:ea typeface="Aptos"/>
+                <a:cs typeface="Aptos"/>
+              </a:defRPr>
+            </a:pPr>
+            <a:r>
+              <a:rPr sz="1875" b="1">
+                <a:solidFill>
+                  <a:srgbClr val="F7F3EA"/>
+                </a:solidFill>
+                <a:latin typeface="Aptos"/>
+                <a:ea typeface="Aptos"/>
+                <a:cs typeface="Aptos"/>
+              </a:rPr>
+              <a:t>1</a:t>
+            </a:r>
+          </a:p>
+        </p:txBody>
+      </p:sp>
+      <p:sp>
+        <p:nvSpPr>
+          <p:cNvPr id="9" name="">
+            <a:extLst xmlns:a="http://schemas.openxmlformats.org/drawingml/2006/main">
+              <a:ext uri="{FF2B5EF4-FFF2-40B4-BE49-F238E27FC236}">
+                <a16:creationId xmlns:a16="http://schemas.microsoft.com/office/drawing/2014/main" id="{430A6EF9-117D-45F6-A46B-535087C60F2F}"/>
+              </a:ext>
+            </a:extLst>
+          </p:cNvPr>
+          <p:cNvSpPr>
+            <a:spLocks xmlns:a="http://schemas.openxmlformats.org/drawingml/2006/main" noGrp="1"/>
+          </p:cNvSpPr>
+          <p:nvPr/>
+        </p:nvSpPr>
+        <p:spPr>
+          <a:xfrm xmlns:a="http://schemas.openxmlformats.org/drawingml/2006/main">
+            <a:off x="1752600" y="1943100"/>
+            <a:ext cx="2095500" cy="304800"/>
+          </a:xfrm>
+          <a:prstGeom xmlns:a="http://schemas.openxmlformats.org/drawingml/2006/main" prst="rect">
+            <a:avLst/>
+          </a:prstGeom>
+          <a:solidFill xmlns:a="http://schemas.openxmlformats.org/drawingml/2006/main">
+            <a:srgbClr val="000000">
+              <a:alpha val="0"/>
+            </a:srgbClr>
+          </a:solidFill>
+          <a:ln xmlns:a="http://schemas.openxmlformats.org/drawingml/2006/main" w="0">
+            <a:solidFill>
+              <a:srgbClr val="000000">
+                <a:alpha val="0"/>
+              </a:srgbClr>
+            </a:solidFill>
+            <a:prstDash val="solid"/>
+          </a:ln>
+        </p:spPr>
+        <p:txBody>
+          <a:bodyPr xmlns:a="http://schemas.openxmlformats.org/drawingml/2006/main" lIns="0" tIns="0" rIns="0" bIns="0" anchor="t"/>
+          <a:lstStyle xmlns:a="http://schemas.openxmlformats.org/drawingml/2006/main"/>
+          <a:p xmlns:a="http://schemas.openxmlformats.org/drawingml/2006/main">
+            <a:pPr algn="l">
+              <a:defRPr sz="1800" b="1">
+                <a:solidFill>
+                  <a:srgbClr val="14213D"/>
+                </a:solidFill>
+                <a:latin typeface="Aptos"/>
+                <a:ea typeface="Aptos"/>
+                <a:cs typeface="Aptos"/>
+              </a:defRPr>
+            </a:pPr>
+            <a:r>
+              <a:rPr sz="1800" b="1">
+                <a:solidFill>
+                  <a:srgbClr val="14213D"/>
+                </a:solidFill>
+                <a:latin typeface="Aptos"/>
+                <a:ea typeface="Aptos"/>
+                <a:cs typeface="Aptos"/>
+              </a:rPr>
+              <a:t>Status quo</a:t>
+            </a:r>
+          </a:p>
+        </p:txBody>
+      </p:sp>
+      <p:sp>
+        <p:nvSpPr>
+          <p:cNvPr id="10" name="">
+            <a:extLst xmlns:a="http://schemas.openxmlformats.org/drawingml/2006/main">
+              <a:ext uri="{FF2B5EF4-FFF2-40B4-BE49-F238E27FC236}">
+                <a16:creationId xmlns:a16="http://schemas.microsoft.com/office/drawing/2014/main" id="{C23ED889-7840-4FB2-8D15-CCF2C0046D62}"/>
+              </a:ext>
+            </a:extLst>
+          </p:cNvPr>
+          <p:cNvSpPr>
+            <a:spLocks xmlns:a="http://schemas.openxmlformats.org/drawingml/2006/main" noGrp="1"/>
+          </p:cNvSpPr>
+          <p:nvPr/>
+        </p:nvSpPr>
+        <p:spPr>
+          <a:xfrm xmlns:a="http://schemas.openxmlformats.org/drawingml/2006/main">
+            <a:off x="1752600" y="2362200"/>
+            <a:ext cx="8001000" cy="533400"/>
+          </a:xfrm>
+          <a:prstGeom xmlns:a="http://schemas.openxmlformats.org/drawingml/2006/main" prst="rect">
+            <a:avLst/>
+          </a:prstGeom>
+          <a:solidFill xmlns:a="http://schemas.openxmlformats.org/drawingml/2006/main">
+            <a:srgbClr val="000000">
+              <a:alpha val="0"/>
+            </a:srgbClr>
+          </a:solidFill>
+          <a:ln xmlns:a="http://schemas.openxmlformats.org/drawingml/2006/main" w="0">
+            <a:solidFill>
+              <a:srgbClr val="000000">
+                <a:alpha val="0"/>
+              </a:srgbClr>
+            </a:solidFill>
+            <a:prstDash val="solid"/>
+          </a:ln>
+        </p:spPr>
+        <p:txBody>
+          <a:bodyPr xmlns:a="http://schemas.openxmlformats.org/drawingml/2006/main" lIns="0" tIns="0" rIns="0" bIns="0" anchor="t"/>
+          <a:lstStyle xmlns:a="http://schemas.openxmlformats.org/drawingml/2006/main"/>
+          <a:p xmlns:a="http://schemas.openxmlformats.org/drawingml/2006/main">
+            <a:pPr algn="l">
+              <a:defRPr sz="1350" b="0">
+                <a:solidFill>
+                  <a:srgbClr val="4D4A43"/>
+                </a:solidFill>
+                <a:latin typeface="Aptos"/>
+                <a:ea typeface="Aptos"/>
+                <a:cs typeface="Aptos"/>
+              </a:defRPr>
+            </a:pPr>
+            <a:r>
+              <a:rPr sz="1350" b="0">
+                <a:solidFill>
+                  <a:srgbClr val="4D4A43"/>
+                </a:solidFill>
+                <a:latin typeface="Aptos"/>
+                <a:ea typeface="Aptos"/>
+                <a:cs typeface="Aptos"/>
+              </a:rPr>
+              <a:t>An analyst reviews an incoming warning, writes ad hoc rules, and creates a small spreadsheet or prompt-only sample.</a:t>
+            </a:r>
+          </a:p>
+        </p:txBody>
+      </p:sp>
+      <p:sp>
+        <p:nvSpPr>
+          <p:cNvPr id="11" name="">
+            <a:extLst xmlns:a="http://schemas.openxmlformats.org/drawingml/2006/main">
+              <a:ext uri="{FF2B5EF4-FFF2-40B4-BE49-F238E27FC236}">
+                <a16:creationId xmlns:a16="http://schemas.microsoft.com/office/drawing/2014/main" id="{D863B5D5-6097-477A-93A4-3E6F3B6C730D}"/>
+              </a:ext>
+            </a:extLst>
+          </p:cNvPr>
+          <p:cNvSpPr>
+            <a:spLocks xmlns:a="http://schemas.openxmlformats.org/drawingml/2006/main" noGrp="1"/>
+          </p:cNvSpPr>
+          <p:nvPr/>
+        </p:nvSpPr>
+        <p:spPr>
+          <a:xfrm xmlns:a="http://schemas.openxmlformats.org/drawingml/2006/main">
+            <a:off x="857250" y="3257550"/>
+            <a:ext cx="609600" cy="609600"/>
+          </a:xfrm>
+          <a:prstGeom xmlns:a="http://schemas.openxmlformats.org/drawingml/2006/main" prst="rect">
+            <a:avLst/>
+          </a:prstGeom>
+          <a:solidFill xmlns:a="http://schemas.openxmlformats.org/drawingml/2006/main">
+            <a:srgbClr val="C44536"/>
+          </a:solidFill>
+          <a:ln xmlns:a="http://schemas.openxmlformats.org/drawingml/2006/main" w="0">
+            <a:solidFill>
+              <a:srgbClr val="000000">
+                <a:alpha val="0"/>
+              </a:srgbClr>
+            </a:solidFill>
+            <a:prstDash val="solid"/>
+          </a:ln>
+        </p:spPr>
+      </p:sp>
+      <p:sp>
+        <p:nvSpPr>
+          <p:cNvPr id="12" name="">
+            <a:extLst xmlns:a="http://schemas.openxmlformats.org/drawingml/2006/main">
+              <a:ext uri="{FF2B5EF4-FFF2-40B4-BE49-F238E27FC236}">
+                <a16:creationId xmlns:a16="http://schemas.microsoft.com/office/drawing/2014/main" id="{19B5E4E7-F264-486F-BBCA-F93876975438}"/>
+              </a:ext>
+            </a:extLst>
+          </p:cNvPr>
+          <p:cNvSpPr>
+            <a:spLocks xmlns:a="http://schemas.openxmlformats.org/drawingml/2006/main" noGrp="1"/>
+          </p:cNvSpPr>
+          <p:nvPr/>
+        </p:nvSpPr>
+        <p:spPr>
+          <a:xfrm xmlns:a="http://schemas.openxmlformats.org/drawingml/2006/main">
+            <a:off x="1028700" y="3390900"/>
+            <a:ext cx="266700" cy="304800"/>
+          </a:xfrm>
+          <a:prstGeom xmlns:a="http://schemas.openxmlformats.org/drawingml/2006/main" prst="rect">
+            <a:avLst/>
+          </a:prstGeom>
+          <a:solidFill xmlns:a="http://schemas.openxmlformats.org/drawingml/2006/main">
+            <a:srgbClr val="000000">
+              <a:alpha val="0"/>
+            </a:srgbClr>
+          </a:solidFill>
+          <a:ln xmlns:a="http://schemas.openxmlformats.org/drawingml/2006/main" w="0">
+            <a:solidFill>
+              <a:srgbClr val="000000">
+                <a:alpha val="0"/>
+              </a:srgbClr>
+            </a:solidFill>
+            <a:prstDash val="solid"/>
+          </a:ln>
+        </p:spPr>
+        <p:txBody>
+          <a:bodyPr xmlns:a="http://schemas.openxmlformats.org/drawingml/2006/main" lIns="0" tIns="0" rIns="0" bIns="0" anchor="t"/>
+          <a:lstStyle xmlns:a="http://schemas.openxmlformats.org/drawingml/2006/main"/>
+          <a:p xmlns:a="http://schemas.openxmlformats.org/drawingml/2006/main">
+            <a:pPr algn="ctr">
+              <a:defRPr sz="1875" b="1">
+                <a:solidFill>
+                  <a:srgbClr val="F7F3EA"/>
+                </a:solidFill>
+                <a:latin typeface="Aptos"/>
+                <a:ea typeface="Aptos"/>
+                <a:cs typeface="Aptos"/>
+              </a:defRPr>
+            </a:pPr>
+            <a:r>
+              <a:rPr sz="1875" b="1">
+                <a:solidFill>
+                  <a:srgbClr val="F7F3EA"/>
+                </a:solidFill>
+                <a:latin typeface="Aptos"/>
+                <a:ea typeface="Aptos"/>
+                <a:cs typeface="Aptos"/>
+              </a:rPr>
+              <a:t>2</a:t>
+            </a:r>
+          </a:p>
+        </p:txBody>
+      </p:sp>
+      <p:sp>
+        <p:nvSpPr>
+          <p:cNvPr id="13" name="">
+            <a:extLst xmlns:a="http://schemas.openxmlformats.org/drawingml/2006/main">
+              <a:ext uri="{FF2B5EF4-FFF2-40B4-BE49-F238E27FC236}">
+                <a16:creationId xmlns:a16="http://schemas.microsoft.com/office/drawing/2014/main" id="{ED0DA801-591A-4466-9818-21C8DAA99BB3}"/>
+              </a:ext>
+            </a:extLst>
+          </p:cNvPr>
+          <p:cNvSpPr>
+            <a:spLocks xmlns:a="http://schemas.openxmlformats.org/drawingml/2006/main" noGrp="1"/>
+          </p:cNvSpPr>
+          <p:nvPr/>
+        </p:nvSpPr>
+        <p:spPr>
+          <a:xfrm xmlns:a="http://schemas.openxmlformats.org/drawingml/2006/main">
+            <a:off x="1752600" y="3238500"/>
+            <a:ext cx="2095500" cy="304800"/>
+          </a:xfrm>
+          <a:prstGeom xmlns:a="http://schemas.openxmlformats.org/drawingml/2006/main" prst="rect">
+            <a:avLst/>
+          </a:prstGeom>
+          <a:solidFill xmlns:a="http://schemas.openxmlformats.org/drawingml/2006/main">
+            <a:srgbClr val="000000">
+              <a:alpha val="0"/>
+            </a:srgbClr>
+          </a:solidFill>
+          <a:ln xmlns:a="http://schemas.openxmlformats.org/drawingml/2006/main" w="0">
+            <a:solidFill>
+              <a:srgbClr val="000000">
+                <a:alpha val="0"/>
+              </a:srgbClr>
+            </a:solidFill>
+            <a:prstDash val="solid"/>
+          </a:ln>
+        </p:spPr>
+        <p:txBody>
+          <a:bodyPr xmlns:a="http://schemas.openxmlformats.org/drawingml/2006/main" lIns="0" tIns="0" rIns="0" bIns="0" anchor="t"/>
+          <a:lstStyle xmlns:a="http://schemas.openxmlformats.org/drawingml/2006/main"/>
+          <a:p xmlns:a="http://schemas.openxmlformats.org/drawingml/2006/main">
+            <a:pPr algn="l">
+              <a:defRPr sz="1800" b="1">
+                <a:solidFill>
+                  <a:srgbClr val="14213D"/>
+                </a:solidFill>
+                <a:latin typeface="Aptos"/>
+                <a:ea typeface="Aptos"/>
+                <a:cs typeface="Aptos"/>
+              </a:defRPr>
+            </a:pPr>
+            <a:r>
+              <a:rPr sz="1800" b="1">
+                <a:solidFill>
+                  <a:srgbClr val="14213D"/>
+                </a:solidFill>
+                <a:latin typeface="Aptos"/>
+                <a:ea typeface="Aptos"/>
+                <a:cs typeface="Aptos"/>
+              </a:rPr>
+              <a:t>Risk</a:t>
+            </a:r>
+          </a:p>
+        </p:txBody>
+      </p:sp>
+      <p:sp>
+        <p:nvSpPr>
+          <p:cNvPr id="14" name="">
+            <a:extLst xmlns:a="http://schemas.openxmlformats.org/drawingml/2006/main">
+              <a:ext uri="{FF2B5EF4-FFF2-40B4-BE49-F238E27FC236}">
+                <a16:creationId xmlns:a16="http://schemas.microsoft.com/office/drawing/2014/main" id="{71943314-E246-44BE-ACCD-DCFBEE9508D1}"/>
+              </a:ext>
+            </a:extLst>
+          </p:cNvPr>
+          <p:cNvSpPr>
+            <a:spLocks xmlns:a="http://schemas.openxmlformats.org/drawingml/2006/main" noGrp="1"/>
+          </p:cNvSpPr>
+          <p:nvPr/>
+        </p:nvSpPr>
+        <p:spPr>
+          <a:xfrm xmlns:a="http://schemas.openxmlformats.org/drawingml/2006/main">
+            <a:off x="1752600" y="3657600"/>
+            <a:ext cx="8001000" cy="533400"/>
+          </a:xfrm>
+          <a:prstGeom xmlns:a="http://schemas.openxmlformats.org/drawingml/2006/main" prst="rect">
+            <a:avLst/>
+          </a:prstGeom>
+          <a:solidFill xmlns:a="http://schemas.openxmlformats.org/drawingml/2006/main">
+            <a:srgbClr val="000000">
+              <a:alpha val="0"/>
+            </a:srgbClr>
+          </a:solidFill>
+          <a:ln xmlns:a="http://schemas.openxmlformats.org/drawingml/2006/main" w="0">
+            <a:solidFill>
+              <a:srgbClr val="000000">
+                <a:alpha val="0"/>
+              </a:srgbClr>
+            </a:solidFill>
+            <a:prstDash val="solid"/>
+          </a:ln>
+        </p:spPr>
+        <p:txBody>
+          <a:bodyPr xmlns:a="http://schemas.openxmlformats.org/drawingml/2006/main" lIns="0" tIns="0" rIns="0" bIns="0" anchor="t"/>
+          <a:lstStyle xmlns:a="http://schemas.openxmlformats.org/drawingml/2006/main"/>
+          <a:p xmlns:a="http://schemas.openxmlformats.org/drawingml/2006/main">
+            <a:pPr algn="l">
+              <a:defRPr sz="1350" b="0">
+                <a:solidFill>
+                  <a:srgbClr val="4D4A43"/>
+                </a:solidFill>
+                <a:latin typeface="Aptos"/>
+                <a:ea typeface="Aptos"/>
+                <a:cs typeface="Aptos"/>
+              </a:defRPr>
+            </a:pPr>
+            <a:r>
+              <a:rPr sz="1350" b="0">
+                <a:solidFill>
+                  <a:srgbClr val="4D4A43"/>
+                </a:solidFill>
+                <a:latin typeface="Aptos"/>
+                <a:ea typeface="Aptos"/>
+                <a:cs typeface="Aptos"/>
+              </a:rPr>
+              <a:t>The resulting data often overfits obvious signals like high amount and misses multi-step fund-flow behavior.</a:t>
+            </a:r>
+          </a:p>
+        </p:txBody>
+      </p:sp>
+      <p:sp>
+        <p:nvSpPr>
+          <p:cNvPr id="15" name="">
+            <a:extLst xmlns:a="http://schemas.openxmlformats.org/drawingml/2006/main">
+              <a:ext uri="{FF2B5EF4-FFF2-40B4-BE49-F238E27FC236}">
+                <a16:creationId xmlns:a16="http://schemas.microsoft.com/office/drawing/2014/main" id="{BB5C2903-AF10-41E8-9DFA-17617CBC919C}"/>
+              </a:ext>
+            </a:extLst>
+          </p:cNvPr>
+          <p:cNvSpPr>
+            <a:spLocks xmlns:a="http://schemas.openxmlformats.org/drawingml/2006/main" noGrp="1"/>
+          </p:cNvSpPr>
+          <p:nvPr/>
+        </p:nvSpPr>
+        <p:spPr>
+          <a:xfrm xmlns:a="http://schemas.openxmlformats.org/drawingml/2006/main">
+            <a:off x="857250" y="4552950"/>
+            <a:ext cx="609600" cy="609600"/>
+          </a:xfrm>
+          <a:prstGeom xmlns:a="http://schemas.openxmlformats.org/drawingml/2006/main" prst="rect">
+            <a:avLst/>
+          </a:prstGeom>
+          <a:solidFill xmlns:a="http://schemas.openxmlformats.org/drawingml/2006/main">
+            <a:srgbClr val="0E7C66"/>
+          </a:solidFill>
+          <a:ln xmlns:a="http://schemas.openxmlformats.org/drawingml/2006/main" w="0">
+            <a:solidFill>
+              <a:srgbClr val="000000">
+                <a:alpha val="0"/>
+              </a:srgbClr>
+            </a:solidFill>
+            <a:prstDash val="solid"/>
+          </a:ln>
+        </p:spPr>
+      </p:sp>
+      <p:sp>
+        <p:nvSpPr>
+          <p:cNvPr id="16" name="">
+            <a:extLst xmlns:a="http://schemas.openxmlformats.org/drawingml/2006/main">
+              <a:ext uri="{FF2B5EF4-FFF2-40B4-BE49-F238E27FC236}">
+                <a16:creationId xmlns:a16="http://schemas.microsoft.com/office/drawing/2014/main" id="{338EEDF1-C82F-40BB-B4CA-E8438E2619B3}"/>
+              </a:ext>
+            </a:extLst>
+          </p:cNvPr>
+          <p:cNvSpPr>
+            <a:spLocks xmlns:a="http://schemas.openxmlformats.org/drawingml/2006/main" noGrp="1"/>
+          </p:cNvSpPr>
+          <p:nvPr/>
+        </p:nvSpPr>
+        <p:spPr>
+          <a:xfrm xmlns:a="http://schemas.openxmlformats.org/drawingml/2006/main">
+            <a:off x="1028700" y="4686300"/>
+            <a:ext cx="266700" cy="304800"/>
+          </a:xfrm>
+          <a:prstGeom xmlns:a="http://schemas.openxmlformats.org/drawingml/2006/main" prst="rect">
+            <a:avLst/>
+          </a:prstGeom>
+          <a:solidFill xmlns:a="http://schemas.openxmlformats.org/drawingml/2006/main">
+            <a:srgbClr val="000000">
+              <a:alpha val="0"/>
+            </a:srgbClr>
+          </a:solidFill>
+          <a:ln xmlns:a="http://schemas.openxmlformats.org/drawingml/2006/main" w="0">
+            <a:solidFill>
+              <a:srgbClr val="000000">
+                <a:alpha val="0"/>
+              </a:srgbClr>
+            </a:solidFill>
+            <a:prstDash val="solid"/>
+          </a:ln>
+        </p:spPr>
+        <p:txBody>
+          <a:bodyPr xmlns:a="http://schemas.openxmlformats.org/drawingml/2006/main" lIns="0" tIns="0" rIns="0" bIns="0" anchor="t"/>
+          <a:lstStyle xmlns:a="http://schemas.openxmlformats.org/drawingml/2006/main"/>
+          <a:p xmlns:a="http://schemas.openxmlformats.org/drawingml/2006/main">
+            <a:pPr algn="ctr">
+              <a:defRPr sz="1875" b="1">
+                <a:solidFill>
+                  <a:srgbClr val="F7F3EA"/>
+                </a:solidFill>
+                <a:latin typeface="Aptos"/>
+                <a:ea typeface="Aptos"/>
+                <a:cs typeface="Aptos"/>
+              </a:defRPr>
+            </a:pPr>
+            <a:r>
+              <a:rPr sz="1875" b="1">
+                <a:solidFill>
+                  <a:srgbClr val="F7F3EA"/>
+                </a:solidFill>
+                <a:latin typeface="Aptos"/>
+                <a:ea typeface="Aptos"/>
+                <a:cs typeface="Aptos"/>
+              </a:rPr>
+              <a:t>3</a:t>
+            </a:r>
+          </a:p>
+        </p:txBody>
+      </p:sp>
+      <p:sp>
+        <p:nvSpPr>
+          <p:cNvPr id="17" name="">
+            <a:extLst xmlns:a="http://schemas.openxmlformats.org/drawingml/2006/main">
+              <a:ext uri="{FF2B5EF4-FFF2-40B4-BE49-F238E27FC236}">
+                <a16:creationId xmlns:a16="http://schemas.microsoft.com/office/drawing/2014/main" id="{0988904B-9874-49B0-BC9B-EFDAF93B7D21}"/>
+              </a:ext>
+            </a:extLst>
+          </p:cNvPr>
+          <p:cNvSpPr>
+            <a:spLocks xmlns:a="http://schemas.openxmlformats.org/drawingml/2006/main" noGrp="1"/>
+          </p:cNvSpPr>
+          <p:nvPr/>
+        </p:nvSpPr>
+        <p:spPr>
+          <a:xfrm xmlns:a="http://schemas.openxmlformats.org/drawingml/2006/main">
+            <a:off x="1752600" y="4533900"/>
+            <a:ext cx="2095500" cy="304800"/>
+          </a:xfrm>
+          <a:prstGeom xmlns:a="http://schemas.openxmlformats.org/drawingml/2006/main" prst="rect">
+            <a:avLst/>
+          </a:prstGeom>
+          <a:solidFill xmlns:a="http://schemas.openxmlformats.org/drawingml/2006/main">
+            <a:srgbClr val="000000">
+              <a:alpha val="0"/>
+            </a:srgbClr>
+          </a:solidFill>
+          <a:ln xmlns:a="http://schemas.openxmlformats.org/drawingml/2006/main" w="0">
+            <a:solidFill>
+              <a:srgbClr val="000000">
+                <a:alpha val="0"/>
+              </a:srgbClr>
+            </a:solidFill>
+            <a:prstDash val="solid"/>
+          </a:ln>
+        </p:spPr>
+        <p:txBody>
+          <a:bodyPr xmlns:a="http://schemas.openxmlformats.org/drawingml/2006/main" lIns="0" tIns="0" rIns="0" bIns="0" anchor="t"/>
+          <a:lstStyle xmlns:a="http://schemas.openxmlformats.org/drawingml/2006/main"/>
+          <a:p xmlns:a="http://schemas.openxmlformats.org/drawingml/2006/main">
+            <a:pPr algn="l">
+              <a:defRPr sz="1800" b="1">
+                <a:solidFill>
+                  <a:srgbClr val="14213D"/>
+                </a:solidFill>
+                <a:latin typeface="Aptos"/>
+                <a:ea typeface="Aptos"/>
+                <a:cs typeface="Aptos"/>
+              </a:defRPr>
+            </a:pPr>
+            <a:r>
+              <a:rPr sz="1800" b="1">
+                <a:solidFill>
+                  <a:srgbClr val="14213D"/>
+                </a:solidFill>
+                <a:latin typeface="Aptos"/>
+                <a:ea typeface="Aptos"/>
+                <a:cs typeface="Aptos"/>
+              </a:rPr>
+              <a:t>SynthAML shift</a:t>
+            </a:r>
+          </a:p>
+        </p:txBody>
+      </p:sp>
+      <p:sp>
+        <p:nvSpPr>
+          <p:cNvPr id="18" name="">
+            <a:extLst xmlns:a="http://schemas.openxmlformats.org/drawingml/2006/main">
+              <a:ext uri="{FF2B5EF4-FFF2-40B4-BE49-F238E27FC236}">
+                <a16:creationId xmlns:a16="http://schemas.microsoft.com/office/drawing/2014/main" id="{FCB63C4F-3A2A-48F8-A06B-593F8B385F22}"/>
+              </a:ext>
+            </a:extLst>
+          </p:cNvPr>
+          <p:cNvSpPr>
+            <a:spLocks xmlns:a="http://schemas.openxmlformats.org/drawingml/2006/main" noGrp="1"/>
+          </p:cNvSpPr>
+          <p:nvPr/>
+        </p:nvSpPr>
+        <p:spPr>
+          <a:xfrm xmlns:a="http://schemas.openxmlformats.org/drawingml/2006/main">
+            <a:off x="1752600" y="4953000"/>
+            <a:ext cx="8001000" cy="533400"/>
+          </a:xfrm>
+          <a:prstGeom xmlns:a="http://schemas.openxmlformats.org/drawingml/2006/main" prst="rect">
+            <a:avLst/>
+          </a:prstGeom>
+          <a:solidFill xmlns:a="http://schemas.openxmlformats.org/drawingml/2006/main">
+            <a:srgbClr val="000000">
+              <a:alpha val="0"/>
+            </a:srgbClr>
+          </a:solidFill>
+          <a:ln xmlns:a="http://schemas.openxmlformats.org/drawingml/2006/main" w="0">
+            <a:solidFill>
+              <a:srgbClr val="000000">
+                <a:alpha val="0"/>
+              </a:srgbClr>
+            </a:solidFill>
+            <a:prstDash val="solid"/>
+          </a:ln>
+        </p:spPr>
+        <p:txBody>
+          <a:bodyPr xmlns:a="http://schemas.openxmlformats.org/drawingml/2006/main" lIns="0" tIns="0" rIns="0" bIns="0" anchor="t"/>
+          <a:lstStyle xmlns:a="http://schemas.openxmlformats.org/drawingml/2006/main"/>
+          <a:p xmlns:a="http://schemas.openxmlformats.org/drawingml/2006/main">
+            <a:pPr algn="l">
+              <a:defRPr sz="1350" b="0">
+                <a:solidFill>
+                  <a:srgbClr val="4D4A43"/>
+                </a:solidFill>
+                <a:latin typeface="Aptos"/>
+                <a:ea typeface="Aptos"/>
+                <a:cs typeface="Aptos"/>
+              </a:defRPr>
+            </a:pPr>
+            <a:r>
+              <a:rPr sz="1350" b="0">
+                <a:solidFill>
+                  <a:srgbClr val="4D4A43"/>
+                </a:solidFill>
+                <a:latin typeface="Aptos"/>
+                <a:ea typeface="Aptos"/>
+                <a:cs typeface="Aptos"/>
+              </a:rPr>
+              <a:t>The app makes the intermediate scenario explicit: regions, timing, split count, narratives, chain logic, and review gates.</a:t>
+            </a:r>
+          </a:p>
+        </p:txBody>
+      </p:sp>
+      <p:sp>
+        <p:nvSpPr>
+          <p:cNvPr id="19" name="">
+            <a:extLst xmlns:a="http://schemas.openxmlformats.org/drawingml/2006/main">
+              <a:ext uri="{FF2B5EF4-FFF2-40B4-BE49-F238E27FC236}">
+                <a16:creationId xmlns:a16="http://schemas.microsoft.com/office/drawing/2014/main" id="{8BD99FF4-965F-4A46-98DA-8DBF36EC982C}"/>
+              </a:ext>
+            </a:extLst>
+          </p:cNvPr>
+          <p:cNvSpPr>
+            <a:spLocks xmlns:a="http://schemas.openxmlformats.org/drawingml/2006/main" noGrp="1"/>
+          </p:cNvSpPr>
+          <p:nvPr/>
+        </p:nvSpPr>
+        <p:spPr>
+          <a:xfrm xmlns:a="http://schemas.openxmlformats.org/drawingml/2006/main">
+            <a:off x="9258300" y="2266950"/>
+            <a:ext cx="1676400" cy="2095500"/>
+          </a:xfrm>
+          <a:prstGeom xmlns:a="http://schemas.openxmlformats.org/drawingml/2006/main" prst="rect">
+            <a:avLst/>
+          </a:prstGeom>
+          <a:solidFill xmlns:a="http://schemas.openxmlformats.org/drawingml/2006/main">
+            <a:srgbClr val="FFF4DB"/>
+          </a:solidFill>
           <a:ln xmlns:a="http://schemas.openxmlformats.org/drawingml/2006/main" w="9525">
             <a:solidFill>
-              <a:srgbClr val="D8D0C0"/>
-            </a:solidFill>
-            <a:prstDash val="solid"/>
-          </a:ln>
-        </p:spPr>
+              <a:srgbClr val="D89C27"/>
+            </a:solidFill>
+            <a:prstDash val="solid"/>
+          </a:ln>
+        </p:spPr>
+      </p:sp>
+      <p:sp>
+        <p:nvSpPr>
+          <p:cNvPr id="20" name="">
+            <a:extLst xmlns:a="http://schemas.openxmlformats.org/drawingml/2006/main">
+              <a:ext uri="{FF2B5EF4-FFF2-40B4-BE49-F238E27FC236}">
+                <a16:creationId xmlns:a16="http://schemas.microsoft.com/office/drawing/2014/main" id="{0D551B84-EA7F-4C7A-9142-5F78FD576A83}"/>
+              </a:ext>
+            </a:extLst>
+          </p:cNvPr>
+          <p:cNvSpPr>
+            <a:spLocks xmlns:a="http://schemas.openxmlformats.org/drawingml/2006/main" noGrp="1"/>
+          </p:cNvSpPr>
+          <p:nvPr/>
+        </p:nvSpPr>
+        <p:spPr>
+          <a:xfrm xmlns:a="http://schemas.openxmlformats.org/drawingml/2006/main">
+            <a:off x="9525000" y="2762250"/>
+            <a:ext cx="1143000" cy="914400"/>
+          </a:xfrm>
+          <a:prstGeom xmlns:a="http://schemas.openxmlformats.org/drawingml/2006/main" prst="rect">
+            <a:avLst/>
+          </a:prstGeom>
+          <a:solidFill xmlns:a="http://schemas.openxmlformats.org/drawingml/2006/main">
+            <a:srgbClr val="000000">
+              <a:alpha val="0"/>
+            </a:srgbClr>
+          </a:solidFill>
+          <a:ln xmlns:a="http://schemas.openxmlformats.org/drawingml/2006/main" w="0">
+            <a:solidFill>
+              <a:srgbClr val="000000">
+                <a:alpha val="0"/>
+              </a:srgbClr>
+            </a:solidFill>
+            <a:prstDash val="solid"/>
+          </a:ln>
+        </p:spPr>
+        <p:txBody>
+          <a:bodyPr xmlns:a="http://schemas.openxmlformats.org/drawingml/2006/main" lIns="0" tIns="0" rIns="0" bIns="0" anchor="t"/>
+          <a:lstStyle xmlns:a="http://schemas.openxmlformats.org/drawingml/2006/main"/>
+          <a:p xmlns:a="http://schemas.openxmlformats.org/drawingml/2006/main">
+            <a:pPr algn="ctr">
+              <a:defRPr sz="1800" b="1">
+                <a:solidFill>
+                  <a:srgbClr val="875B11"/>
+                </a:solidFill>
+                <a:latin typeface="Aptos Display"/>
+                <a:ea typeface="Aptos Display"/>
+                <a:cs typeface="Aptos Display"/>
+              </a:defRPr>
+            </a:pPr>
+            <a:r>
+              <a:rPr sz="1800" b="1">
+                <a:solidFill>
+                  <a:srgbClr val="875B11"/>
+                </a:solidFill>
+                <a:latin typeface="Aptos Display"/>
+                <a:ea typeface="Aptos Display"/>
+                <a:cs typeface="Aptos Display"/>
+              </a:rPr>
+              <a:t>Human review stays central</a:t>
+            </a:r>
+          </a:p>
+        </p:txBody>
       </p:sp>
     </p:spTree>
     <p:extLst>
       <p:ext uri="{BB962C8B-B14F-4D97-AF65-F5344CB8AC3E}">
-        <p14:creationId xmlns:p14="http://schemas.microsoft.com/office/powerpoint/2010/main" val="1403264745"/>
+        <p14:creationId xmlns:p14="http://schemas.microsoft.com/office/powerpoint/2010/main" val="761831590"/>
       </p:ext>
     </p:extLst>
   </p:cSld>
@@ -6892,7 +7613,7 @@
           <p:cNvPr id="1" name="">
             <a:extLst xmlns:a="http://schemas.openxmlformats.org/drawingml/2006/main">
               <a:ext uri="{FF2B5EF4-FFF2-40B4-BE49-F238E27FC236}">
-                <a16:creationId xmlns:a16="http://schemas.microsoft.com/office/drawing/2014/main" id="{A8BF77F5-70D7-45C8-A76B-CDC1049922D1}"/>
+                <a16:creationId xmlns:a16="http://schemas.microsoft.com/office/drawing/2014/main" id="{54BBFD17-9CC3-43F2-8B44-BA66202E511E}"/>
               </a:ext>
             </a:extLst>
           </p:cNvPr>
@@ -6927,7 +7648,7 @@
           <p:cNvPr id="2" name="kicker-marker">
             <a:extLst xmlns:a="http://schemas.openxmlformats.org/drawingml/2006/main">
               <a:ext uri="{FF2B5EF4-FFF2-40B4-BE49-F238E27FC236}">
-                <a16:creationId xmlns:a16="http://schemas.microsoft.com/office/drawing/2014/main" id="{ED3AD4AF-ADB7-4936-8C8D-48BA7E21DA18}"/>
+                <a16:creationId xmlns:a16="http://schemas.microsoft.com/office/drawing/2014/main" id="{6CCCFEBC-B49E-46C5-8654-CD0BB394DAB2}"/>
               </a:ext>
             </a:extLst>
           </p:cNvPr>
@@ -6962,7 +7683,7 @@
           <p:cNvPr id="3" name="kicker-label">
             <a:extLst xmlns:a="http://schemas.openxmlformats.org/drawingml/2006/main">
               <a:ext uri="{FF2B5EF4-FFF2-40B4-BE49-F238E27FC236}">
-                <a16:creationId xmlns:a16="http://schemas.microsoft.com/office/drawing/2014/main" id="{835DA3EC-71FB-4979-BC4D-9FCB3E8351D2}"/>
+                <a16:creationId xmlns:a16="http://schemas.microsoft.com/office/drawing/2014/main" id="{7B04AB83-93E3-409D-A95A-7C28ACC02BCB}"/>
               </a:ext>
             </a:extLst>
           </p:cNvPr>
@@ -7016,7 +7737,7 @@
                 <a:ea typeface="Aptos"/>
                 <a:cs typeface="Aptos"/>
               </a:rPr>
-              <a:t>UI WALKTHROUGH 2</a:t>
+              <a:t>WHAT THE APP DOES</a:t>
             </a:r>
           </a:p>
         </p:txBody>
@@ -7026,7 +7747,7 @@
           <p:cNvPr id="4" name="">
             <a:extLst xmlns:a="http://schemas.openxmlformats.org/drawingml/2006/main">
               <a:ext uri="{FF2B5EF4-FFF2-40B4-BE49-F238E27FC236}">
-                <a16:creationId xmlns:a16="http://schemas.microsoft.com/office/drawing/2014/main" id="{BC4E9576-952A-4899-8112-4009056CA339}"/>
+                <a16:creationId xmlns:a16="http://schemas.microsoft.com/office/drawing/2014/main" id="{9A8C0573-209D-4B2A-8F07-232FDC49BA9D}"/>
               </a:ext>
             </a:extLst>
           </p:cNvPr>
@@ -7080,7 +7801,7 @@
                 <a:ea typeface="Aptos Display"/>
                 <a:cs typeface="Aptos Display"/>
               </a:rPr>
-              <a:t>The evaluation tab compares SynthAML’s guided data against the simple baseline.</a:t>
+              <a:t>The application is a workbench for one narrow business workflow: typology intake to model QA export.</a:t>
             </a:r>
           </a:p>
         </p:txBody>
@@ -7090,7 +7811,7 @@
           <p:cNvPr id="5" name="">
             <a:extLst xmlns:a="http://schemas.openxmlformats.org/drawingml/2006/main">
               <a:ext uri="{FF2B5EF4-FFF2-40B4-BE49-F238E27FC236}">
-                <a16:creationId xmlns:a16="http://schemas.microsoft.com/office/drawing/2014/main" id="{A9AC5543-4F5E-4A83-93C9-A85D55B63779}"/>
+                <a16:creationId xmlns:a16="http://schemas.microsoft.com/office/drawing/2014/main" id="{2C4FFD2E-3BF2-44D4-8D31-56ED11E1BF45}"/>
               </a:ext>
             </a:extLst>
           </p:cNvPr>
@@ -7125,7 +7846,7 @@
           <p:cNvPr id="6" name="">
             <a:extLst xmlns:a="http://schemas.openxmlformats.org/drawingml/2006/main">
               <a:ext uri="{FF2B5EF4-FFF2-40B4-BE49-F238E27FC236}">
-                <a16:creationId xmlns:a16="http://schemas.microsoft.com/office/drawing/2014/main" id="{180FAACC-66FD-471D-A162-A776A1C5456C}"/>
+                <a16:creationId xmlns:a16="http://schemas.microsoft.com/office/drawing/2014/main" id="{A4BFD4BB-EB46-4D86-A996-91FB0CE5A322}"/>
               </a:ext>
             </a:extLst>
           </p:cNvPr>
@@ -7184,46 +7905,57 @@
           </a:p>
         </p:txBody>
       </p:sp>
-      <p:pic>
-        <p:nvPicPr>
-          <p:cNvPr id="7" name=""/>
-          <p:cNvPicPr>
-            <a:picLocks xmlns:a="http://schemas.openxmlformats.org/drawingml/2006/main" noChangeAspect="1"/>
-          </p:cNvPicPr>
-          <p:nvPr/>
-        </p:nvPicPr>
-        <p:blipFill>
-          <a:blip xmlns:r="http://schemas.openxmlformats.org/officeDocument/2006/relationships" xmlns:a="http://schemas.openxmlformats.org/drawingml/2006/main" r:embed="R1a83b971b76f4418"/>
-          <a:stretch xmlns:a="http://schemas.openxmlformats.org/drawingml/2006/main"/>
-        </p:blipFill>
-        <p:spPr>
-          <a:xfrm xmlns:a="http://schemas.openxmlformats.org/drawingml/2006/main">
-            <a:off x="2959244" y="1714500"/>
-            <a:ext cx="6273511" cy="4381500"/>
-          </a:xfrm>
-          <a:prstGeom xmlns:a="http://schemas.openxmlformats.org/drawingml/2006/main" prst="rect">
-            <a:avLst/>
-          </a:prstGeom>
-        </p:spPr>
-      </p:pic>
+      <p:sp>
+        <p:nvSpPr>
+          <p:cNvPr id="7" name="">
+            <a:extLst xmlns:a="http://schemas.openxmlformats.org/drawingml/2006/main">
+              <a:ext uri="{FF2B5EF4-FFF2-40B4-BE49-F238E27FC236}">
+                <a16:creationId xmlns:a16="http://schemas.microsoft.com/office/drawing/2014/main" id="{D4EDE8A4-4580-445C-AC04-A3315EFCD058}"/>
+              </a:ext>
+            </a:extLst>
+          </p:cNvPr>
+          <p:cNvSpPr>
+            <a:spLocks xmlns:a="http://schemas.openxmlformats.org/drawingml/2006/main" noGrp="1"/>
+          </p:cNvSpPr>
+          <p:nvPr/>
+        </p:nvSpPr>
+        <p:spPr>
+          <a:xfrm xmlns:a="http://schemas.openxmlformats.org/drawingml/2006/main">
+            <a:off x="914400" y="1809750"/>
+            <a:ext cx="9906000" cy="552450"/>
+          </a:xfrm>
+          <a:prstGeom xmlns:a="http://schemas.openxmlformats.org/drawingml/2006/main" prst="rect">
+            <a:avLst/>
+          </a:prstGeom>
+          <a:solidFill xmlns:a="http://schemas.openxmlformats.org/drawingml/2006/main">
+            <a:srgbClr val="FFFFFF"/>
+          </a:solidFill>
+          <a:ln xmlns:a="http://schemas.openxmlformats.org/drawingml/2006/main" w="9525">
+            <a:solidFill>
+              <a:srgbClr val="D8D0C0"/>
+            </a:solidFill>
+            <a:prstDash val="solid"/>
+          </a:ln>
+        </p:spPr>
+      </p:sp>
       <p:sp>
         <p:nvSpPr>
           <p:cNvPr id="8" name="">
             <a:extLst xmlns:a="http://schemas.openxmlformats.org/drawingml/2006/main">
               <a:ext uri="{FF2B5EF4-FFF2-40B4-BE49-F238E27FC236}">
-                <a16:creationId xmlns:a16="http://schemas.microsoft.com/office/drawing/2014/main" id="{A136A1EA-D5F3-4752-B05B-04ED04379C45}"/>
-              </a:ext>
-            </a:extLst>
-          </p:cNvPr>
-          <p:cNvSpPr>
-            <a:spLocks xmlns:a="http://schemas.openxmlformats.org/drawingml/2006/main" noGrp="1"/>
-          </p:cNvSpPr>
-          <p:nvPr/>
-        </p:nvSpPr>
-        <p:spPr>
-          <a:xfrm xmlns:a="http://schemas.openxmlformats.org/drawingml/2006/main">
-            <a:off x="2200275" y="1714500"/>
-            <a:ext cx="7791450" cy="4381500"/>
+                <a16:creationId xmlns:a16="http://schemas.microsoft.com/office/drawing/2014/main" id="{A081D1E5-F019-4286-B0AD-8EFEF704BED4}"/>
+              </a:ext>
+            </a:extLst>
+          </p:cNvPr>
+          <p:cNvSpPr>
+            <a:spLocks xmlns:a="http://schemas.openxmlformats.org/drawingml/2006/main" noGrp="1"/>
+          </p:cNvSpPr>
+          <p:nvPr/>
+        </p:nvSpPr>
+        <p:spPr>
+          <a:xfrm xmlns:a="http://schemas.openxmlformats.org/drawingml/2006/main">
+            <a:off x="1181100" y="1943100"/>
+            <a:ext cx="1809750" cy="266700"/>
           </a:xfrm>
           <a:prstGeom xmlns:a="http://schemas.openxmlformats.org/drawingml/2006/main" prst="rect">
             <a:avLst/>
@@ -7233,6 +7965,132 @@
               <a:alpha val="0"/>
             </a:srgbClr>
           </a:solidFill>
+          <a:ln xmlns:a="http://schemas.openxmlformats.org/drawingml/2006/main" w="0">
+            <a:solidFill>
+              <a:srgbClr val="000000">
+                <a:alpha val="0"/>
+              </a:srgbClr>
+            </a:solidFill>
+            <a:prstDash val="solid"/>
+          </a:ln>
+        </p:spPr>
+        <p:txBody>
+          <a:bodyPr xmlns:a="http://schemas.openxmlformats.org/drawingml/2006/main" lIns="0" tIns="0" rIns="0" bIns="0" anchor="t"/>
+          <a:lstStyle xmlns:a="http://schemas.openxmlformats.org/drawingml/2006/main"/>
+          <a:p xmlns:a="http://schemas.openxmlformats.org/drawingml/2006/main">
+            <a:pPr algn="l">
+              <a:defRPr sz="1425" b="1">
+                <a:solidFill>
+                  <a:srgbClr val="0E7C66"/>
+                </a:solidFill>
+                <a:latin typeface="Aptos"/>
+                <a:ea typeface="Aptos"/>
+                <a:cs typeface="Aptos"/>
+              </a:defRPr>
+            </a:pPr>
+            <a:r>
+              <a:rPr sz="1425" b="1">
+                <a:solidFill>
+                  <a:srgbClr val="0E7C66"/>
+                </a:solidFill>
+                <a:latin typeface="Aptos"/>
+                <a:ea typeface="Aptos"/>
+                <a:cs typeface="Aptos"/>
+              </a:rPr>
+              <a:t>1. Source intake</a:t>
+            </a:r>
+          </a:p>
+        </p:txBody>
+      </p:sp>
+      <p:sp>
+        <p:nvSpPr>
+          <p:cNvPr id="9" name="">
+            <a:extLst xmlns:a="http://schemas.openxmlformats.org/drawingml/2006/main">
+              <a:ext uri="{FF2B5EF4-FFF2-40B4-BE49-F238E27FC236}">
+                <a16:creationId xmlns:a16="http://schemas.microsoft.com/office/drawing/2014/main" id="{2956ADDC-593B-4BA6-AC1F-FA31BBFD5D06}"/>
+              </a:ext>
+            </a:extLst>
+          </p:cNvPr>
+          <p:cNvSpPr>
+            <a:spLocks xmlns:a="http://schemas.openxmlformats.org/drawingml/2006/main" noGrp="1"/>
+          </p:cNvSpPr>
+          <p:nvPr/>
+        </p:nvSpPr>
+        <p:spPr>
+          <a:xfrm xmlns:a="http://schemas.openxmlformats.org/drawingml/2006/main">
+            <a:off x="3143250" y="1943100"/>
+            <a:ext cx="7239000" cy="285750"/>
+          </a:xfrm>
+          <a:prstGeom xmlns:a="http://schemas.openxmlformats.org/drawingml/2006/main" prst="rect">
+            <a:avLst/>
+          </a:prstGeom>
+          <a:solidFill xmlns:a="http://schemas.openxmlformats.org/drawingml/2006/main">
+            <a:srgbClr val="000000">
+              <a:alpha val="0"/>
+            </a:srgbClr>
+          </a:solidFill>
+          <a:ln xmlns:a="http://schemas.openxmlformats.org/drawingml/2006/main" w="0">
+            <a:solidFill>
+              <a:srgbClr val="000000">
+                <a:alpha val="0"/>
+              </a:srgbClr>
+            </a:solidFill>
+            <a:prstDash val="solid"/>
+          </a:ln>
+        </p:spPr>
+        <p:txBody>
+          <a:bodyPr xmlns:a="http://schemas.openxmlformats.org/drawingml/2006/main" lIns="0" tIns="0" rIns="0" bIns="0" anchor="t"/>
+          <a:lstStyle xmlns:a="http://schemas.openxmlformats.org/drawingml/2006/main"/>
+          <a:p xmlns:a="http://schemas.openxmlformats.org/drawingml/2006/main">
+            <a:pPr algn="l">
+              <a:defRPr sz="1350" b="0">
+                <a:solidFill>
+                  <a:srgbClr val="14213D"/>
+                </a:solidFill>
+                <a:latin typeface="Aptos"/>
+                <a:ea typeface="Aptos"/>
+                <a:cs typeface="Aptos"/>
+              </a:defRPr>
+            </a:pPr>
+            <a:r>
+              <a:rPr sz="1350" b="0">
+                <a:solidFill>
+                  <a:srgbClr val="14213D"/>
+                </a:solidFill>
+                <a:latin typeface="Aptos"/>
+                <a:ea typeface="Aptos"/>
+                <a:cs typeface="Aptos"/>
+              </a:rPr>
+              <a:t>Import the regulatory alert or internal typology note and preserve source traceability.</a:t>
+            </a:r>
+          </a:p>
+        </p:txBody>
+      </p:sp>
+      <p:sp>
+        <p:nvSpPr>
+          <p:cNvPr id="10" name="">
+            <a:extLst xmlns:a="http://schemas.openxmlformats.org/drawingml/2006/main">
+              <a:ext uri="{FF2B5EF4-FFF2-40B4-BE49-F238E27FC236}">
+                <a16:creationId xmlns:a16="http://schemas.microsoft.com/office/drawing/2014/main" id="{F31CD1BF-5296-4654-91B4-B5A4B5379EAF}"/>
+              </a:ext>
+            </a:extLst>
+          </p:cNvPr>
+          <p:cNvSpPr>
+            <a:spLocks xmlns:a="http://schemas.openxmlformats.org/drawingml/2006/main" noGrp="1"/>
+          </p:cNvSpPr>
+          <p:nvPr/>
+        </p:nvSpPr>
+        <p:spPr>
+          <a:xfrm xmlns:a="http://schemas.openxmlformats.org/drawingml/2006/main">
+            <a:off x="914400" y="2590800"/>
+            <a:ext cx="9906000" cy="552450"/>
+          </a:xfrm>
+          <a:prstGeom xmlns:a="http://schemas.openxmlformats.org/drawingml/2006/main" prst="rect">
+            <a:avLst/>
+          </a:prstGeom>
+          <a:solidFill xmlns:a="http://schemas.openxmlformats.org/drawingml/2006/main">
+            <a:srgbClr val="FBFAF6"/>
+          </a:solidFill>
           <a:ln xmlns:a="http://schemas.openxmlformats.org/drawingml/2006/main" w="9525">
             <a:solidFill>
               <a:srgbClr val="D8D0C0"/>
@@ -7240,11 +8098,686 @@
             <a:prstDash val="solid"/>
           </a:ln>
         </p:spPr>
+      </p:sp>
+      <p:sp>
+        <p:nvSpPr>
+          <p:cNvPr id="11" name="">
+            <a:extLst xmlns:a="http://schemas.openxmlformats.org/drawingml/2006/main">
+              <a:ext uri="{FF2B5EF4-FFF2-40B4-BE49-F238E27FC236}">
+                <a16:creationId xmlns:a16="http://schemas.microsoft.com/office/drawing/2014/main" id="{D2086386-182E-40F9-AAFF-DD28322003C8}"/>
+              </a:ext>
+            </a:extLst>
+          </p:cNvPr>
+          <p:cNvSpPr>
+            <a:spLocks xmlns:a="http://schemas.openxmlformats.org/drawingml/2006/main" noGrp="1"/>
+          </p:cNvSpPr>
+          <p:nvPr/>
+        </p:nvSpPr>
+        <p:spPr>
+          <a:xfrm xmlns:a="http://schemas.openxmlformats.org/drawingml/2006/main">
+            <a:off x="1181100" y="2724150"/>
+            <a:ext cx="1809750" cy="266700"/>
+          </a:xfrm>
+          <a:prstGeom xmlns:a="http://schemas.openxmlformats.org/drawingml/2006/main" prst="rect">
+            <a:avLst/>
+          </a:prstGeom>
+          <a:solidFill xmlns:a="http://schemas.openxmlformats.org/drawingml/2006/main">
+            <a:srgbClr val="000000">
+              <a:alpha val="0"/>
+            </a:srgbClr>
+          </a:solidFill>
+          <a:ln xmlns:a="http://schemas.openxmlformats.org/drawingml/2006/main" w="0">
+            <a:solidFill>
+              <a:srgbClr val="000000">
+                <a:alpha val="0"/>
+              </a:srgbClr>
+            </a:solidFill>
+            <a:prstDash val="solid"/>
+          </a:ln>
+        </p:spPr>
+        <p:txBody>
+          <a:bodyPr xmlns:a="http://schemas.openxmlformats.org/drawingml/2006/main" lIns="0" tIns="0" rIns="0" bIns="0" anchor="t"/>
+          <a:lstStyle xmlns:a="http://schemas.openxmlformats.org/drawingml/2006/main"/>
+          <a:p xmlns:a="http://schemas.openxmlformats.org/drawingml/2006/main">
+            <a:pPr algn="l">
+              <a:defRPr sz="1425" b="1">
+                <a:solidFill>
+                  <a:srgbClr val="0E7C66"/>
+                </a:solidFill>
+                <a:latin typeface="Aptos"/>
+                <a:ea typeface="Aptos"/>
+                <a:cs typeface="Aptos"/>
+              </a:defRPr>
+            </a:pPr>
+            <a:r>
+              <a:rPr sz="1425" b="1">
+                <a:solidFill>
+                  <a:srgbClr val="0E7C66"/>
+                </a:solidFill>
+                <a:latin typeface="Aptos"/>
+                <a:ea typeface="Aptos"/>
+                <a:cs typeface="Aptos"/>
+              </a:rPr>
+              <a:t>2. Scenario review</a:t>
+            </a:r>
+          </a:p>
+        </p:txBody>
+      </p:sp>
+      <p:sp>
+        <p:nvSpPr>
+          <p:cNvPr id="12" name="">
+            <a:extLst xmlns:a="http://schemas.openxmlformats.org/drawingml/2006/main">
+              <a:ext uri="{FF2B5EF4-FFF2-40B4-BE49-F238E27FC236}">
+                <a16:creationId xmlns:a16="http://schemas.microsoft.com/office/drawing/2014/main" id="{70F7B408-472C-4078-97BD-ED99C653AD2C}"/>
+              </a:ext>
+            </a:extLst>
+          </p:cNvPr>
+          <p:cNvSpPr>
+            <a:spLocks xmlns:a="http://schemas.openxmlformats.org/drawingml/2006/main" noGrp="1"/>
+          </p:cNvSpPr>
+          <p:nvPr/>
+        </p:nvSpPr>
+        <p:spPr>
+          <a:xfrm xmlns:a="http://schemas.openxmlformats.org/drawingml/2006/main">
+            <a:off x="3143250" y="2724150"/>
+            <a:ext cx="7239000" cy="285750"/>
+          </a:xfrm>
+          <a:prstGeom xmlns:a="http://schemas.openxmlformats.org/drawingml/2006/main" prst="rect">
+            <a:avLst/>
+          </a:prstGeom>
+          <a:solidFill xmlns:a="http://schemas.openxmlformats.org/drawingml/2006/main">
+            <a:srgbClr val="000000">
+              <a:alpha val="0"/>
+            </a:srgbClr>
+          </a:solidFill>
+          <a:ln xmlns:a="http://schemas.openxmlformats.org/drawingml/2006/main" w="0">
+            <a:solidFill>
+              <a:srgbClr val="000000">
+                <a:alpha val="0"/>
+              </a:srgbClr>
+            </a:solidFill>
+            <a:prstDash val="solid"/>
+          </a:ln>
+        </p:spPr>
+        <p:txBody>
+          <a:bodyPr xmlns:a="http://schemas.openxmlformats.org/drawingml/2006/main" lIns="0" tIns="0" rIns="0" bIns="0" anchor="t"/>
+          <a:lstStyle xmlns:a="http://schemas.openxmlformats.org/drawingml/2006/main"/>
+          <a:p xmlns:a="http://schemas.openxmlformats.org/drawingml/2006/main">
+            <a:pPr algn="l">
+              <a:defRPr sz="1350" b="0">
+                <a:solidFill>
+                  <a:srgbClr val="14213D"/>
+                </a:solidFill>
+                <a:latin typeface="Aptos"/>
+                <a:ea typeface="Aptos"/>
+                <a:cs typeface="Aptos"/>
+              </a:defRPr>
+            </a:pPr>
+            <a:r>
+              <a:rPr sz="1350" b="0">
+                <a:solidFill>
+                  <a:srgbClr val="14213D"/>
+                </a:solidFill>
+                <a:latin typeface="Aptos"/>
+                <a:ea typeface="Aptos"/>
+                <a:cs typeface="Aptos"/>
+              </a:rPr>
+              <a:t>Let the analyst approve amounts, regions, split counts, timing windows, and narratives.</a:t>
+            </a:r>
+          </a:p>
+        </p:txBody>
+      </p:sp>
+      <p:sp>
+        <p:nvSpPr>
+          <p:cNvPr id="13" name="">
+            <a:extLst xmlns:a="http://schemas.openxmlformats.org/drawingml/2006/main">
+              <a:ext uri="{FF2B5EF4-FFF2-40B4-BE49-F238E27FC236}">
+                <a16:creationId xmlns:a16="http://schemas.microsoft.com/office/drawing/2014/main" id="{D0420028-BDA9-46BB-B304-E9343684333A}"/>
+              </a:ext>
+            </a:extLst>
+          </p:cNvPr>
+          <p:cNvSpPr>
+            <a:spLocks xmlns:a="http://schemas.openxmlformats.org/drawingml/2006/main" noGrp="1"/>
+          </p:cNvSpPr>
+          <p:nvPr/>
+        </p:nvSpPr>
+        <p:spPr>
+          <a:xfrm xmlns:a="http://schemas.openxmlformats.org/drawingml/2006/main">
+            <a:off x="914400" y="3371850"/>
+            <a:ext cx="9906000" cy="552450"/>
+          </a:xfrm>
+          <a:prstGeom xmlns:a="http://schemas.openxmlformats.org/drawingml/2006/main" prst="rect">
+            <a:avLst/>
+          </a:prstGeom>
+          <a:solidFill xmlns:a="http://schemas.openxmlformats.org/drawingml/2006/main">
+            <a:srgbClr val="FFFFFF"/>
+          </a:solidFill>
+          <a:ln xmlns:a="http://schemas.openxmlformats.org/drawingml/2006/main" w="9525">
+            <a:solidFill>
+              <a:srgbClr val="D8D0C0"/>
+            </a:solidFill>
+            <a:prstDash val="solid"/>
+          </a:ln>
+        </p:spPr>
+      </p:sp>
+      <p:sp>
+        <p:nvSpPr>
+          <p:cNvPr id="14" name="">
+            <a:extLst xmlns:a="http://schemas.openxmlformats.org/drawingml/2006/main">
+              <a:ext uri="{FF2B5EF4-FFF2-40B4-BE49-F238E27FC236}">
+                <a16:creationId xmlns:a16="http://schemas.microsoft.com/office/drawing/2014/main" id="{3970F837-1548-4718-B97D-05312DA3E0A4}"/>
+              </a:ext>
+            </a:extLst>
+          </p:cNvPr>
+          <p:cNvSpPr>
+            <a:spLocks xmlns:a="http://schemas.openxmlformats.org/drawingml/2006/main" noGrp="1"/>
+          </p:cNvSpPr>
+          <p:nvPr/>
+        </p:nvSpPr>
+        <p:spPr>
+          <a:xfrm xmlns:a="http://schemas.openxmlformats.org/drawingml/2006/main">
+            <a:off x="1181100" y="3505200"/>
+            <a:ext cx="1809750" cy="266700"/>
+          </a:xfrm>
+          <a:prstGeom xmlns:a="http://schemas.openxmlformats.org/drawingml/2006/main" prst="rect">
+            <a:avLst/>
+          </a:prstGeom>
+          <a:solidFill xmlns:a="http://schemas.openxmlformats.org/drawingml/2006/main">
+            <a:srgbClr val="000000">
+              <a:alpha val="0"/>
+            </a:srgbClr>
+          </a:solidFill>
+          <a:ln xmlns:a="http://schemas.openxmlformats.org/drawingml/2006/main" w="0">
+            <a:solidFill>
+              <a:srgbClr val="000000">
+                <a:alpha val="0"/>
+              </a:srgbClr>
+            </a:solidFill>
+            <a:prstDash val="solid"/>
+          </a:ln>
+        </p:spPr>
+        <p:txBody>
+          <a:bodyPr xmlns:a="http://schemas.openxmlformats.org/drawingml/2006/main" lIns="0" tIns="0" rIns="0" bIns="0" anchor="t"/>
+          <a:lstStyle xmlns:a="http://schemas.openxmlformats.org/drawingml/2006/main"/>
+          <a:p xmlns:a="http://schemas.openxmlformats.org/drawingml/2006/main">
+            <a:pPr algn="l">
+              <a:defRPr sz="1425" b="1">
+                <a:solidFill>
+                  <a:srgbClr val="0E7C66"/>
+                </a:solidFill>
+                <a:latin typeface="Aptos"/>
+                <a:ea typeface="Aptos"/>
+                <a:cs typeface="Aptos"/>
+              </a:defRPr>
+            </a:pPr>
+            <a:r>
+              <a:rPr sz="1425" b="1">
+                <a:solidFill>
+                  <a:srgbClr val="0E7C66"/>
+                </a:solidFill>
+                <a:latin typeface="Aptos"/>
+                <a:ea typeface="Aptos"/>
+                <a:cs typeface="Aptos"/>
+              </a:rPr>
+              <a:t>3. Generation plan</a:t>
+            </a:r>
+          </a:p>
+        </p:txBody>
+      </p:sp>
+      <p:sp>
+        <p:nvSpPr>
+          <p:cNvPr id="15" name="">
+            <a:extLst xmlns:a="http://schemas.openxmlformats.org/drawingml/2006/main">
+              <a:ext uri="{FF2B5EF4-FFF2-40B4-BE49-F238E27FC236}">
+                <a16:creationId xmlns:a16="http://schemas.microsoft.com/office/drawing/2014/main" id="{E37DE179-D970-4BD4-9512-EB352FC7020C}"/>
+              </a:ext>
+            </a:extLst>
+          </p:cNvPr>
+          <p:cNvSpPr>
+            <a:spLocks xmlns:a="http://schemas.openxmlformats.org/drawingml/2006/main" noGrp="1"/>
+          </p:cNvSpPr>
+          <p:nvPr/>
+        </p:nvSpPr>
+        <p:spPr>
+          <a:xfrm xmlns:a="http://schemas.openxmlformats.org/drawingml/2006/main">
+            <a:off x="3143250" y="3505200"/>
+            <a:ext cx="7239000" cy="285750"/>
+          </a:xfrm>
+          <a:prstGeom xmlns:a="http://schemas.openxmlformats.org/drawingml/2006/main" prst="rect">
+            <a:avLst/>
+          </a:prstGeom>
+          <a:solidFill xmlns:a="http://schemas.openxmlformats.org/drawingml/2006/main">
+            <a:srgbClr val="000000">
+              <a:alpha val="0"/>
+            </a:srgbClr>
+          </a:solidFill>
+          <a:ln xmlns:a="http://schemas.openxmlformats.org/drawingml/2006/main" w="0">
+            <a:solidFill>
+              <a:srgbClr val="000000">
+                <a:alpha val="0"/>
+              </a:srgbClr>
+            </a:solidFill>
+            <a:prstDash val="solid"/>
+          </a:ln>
+        </p:spPr>
+        <p:txBody>
+          <a:bodyPr xmlns:a="http://schemas.openxmlformats.org/drawingml/2006/main" lIns="0" tIns="0" rIns="0" bIns="0" anchor="t"/>
+          <a:lstStyle xmlns:a="http://schemas.openxmlformats.org/drawingml/2006/main"/>
+          <a:p xmlns:a="http://schemas.openxmlformats.org/drawingml/2006/main">
+            <a:pPr algn="l">
+              <a:defRPr sz="1350" b="0">
+                <a:solidFill>
+                  <a:srgbClr val="14213D"/>
+                </a:solidFill>
+                <a:latin typeface="Aptos"/>
+                <a:ea typeface="Aptos"/>
+                <a:cs typeface="Aptos"/>
+              </a:defRPr>
+            </a:pPr>
+            <a:r>
+              <a:rPr sz="1350" b="0">
+                <a:solidFill>
+                  <a:srgbClr val="14213D"/>
+                </a:solidFill>
+                <a:latin typeface="Aptos"/>
+                <a:ea typeface="Aptos"/>
+                <a:cs typeface="Aptos"/>
+              </a:rPr>
+              <a:t>Create synthetic background traffic plus suspicious chains that conserve funds.</a:t>
+            </a:r>
+          </a:p>
+        </p:txBody>
+      </p:sp>
+      <p:sp>
+        <p:nvSpPr>
+          <p:cNvPr id="16" name="">
+            <a:extLst xmlns:a="http://schemas.openxmlformats.org/drawingml/2006/main">
+              <a:ext uri="{FF2B5EF4-FFF2-40B4-BE49-F238E27FC236}">
+                <a16:creationId xmlns:a16="http://schemas.microsoft.com/office/drawing/2014/main" id="{0BE47C55-4711-428E-AEB8-AF4FDC5660C7}"/>
+              </a:ext>
+            </a:extLst>
+          </p:cNvPr>
+          <p:cNvSpPr>
+            <a:spLocks xmlns:a="http://schemas.openxmlformats.org/drawingml/2006/main" noGrp="1"/>
+          </p:cNvSpPr>
+          <p:nvPr/>
+        </p:nvSpPr>
+        <p:spPr>
+          <a:xfrm xmlns:a="http://schemas.openxmlformats.org/drawingml/2006/main">
+            <a:off x="914400" y="4152900"/>
+            <a:ext cx="9906000" cy="552450"/>
+          </a:xfrm>
+          <a:prstGeom xmlns:a="http://schemas.openxmlformats.org/drawingml/2006/main" prst="rect">
+            <a:avLst/>
+          </a:prstGeom>
+          <a:solidFill xmlns:a="http://schemas.openxmlformats.org/drawingml/2006/main">
+            <a:srgbClr val="FBFAF6"/>
+          </a:solidFill>
+          <a:ln xmlns:a="http://schemas.openxmlformats.org/drawingml/2006/main" w="9525">
+            <a:solidFill>
+              <a:srgbClr val="D8D0C0"/>
+            </a:solidFill>
+            <a:prstDash val="solid"/>
+          </a:ln>
+        </p:spPr>
+      </p:sp>
+      <p:sp>
+        <p:nvSpPr>
+          <p:cNvPr id="17" name="">
+            <a:extLst xmlns:a="http://schemas.openxmlformats.org/drawingml/2006/main">
+              <a:ext uri="{FF2B5EF4-FFF2-40B4-BE49-F238E27FC236}">
+                <a16:creationId xmlns:a16="http://schemas.microsoft.com/office/drawing/2014/main" id="{1F509EE9-48E9-4F4D-91DB-B0AF1C1A64BF}"/>
+              </a:ext>
+            </a:extLst>
+          </p:cNvPr>
+          <p:cNvSpPr>
+            <a:spLocks xmlns:a="http://schemas.openxmlformats.org/drawingml/2006/main" noGrp="1"/>
+          </p:cNvSpPr>
+          <p:nvPr/>
+        </p:nvSpPr>
+        <p:spPr>
+          <a:xfrm xmlns:a="http://schemas.openxmlformats.org/drawingml/2006/main">
+            <a:off x="1181100" y="4286250"/>
+            <a:ext cx="1809750" cy="266700"/>
+          </a:xfrm>
+          <a:prstGeom xmlns:a="http://schemas.openxmlformats.org/drawingml/2006/main" prst="rect">
+            <a:avLst/>
+          </a:prstGeom>
+          <a:solidFill xmlns:a="http://schemas.openxmlformats.org/drawingml/2006/main">
+            <a:srgbClr val="000000">
+              <a:alpha val="0"/>
+            </a:srgbClr>
+          </a:solidFill>
+          <a:ln xmlns:a="http://schemas.openxmlformats.org/drawingml/2006/main" w="0">
+            <a:solidFill>
+              <a:srgbClr val="000000">
+                <a:alpha val="0"/>
+              </a:srgbClr>
+            </a:solidFill>
+            <a:prstDash val="solid"/>
+          </a:ln>
+        </p:spPr>
+        <p:txBody>
+          <a:bodyPr xmlns:a="http://schemas.openxmlformats.org/drawingml/2006/main" lIns="0" tIns="0" rIns="0" bIns="0" anchor="t"/>
+          <a:lstStyle xmlns:a="http://schemas.openxmlformats.org/drawingml/2006/main"/>
+          <a:p xmlns:a="http://schemas.openxmlformats.org/drawingml/2006/main">
+            <a:pPr algn="l">
+              <a:defRPr sz="1425" b="1">
+                <a:solidFill>
+                  <a:srgbClr val="0E7C66"/>
+                </a:solidFill>
+                <a:latin typeface="Aptos"/>
+                <a:ea typeface="Aptos"/>
+                <a:cs typeface="Aptos"/>
+              </a:defRPr>
+            </a:pPr>
+            <a:r>
+              <a:rPr sz="1425" b="1">
+                <a:solidFill>
+                  <a:srgbClr val="0E7C66"/>
+                </a:solidFill>
+                <a:latin typeface="Aptos"/>
+                <a:ea typeface="Aptos"/>
+                <a:cs typeface="Aptos"/>
+              </a:rPr>
+              <a:t>4. Ledger analysis</a:t>
+            </a:r>
+          </a:p>
+        </p:txBody>
+      </p:sp>
+      <p:sp>
+        <p:nvSpPr>
+          <p:cNvPr id="18" name="">
+            <a:extLst xmlns:a="http://schemas.openxmlformats.org/drawingml/2006/main">
+              <a:ext uri="{FF2B5EF4-FFF2-40B4-BE49-F238E27FC236}">
+                <a16:creationId xmlns:a16="http://schemas.microsoft.com/office/drawing/2014/main" id="{CC56828B-E7C1-43BB-AD9A-DFBABCF5B20A}"/>
+              </a:ext>
+            </a:extLst>
+          </p:cNvPr>
+          <p:cNvSpPr>
+            <a:spLocks xmlns:a="http://schemas.openxmlformats.org/drawingml/2006/main" noGrp="1"/>
+          </p:cNvSpPr>
+          <p:nvPr/>
+        </p:nvSpPr>
+        <p:spPr>
+          <a:xfrm xmlns:a="http://schemas.openxmlformats.org/drawingml/2006/main">
+            <a:off x="3143250" y="4286250"/>
+            <a:ext cx="7239000" cy="285750"/>
+          </a:xfrm>
+          <a:prstGeom xmlns:a="http://schemas.openxmlformats.org/drawingml/2006/main" prst="rect">
+            <a:avLst/>
+          </a:prstGeom>
+          <a:solidFill xmlns:a="http://schemas.openxmlformats.org/drawingml/2006/main">
+            <a:srgbClr val="000000">
+              <a:alpha val="0"/>
+            </a:srgbClr>
+          </a:solidFill>
+          <a:ln xmlns:a="http://schemas.openxmlformats.org/drawingml/2006/main" w="0">
+            <a:solidFill>
+              <a:srgbClr val="000000">
+                <a:alpha val="0"/>
+              </a:srgbClr>
+            </a:solidFill>
+            <a:prstDash val="solid"/>
+          </a:ln>
+        </p:spPr>
+        <p:txBody>
+          <a:bodyPr xmlns:a="http://schemas.openxmlformats.org/drawingml/2006/main" lIns="0" tIns="0" rIns="0" bIns="0" anchor="t"/>
+          <a:lstStyle xmlns:a="http://schemas.openxmlformats.org/drawingml/2006/main"/>
+          <a:p xmlns:a="http://schemas.openxmlformats.org/drawingml/2006/main">
+            <a:pPr algn="l">
+              <a:defRPr sz="1350" b="0">
+                <a:solidFill>
+                  <a:srgbClr val="14213D"/>
+                </a:solidFill>
+                <a:latin typeface="Aptos"/>
+                <a:ea typeface="Aptos"/>
+                <a:cs typeface="Aptos"/>
+              </a:defRPr>
+            </a:pPr>
+            <a:r>
+              <a:rPr sz="1350" b="0">
+                <a:solidFill>
+                  <a:srgbClr val="14213D"/>
+                </a:solidFill>
+                <a:latin typeface="Aptos"/>
+                <a:ea typeface="Aptos"/>
+                <a:cs typeface="Aptos"/>
+              </a:rPr>
+              <a:t>Filter and inspect transaction rows, chain IDs, labels, and risk signals.</a:t>
+            </a:r>
+          </a:p>
+        </p:txBody>
+      </p:sp>
+      <p:sp>
+        <p:nvSpPr>
+          <p:cNvPr id="19" name="">
+            <a:extLst xmlns:a="http://schemas.openxmlformats.org/drawingml/2006/main">
+              <a:ext uri="{FF2B5EF4-FFF2-40B4-BE49-F238E27FC236}">
+                <a16:creationId xmlns:a16="http://schemas.microsoft.com/office/drawing/2014/main" id="{09D9FA7B-748A-4817-972B-6C891FD1EEBA}"/>
+              </a:ext>
+            </a:extLst>
+          </p:cNvPr>
+          <p:cNvSpPr>
+            <a:spLocks xmlns:a="http://schemas.openxmlformats.org/drawingml/2006/main" noGrp="1"/>
+          </p:cNvSpPr>
+          <p:nvPr/>
+        </p:nvSpPr>
+        <p:spPr>
+          <a:xfrm xmlns:a="http://schemas.openxmlformats.org/drawingml/2006/main">
+            <a:off x="914400" y="4933950"/>
+            <a:ext cx="9906000" cy="552450"/>
+          </a:xfrm>
+          <a:prstGeom xmlns:a="http://schemas.openxmlformats.org/drawingml/2006/main" prst="rect">
+            <a:avLst/>
+          </a:prstGeom>
+          <a:solidFill xmlns:a="http://schemas.openxmlformats.org/drawingml/2006/main">
+            <a:srgbClr val="FFFFFF"/>
+          </a:solidFill>
+          <a:ln xmlns:a="http://schemas.openxmlformats.org/drawingml/2006/main" w="9525">
+            <a:solidFill>
+              <a:srgbClr val="D8D0C0"/>
+            </a:solidFill>
+            <a:prstDash val="solid"/>
+          </a:ln>
+        </p:spPr>
+      </p:sp>
+      <p:sp>
+        <p:nvSpPr>
+          <p:cNvPr id="20" name="">
+            <a:extLst xmlns:a="http://schemas.openxmlformats.org/drawingml/2006/main">
+              <a:ext uri="{FF2B5EF4-FFF2-40B4-BE49-F238E27FC236}">
+                <a16:creationId xmlns:a16="http://schemas.microsoft.com/office/drawing/2014/main" id="{45FA62A9-D48E-4FBE-98B7-F344CF688EF8}"/>
+              </a:ext>
+            </a:extLst>
+          </p:cNvPr>
+          <p:cNvSpPr>
+            <a:spLocks xmlns:a="http://schemas.openxmlformats.org/drawingml/2006/main" noGrp="1"/>
+          </p:cNvSpPr>
+          <p:nvPr/>
+        </p:nvSpPr>
+        <p:spPr>
+          <a:xfrm xmlns:a="http://schemas.openxmlformats.org/drawingml/2006/main">
+            <a:off x="1181100" y="5067300"/>
+            <a:ext cx="1809750" cy="266700"/>
+          </a:xfrm>
+          <a:prstGeom xmlns:a="http://schemas.openxmlformats.org/drawingml/2006/main" prst="rect">
+            <a:avLst/>
+          </a:prstGeom>
+          <a:solidFill xmlns:a="http://schemas.openxmlformats.org/drawingml/2006/main">
+            <a:srgbClr val="000000">
+              <a:alpha val="0"/>
+            </a:srgbClr>
+          </a:solidFill>
+          <a:ln xmlns:a="http://schemas.openxmlformats.org/drawingml/2006/main" w="0">
+            <a:solidFill>
+              <a:srgbClr val="000000">
+                <a:alpha val="0"/>
+              </a:srgbClr>
+            </a:solidFill>
+            <a:prstDash val="solid"/>
+          </a:ln>
+        </p:spPr>
+        <p:txBody>
+          <a:bodyPr xmlns:a="http://schemas.openxmlformats.org/drawingml/2006/main" lIns="0" tIns="0" rIns="0" bIns="0" anchor="t"/>
+          <a:lstStyle xmlns:a="http://schemas.openxmlformats.org/drawingml/2006/main"/>
+          <a:p xmlns:a="http://schemas.openxmlformats.org/drawingml/2006/main">
+            <a:pPr algn="l">
+              <a:defRPr sz="1425" b="1">
+                <a:solidFill>
+                  <a:srgbClr val="0E7C66"/>
+                </a:solidFill>
+                <a:latin typeface="Aptos"/>
+                <a:ea typeface="Aptos"/>
+                <a:cs typeface="Aptos"/>
+              </a:defRPr>
+            </a:pPr>
+            <a:r>
+              <a:rPr sz="1425" b="1">
+                <a:solidFill>
+                  <a:srgbClr val="0E7C66"/>
+                </a:solidFill>
+                <a:latin typeface="Aptos"/>
+                <a:ea typeface="Aptos"/>
+                <a:cs typeface="Aptos"/>
+              </a:rPr>
+              <a:t>5. Evaluation + export</a:t>
+            </a:r>
+          </a:p>
+        </p:txBody>
+      </p:sp>
+      <p:sp>
+        <p:nvSpPr>
+          <p:cNvPr id="21" name="">
+            <a:extLst xmlns:a="http://schemas.openxmlformats.org/drawingml/2006/main">
+              <a:ext uri="{FF2B5EF4-FFF2-40B4-BE49-F238E27FC236}">
+                <a16:creationId xmlns:a16="http://schemas.microsoft.com/office/drawing/2014/main" id="{75269A0B-8B44-49B3-8E97-9428AD60806F}"/>
+              </a:ext>
+            </a:extLst>
+          </p:cNvPr>
+          <p:cNvSpPr>
+            <a:spLocks xmlns:a="http://schemas.openxmlformats.org/drawingml/2006/main" noGrp="1"/>
+          </p:cNvSpPr>
+          <p:nvPr/>
+        </p:nvSpPr>
+        <p:spPr>
+          <a:xfrm xmlns:a="http://schemas.openxmlformats.org/drawingml/2006/main">
+            <a:off x="3143250" y="5067300"/>
+            <a:ext cx="7239000" cy="285750"/>
+          </a:xfrm>
+          <a:prstGeom xmlns:a="http://schemas.openxmlformats.org/drawingml/2006/main" prst="rect">
+            <a:avLst/>
+          </a:prstGeom>
+          <a:solidFill xmlns:a="http://schemas.openxmlformats.org/drawingml/2006/main">
+            <a:srgbClr val="000000">
+              <a:alpha val="0"/>
+            </a:srgbClr>
+          </a:solidFill>
+          <a:ln xmlns:a="http://schemas.openxmlformats.org/drawingml/2006/main" w="0">
+            <a:solidFill>
+              <a:srgbClr val="000000">
+                <a:alpha val="0"/>
+              </a:srgbClr>
+            </a:solidFill>
+            <a:prstDash val="solid"/>
+          </a:ln>
+        </p:spPr>
+        <p:txBody>
+          <a:bodyPr xmlns:a="http://schemas.openxmlformats.org/drawingml/2006/main" lIns="0" tIns="0" rIns="0" bIns="0" anchor="t"/>
+          <a:lstStyle xmlns:a="http://schemas.openxmlformats.org/drawingml/2006/main"/>
+          <a:p xmlns:a="http://schemas.openxmlformats.org/drawingml/2006/main">
+            <a:pPr algn="l">
+              <a:defRPr sz="1350" b="0">
+                <a:solidFill>
+                  <a:srgbClr val="14213D"/>
+                </a:solidFill>
+                <a:latin typeface="Aptos"/>
+                <a:ea typeface="Aptos"/>
+                <a:cs typeface="Aptos"/>
+              </a:defRPr>
+            </a:pPr>
+            <a:r>
+              <a:rPr sz="1350" b="0">
+                <a:solidFill>
+                  <a:srgbClr val="14213D"/>
+                </a:solidFill>
+                <a:latin typeface="Aptos"/>
+                <a:ea typeface="Aptos"/>
+                <a:cs typeface="Aptos"/>
+              </a:rPr>
+              <a:t>Compare against the baseline and download the QA package.</a:t>
+            </a:r>
+          </a:p>
+        </p:txBody>
+      </p:sp>
+      <p:sp>
+        <p:nvSpPr>
+          <p:cNvPr id="22" name="">
+            <a:extLst xmlns:a="http://schemas.openxmlformats.org/drawingml/2006/main">
+              <a:ext uri="{FF2B5EF4-FFF2-40B4-BE49-F238E27FC236}">
+                <a16:creationId xmlns:a16="http://schemas.microsoft.com/office/drawing/2014/main" id="{2D344567-0FE2-416B-9839-BA2EC5FF75E6}"/>
+              </a:ext>
+            </a:extLst>
+          </p:cNvPr>
+          <p:cNvSpPr>
+            <a:spLocks xmlns:a="http://schemas.openxmlformats.org/drawingml/2006/main" noGrp="1"/>
+          </p:cNvSpPr>
+          <p:nvPr/>
+        </p:nvSpPr>
+        <p:spPr>
+          <a:xfrm xmlns:a="http://schemas.openxmlformats.org/drawingml/2006/main">
+            <a:off x="1257300" y="5829300"/>
+            <a:ext cx="8953500" cy="323850"/>
+          </a:xfrm>
+          <a:prstGeom xmlns:a="http://schemas.openxmlformats.org/drawingml/2006/main" prst="rect">
+            <a:avLst/>
+          </a:prstGeom>
+          <a:solidFill xmlns:a="http://schemas.openxmlformats.org/drawingml/2006/main">
+            <a:srgbClr val="000000">
+              <a:alpha val="0"/>
+            </a:srgbClr>
+          </a:solidFill>
+          <a:ln xmlns:a="http://schemas.openxmlformats.org/drawingml/2006/main" w="0">
+            <a:solidFill>
+              <a:srgbClr val="000000">
+                <a:alpha val="0"/>
+              </a:srgbClr>
+            </a:solidFill>
+            <a:prstDash val="solid"/>
+          </a:ln>
+        </p:spPr>
+        <p:txBody>
+          <a:bodyPr xmlns:a="http://schemas.openxmlformats.org/drawingml/2006/main" lIns="0" tIns="0" rIns="0" bIns="0" anchor="t"/>
+          <a:lstStyle xmlns:a="http://schemas.openxmlformats.org/drawingml/2006/main"/>
+          <a:p xmlns:a="http://schemas.openxmlformats.org/drawingml/2006/main">
+            <a:pPr algn="ctr">
+              <a:defRPr sz="1200" b="0">
+                <a:solidFill>
+                  <a:srgbClr val="3D405B"/>
+                </a:solidFill>
+                <a:latin typeface="Aptos"/>
+                <a:ea typeface="Aptos"/>
+                <a:cs typeface="Aptos"/>
+              </a:defRPr>
+            </a:pPr>
+            <a:r>
+              <a:rPr sz="1200" b="0">
+                <a:solidFill>
+                  <a:srgbClr val="3D405B"/>
+                </a:solidFill>
+                <a:latin typeface="Aptos"/>
+                <a:ea typeface="Aptos"/>
+                <a:cs typeface="Aptos"/>
+              </a:rPr>
+              <a:t>Commercial framing: this is not a generic chatbot. It is a structured operating surface for a repeatable compliance data workflow.</a:t>
+            </a:r>
+          </a:p>
+        </p:txBody>
       </p:sp>
     </p:spTree>
     <p:extLst>
       <p:ext uri="{BB962C8B-B14F-4D97-AF65-F5344CB8AC3E}">
-        <p14:creationId xmlns:p14="http://schemas.microsoft.com/office/powerpoint/2010/main" val="1223509133"/>
+        <p14:creationId xmlns:p14="http://schemas.microsoft.com/office/powerpoint/2010/main" val="675409049"/>
       </p:ext>
     </p:extLst>
   </p:cSld>
@@ -7268,7 +8801,7 @@
           <p:cNvPr id="1" name="">
             <a:extLst xmlns:a="http://schemas.openxmlformats.org/drawingml/2006/main">
               <a:ext uri="{FF2B5EF4-FFF2-40B4-BE49-F238E27FC236}">
-                <a16:creationId xmlns:a16="http://schemas.microsoft.com/office/drawing/2014/main" id="{2B83D669-00FF-4A25-A242-8D768F3EA6EF}"/>
+                <a16:creationId xmlns:a16="http://schemas.microsoft.com/office/drawing/2014/main" id="{C14EAACB-4475-47C4-9F09-793F6D489EF1}"/>
               </a:ext>
             </a:extLst>
           </p:cNvPr>
@@ -7303,7 +8836,7 @@
           <p:cNvPr id="2" name="kicker-marker">
             <a:extLst xmlns:a="http://schemas.openxmlformats.org/drawingml/2006/main">
               <a:ext uri="{FF2B5EF4-FFF2-40B4-BE49-F238E27FC236}">
-                <a16:creationId xmlns:a16="http://schemas.microsoft.com/office/drawing/2014/main" id="{9EAD8F88-0F51-47D6-9928-71FBE48468D4}"/>
+                <a16:creationId xmlns:a16="http://schemas.microsoft.com/office/drawing/2014/main" id="{E5F59D83-7C45-4E7D-9B4B-238303F4B2BF}"/>
               </a:ext>
             </a:extLst>
           </p:cNvPr>
@@ -7338,7 +8871,7 @@
           <p:cNvPr id="3" name="kicker-label">
             <a:extLst xmlns:a="http://schemas.openxmlformats.org/drawingml/2006/main">
               <a:ext uri="{FF2B5EF4-FFF2-40B4-BE49-F238E27FC236}">
-                <a16:creationId xmlns:a16="http://schemas.microsoft.com/office/drawing/2014/main" id="{BF0262BD-1E5E-4129-8DF9-886AAB7FB4FD}"/>
+                <a16:creationId xmlns:a16="http://schemas.microsoft.com/office/drawing/2014/main" id="{7E8D3E66-1086-4AC8-87D8-AF2E01026693}"/>
               </a:ext>
             </a:extLst>
           </p:cNvPr>
@@ -7392,7 +8925,7 @@
                 <a:ea typeface="Aptos"/>
                 <a:cs typeface="Aptos"/>
               </a:rPr>
-              <a:t>CLICKABLE BROWSER DEMO</a:t>
+              <a:t>LIVE DEMO PLAN</a:t>
             </a:r>
           </a:p>
         </p:txBody>
@@ -7402,7 +8935,7 @@
           <p:cNvPr id="4" name="">
             <a:extLst xmlns:a="http://schemas.openxmlformats.org/drawingml/2006/main">
               <a:ext uri="{FF2B5EF4-FFF2-40B4-BE49-F238E27FC236}">
-                <a16:creationId xmlns:a16="http://schemas.microsoft.com/office/drawing/2014/main" id="{50B55E4F-F76E-477C-B7DB-882571B4324E}"/>
+                <a16:creationId xmlns:a16="http://schemas.microsoft.com/office/drawing/2014/main" id="{5ED15EF2-F8AE-4BFF-B264-ECEFFE8EA2DB}"/>
               </a:ext>
             </a:extLst>
           </p:cNvPr>
@@ -7456,7 +8989,7 @@
                 <a:ea typeface="Aptos Display"/>
                 <a:cs typeface="Aptos Display"/>
               </a:rPr>
-              <a:t>Open the static web demo from the slide, then show intake, data, evaluation, and export.</a:t>
+              <a:t>In the final minute, show the browser workbench instead of static screenshots.</a:t>
             </a:r>
           </a:p>
         </p:txBody>
@@ -7466,7 +8999,7 @@
           <p:cNvPr id="5" name="">
             <a:extLst xmlns:a="http://schemas.openxmlformats.org/drawingml/2006/main">
               <a:ext uri="{FF2B5EF4-FFF2-40B4-BE49-F238E27FC236}">
-                <a16:creationId xmlns:a16="http://schemas.microsoft.com/office/drawing/2014/main" id="{774B63BC-CF78-420A-942D-7612D75457DA}"/>
+                <a16:creationId xmlns:a16="http://schemas.microsoft.com/office/drawing/2014/main" id="{9D214B17-EBE0-4CD9-B64D-8A658E3C7554}"/>
               </a:ext>
             </a:extLst>
           </p:cNvPr>
@@ -7501,7 +9034,7 @@
           <p:cNvPr id="6" name="">
             <a:extLst xmlns:a="http://schemas.openxmlformats.org/drawingml/2006/main">
               <a:ext uri="{FF2B5EF4-FFF2-40B4-BE49-F238E27FC236}">
-                <a16:creationId xmlns:a16="http://schemas.microsoft.com/office/drawing/2014/main" id="{02F19FC6-FEE1-4365-9C26-771698698F91}"/>
+                <a16:creationId xmlns:a16="http://schemas.microsoft.com/office/drawing/2014/main" id="{8D98BC10-5BA6-412D-8DD0-4ECB91452881}"/>
               </a:ext>
             </a:extLst>
           </p:cNvPr>
@@ -7560,46 +9093,57 @@
           </a:p>
         </p:txBody>
       </p:sp>
-      <p:pic>
-        <p:nvPicPr>
-          <p:cNvPr id="7" name=""/>
-          <p:cNvPicPr>
-            <a:picLocks xmlns:a="http://schemas.openxmlformats.org/drawingml/2006/main" noChangeAspect="1"/>
-          </p:cNvPicPr>
-          <p:nvPr/>
-        </p:nvPicPr>
-        <p:blipFill>
-          <a:blip xmlns:r="http://schemas.openxmlformats.org/officeDocument/2006/relationships" xmlns:a="http://schemas.openxmlformats.org/drawingml/2006/main" r:embed="R3e99a8175f6b4330"/>
-          <a:stretch xmlns:a="http://schemas.openxmlformats.org/drawingml/2006/main"/>
-        </p:blipFill>
-        <p:spPr>
-          <a:xfrm xmlns:a="http://schemas.openxmlformats.org/drawingml/2006/main">
-            <a:off x="2959244" y="1714500"/>
-            <a:ext cx="6273511" cy="4381500"/>
-          </a:xfrm>
-          <a:prstGeom xmlns:a="http://schemas.openxmlformats.org/drawingml/2006/main" prst="rect">
-            <a:avLst/>
-          </a:prstGeom>
-        </p:spPr>
-      </p:pic>
+      <p:sp>
+        <p:nvSpPr>
+          <p:cNvPr id="7" name="">
+            <a:extLst xmlns:a="http://schemas.openxmlformats.org/drawingml/2006/main">
+              <a:ext uri="{FF2B5EF4-FFF2-40B4-BE49-F238E27FC236}">
+                <a16:creationId xmlns:a16="http://schemas.microsoft.com/office/drawing/2014/main" id="{FCCB01C3-E115-47F6-AED9-0F45B749803C}"/>
+              </a:ext>
+            </a:extLst>
+          </p:cNvPr>
+          <p:cNvSpPr>
+            <a:spLocks xmlns:a="http://schemas.openxmlformats.org/drawingml/2006/main" noGrp="1"/>
+          </p:cNvSpPr>
+          <p:nvPr/>
+        </p:nvSpPr>
+        <p:spPr>
+          <a:xfrm xmlns:a="http://schemas.openxmlformats.org/drawingml/2006/main">
+            <a:off x="857250" y="1943100"/>
+            <a:ext cx="4552950" cy="1066800"/>
+          </a:xfrm>
+          <a:prstGeom xmlns:a="http://schemas.openxmlformats.org/drawingml/2006/main" prst="rect">
+            <a:avLst/>
+          </a:prstGeom>
+          <a:solidFill xmlns:a="http://schemas.openxmlformats.org/drawingml/2006/main">
+            <a:srgbClr val="FFFFFF"/>
+          </a:solidFill>
+          <a:ln xmlns:a="http://schemas.openxmlformats.org/drawingml/2006/main" w="9525">
+            <a:solidFill>
+              <a:srgbClr val="D8D0C0"/>
+            </a:solidFill>
+            <a:prstDash val="solid"/>
+          </a:ln>
+        </p:spPr>
+      </p:sp>
       <p:sp>
         <p:nvSpPr>
           <p:cNvPr id="8" name="">
             <a:extLst xmlns:a="http://schemas.openxmlformats.org/drawingml/2006/main">
               <a:ext uri="{FF2B5EF4-FFF2-40B4-BE49-F238E27FC236}">
-                <a16:creationId xmlns:a16="http://schemas.microsoft.com/office/drawing/2014/main" id="{E6FE33EC-7F36-4A6A-B3BA-E1334863AB73}"/>
-              </a:ext>
-            </a:extLst>
-          </p:cNvPr>
-          <p:cNvSpPr>
-            <a:spLocks xmlns:a="http://schemas.openxmlformats.org/drawingml/2006/main" noGrp="1"/>
-          </p:cNvSpPr>
-          <p:nvPr/>
-        </p:nvSpPr>
-        <p:spPr>
-          <a:xfrm xmlns:a="http://schemas.openxmlformats.org/drawingml/2006/main">
-            <a:off x="2200275" y="1714500"/>
-            <a:ext cx="7791450" cy="4381500"/>
+                <a16:creationId xmlns:a16="http://schemas.microsoft.com/office/drawing/2014/main" id="{26CC5E1F-0C44-479A-91E6-1F88B29470C7}"/>
+              </a:ext>
+            </a:extLst>
+          </p:cNvPr>
+          <p:cNvSpPr>
+            <a:spLocks xmlns:a="http://schemas.openxmlformats.org/drawingml/2006/main" noGrp="1"/>
+          </p:cNvSpPr>
+          <p:nvPr/>
+        </p:nvSpPr>
+        <p:spPr>
+          <a:xfrm xmlns:a="http://schemas.openxmlformats.org/drawingml/2006/main">
+            <a:off x="1085850" y="2114550"/>
+            <a:ext cx="2095500" cy="342900"/>
           </a:xfrm>
           <a:prstGeom xmlns:a="http://schemas.openxmlformats.org/drawingml/2006/main" prst="rect">
             <a:avLst/>
@@ -7609,67 +9153,61 @@
               <a:alpha val="0"/>
             </a:srgbClr>
           </a:solidFill>
-          <a:ln xmlns:a="http://schemas.openxmlformats.org/drawingml/2006/main" w="9525">
-            <a:solidFill>
-              <a:srgbClr val="D8D0C0"/>
-            </a:solidFill>
-            <a:prstDash val="solid"/>
-          </a:ln>
-        </p:spPr>
+          <a:ln xmlns:a="http://schemas.openxmlformats.org/drawingml/2006/main" w="0">
+            <a:solidFill>
+              <a:srgbClr val="000000">
+                <a:alpha val="0"/>
+              </a:srgbClr>
+            </a:solidFill>
+            <a:prstDash val="solid"/>
+          </a:ln>
+        </p:spPr>
+        <p:txBody>
+          <a:bodyPr xmlns:a="http://schemas.openxmlformats.org/drawingml/2006/main" lIns="0" tIns="0" rIns="0" bIns="0" anchor="t"/>
+          <a:lstStyle xmlns:a="http://schemas.openxmlformats.org/drawingml/2006/main"/>
+          <a:p xmlns:a="http://schemas.openxmlformats.org/drawingml/2006/main">
+            <a:pPr algn="l">
+              <a:defRPr sz="1650" b="1">
+                <a:solidFill>
+                  <a:srgbClr val="14213D"/>
+                </a:solidFill>
+                <a:latin typeface="Aptos"/>
+                <a:ea typeface="Aptos"/>
+                <a:cs typeface="Aptos"/>
+              </a:defRPr>
+            </a:pPr>
+            <a:r>
+              <a:rPr sz="1650" b="1">
+                <a:solidFill>
+                  <a:srgbClr val="14213D"/>
+                </a:solidFill>
+                <a:latin typeface="Aptos"/>
+                <a:ea typeface="Aptos"/>
+                <a:cs typeface="Aptos"/>
+              </a:rPr>
+              <a:t>Source intake</a:t>
+            </a:r>
+          </a:p>
+        </p:txBody>
       </p:sp>
       <p:sp>
         <p:nvSpPr>
           <p:cNvPr id="9" name="">
             <a:extLst xmlns:a="http://schemas.openxmlformats.org/drawingml/2006/main">
               <a:ext uri="{FF2B5EF4-FFF2-40B4-BE49-F238E27FC236}">
-                <a16:creationId xmlns:a16="http://schemas.microsoft.com/office/drawing/2014/main" id="{A070E0D3-EC72-4BE0-A1AD-998F49264145}"/>
-              </a:ext>
-            </a:extLst>
-          </p:cNvPr>
-          <p:cNvSpPr>
-            <a:spLocks xmlns:a="http://schemas.openxmlformats.org/drawingml/2006/main" noGrp="1"/>
-          </p:cNvSpPr>
-          <p:nvPr/>
-        </p:nvSpPr>
-        <p:spPr>
-          <a:xfrm xmlns:a="http://schemas.openxmlformats.org/drawingml/2006/main">
-            <a:off x="3429000" y="5619750"/>
-            <a:ext cx="5334000" cy="400050"/>
-          </a:xfrm>
-          <a:prstGeom xmlns:a="http://schemas.openxmlformats.org/drawingml/2006/main" prst="rect">
-            <a:avLst/>
-          </a:prstGeom>
-          <a:solidFill xmlns:a="http://schemas.openxmlformats.org/drawingml/2006/main">
-            <a:srgbClr val="111D32"/>
-          </a:solidFill>
-          <a:ln xmlns:a="http://schemas.openxmlformats.org/drawingml/2006/main" w="0">
-            <a:solidFill>
-              <a:srgbClr val="000000">
-                <a:alpha val="0"/>
-              </a:srgbClr>
-            </a:solidFill>
-            <a:prstDash val="solid"/>
-          </a:ln>
-        </p:spPr>
-      </p:sp>
-      <p:sp>
-        <p:nvSpPr>
-          <p:cNvPr id="10" name="">
-            <a:extLst xmlns:a="http://schemas.openxmlformats.org/drawingml/2006/main">
-              <a:ext uri="{FF2B5EF4-FFF2-40B4-BE49-F238E27FC236}">
-                <a16:creationId xmlns:a16="http://schemas.microsoft.com/office/drawing/2014/main" id="{1FD70D16-67E1-4213-9146-D74B45908DAF}"/>
-              </a:ext>
-            </a:extLst>
-          </p:cNvPr>
-          <p:cNvSpPr>
-            <a:spLocks xmlns:a="http://schemas.openxmlformats.org/drawingml/2006/main" noGrp="1"/>
-          </p:cNvSpPr>
-          <p:nvPr/>
-        </p:nvSpPr>
-        <p:spPr>
-          <a:xfrm xmlns:a="http://schemas.openxmlformats.org/drawingml/2006/main">
-            <a:off x="3829050" y="5705475"/>
-            <a:ext cx="4533900" cy="209550"/>
+                <a16:creationId xmlns:a16="http://schemas.microsoft.com/office/drawing/2014/main" id="{AB9BA0E6-7434-48CC-B702-1F52FEBB3080}"/>
+              </a:ext>
+            </a:extLst>
+          </p:cNvPr>
+          <p:cNvSpPr>
+            <a:spLocks xmlns:a="http://schemas.openxmlformats.org/drawingml/2006/main" noGrp="1"/>
+          </p:cNvSpPr>
+          <p:nvPr/>
+        </p:nvSpPr>
+        <p:spPr>
+          <a:xfrm xmlns:a="http://schemas.openxmlformats.org/drawingml/2006/main">
+            <a:off x="1085850" y="2514600"/>
+            <a:ext cx="3924300" cy="400050"/>
           </a:xfrm>
           <a:prstGeom xmlns:a="http://schemas.openxmlformats.org/drawingml/2006/main" prst="rect">
             <a:avLst/>
@@ -7692,10 +9230,10 @@
           <a:bodyPr xmlns:a="http://schemas.openxmlformats.org/drawingml/2006/main" lIns="0" tIns="0" rIns="0" bIns="0" anchor="t"/>
           <a:lstStyle xmlns:a="http://schemas.openxmlformats.org/drawingml/2006/main"/>
           <a:p xmlns:a="http://schemas.openxmlformats.org/drawingml/2006/main">
-            <a:pPr algn="ctr">
-              <a:defRPr sz="1200" b="1">
-                <a:solidFill>
-                  <a:srgbClr val="F7F3EA"/>
+            <a:pPr algn="l">
+              <a:defRPr sz="1050" b="0">
+                <a:solidFill>
+                  <a:srgbClr val="4D4A43"/>
                 </a:solidFill>
                 <a:latin typeface="Aptos"/>
                 <a:ea typeface="Aptos"/>
@@ -7703,37 +9241,619 @@
               </a:defRPr>
             </a:pPr>
             <a:r>
-              <a:rPr sz="1200" b="1">
-                <a:solidFill>
-                  <a:srgbClr val="F7F3EA"/>
+              <a:rPr sz="1050" b="0">
+                <a:solidFill>
+                  <a:srgbClr val="4D4A43"/>
                 </a:solidFill>
                 <a:latin typeface="Aptos"/>
                 <a:ea typeface="Aptos"/>
                 <a:cs typeface="Aptos"/>
               </a:rPr>
-              <a:t>CLICK HERE FOR BROWSER DEMO</a:t>
+              <a:t>Show the preloaded source packet and run extraction.</a:t>
             </a:r>
           </a:p>
         </p:txBody>
       </p:sp>
       <p:sp>
         <p:nvSpPr>
+          <p:cNvPr id="10" name="">
+            <a:extLst xmlns:a="http://schemas.openxmlformats.org/drawingml/2006/main">
+              <a:ext uri="{FF2B5EF4-FFF2-40B4-BE49-F238E27FC236}">
+                <a16:creationId xmlns:a16="http://schemas.microsoft.com/office/drawing/2014/main" id="{EC108D00-A2B8-47BC-A1AF-24E031B705F0}"/>
+              </a:ext>
+            </a:extLst>
+          </p:cNvPr>
+          <p:cNvSpPr>
+            <a:spLocks xmlns:a="http://schemas.openxmlformats.org/drawingml/2006/main" noGrp="1"/>
+          </p:cNvSpPr>
+          <p:nvPr/>
+        </p:nvSpPr>
+        <p:spPr>
+          <a:xfrm xmlns:a="http://schemas.openxmlformats.org/drawingml/2006/main">
+            <a:off x="6191250" y="1943100"/>
+            <a:ext cx="4552950" cy="1066800"/>
+          </a:xfrm>
+          <a:prstGeom xmlns:a="http://schemas.openxmlformats.org/drawingml/2006/main" prst="rect">
+            <a:avLst/>
+          </a:prstGeom>
+          <a:solidFill xmlns:a="http://schemas.openxmlformats.org/drawingml/2006/main">
+            <a:srgbClr val="FFFFFF"/>
+          </a:solidFill>
+          <a:ln xmlns:a="http://schemas.openxmlformats.org/drawingml/2006/main" w="9525">
+            <a:solidFill>
+              <a:srgbClr val="D8D0C0"/>
+            </a:solidFill>
+            <a:prstDash val="solid"/>
+          </a:ln>
+        </p:spPr>
+      </p:sp>
+      <p:sp>
+        <p:nvSpPr>
           <p:cNvPr id="11" name="">
             <a:extLst xmlns:a="http://schemas.openxmlformats.org/drawingml/2006/main">
               <a:ext uri="{FF2B5EF4-FFF2-40B4-BE49-F238E27FC236}">
-                <a16:creationId xmlns:a16="http://schemas.microsoft.com/office/drawing/2014/main" id="{C416040C-98B0-4CD5-B94D-846CB32117AE}"/>
-              </a:ext>
-            </a:extLst>
-          </p:cNvPr>
-          <p:cNvSpPr>
-            <a:spLocks xmlns:a="http://schemas.openxmlformats.org/drawingml/2006/main" noGrp="1"/>
-          </p:cNvSpPr>
-          <p:nvPr/>
-        </p:nvSpPr>
-        <p:spPr>
-          <a:xfrm xmlns:a="http://schemas.openxmlformats.org/drawingml/2006/main">
-            <a:off x="2219325" y="6115050"/>
-            <a:ext cx="7772400" cy="190500"/>
+                <a16:creationId xmlns:a16="http://schemas.microsoft.com/office/drawing/2014/main" id="{C144939E-3ABC-40AE-AB2A-4087128104D1}"/>
+              </a:ext>
+            </a:extLst>
+          </p:cNvPr>
+          <p:cNvSpPr>
+            <a:spLocks xmlns:a="http://schemas.openxmlformats.org/drawingml/2006/main" noGrp="1"/>
+          </p:cNvSpPr>
+          <p:nvPr/>
+        </p:nvSpPr>
+        <p:spPr>
+          <a:xfrm xmlns:a="http://schemas.openxmlformats.org/drawingml/2006/main">
+            <a:off x="6419850" y="2114550"/>
+            <a:ext cx="2095500" cy="342900"/>
+          </a:xfrm>
+          <a:prstGeom xmlns:a="http://schemas.openxmlformats.org/drawingml/2006/main" prst="rect">
+            <a:avLst/>
+          </a:prstGeom>
+          <a:solidFill xmlns:a="http://schemas.openxmlformats.org/drawingml/2006/main">
+            <a:srgbClr val="000000">
+              <a:alpha val="0"/>
+            </a:srgbClr>
+          </a:solidFill>
+          <a:ln xmlns:a="http://schemas.openxmlformats.org/drawingml/2006/main" w="0">
+            <a:solidFill>
+              <a:srgbClr val="000000">
+                <a:alpha val="0"/>
+              </a:srgbClr>
+            </a:solidFill>
+            <a:prstDash val="solid"/>
+          </a:ln>
+        </p:spPr>
+        <p:txBody>
+          <a:bodyPr xmlns:a="http://schemas.openxmlformats.org/drawingml/2006/main" lIns="0" tIns="0" rIns="0" bIns="0" anchor="t"/>
+          <a:lstStyle xmlns:a="http://schemas.openxmlformats.org/drawingml/2006/main"/>
+          <a:p xmlns:a="http://schemas.openxmlformats.org/drawingml/2006/main">
+            <a:pPr algn="l">
+              <a:defRPr sz="1650" b="1">
+                <a:solidFill>
+                  <a:srgbClr val="14213D"/>
+                </a:solidFill>
+                <a:latin typeface="Aptos"/>
+                <a:ea typeface="Aptos"/>
+                <a:cs typeface="Aptos"/>
+              </a:defRPr>
+            </a:pPr>
+            <a:r>
+              <a:rPr sz="1650" b="1">
+                <a:solidFill>
+                  <a:srgbClr val="14213D"/>
+                </a:solidFill>
+                <a:latin typeface="Aptos"/>
+                <a:ea typeface="Aptos"/>
+                <a:cs typeface="Aptos"/>
+              </a:rPr>
+              <a:t>Scenario review</a:t>
+            </a:r>
+          </a:p>
+        </p:txBody>
+      </p:sp>
+      <p:sp>
+        <p:nvSpPr>
+          <p:cNvPr id="12" name="">
+            <a:extLst xmlns:a="http://schemas.openxmlformats.org/drawingml/2006/main">
+              <a:ext uri="{FF2B5EF4-FFF2-40B4-BE49-F238E27FC236}">
+                <a16:creationId xmlns:a16="http://schemas.microsoft.com/office/drawing/2014/main" id="{0C9DC53D-556A-4E85-BB26-328325963754}"/>
+              </a:ext>
+            </a:extLst>
+          </p:cNvPr>
+          <p:cNvSpPr>
+            <a:spLocks xmlns:a="http://schemas.openxmlformats.org/drawingml/2006/main" noGrp="1"/>
+          </p:cNvSpPr>
+          <p:nvPr/>
+        </p:nvSpPr>
+        <p:spPr>
+          <a:xfrm xmlns:a="http://schemas.openxmlformats.org/drawingml/2006/main">
+            <a:off x="6419850" y="2514600"/>
+            <a:ext cx="3924300" cy="400050"/>
+          </a:xfrm>
+          <a:prstGeom xmlns:a="http://schemas.openxmlformats.org/drawingml/2006/main" prst="rect">
+            <a:avLst/>
+          </a:prstGeom>
+          <a:solidFill xmlns:a="http://schemas.openxmlformats.org/drawingml/2006/main">
+            <a:srgbClr val="000000">
+              <a:alpha val="0"/>
+            </a:srgbClr>
+          </a:solidFill>
+          <a:ln xmlns:a="http://schemas.openxmlformats.org/drawingml/2006/main" w="0">
+            <a:solidFill>
+              <a:srgbClr val="000000">
+                <a:alpha val="0"/>
+              </a:srgbClr>
+            </a:solidFill>
+            <a:prstDash val="solid"/>
+          </a:ln>
+        </p:spPr>
+        <p:txBody>
+          <a:bodyPr xmlns:a="http://schemas.openxmlformats.org/drawingml/2006/main" lIns="0" tIns="0" rIns="0" bIns="0" anchor="t"/>
+          <a:lstStyle xmlns:a="http://schemas.openxmlformats.org/drawingml/2006/main"/>
+          <a:p xmlns:a="http://schemas.openxmlformats.org/drawingml/2006/main">
+            <a:pPr algn="l">
+              <a:defRPr sz="1050" b="0">
+                <a:solidFill>
+                  <a:srgbClr val="4D4A43"/>
+                </a:solidFill>
+                <a:latin typeface="Aptos"/>
+                <a:ea typeface="Aptos"/>
+                <a:cs typeface="Aptos"/>
+              </a:defRPr>
+            </a:pPr>
+            <a:r>
+              <a:rPr sz="1050" b="0">
+                <a:solidFill>
+                  <a:srgbClr val="4D4A43"/>
+                </a:solidFill>
+                <a:latin typeface="Aptos"/>
+                <a:ea typeface="Aptos"/>
+                <a:cs typeface="Aptos"/>
+              </a:rPr>
+              <a:t>Show that constraints are editable and require analyst approval.</a:t>
+            </a:r>
+          </a:p>
+        </p:txBody>
+      </p:sp>
+      <p:sp>
+        <p:nvSpPr>
+          <p:cNvPr id="13" name="">
+            <a:extLst xmlns:a="http://schemas.openxmlformats.org/drawingml/2006/main">
+              <a:ext uri="{FF2B5EF4-FFF2-40B4-BE49-F238E27FC236}">
+                <a16:creationId xmlns:a16="http://schemas.microsoft.com/office/drawing/2014/main" id="{407C04E1-8D0A-4FD1-AE85-A345BF919EAA}"/>
+              </a:ext>
+            </a:extLst>
+          </p:cNvPr>
+          <p:cNvSpPr>
+            <a:spLocks xmlns:a="http://schemas.openxmlformats.org/drawingml/2006/main" noGrp="1"/>
+          </p:cNvSpPr>
+          <p:nvPr/>
+        </p:nvSpPr>
+        <p:spPr>
+          <a:xfrm xmlns:a="http://schemas.openxmlformats.org/drawingml/2006/main">
+            <a:off x="857250" y="3409950"/>
+            <a:ext cx="4552950" cy="1066800"/>
+          </a:xfrm>
+          <a:prstGeom xmlns:a="http://schemas.openxmlformats.org/drawingml/2006/main" prst="rect">
+            <a:avLst/>
+          </a:prstGeom>
+          <a:solidFill xmlns:a="http://schemas.openxmlformats.org/drawingml/2006/main">
+            <a:srgbClr val="FFFFFF"/>
+          </a:solidFill>
+          <a:ln xmlns:a="http://schemas.openxmlformats.org/drawingml/2006/main" w="9525">
+            <a:solidFill>
+              <a:srgbClr val="D8D0C0"/>
+            </a:solidFill>
+            <a:prstDash val="solid"/>
+          </a:ln>
+        </p:spPr>
+      </p:sp>
+      <p:sp>
+        <p:nvSpPr>
+          <p:cNvPr id="14" name="">
+            <a:extLst xmlns:a="http://schemas.openxmlformats.org/drawingml/2006/main">
+              <a:ext uri="{FF2B5EF4-FFF2-40B4-BE49-F238E27FC236}">
+                <a16:creationId xmlns:a16="http://schemas.microsoft.com/office/drawing/2014/main" id="{89821EC6-62A8-4C60-A2CF-2D8FD7E9FCDF}"/>
+              </a:ext>
+            </a:extLst>
+          </p:cNvPr>
+          <p:cNvSpPr>
+            <a:spLocks xmlns:a="http://schemas.openxmlformats.org/drawingml/2006/main" noGrp="1"/>
+          </p:cNvSpPr>
+          <p:nvPr/>
+        </p:nvSpPr>
+        <p:spPr>
+          <a:xfrm xmlns:a="http://schemas.openxmlformats.org/drawingml/2006/main">
+            <a:off x="1085850" y="3581400"/>
+            <a:ext cx="2095500" cy="342900"/>
+          </a:xfrm>
+          <a:prstGeom xmlns:a="http://schemas.openxmlformats.org/drawingml/2006/main" prst="rect">
+            <a:avLst/>
+          </a:prstGeom>
+          <a:solidFill xmlns:a="http://schemas.openxmlformats.org/drawingml/2006/main">
+            <a:srgbClr val="000000">
+              <a:alpha val="0"/>
+            </a:srgbClr>
+          </a:solidFill>
+          <a:ln xmlns:a="http://schemas.openxmlformats.org/drawingml/2006/main" w="0">
+            <a:solidFill>
+              <a:srgbClr val="000000">
+                <a:alpha val="0"/>
+              </a:srgbClr>
+            </a:solidFill>
+            <a:prstDash val="solid"/>
+          </a:ln>
+        </p:spPr>
+        <p:txBody>
+          <a:bodyPr xmlns:a="http://schemas.openxmlformats.org/drawingml/2006/main" lIns="0" tIns="0" rIns="0" bIns="0" anchor="t"/>
+          <a:lstStyle xmlns:a="http://schemas.openxmlformats.org/drawingml/2006/main"/>
+          <a:p xmlns:a="http://schemas.openxmlformats.org/drawingml/2006/main">
+            <a:pPr algn="l">
+              <a:defRPr sz="1650" b="1">
+                <a:solidFill>
+                  <a:srgbClr val="14213D"/>
+                </a:solidFill>
+                <a:latin typeface="Aptos"/>
+                <a:ea typeface="Aptos"/>
+                <a:cs typeface="Aptos"/>
+              </a:defRPr>
+            </a:pPr>
+            <a:r>
+              <a:rPr sz="1650" b="1">
+                <a:solidFill>
+                  <a:srgbClr val="14213D"/>
+                </a:solidFill>
+                <a:latin typeface="Aptos"/>
+                <a:ea typeface="Aptos"/>
+                <a:cs typeface="Aptos"/>
+              </a:rPr>
+              <a:t>Ledger + evaluation</a:t>
+            </a:r>
+          </a:p>
+        </p:txBody>
+      </p:sp>
+      <p:sp>
+        <p:nvSpPr>
+          <p:cNvPr id="15" name="">
+            <a:extLst xmlns:a="http://schemas.openxmlformats.org/drawingml/2006/main">
+              <a:ext uri="{FF2B5EF4-FFF2-40B4-BE49-F238E27FC236}">
+                <a16:creationId xmlns:a16="http://schemas.microsoft.com/office/drawing/2014/main" id="{C17F4F5C-1E0F-4051-959C-3852D0ABFE24}"/>
+              </a:ext>
+            </a:extLst>
+          </p:cNvPr>
+          <p:cNvSpPr>
+            <a:spLocks xmlns:a="http://schemas.openxmlformats.org/drawingml/2006/main" noGrp="1"/>
+          </p:cNvSpPr>
+          <p:nvPr/>
+        </p:nvSpPr>
+        <p:spPr>
+          <a:xfrm xmlns:a="http://schemas.openxmlformats.org/drawingml/2006/main">
+            <a:off x="1085850" y="3981450"/>
+            <a:ext cx="3924300" cy="400050"/>
+          </a:xfrm>
+          <a:prstGeom xmlns:a="http://schemas.openxmlformats.org/drawingml/2006/main" prst="rect">
+            <a:avLst/>
+          </a:prstGeom>
+          <a:solidFill xmlns:a="http://schemas.openxmlformats.org/drawingml/2006/main">
+            <a:srgbClr val="000000">
+              <a:alpha val="0"/>
+            </a:srgbClr>
+          </a:solidFill>
+          <a:ln xmlns:a="http://schemas.openxmlformats.org/drawingml/2006/main" w="0">
+            <a:solidFill>
+              <a:srgbClr val="000000">
+                <a:alpha val="0"/>
+              </a:srgbClr>
+            </a:solidFill>
+            <a:prstDash val="solid"/>
+          </a:ln>
+        </p:spPr>
+        <p:txBody>
+          <a:bodyPr xmlns:a="http://schemas.openxmlformats.org/drawingml/2006/main" lIns="0" tIns="0" rIns="0" bIns="0" anchor="t"/>
+          <a:lstStyle xmlns:a="http://schemas.openxmlformats.org/drawingml/2006/main"/>
+          <a:p xmlns:a="http://schemas.openxmlformats.org/drawingml/2006/main">
+            <a:pPr algn="l">
+              <a:defRPr sz="1050" b="0">
+                <a:solidFill>
+                  <a:srgbClr val="4D4A43"/>
+                </a:solidFill>
+                <a:latin typeface="Aptos"/>
+                <a:ea typeface="Aptos"/>
+                <a:cs typeface="Aptos"/>
+              </a:defRPr>
+            </a:pPr>
+            <a:r>
+              <a:rPr sz="1050" b="0">
+                <a:solidFill>
+                  <a:srgbClr val="4D4A43"/>
+                </a:solidFill>
+                <a:latin typeface="Aptos"/>
+                <a:ea typeface="Aptos"/>
+                <a:cs typeface="Aptos"/>
+              </a:rPr>
+              <a:t>Filter suspicious chains, then show baseline comparison.</a:t>
+            </a:r>
+          </a:p>
+        </p:txBody>
+      </p:sp>
+      <p:sp>
+        <p:nvSpPr>
+          <p:cNvPr id="16" name="">
+            <a:extLst xmlns:a="http://schemas.openxmlformats.org/drawingml/2006/main">
+              <a:ext uri="{FF2B5EF4-FFF2-40B4-BE49-F238E27FC236}">
+                <a16:creationId xmlns:a16="http://schemas.microsoft.com/office/drawing/2014/main" id="{08D6E019-B593-418F-93C2-6E94557CEA54}"/>
+              </a:ext>
+            </a:extLst>
+          </p:cNvPr>
+          <p:cNvSpPr>
+            <a:spLocks xmlns:a="http://schemas.openxmlformats.org/drawingml/2006/main" noGrp="1"/>
+          </p:cNvSpPr>
+          <p:nvPr/>
+        </p:nvSpPr>
+        <p:spPr>
+          <a:xfrm xmlns:a="http://schemas.openxmlformats.org/drawingml/2006/main">
+            <a:off x="6191250" y="3409950"/>
+            <a:ext cx="4552950" cy="1066800"/>
+          </a:xfrm>
+          <a:prstGeom xmlns:a="http://schemas.openxmlformats.org/drawingml/2006/main" prst="rect">
+            <a:avLst/>
+          </a:prstGeom>
+          <a:solidFill xmlns:a="http://schemas.openxmlformats.org/drawingml/2006/main">
+            <a:srgbClr val="FFFFFF"/>
+          </a:solidFill>
+          <a:ln xmlns:a="http://schemas.openxmlformats.org/drawingml/2006/main" w="9525">
+            <a:solidFill>
+              <a:srgbClr val="D8D0C0"/>
+            </a:solidFill>
+            <a:prstDash val="solid"/>
+          </a:ln>
+        </p:spPr>
+      </p:sp>
+      <p:sp>
+        <p:nvSpPr>
+          <p:cNvPr id="17" name="">
+            <a:extLst xmlns:a="http://schemas.openxmlformats.org/drawingml/2006/main">
+              <a:ext uri="{FF2B5EF4-FFF2-40B4-BE49-F238E27FC236}">
+                <a16:creationId xmlns:a16="http://schemas.microsoft.com/office/drawing/2014/main" id="{A25D2B97-475B-46A4-B450-FDA7DBDC46B3}"/>
+              </a:ext>
+            </a:extLst>
+          </p:cNvPr>
+          <p:cNvSpPr>
+            <a:spLocks xmlns:a="http://schemas.openxmlformats.org/drawingml/2006/main" noGrp="1"/>
+          </p:cNvSpPr>
+          <p:nvPr/>
+        </p:nvSpPr>
+        <p:spPr>
+          <a:xfrm xmlns:a="http://schemas.openxmlformats.org/drawingml/2006/main">
+            <a:off x="6419850" y="3581400"/>
+            <a:ext cx="2095500" cy="342900"/>
+          </a:xfrm>
+          <a:prstGeom xmlns:a="http://schemas.openxmlformats.org/drawingml/2006/main" prst="rect">
+            <a:avLst/>
+          </a:prstGeom>
+          <a:solidFill xmlns:a="http://schemas.openxmlformats.org/drawingml/2006/main">
+            <a:srgbClr val="000000">
+              <a:alpha val="0"/>
+            </a:srgbClr>
+          </a:solidFill>
+          <a:ln xmlns:a="http://schemas.openxmlformats.org/drawingml/2006/main" w="0">
+            <a:solidFill>
+              <a:srgbClr val="000000">
+                <a:alpha val="0"/>
+              </a:srgbClr>
+            </a:solidFill>
+            <a:prstDash val="solid"/>
+          </a:ln>
+        </p:spPr>
+        <p:txBody>
+          <a:bodyPr xmlns:a="http://schemas.openxmlformats.org/drawingml/2006/main" lIns="0" tIns="0" rIns="0" bIns="0" anchor="t"/>
+          <a:lstStyle xmlns:a="http://schemas.openxmlformats.org/drawingml/2006/main"/>
+          <a:p xmlns:a="http://schemas.openxmlformats.org/drawingml/2006/main">
+            <a:pPr algn="l">
+              <a:defRPr sz="1650" b="1">
+                <a:solidFill>
+                  <a:srgbClr val="14213D"/>
+                </a:solidFill>
+                <a:latin typeface="Aptos"/>
+                <a:ea typeface="Aptos"/>
+                <a:cs typeface="Aptos"/>
+              </a:defRPr>
+            </a:pPr>
+            <a:r>
+              <a:rPr sz="1650" b="1">
+                <a:solidFill>
+                  <a:srgbClr val="14213D"/>
+                </a:solidFill>
+                <a:latin typeface="Aptos"/>
+                <a:ea typeface="Aptos"/>
+                <a:cs typeface="Aptos"/>
+              </a:rPr>
+              <a:t>Export</a:t>
+            </a:r>
+          </a:p>
+        </p:txBody>
+      </p:sp>
+      <p:sp>
+        <p:nvSpPr>
+          <p:cNvPr id="18" name="">
+            <a:extLst xmlns:a="http://schemas.openxmlformats.org/drawingml/2006/main">
+              <a:ext uri="{FF2B5EF4-FFF2-40B4-BE49-F238E27FC236}">
+                <a16:creationId xmlns:a16="http://schemas.microsoft.com/office/drawing/2014/main" id="{916C5BF9-A0F3-4788-AE42-C0AE2FAD301B}"/>
+              </a:ext>
+            </a:extLst>
+          </p:cNvPr>
+          <p:cNvSpPr>
+            <a:spLocks xmlns:a="http://schemas.openxmlformats.org/drawingml/2006/main" noGrp="1"/>
+          </p:cNvSpPr>
+          <p:nvPr/>
+        </p:nvSpPr>
+        <p:spPr>
+          <a:xfrm xmlns:a="http://schemas.openxmlformats.org/drawingml/2006/main">
+            <a:off x="6419850" y="3981450"/>
+            <a:ext cx="3924300" cy="400050"/>
+          </a:xfrm>
+          <a:prstGeom xmlns:a="http://schemas.openxmlformats.org/drawingml/2006/main" prst="rect">
+            <a:avLst/>
+          </a:prstGeom>
+          <a:solidFill xmlns:a="http://schemas.openxmlformats.org/drawingml/2006/main">
+            <a:srgbClr val="000000">
+              <a:alpha val="0"/>
+            </a:srgbClr>
+          </a:solidFill>
+          <a:ln xmlns:a="http://schemas.openxmlformats.org/drawingml/2006/main" w="0">
+            <a:solidFill>
+              <a:srgbClr val="000000">
+                <a:alpha val="0"/>
+              </a:srgbClr>
+            </a:solidFill>
+            <a:prstDash val="solid"/>
+          </a:ln>
+        </p:spPr>
+        <p:txBody>
+          <a:bodyPr xmlns:a="http://schemas.openxmlformats.org/drawingml/2006/main" lIns="0" tIns="0" rIns="0" bIns="0" anchor="t"/>
+          <a:lstStyle xmlns:a="http://schemas.openxmlformats.org/drawingml/2006/main"/>
+          <a:p xmlns:a="http://schemas.openxmlformats.org/drawingml/2006/main">
+            <a:pPr algn="l">
+              <a:defRPr sz="1050" b="0">
+                <a:solidFill>
+                  <a:srgbClr val="4D4A43"/>
+                </a:solidFill>
+                <a:latin typeface="Aptos"/>
+                <a:ea typeface="Aptos"/>
+                <a:cs typeface="Aptos"/>
+              </a:defRPr>
+            </a:pPr>
+            <a:r>
+              <a:rPr sz="1050" b="0">
+                <a:solidFill>
+                  <a:srgbClr val="4D4A43"/>
+                </a:solidFill>
+                <a:latin typeface="Aptos"/>
+                <a:ea typeface="Aptos"/>
+                <a:cs typeface="Aptos"/>
+              </a:rPr>
+              <a:t>Show the guided CSV, baseline CSV, and evaluation JSON package.</a:t>
+            </a:r>
+          </a:p>
+        </p:txBody>
+      </p:sp>
+      <p:sp>
+        <p:nvSpPr>
+          <p:cNvPr id="19" name="">
+            <a:extLst xmlns:a="http://schemas.openxmlformats.org/drawingml/2006/main">
+              <a:ext uri="{FF2B5EF4-FFF2-40B4-BE49-F238E27FC236}">
+                <a16:creationId xmlns:a16="http://schemas.microsoft.com/office/drawing/2014/main" id="{9C76F897-03DA-4843-A41E-856A7AD58BD7}"/>
+              </a:ext>
+            </a:extLst>
+          </p:cNvPr>
+          <p:cNvSpPr>
+            <a:spLocks xmlns:a="http://schemas.openxmlformats.org/drawingml/2006/main" noGrp="1"/>
+          </p:cNvSpPr>
+          <p:nvPr/>
+        </p:nvSpPr>
+        <p:spPr>
+          <a:xfrm xmlns:a="http://schemas.openxmlformats.org/drawingml/2006/main">
+            <a:off x="2552700" y="5200650"/>
+            <a:ext cx="7086600" cy="457200"/>
+          </a:xfrm>
+          <a:prstGeom xmlns:a="http://schemas.openxmlformats.org/drawingml/2006/main" prst="rect">
+            <a:avLst/>
+          </a:prstGeom>
+          <a:solidFill xmlns:a="http://schemas.openxmlformats.org/drawingml/2006/main">
+            <a:srgbClr val="111D32"/>
+          </a:solidFill>
+          <a:ln xmlns:a="http://schemas.openxmlformats.org/drawingml/2006/main" w="0">
+            <a:solidFill>
+              <a:srgbClr val="000000">
+                <a:alpha val="0"/>
+              </a:srgbClr>
+            </a:solidFill>
+            <a:prstDash val="solid"/>
+          </a:ln>
+        </p:spPr>
+      </p:sp>
+      <p:sp>
+        <p:nvSpPr>
+          <p:cNvPr id="20" name="">
+            <a:extLst xmlns:a="http://schemas.openxmlformats.org/drawingml/2006/main">
+              <a:ext uri="{FF2B5EF4-FFF2-40B4-BE49-F238E27FC236}">
+                <a16:creationId xmlns:a16="http://schemas.microsoft.com/office/drawing/2014/main" id="{9530C744-9838-48CC-A93A-6C0B391922E5}"/>
+              </a:ext>
+            </a:extLst>
+          </p:cNvPr>
+          <p:cNvSpPr>
+            <a:spLocks xmlns:a="http://schemas.openxmlformats.org/drawingml/2006/main" noGrp="1"/>
+          </p:cNvSpPr>
+          <p:nvPr/>
+        </p:nvSpPr>
+        <p:spPr>
+          <a:xfrm xmlns:a="http://schemas.openxmlformats.org/drawingml/2006/main">
+            <a:off x="3181350" y="5314950"/>
+            <a:ext cx="5829300" cy="228600"/>
+          </a:xfrm>
+          <a:prstGeom xmlns:a="http://schemas.openxmlformats.org/drawingml/2006/main" prst="rect">
+            <a:avLst/>
+          </a:prstGeom>
+          <a:solidFill xmlns:a="http://schemas.openxmlformats.org/drawingml/2006/main">
+            <a:srgbClr val="000000">
+              <a:alpha val="0"/>
+            </a:srgbClr>
+          </a:solidFill>
+          <a:ln xmlns:a="http://schemas.openxmlformats.org/drawingml/2006/main" w="0">
+            <a:solidFill>
+              <a:srgbClr val="000000">
+                <a:alpha val="0"/>
+              </a:srgbClr>
+            </a:solidFill>
+            <a:prstDash val="solid"/>
+          </a:ln>
+        </p:spPr>
+        <p:txBody>
+          <a:bodyPr xmlns:a="http://schemas.openxmlformats.org/drawingml/2006/main" lIns="0" tIns="0" rIns="0" bIns="0" anchor="t"/>
+          <a:lstStyle xmlns:a="http://schemas.openxmlformats.org/drawingml/2006/main"/>
+          <a:p xmlns:a="http://schemas.openxmlformats.org/drawingml/2006/main">
+            <a:pPr algn="ctr">
+              <a:defRPr sz="1350" b="1">
+                <a:solidFill>
+                  <a:srgbClr val="F7F3EA"/>
+                </a:solidFill>
+                <a:latin typeface="Aptos"/>
+                <a:ea typeface="Aptos"/>
+                <a:cs typeface="Aptos"/>
+              </a:defRPr>
+            </a:pPr>
+            <a:r>
+              <a:rPr sz="1350" b="1">
+                <a:solidFill>
+                  <a:srgbClr val="F7F3EA"/>
+                </a:solidFill>
+                <a:latin typeface="Aptos"/>
+                <a:ea typeface="Aptos"/>
+                <a:cs typeface="Aptos"/>
+              </a:rPr>
+              <a:t>CLICK HERE FOR LIVE BROWSER DEMO</a:t>
+            </a:r>
+          </a:p>
+        </p:txBody>
+      </p:sp>
+      <p:sp>
+        <p:nvSpPr>
+          <p:cNvPr id="21" name="">
+            <a:extLst xmlns:a="http://schemas.openxmlformats.org/drawingml/2006/main">
+              <a:ext uri="{FF2B5EF4-FFF2-40B4-BE49-F238E27FC236}">
+                <a16:creationId xmlns:a16="http://schemas.microsoft.com/office/drawing/2014/main" id="{922EEFB3-51FF-4ADD-9C86-9916A98105AA}"/>
+              </a:ext>
+            </a:extLst>
+          </p:cNvPr>
+          <p:cNvSpPr>
+            <a:spLocks xmlns:a="http://schemas.openxmlformats.org/drawingml/2006/main" noGrp="1"/>
+          </p:cNvSpPr>
+          <p:nvPr/>
+        </p:nvSpPr>
+        <p:spPr>
+          <a:xfrm xmlns:a="http://schemas.openxmlformats.org/drawingml/2006/main">
+            <a:off x="1962150" y="5886450"/>
+            <a:ext cx="8267700" cy="190500"/>
           </a:xfrm>
           <a:prstGeom xmlns:a="http://schemas.openxmlformats.org/drawingml/2006/main" prst="rect">
             <a:avLst/>
@@ -7784,7 +9904,7 @@
     </p:spTree>
     <p:extLst>
       <p:ext uri="{BB962C8B-B14F-4D97-AF65-F5344CB8AC3E}">
-        <p14:creationId xmlns:p14="http://schemas.microsoft.com/office/powerpoint/2010/main" val="1354282647"/>
+        <p14:creationId xmlns:p14="http://schemas.microsoft.com/office/powerpoint/2010/main" val="943759994"/>
       </p:ext>
     </p:extLst>
   </p:cSld>

</xml_diff>

<commit_message>
Reframe SynthAML as record-driven pattern discovery
</commit_message>
<xml_diff>
--- a/docs/synthaml-final-presentation.pptx
+++ b/docs/synthaml-final-presentation.pptx
@@ -2,19 +2,19 @@
 <file path=ppt/presentation.xml><?xml version="1.0" encoding="utf-8"?>
 <p:presentation xmlns:p="http://schemas.openxmlformats.org/presentationml/2006/main">
   <p:sldMasterIdLst>
-    <p:sldMasterId xmlns:r="http://schemas.openxmlformats.org/officeDocument/2006/relationships" id="2147483648" r:id="R3a2fce655f4f4826"/>
+    <p:sldMasterId xmlns:r="http://schemas.openxmlformats.org/officeDocument/2006/relationships" id="2147483648" r:id="Ra68f313c18804905"/>
   </p:sldMasterIdLst>
   <p:notesMasterIdLst>
-    <p:notesMasterId xmlns:r="http://schemas.openxmlformats.org/officeDocument/2006/relationships" r:id="R305f9166c38f47bb"/>
+    <p:notesMasterId xmlns:r="http://schemas.openxmlformats.org/officeDocument/2006/relationships" r:id="Rf46faca964c5475d"/>
   </p:notesMasterIdLst>
   <p:sldIdLst>
-    <p:sldId xmlns:r="http://schemas.openxmlformats.org/officeDocument/2006/relationships" id="256" r:id="R89e760b3261941b7"/>
-    <p:sldId xmlns:r="http://schemas.openxmlformats.org/officeDocument/2006/relationships" id="257" r:id="Re2ce619c0fb14d01"/>
-    <p:sldId xmlns:r="http://schemas.openxmlformats.org/officeDocument/2006/relationships" id="258" r:id="R802e3841f913462a"/>
-    <p:sldId xmlns:r="http://schemas.openxmlformats.org/officeDocument/2006/relationships" id="259" r:id="R98d1f3b385784555"/>
-    <p:sldId xmlns:r="http://schemas.openxmlformats.org/officeDocument/2006/relationships" id="260" r:id="Rd40b4e84048f41ba"/>
-    <p:sldId xmlns:r="http://schemas.openxmlformats.org/officeDocument/2006/relationships" id="261" r:id="Rbf01955847564b69"/>
-    <p:sldId xmlns:r="http://schemas.openxmlformats.org/officeDocument/2006/relationships" id="262" r:id="Re667ac80bce74e35"/>
+    <p:sldId xmlns:r="http://schemas.openxmlformats.org/officeDocument/2006/relationships" id="256" r:id="R5eed4f59fe914b62"/>
+    <p:sldId xmlns:r="http://schemas.openxmlformats.org/officeDocument/2006/relationships" id="257" r:id="R8772645b1b1d40b0"/>
+    <p:sldId xmlns:r="http://schemas.openxmlformats.org/officeDocument/2006/relationships" id="258" r:id="R325526c031924799"/>
+    <p:sldId xmlns:r="http://schemas.openxmlformats.org/officeDocument/2006/relationships" id="259" r:id="R3b3ecb53864c4b4e"/>
+    <p:sldId xmlns:r="http://schemas.openxmlformats.org/officeDocument/2006/relationships" id="260" r:id="R224bd872dd65472f"/>
+    <p:sldId xmlns:r="http://schemas.openxmlformats.org/officeDocument/2006/relationships" id="261" r:id="Rc0ba681470dd4de6"/>
+    <p:sldId xmlns:r="http://schemas.openxmlformats.org/officeDocument/2006/relationships" id="262" r:id="Re224aac4bae8434f"/>
   </p:sldIdLst>
   <p:sldSz cx="12192000" cy="6858000"/>
   <p:notesSz cx="6858000" cy="9144000"/>
@@ -957,7 +957,7 @@
   </p:cSld>
   <p:clrMap bg1="lt1" tx1="dk1" bg2="lt2" tx2="dk2" accent1="accent1" accent2="accent2" accent3="accent3" accent4="accent4" accent5="accent5" accent6="accent6" hlink="hlink" folHlink="folHlink"/>
   <p:sldLayoutIdLst>
-    <p:sldLayoutId xmlns:r="http://schemas.openxmlformats.org/officeDocument/2006/relationships" id="2147483649" r:id="R3c71c3e4e21b454e"/>
+    <p:sldLayoutId xmlns:r="http://schemas.openxmlformats.org/officeDocument/2006/relationships" id="2147483649" r:id="Re32c581106924607"/>
   </p:sldLayoutIdLst>
   <p:txStyles>
     <p:titleStyle>
@@ -1256,7 +1256,7 @@
           <p:cNvPr id="1" name="">
             <a:extLst xmlns:a="http://schemas.openxmlformats.org/drawingml/2006/main">
               <a:ext uri="{FF2B5EF4-FFF2-40B4-BE49-F238E27FC236}">
-                <a16:creationId xmlns:a16="http://schemas.microsoft.com/office/drawing/2014/main" id="{39CAB9FB-387D-47DF-95CF-2EF8D93D6922}"/>
+                <a16:creationId xmlns:a16="http://schemas.microsoft.com/office/drawing/2014/main" id="{EC383595-02AA-4CF5-8BA5-CFCB18620B77}"/>
               </a:ext>
             </a:extLst>
           </p:cNvPr>
@@ -1291,7 +1291,7 @@
           <p:cNvPr id="2" name="">
             <a:extLst xmlns:a="http://schemas.openxmlformats.org/drawingml/2006/main">
               <a:ext uri="{FF2B5EF4-FFF2-40B4-BE49-F238E27FC236}">
-                <a16:creationId xmlns:a16="http://schemas.microsoft.com/office/drawing/2014/main" id="{CF47CC68-88BE-4A45-9AF0-09FFA886E5AD}"/>
+                <a16:creationId xmlns:a16="http://schemas.microsoft.com/office/drawing/2014/main" id="{68C12D06-C8C8-4889-8547-F6D168C5E8C2}"/>
               </a:ext>
             </a:extLst>
           </p:cNvPr>
@@ -1326,7 +1326,7 @@
           <p:cNvPr id="3" name="">
             <a:extLst xmlns:a="http://schemas.openxmlformats.org/drawingml/2006/main">
               <a:ext uri="{FF2B5EF4-FFF2-40B4-BE49-F238E27FC236}">
-                <a16:creationId xmlns:a16="http://schemas.microsoft.com/office/drawing/2014/main" id="{CB624444-27DC-4FCE-A755-174F11EC28B7}"/>
+                <a16:creationId xmlns:a16="http://schemas.microsoft.com/office/drawing/2014/main" id="{75BF0E2E-2E6F-40E4-AF60-96B38C8C05BC}"/>
               </a:ext>
             </a:extLst>
           </p:cNvPr>
@@ -1390,7 +1390,7 @@
           <p:cNvPr id="4" name="">
             <a:extLst xmlns:a="http://schemas.openxmlformats.org/drawingml/2006/main">
               <a:ext uri="{FF2B5EF4-FFF2-40B4-BE49-F238E27FC236}">
-                <a16:creationId xmlns:a16="http://schemas.microsoft.com/office/drawing/2014/main" id="{7379FE1D-C1A6-4614-801A-7C2C6C586BA3}"/>
+                <a16:creationId xmlns:a16="http://schemas.microsoft.com/office/drawing/2014/main" id="{79FF6EA5-33F0-482A-9020-540CC7C22848}"/>
               </a:ext>
             </a:extLst>
           </p:cNvPr>
@@ -1454,7 +1454,7 @@
           <p:cNvPr id="5" name="">
             <a:extLst xmlns:a="http://schemas.openxmlformats.org/drawingml/2006/main">
               <a:ext uri="{FF2B5EF4-FFF2-40B4-BE49-F238E27FC236}">
-                <a16:creationId xmlns:a16="http://schemas.microsoft.com/office/drawing/2014/main" id="{5167B0EE-0DD1-41FB-A91B-2453B98CF36D}"/>
+                <a16:creationId xmlns:a16="http://schemas.microsoft.com/office/drawing/2014/main" id="{BD6983BA-1156-4080-AABF-B241F308EF65}"/>
               </a:ext>
             </a:extLst>
           </p:cNvPr>
@@ -1508,7 +1508,7 @@
                 <a:ea typeface="Aptos"/>
                 <a:cs typeface="Aptos"/>
               </a:rPr>
-              <a:t>A focused GenAI workflow for the AML data cold-start: from typology warning to reviewed model QA package.</a:t>
+              <a:t>A focused GenAI workflow for detecting candidate laundering patterns from records and turning them into model QA packages.</a:t>
             </a:r>
           </a:p>
         </p:txBody>
@@ -1518,7 +1518,7 @@
           <p:cNvPr id="6" name="">
             <a:extLst xmlns:a="http://schemas.openxmlformats.org/drawingml/2006/main">
               <a:ext uri="{FF2B5EF4-FFF2-40B4-BE49-F238E27FC236}">
-                <a16:creationId xmlns:a16="http://schemas.microsoft.com/office/drawing/2014/main" id="{C3957CFE-9626-4E85-A2BC-723FFA1E0E5C}"/>
+                <a16:creationId xmlns:a16="http://schemas.microsoft.com/office/drawing/2014/main" id="{1BA85056-DDB2-4DBD-B253-C2590523644A}"/>
               </a:ext>
             </a:extLst>
           </p:cNvPr>
@@ -1553,7 +1553,7 @@
           <p:cNvPr id="7" name="">
             <a:extLst xmlns:a="http://schemas.openxmlformats.org/drawingml/2006/main">
               <a:ext uri="{FF2B5EF4-FFF2-40B4-BE49-F238E27FC236}">
-                <a16:creationId xmlns:a16="http://schemas.microsoft.com/office/drawing/2014/main" id="{6B56629B-CE6E-41B5-ABC0-2DCBCE5B3A19}"/>
+                <a16:creationId xmlns:a16="http://schemas.microsoft.com/office/drawing/2014/main" id="{FA7BC993-4D35-48A9-BD80-58FFAEC9C3EA}"/>
               </a:ext>
             </a:extLst>
           </p:cNvPr>
@@ -1617,7 +1617,7 @@
           <p:cNvPr id="8" name="">
             <a:extLst xmlns:a="http://schemas.openxmlformats.org/drawingml/2006/main">
               <a:ext uri="{FF2B5EF4-FFF2-40B4-BE49-F238E27FC236}">
-                <a16:creationId xmlns:a16="http://schemas.microsoft.com/office/drawing/2014/main" id="{2CC43EF4-4084-480D-852D-85196DF2650C}"/>
+                <a16:creationId xmlns:a16="http://schemas.microsoft.com/office/drawing/2014/main" id="{10087370-BF67-4A3E-902E-582175E1F58E}"/>
               </a:ext>
             </a:extLst>
           </p:cNvPr>
@@ -1681,7 +1681,7 @@
           <p:cNvPr id="9" name="">
             <a:extLst xmlns:a="http://schemas.openxmlformats.org/drawingml/2006/main">
               <a:ext uri="{FF2B5EF4-FFF2-40B4-BE49-F238E27FC236}">
-                <a16:creationId xmlns:a16="http://schemas.microsoft.com/office/drawing/2014/main" id="{E7EE1238-4585-4AC2-825D-5EEC3759DFBB}"/>
+                <a16:creationId xmlns:a16="http://schemas.microsoft.com/office/drawing/2014/main" id="{12B9EA36-F047-4BB7-BBF0-F18349FABE0E}"/>
               </a:ext>
             </a:extLst>
           </p:cNvPr>
@@ -1745,7 +1745,7 @@
           <p:cNvPr id="10" name="">
             <a:extLst xmlns:a="http://schemas.openxmlformats.org/drawingml/2006/main">
               <a:ext uri="{FF2B5EF4-FFF2-40B4-BE49-F238E27FC236}">
-                <a16:creationId xmlns:a16="http://schemas.microsoft.com/office/drawing/2014/main" id="{05809DA0-A7B1-4AF3-82B9-046AD0F57A01}"/>
+                <a16:creationId xmlns:a16="http://schemas.microsoft.com/office/drawing/2014/main" id="{70C51C5D-8C2E-4C55-9C3B-46F3128CC05C}"/>
               </a:ext>
             </a:extLst>
           </p:cNvPr>
@@ -1799,7 +1799,7 @@
                 <a:ea typeface="Aptos"/>
                 <a:cs typeface="Aptos"/>
               </a:rPr>
-              <a:t>Warning to QA package</a:t>
+              <a:t>Records to QA package</a:t>
             </a:r>
           </a:p>
         </p:txBody>
@@ -1809,7 +1809,7 @@
           <p:cNvPr id="11" name="">
             <a:extLst xmlns:a="http://schemas.openxmlformats.org/drawingml/2006/main">
               <a:ext uri="{FF2B5EF4-FFF2-40B4-BE49-F238E27FC236}">
-                <a16:creationId xmlns:a16="http://schemas.microsoft.com/office/drawing/2014/main" id="{46E84EB7-0711-4588-9454-0210484C3824}"/>
+                <a16:creationId xmlns:a16="http://schemas.microsoft.com/office/drawing/2014/main" id="{E33E9A6F-8E1B-481F-99EA-D4B516B8B361}"/>
               </a:ext>
             </a:extLst>
           </p:cNvPr>
@@ -1873,7 +1873,7 @@
           <p:cNvPr id="12" name="">
             <a:extLst xmlns:a="http://schemas.openxmlformats.org/drawingml/2006/main">
               <a:ext uri="{FF2B5EF4-FFF2-40B4-BE49-F238E27FC236}">
-                <a16:creationId xmlns:a16="http://schemas.microsoft.com/office/drawing/2014/main" id="{64F98802-3882-42E0-8826-6073603EB6C9}"/>
+                <a16:creationId xmlns:a16="http://schemas.microsoft.com/office/drawing/2014/main" id="{0409908B-A7EF-4A2A-84A1-9B2F06B8A533}"/>
               </a:ext>
             </a:extLst>
           </p:cNvPr>
@@ -1937,7 +1937,7 @@
           <p:cNvPr id="13" name="">
             <a:extLst xmlns:a="http://schemas.openxmlformats.org/drawingml/2006/main">
               <a:ext uri="{FF2B5EF4-FFF2-40B4-BE49-F238E27FC236}">
-                <a16:creationId xmlns:a16="http://schemas.microsoft.com/office/drawing/2014/main" id="{7A85C393-5C8B-4A98-AA4F-44E55BF8042B}"/>
+                <a16:creationId xmlns:a16="http://schemas.microsoft.com/office/drawing/2014/main" id="{E761F536-19B8-4593-9ACE-AFE456E92646}"/>
               </a:ext>
             </a:extLst>
           </p:cNvPr>
@@ -1972,7 +1972,7 @@
           <p:cNvPr id="14" name="">
             <a:extLst xmlns:a="http://schemas.openxmlformats.org/drawingml/2006/main">
               <a:ext uri="{FF2B5EF4-FFF2-40B4-BE49-F238E27FC236}">
-                <a16:creationId xmlns:a16="http://schemas.microsoft.com/office/drawing/2014/main" id="{2ADAE7FF-ABA8-4039-9EDE-86DC90C9AA85}"/>
+                <a16:creationId xmlns:a16="http://schemas.microsoft.com/office/drawing/2014/main" id="{AE2E647D-6EB2-4400-9997-CCA3DC94FBA4}"/>
               </a:ext>
             </a:extLst>
           </p:cNvPr>
@@ -2036,7 +2036,7 @@
           <p:cNvPr id="15" name="">
             <a:extLst xmlns:a="http://schemas.openxmlformats.org/drawingml/2006/main">
               <a:ext uri="{FF2B5EF4-FFF2-40B4-BE49-F238E27FC236}">
-                <a16:creationId xmlns:a16="http://schemas.microsoft.com/office/drawing/2014/main" id="{A950BCBC-0DE0-40C3-BA33-EA904F836108}"/>
+                <a16:creationId xmlns:a16="http://schemas.microsoft.com/office/drawing/2014/main" id="{DEA31200-B6B4-4528-BCF1-4657FABDFBB7}"/>
               </a:ext>
             </a:extLst>
           </p:cNvPr>
@@ -2123,7 +2123,7 @@
           <p:cNvPr id="16" name="">
             <a:extLst xmlns:a="http://schemas.openxmlformats.org/drawingml/2006/main">
               <a:ext uri="{FF2B5EF4-FFF2-40B4-BE49-F238E27FC236}">
-                <a16:creationId xmlns:a16="http://schemas.microsoft.com/office/drawing/2014/main" id="{36E6BAE1-5F2E-41BF-A411-A3EC56A81F39}"/>
+                <a16:creationId xmlns:a16="http://schemas.microsoft.com/office/drawing/2014/main" id="{4C31179B-D606-4DF4-9D92-5E907D22067F}"/>
               </a:ext>
             </a:extLst>
           </p:cNvPr>
@@ -2187,7 +2187,7 @@
           <p:cNvPr id="17" name="">
             <a:extLst xmlns:a="http://schemas.openxmlformats.org/drawingml/2006/main">
               <a:ext uri="{FF2B5EF4-FFF2-40B4-BE49-F238E27FC236}">
-                <a16:creationId xmlns:a16="http://schemas.microsoft.com/office/drawing/2014/main" id="{AE23D9EB-B24B-4321-B6D6-D890868D7742}"/>
+                <a16:creationId xmlns:a16="http://schemas.microsoft.com/office/drawing/2014/main" id="{CA8843FB-CF93-4DA3-94A0-CC4C6219D38B}"/>
               </a:ext>
             </a:extLst>
           </p:cNvPr>
@@ -2240,7 +2240,6 @@
                 <a:latin typeface="Aptos"/>
                 <a:ea typeface="Aptos"/>
                 <a:cs typeface="Aptos"/>
-                <a:hlinkClick xmlns:r="http://schemas.openxmlformats.org/officeDocument/2006/relationships" r:id="rIdSynthAMLDemo"/>
               </a:rPr>
               <a:t>https://raw.githack.com/yq688m3JT/genAI_final/ae9c84ea574e9f8c48c84f1863ce82f77ea4f24e/docs/demo.html</a:t>
             </a:r>
@@ -2250,7 +2249,7 @@
     </p:spTree>
     <p:extLst>
       <p:ext uri="{BB962C8B-B14F-4D97-AF65-F5344CB8AC3E}">
-        <p14:creationId xmlns:p14="http://schemas.microsoft.com/office/powerpoint/2010/main" val="1442319251"/>
+        <p14:creationId xmlns:p14="http://schemas.microsoft.com/office/powerpoint/2010/main" val="1246424780"/>
       </p:ext>
     </p:extLst>
   </p:cSld>
@@ -2274,7 +2273,7 @@
           <p:cNvPr id="1" name="">
             <a:extLst xmlns:a="http://schemas.openxmlformats.org/drawingml/2006/main">
               <a:ext uri="{FF2B5EF4-FFF2-40B4-BE49-F238E27FC236}">
-                <a16:creationId xmlns:a16="http://schemas.microsoft.com/office/drawing/2014/main" id="{5AA3739A-ADFE-4021-9EA0-1F35BC43A3A6}"/>
+                <a16:creationId xmlns:a16="http://schemas.microsoft.com/office/drawing/2014/main" id="{57330D52-BF53-41D8-8D9A-B364DD4AF307}"/>
               </a:ext>
             </a:extLst>
           </p:cNvPr>
@@ -2309,7 +2308,7 @@
           <p:cNvPr id="2" name="kicker-marker">
             <a:extLst xmlns:a="http://schemas.openxmlformats.org/drawingml/2006/main">
               <a:ext uri="{FF2B5EF4-FFF2-40B4-BE49-F238E27FC236}">
-                <a16:creationId xmlns:a16="http://schemas.microsoft.com/office/drawing/2014/main" id="{F212126D-5C70-45D8-BC37-D556259F7F8F}"/>
+                <a16:creationId xmlns:a16="http://schemas.microsoft.com/office/drawing/2014/main" id="{6012C92C-AF98-4966-A481-860F2E82BD00}"/>
               </a:ext>
             </a:extLst>
           </p:cNvPr>
@@ -2344,7 +2343,7 @@
           <p:cNvPr id="3" name="kicker-label">
             <a:extLst xmlns:a="http://schemas.openxmlformats.org/drawingml/2006/main">
               <a:ext uri="{FF2B5EF4-FFF2-40B4-BE49-F238E27FC236}">
-                <a16:creationId xmlns:a16="http://schemas.microsoft.com/office/drawing/2014/main" id="{AB291D75-651D-49C1-81A2-C04F3F2C97A0}"/>
+                <a16:creationId xmlns:a16="http://schemas.microsoft.com/office/drawing/2014/main" id="{5B1D54C5-3FA9-4FFA-BDF5-88462F9BBCA8}"/>
               </a:ext>
             </a:extLst>
           </p:cNvPr>
@@ -2408,7 +2407,7 @@
           <p:cNvPr id="4" name="">
             <a:extLst xmlns:a="http://schemas.openxmlformats.org/drawingml/2006/main">
               <a:ext uri="{FF2B5EF4-FFF2-40B4-BE49-F238E27FC236}">
-                <a16:creationId xmlns:a16="http://schemas.microsoft.com/office/drawing/2014/main" id="{B0B981B8-F286-4957-8172-0AA47014EB78}"/>
+                <a16:creationId xmlns:a16="http://schemas.microsoft.com/office/drawing/2014/main" id="{18867EAC-58E3-45BA-B520-82C730DB290E}"/>
               </a:ext>
             </a:extLst>
           </p:cNvPr>
@@ -2462,7 +2461,7 @@
                 <a:ea typeface="Aptos Display"/>
                 <a:cs typeface="Aptos Display"/>
               </a:rPr>
-              <a:t>AML teams need to test new laundering patterns before real labeled cases exist.</a:t>
+              <a:t>AML teams need to turn messy laundering records into reusable model-test patterns.</a:t>
             </a:r>
           </a:p>
         </p:txBody>
@@ -2472,7 +2471,7 @@
           <p:cNvPr id="5" name="">
             <a:extLst xmlns:a="http://schemas.openxmlformats.org/drawingml/2006/main">
               <a:ext uri="{FF2B5EF4-FFF2-40B4-BE49-F238E27FC236}">
-                <a16:creationId xmlns:a16="http://schemas.microsoft.com/office/drawing/2014/main" id="{D92F87F2-DE5F-4515-B1FD-10CA5A933F3C}"/>
+                <a16:creationId xmlns:a16="http://schemas.microsoft.com/office/drawing/2014/main" id="{D623A52D-7883-43B5-89E9-2126851C205E}"/>
               </a:ext>
             </a:extLst>
           </p:cNvPr>
@@ -2536,7 +2535,7 @@
           <p:cNvPr id="6" name="">
             <a:extLst xmlns:a="http://schemas.openxmlformats.org/drawingml/2006/main">
               <a:ext uri="{FF2B5EF4-FFF2-40B4-BE49-F238E27FC236}">
-                <a16:creationId xmlns:a16="http://schemas.microsoft.com/office/drawing/2014/main" id="{6592A430-BEED-49EC-9A67-F44A12A9A644}"/>
+                <a16:creationId xmlns:a16="http://schemas.microsoft.com/office/drawing/2014/main" id="{7A12355E-AE44-4035-8EBF-7564E43AAE85}"/>
               </a:ext>
             </a:extLst>
           </p:cNvPr>
@@ -2571,7 +2570,7 @@
           <p:cNvPr id="7" name="">
             <a:extLst xmlns:a="http://schemas.openxmlformats.org/drawingml/2006/main">
               <a:ext uri="{FF2B5EF4-FFF2-40B4-BE49-F238E27FC236}">
-                <a16:creationId xmlns:a16="http://schemas.microsoft.com/office/drawing/2014/main" id="{2616D5A6-997B-4135-B05F-DCD9B1E01F05}"/>
+                <a16:creationId xmlns:a16="http://schemas.microsoft.com/office/drawing/2014/main" id="{24F974BE-8B62-4F95-AB34-182E1C5299C1}"/>
               </a:ext>
             </a:extLst>
           </p:cNvPr>
@@ -2635,7 +2634,7 @@
           <p:cNvPr id="8" name="">
             <a:extLst xmlns:a="http://schemas.openxmlformats.org/drawingml/2006/main">
               <a:ext uri="{FF2B5EF4-FFF2-40B4-BE49-F238E27FC236}">
-                <a16:creationId xmlns:a16="http://schemas.microsoft.com/office/drawing/2014/main" id="{0233AF46-9205-496C-B1D8-85D6BE5769E5}"/>
+                <a16:creationId xmlns:a16="http://schemas.microsoft.com/office/drawing/2014/main" id="{645534DD-5911-4D3A-BB7B-515DB23E0B80}"/>
               </a:ext>
             </a:extLst>
           </p:cNvPr>
@@ -2689,7 +2688,7 @@
                 <a:ea typeface="Aptos"/>
                 <a:cs typeface="Aptos"/>
               </a:rPr>
-              <a:t>New warning</a:t>
+              <a:t>Record batch</a:t>
             </a:r>
           </a:p>
         </p:txBody>
@@ -2699,7 +2698,7 @@
           <p:cNvPr id="9" name="">
             <a:extLst xmlns:a="http://schemas.openxmlformats.org/drawingml/2006/main">
               <a:ext uri="{FF2B5EF4-FFF2-40B4-BE49-F238E27FC236}">
-                <a16:creationId xmlns:a16="http://schemas.microsoft.com/office/drawing/2014/main" id="{8ADFD8B2-C4BF-4160-99F6-9866C5A836BD}"/>
+                <a16:creationId xmlns:a16="http://schemas.microsoft.com/office/drawing/2014/main" id="{0160D56C-8C62-4003-B929-0CAFA67B18AC}"/>
               </a:ext>
             </a:extLst>
           </p:cNvPr>
@@ -2753,7 +2752,7 @@
                 <a:ea typeface="Aptos"/>
                 <a:cs typeface="Aptos"/>
               </a:rPr>
-              <a:t>A regulator describes a shell-company trade pattern in prose.</a:t>
+              <a:t>Closed cases and suspicious samples contain repeated behavior.</a:t>
             </a:r>
           </a:p>
         </p:txBody>
@@ -2763,7 +2762,7 @@
           <p:cNvPr id="10" name="">
             <a:extLst xmlns:a="http://schemas.openxmlformats.org/drawingml/2006/main">
               <a:ext uri="{FF2B5EF4-FFF2-40B4-BE49-F238E27FC236}">
-                <a16:creationId xmlns:a16="http://schemas.microsoft.com/office/drawing/2014/main" id="{D6E96F76-380C-46B5-87CE-C5B627081ED9}"/>
+                <a16:creationId xmlns:a16="http://schemas.microsoft.com/office/drawing/2014/main" id="{8D113DEE-CDC1-42A5-B65A-E4AAB249B2D4}"/>
               </a:ext>
             </a:extLst>
           </p:cNvPr>
@@ -2798,7 +2797,7 @@
           <p:cNvPr id="11" name="">
             <a:extLst xmlns:a="http://schemas.openxmlformats.org/drawingml/2006/main">
               <a:ext uri="{FF2B5EF4-FFF2-40B4-BE49-F238E27FC236}">
-                <a16:creationId xmlns:a16="http://schemas.microsoft.com/office/drawing/2014/main" id="{5BD173DF-8191-4261-A1C2-D8B5A2F5502B}"/>
+                <a16:creationId xmlns:a16="http://schemas.microsoft.com/office/drawing/2014/main" id="{480FECA1-B9CB-46C9-B4DA-4689F1B159A4}"/>
               </a:ext>
             </a:extLst>
           </p:cNvPr>
@@ -2833,7 +2832,7 @@
           <p:cNvPr id="12" name="">
             <a:extLst xmlns:a="http://schemas.openxmlformats.org/drawingml/2006/main">
               <a:ext uri="{FF2B5EF4-FFF2-40B4-BE49-F238E27FC236}">
-                <a16:creationId xmlns:a16="http://schemas.microsoft.com/office/drawing/2014/main" id="{7DD1AFD4-BF4B-45BB-8033-AE8C7B3920AF}"/>
+                <a16:creationId xmlns:a16="http://schemas.microsoft.com/office/drawing/2014/main" id="{E3918A58-AB3F-424F-99DD-8845A4A530C9}"/>
               </a:ext>
             </a:extLst>
           </p:cNvPr>
@@ -2868,7 +2867,7 @@
           <p:cNvPr id="13" name="">
             <a:extLst xmlns:a="http://schemas.openxmlformats.org/drawingml/2006/main">
               <a:ext uri="{FF2B5EF4-FFF2-40B4-BE49-F238E27FC236}">
-                <a16:creationId xmlns:a16="http://schemas.microsoft.com/office/drawing/2014/main" id="{91BECE90-0660-4EE5-BCDE-3E2F3E52D7CD}"/>
+                <a16:creationId xmlns:a16="http://schemas.microsoft.com/office/drawing/2014/main" id="{FDD19470-D8B5-4C68-A22B-4BBE4BA08273}"/>
               </a:ext>
             </a:extLst>
           </p:cNvPr>
@@ -2932,7 +2931,7 @@
           <p:cNvPr id="14" name="">
             <a:extLst xmlns:a="http://schemas.openxmlformats.org/drawingml/2006/main">
               <a:ext uri="{FF2B5EF4-FFF2-40B4-BE49-F238E27FC236}">
-                <a16:creationId xmlns:a16="http://schemas.microsoft.com/office/drawing/2014/main" id="{79203AAA-1FEA-4327-8D2B-44A642AD920E}"/>
+                <a16:creationId xmlns:a16="http://schemas.microsoft.com/office/drawing/2014/main" id="{0463A178-1E4C-496E-9A67-D81DAA120C3C}"/>
               </a:ext>
             </a:extLst>
           </p:cNvPr>
@@ -2986,7 +2985,7 @@
                 <a:ea typeface="Aptos"/>
                 <a:cs typeface="Aptos"/>
               </a:rPr>
-              <a:t>No labels</a:t>
+              <a:t>No typology</a:t>
             </a:r>
           </a:p>
         </p:txBody>
@@ -2996,7 +2995,7 @@
           <p:cNvPr id="15" name="">
             <a:extLst xmlns:a="http://schemas.openxmlformats.org/drawingml/2006/main">
               <a:ext uri="{FF2B5EF4-FFF2-40B4-BE49-F238E27FC236}">
-                <a16:creationId xmlns:a16="http://schemas.microsoft.com/office/drawing/2014/main" id="{DFEE2614-7874-4C12-8283-351D0C830142}"/>
+                <a16:creationId xmlns:a16="http://schemas.microsoft.com/office/drawing/2014/main" id="{E5BB8646-A2EA-4615-B085-F2125D58BC61}"/>
               </a:ext>
             </a:extLst>
           </p:cNvPr>
@@ -3050,7 +3049,7 @@
                 <a:ea typeface="Aptos"/>
                 <a:cs typeface="Aptos"/>
               </a:rPr>
-              <a:t>The model team cannot train or test on cases it has not seen.</a:t>
+              <a:t>The pattern is not yet formalized into a reusable test scenario.</a:t>
             </a:r>
           </a:p>
         </p:txBody>
@@ -3060,7 +3059,7 @@
           <p:cNvPr id="16" name="">
             <a:extLst xmlns:a="http://schemas.openxmlformats.org/drawingml/2006/main">
               <a:ext uri="{FF2B5EF4-FFF2-40B4-BE49-F238E27FC236}">
-                <a16:creationId xmlns:a16="http://schemas.microsoft.com/office/drawing/2014/main" id="{2FA4D1D5-B0A3-4086-ADD3-67FB2C22FEB5}"/>
+                <a16:creationId xmlns:a16="http://schemas.microsoft.com/office/drawing/2014/main" id="{B346B160-BAAE-45D0-89C5-3D257F7FF573}"/>
               </a:ext>
             </a:extLst>
           </p:cNvPr>
@@ -3095,7 +3094,7 @@
           <p:cNvPr id="17" name="">
             <a:extLst xmlns:a="http://schemas.openxmlformats.org/drawingml/2006/main">
               <a:ext uri="{FF2B5EF4-FFF2-40B4-BE49-F238E27FC236}">
-                <a16:creationId xmlns:a16="http://schemas.microsoft.com/office/drawing/2014/main" id="{A2A095E8-09A8-4BB7-AA3C-F2AAE9FA3F29}"/>
+                <a16:creationId xmlns:a16="http://schemas.microsoft.com/office/drawing/2014/main" id="{CFF80E1D-5183-4F48-B809-5A7E2401D826}"/>
               </a:ext>
             </a:extLst>
           </p:cNvPr>
@@ -3130,7 +3129,7 @@
           <p:cNvPr id="18" name="">
             <a:extLst xmlns:a="http://schemas.openxmlformats.org/drawingml/2006/main">
               <a:ext uri="{FF2B5EF4-FFF2-40B4-BE49-F238E27FC236}">
-                <a16:creationId xmlns:a16="http://schemas.microsoft.com/office/drawing/2014/main" id="{9F9E0F82-BABA-4E47-809B-4AF461320A79}"/>
+                <a16:creationId xmlns:a16="http://schemas.microsoft.com/office/drawing/2014/main" id="{BCC3BFAA-3514-44FC-AE0A-A2E86FAD1EF5}"/>
               </a:ext>
             </a:extLst>
           </p:cNvPr>
@@ -3165,7 +3164,7 @@
           <p:cNvPr id="19" name="">
             <a:extLst xmlns:a="http://schemas.openxmlformats.org/drawingml/2006/main">
               <a:ext uri="{FF2B5EF4-FFF2-40B4-BE49-F238E27FC236}">
-                <a16:creationId xmlns:a16="http://schemas.microsoft.com/office/drawing/2014/main" id="{0BF7089A-B0F4-47AB-B7EF-FE060604A20C}"/>
+                <a16:creationId xmlns:a16="http://schemas.microsoft.com/office/drawing/2014/main" id="{EF18ADB2-8139-4A7C-83C6-ECB89474A770}"/>
               </a:ext>
             </a:extLst>
           </p:cNvPr>
@@ -3229,7 +3228,7 @@
           <p:cNvPr id="20" name="">
             <a:extLst xmlns:a="http://schemas.openxmlformats.org/drawingml/2006/main">
               <a:ext uri="{FF2B5EF4-FFF2-40B4-BE49-F238E27FC236}">
-                <a16:creationId xmlns:a16="http://schemas.microsoft.com/office/drawing/2014/main" id="{4272A77A-DCD0-4CE5-9615-1869457BE1AB}"/>
+                <a16:creationId xmlns:a16="http://schemas.microsoft.com/office/drawing/2014/main" id="{A5D1CC8F-7405-4A67-9F21-6F00D8F54008}"/>
               </a:ext>
             </a:extLst>
           </p:cNvPr>
@@ -3293,7 +3292,7 @@
           <p:cNvPr id="21" name="">
             <a:extLst xmlns:a="http://schemas.openxmlformats.org/drawingml/2006/main">
               <a:ext uri="{FF2B5EF4-FFF2-40B4-BE49-F238E27FC236}">
-                <a16:creationId xmlns:a16="http://schemas.microsoft.com/office/drawing/2014/main" id="{CB098091-0065-41D9-AE38-3707E9B0DC9B}"/>
+                <a16:creationId xmlns:a16="http://schemas.microsoft.com/office/drawing/2014/main" id="{6E6C2538-78BE-45CF-8D78-B02A84FB6339}"/>
               </a:ext>
             </a:extLst>
           </p:cNvPr>
@@ -3357,7 +3356,7 @@
           <p:cNvPr id="22" name="">
             <a:extLst xmlns:a="http://schemas.openxmlformats.org/drawingml/2006/main">
               <a:ext uri="{FF2B5EF4-FFF2-40B4-BE49-F238E27FC236}">
-                <a16:creationId xmlns:a16="http://schemas.microsoft.com/office/drawing/2014/main" id="{B9B20DC0-2520-4FF7-BFE8-C082F4A2A750}"/>
+                <a16:creationId xmlns:a16="http://schemas.microsoft.com/office/drawing/2014/main" id="{AF65CF4D-C121-44CC-90D7-A0F70ED1100A}"/>
               </a:ext>
             </a:extLst>
           </p:cNvPr>
@@ -3390,7 +3389,7 @@
           <p:cNvPr id="23" name="">
             <a:extLst xmlns:a="http://schemas.openxmlformats.org/drawingml/2006/main">
               <a:ext uri="{FF2B5EF4-FFF2-40B4-BE49-F238E27FC236}">
-                <a16:creationId xmlns:a16="http://schemas.microsoft.com/office/drawing/2014/main" id="{B3942341-7038-44F9-981F-3656B8D9CCA4}"/>
+                <a16:creationId xmlns:a16="http://schemas.microsoft.com/office/drawing/2014/main" id="{E1DEBF0C-B08E-437D-9FC0-95004ABC6D6A}"/>
               </a:ext>
             </a:extLst>
           </p:cNvPr>
@@ -3454,7 +3453,7 @@
           <p:cNvPr id="24" name="">
             <a:extLst xmlns:a="http://schemas.openxmlformats.org/drawingml/2006/main">
               <a:ext uri="{FF2B5EF4-FFF2-40B4-BE49-F238E27FC236}">
-                <a16:creationId xmlns:a16="http://schemas.microsoft.com/office/drawing/2014/main" id="{304190EE-6DBE-405E-98F0-2B6881B9F8B1}"/>
+                <a16:creationId xmlns:a16="http://schemas.microsoft.com/office/drawing/2014/main" id="{2FEDD4B9-A60F-4B0D-B0E3-4655E9CB2506}"/>
               </a:ext>
             </a:extLst>
           </p:cNvPr>
@@ -3541,7 +3540,7 @@
           <p:cNvPr id="25" name="">
             <a:extLst xmlns:a="http://schemas.openxmlformats.org/drawingml/2006/main">
               <a:ext uri="{FF2B5EF4-FFF2-40B4-BE49-F238E27FC236}">
-                <a16:creationId xmlns:a16="http://schemas.microsoft.com/office/drawing/2014/main" id="{61EE42A3-E8B2-42DC-BB54-C577627691CD}"/>
+                <a16:creationId xmlns:a16="http://schemas.microsoft.com/office/drawing/2014/main" id="{2D322983-A630-4BC1-9ACD-848E4685542F}"/>
               </a:ext>
             </a:extLst>
           </p:cNvPr>
@@ -3576,7 +3575,7 @@
           <p:cNvPr id="26" name="">
             <a:extLst xmlns:a="http://schemas.openxmlformats.org/drawingml/2006/main">
               <a:ext uri="{FF2B5EF4-FFF2-40B4-BE49-F238E27FC236}">
-                <a16:creationId xmlns:a16="http://schemas.microsoft.com/office/drawing/2014/main" id="{019F47C6-5978-4EE9-A562-51915D4BDE25}"/>
+                <a16:creationId xmlns:a16="http://schemas.microsoft.com/office/drawing/2014/main" id="{4204AC96-F685-4E6D-8C5C-D6DB9753CC34}"/>
               </a:ext>
             </a:extLst>
           </p:cNvPr>
@@ -3638,7 +3637,7 @@
     </p:spTree>
     <p:extLst>
       <p:ext uri="{BB962C8B-B14F-4D97-AF65-F5344CB8AC3E}">
-        <p14:creationId xmlns:p14="http://schemas.microsoft.com/office/powerpoint/2010/main" val="452683369"/>
+        <p14:creationId xmlns:p14="http://schemas.microsoft.com/office/powerpoint/2010/main" val="716766767"/>
       </p:ext>
     </p:extLst>
   </p:cSld>
@@ -3662,7 +3661,7 @@
           <p:cNvPr id="1" name="">
             <a:extLst xmlns:a="http://schemas.openxmlformats.org/drawingml/2006/main">
               <a:ext uri="{FF2B5EF4-FFF2-40B4-BE49-F238E27FC236}">
-                <a16:creationId xmlns:a16="http://schemas.microsoft.com/office/drawing/2014/main" id="{F181F354-4ED8-411D-A63E-13F7CFF7AC17}"/>
+                <a16:creationId xmlns:a16="http://schemas.microsoft.com/office/drawing/2014/main" id="{AAC8A639-C47F-4AA1-92C7-5DAFE3DE16F7}"/>
               </a:ext>
             </a:extLst>
           </p:cNvPr>
@@ -3697,7 +3696,7 @@
           <p:cNvPr id="2" name="kicker-marker">
             <a:extLst xmlns:a="http://schemas.openxmlformats.org/drawingml/2006/main">
               <a:ext uri="{FF2B5EF4-FFF2-40B4-BE49-F238E27FC236}">
-                <a16:creationId xmlns:a16="http://schemas.microsoft.com/office/drawing/2014/main" id="{B7138D3A-9BCC-4F4F-9AD1-58744BB2151B}"/>
+                <a16:creationId xmlns:a16="http://schemas.microsoft.com/office/drawing/2014/main" id="{B7D5556F-2795-4684-97A2-EEB64685B8D4}"/>
               </a:ext>
             </a:extLst>
           </p:cNvPr>
@@ -3732,7 +3731,7 @@
           <p:cNvPr id="3" name="kicker-label">
             <a:extLst xmlns:a="http://schemas.openxmlformats.org/drawingml/2006/main">
               <a:ext uri="{FF2B5EF4-FFF2-40B4-BE49-F238E27FC236}">
-                <a16:creationId xmlns:a16="http://schemas.microsoft.com/office/drawing/2014/main" id="{6855E705-17EB-445B-902B-95A441BFF666}"/>
+                <a16:creationId xmlns:a16="http://schemas.microsoft.com/office/drawing/2014/main" id="{BC2736FB-FEAE-43C0-A4C0-61FD6734B92B}"/>
               </a:ext>
             </a:extLst>
           </p:cNvPr>
@@ -3796,7 +3795,7 @@
           <p:cNvPr id="4" name="">
             <a:extLst xmlns:a="http://schemas.openxmlformats.org/drawingml/2006/main">
               <a:ext uri="{FF2B5EF4-FFF2-40B4-BE49-F238E27FC236}">
-                <a16:creationId xmlns:a16="http://schemas.microsoft.com/office/drawing/2014/main" id="{CF7E0C9B-E2DD-44BC-BC4E-7335D9EDF0BC}"/>
+                <a16:creationId xmlns:a16="http://schemas.microsoft.com/office/drawing/2014/main" id="{1E928784-6792-429F-A9CD-C8A6AEAF81BA}"/>
               </a:ext>
             </a:extLst>
           </p:cNvPr>
@@ -3850,7 +3849,7 @@
                 <a:ea typeface="Aptos Display"/>
                 <a:cs typeface="Aptos Display"/>
               </a:rPr>
-              <a:t>SynthAML supports the full handoff from compliance prose to model QA artifacts.</a:t>
+              <a:t>SynthAML uses GenAI to detect a candidate typology from suspicious record batches.</a:t>
             </a:r>
           </a:p>
         </p:txBody>
@@ -3860,7 +3859,7 @@
           <p:cNvPr id="5" name="">
             <a:extLst xmlns:a="http://schemas.openxmlformats.org/drawingml/2006/main">
               <a:ext uri="{FF2B5EF4-FFF2-40B4-BE49-F238E27FC236}">
-                <a16:creationId xmlns:a16="http://schemas.microsoft.com/office/drawing/2014/main" id="{30900884-D585-4CFF-B650-ADB5E9260BD6}"/>
+                <a16:creationId xmlns:a16="http://schemas.microsoft.com/office/drawing/2014/main" id="{EE4FF20A-28B8-4DBA-BDF4-0E681D57DFD7}"/>
               </a:ext>
             </a:extLst>
           </p:cNvPr>
@@ -3895,7 +3894,7 @@
           <p:cNvPr id="6" name="">
             <a:extLst xmlns:a="http://schemas.openxmlformats.org/drawingml/2006/main">
               <a:ext uri="{FF2B5EF4-FFF2-40B4-BE49-F238E27FC236}">
-                <a16:creationId xmlns:a16="http://schemas.microsoft.com/office/drawing/2014/main" id="{0105046F-D003-404D-9217-1FDD00538105}"/>
+                <a16:creationId xmlns:a16="http://schemas.microsoft.com/office/drawing/2014/main" id="{5FE2F976-B612-4BCF-9A22-F62569B68339}"/>
               </a:ext>
             </a:extLst>
           </p:cNvPr>
@@ -3959,7 +3958,7 @@
           <p:cNvPr id="7" name="">
             <a:extLst xmlns:a="http://schemas.openxmlformats.org/drawingml/2006/main">
               <a:ext uri="{FF2B5EF4-FFF2-40B4-BE49-F238E27FC236}">
-                <a16:creationId xmlns:a16="http://schemas.microsoft.com/office/drawing/2014/main" id="{7668BE2D-8056-41E8-889C-3053FE0B08E4}"/>
+                <a16:creationId xmlns:a16="http://schemas.microsoft.com/office/drawing/2014/main" id="{FA3CDC97-CA05-4AFB-ADDF-EC72DFE03321}"/>
               </a:ext>
             </a:extLst>
           </p:cNvPr>
@@ -3992,7 +3991,7 @@
           <p:cNvPr id="8" name="">
             <a:extLst xmlns:a="http://schemas.openxmlformats.org/drawingml/2006/main">
               <a:ext uri="{FF2B5EF4-FFF2-40B4-BE49-F238E27FC236}">
-                <a16:creationId xmlns:a16="http://schemas.microsoft.com/office/drawing/2014/main" id="{C700AB5E-AE4C-40A4-BE6D-F5103BDE5918}"/>
+                <a16:creationId xmlns:a16="http://schemas.microsoft.com/office/drawing/2014/main" id="{83E675DF-DC2B-4277-8E6D-359848C58AD0}"/>
               </a:ext>
             </a:extLst>
           </p:cNvPr>
@@ -4056,7 +4055,7 @@
           <p:cNvPr id="9" name="">
             <a:extLst xmlns:a="http://schemas.openxmlformats.org/drawingml/2006/main">
               <a:ext uri="{FF2B5EF4-FFF2-40B4-BE49-F238E27FC236}">
-                <a16:creationId xmlns:a16="http://schemas.microsoft.com/office/drawing/2014/main" id="{9AFA27B1-0211-4C93-980A-6C5095AED6D5}"/>
+                <a16:creationId xmlns:a16="http://schemas.microsoft.com/office/drawing/2014/main" id="{B7807BDC-06A6-4562-ACCF-A78FF65F5470}"/>
               </a:ext>
             </a:extLst>
           </p:cNvPr>
@@ -4110,7 +4109,7 @@
                 <a:ea typeface="Aptos"/>
                 <a:cs typeface="Aptos"/>
               </a:rPr>
-              <a:t>Ingest</a:t>
+              <a:t>Self-intake</a:t>
             </a:r>
           </a:p>
         </p:txBody>
@@ -4120,7 +4119,7 @@
           <p:cNvPr id="10" name="">
             <a:extLst xmlns:a="http://schemas.openxmlformats.org/drawingml/2006/main">
               <a:ext uri="{FF2B5EF4-FFF2-40B4-BE49-F238E27FC236}">
-                <a16:creationId xmlns:a16="http://schemas.microsoft.com/office/drawing/2014/main" id="{908791C8-FFF9-4ADE-98AF-7B5C10249347}"/>
+                <a16:creationId xmlns:a16="http://schemas.microsoft.com/office/drawing/2014/main" id="{87AF300A-E312-47F5-8DE9-6819C17D1A03}"/>
               </a:ext>
             </a:extLst>
           </p:cNvPr>
@@ -4174,7 +4173,7 @@
                 <a:ea typeface="Aptos"/>
                 <a:cs typeface="Aptos"/>
               </a:rPr>
-              <a:t>Import alert text from a feed, case queue, memo, or knowledge base</a:t>
+              <a:t>Ingest closed cases, suspicious samples, or analyst notes</a:t>
             </a:r>
           </a:p>
         </p:txBody>
@@ -4184,7 +4183,7 @@
           <p:cNvPr id="11" name="">
             <a:extLst xmlns:a="http://schemas.openxmlformats.org/drawingml/2006/main">
               <a:ext uri="{FF2B5EF4-FFF2-40B4-BE49-F238E27FC236}">
-                <a16:creationId xmlns:a16="http://schemas.microsoft.com/office/drawing/2014/main" id="{FDD50E75-0C79-4B42-8EB6-883106C22FF3}"/>
+                <a16:creationId xmlns:a16="http://schemas.microsoft.com/office/drawing/2014/main" id="{FE9BC0DD-B5DF-4CE4-B242-AC3572DFCF03}"/>
               </a:ext>
             </a:extLst>
           </p:cNvPr>
@@ -4219,7 +4218,7 @@
           <p:cNvPr id="12" name="">
             <a:extLst xmlns:a="http://schemas.openxmlformats.org/drawingml/2006/main">
               <a:ext uri="{FF2B5EF4-FFF2-40B4-BE49-F238E27FC236}">
-                <a16:creationId xmlns:a16="http://schemas.microsoft.com/office/drawing/2014/main" id="{56EE2556-BCFB-42B9-96AE-AEDA8E987D8E}"/>
+                <a16:creationId xmlns:a16="http://schemas.microsoft.com/office/drawing/2014/main" id="{02F5D548-F6E5-4A4A-BB1F-69220667CEAE}"/>
               </a:ext>
             </a:extLst>
           </p:cNvPr>
@@ -4254,7 +4253,7 @@
           <p:cNvPr id="13" name="">
             <a:extLst xmlns:a="http://schemas.openxmlformats.org/drawingml/2006/main">
               <a:ext uri="{FF2B5EF4-FFF2-40B4-BE49-F238E27FC236}">
-                <a16:creationId xmlns:a16="http://schemas.microsoft.com/office/drawing/2014/main" id="{E4BD0452-3BFF-4712-A058-10DB449DBB08}"/>
+                <a16:creationId xmlns:a16="http://schemas.microsoft.com/office/drawing/2014/main" id="{4946F63B-6244-43E9-9695-2EEC063AFF33}"/>
               </a:ext>
             </a:extLst>
           </p:cNvPr>
@@ -4287,7 +4286,7 @@
           <p:cNvPr id="14" name="">
             <a:extLst xmlns:a="http://schemas.openxmlformats.org/drawingml/2006/main">
               <a:ext uri="{FF2B5EF4-FFF2-40B4-BE49-F238E27FC236}">
-                <a16:creationId xmlns:a16="http://schemas.microsoft.com/office/drawing/2014/main" id="{354A4F9B-821D-40A2-861E-EC55A6AACAB5}"/>
+                <a16:creationId xmlns:a16="http://schemas.microsoft.com/office/drawing/2014/main" id="{11049A39-AB8D-4B5E-A74E-94650CD4A43E}"/>
               </a:ext>
             </a:extLst>
           </p:cNvPr>
@@ -4351,7 +4350,7 @@
           <p:cNvPr id="15" name="">
             <a:extLst xmlns:a="http://schemas.openxmlformats.org/drawingml/2006/main">
               <a:ext uri="{FF2B5EF4-FFF2-40B4-BE49-F238E27FC236}">
-                <a16:creationId xmlns:a16="http://schemas.microsoft.com/office/drawing/2014/main" id="{69B1511B-AB7F-483C-98A6-BE3DF6004AEC}"/>
+                <a16:creationId xmlns:a16="http://schemas.microsoft.com/office/drawing/2014/main" id="{20E82A60-148E-4FD3-A5BD-423B4258C889}"/>
               </a:ext>
             </a:extLst>
           </p:cNvPr>
@@ -4405,7 +4404,7 @@
                 <a:ea typeface="Aptos"/>
                 <a:cs typeface="Aptos"/>
               </a:rPr>
-              <a:t>Review</a:t>
+              <a:t>Discover</a:t>
             </a:r>
           </a:p>
         </p:txBody>
@@ -4415,7 +4414,7 @@
           <p:cNvPr id="16" name="">
             <a:extLst xmlns:a="http://schemas.openxmlformats.org/drawingml/2006/main">
               <a:ext uri="{FF2B5EF4-FFF2-40B4-BE49-F238E27FC236}">
-                <a16:creationId xmlns:a16="http://schemas.microsoft.com/office/drawing/2014/main" id="{B448A222-B977-4B7F-A0A1-6CE9B5F397B2}"/>
+                <a16:creationId xmlns:a16="http://schemas.microsoft.com/office/drawing/2014/main" id="{CF4995D9-E6EC-4291-9E5D-134CC5D1810A}"/>
               </a:ext>
             </a:extLst>
           </p:cNvPr>
@@ -4469,7 +4468,7 @@
                 <a:ea typeface="Aptos"/>
                 <a:cs typeface="Aptos"/>
               </a:rPr>
-              <a:t>Approve extracted regions, timing, narratives, and methods</a:t>
+              <a:t>LLM proposes recurring regions, timing, narratives, and methods</a:t>
             </a:r>
           </a:p>
         </p:txBody>
@@ -4479,7 +4478,7 @@
           <p:cNvPr id="17" name="">
             <a:extLst xmlns:a="http://schemas.openxmlformats.org/drawingml/2006/main">
               <a:ext uri="{FF2B5EF4-FFF2-40B4-BE49-F238E27FC236}">
-                <a16:creationId xmlns:a16="http://schemas.microsoft.com/office/drawing/2014/main" id="{DF3FE2F2-F91B-4E52-BB91-10CF9CDCB95E}"/>
+                <a16:creationId xmlns:a16="http://schemas.microsoft.com/office/drawing/2014/main" id="{30B13C90-A99C-4971-A1D9-8BF5DCD1A36E}"/>
               </a:ext>
             </a:extLst>
           </p:cNvPr>
@@ -4514,7 +4513,7 @@
           <p:cNvPr id="18" name="">
             <a:extLst xmlns:a="http://schemas.openxmlformats.org/drawingml/2006/main">
               <a:ext uri="{FF2B5EF4-FFF2-40B4-BE49-F238E27FC236}">
-                <a16:creationId xmlns:a16="http://schemas.microsoft.com/office/drawing/2014/main" id="{7A639F42-EB4F-41E2-B182-16955B3CE4D2}"/>
+                <a16:creationId xmlns:a16="http://schemas.microsoft.com/office/drawing/2014/main" id="{74DF194B-2EE1-4032-B125-BB98D2BFF4F0}"/>
               </a:ext>
             </a:extLst>
           </p:cNvPr>
@@ -4549,7 +4548,7 @@
           <p:cNvPr id="19" name="">
             <a:extLst xmlns:a="http://schemas.openxmlformats.org/drawingml/2006/main">
               <a:ext uri="{FF2B5EF4-FFF2-40B4-BE49-F238E27FC236}">
-                <a16:creationId xmlns:a16="http://schemas.microsoft.com/office/drawing/2014/main" id="{A263C8C5-555C-41B1-AFFD-4A5E6B6D25E0}"/>
+                <a16:creationId xmlns:a16="http://schemas.microsoft.com/office/drawing/2014/main" id="{B734F563-B1DA-4243-98E1-2E9E934D1A7D}"/>
               </a:ext>
             </a:extLst>
           </p:cNvPr>
@@ -4582,7 +4581,7 @@
           <p:cNvPr id="20" name="">
             <a:extLst xmlns:a="http://schemas.openxmlformats.org/drawingml/2006/main">
               <a:ext uri="{FF2B5EF4-FFF2-40B4-BE49-F238E27FC236}">
-                <a16:creationId xmlns:a16="http://schemas.microsoft.com/office/drawing/2014/main" id="{394A1ED9-5D05-456C-9FA5-764EA333C761}"/>
+                <a16:creationId xmlns:a16="http://schemas.microsoft.com/office/drawing/2014/main" id="{8B5FC658-3DD0-4A05-BE25-9A65F66654F6}"/>
               </a:ext>
             </a:extLst>
           </p:cNvPr>
@@ -4646,7 +4645,7 @@
           <p:cNvPr id="21" name="">
             <a:extLst xmlns:a="http://schemas.openxmlformats.org/drawingml/2006/main">
               <a:ext uri="{FF2B5EF4-FFF2-40B4-BE49-F238E27FC236}">
-                <a16:creationId xmlns:a16="http://schemas.microsoft.com/office/drawing/2014/main" id="{8327D020-E942-4EF0-A41C-38AD6ECCF629}"/>
+                <a16:creationId xmlns:a16="http://schemas.microsoft.com/office/drawing/2014/main" id="{221A2436-E472-4A9E-B081-6EF32F26092D}"/>
               </a:ext>
             </a:extLst>
           </p:cNvPr>
@@ -4700,7 +4699,7 @@
                 <a:ea typeface="Aptos"/>
                 <a:cs typeface="Aptos"/>
               </a:rPr>
-              <a:t>Generate</a:t>
+              <a:t>Validate</a:t>
             </a:r>
           </a:p>
         </p:txBody>
@@ -4710,7 +4709,7 @@
           <p:cNvPr id="22" name="">
             <a:extLst xmlns:a="http://schemas.openxmlformats.org/drawingml/2006/main">
               <a:ext uri="{FF2B5EF4-FFF2-40B4-BE49-F238E27FC236}">
-                <a16:creationId xmlns:a16="http://schemas.microsoft.com/office/drawing/2014/main" id="{ED9EC9C9-4D25-4A35-90D0-566BCD471E5B}"/>
+                <a16:creationId xmlns:a16="http://schemas.microsoft.com/office/drawing/2014/main" id="{173ED115-4038-430E-917C-F50C9A5ABB5A}"/>
               </a:ext>
             </a:extLst>
           </p:cNvPr>
@@ -4764,7 +4763,7 @@
                 <a:ea typeface="Aptos"/>
                 <a:cs typeface="Aptos"/>
               </a:rPr>
-              <a:t>Create normal traffic plus suspicious multi-step chains</a:t>
+              <a:t>Analyst approves the detected pattern, not hand-written rules</a:t>
             </a:r>
           </a:p>
         </p:txBody>
@@ -4774,7 +4773,7 @@
           <p:cNvPr id="23" name="">
             <a:extLst xmlns:a="http://schemas.openxmlformats.org/drawingml/2006/main">
               <a:ext uri="{FF2B5EF4-FFF2-40B4-BE49-F238E27FC236}">
-                <a16:creationId xmlns:a16="http://schemas.microsoft.com/office/drawing/2014/main" id="{01A5F604-E3DC-453E-8D48-D60B190EED5E}"/>
+                <a16:creationId xmlns:a16="http://schemas.microsoft.com/office/drawing/2014/main" id="{595D4EF7-2BBE-4AA8-9DB3-1CFD203F63D5}"/>
               </a:ext>
             </a:extLst>
           </p:cNvPr>
@@ -4809,7 +4808,7 @@
           <p:cNvPr id="24" name="">
             <a:extLst xmlns:a="http://schemas.openxmlformats.org/drawingml/2006/main">
               <a:ext uri="{FF2B5EF4-FFF2-40B4-BE49-F238E27FC236}">
-                <a16:creationId xmlns:a16="http://schemas.microsoft.com/office/drawing/2014/main" id="{366E6F1D-AAA6-45EB-A653-FE402BA936FB}"/>
+                <a16:creationId xmlns:a16="http://schemas.microsoft.com/office/drawing/2014/main" id="{8FA17389-9A2A-49D7-8882-0E52B418F924}"/>
               </a:ext>
             </a:extLst>
           </p:cNvPr>
@@ -4844,7 +4843,7 @@
           <p:cNvPr id="25" name="">
             <a:extLst xmlns:a="http://schemas.openxmlformats.org/drawingml/2006/main">
               <a:ext uri="{FF2B5EF4-FFF2-40B4-BE49-F238E27FC236}">
-                <a16:creationId xmlns:a16="http://schemas.microsoft.com/office/drawing/2014/main" id="{8188FAE9-D7A0-404E-8D4C-D1151ABD28C8}"/>
+                <a16:creationId xmlns:a16="http://schemas.microsoft.com/office/drawing/2014/main" id="{931EED2E-FDFB-47DA-ABA2-533167BB8BC4}"/>
               </a:ext>
             </a:extLst>
           </p:cNvPr>
@@ -4877,7 +4876,7 @@
           <p:cNvPr id="26" name="">
             <a:extLst xmlns:a="http://schemas.openxmlformats.org/drawingml/2006/main">
               <a:ext uri="{FF2B5EF4-FFF2-40B4-BE49-F238E27FC236}">
-                <a16:creationId xmlns:a16="http://schemas.microsoft.com/office/drawing/2014/main" id="{F8C9B0D2-2538-45A2-87E0-31DA6B6DDD89}"/>
+                <a16:creationId xmlns:a16="http://schemas.microsoft.com/office/drawing/2014/main" id="{796EE8D2-D17F-422A-8ED2-CE371BD5C49D}"/>
               </a:ext>
             </a:extLst>
           </p:cNvPr>
@@ -4941,7 +4940,7 @@
           <p:cNvPr id="27" name="">
             <a:extLst xmlns:a="http://schemas.openxmlformats.org/drawingml/2006/main">
               <a:ext uri="{FF2B5EF4-FFF2-40B4-BE49-F238E27FC236}">
-                <a16:creationId xmlns:a16="http://schemas.microsoft.com/office/drawing/2014/main" id="{C3317E09-D4F5-4D3E-A86D-E6B86C158CBF}"/>
+                <a16:creationId xmlns:a16="http://schemas.microsoft.com/office/drawing/2014/main" id="{047B7CD5-5FB2-4A0E-8C04-0C025CD394AD}"/>
               </a:ext>
             </a:extLst>
           </p:cNvPr>
@@ -5005,7 +5004,7 @@
           <p:cNvPr id="28" name="">
             <a:extLst xmlns:a="http://schemas.openxmlformats.org/drawingml/2006/main">
               <a:ext uri="{FF2B5EF4-FFF2-40B4-BE49-F238E27FC236}">
-                <a16:creationId xmlns:a16="http://schemas.microsoft.com/office/drawing/2014/main" id="{D5EA6621-21A4-4A57-9171-96E437B86F90}"/>
+                <a16:creationId xmlns:a16="http://schemas.microsoft.com/office/drawing/2014/main" id="{F655F9B2-C914-4F74-9EB5-55135D9F876C}"/>
               </a:ext>
             </a:extLst>
           </p:cNvPr>
@@ -5069,7 +5068,7 @@
           <p:cNvPr id="29" name="">
             <a:extLst xmlns:a="http://schemas.openxmlformats.org/drawingml/2006/main">
               <a:ext uri="{FF2B5EF4-FFF2-40B4-BE49-F238E27FC236}">
-                <a16:creationId xmlns:a16="http://schemas.microsoft.com/office/drawing/2014/main" id="{426A6BBB-3FA2-4659-9036-B1A96AB825E7}"/>
+                <a16:creationId xmlns:a16="http://schemas.microsoft.com/office/drawing/2014/main" id="{4B1D1BC7-3E1D-4506-AA2B-C2E6C494E0F6}"/>
               </a:ext>
             </a:extLst>
           </p:cNvPr>
@@ -5123,7 +5122,7 @@
                 <a:ea typeface="Aptos"/>
                 <a:cs typeface="Aptos"/>
               </a:rPr>
-              <a:t>Design choice: GenAI is used only where it helps most: translating unstructured compliance language into structured, reviewable generation constraints. The reviewer stays in control before export.</a:t>
+              <a:t>Design choice: GenAI detects the candidate laundering pattern from messy records. The reviewer validates the inferred typology before synthetic data is generated or exported.</a:t>
             </a:r>
           </a:p>
         </p:txBody>
@@ -5131,7 +5130,7 @@
     </p:spTree>
     <p:extLst>
       <p:ext uri="{BB962C8B-B14F-4D97-AF65-F5344CB8AC3E}">
-        <p14:creationId xmlns:p14="http://schemas.microsoft.com/office/powerpoint/2010/main" val="934295792"/>
+        <p14:creationId xmlns:p14="http://schemas.microsoft.com/office/powerpoint/2010/main" val="496892922"/>
       </p:ext>
     </p:extLst>
   </p:cSld>
@@ -5155,7 +5154,7 @@
           <p:cNvPr id="1" name="">
             <a:extLst xmlns:a="http://schemas.openxmlformats.org/drawingml/2006/main">
               <a:ext uri="{FF2B5EF4-FFF2-40B4-BE49-F238E27FC236}">
-                <a16:creationId xmlns:a16="http://schemas.microsoft.com/office/drawing/2014/main" id="{B2BE1245-BACD-4A8D-973E-192D6B7E30EE}"/>
+                <a16:creationId xmlns:a16="http://schemas.microsoft.com/office/drawing/2014/main" id="{925E2C24-7634-4822-8431-DB247B28EE97}"/>
               </a:ext>
             </a:extLst>
           </p:cNvPr>
@@ -5190,7 +5189,7 @@
           <p:cNvPr id="2" name="kicker-marker">
             <a:extLst xmlns:a="http://schemas.openxmlformats.org/drawingml/2006/main">
               <a:ext uri="{FF2B5EF4-FFF2-40B4-BE49-F238E27FC236}">
-                <a16:creationId xmlns:a16="http://schemas.microsoft.com/office/drawing/2014/main" id="{6E13CC13-8F09-4BD4-9EC2-3A1ADB3D254F}"/>
+                <a16:creationId xmlns:a16="http://schemas.microsoft.com/office/drawing/2014/main" id="{695B4013-6351-4507-88B2-9D557DF50C7C}"/>
               </a:ext>
             </a:extLst>
           </p:cNvPr>
@@ -5225,7 +5224,7 @@
           <p:cNvPr id="3" name="kicker-label">
             <a:extLst xmlns:a="http://schemas.openxmlformats.org/drawingml/2006/main">
               <a:ext uri="{FF2B5EF4-FFF2-40B4-BE49-F238E27FC236}">
-                <a16:creationId xmlns:a16="http://schemas.microsoft.com/office/drawing/2014/main" id="{41A433B7-592C-4C73-BF26-0CC3558565C1}"/>
+                <a16:creationId xmlns:a16="http://schemas.microsoft.com/office/drawing/2014/main" id="{BA6EE0B5-E05D-46B3-B024-2E94594A3F78}"/>
               </a:ext>
             </a:extLst>
           </p:cNvPr>
@@ -5289,7 +5288,7 @@
           <p:cNvPr id="4" name="">
             <a:extLst xmlns:a="http://schemas.openxmlformats.org/drawingml/2006/main">
               <a:ext uri="{FF2B5EF4-FFF2-40B4-BE49-F238E27FC236}">
-                <a16:creationId xmlns:a16="http://schemas.microsoft.com/office/drawing/2014/main" id="{01740EB0-70D8-447D-98E3-FE1D44C4466D}"/>
+                <a16:creationId xmlns:a16="http://schemas.microsoft.com/office/drawing/2014/main" id="{7161028A-5ADD-4E47-B768-51FCC8FE8547}"/>
               </a:ext>
             </a:extLst>
           </p:cNvPr>
@@ -5353,7 +5352,7 @@
           <p:cNvPr id="5" name="">
             <a:extLst xmlns:a="http://schemas.openxmlformats.org/drawingml/2006/main">
               <a:ext uri="{FF2B5EF4-FFF2-40B4-BE49-F238E27FC236}">
-                <a16:creationId xmlns:a16="http://schemas.microsoft.com/office/drawing/2014/main" id="{21EB796B-8EBD-4045-A11C-1F94933266F7}"/>
+                <a16:creationId xmlns:a16="http://schemas.microsoft.com/office/drawing/2014/main" id="{EA2D458D-5655-4B6E-9AF2-973754202734}"/>
               </a:ext>
             </a:extLst>
           </p:cNvPr>
@@ -5388,7 +5387,7 @@
           <p:cNvPr id="6" name="">
             <a:extLst xmlns:a="http://schemas.openxmlformats.org/drawingml/2006/main">
               <a:ext uri="{FF2B5EF4-FFF2-40B4-BE49-F238E27FC236}">
-                <a16:creationId xmlns:a16="http://schemas.microsoft.com/office/drawing/2014/main" id="{72D73175-3C16-4290-8727-C15A2CCAA258}"/>
+                <a16:creationId xmlns:a16="http://schemas.microsoft.com/office/drawing/2014/main" id="{3ED80C30-BDAE-43B8-9F9B-16CADE8F1ADE}"/>
               </a:ext>
             </a:extLst>
           </p:cNvPr>
@@ -5452,7 +5451,7 @@
           <p:cNvPr id="7" name="">
             <a:extLst xmlns:a="http://schemas.openxmlformats.org/drawingml/2006/main">
               <a:ext uri="{FF2B5EF4-FFF2-40B4-BE49-F238E27FC236}">
-                <a16:creationId xmlns:a16="http://schemas.microsoft.com/office/drawing/2014/main" id="{DA0E727C-726C-4A46-926D-C805E8121B7F}"/>
+                <a16:creationId xmlns:a16="http://schemas.microsoft.com/office/drawing/2014/main" id="{88F62E6E-3B3E-45B7-BA4C-8CF45A2DCD46}"/>
               </a:ext>
             </a:extLst>
           </p:cNvPr>
@@ -5516,7 +5515,7 @@
           <p:cNvPr id="8" name="">
             <a:extLst xmlns:a="http://schemas.openxmlformats.org/drawingml/2006/main">
               <a:ext uri="{FF2B5EF4-FFF2-40B4-BE49-F238E27FC236}">
-                <a16:creationId xmlns:a16="http://schemas.microsoft.com/office/drawing/2014/main" id="{6F139AAB-3250-4FD2-A31B-D8C161A821A9}"/>
+                <a16:creationId xmlns:a16="http://schemas.microsoft.com/office/drawing/2014/main" id="{73B8B76D-ABFA-458D-A61B-73B2EA472F47}"/>
               </a:ext>
             </a:extLst>
           </p:cNvPr>
@@ -5580,7 +5579,7 @@
           <p:cNvPr id="9" name="">
             <a:extLst xmlns:a="http://schemas.openxmlformats.org/drawingml/2006/main">
               <a:ext uri="{FF2B5EF4-FFF2-40B4-BE49-F238E27FC236}">
-                <a16:creationId xmlns:a16="http://schemas.microsoft.com/office/drawing/2014/main" id="{79FE3C4D-B660-46DC-BBA7-7F605A7B465D}"/>
+                <a16:creationId xmlns:a16="http://schemas.microsoft.com/office/drawing/2014/main" id="{C75DC2CA-C56B-4CAB-A99A-AF32C2E939A2}"/>
               </a:ext>
             </a:extLst>
           </p:cNvPr>
@@ -5615,7 +5614,7 @@
           <p:cNvPr id="10" name="">
             <a:extLst xmlns:a="http://schemas.openxmlformats.org/drawingml/2006/main">
               <a:ext uri="{FF2B5EF4-FFF2-40B4-BE49-F238E27FC236}">
-                <a16:creationId xmlns:a16="http://schemas.microsoft.com/office/drawing/2014/main" id="{4A9599FB-27F3-4923-B61C-B58BDA64EDF3}"/>
+                <a16:creationId xmlns:a16="http://schemas.microsoft.com/office/drawing/2014/main" id="{7961E182-C1C0-4AD8-B937-BE66B731D4BD}"/>
               </a:ext>
             </a:extLst>
           </p:cNvPr>
@@ -5650,7 +5649,7 @@
           <p:cNvPr id="11" name="">
             <a:extLst xmlns:a="http://schemas.openxmlformats.org/drawingml/2006/main">
               <a:ext uri="{FF2B5EF4-FFF2-40B4-BE49-F238E27FC236}">
-                <a16:creationId xmlns:a16="http://schemas.microsoft.com/office/drawing/2014/main" id="{50655B1E-5492-4E9E-8E93-669105E8D91B}"/>
+                <a16:creationId xmlns:a16="http://schemas.microsoft.com/office/drawing/2014/main" id="{5114AA5C-8206-41FD-9E40-A0805872FABD}"/>
               </a:ext>
             </a:extLst>
           </p:cNvPr>
@@ -5714,7 +5713,7 @@
           <p:cNvPr id="12" name="">
             <a:extLst xmlns:a="http://schemas.openxmlformats.org/drawingml/2006/main">
               <a:ext uri="{FF2B5EF4-FFF2-40B4-BE49-F238E27FC236}">
-                <a16:creationId xmlns:a16="http://schemas.microsoft.com/office/drawing/2014/main" id="{60FCBFBC-ABE3-4FD9-9568-D62A24438F9D}"/>
+                <a16:creationId xmlns:a16="http://schemas.microsoft.com/office/drawing/2014/main" id="{E742F248-859D-4BE9-8BA8-4C3331EFF791}"/>
               </a:ext>
             </a:extLst>
           </p:cNvPr>
@@ -5778,7 +5777,7 @@
           <p:cNvPr id="13" name="">
             <a:extLst xmlns:a="http://schemas.openxmlformats.org/drawingml/2006/main">
               <a:ext uri="{FF2B5EF4-FFF2-40B4-BE49-F238E27FC236}">
-                <a16:creationId xmlns:a16="http://schemas.microsoft.com/office/drawing/2014/main" id="{4B8A091E-C27D-4958-96FA-B781A913152C}"/>
+                <a16:creationId xmlns:a16="http://schemas.microsoft.com/office/drawing/2014/main" id="{1D4B357D-D5BA-4BC6-88DC-C756C6BF5C32}"/>
               </a:ext>
             </a:extLst>
           </p:cNvPr>
@@ -5813,7 +5812,7 @@
           <p:cNvPr id="14" name="">
             <a:extLst xmlns:a="http://schemas.openxmlformats.org/drawingml/2006/main">
               <a:ext uri="{FF2B5EF4-FFF2-40B4-BE49-F238E27FC236}">
-                <a16:creationId xmlns:a16="http://schemas.microsoft.com/office/drawing/2014/main" id="{628CF341-0C78-4C3E-874B-D06196C530A4}"/>
+                <a16:creationId xmlns:a16="http://schemas.microsoft.com/office/drawing/2014/main" id="{7DD1888E-A4B0-4AB4-8ECD-F1797936F103}"/>
               </a:ext>
             </a:extLst>
           </p:cNvPr>
@@ -5848,7 +5847,7 @@
           <p:cNvPr id="15" name="">
             <a:extLst xmlns:a="http://schemas.openxmlformats.org/drawingml/2006/main">
               <a:ext uri="{FF2B5EF4-FFF2-40B4-BE49-F238E27FC236}">
-                <a16:creationId xmlns:a16="http://schemas.microsoft.com/office/drawing/2014/main" id="{596D4C13-05C7-4E25-BC0B-4B15623908CB}"/>
+                <a16:creationId xmlns:a16="http://schemas.microsoft.com/office/drawing/2014/main" id="{795A913C-C6DF-49B1-94E1-25C3945FBD92}"/>
               </a:ext>
             </a:extLst>
           </p:cNvPr>
@@ -5912,7 +5911,7 @@
           <p:cNvPr id="16" name="">
             <a:extLst xmlns:a="http://schemas.openxmlformats.org/drawingml/2006/main">
               <a:ext uri="{FF2B5EF4-FFF2-40B4-BE49-F238E27FC236}">
-                <a16:creationId xmlns:a16="http://schemas.microsoft.com/office/drawing/2014/main" id="{BA08E6BD-827B-4F97-AA3F-2CC1B71B7C41}"/>
+                <a16:creationId xmlns:a16="http://schemas.microsoft.com/office/drawing/2014/main" id="{1E00EF3E-B2CF-4CCE-86A2-42E8282DECF6}"/>
               </a:ext>
             </a:extLst>
           </p:cNvPr>
@@ -5947,7 +5946,7 @@
           <p:cNvPr id="17" name="">
             <a:extLst xmlns:a="http://schemas.openxmlformats.org/drawingml/2006/main">
               <a:ext uri="{FF2B5EF4-FFF2-40B4-BE49-F238E27FC236}">
-                <a16:creationId xmlns:a16="http://schemas.microsoft.com/office/drawing/2014/main" id="{8446D8DF-4B27-481E-8D37-850A6564ED6C}"/>
+                <a16:creationId xmlns:a16="http://schemas.microsoft.com/office/drawing/2014/main" id="{65DE05C3-3828-4367-BEC7-9395A7727869}"/>
               </a:ext>
             </a:extLst>
           </p:cNvPr>
@@ -6011,7 +6010,7 @@
           <p:cNvPr id="18" name="">
             <a:extLst xmlns:a="http://schemas.openxmlformats.org/drawingml/2006/main">
               <a:ext uri="{FF2B5EF4-FFF2-40B4-BE49-F238E27FC236}">
-                <a16:creationId xmlns:a16="http://schemas.microsoft.com/office/drawing/2014/main" id="{A9D87533-D78B-4255-AC70-1C50E9F60FCD}"/>
+                <a16:creationId xmlns:a16="http://schemas.microsoft.com/office/drawing/2014/main" id="{9ECDB89E-1009-4180-B914-94EF361A0DA8}"/>
               </a:ext>
             </a:extLst>
           </p:cNvPr>
@@ -6046,7 +6045,7 @@
           <p:cNvPr id="19" name="">
             <a:extLst xmlns:a="http://schemas.openxmlformats.org/drawingml/2006/main">
               <a:ext uri="{FF2B5EF4-FFF2-40B4-BE49-F238E27FC236}">
-                <a16:creationId xmlns:a16="http://schemas.microsoft.com/office/drawing/2014/main" id="{ADB03A06-2316-4DAC-B6D3-A89D6931E05C}"/>
+                <a16:creationId xmlns:a16="http://schemas.microsoft.com/office/drawing/2014/main" id="{BCDE9228-A36A-4FD3-A89A-3E6C37239771}"/>
               </a:ext>
             </a:extLst>
           </p:cNvPr>
@@ -6110,7 +6109,7 @@
           <p:cNvPr id="20" name="">
             <a:extLst xmlns:a="http://schemas.openxmlformats.org/drawingml/2006/main">
               <a:ext uri="{FF2B5EF4-FFF2-40B4-BE49-F238E27FC236}">
-                <a16:creationId xmlns:a16="http://schemas.microsoft.com/office/drawing/2014/main" id="{4A5D0077-6124-4508-8934-565AE6418CF6}"/>
+                <a16:creationId xmlns:a16="http://schemas.microsoft.com/office/drawing/2014/main" id="{9A76208B-F4AD-4C59-8F47-27F7E80F6992}"/>
               </a:ext>
             </a:extLst>
           </p:cNvPr>
@@ -6145,7 +6144,7 @@
           <p:cNvPr id="21" name="">
             <a:extLst xmlns:a="http://schemas.openxmlformats.org/drawingml/2006/main">
               <a:ext uri="{FF2B5EF4-FFF2-40B4-BE49-F238E27FC236}">
-                <a16:creationId xmlns:a16="http://schemas.microsoft.com/office/drawing/2014/main" id="{646B758D-8E7D-4391-ADBA-114DB3CEAF5D}"/>
+                <a16:creationId xmlns:a16="http://schemas.microsoft.com/office/drawing/2014/main" id="{F1941672-7E32-4A4C-A5AF-6BA774CACFC0}"/>
               </a:ext>
             </a:extLst>
           </p:cNvPr>
@@ -6209,7 +6208,7 @@
           <p:cNvPr id="22" name="">
             <a:extLst xmlns:a="http://schemas.openxmlformats.org/drawingml/2006/main">
               <a:ext uri="{FF2B5EF4-FFF2-40B4-BE49-F238E27FC236}">
-                <a16:creationId xmlns:a16="http://schemas.microsoft.com/office/drawing/2014/main" id="{9608245C-093B-43F5-BD69-7260E20BEC29}"/>
+                <a16:creationId xmlns:a16="http://schemas.microsoft.com/office/drawing/2014/main" id="{557BDFCF-813B-4C7D-939A-D640315C38B5}"/>
               </a:ext>
             </a:extLst>
           </p:cNvPr>
@@ -6244,7 +6243,7 @@
           <p:cNvPr id="23" name="">
             <a:extLst xmlns:a="http://schemas.openxmlformats.org/drawingml/2006/main">
               <a:ext uri="{FF2B5EF4-FFF2-40B4-BE49-F238E27FC236}">
-                <a16:creationId xmlns:a16="http://schemas.microsoft.com/office/drawing/2014/main" id="{E63AB773-9955-4EDD-AC8D-700F83A248EE}"/>
+                <a16:creationId xmlns:a16="http://schemas.microsoft.com/office/drawing/2014/main" id="{1E39090C-C2FC-4EC5-BF95-362CE097433E}"/>
               </a:ext>
             </a:extLst>
           </p:cNvPr>
@@ -6298,7 +6297,7 @@
                 <a:ea typeface="Aptos"/>
                 <a:cs typeface="Aptos"/>
               </a:rPr>
-              <a:t>Human reviewer can inspect constraints and records</a:t>
+              <a:t>Human reviewer can inspect the detected pattern and records</a:t>
             </a:r>
           </a:p>
         </p:txBody>
@@ -6308,7 +6307,7 @@
           <p:cNvPr id="24" name="">
             <a:extLst xmlns:a="http://schemas.openxmlformats.org/drawingml/2006/main">
               <a:ext uri="{FF2B5EF4-FFF2-40B4-BE49-F238E27FC236}">
-                <a16:creationId xmlns:a16="http://schemas.microsoft.com/office/drawing/2014/main" id="{1548BA40-EDD9-4619-A399-869F7F05AAC1}"/>
+                <a16:creationId xmlns:a16="http://schemas.microsoft.com/office/drawing/2014/main" id="{89CEC1C4-C424-4026-986B-8EFE0AB8FE07}"/>
               </a:ext>
             </a:extLst>
           </p:cNvPr>
@@ -6343,7 +6342,7 @@
           <p:cNvPr id="25" name="">
             <a:extLst xmlns:a="http://schemas.openxmlformats.org/drawingml/2006/main">
               <a:ext uri="{FF2B5EF4-FFF2-40B4-BE49-F238E27FC236}">
-                <a16:creationId xmlns:a16="http://schemas.microsoft.com/office/drawing/2014/main" id="{C5439CE2-01F1-4E70-ABEF-8EFE733590CC}"/>
+                <a16:creationId xmlns:a16="http://schemas.microsoft.com/office/drawing/2014/main" id="{A9E40B8E-227C-48D2-86F6-1FB2D99294A7}"/>
               </a:ext>
             </a:extLst>
           </p:cNvPr>
@@ -6407,7 +6406,7 @@
           <p:cNvPr id="26" name="">
             <a:extLst xmlns:a="http://schemas.openxmlformats.org/drawingml/2006/main">
               <a:ext uri="{FF2B5EF4-FFF2-40B4-BE49-F238E27FC236}">
-                <a16:creationId xmlns:a16="http://schemas.microsoft.com/office/drawing/2014/main" id="{8D151B6F-1B48-4F2F-9EB3-696DE49FD4FA}"/>
+                <a16:creationId xmlns:a16="http://schemas.microsoft.com/office/drawing/2014/main" id="{354976E0-AE80-4C1B-AA88-1211506500C4}"/>
               </a:ext>
             </a:extLst>
           </p:cNvPr>
@@ -6492,7 +6491,7 @@
     </p:spTree>
     <p:extLst>
       <p:ext uri="{BB962C8B-B14F-4D97-AF65-F5344CB8AC3E}">
-        <p14:creationId xmlns:p14="http://schemas.microsoft.com/office/powerpoint/2010/main" val="1239936456"/>
+        <p14:creationId xmlns:p14="http://schemas.microsoft.com/office/powerpoint/2010/main" val="1729825183"/>
       </p:ext>
     </p:extLst>
   </p:cSld>
@@ -6516,7 +6515,7 @@
           <p:cNvPr id="1" name="">
             <a:extLst xmlns:a="http://schemas.openxmlformats.org/drawingml/2006/main">
               <a:ext uri="{FF2B5EF4-FFF2-40B4-BE49-F238E27FC236}">
-                <a16:creationId xmlns:a16="http://schemas.microsoft.com/office/drawing/2014/main" id="{3CBACB7B-F72A-491E-9166-6ED69A1F5CF6}"/>
+                <a16:creationId xmlns:a16="http://schemas.microsoft.com/office/drawing/2014/main" id="{6FAAC5DA-9F95-4005-B6AF-0D8A1A3AB806}"/>
               </a:ext>
             </a:extLst>
           </p:cNvPr>
@@ -6551,7 +6550,7 @@
           <p:cNvPr id="2" name="kicker-marker">
             <a:extLst xmlns:a="http://schemas.openxmlformats.org/drawingml/2006/main">
               <a:ext uri="{FF2B5EF4-FFF2-40B4-BE49-F238E27FC236}">
-                <a16:creationId xmlns:a16="http://schemas.microsoft.com/office/drawing/2014/main" id="{4482D665-5F47-42C4-9253-8BD5447C8282}"/>
+                <a16:creationId xmlns:a16="http://schemas.microsoft.com/office/drawing/2014/main" id="{551D6422-6062-4F61-8EC0-D4B113069B1D}"/>
               </a:ext>
             </a:extLst>
           </p:cNvPr>
@@ -6586,7 +6585,7 @@
           <p:cNvPr id="3" name="kicker-label">
             <a:extLst xmlns:a="http://schemas.openxmlformats.org/drawingml/2006/main">
               <a:ext uri="{FF2B5EF4-FFF2-40B4-BE49-F238E27FC236}">
-                <a16:creationId xmlns:a16="http://schemas.microsoft.com/office/drawing/2014/main" id="{4C397154-36EC-488E-95A4-26CCB6C4374C}"/>
+                <a16:creationId xmlns:a16="http://schemas.microsoft.com/office/drawing/2014/main" id="{2EF3829A-5BC2-4496-8A01-A1F029A19CD3}"/>
               </a:ext>
             </a:extLst>
           </p:cNvPr>
@@ -6650,7 +6649,7 @@
           <p:cNvPr id="4" name="">
             <a:extLst xmlns:a="http://schemas.openxmlformats.org/drawingml/2006/main">
               <a:ext uri="{FF2B5EF4-FFF2-40B4-BE49-F238E27FC236}">
-                <a16:creationId xmlns:a16="http://schemas.microsoft.com/office/drawing/2014/main" id="{BEFA377D-E548-4E06-A754-BE47564D8C9C}"/>
+                <a16:creationId xmlns:a16="http://schemas.microsoft.com/office/drawing/2014/main" id="{9E75DC35-A435-4019-94E9-F389E27F7153}"/>
               </a:ext>
             </a:extLst>
           </p:cNvPr>
@@ -6704,7 +6703,7 @@
                 <a:ea typeface="Aptos Display"/>
                 <a:cs typeface="Aptos Display"/>
               </a:rPr>
-              <a:t>The real bottleneck is not generating rows. It is turning vague typology language into testable model behavior.</a:t>
+              <a:t>The real bottleneck is detecting a reusable laundering pattern from messy case evidence.</a:t>
             </a:r>
           </a:p>
         </p:txBody>
@@ -6714,7 +6713,7 @@
           <p:cNvPr id="5" name="">
             <a:extLst xmlns:a="http://schemas.openxmlformats.org/drawingml/2006/main">
               <a:ext uri="{FF2B5EF4-FFF2-40B4-BE49-F238E27FC236}">
-                <a16:creationId xmlns:a16="http://schemas.microsoft.com/office/drawing/2014/main" id="{6BB0CE36-DEDE-48C0-A7C9-DDB0C57A13B6}"/>
+                <a16:creationId xmlns:a16="http://schemas.microsoft.com/office/drawing/2014/main" id="{7DCEC67B-7B05-4A3A-A84B-A8C3542D41B9}"/>
               </a:ext>
             </a:extLst>
           </p:cNvPr>
@@ -6749,7 +6748,7 @@
           <p:cNvPr id="6" name="">
             <a:extLst xmlns:a="http://schemas.openxmlformats.org/drawingml/2006/main">
               <a:ext uri="{FF2B5EF4-FFF2-40B4-BE49-F238E27FC236}">
-                <a16:creationId xmlns:a16="http://schemas.microsoft.com/office/drawing/2014/main" id="{7DAB4931-3DE6-4BB5-9AB2-3E8E64976EBA}"/>
+                <a16:creationId xmlns:a16="http://schemas.microsoft.com/office/drawing/2014/main" id="{44765FC3-A0B1-49AC-888A-FC4578680765}"/>
               </a:ext>
             </a:extLst>
           </p:cNvPr>
@@ -6813,7 +6812,7 @@
           <p:cNvPr id="7" name="">
             <a:extLst xmlns:a="http://schemas.openxmlformats.org/drawingml/2006/main">
               <a:ext uri="{FF2B5EF4-FFF2-40B4-BE49-F238E27FC236}">
-                <a16:creationId xmlns:a16="http://schemas.microsoft.com/office/drawing/2014/main" id="{B9A35539-50E3-4706-AD51-E423B13F5CA8}"/>
+                <a16:creationId xmlns:a16="http://schemas.microsoft.com/office/drawing/2014/main" id="{953329A1-298A-4304-878F-6BF304D99283}"/>
               </a:ext>
             </a:extLst>
           </p:cNvPr>
@@ -6848,7 +6847,7 @@
           <p:cNvPr id="8" name="">
             <a:extLst xmlns:a="http://schemas.openxmlformats.org/drawingml/2006/main">
               <a:ext uri="{FF2B5EF4-FFF2-40B4-BE49-F238E27FC236}">
-                <a16:creationId xmlns:a16="http://schemas.microsoft.com/office/drawing/2014/main" id="{688A7DE2-151E-4D68-8407-2A07FEEEF360}"/>
+                <a16:creationId xmlns:a16="http://schemas.microsoft.com/office/drawing/2014/main" id="{A70B58DA-F5C8-4D0F-A638-CE8CFB0491BD}"/>
               </a:ext>
             </a:extLst>
           </p:cNvPr>
@@ -6912,7 +6911,7 @@
           <p:cNvPr id="9" name="">
             <a:extLst xmlns:a="http://schemas.openxmlformats.org/drawingml/2006/main">
               <a:ext uri="{FF2B5EF4-FFF2-40B4-BE49-F238E27FC236}">
-                <a16:creationId xmlns:a16="http://schemas.microsoft.com/office/drawing/2014/main" id="{430A6EF9-117D-45F6-A46B-535087C60F2F}"/>
+                <a16:creationId xmlns:a16="http://schemas.microsoft.com/office/drawing/2014/main" id="{34522232-7ED7-4F02-92BF-5249FC2569F0}"/>
               </a:ext>
             </a:extLst>
           </p:cNvPr>
@@ -6976,7 +6975,7 @@
           <p:cNvPr id="10" name="">
             <a:extLst xmlns:a="http://schemas.openxmlformats.org/drawingml/2006/main">
               <a:ext uri="{FF2B5EF4-FFF2-40B4-BE49-F238E27FC236}">
-                <a16:creationId xmlns:a16="http://schemas.microsoft.com/office/drawing/2014/main" id="{C23ED889-7840-4FB2-8D15-CCF2C0046D62}"/>
+                <a16:creationId xmlns:a16="http://schemas.microsoft.com/office/drawing/2014/main" id="{899E5E1A-F0CF-4249-A347-520EC2238B0C}"/>
               </a:ext>
             </a:extLst>
           </p:cNvPr>
@@ -6988,7 +6987,7 @@
         <p:spPr>
           <a:xfrm xmlns:a="http://schemas.openxmlformats.org/drawingml/2006/main">
             <a:off x="1752600" y="2362200"/>
-            <a:ext cx="8001000" cy="533400"/>
+            <a:ext cx="6953250" cy="533400"/>
           </a:xfrm>
           <a:prstGeom xmlns:a="http://schemas.openxmlformats.org/drawingml/2006/main" prst="rect">
             <a:avLst/>
@@ -7030,7 +7029,7 @@
                 <a:ea typeface="Aptos"/>
                 <a:cs typeface="Aptos"/>
               </a:rPr>
-              <a:t>An analyst reviews an incoming warning, writes ad hoc rules, and creates a small spreadsheet or prompt-only sample.</a:t>
+              <a:t>An analyst reviews case records, notices similarities, and manually drafts a test scenario or rule.</a:t>
             </a:r>
           </a:p>
         </p:txBody>
@@ -7040,7 +7039,7 @@
           <p:cNvPr id="11" name="">
             <a:extLst xmlns:a="http://schemas.openxmlformats.org/drawingml/2006/main">
               <a:ext uri="{FF2B5EF4-FFF2-40B4-BE49-F238E27FC236}">
-                <a16:creationId xmlns:a16="http://schemas.microsoft.com/office/drawing/2014/main" id="{D863B5D5-6097-477A-93A4-3E6F3B6C730D}"/>
+                <a16:creationId xmlns:a16="http://schemas.microsoft.com/office/drawing/2014/main" id="{2CEDD9C8-D651-4DBF-B9A6-DBA83F65579D}"/>
               </a:ext>
             </a:extLst>
           </p:cNvPr>
@@ -7075,7 +7074,7 @@
           <p:cNvPr id="12" name="">
             <a:extLst xmlns:a="http://schemas.openxmlformats.org/drawingml/2006/main">
               <a:ext uri="{FF2B5EF4-FFF2-40B4-BE49-F238E27FC236}">
-                <a16:creationId xmlns:a16="http://schemas.microsoft.com/office/drawing/2014/main" id="{19B5E4E7-F264-486F-BBCA-F93876975438}"/>
+                <a16:creationId xmlns:a16="http://schemas.microsoft.com/office/drawing/2014/main" id="{B972A830-C8BC-49F2-A70D-838CCFFDCE70}"/>
               </a:ext>
             </a:extLst>
           </p:cNvPr>
@@ -7139,7 +7138,7 @@
           <p:cNvPr id="13" name="">
             <a:extLst xmlns:a="http://schemas.openxmlformats.org/drawingml/2006/main">
               <a:ext uri="{FF2B5EF4-FFF2-40B4-BE49-F238E27FC236}">
-                <a16:creationId xmlns:a16="http://schemas.microsoft.com/office/drawing/2014/main" id="{ED0DA801-591A-4466-9818-21C8DAA99BB3}"/>
+                <a16:creationId xmlns:a16="http://schemas.microsoft.com/office/drawing/2014/main" id="{49475C8F-409F-420C-B77C-3B7E848EEC5C}"/>
               </a:ext>
             </a:extLst>
           </p:cNvPr>
@@ -7203,7 +7202,7 @@
           <p:cNvPr id="14" name="">
             <a:extLst xmlns:a="http://schemas.openxmlformats.org/drawingml/2006/main">
               <a:ext uri="{FF2B5EF4-FFF2-40B4-BE49-F238E27FC236}">
-                <a16:creationId xmlns:a16="http://schemas.microsoft.com/office/drawing/2014/main" id="{71943314-E246-44BE-ACCD-DCFBEE9508D1}"/>
+                <a16:creationId xmlns:a16="http://schemas.microsoft.com/office/drawing/2014/main" id="{AB9E14EA-8BCC-40F6-A60E-A074166ED06A}"/>
               </a:ext>
             </a:extLst>
           </p:cNvPr>
@@ -7215,7 +7214,7 @@
         <p:spPr>
           <a:xfrm xmlns:a="http://schemas.openxmlformats.org/drawingml/2006/main">
             <a:off x="1752600" y="3657600"/>
-            <a:ext cx="8001000" cy="533400"/>
+            <a:ext cx="6953250" cy="533400"/>
           </a:xfrm>
           <a:prstGeom xmlns:a="http://schemas.openxmlformats.org/drawingml/2006/main" prst="rect">
             <a:avLst/>
@@ -7257,7 +7256,7 @@
                 <a:ea typeface="Aptos"/>
                 <a:cs typeface="Aptos"/>
               </a:rPr>
-              <a:t>The resulting data often overfits obvious signals like high amount and misses multi-step fund-flow behavior.</a:t>
+              <a:t>The resulting data can overfit high amounts and miss multi-step chains.</a:t>
             </a:r>
           </a:p>
         </p:txBody>
@@ -7267,7 +7266,7 @@
           <p:cNvPr id="15" name="">
             <a:extLst xmlns:a="http://schemas.openxmlformats.org/drawingml/2006/main">
               <a:ext uri="{FF2B5EF4-FFF2-40B4-BE49-F238E27FC236}">
-                <a16:creationId xmlns:a16="http://schemas.microsoft.com/office/drawing/2014/main" id="{BB5C2903-AF10-41E8-9DFA-17617CBC919C}"/>
+                <a16:creationId xmlns:a16="http://schemas.microsoft.com/office/drawing/2014/main" id="{79170962-7DDC-4ED0-A0F0-71C9547B134D}"/>
               </a:ext>
             </a:extLst>
           </p:cNvPr>
@@ -7302,7 +7301,7 @@
           <p:cNvPr id="16" name="">
             <a:extLst xmlns:a="http://schemas.openxmlformats.org/drawingml/2006/main">
               <a:ext uri="{FF2B5EF4-FFF2-40B4-BE49-F238E27FC236}">
-                <a16:creationId xmlns:a16="http://schemas.microsoft.com/office/drawing/2014/main" id="{338EEDF1-C82F-40BB-B4CA-E8438E2619B3}"/>
+                <a16:creationId xmlns:a16="http://schemas.microsoft.com/office/drawing/2014/main" id="{35340493-E487-4D80-B83A-05C809DF5E31}"/>
               </a:ext>
             </a:extLst>
           </p:cNvPr>
@@ -7366,7 +7365,7 @@
           <p:cNvPr id="17" name="">
             <a:extLst xmlns:a="http://schemas.openxmlformats.org/drawingml/2006/main">
               <a:ext uri="{FF2B5EF4-FFF2-40B4-BE49-F238E27FC236}">
-                <a16:creationId xmlns:a16="http://schemas.microsoft.com/office/drawing/2014/main" id="{0988904B-9874-49B0-BC9B-EFDAF93B7D21}"/>
+                <a16:creationId xmlns:a16="http://schemas.microsoft.com/office/drawing/2014/main" id="{A02FF3B9-19B4-42EF-BC43-42DE68B92048}"/>
               </a:ext>
             </a:extLst>
           </p:cNvPr>
@@ -7430,7 +7429,7 @@
           <p:cNvPr id="18" name="">
             <a:extLst xmlns:a="http://schemas.openxmlformats.org/drawingml/2006/main">
               <a:ext uri="{FF2B5EF4-FFF2-40B4-BE49-F238E27FC236}">
-                <a16:creationId xmlns:a16="http://schemas.microsoft.com/office/drawing/2014/main" id="{FCB63C4F-3A2A-48F8-A06B-593F8B385F22}"/>
+                <a16:creationId xmlns:a16="http://schemas.microsoft.com/office/drawing/2014/main" id="{C2E944F1-8299-4276-8CAD-252B339C8671}"/>
               </a:ext>
             </a:extLst>
           </p:cNvPr>
@@ -7442,7 +7441,7 @@
         <p:spPr>
           <a:xfrm xmlns:a="http://schemas.openxmlformats.org/drawingml/2006/main">
             <a:off x="1752600" y="4953000"/>
-            <a:ext cx="8001000" cy="533400"/>
+            <a:ext cx="6953250" cy="533400"/>
           </a:xfrm>
           <a:prstGeom xmlns:a="http://schemas.openxmlformats.org/drawingml/2006/main" prst="rect">
             <a:avLst/>
@@ -7484,7 +7483,7 @@
                 <a:ea typeface="Aptos"/>
                 <a:cs typeface="Aptos"/>
               </a:rPr>
-              <a:t>The app makes the intermediate scenario explicit: regions, timing, split count, narratives, chain logic, and review gates.</a:t>
+              <a:t>The LLM surfaces a candidate typology, while the reviewer validates the business meaning and evidence.</a:t>
             </a:r>
           </a:p>
         </p:txBody>
@@ -7494,7 +7493,7 @@
           <p:cNvPr id="19" name="">
             <a:extLst xmlns:a="http://schemas.openxmlformats.org/drawingml/2006/main">
               <a:ext uri="{FF2B5EF4-FFF2-40B4-BE49-F238E27FC236}">
-                <a16:creationId xmlns:a16="http://schemas.microsoft.com/office/drawing/2014/main" id="{8BD99FF4-965F-4A46-98DA-8DBF36EC982C}"/>
+                <a16:creationId xmlns:a16="http://schemas.microsoft.com/office/drawing/2014/main" id="{989D0EE0-0073-44B1-BBD9-509043FBB5F6}"/>
               </a:ext>
             </a:extLst>
           </p:cNvPr>
@@ -7527,19 +7526,19 @@
           <p:cNvPr id="20" name="">
             <a:extLst xmlns:a="http://schemas.openxmlformats.org/drawingml/2006/main">
               <a:ext uri="{FF2B5EF4-FFF2-40B4-BE49-F238E27FC236}">
-                <a16:creationId xmlns:a16="http://schemas.microsoft.com/office/drawing/2014/main" id="{0D551B84-EA7F-4C7A-9142-5F78FD576A83}"/>
-              </a:ext>
-            </a:extLst>
-          </p:cNvPr>
-          <p:cNvSpPr>
-            <a:spLocks xmlns:a="http://schemas.openxmlformats.org/drawingml/2006/main" noGrp="1"/>
-          </p:cNvSpPr>
-          <p:nvPr/>
-        </p:nvSpPr>
-        <p:spPr>
-          <a:xfrm xmlns:a="http://schemas.openxmlformats.org/drawingml/2006/main">
-            <a:off x="9525000" y="2762250"/>
-            <a:ext cx="1143000" cy="914400"/>
+                <a16:creationId xmlns:a16="http://schemas.microsoft.com/office/drawing/2014/main" id="{C955B6BB-7D20-4B4F-8030-C8E65D0FC32C}"/>
+              </a:ext>
+            </a:extLst>
+          </p:cNvPr>
+          <p:cNvSpPr>
+            <a:spLocks xmlns:a="http://schemas.openxmlformats.org/drawingml/2006/main" noGrp="1"/>
+          </p:cNvSpPr>
+          <p:nvPr/>
+        </p:nvSpPr>
+        <p:spPr>
+          <a:xfrm xmlns:a="http://schemas.openxmlformats.org/drawingml/2006/main">
+            <a:off x="9525000" y="2705100"/>
+            <a:ext cx="1143000" cy="1028700"/>
           </a:xfrm>
           <a:prstGeom xmlns:a="http://schemas.openxmlformats.org/drawingml/2006/main" prst="rect">
             <a:avLst/>
@@ -7563,7 +7562,7 @@
           <a:lstStyle xmlns:a="http://schemas.openxmlformats.org/drawingml/2006/main"/>
           <a:p xmlns:a="http://schemas.openxmlformats.org/drawingml/2006/main">
             <a:pPr algn="ctr">
-              <a:defRPr sz="1800" b="1">
+              <a:defRPr sz="1650" b="1">
                 <a:solidFill>
                   <a:srgbClr val="875B11"/>
                 </a:solidFill>
@@ -7573,7 +7572,7 @@
               </a:defRPr>
             </a:pPr>
             <a:r>
-              <a:rPr sz="1800" b="1">
+              <a:rPr sz="1650" b="1">
                 <a:solidFill>
                   <a:srgbClr val="875B11"/>
                 </a:solidFill>
@@ -7581,7 +7580,7 @@
                 <a:ea typeface="Aptos Display"/>
                 <a:cs typeface="Aptos Display"/>
               </a:rPr>
-              <a:t>Human review stays central</a:t>
+              <a:t>Human validation stays central</a:t>
             </a:r>
           </a:p>
         </p:txBody>
@@ -7589,7 +7588,7 @@
     </p:spTree>
     <p:extLst>
       <p:ext uri="{BB962C8B-B14F-4D97-AF65-F5344CB8AC3E}">
-        <p14:creationId xmlns:p14="http://schemas.microsoft.com/office/powerpoint/2010/main" val="761831590"/>
+        <p14:creationId xmlns:p14="http://schemas.microsoft.com/office/powerpoint/2010/main" val="621732542"/>
       </p:ext>
     </p:extLst>
   </p:cSld>
@@ -7613,7 +7612,7 @@
           <p:cNvPr id="1" name="">
             <a:extLst xmlns:a="http://schemas.openxmlformats.org/drawingml/2006/main">
               <a:ext uri="{FF2B5EF4-FFF2-40B4-BE49-F238E27FC236}">
-                <a16:creationId xmlns:a16="http://schemas.microsoft.com/office/drawing/2014/main" id="{54BBFD17-9CC3-43F2-8B44-BA66202E511E}"/>
+                <a16:creationId xmlns:a16="http://schemas.microsoft.com/office/drawing/2014/main" id="{BB1C0C99-7B7D-443A-9C8B-218314E87327}"/>
               </a:ext>
             </a:extLst>
           </p:cNvPr>
@@ -7648,7 +7647,7 @@
           <p:cNvPr id="2" name="kicker-marker">
             <a:extLst xmlns:a="http://schemas.openxmlformats.org/drawingml/2006/main">
               <a:ext uri="{FF2B5EF4-FFF2-40B4-BE49-F238E27FC236}">
-                <a16:creationId xmlns:a16="http://schemas.microsoft.com/office/drawing/2014/main" id="{6CCCFEBC-B49E-46C5-8654-CD0BB394DAB2}"/>
+                <a16:creationId xmlns:a16="http://schemas.microsoft.com/office/drawing/2014/main" id="{83D25DA0-CC1D-4E65-8D27-EFA574B5B408}"/>
               </a:ext>
             </a:extLst>
           </p:cNvPr>
@@ -7683,7 +7682,7 @@
           <p:cNvPr id="3" name="kicker-label">
             <a:extLst xmlns:a="http://schemas.openxmlformats.org/drawingml/2006/main">
               <a:ext uri="{FF2B5EF4-FFF2-40B4-BE49-F238E27FC236}">
-                <a16:creationId xmlns:a16="http://schemas.microsoft.com/office/drawing/2014/main" id="{7B04AB83-93E3-409D-A95A-7C28ACC02BCB}"/>
+                <a16:creationId xmlns:a16="http://schemas.microsoft.com/office/drawing/2014/main" id="{122BDF39-E534-4BC1-AEBC-AB0E6C2B4AD2}"/>
               </a:ext>
             </a:extLst>
           </p:cNvPr>
@@ -7747,7 +7746,7 @@
           <p:cNvPr id="4" name="">
             <a:extLst xmlns:a="http://schemas.openxmlformats.org/drawingml/2006/main">
               <a:ext uri="{FF2B5EF4-FFF2-40B4-BE49-F238E27FC236}">
-                <a16:creationId xmlns:a16="http://schemas.microsoft.com/office/drawing/2014/main" id="{9A8C0573-209D-4B2A-8F07-232FDC49BA9D}"/>
+                <a16:creationId xmlns:a16="http://schemas.microsoft.com/office/drawing/2014/main" id="{FFF1559E-D030-454A-A1A4-45BCE7B316CB}"/>
               </a:ext>
             </a:extLst>
           </p:cNvPr>
@@ -7801,7 +7800,7 @@
                 <a:ea typeface="Aptos Display"/>
                 <a:cs typeface="Aptos Display"/>
               </a:rPr>
-              <a:t>The application is a workbench for one narrow business workflow: typology intake to model QA export.</a:t>
+              <a:t>The application is a workbench for one narrow workflow: record-driven pattern discovery to model QA export.</a:t>
             </a:r>
           </a:p>
         </p:txBody>
@@ -7811,7 +7810,7 @@
           <p:cNvPr id="5" name="">
             <a:extLst xmlns:a="http://schemas.openxmlformats.org/drawingml/2006/main">
               <a:ext uri="{FF2B5EF4-FFF2-40B4-BE49-F238E27FC236}">
-                <a16:creationId xmlns:a16="http://schemas.microsoft.com/office/drawing/2014/main" id="{2C4FFD2E-3BF2-44D4-8D31-56ED11E1BF45}"/>
+                <a16:creationId xmlns:a16="http://schemas.microsoft.com/office/drawing/2014/main" id="{FC41C9E4-D693-488B-86B1-7599E596FC5F}"/>
               </a:ext>
             </a:extLst>
           </p:cNvPr>
@@ -7846,7 +7845,7 @@
           <p:cNvPr id="6" name="">
             <a:extLst xmlns:a="http://schemas.openxmlformats.org/drawingml/2006/main">
               <a:ext uri="{FF2B5EF4-FFF2-40B4-BE49-F238E27FC236}">
-                <a16:creationId xmlns:a16="http://schemas.microsoft.com/office/drawing/2014/main" id="{A4BFD4BB-EB46-4D86-A996-91FB0CE5A322}"/>
+                <a16:creationId xmlns:a16="http://schemas.microsoft.com/office/drawing/2014/main" id="{D8E1895B-3341-4FF5-84C1-135CDCD96C10}"/>
               </a:ext>
             </a:extLst>
           </p:cNvPr>
@@ -7910,7 +7909,7 @@
           <p:cNvPr id="7" name="">
             <a:extLst xmlns:a="http://schemas.openxmlformats.org/drawingml/2006/main">
               <a:ext uri="{FF2B5EF4-FFF2-40B4-BE49-F238E27FC236}">
-                <a16:creationId xmlns:a16="http://schemas.microsoft.com/office/drawing/2014/main" id="{D4EDE8A4-4580-445C-AC04-A3315EFCD058}"/>
+                <a16:creationId xmlns:a16="http://schemas.microsoft.com/office/drawing/2014/main" id="{B3C2DCD9-04A2-452E-880A-4475261038F2}"/>
               </a:ext>
             </a:extLst>
           </p:cNvPr>
@@ -7943,7 +7942,7 @@
           <p:cNvPr id="8" name="">
             <a:extLst xmlns:a="http://schemas.openxmlformats.org/drawingml/2006/main">
               <a:ext uri="{FF2B5EF4-FFF2-40B4-BE49-F238E27FC236}">
-                <a16:creationId xmlns:a16="http://schemas.microsoft.com/office/drawing/2014/main" id="{A081D1E5-F019-4286-B0AD-8EFEF704BED4}"/>
+                <a16:creationId xmlns:a16="http://schemas.microsoft.com/office/drawing/2014/main" id="{4F8FC056-5B37-49B6-88B5-8EC207AC8500}"/>
               </a:ext>
             </a:extLst>
           </p:cNvPr>
@@ -7997,7 +7996,7 @@
                 <a:ea typeface="Aptos"/>
                 <a:cs typeface="Aptos"/>
               </a:rPr>
-              <a:t>1. Source intake</a:t>
+              <a:t>1. Record self-intake</a:t>
             </a:r>
           </a:p>
         </p:txBody>
@@ -8007,7 +8006,7 @@
           <p:cNvPr id="9" name="">
             <a:extLst xmlns:a="http://schemas.openxmlformats.org/drawingml/2006/main">
               <a:ext uri="{FF2B5EF4-FFF2-40B4-BE49-F238E27FC236}">
-                <a16:creationId xmlns:a16="http://schemas.microsoft.com/office/drawing/2014/main" id="{2956ADDC-593B-4BA6-AC1F-FA31BBFD5D06}"/>
+                <a16:creationId xmlns:a16="http://schemas.microsoft.com/office/drawing/2014/main" id="{25054B6E-F604-4B9C-9598-719E10D8F0B5}"/>
               </a:ext>
             </a:extLst>
           </p:cNvPr>
@@ -8061,7 +8060,7 @@
                 <a:ea typeface="Aptos"/>
                 <a:cs typeface="Aptos"/>
               </a:rPr>
-              <a:t>Import the regulatory alert or internal typology note and preserve source traceability.</a:t>
+              <a:t>Load suspicious records, closed case notes, or analyst-labeled samples.</a:t>
             </a:r>
           </a:p>
         </p:txBody>
@@ -8071,7 +8070,7 @@
           <p:cNvPr id="10" name="">
             <a:extLst xmlns:a="http://schemas.openxmlformats.org/drawingml/2006/main">
               <a:ext uri="{FF2B5EF4-FFF2-40B4-BE49-F238E27FC236}">
-                <a16:creationId xmlns:a16="http://schemas.microsoft.com/office/drawing/2014/main" id="{F31CD1BF-5296-4654-91B4-B5A4B5379EAF}"/>
+                <a16:creationId xmlns:a16="http://schemas.microsoft.com/office/drawing/2014/main" id="{C666432E-98F7-4EFD-B3A4-A37D754F81C2}"/>
               </a:ext>
             </a:extLst>
           </p:cNvPr>
@@ -8104,7 +8103,7 @@
           <p:cNvPr id="11" name="">
             <a:extLst xmlns:a="http://schemas.openxmlformats.org/drawingml/2006/main">
               <a:ext uri="{FF2B5EF4-FFF2-40B4-BE49-F238E27FC236}">
-                <a16:creationId xmlns:a16="http://schemas.microsoft.com/office/drawing/2014/main" id="{D2086386-182E-40F9-AAFF-DD28322003C8}"/>
+                <a16:creationId xmlns:a16="http://schemas.microsoft.com/office/drawing/2014/main" id="{8A8C278B-13D4-494A-A7FE-9417BE83E1F7}"/>
               </a:ext>
             </a:extLst>
           </p:cNvPr>
@@ -8158,7 +8157,7 @@
                 <a:ea typeface="Aptos"/>
                 <a:cs typeface="Aptos"/>
               </a:rPr>
-              <a:t>2. Scenario review</a:t>
+              <a:t>2. Pattern discovery</a:t>
             </a:r>
           </a:p>
         </p:txBody>
@@ -8168,7 +8167,7 @@
           <p:cNvPr id="12" name="">
             <a:extLst xmlns:a="http://schemas.openxmlformats.org/drawingml/2006/main">
               <a:ext uri="{FF2B5EF4-FFF2-40B4-BE49-F238E27FC236}">
-                <a16:creationId xmlns:a16="http://schemas.microsoft.com/office/drawing/2014/main" id="{70F7B408-472C-4078-97BD-ED99C653AD2C}"/>
+                <a16:creationId xmlns:a16="http://schemas.microsoft.com/office/drawing/2014/main" id="{F8434615-DAA9-440A-9955-5A4137269E46}"/>
               </a:ext>
             </a:extLst>
           </p:cNvPr>
@@ -8222,7 +8221,7 @@
                 <a:ea typeface="Aptos"/>
                 <a:cs typeface="Aptos"/>
               </a:rPr>
-              <a:t>Let the analyst approve amounts, regions, split counts, timing windows, and narratives.</a:t>
+              <a:t>Let the LLM infer recurring regions, timing, narratives, counterparties, and split behavior.</a:t>
             </a:r>
           </a:p>
         </p:txBody>
@@ -8232,7 +8231,7 @@
           <p:cNvPr id="13" name="">
             <a:extLst xmlns:a="http://schemas.openxmlformats.org/drawingml/2006/main">
               <a:ext uri="{FF2B5EF4-FFF2-40B4-BE49-F238E27FC236}">
-                <a16:creationId xmlns:a16="http://schemas.microsoft.com/office/drawing/2014/main" id="{D0420028-BDA9-46BB-B304-E9343684333A}"/>
+                <a16:creationId xmlns:a16="http://schemas.microsoft.com/office/drawing/2014/main" id="{8EF0D879-F95D-446F-AB0A-473836D37992}"/>
               </a:ext>
             </a:extLst>
           </p:cNvPr>
@@ -8265,7 +8264,7 @@
           <p:cNvPr id="14" name="">
             <a:extLst xmlns:a="http://schemas.openxmlformats.org/drawingml/2006/main">
               <a:ext uri="{FF2B5EF4-FFF2-40B4-BE49-F238E27FC236}">
-                <a16:creationId xmlns:a16="http://schemas.microsoft.com/office/drawing/2014/main" id="{3970F837-1548-4718-B97D-05312DA3E0A4}"/>
+                <a16:creationId xmlns:a16="http://schemas.microsoft.com/office/drawing/2014/main" id="{29301A25-9323-4515-A8AD-72626387031F}"/>
               </a:ext>
             </a:extLst>
           </p:cNvPr>
@@ -8319,7 +8318,7 @@
                 <a:ea typeface="Aptos"/>
                 <a:cs typeface="Aptos"/>
               </a:rPr>
-              <a:t>3. Generation plan</a:t>
+              <a:t>3. Human validation</a:t>
             </a:r>
           </a:p>
         </p:txBody>
@@ -8329,7 +8328,7 @@
           <p:cNvPr id="15" name="">
             <a:extLst xmlns:a="http://schemas.openxmlformats.org/drawingml/2006/main">
               <a:ext uri="{FF2B5EF4-FFF2-40B4-BE49-F238E27FC236}">
-                <a16:creationId xmlns:a16="http://schemas.microsoft.com/office/drawing/2014/main" id="{E37DE179-D970-4BD4-9512-EB352FC7020C}"/>
+                <a16:creationId xmlns:a16="http://schemas.microsoft.com/office/drawing/2014/main" id="{D81349C9-2ED5-486D-A3B9-6A5EDFC75D01}"/>
               </a:ext>
             </a:extLst>
           </p:cNvPr>
@@ -8383,7 +8382,7 @@
                 <a:ea typeface="Aptos"/>
                 <a:cs typeface="Aptos"/>
               </a:rPr>
-              <a:t>Create synthetic background traffic plus suspicious chains that conserve funds.</a:t>
+              <a:t>Approve the detected typology only when it matches the evidence and business context.</a:t>
             </a:r>
           </a:p>
         </p:txBody>
@@ -8393,7 +8392,7 @@
           <p:cNvPr id="16" name="">
             <a:extLst xmlns:a="http://schemas.openxmlformats.org/drawingml/2006/main">
               <a:ext uri="{FF2B5EF4-FFF2-40B4-BE49-F238E27FC236}">
-                <a16:creationId xmlns:a16="http://schemas.microsoft.com/office/drawing/2014/main" id="{0BE47C55-4711-428E-AEB8-AF4FDC5660C7}"/>
+                <a16:creationId xmlns:a16="http://schemas.microsoft.com/office/drawing/2014/main" id="{DF5CF99A-0B2D-452A-A823-CC2BDA818403}"/>
               </a:ext>
             </a:extLst>
           </p:cNvPr>
@@ -8426,7 +8425,7 @@
           <p:cNvPr id="17" name="">
             <a:extLst xmlns:a="http://schemas.openxmlformats.org/drawingml/2006/main">
               <a:ext uri="{FF2B5EF4-FFF2-40B4-BE49-F238E27FC236}">
-                <a16:creationId xmlns:a16="http://schemas.microsoft.com/office/drawing/2014/main" id="{1F509EE9-48E9-4F4D-91DB-B0AF1C1A64BF}"/>
+                <a16:creationId xmlns:a16="http://schemas.microsoft.com/office/drawing/2014/main" id="{0B454BA0-9888-42F3-80E4-9675E1CC8E66}"/>
               </a:ext>
             </a:extLst>
           </p:cNvPr>
@@ -8490,7 +8489,7 @@
           <p:cNvPr id="18" name="">
             <a:extLst xmlns:a="http://schemas.openxmlformats.org/drawingml/2006/main">
               <a:ext uri="{FF2B5EF4-FFF2-40B4-BE49-F238E27FC236}">
-                <a16:creationId xmlns:a16="http://schemas.microsoft.com/office/drawing/2014/main" id="{CC56828B-E7C1-43BB-AD9A-DFBABCF5B20A}"/>
+                <a16:creationId xmlns:a16="http://schemas.microsoft.com/office/drawing/2014/main" id="{C18DDFC6-A75F-4AD3-9FD2-86E521BC4794}"/>
               </a:ext>
             </a:extLst>
           </p:cNvPr>
@@ -8554,7 +8553,7 @@
           <p:cNvPr id="19" name="">
             <a:extLst xmlns:a="http://schemas.openxmlformats.org/drawingml/2006/main">
               <a:ext uri="{FF2B5EF4-FFF2-40B4-BE49-F238E27FC236}">
-                <a16:creationId xmlns:a16="http://schemas.microsoft.com/office/drawing/2014/main" id="{09D9FA7B-748A-4817-972B-6C891FD1EEBA}"/>
+                <a16:creationId xmlns:a16="http://schemas.microsoft.com/office/drawing/2014/main" id="{988E40B7-B8B6-4BBB-B404-B398B275D6BB}"/>
               </a:ext>
             </a:extLst>
           </p:cNvPr>
@@ -8587,7 +8586,7 @@
           <p:cNvPr id="20" name="">
             <a:extLst xmlns:a="http://schemas.openxmlformats.org/drawingml/2006/main">
               <a:ext uri="{FF2B5EF4-FFF2-40B4-BE49-F238E27FC236}">
-                <a16:creationId xmlns:a16="http://schemas.microsoft.com/office/drawing/2014/main" id="{45FA62A9-D48E-4FBE-98B7-F344CF688EF8}"/>
+                <a16:creationId xmlns:a16="http://schemas.microsoft.com/office/drawing/2014/main" id="{92B16301-305F-4508-BA4D-85C8EFD4B5BA}"/>
               </a:ext>
             </a:extLst>
           </p:cNvPr>
@@ -8651,7 +8650,7 @@
           <p:cNvPr id="21" name="">
             <a:extLst xmlns:a="http://schemas.openxmlformats.org/drawingml/2006/main">
               <a:ext uri="{FF2B5EF4-FFF2-40B4-BE49-F238E27FC236}">
-                <a16:creationId xmlns:a16="http://schemas.microsoft.com/office/drawing/2014/main" id="{75269A0B-8B44-49B3-8E97-9428AD60806F}"/>
+                <a16:creationId xmlns:a16="http://schemas.microsoft.com/office/drawing/2014/main" id="{59F4A2A3-914E-4D1E-914D-738ED8EA7F64}"/>
               </a:ext>
             </a:extLst>
           </p:cNvPr>
@@ -8715,7 +8714,7 @@
           <p:cNvPr id="22" name="">
             <a:extLst xmlns:a="http://schemas.openxmlformats.org/drawingml/2006/main">
               <a:ext uri="{FF2B5EF4-FFF2-40B4-BE49-F238E27FC236}">
-                <a16:creationId xmlns:a16="http://schemas.microsoft.com/office/drawing/2014/main" id="{2D344567-0FE2-416B-9839-BA2EC5FF75E6}"/>
+                <a16:creationId xmlns:a16="http://schemas.microsoft.com/office/drawing/2014/main" id="{9FEB754D-8B11-4FCC-98F3-EE6A9BE6B3F8}"/>
               </a:ext>
             </a:extLst>
           </p:cNvPr>
@@ -8769,7 +8768,7 @@
                 <a:ea typeface="Aptos"/>
                 <a:cs typeface="Aptos"/>
               </a:rPr>
-              <a:t>Commercial framing: this is not a generic chatbot. It is a structured operating surface for a repeatable compliance data workflow.</a:t>
+              <a:t>Commercial framing: this is not a rule form. It is a structured operating surface for LLM-assisted pattern discovery with human governance.</a:t>
             </a:r>
           </a:p>
         </p:txBody>
@@ -8777,7 +8776,7 @@
     </p:spTree>
     <p:extLst>
       <p:ext uri="{BB962C8B-B14F-4D97-AF65-F5344CB8AC3E}">
-        <p14:creationId xmlns:p14="http://schemas.microsoft.com/office/powerpoint/2010/main" val="675409049"/>
+        <p14:creationId xmlns:p14="http://schemas.microsoft.com/office/powerpoint/2010/main" val="1360612133"/>
       </p:ext>
     </p:extLst>
   </p:cSld>
@@ -8801,7 +8800,7 @@
           <p:cNvPr id="1" name="">
             <a:extLst xmlns:a="http://schemas.openxmlformats.org/drawingml/2006/main">
               <a:ext uri="{FF2B5EF4-FFF2-40B4-BE49-F238E27FC236}">
-                <a16:creationId xmlns:a16="http://schemas.microsoft.com/office/drawing/2014/main" id="{C14EAACB-4475-47C4-9F09-793F6D489EF1}"/>
+                <a16:creationId xmlns:a16="http://schemas.microsoft.com/office/drawing/2014/main" id="{672D8314-FC06-4148-AE31-00984522EB77}"/>
               </a:ext>
             </a:extLst>
           </p:cNvPr>
@@ -8836,7 +8835,7 @@
           <p:cNvPr id="2" name="kicker-marker">
             <a:extLst xmlns:a="http://schemas.openxmlformats.org/drawingml/2006/main">
               <a:ext uri="{FF2B5EF4-FFF2-40B4-BE49-F238E27FC236}">
-                <a16:creationId xmlns:a16="http://schemas.microsoft.com/office/drawing/2014/main" id="{E5F59D83-7C45-4E7D-9B4B-238303F4B2BF}"/>
+                <a16:creationId xmlns:a16="http://schemas.microsoft.com/office/drawing/2014/main" id="{0A3F315B-4B3A-4A4D-812B-493B13655F0B}"/>
               </a:ext>
             </a:extLst>
           </p:cNvPr>
@@ -8871,7 +8870,7 @@
           <p:cNvPr id="3" name="kicker-label">
             <a:extLst xmlns:a="http://schemas.openxmlformats.org/drawingml/2006/main">
               <a:ext uri="{FF2B5EF4-FFF2-40B4-BE49-F238E27FC236}">
-                <a16:creationId xmlns:a16="http://schemas.microsoft.com/office/drawing/2014/main" id="{7E8D3E66-1086-4AC8-87D8-AF2E01026693}"/>
+                <a16:creationId xmlns:a16="http://schemas.microsoft.com/office/drawing/2014/main" id="{8D261404-9BDA-4A98-9DE5-8173236097A3}"/>
               </a:ext>
             </a:extLst>
           </p:cNvPr>
@@ -8935,7 +8934,7 @@
           <p:cNvPr id="4" name="">
             <a:extLst xmlns:a="http://schemas.openxmlformats.org/drawingml/2006/main">
               <a:ext uri="{FF2B5EF4-FFF2-40B4-BE49-F238E27FC236}">
-                <a16:creationId xmlns:a16="http://schemas.microsoft.com/office/drawing/2014/main" id="{5ED15EF2-F8AE-4BFF-B264-ECEFFE8EA2DB}"/>
+                <a16:creationId xmlns:a16="http://schemas.microsoft.com/office/drawing/2014/main" id="{C4DE3C99-E929-4292-9391-C089FC4B6DA3}"/>
               </a:ext>
             </a:extLst>
           </p:cNvPr>
@@ -8989,7 +8988,7 @@
                 <a:ea typeface="Aptos Display"/>
                 <a:cs typeface="Aptos Display"/>
               </a:rPr>
-              <a:t>In the final minute, show the browser workbench instead of static screenshots.</a:t>
+              <a:t>In the final minute, open the browser workbench and show the workflow live.</a:t>
             </a:r>
           </a:p>
         </p:txBody>
@@ -8999,7 +8998,7 @@
           <p:cNvPr id="5" name="">
             <a:extLst xmlns:a="http://schemas.openxmlformats.org/drawingml/2006/main">
               <a:ext uri="{FF2B5EF4-FFF2-40B4-BE49-F238E27FC236}">
-                <a16:creationId xmlns:a16="http://schemas.microsoft.com/office/drawing/2014/main" id="{9D214B17-EBE0-4CD9-B64D-8A658E3C7554}"/>
+                <a16:creationId xmlns:a16="http://schemas.microsoft.com/office/drawing/2014/main" id="{223D271F-90ED-43B4-8F22-74F31DAE8AE7}"/>
               </a:ext>
             </a:extLst>
           </p:cNvPr>
@@ -9034,7 +9033,7 @@
           <p:cNvPr id="6" name="">
             <a:extLst xmlns:a="http://schemas.openxmlformats.org/drawingml/2006/main">
               <a:ext uri="{FF2B5EF4-FFF2-40B4-BE49-F238E27FC236}">
-                <a16:creationId xmlns:a16="http://schemas.microsoft.com/office/drawing/2014/main" id="{8D98BC10-5BA6-412D-8DD0-4ECB91452881}"/>
+                <a16:creationId xmlns:a16="http://schemas.microsoft.com/office/drawing/2014/main" id="{95B596FF-E197-4F8A-90E6-27817F906800}"/>
               </a:ext>
             </a:extLst>
           </p:cNvPr>
@@ -9098,7 +9097,7 @@
           <p:cNvPr id="7" name="">
             <a:extLst xmlns:a="http://schemas.openxmlformats.org/drawingml/2006/main">
               <a:ext uri="{FF2B5EF4-FFF2-40B4-BE49-F238E27FC236}">
-                <a16:creationId xmlns:a16="http://schemas.microsoft.com/office/drawing/2014/main" id="{FCCB01C3-E115-47F6-AED9-0F45B749803C}"/>
+                <a16:creationId xmlns:a16="http://schemas.microsoft.com/office/drawing/2014/main" id="{DB3D680D-4A7B-4F03-8EC4-9653A957A808}"/>
               </a:ext>
             </a:extLst>
           </p:cNvPr>
@@ -9131,7 +9130,7 @@
           <p:cNvPr id="8" name="">
             <a:extLst xmlns:a="http://schemas.openxmlformats.org/drawingml/2006/main">
               <a:ext uri="{FF2B5EF4-FFF2-40B4-BE49-F238E27FC236}">
-                <a16:creationId xmlns:a16="http://schemas.microsoft.com/office/drawing/2014/main" id="{26CC5E1F-0C44-479A-91E6-1F88B29470C7}"/>
+                <a16:creationId xmlns:a16="http://schemas.microsoft.com/office/drawing/2014/main" id="{46F5FA2B-88AE-4F9A-B570-00A2946B0F14}"/>
               </a:ext>
             </a:extLst>
           </p:cNvPr>
@@ -9185,7 +9184,7 @@
                 <a:ea typeface="Aptos"/>
                 <a:cs typeface="Aptos"/>
               </a:rPr>
-              <a:t>Source intake</a:t>
+              <a:t>Record self-intake</a:t>
             </a:r>
           </a:p>
         </p:txBody>
@@ -9195,7 +9194,7 @@
           <p:cNvPr id="9" name="">
             <a:extLst xmlns:a="http://schemas.openxmlformats.org/drawingml/2006/main">
               <a:ext uri="{FF2B5EF4-FFF2-40B4-BE49-F238E27FC236}">
-                <a16:creationId xmlns:a16="http://schemas.microsoft.com/office/drawing/2014/main" id="{AB9BA0E6-7434-48CC-B702-1F52FEBB3080}"/>
+                <a16:creationId xmlns:a16="http://schemas.microsoft.com/office/drawing/2014/main" id="{54353FAD-C4F4-405B-BD82-54DA8C8E34C0}"/>
               </a:ext>
             </a:extLst>
           </p:cNvPr>
@@ -9249,7 +9248,7 @@
                 <a:ea typeface="Aptos"/>
                 <a:cs typeface="Aptos"/>
               </a:rPr>
-              <a:t>Show the preloaded source packet and run extraction.</a:t>
+              <a:t>Show the sample laundering records and run pattern discovery.</a:t>
             </a:r>
           </a:p>
         </p:txBody>
@@ -9259,7 +9258,7 @@
           <p:cNvPr id="10" name="">
             <a:extLst xmlns:a="http://schemas.openxmlformats.org/drawingml/2006/main">
               <a:ext uri="{FF2B5EF4-FFF2-40B4-BE49-F238E27FC236}">
-                <a16:creationId xmlns:a16="http://schemas.microsoft.com/office/drawing/2014/main" id="{EC108D00-A2B8-47BC-A1AF-24E031B705F0}"/>
+                <a16:creationId xmlns:a16="http://schemas.microsoft.com/office/drawing/2014/main" id="{538A3E46-8C10-4510-9C06-41E77A685DAB}"/>
               </a:ext>
             </a:extLst>
           </p:cNvPr>
@@ -9292,7 +9291,7 @@
           <p:cNvPr id="11" name="">
             <a:extLst xmlns:a="http://schemas.openxmlformats.org/drawingml/2006/main">
               <a:ext uri="{FF2B5EF4-FFF2-40B4-BE49-F238E27FC236}">
-                <a16:creationId xmlns:a16="http://schemas.microsoft.com/office/drawing/2014/main" id="{C144939E-3ABC-40AE-AB2A-4087128104D1}"/>
+                <a16:creationId xmlns:a16="http://schemas.microsoft.com/office/drawing/2014/main" id="{5A7F9461-3E60-4EB1-B280-C28C7D8A8F3D}"/>
               </a:ext>
             </a:extLst>
           </p:cNvPr>
@@ -9346,7 +9345,7 @@
                 <a:ea typeface="Aptos"/>
                 <a:cs typeface="Aptos"/>
               </a:rPr>
-              <a:t>Scenario review</a:t>
+              <a:t>Pattern review</a:t>
             </a:r>
           </a:p>
         </p:txBody>
@@ -9356,7 +9355,7 @@
           <p:cNvPr id="12" name="">
             <a:extLst xmlns:a="http://schemas.openxmlformats.org/drawingml/2006/main">
               <a:ext uri="{FF2B5EF4-FFF2-40B4-BE49-F238E27FC236}">
-                <a16:creationId xmlns:a16="http://schemas.microsoft.com/office/drawing/2014/main" id="{0C9DC53D-556A-4E85-BB26-328325963754}"/>
+                <a16:creationId xmlns:a16="http://schemas.microsoft.com/office/drawing/2014/main" id="{F99831A6-63E1-46A6-B588-1F1D80259A87}"/>
               </a:ext>
             </a:extLst>
           </p:cNvPr>
@@ -9410,7 +9409,7 @@
                 <a:ea typeface="Aptos"/>
                 <a:cs typeface="Aptos"/>
               </a:rPr>
-              <a:t>Show that constraints are editable and require analyst approval.</a:t>
+              <a:t>Show the detected typology and human validation gate.</a:t>
             </a:r>
           </a:p>
         </p:txBody>
@@ -9420,7 +9419,7 @@
           <p:cNvPr id="13" name="">
             <a:extLst xmlns:a="http://schemas.openxmlformats.org/drawingml/2006/main">
               <a:ext uri="{FF2B5EF4-FFF2-40B4-BE49-F238E27FC236}">
-                <a16:creationId xmlns:a16="http://schemas.microsoft.com/office/drawing/2014/main" id="{407C04E1-8D0A-4FD1-AE85-A345BF919EAA}"/>
+                <a16:creationId xmlns:a16="http://schemas.microsoft.com/office/drawing/2014/main" id="{5BAB91BE-8741-404C-8515-8484EA11F713}"/>
               </a:ext>
             </a:extLst>
           </p:cNvPr>
@@ -9453,7 +9452,7 @@
           <p:cNvPr id="14" name="">
             <a:extLst xmlns:a="http://schemas.openxmlformats.org/drawingml/2006/main">
               <a:ext uri="{FF2B5EF4-FFF2-40B4-BE49-F238E27FC236}">
-                <a16:creationId xmlns:a16="http://schemas.microsoft.com/office/drawing/2014/main" id="{89821EC6-62A8-4C60-A2CF-2D8FD7E9FCDF}"/>
+                <a16:creationId xmlns:a16="http://schemas.microsoft.com/office/drawing/2014/main" id="{AC204067-66F0-4FB7-AD83-540093E20AB4}"/>
               </a:ext>
             </a:extLst>
           </p:cNvPr>
@@ -9517,7 +9516,7 @@
           <p:cNvPr id="15" name="">
             <a:extLst xmlns:a="http://schemas.openxmlformats.org/drawingml/2006/main">
               <a:ext uri="{FF2B5EF4-FFF2-40B4-BE49-F238E27FC236}">
-                <a16:creationId xmlns:a16="http://schemas.microsoft.com/office/drawing/2014/main" id="{C17F4F5C-1E0F-4051-959C-3852D0ABFE24}"/>
+                <a16:creationId xmlns:a16="http://schemas.microsoft.com/office/drawing/2014/main" id="{E789DE08-E235-45CA-A6C9-4629BDFA8218}"/>
               </a:ext>
             </a:extLst>
           </p:cNvPr>
@@ -9581,7 +9580,7 @@
           <p:cNvPr id="16" name="">
             <a:extLst xmlns:a="http://schemas.openxmlformats.org/drawingml/2006/main">
               <a:ext uri="{FF2B5EF4-FFF2-40B4-BE49-F238E27FC236}">
-                <a16:creationId xmlns:a16="http://schemas.microsoft.com/office/drawing/2014/main" id="{08D6E019-B593-418F-93C2-6E94557CEA54}"/>
+                <a16:creationId xmlns:a16="http://schemas.microsoft.com/office/drawing/2014/main" id="{E0ABA103-2A53-4B76-99DB-030973934A45}"/>
               </a:ext>
             </a:extLst>
           </p:cNvPr>
@@ -9614,7 +9613,7 @@
           <p:cNvPr id="17" name="">
             <a:extLst xmlns:a="http://schemas.openxmlformats.org/drawingml/2006/main">
               <a:ext uri="{FF2B5EF4-FFF2-40B4-BE49-F238E27FC236}">
-                <a16:creationId xmlns:a16="http://schemas.microsoft.com/office/drawing/2014/main" id="{A25D2B97-475B-46A4-B450-FDA7DBDC46B3}"/>
+                <a16:creationId xmlns:a16="http://schemas.microsoft.com/office/drawing/2014/main" id="{B23DAB56-4BA8-46A0-812A-9E28801C876F}"/>
               </a:ext>
             </a:extLst>
           </p:cNvPr>
@@ -9678,7 +9677,7 @@
           <p:cNvPr id="18" name="">
             <a:extLst xmlns:a="http://schemas.openxmlformats.org/drawingml/2006/main">
               <a:ext uri="{FF2B5EF4-FFF2-40B4-BE49-F238E27FC236}">
-                <a16:creationId xmlns:a16="http://schemas.microsoft.com/office/drawing/2014/main" id="{916C5BF9-A0F3-4788-AE42-C0AE2FAD301B}"/>
+                <a16:creationId xmlns:a16="http://schemas.microsoft.com/office/drawing/2014/main" id="{4BF34754-66C6-4326-B6FA-964AA2CA3698}"/>
               </a:ext>
             </a:extLst>
           </p:cNvPr>
@@ -9742,7 +9741,7 @@
           <p:cNvPr id="19" name="">
             <a:extLst xmlns:a="http://schemas.openxmlformats.org/drawingml/2006/main">
               <a:ext uri="{FF2B5EF4-FFF2-40B4-BE49-F238E27FC236}">
-                <a16:creationId xmlns:a16="http://schemas.microsoft.com/office/drawing/2014/main" id="{9C76F897-03DA-4843-A41E-856A7AD58BD7}"/>
+                <a16:creationId xmlns:a16="http://schemas.microsoft.com/office/drawing/2014/main" id="{D6357BC8-5333-4E13-8891-BAC33336440F}"/>
               </a:ext>
             </a:extLst>
           </p:cNvPr>
@@ -9777,7 +9776,7 @@
           <p:cNvPr id="20" name="">
             <a:extLst xmlns:a="http://schemas.openxmlformats.org/drawingml/2006/main">
               <a:ext uri="{FF2B5EF4-FFF2-40B4-BE49-F238E27FC236}">
-                <a16:creationId xmlns:a16="http://schemas.microsoft.com/office/drawing/2014/main" id="{9530C744-9838-48CC-A93A-6C0B391922E5}"/>
+                <a16:creationId xmlns:a16="http://schemas.microsoft.com/office/drawing/2014/main" id="{67F70DD7-127A-47A0-BC1E-86DE41C9D1B1}"/>
               </a:ext>
             </a:extLst>
           </p:cNvPr>
@@ -9841,7 +9840,7 @@
           <p:cNvPr id="21" name="">
             <a:extLst xmlns:a="http://schemas.openxmlformats.org/drawingml/2006/main">
               <a:ext uri="{FF2B5EF4-FFF2-40B4-BE49-F238E27FC236}">
-                <a16:creationId xmlns:a16="http://schemas.microsoft.com/office/drawing/2014/main" id="{922EEFB3-51FF-4ADD-9C86-9916A98105AA}"/>
+                <a16:creationId xmlns:a16="http://schemas.microsoft.com/office/drawing/2014/main" id="{43E2C67C-ACEC-4995-A3A5-03E0C1E485AF}"/>
               </a:ext>
             </a:extLst>
           </p:cNvPr>
@@ -9894,7 +9893,6 @@
                 <a:latin typeface="Aptos"/>
                 <a:ea typeface="Aptos"/>
                 <a:cs typeface="Aptos"/>
-                <a:hlinkClick xmlns:r="http://schemas.openxmlformats.org/officeDocument/2006/relationships" r:id="rIdSynthAMLDemo"/>
               </a:rPr>
               <a:t>https://raw.githack.com/yq688m3JT/genAI_final/ae9c84ea574e9f8c48c84f1863ce82f77ea4f24e/docs/demo.html</a:t>
             </a:r>
@@ -9904,7 +9902,7 @@
     </p:spTree>
     <p:extLst>
       <p:ext uri="{BB962C8B-B14F-4D97-AF65-F5344CB8AC3E}">
-        <p14:creationId xmlns:p14="http://schemas.microsoft.com/office/powerpoint/2010/main" val="943759994"/>
+        <p14:creationId xmlns:p14="http://schemas.microsoft.com/office/powerpoint/2010/main" val="386717638"/>
       </p:ext>
     </p:extLst>
   </p:cSld>

</xml_diff>

<commit_message>
Pin corrected browser demo link
</commit_message>
<xml_diff>
--- a/docs/synthaml-final-presentation.pptx
+++ b/docs/synthaml-final-presentation.pptx
@@ -2,19 +2,19 @@
 <file path=ppt/presentation.xml><?xml version="1.0" encoding="utf-8"?>
 <p:presentation xmlns:p="http://schemas.openxmlformats.org/presentationml/2006/main">
   <p:sldMasterIdLst>
-    <p:sldMasterId xmlns:r="http://schemas.openxmlformats.org/officeDocument/2006/relationships" id="2147483648" r:id="Ra68f313c18804905"/>
+    <p:sldMasterId xmlns:r="http://schemas.openxmlformats.org/officeDocument/2006/relationships" id="2147483648" r:id="Rcfef0ef060c8418c"/>
   </p:sldMasterIdLst>
   <p:notesMasterIdLst>
-    <p:notesMasterId xmlns:r="http://schemas.openxmlformats.org/officeDocument/2006/relationships" r:id="Rf46faca964c5475d"/>
+    <p:notesMasterId xmlns:r="http://schemas.openxmlformats.org/officeDocument/2006/relationships" r:id="R9d876333ddde406f"/>
   </p:notesMasterIdLst>
   <p:sldIdLst>
-    <p:sldId xmlns:r="http://schemas.openxmlformats.org/officeDocument/2006/relationships" id="256" r:id="R5eed4f59fe914b62"/>
-    <p:sldId xmlns:r="http://schemas.openxmlformats.org/officeDocument/2006/relationships" id="257" r:id="R8772645b1b1d40b0"/>
-    <p:sldId xmlns:r="http://schemas.openxmlformats.org/officeDocument/2006/relationships" id="258" r:id="R325526c031924799"/>
-    <p:sldId xmlns:r="http://schemas.openxmlformats.org/officeDocument/2006/relationships" id="259" r:id="R3b3ecb53864c4b4e"/>
-    <p:sldId xmlns:r="http://schemas.openxmlformats.org/officeDocument/2006/relationships" id="260" r:id="R224bd872dd65472f"/>
-    <p:sldId xmlns:r="http://schemas.openxmlformats.org/officeDocument/2006/relationships" id="261" r:id="Rc0ba681470dd4de6"/>
-    <p:sldId xmlns:r="http://schemas.openxmlformats.org/officeDocument/2006/relationships" id="262" r:id="Re224aac4bae8434f"/>
+    <p:sldId xmlns:r="http://schemas.openxmlformats.org/officeDocument/2006/relationships" id="256" r:id="R548c0bbe1e54443e"/>
+    <p:sldId xmlns:r="http://schemas.openxmlformats.org/officeDocument/2006/relationships" id="257" r:id="R6f1c515c0f2f4a47"/>
+    <p:sldId xmlns:r="http://schemas.openxmlformats.org/officeDocument/2006/relationships" id="258" r:id="R8773f2e9089a41fb"/>
+    <p:sldId xmlns:r="http://schemas.openxmlformats.org/officeDocument/2006/relationships" id="259" r:id="Rd10ba0bc75504158"/>
+    <p:sldId xmlns:r="http://schemas.openxmlformats.org/officeDocument/2006/relationships" id="260" r:id="R2143d4f99a1f403a"/>
+    <p:sldId xmlns:r="http://schemas.openxmlformats.org/officeDocument/2006/relationships" id="261" r:id="Rd314185a59ff4968"/>
+    <p:sldId xmlns:r="http://schemas.openxmlformats.org/officeDocument/2006/relationships" id="262" r:id="R51060c052ab346b9"/>
   </p:sldIdLst>
   <p:sldSz cx="12192000" cy="6858000"/>
   <p:notesSz cx="6858000" cy="9144000"/>
@@ -957,7 +957,7 @@
   </p:cSld>
   <p:clrMap bg1="lt1" tx1="dk1" bg2="lt2" tx2="dk2" accent1="accent1" accent2="accent2" accent3="accent3" accent4="accent4" accent5="accent5" accent6="accent6" hlink="hlink" folHlink="folHlink"/>
   <p:sldLayoutIdLst>
-    <p:sldLayoutId xmlns:r="http://schemas.openxmlformats.org/officeDocument/2006/relationships" id="2147483649" r:id="Re32c581106924607"/>
+    <p:sldLayoutId xmlns:r="http://schemas.openxmlformats.org/officeDocument/2006/relationships" id="2147483649" r:id="Rd2ab3c0fce01427e"/>
   </p:sldLayoutIdLst>
   <p:txStyles>
     <p:titleStyle>
@@ -1256,7 +1256,7 @@
           <p:cNvPr id="1" name="">
             <a:extLst xmlns:a="http://schemas.openxmlformats.org/drawingml/2006/main">
               <a:ext uri="{FF2B5EF4-FFF2-40B4-BE49-F238E27FC236}">
-                <a16:creationId xmlns:a16="http://schemas.microsoft.com/office/drawing/2014/main" id="{EC383595-02AA-4CF5-8BA5-CFCB18620B77}"/>
+                <a16:creationId xmlns:a16="http://schemas.microsoft.com/office/drawing/2014/main" id="{986C2AF5-EA10-4A9E-8282-C8A78118B0BF}"/>
               </a:ext>
             </a:extLst>
           </p:cNvPr>
@@ -1291,7 +1291,7 @@
           <p:cNvPr id="2" name="">
             <a:extLst xmlns:a="http://schemas.openxmlformats.org/drawingml/2006/main">
               <a:ext uri="{FF2B5EF4-FFF2-40B4-BE49-F238E27FC236}">
-                <a16:creationId xmlns:a16="http://schemas.microsoft.com/office/drawing/2014/main" id="{68C12D06-C8C8-4889-8547-F6D168C5E8C2}"/>
+                <a16:creationId xmlns:a16="http://schemas.microsoft.com/office/drawing/2014/main" id="{8B9F09E3-CE97-42DA-B754-69512FF5622F}"/>
               </a:ext>
             </a:extLst>
           </p:cNvPr>
@@ -1326,7 +1326,7 @@
           <p:cNvPr id="3" name="">
             <a:extLst xmlns:a="http://schemas.openxmlformats.org/drawingml/2006/main">
               <a:ext uri="{FF2B5EF4-FFF2-40B4-BE49-F238E27FC236}">
-                <a16:creationId xmlns:a16="http://schemas.microsoft.com/office/drawing/2014/main" id="{75BF0E2E-2E6F-40E4-AF60-96B38C8C05BC}"/>
+                <a16:creationId xmlns:a16="http://schemas.microsoft.com/office/drawing/2014/main" id="{99675DE5-D985-4E32-AFD5-C6AF36E297E1}"/>
               </a:ext>
             </a:extLst>
           </p:cNvPr>
@@ -1390,7 +1390,7 @@
           <p:cNvPr id="4" name="">
             <a:extLst xmlns:a="http://schemas.openxmlformats.org/drawingml/2006/main">
               <a:ext uri="{FF2B5EF4-FFF2-40B4-BE49-F238E27FC236}">
-                <a16:creationId xmlns:a16="http://schemas.microsoft.com/office/drawing/2014/main" id="{79FF6EA5-33F0-482A-9020-540CC7C22848}"/>
+                <a16:creationId xmlns:a16="http://schemas.microsoft.com/office/drawing/2014/main" id="{D436324B-702F-4C20-B2A9-630B7347392D}"/>
               </a:ext>
             </a:extLst>
           </p:cNvPr>
@@ -1454,7 +1454,7 @@
           <p:cNvPr id="5" name="">
             <a:extLst xmlns:a="http://schemas.openxmlformats.org/drawingml/2006/main">
               <a:ext uri="{FF2B5EF4-FFF2-40B4-BE49-F238E27FC236}">
-                <a16:creationId xmlns:a16="http://schemas.microsoft.com/office/drawing/2014/main" id="{BD6983BA-1156-4080-AABF-B241F308EF65}"/>
+                <a16:creationId xmlns:a16="http://schemas.microsoft.com/office/drawing/2014/main" id="{907EA4C4-5830-4379-928A-13CDB6B2C8C5}"/>
               </a:ext>
             </a:extLst>
           </p:cNvPr>
@@ -1518,7 +1518,7 @@
           <p:cNvPr id="6" name="">
             <a:extLst xmlns:a="http://schemas.openxmlformats.org/drawingml/2006/main">
               <a:ext uri="{FF2B5EF4-FFF2-40B4-BE49-F238E27FC236}">
-                <a16:creationId xmlns:a16="http://schemas.microsoft.com/office/drawing/2014/main" id="{1BA85056-DDB2-4DBD-B253-C2590523644A}"/>
+                <a16:creationId xmlns:a16="http://schemas.microsoft.com/office/drawing/2014/main" id="{1119CA1C-EF9A-4AD2-986A-DC7C32DBD967}"/>
               </a:ext>
             </a:extLst>
           </p:cNvPr>
@@ -1553,7 +1553,7 @@
           <p:cNvPr id="7" name="">
             <a:extLst xmlns:a="http://schemas.openxmlformats.org/drawingml/2006/main">
               <a:ext uri="{FF2B5EF4-FFF2-40B4-BE49-F238E27FC236}">
-                <a16:creationId xmlns:a16="http://schemas.microsoft.com/office/drawing/2014/main" id="{FA7BC993-4D35-48A9-BD80-58FFAEC9C3EA}"/>
+                <a16:creationId xmlns:a16="http://schemas.microsoft.com/office/drawing/2014/main" id="{6D5B59BE-B27F-422A-93A8-1DA51BAA1DAD}"/>
               </a:ext>
             </a:extLst>
           </p:cNvPr>
@@ -1617,7 +1617,7 @@
           <p:cNvPr id="8" name="">
             <a:extLst xmlns:a="http://schemas.openxmlformats.org/drawingml/2006/main">
               <a:ext uri="{FF2B5EF4-FFF2-40B4-BE49-F238E27FC236}">
-                <a16:creationId xmlns:a16="http://schemas.microsoft.com/office/drawing/2014/main" id="{10087370-BF67-4A3E-902E-582175E1F58E}"/>
+                <a16:creationId xmlns:a16="http://schemas.microsoft.com/office/drawing/2014/main" id="{7EDB3EC2-CAA9-4EE1-884F-C1EC882115C4}"/>
               </a:ext>
             </a:extLst>
           </p:cNvPr>
@@ -1681,7 +1681,7 @@
           <p:cNvPr id="9" name="">
             <a:extLst xmlns:a="http://schemas.openxmlformats.org/drawingml/2006/main">
               <a:ext uri="{FF2B5EF4-FFF2-40B4-BE49-F238E27FC236}">
-                <a16:creationId xmlns:a16="http://schemas.microsoft.com/office/drawing/2014/main" id="{12B9EA36-F047-4BB7-BBF0-F18349FABE0E}"/>
+                <a16:creationId xmlns:a16="http://schemas.microsoft.com/office/drawing/2014/main" id="{D0F6B052-C993-40D6-A2F0-7354895725C3}"/>
               </a:ext>
             </a:extLst>
           </p:cNvPr>
@@ -1745,7 +1745,7 @@
           <p:cNvPr id="10" name="">
             <a:extLst xmlns:a="http://schemas.openxmlformats.org/drawingml/2006/main">
               <a:ext uri="{FF2B5EF4-FFF2-40B4-BE49-F238E27FC236}">
-                <a16:creationId xmlns:a16="http://schemas.microsoft.com/office/drawing/2014/main" id="{70C51C5D-8C2E-4C55-9C3B-46F3128CC05C}"/>
+                <a16:creationId xmlns:a16="http://schemas.microsoft.com/office/drawing/2014/main" id="{BAA0AABD-813F-45A4-A26A-C9CDE57C510F}"/>
               </a:ext>
             </a:extLst>
           </p:cNvPr>
@@ -1809,7 +1809,7 @@
           <p:cNvPr id="11" name="">
             <a:extLst xmlns:a="http://schemas.openxmlformats.org/drawingml/2006/main">
               <a:ext uri="{FF2B5EF4-FFF2-40B4-BE49-F238E27FC236}">
-                <a16:creationId xmlns:a16="http://schemas.microsoft.com/office/drawing/2014/main" id="{E33E9A6F-8E1B-481F-99EA-D4B516B8B361}"/>
+                <a16:creationId xmlns:a16="http://schemas.microsoft.com/office/drawing/2014/main" id="{A65665BD-61E2-49C4-B511-323482CC3D1E}"/>
               </a:ext>
             </a:extLst>
           </p:cNvPr>
@@ -1873,7 +1873,7 @@
           <p:cNvPr id="12" name="">
             <a:extLst xmlns:a="http://schemas.openxmlformats.org/drawingml/2006/main">
               <a:ext uri="{FF2B5EF4-FFF2-40B4-BE49-F238E27FC236}">
-                <a16:creationId xmlns:a16="http://schemas.microsoft.com/office/drawing/2014/main" id="{0409908B-A7EF-4A2A-84A1-9B2F06B8A533}"/>
+                <a16:creationId xmlns:a16="http://schemas.microsoft.com/office/drawing/2014/main" id="{EB5034D4-B52F-48F8-9BC6-894481568138}"/>
               </a:ext>
             </a:extLst>
           </p:cNvPr>
@@ -1937,7 +1937,7 @@
           <p:cNvPr id="13" name="">
             <a:extLst xmlns:a="http://schemas.openxmlformats.org/drawingml/2006/main">
               <a:ext uri="{FF2B5EF4-FFF2-40B4-BE49-F238E27FC236}">
-                <a16:creationId xmlns:a16="http://schemas.microsoft.com/office/drawing/2014/main" id="{E761F536-19B8-4593-9ACE-AFE456E92646}"/>
+                <a16:creationId xmlns:a16="http://schemas.microsoft.com/office/drawing/2014/main" id="{AE70E98D-8A47-4AB0-AC9B-4269801FC0CC}"/>
               </a:ext>
             </a:extLst>
           </p:cNvPr>
@@ -1972,7 +1972,7 @@
           <p:cNvPr id="14" name="">
             <a:extLst xmlns:a="http://schemas.openxmlformats.org/drawingml/2006/main">
               <a:ext uri="{FF2B5EF4-FFF2-40B4-BE49-F238E27FC236}">
-                <a16:creationId xmlns:a16="http://schemas.microsoft.com/office/drawing/2014/main" id="{AE2E647D-6EB2-4400-9997-CCA3DC94FBA4}"/>
+                <a16:creationId xmlns:a16="http://schemas.microsoft.com/office/drawing/2014/main" id="{03978FD1-3BDE-493E-B912-F4698A9F5CF3}"/>
               </a:ext>
             </a:extLst>
           </p:cNvPr>
@@ -2036,7 +2036,7 @@
           <p:cNvPr id="15" name="">
             <a:extLst xmlns:a="http://schemas.openxmlformats.org/drawingml/2006/main">
               <a:ext uri="{FF2B5EF4-FFF2-40B4-BE49-F238E27FC236}">
-                <a16:creationId xmlns:a16="http://schemas.microsoft.com/office/drawing/2014/main" id="{DEA31200-B6B4-4528-BCF1-4657FABDFBB7}"/>
+                <a16:creationId xmlns:a16="http://schemas.microsoft.com/office/drawing/2014/main" id="{44190A00-3650-404B-A5A9-51854BC34121}"/>
               </a:ext>
             </a:extLst>
           </p:cNvPr>
@@ -2123,7 +2123,7 @@
           <p:cNvPr id="16" name="">
             <a:extLst xmlns:a="http://schemas.openxmlformats.org/drawingml/2006/main">
               <a:ext uri="{FF2B5EF4-FFF2-40B4-BE49-F238E27FC236}">
-                <a16:creationId xmlns:a16="http://schemas.microsoft.com/office/drawing/2014/main" id="{4C31179B-D606-4DF4-9D92-5E907D22067F}"/>
+                <a16:creationId xmlns:a16="http://schemas.microsoft.com/office/drawing/2014/main" id="{E4E5B31F-200F-453A-A69E-4FF89E33DBE6}"/>
               </a:ext>
             </a:extLst>
           </p:cNvPr>
@@ -2187,7 +2187,7 @@
           <p:cNvPr id="17" name="">
             <a:extLst xmlns:a="http://schemas.openxmlformats.org/drawingml/2006/main">
               <a:ext uri="{FF2B5EF4-FFF2-40B4-BE49-F238E27FC236}">
-                <a16:creationId xmlns:a16="http://schemas.microsoft.com/office/drawing/2014/main" id="{CA8843FB-CF93-4DA3-94A0-CC4C6219D38B}"/>
+                <a16:creationId xmlns:a16="http://schemas.microsoft.com/office/drawing/2014/main" id="{0AD077D7-8926-4F51-A0BE-A4F738990934}"/>
               </a:ext>
             </a:extLst>
           </p:cNvPr>
@@ -2240,8 +2240,9 @@
                 <a:latin typeface="Aptos"/>
                 <a:ea typeface="Aptos"/>
                 <a:cs typeface="Aptos"/>
+                <a:hlinkClick xmlns:r="http://schemas.openxmlformats.org/officeDocument/2006/relationships" r:id="rIdSynthAMLDemo"/>
               </a:rPr>
-              <a:t>https://raw.githack.com/yq688m3JT/genAI_final/ae9c84ea574e9f8c48c84f1863ce82f77ea4f24e/docs/demo.html</a:t>
+              <a:t>https://raw.githack.com/yq688m3JT/genAI_final/a909764e2905cf627550479f619ade84aa52cfa9/docs/demo.html</a:t>
             </a:r>
           </a:p>
         </p:txBody>
@@ -2249,7 +2250,7 @@
     </p:spTree>
     <p:extLst>
       <p:ext uri="{BB962C8B-B14F-4D97-AF65-F5344CB8AC3E}">
-        <p14:creationId xmlns:p14="http://schemas.microsoft.com/office/powerpoint/2010/main" val="1246424780"/>
+        <p14:creationId xmlns:p14="http://schemas.microsoft.com/office/powerpoint/2010/main" val="1762840131"/>
       </p:ext>
     </p:extLst>
   </p:cSld>
@@ -2273,7 +2274,7 @@
           <p:cNvPr id="1" name="">
             <a:extLst xmlns:a="http://schemas.openxmlformats.org/drawingml/2006/main">
               <a:ext uri="{FF2B5EF4-FFF2-40B4-BE49-F238E27FC236}">
-                <a16:creationId xmlns:a16="http://schemas.microsoft.com/office/drawing/2014/main" id="{57330D52-BF53-41D8-8D9A-B364DD4AF307}"/>
+                <a16:creationId xmlns:a16="http://schemas.microsoft.com/office/drawing/2014/main" id="{11B534BA-824D-4638-8D48-94244B1D632F}"/>
               </a:ext>
             </a:extLst>
           </p:cNvPr>
@@ -2308,7 +2309,7 @@
           <p:cNvPr id="2" name="kicker-marker">
             <a:extLst xmlns:a="http://schemas.openxmlformats.org/drawingml/2006/main">
               <a:ext uri="{FF2B5EF4-FFF2-40B4-BE49-F238E27FC236}">
-                <a16:creationId xmlns:a16="http://schemas.microsoft.com/office/drawing/2014/main" id="{6012C92C-AF98-4966-A481-860F2E82BD00}"/>
+                <a16:creationId xmlns:a16="http://schemas.microsoft.com/office/drawing/2014/main" id="{00C4AD68-8164-4856-B6EE-75F81BE12D43}"/>
               </a:ext>
             </a:extLst>
           </p:cNvPr>
@@ -2343,7 +2344,7 @@
           <p:cNvPr id="3" name="kicker-label">
             <a:extLst xmlns:a="http://schemas.openxmlformats.org/drawingml/2006/main">
               <a:ext uri="{FF2B5EF4-FFF2-40B4-BE49-F238E27FC236}">
-                <a16:creationId xmlns:a16="http://schemas.microsoft.com/office/drawing/2014/main" id="{5B1D54C5-3FA9-4FFA-BDF5-88462F9BBCA8}"/>
+                <a16:creationId xmlns:a16="http://schemas.microsoft.com/office/drawing/2014/main" id="{0EDB8118-B9B8-4BD2-9059-D1C746E09471}"/>
               </a:ext>
             </a:extLst>
           </p:cNvPr>
@@ -2407,7 +2408,7 @@
           <p:cNvPr id="4" name="">
             <a:extLst xmlns:a="http://schemas.openxmlformats.org/drawingml/2006/main">
               <a:ext uri="{FF2B5EF4-FFF2-40B4-BE49-F238E27FC236}">
-                <a16:creationId xmlns:a16="http://schemas.microsoft.com/office/drawing/2014/main" id="{18867EAC-58E3-45BA-B520-82C730DB290E}"/>
+                <a16:creationId xmlns:a16="http://schemas.microsoft.com/office/drawing/2014/main" id="{506CA177-5C3A-4591-8C51-47B33AB1278E}"/>
               </a:ext>
             </a:extLst>
           </p:cNvPr>
@@ -2471,7 +2472,7 @@
           <p:cNvPr id="5" name="">
             <a:extLst xmlns:a="http://schemas.openxmlformats.org/drawingml/2006/main">
               <a:ext uri="{FF2B5EF4-FFF2-40B4-BE49-F238E27FC236}">
-                <a16:creationId xmlns:a16="http://schemas.microsoft.com/office/drawing/2014/main" id="{D623A52D-7883-43B5-89E9-2126851C205E}"/>
+                <a16:creationId xmlns:a16="http://schemas.microsoft.com/office/drawing/2014/main" id="{2A9971B8-3E04-4928-BC0F-63B033EB00E9}"/>
               </a:ext>
             </a:extLst>
           </p:cNvPr>
@@ -2535,7 +2536,7 @@
           <p:cNvPr id="6" name="">
             <a:extLst xmlns:a="http://schemas.openxmlformats.org/drawingml/2006/main">
               <a:ext uri="{FF2B5EF4-FFF2-40B4-BE49-F238E27FC236}">
-                <a16:creationId xmlns:a16="http://schemas.microsoft.com/office/drawing/2014/main" id="{7A12355E-AE44-4035-8EBF-7564E43AAE85}"/>
+                <a16:creationId xmlns:a16="http://schemas.microsoft.com/office/drawing/2014/main" id="{414EC91D-067B-4F36-B8AB-9F933C132A29}"/>
               </a:ext>
             </a:extLst>
           </p:cNvPr>
@@ -2570,7 +2571,7 @@
           <p:cNvPr id="7" name="">
             <a:extLst xmlns:a="http://schemas.openxmlformats.org/drawingml/2006/main">
               <a:ext uri="{FF2B5EF4-FFF2-40B4-BE49-F238E27FC236}">
-                <a16:creationId xmlns:a16="http://schemas.microsoft.com/office/drawing/2014/main" id="{24F974BE-8B62-4F95-AB34-182E1C5299C1}"/>
+                <a16:creationId xmlns:a16="http://schemas.microsoft.com/office/drawing/2014/main" id="{0B34B94F-74C7-486F-8E5B-A6A7C86BACB8}"/>
               </a:ext>
             </a:extLst>
           </p:cNvPr>
@@ -2634,7 +2635,7 @@
           <p:cNvPr id="8" name="">
             <a:extLst xmlns:a="http://schemas.openxmlformats.org/drawingml/2006/main">
               <a:ext uri="{FF2B5EF4-FFF2-40B4-BE49-F238E27FC236}">
-                <a16:creationId xmlns:a16="http://schemas.microsoft.com/office/drawing/2014/main" id="{645534DD-5911-4D3A-BB7B-515DB23E0B80}"/>
+                <a16:creationId xmlns:a16="http://schemas.microsoft.com/office/drawing/2014/main" id="{1FF4AEB7-D23A-41FB-9ADF-0517FCA511E8}"/>
               </a:ext>
             </a:extLst>
           </p:cNvPr>
@@ -2698,7 +2699,7 @@
           <p:cNvPr id="9" name="">
             <a:extLst xmlns:a="http://schemas.openxmlformats.org/drawingml/2006/main">
               <a:ext uri="{FF2B5EF4-FFF2-40B4-BE49-F238E27FC236}">
-                <a16:creationId xmlns:a16="http://schemas.microsoft.com/office/drawing/2014/main" id="{0160D56C-8C62-4003-B929-0CAFA67B18AC}"/>
+                <a16:creationId xmlns:a16="http://schemas.microsoft.com/office/drawing/2014/main" id="{039A8938-CCF7-4D68-B25A-C6C229187439}"/>
               </a:ext>
             </a:extLst>
           </p:cNvPr>
@@ -2762,7 +2763,7 @@
           <p:cNvPr id="10" name="">
             <a:extLst xmlns:a="http://schemas.openxmlformats.org/drawingml/2006/main">
               <a:ext uri="{FF2B5EF4-FFF2-40B4-BE49-F238E27FC236}">
-                <a16:creationId xmlns:a16="http://schemas.microsoft.com/office/drawing/2014/main" id="{8D113DEE-CDC1-42A5-B65A-E4AAB249B2D4}"/>
+                <a16:creationId xmlns:a16="http://schemas.microsoft.com/office/drawing/2014/main" id="{B5FF3C0D-E690-4FFA-8797-CA03593530D3}"/>
               </a:ext>
             </a:extLst>
           </p:cNvPr>
@@ -2797,7 +2798,7 @@
           <p:cNvPr id="11" name="">
             <a:extLst xmlns:a="http://schemas.openxmlformats.org/drawingml/2006/main">
               <a:ext uri="{FF2B5EF4-FFF2-40B4-BE49-F238E27FC236}">
-                <a16:creationId xmlns:a16="http://schemas.microsoft.com/office/drawing/2014/main" id="{480FECA1-B9CB-46C9-B4DA-4689F1B159A4}"/>
+                <a16:creationId xmlns:a16="http://schemas.microsoft.com/office/drawing/2014/main" id="{9470DEB2-2550-4B7D-A5EC-12672564BC34}"/>
               </a:ext>
             </a:extLst>
           </p:cNvPr>
@@ -2832,7 +2833,7 @@
           <p:cNvPr id="12" name="">
             <a:extLst xmlns:a="http://schemas.openxmlformats.org/drawingml/2006/main">
               <a:ext uri="{FF2B5EF4-FFF2-40B4-BE49-F238E27FC236}">
-                <a16:creationId xmlns:a16="http://schemas.microsoft.com/office/drawing/2014/main" id="{E3918A58-AB3F-424F-99DD-8845A4A530C9}"/>
+                <a16:creationId xmlns:a16="http://schemas.microsoft.com/office/drawing/2014/main" id="{3F7C31E1-53D2-4E41-8BA1-FAF55E457618}"/>
               </a:ext>
             </a:extLst>
           </p:cNvPr>
@@ -2867,7 +2868,7 @@
           <p:cNvPr id="13" name="">
             <a:extLst xmlns:a="http://schemas.openxmlformats.org/drawingml/2006/main">
               <a:ext uri="{FF2B5EF4-FFF2-40B4-BE49-F238E27FC236}">
-                <a16:creationId xmlns:a16="http://schemas.microsoft.com/office/drawing/2014/main" id="{FDD19470-D8B5-4C68-A22B-4BBE4BA08273}"/>
+                <a16:creationId xmlns:a16="http://schemas.microsoft.com/office/drawing/2014/main" id="{64FBA750-9631-4723-BA86-FF6A731F10C9}"/>
               </a:ext>
             </a:extLst>
           </p:cNvPr>
@@ -2931,7 +2932,7 @@
           <p:cNvPr id="14" name="">
             <a:extLst xmlns:a="http://schemas.openxmlformats.org/drawingml/2006/main">
               <a:ext uri="{FF2B5EF4-FFF2-40B4-BE49-F238E27FC236}">
-                <a16:creationId xmlns:a16="http://schemas.microsoft.com/office/drawing/2014/main" id="{0463A178-1E4C-496E-9A67-D81DAA120C3C}"/>
+                <a16:creationId xmlns:a16="http://schemas.microsoft.com/office/drawing/2014/main" id="{C02D943A-D7BB-43DC-A09B-A85F2F355B1C}"/>
               </a:ext>
             </a:extLst>
           </p:cNvPr>
@@ -2995,7 +2996,7 @@
           <p:cNvPr id="15" name="">
             <a:extLst xmlns:a="http://schemas.openxmlformats.org/drawingml/2006/main">
               <a:ext uri="{FF2B5EF4-FFF2-40B4-BE49-F238E27FC236}">
-                <a16:creationId xmlns:a16="http://schemas.microsoft.com/office/drawing/2014/main" id="{E5BB8646-A2EA-4615-B085-F2125D58BC61}"/>
+                <a16:creationId xmlns:a16="http://schemas.microsoft.com/office/drawing/2014/main" id="{AE833655-4278-491F-A300-DC2548BDA58A}"/>
               </a:ext>
             </a:extLst>
           </p:cNvPr>
@@ -3059,7 +3060,7 @@
           <p:cNvPr id="16" name="">
             <a:extLst xmlns:a="http://schemas.openxmlformats.org/drawingml/2006/main">
               <a:ext uri="{FF2B5EF4-FFF2-40B4-BE49-F238E27FC236}">
-                <a16:creationId xmlns:a16="http://schemas.microsoft.com/office/drawing/2014/main" id="{B346B160-BAAE-45D0-89C5-3D257F7FF573}"/>
+                <a16:creationId xmlns:a16="http://schemas.microsoft.com/office/drawing/2014/main" id="{C2C55566-8664-4D1B-8F18-BE7BB189849D}"/>
               </a:ext>
             </a:extLst>
           </p:cNvPr>
@@ -3094,7 +3095,7 @@
           <p:cNvPr id="17" name="">
             <a:extLst xmlns:a="http://schemas.openxmlformats.org/drawingml/2006/main">
               <a:ext uri="{FF2B5EF4-FFF2-40B4-BE49-F238E27FC236}">
-                <a16:creationId xmlns:a16="http://schemas.microsoft.com/office/drawing/2014/main" id="{CFF80E1D-5183-4F48-B809-5A7E2401D826}"/>
+                <a16:creationId xmlns:a16="http://schemas.microsoft.com/office/drawing/2014/main" id="{5A493191-0EAB-4DAD-9478-39E889E011E6}"/>
               </a:ext>
             </a:extLst>
           </p:cNvPr>
@@ -3129,7 +3130,7 @@
           <p:cNvPr id="18" name="">
             <a:extLst xmlns:a="http://schemas.openxmlformats.org/drawingml/2006/main">
               <a:ext uri="{FF2B5EF4-FFF2-40B4-BE49-F238E27FC236}">
-                <a16:creationId xmlns:a16="http://schemas.microsoft.com/office/drawing/2014/main" id="{BCC3BFAA-3514-44FC-AE0A-A2E86FAD1EF5}"/>
+                <a16:creationId xmlns:a16="http://schemas.microsoft.com/office/drawing/2014/main" id="{523808CA-89FF-4ED2-A6B9-C9648A01243A}"/>
               </a:ext>
             </a:extLst>
           </p:cNvPr>
@@ -3164,7 +3165,7 @@
           <p:cNvPr id="19" name="">
             <a:extLst xmlns:a="http://schemas.openxmlformats.org/drawingml/2006/main">
               <a:ext uri="{FF2B5EF4-FFF2-40B4-BE49-F238E27FC236}">
-                <a16:creationId xmlns:a16="http://schemas.microsoft.com/office/drawing/2014/main" id="{EF18ADB2-8139-4A7C-83C6-ECB89474A770}"/>
+                <a16:creationId xmlns:a16="http://schemas.microsoft.com/office/drawing/2014/main" id="{14E6E8DD-C97A-4727-909E-8706645C03C1}"/>
               </a:ext>
             </a:extLst>
           </p:cNvPr>
@@ -3228,7 +3229,7 @@
           <p:cNvPr id="20" name="">
             <a:extLst xmlns:a="http://schemas.openxmlformats.org/drawingml/2006/main">
               <a:ext uri="{FF2B5EF4-FFF2-40B4-BE49-F238E27FC236}">
-                <a16:creationId xmlns:a16="http://schemas.microsoft.com/office/drawing/2014/main" id="{A5D1CC8F-7405-4A67-9F21-6F00D8F54008}"/>
+                <a16:creationId xmlns:a16="http://schemas.microsoft.com/office/drawing/2014/main" id="{6C618694-5654-46EC-91AC-F60C516EA207}"/>
               </a:ext>
             </a:extLst>
           </p:cNvPr>
@@ -3292,7 +3293,7 @@
           <p:cNvPr id="21" name="">
             <a:extLst xmlns:a="http://schemas.openxmlformats.org/drawingml/2006/main">
               <a:ext uri="{FF2B5EF4-FFF2-40B4-BE49-F238E27FC236}">
-                <a16:creationId xmlns:a16="http://schemas.microsoft.com/office/drawing/2014/main" id="{6E6C2538-78BE-45CF-8D78-B02A84FB6339}"/>
+                <a16:creationId xmlns:a16="http://schemas.microsoft.com/office/drawing/2014/main" id="{E8C249E2-F8D6-4098-9A03-B360B48D77E4}"/>
               </a:ext>
             </a:extLst>
           </p:cNvPr>
@@ -3356,7 +3357,7 @@
           <p:cNvPr id="22" name="">
             <a:extLst xmlns:a="http://schemas.openxmlformats.org/drawingml/2006/main">
               <a:ext uri="{FF2B5EF4-FFF2-40B4-BE49-F238E27FC236}">
-                <a16:creationId xmlns:a16="http://schemas.microsoft.com/office/drawing/2014/main" id="{AF65CF4D-C121-44CC-90D7-A0F70ED1100A}"/>
+                <a16:creationId xmlns:a16="http://schemas.microsoft.com/office/drawing/2014/main" id="{95147C3D-69EF-42A7-90C5-7F0C14A1CFE3}"/>
               </a:ext>
             </a:extLst>
           </p:cNvPr>
@@ -3389,7 +3390,7 @@
           <p:cNvPr id="23" name="">
             <a:extLst xmlns:a="http://schemas.openxmlformats.org/drawingml/2006/main">
               <a:ext uri="{FF2B5EF4-FFF2-40B4-BE49-F238E27FC236}">
-                <a16:creationId xmlns:a16="http://schemas.microsoft.com/office/drawing/2014/main" id="{E1DEBF0C-B08E-437D-9FC0-95004ABC6D6A}"/>
+                <a16:creationId xmlns:a16="http://schemas.microsoft.com/office/drawing/2014/main" id="{B78908A6-0C3F-4E1A-A033-E2776250FF5E}"/>
               </a:ext>
             </a:extLst>
           </p:cNvPr>
@@ -3453,7 +3454,7 @@
           <p:cNvPr id="24" name="">
             <a:extLst xmlns:a="http://schemas.openxmlformats.org/drawingml/2006/main">
               <a:ext uri="{FF2B5EF4-FFF2-40B4-BE49-F238E27FC236}">
-                <a16:creationId xmlns:a16="http://schemas.microsoft.com/office/drawing/2014/main" id="{2FEDD4B9-A60F-4B0D-B0E3-4655E9CB2506}"/>
+                <a16:creationId xmlns:a16="http://schemas.microsoft.com/office/drawing/2014/main" id="{49EDCB6B-1A02-4790-AE33-F719FEDA054E}"/>
               </a:ext>
             </a:extLst>
           </p:cNvPr>
@@ -3540,7 +3541,7 @@
           <p:cNvPr id="25" name="">
             <a:extLst xmlns:a="http://schemas.openxmlformats.org/drawingml/2006/main">
               <a:ext uri="{FF2B5EF4-FFF2-40B4-BE49-F238E27FC236}">
-                <a16:creationId xmlns:a16="http://schemas.microsoft.com/office/drawing/2014/main" id="{2D322983-A630-4BC1-9ACD-848E4685542F}"/>
+                <a16:creationId xmlns:a16="http://schemas.microsoft.com/office/drawing/2014/main" id="{4AFAB65B-FABF-428C-86D8-77C9EAABA63E}"/>
               </a:ext>
             </a:extLst>
           </p:cNvPr>
@@ -3575,7 +3576,7 @@
           <p:cNvPr id="26" name="">
             <a:extLst xmlns:a="http://schemas.openxmlformats.org/drawingml/2006/main">
               <a:ext uri="{FF2B5EF4-FFF2-40B4-BE49-F238E27FC236}">
-                <a16:creationId xmlns:a16="http://schemas.microsoft.com/office/drawing/2014/main" id="{4204AC96-F685-4E6D-8C5C-D6DB9753CC34}"/>
+                <a16:creationId xmlns:a16="http://schemas.microsoft.com/office/drawing/2014/main" id="{5C52724F-A72F-467A-8048-1E87EA728C15}"/>
               </a:ext>
             </a:extLst>
           </p:cNvPr>
@@ -3637,7 +3638,7 @@
     </p:spTree>
     <p:extLst>
       <p:ext uri="{BB962C8B-B14F-4D97-AF65-F5344CB8AC3E}">
-        <p14:creationId xmlns:p14="http://schemas.microsoft.com/office/powerpoint/2010/main" val="716766767"/>
+        <p14:creationId xmlns:p14="http://schemas.microsoft.com/office/powerpoint/2010/main" val="55718997"/>
       </p:ext>
     </p:extLst>
   </p:cSld>
@@ -3661,7 +3662,7 @@
           <p:cNvPr id="1" name="">
             <a:extLst xmlns:a="http://schemas.openxmlformats.org/drawingml/2006/main">
               <a:ext uri="{FF2B5EF4-FFF2-40B4-BE49-F238E27FC236}">
-                <a16:creationId xmlns:a16="http://schemas.microsoft.com/office/drawing/2014/main" id="{AAC8A639-C47F-4AA1-92C7-5DAFE3DE16F7}"/>
+                <a16:creationId xmlns:a16="http://schemas.microsoft.com/office/drawing/2014/main" id="{94915A1B-30FE-4B96-9740-4CC6C767C647}"/>
               </a:ext>
             </a:extLst>
           </p:cNvPr>
@@ -3696,7 +3697,7 @@
           <p:cNvPr id="2" name="kicker-marker">
             <a:extLst xmlns:a="http://schemas.openxmlformats.org/drawingml/2006/main">
               <a:ext uri="{FF2B5EF4-FFF2-40B4-BE49-F238E27FC236}">
-                <a16:creationId xmlns:a16="http://schemas.microsoft.com/office/drawing/2014/main" id="{B7D5556F-2795-4684-97A2-EEB64685B8D4}"/>
+                <a16:creationId xmlns:a16="http://schemas.microsoft.com/office/drawing/2014/main" id="{3BD3005B-A87D-4628-8C7B-1F02D2F62C9C}"/>
               </a:ext>
             </a:extLst>
           </p:cNvPr>
@@ -3731,7 +3732,7 @@
           <p:cNvPr id="3" name="kicker-label">
             <a:extLst xmlns:a="http://schemas.openxmlformats.org/drawingml/2006/main">
               <a:ext uri="{FF2B5EF4-FFF2-40B4-BE49-F238E27FC236}">
-                <a16:creationId xmlns:a16="http://schemas.microsoft.com/office/drawing/2014/main" id="{BC2736FB-FEAE-43C0-A4C0-61FD6734B92B}"/>
+                <a16:creationId xmlns:a16="http://schemas.microsoft.com/office/drawing/2014/main" id="{05A049CB-9C33-4C52-A937-E3A75676D886}"/>
               </a:ext>
             </a:extLst>
           </p:cNvPr>
@@ -3795,7 +3796,7 @@
           <p:cNvPr id="4" name="">
             <a:extLst xmlns:a="http://schemas.openxmlformats.org/drawingml/2006/main">
               <a:ext uri="{FF2B5EF4-FFF2-40B4-BE49-F238E27FC236}">
-                <a16:creationId xmlns:a16="http://schemas.microsoft.com/office/drawing/2014/main" id="{1E928784-6792-429F-A9CD-C8A6AEAF81BA}"/>
+                <a16:creationId xmlns:a16="http://schemas.microsoft.com/office/drawing/2014/main" id="{CBD1475C-B99B-4729-97FE-11E885C9EBED}"/>
               </a:ext>
             </a:extLst>
           </p:cNvPr>
@@ -3859,7 +3860,7 @@
           <p:cNvPr id="5" name="">
             <a:extLst xmlns:a="http://schemas.openxmlformats.org/drawingml/2006/main">
               <a:ext uri="{FF2B5EF4-FFF2-40B4-BE49-F238E27FC236}">
-                <a16:creationId xmlns:a16="http://schemas.microsoft.com/office/drawing/2014/main" id="{EE4FF20A-28B8-4DBA-BDF4-0E681D57DFD7}"/>
+                <a16:creationId xmlns:a16="http://schemas.microsoft.com/office/drawing/2014/main" id="{63A48E5F-72B8-4C8D-B7A7-A66E404E1253}"/>
               </a:ext>
             </a:extLst>
           </p:cNvPr>
@@ -3894,7 +3895,7 @@
           <p:cNvPr id="6" name="">
             <a:extLst xmlns:a="http://schemas.openxmlformats.org/drawingml/2006/main">
               <a:ext uri="{FF2B5EF4-FFF2-40B4-BE49-F238E27FC236}">
-                <a16:creationId xmlns:a16="http://schemas.microsoft.com/office/drawing/2014/main" id="{5FE2F976-B612-4BCF-9A22-F62569B68339}"/>
+                <a16:creationId xmlns:a16="http://schemas.microsoft.com/office/drawing/2014/main" id="{8E204E9F-E3E4-4081-AF53-95832CCEF8BF}"/>
               </a:ext>
             </a:extLst>
           </p:cNvPr>
@@ -3958,7 +3959,7 @@
           <p:cNvPr id="7" name="">
             <a:extLst xmlns:a="http://schemas.openxmlformats.org/drawingml/2006/main">
               <a:ext uri="{FF2B5EF4-FFF2-40B4-BE49-F238E27FC236}">
-                <a16:creationId xmlns:a16="http://schemas.microsoft.com/office/drawing/2014/main" id="{FA3CDC97-CA05-4AFB-ADDF-EC72DFE03321}"/>
+                <a16:creationId xmlns:a16="http://schemas.microsoft.com/office/drawing/2014/main" id="{69E43565-73E1-485E-BF88-E88B9562311A}"/>
               </a:ext>
             </a:extLst>
           </p:cNvPr>
@@ -3991,7 +3992,7 @@
           <p:cNvPr id="8" name="">
             <a:extLst xmlns:a="http://schemas.openxmlformats.org/drawingml/2006/main">
               <a:ext uri="{FF2B5EF4-FFF2-40B4-BE49-F238E27FC236}">
-                <a16:creationId xmlns:a16="http://schemas.microsoft.com/office/drawing/2014/main" id="{83E675DF-DC2B-4277-8E6D-359848C58AD0}"/>
+                <a16:creationId xmlns:a16="http://schemas.microsoft.com/office/drawing/2014/main" id="{39B552D6-5A90-423F-9F74-35F2D17427F9}"/>
               </a:ext>
             </a:extLst>
           </p:cNvPr>
@@ -4055,7 +4056,7 @@
           <p:cNvPr id="9" name="">
             <a:extLst xmlns:a="http://schemas.openxmlformats.org/drawingml/2006/main">
               <a:ext uri="{FF2B5EF4-FFF2-40B4-BE49-F238E27FC236}">
-                <a16:creationId xmlns:a16="http://schemas.microsoft.com/office/drawing/2014/main" id="{B7807BDC-06A6-4562-ACCF-A78FF65F5470}"/>
+                <a16:creationId xmlns:a16="http://schemas.microsoft.com/office/drawing/2014/main" id="{6BE73ECC-CC27-42CF-8344-21FBA89912B9}"/>
               </a:ext>
             </a:extLst>
           </p:cNvPr>
@@ -4119,7 +4120,7 @@
           <p:cNvPr id="10" name="">
             <a:extLst xmlns:a="http://schemas.openxmlformats.org/drawingml/2006/main">
               <a:ext uri="{FF2B5EF4-FFF2-40B4-BE49-F238E27FC236}">
-                <a16:creationId xmlns:a16="http://schemas.microsoft.com/office/drawing/2014/main" id="{87AF300A-E312-47F5-8DE9-6819C17D1A03}"/>
+                <a16:creationId xmlns:a16="http://schemas.microsoft.com/office/drawing/2014/main" id="{3D0CD225-F239-42A2-BDA5-F8E98099C0EC}"/>
               </a:ext>
             </a:extLst>
           </p:cNvPr>
@@ -4183,7 +4184,7 @@
           <p:cNvPr id="11" name="">
             <a:extLst xmlns:a="http://schemas.openxmlformats.org/drawingml/2006/main">
               <a:ext uri="{FF2B5EF4-FFF2-40B4-BE49-F238E27FC236}">
-                <a16:creationId xmlns:a16="http://schemas.microsoft.com/office/drawing/2014/main" id="{FE9BC0DD-B5DF-4CE4-B242-AC3572DFCF03}"/>
+                <a16:creationId xmlns:a16="http://schemas.microsoft.com/office/drawing/2014/main" id="{ADA3A42D-6A07-4C04-8256-145FF1ED1EF8}"/>
               </a:ext>
             </a:extLst>
           </p:cNvPr>
@@ -4218,7 +4219,7 @@
           <p:cNvPr id="12" name="">
             <a:extLst xmlns:a="http://schemas.openxmlformats.org/drawingml/2006/main">
               <a:ext uri="{FF2B5EF4-FFF2-40B4-BE49-F238E27FC236}">
-                <a16:creationId xmlns:a16="http://schemas.microsoft.com/office/drawing/2014/main" id="{02F5D548-F6E5-4A4A-BB1F-69220667CEAE}"/>
+                <a16:creationId xmlns:a16="http://schemas.microsoft.com/office/drawing/2014/main" id="{830A27C2-0FEA-4271-86D7-39E31B3174BC}"/>
               </a:ext>
             </a:extLst>
           </p:cNvPr>
@@ -4253,7 +4254,7 @@
           <p:cNvPr id="13" name="">
             <a:extLst xmlns:a="http://schemas.openxmlformats.org/drawingml/2006/main">
               <a:ext uri="{FF2B5EF4-FFF2-40B4-BE49-F238E27FC236}">
-                <a16:creationId xmlns:a16="http://schemas.microsoft.com/office/drawing/2014/main" id="{4946F63B-6244-43E9-9695-2EEC063AFF33}"/>
+                <a16:creationId xmlns:a16="http://schemas.microsoft.com/office/drawing/2014/main" id="{D4E5C55E-28F9-4CA4-9D54-E9FD7749112E}"/>
               </a:ext>
             </a:extLst>
           </p:cNvPr>
@@ -4286,7 +4287,7 @@
           <p:cNvPr id="14" name="">
             <a:extLst xmlns:a="http://schemas.openxmlformats.org/drawingml/2006/main">
               <a:ext uri="{FF2B5EF4-FFF2-40B4-BE49-F238E27FC236}">
-                <a16:creationId xmlns:a16="http://schemas.microsoft.com/office/drawing/2014/main" id="{11049A39-AB8D-4B5E-A74E-94650CD4A43E}"/>
+                <a16:creationId xmlns:a16="http://schemas.microsoft.com/office/drawing/2014/main" id="{E453FDF9-D0A8-4FF7-BF6F-E9BE2E878864}"/>
               </a:ext>
             </a:extLst>
           </p:cNvPr>
@@ -4350,7 +4351,7 @@
           <p:cNvPr id="15" name="">
             <a:extLst xmlns:a="http://schemas.openxmlformats.org/drawingml/2006/main">
               <a:ext uri="{FF2B5EF4-FFF2-40B4-BE49-F238E27FC236}">
-                <a16:creationId xmlns:a16="http://schemas.microsoft.com/office/drawing/2014/main" id="{20E82A60-148E-4FD3-A5BD-423B4258C889}"/>
+                <a16:creationId xmlns:a16="http://schemas.microsoft.com/office/drawing/2014/main" id="{D755C995-CF7C-4059-8744-E87E0C4A384E}"/>
               </a:ext>
             </a:extLst>
           </p:cNvPr>
@@ -4414,7 +4415,7 @@
           <p:cNvPr id="16" name="">
             <a:extLst xmlns:a="http://schemas.openxmlformats.org/drawingml/2006/main">
               <a:ext uri="{FF2B5EF4-FFF2-40B4-BE49-F238E27FC236}">
-                <a16:creationId xmlns:a16="http://schemas.microsoft.com/office/drawing/2014/main" id="{CF4995D9-E6EC-4291-9E5D-134CC5D1810A}"/>
+                <a16:creationId xmlns:a16="http://schemas.microsoft.com/office/drawing/2014/main" id="{E08FB254-B4AC-4C3B-8961-E870E61D3D36}"/>
               </a:ext>
             </a:extLst>
           </p:cNvPr>
@@ -4478,7 +4479,7 @@
           <p:cNvPr id="17" name="">
             <a:extLst xmlns:a="http://schemas.openxmlformats.org/drawingml/2006/main">
               <a:ext uri="{FF2B5EF4-FFF2-40B4-BE49-F238E27FC236}">
-                <a16:creationId xmlns:a16="http://schemas.microsoft.com/office/drawing/2014/main" id="{30B13C90-A99C-4971-A1D9-8BF5DCD1A36E}"/>
+                <a16:creationId xmlns:a16="http://schemas.microsoft.com/office/drawing/2014/main" id="{CE53234A-9CF3-42B0-81A1-6208D74DA919}"/>
               </a:ext>
             </a:extLst>
           </p:cNvPr>
@@ -4513,7 +4514,7 @@
           <p:cNvPr id="18" name="">
             <a:extLst xmlns:a="http://schemas.openxmlformats.org/drawingml/2006/main">
               <a:ext uri="{FF2B5EF4-FFF2-40B4-BE49-F238E27FC236}">
-                <a16:creationId xmlns:a16="http://schemas.microsoft.com/office/drawing/2014/main" id="{74DF194B-2EE1-4032-B125-BB98D2BFF4F0}"/>
+                <a16:creationId xmlns:a16="http://schemas.microsoft.com/office/drawing/2014/main" id="{84593869-9B03-45B1-BFE1-7D55EF019DFA}"/>
               </a:ext>
             </a:extLst>
           </p:cNvPr>
@@ -4548,7 +4549,7 @@
           <p:cNvPr id="19" name="">
             <a:extLst xmlns:a="http://schemas.openxmlformats.org/drawingml/2006/main">
               <a:ext uri="{FF2B5EF4-FFF2-40B4-BE49-F238E27FC236}">
-                <a16:creationId xmlns:a16="http://schemas.microsoft.com/office/drawing/2014/main" id="{B734F563-B1DA-4243-98E1-2E9E934D1A7D}"/>
+                <a16:creationId xmlns:a16="http://schemas.microsoft.com/office/drawing/2014/main" id="{A4E764F3-5405-4FAB-9563-53274058DC5D}"/>
               </a:ext>
             </a:extLst>
           </p:cNvPr>
@@ -4581,7 +4582,7 @@
           <p:cNvPr id="20" name="">
             <a:extLst xmlns:a="http://schemas.openxmlformats.org/drawingml/2006/main">
               <a:ext uri="{FF2B5EF4-FFF2-40B4-BE49-F238E27FC236}">
-                <a16:creationId xmlns:a16="http://schemas.microsoft.com/office/drawing/2014/main" id="{8B5FC658-3DD0-4A05-BE25-9A65F66654F6}"/>
+                <a16:creationId xmlns:a16="http://schemas.microsoft.com/office/drawing/2014/main" id="{841F84AB-0B8C-4735-9919-79FD961DB936}"/>
               </a:ext>
             </a:extLst>
           </p:cNvPr>
@@ -4645,7 +4646,7 @@
           <p:cNvPr id="21" name="">
             <a:extLst xmlns:a="http://schemas.openxmlformats.org/drawingml/2006/main">
               <a:ext uri="{FF2B5EF4-FFF2-40B4-BE49-F238E27FC236}">
-                <a16:creationId xmlns:a16="http://schemas.microsoft.com/office/drawing/2014/main" id="{221A2436-E472-4A9E-B081-6EF32F26092D}"/>
+                <a16:creationId xmlns:a16="http://schemas.microsoft.com/office/drawing/2014/main" id="{754E0184-43A5-449C-A347-13FA6D51EB55}"/>
               </a:ext>
             </a:extLst>
           </p:cNvPr>
@@ -4709,7 +4710,7 @@
           <p:cNvPr id="22" name="">
             <a:extLst xmlns:a="http://schemas.openxmlformats.org/drawingml/2006/main">
               <a:ext uri="{FF2B5EF4-FFF2-40B4-BE49-F238E27FC236}">
-                <a16:creationId xmlns:a16="http://schemas.microsoft.com/office/drawing/2014/main" id="{173ED115-4038-430E-917C-F50C9A5ABB5A}"/>
+                <a16:creationId xmlns:a16="http://schemas.microsoft.com/office/drawing/2014/main" id="{F2EDB626-00D1-4F61-937D-3A0C54C456C6}"/>
               </a:ext>
             </a:extLst>
           </p:cNvPr>
@@ -4773,7 +4774,7 @@
           <p:cNvPr id="23" name="">
             <a:extLst xmlns:a="http://schemas.openxmlformats.org/drawingml/2006/main">
               <a:ext uri="{FF2B5EF4-FFF2-40B4-BE49-F238E27FC236}">
-                <a16:creationId xmlns:a16="http://schemas.microsoft.com/office/drawing/2014/main" id="{595D4EF7-2BBE-4AA8-9DB3-1CFD203F63D5}"/>
+                <a16:creationId xmlns:a16="http://schemas.microsoft.com/office/drawing/2014/main" id="{B2D6585A-7E26-408E-8CFE-0F6E0E23C150}"/>
               </a:ext>
             </a:extLst>
           </p:cNvPr>
@@ -4808,7 +4809,7 @@
           <p:cNvPr id="24" name="">
             <a:extLst xmlns:a="http://schemas.openxmlformats.org/drawingml/2006/main">
               <a:ext uri="{FF2B5EF4-FFF2-40B4-BE49-F238E27FC236}">
-                <a16:creationId xmlns:a16="http://schemas.microsoft.com/office/drawing/2014/main" id="{8FA17389-9A2A-49D7-8882-0E52B418F924}"/>
+                <a16:creationId xmlns:a16="http://schemas.microsoft.com/office/drawing/2014/main" id="{4415ECAA-7EDB-4D5B-84FD-CCF8B7FB6817}"/>
               </a:ext>
             </a:extLst>
           </p:cNvPr>
@@ -4843,7 +4844,7 @@
           <p:cNvPr id="25" name="">
             <a:extLst xmlns:a="http://schemas.openxmlformats.org/drawingml/2006/main">
               <a:ext uri="{FF2B5EF4-FFF2-40B4-BE49-F238E27FC236}">
-                <a16:creationId xmlns:a16="http://schemas.microsoft.com/office/drawing/2014/main" id="{931EED2E-FDFB-47DA-ABA2-533167BB8BC4}"/>
+                <a16:creationId xmlns:a16="http://schemas.microsoft.com/office/drawing/2014/main" id="{FE88E21C-7152-491D-ADC3-B78DF56552E9}"/>
               </a:ext>
             </a:extLst>
           </p:cNvPr>
@@ -4876,7 +4877,7 @@
           <p:cNvPr id="26" name="">
             <a:extLst xmlns:a="http://schemas.openxmlformats.org/drawingml/2006/main">
               <a:ext uri="{FF2B5EF4-FFF2-40B4-BE49-F238E27FC236}">
-                <a16:creationId xmlns:a16="http://schemas.microsoft.com/office/drawing/2014/main" id="{796EE8D2-D17F-422A-8ED2-CE371BD5C49D}"/>
+                <a16:creationId xmlns:a16="http://schemas.microsoft.com/office/drawing/2014/main" id="{D9A6BAE7-DE3F-4B8E-94EB-388E7D3C47DB}"/>
               </a:ext>
             </a:extLst>
           </p:cNvPr>
@@ -4940,7 +4941,7 @@
           <p:cNvPr id="27" name="">
             <a:extLst xmlns:a="http://schemas.openxmlformats.org/drawingml/2006/main">
               <a:ext uri="{FF2B5EF4-FFF2-40B4-BE49-F238E27FC236}">
-                <a16:creationId xmlns:a16="http://schemas.microsoft.com/office/drawing/2014/main" id="{047B7CD5-5FB2-4A0E-8C04-0C025CD394AD}"/>
+                <a16:creationId xmlns:a16="http://schemas.microsoft.com/office/drawing/2014/main" id="{DCA4DEC9-18D2-4726-84FC-E5CF0B06F801}"/>
               </a:ext>
             </a:extLst>
           </p:cNvPr>
@@ -5004,7 +5005,7 @@
           <p:cNvPr id="28" name="">
             <a:extLst xmlns:a="http://schemas.openxmlformats.org/drawingml/2006/main">
               <a:ext uri="{FF2B5EF4-FFF2-40B4-BE49-F238E27FC236}">
-                <a16:creationId xmlns:a16="http://schemas.microsoft.com/office/drawing/2014/main" id="{F655F9B2-C914-4F74-9EB5-55135D9F876C}"/>
+                <a16:creationId xmlns:a16="http://schemas.microsoft.com/office/drawing/2014/main" id="{5DAC62F0-30E1-4FCB-A8A2-3D49D42B58C5}"/>
               </a:ext>
             </a:extLst>
           </p:cNvPr>
@@ -5068,7 +5069,7 @@
           <p:cNvPr id="29" name="">
             <a:extLst xmlns:a="http://schemas.openxmlformats.org/drawingml/2006/main">
               <a:ext uri="{FF2B5EF4-FFF2-40B4-BE49-F238E27FC236}">
-                <a16:creationId xmlns:a16="http://schemas.microsoft.com/office/drawing/2014/main" id="{4B1D1BC7-3E1D-4506-AA2B-C2E6C494E0F6}"/>
+                <a16:creationId xmlns:a16="http://schemas.microsoft.com/office/drawing/2014/main" id="{B5591A7E-84DF-4C79-913E-AE00763937EA}"/>
               </a:ext>
             </a:extLst>
           </p:cNvPr>
@@ -5130,7 +5131,7 @@
     </p:spTree>
     <p:extLst>
       <p:ext uri="{BB962C8B-B14F-4D97-AF65-F5344CB8AC3E}">
-        <p14:creationId xmlns:p14="http://schemas.microsoft.com/office/powerpoint/2010/main" val="496892922"/>
+        <p14:creationId xmlns:p14="http://schemas.microsoft.com/office/powerpoint/2010/main" val="748237965"/>
       </p:ext>
     </p:extLst>
   </p:cSld>
@@ -5154,7 +5155,7 @@
           <p:cNvPr id="1" name="">
             <a:extLst xmlns:a="http://schemas.openxmlformats.org/drawingml/2006/main">
               <a:ext uri="{FF2B5EF4-FFF2-40B4-BE49-F238E27FC236}">
-                <a16:creationId xmlns:a16="http://schemas.microsoft.com/office/drawing/2014/main" id="{925E2C24-7634-4822-8431-DB247B28EE97}"/>
+                <a16:creationId xmlns:a16="http://schemas.microsoft.com/office/drawing/2014/main" id="{FFDC7DA2-D411-44B9-916F-FBD1D828CA8D}"/>
               </a:ext>
             </a:extLst>
           </p:cNvPr>
@@ -5189,7 +5190,7 @@
           <p:cNvPr id="2" name="kicker-marker">
             <a:extLst xmlns:a="http://schemas.openxmlformats.org/drawingml/2006/main">
               <a:ext uri="{FF2B5EF4-FFF2-40B4-BE49-F238E27FC236}">
-                <a16:creationId xmlns:a16="http://schemas.microsoft.com/office/drawing/2014/main" id="{695B4013-6351-4507-88B2-9D557DF50C7C}"/>
+                <a16:creationId xmlns:a16="http://schemas.microsoft.com/office/drawing/2014/main" id="{48A4F569-6BAE-4D4D-AD26-6351D7D6C284}"/>
               </a:ext>
             </a:extLst>
           </p:cNvPr>
@@ -5224,7 +5225,7 @@
           <p:cNvPr id="3" name="kicker-label">
             <a:extLst xmlns:a="http://schemas.openxmlformats.org/drawingml/2006/main">
               <a:ext uri="{FF2B5EF4-FFF2-40B4-BE49-F238E27FC236}">
-                <a16:creationId xmlns:a16="http://schemas.microsoft.com/office/drawing/2014/main" id="{BA6EE0B5-E05D-46B3-B024-2E94594A3F78}"/>
+                <a16:creationId xmlns:a16="http://schemas.microsoft.com/office/drawing/2014/main" id="{0FD3262F-8E11-4967-87C3-876A64EC7E8A}"/>
               </a:ext>
             </a:extLst>
           </p:cNvPr>
@@ -5288,7 +5289,7 @@
           <p:cNvPr id="4" name="">
             <a:extLst xmlns:a="http://schemas.openxmlformats.org/drawingml/2006/main">
               <a:ext uri="{FF2B5EF4-FFF2-40B4-BE49-F238E27FC236}">
-                <a16:creationId xmlns:a16="http://schemas.microsoft.com/office/drawing/2014/main" id="{7161028A-5ADD-4E47-B768-51FCC8FE8547}"/>
+                <a16:creationId xmlns:a16="http://schemas.microsoft.com/office/drawing/2014/main" id="{AD9F5D97-9E81-4DEA-A233-7FAD48E719CA}"/>
               </a:ext>
             </a:extLst>
           </p:cNvPr>
@@ -5352,7 +5353,7 @@
           <p:cNvPr id="5" name="">
             <a:extLst xmlns:a="http://schemas.openxmlformats.org/drawingml/2006/main">
               <a:ext uri="{FF2B5EF4-FFF2-40B4-BE49-F238E27FC236}">
-                <a16:creationId xmlns:a16="http://schemas.microsoft.com/office/drawing/2014/main" id="{EA2D458D-5655-4B6E-9AF2-973754202734}"/>
+                <a16:creationId xmlns:a16="http://schemas.microsoft.com/office/drawing/2014/main" id="{D654C9CF-0982-4DBB-A0CD-0EA44482E059}"/>
               </a:ext>
             </a:extLst>
           </p:cNvPr>
@@ -5387,7 +5388,7 @@
           <p:cNvPr id="6" name="">
             <a:extLst xmlns:a="http://schemas.openxmlformats.org/drawingml/2006/main">
               <a:ext uri="{FF2B5EF4-FFF2-40B4-BE49-F238E27FC236}">
-                <a16:creationId xmlns:a16="http://schemas.microsoft.com/office/drawing/2014/main" id="{3ED80C30-BDAE-43B8-9F9B-16CADE8F1ADE}"/>
+                <a16:creationId xmlns:a16="http://schemas.microsoft.com/office/drawing/2014/main" id="{B6F1D055-4A33-4354-8BC4-C61BDD1D47B0}"/>
               </a:ext>
             </a:extLst>
           </p:cNvPr>
@@ -5451,7 +5452,7 @@
           <p:cNvPr id="7" name="">
             <a:extLst xmlns:a="http://schemas.openxmlformats.org/drawingml/2006/main">
               <a:ext uri="{FF2B5EF4-FFF2-40B4-BE49-F238E27FC236}">
-                <a16:creationId xmlns:a16="http://schemas.microsoft.com/office/drawing/2014/main" id="{88F62E6E-3B3E-45B7-BA4C-8CF45A2DCD46}"/>
+                <a16:creationId xmlns:a16="http://schemas.microsoft.com/office/drawing/2014/main" id="{862F63BF-C9D0-434E-891F-6C4B65895459}"/>
               </a:ext>
             </a:extLst>
           </p:cNvPr>
@@ -5515,7 +5516,7 @@
           <p:cNvPr id="8" name="">
             <a:extLst xmlns:a="http://schemas.openxmlformats.org/drawingml/2006/main">
               <a:ext uri="{FF2B5EF4-FFF2-40B4-BE49-F238E27FC236}">
-                <a16:creationId xmlns:a16="http://schemas.microsoft.com/office/drawing/2014/main" id="{73B8B76D-ABFA-458D-A61B-73B2EA472F47}"/>
+                <a16:creationId xmlns:a16="http://schemas.microsoft.com/office/drawing/2014/main" id="{C39B6A33-BF79-4560-B780-477A6CBF01BE}"/>
               </a:ext>
             </a:extLst>
           </p:cNvPr>
@@ -5579,7 +5580,7 @@
           <p:cNvPr id="9" name="">
             <a:extLst xmlns:a="http://schemas.openxmlformats.org/drawingml/2006/main">
               <a:ext uri="{FF2B5EF4-FFF2-40B4-BE49-F238E27FC236}">
-                <a16:creationId xmlns:a16="http://schemas.microsoft.com/office/drawing/2014/main" id="{C75DC2CA-C56B-4CAB-A99A-AF32C2E939A2}"/>
+                <a16:creationId xmlns:a16="http://schemas.microsoft.com/office/drawing/2014/main" id="{6B3F58B4-96D1-4F3D-80FD-6E09EC33C143}"/>
               </a:ext>
             </a:extLst>
           </p:cNvPr>
@@ -5614,7 +5615,7 @@
           <p:cNvPr id="10" name="">
             <a:extLst xmlns:a="http://schemas.openxmlformats.org/drawingml/2006/main">
               <a:ext uri="{FF2B5EF4-FFF2-40B4-BE49-F238E27FC236}">
-                <a16:creationId xmlns:a16="http://schemas.microsoft.com/office/drawing/2014/main" id="{7961E182-C1C0-4AD8-B937-BE66B731D4BD}"/>
+                <a16:creationId xmlns:a16="http://schemas.microsoft.com/office/drawing/2014/main" id="{E411156E-763D-4595-AC25-F04D6A4B0501}"/>
               </a:ext>
             </a:extLst>
           </p:cNvPr>
@@ -5649,7 +5650,7 @@
           <p:cNvPr id="11" name="">
             <a:extLst xmlns:a="http://schemas.openxmlformats.org/drawingml/2006/main">
               <a:ext uri="{FF2B5EF4-FFF2-40B4-BE49-F238E27FC236}">
-                <a16:creationId xmlns:a16="http://schemas.microsoft.com/office/drawing/2014/main" id="{5114AA5C-8206-41FD-9E40-A0805872FABD}"/>
+                <a16:creationId xmlns:a16="http://schemas.microsoft.com/office/drawing/2014/main" id="{DF68FAF8-5886-481C-B5A3-687B65B28763}"/>
               </a:ext>
             </a:extLst>
           </p:cNvPr>
@@ -5713,7 +5714,7 @@
           <p:cNvPr id="12" name="">
             <a:extLst xmlns:a="http://schemas.openxmlformats.org/drawingml/2006/main">
               <a:ext uri="{FF2B5EF4-FFF2-40B4-BE49-F238E27FC236}">
-                <a16:creationId xmlns:a16="http://schemas.microsoft.com/office/drawing/2014/main" id="{E742F248-859D-4BE9-8BA8-4C3331EFF791}"/>
+                <a16:creationId xmlns:a16="http://schemas.microsoft.com/office/drawing/2014/main" id="{5B8587C2-F431-47D6-A84C-3690A0B0438E}"/>
               </a:ext>
             </a:extLst>
           </p:cNvPr>
@@ -5777,7 +5778,7 @@
           <p:cNvPr id="13" name="">
             <a:extLst xmlns:a="http://schemas.openxmlformats.org/drawingml/2006/main">
               <a:ext uri="{FF2B5EF4-FFF2-40B4-BE49-F238E27FC236}">
-                <a16:creationId xmlns:a16="http://schemas.microsoft.com/office/drawing/2014/main" id="{1D4B357D-D5BA-4BC6-88DC-C756C6BF5C32}"/>
+                <a16:creationId xmlns:a16="http://schemas.microsoft.com/office/drawing/2014/main" id="{12A306FD-51B6-4DBD-9DDE-8C76B71C6646}"/>
               </a:ext>
             </a:extLst>
           </p:cNvPr>
@@ -5812,7 +5813,7 @@
           <p:cNvPr id="14" name="">
             <a:extLst xmlns:a="http://schemas.openxmlformats.org/drawingml/2006/main">
               <a:ext uri="{FF2B5EF4-FFF2-40B4-BE49-F238E27FC236}">
-                <a16:creationId xmlns:a16="http://schemas.microsoft.com/office/drawing/2014/main" id="{7DD1888E-A4B0-4AB4-8ECD-F1797936F103}"/>
+                <a16:creationId xmlns:a16="http://schemas.microsoft.com/office/drawing/2014/main" id="{BE5D1B1D-7ACD-4050-88C9-768431CFEF6E}"/>
               </a:ext>
             </a:extLst>
           </p:cNvPr>
@@ -5847,7 +5848,7 @@
           <p:cNvPr id="15" name="">
             <a:extLst xmlns:a="http://schemas.openxmlformats.org/drawingml/2006/main">
               <a:ext uri="{FF2B5EF4-FFF2-40B4-BE49-F238E27FC236}">
-                <a16:creationId xmlns:a16="http://schemas.microsoft.com/office/drawing/2014/main" id="{795A913C-C6DF-49B1-94E1-25C3945FBD92}"/>
+                <a16:creationId xmlns:a16="http://schemas.microsoft.com/office/drawing/2014/main" id="{4658C2F3-5546-4424-937D-7309C40E296D}"/>
               </a:ext>
             </a:extLst>
           </p:cNvPr>
@@ -5911,7 +5912,7 @@
           <p:cNvPr id="16" name="">
             <a:extLst xmlns:a="http://schemas.openxmlformats.org/drawingml/2006/main">
               <a:ext uri="{FF2B5EF4-FFF2-40B4-BE49-F238E27FC236}">
-                <a16:creationId xmlns:a16="http://schemas.microsoft.com/office/drawing/2014/main" id="{1E00EF3E-B2CF-4CCE-86A2-42E8282DECF6}"/>
+                <a16:creationId xmlns:a16="http://schemas.microsoft.com/office/drawing/2014/main" id="{84374AD6-A5CD-4FA5-9BA3-A54D48C9EDB9}"/>
               </a:ext>
             </a:extLst>
           </p:cNvPr>
@@ -5946,7 +5947,7 @@
           <p:cNvPr id="17" name="">
             <a:extLst xmlns:a="http://schemas.openxmlformats.org/drawingml/2006/main">
               <a:ext uri="{FF2B5EF4-FFF2-40B4-BE49-F238E27FC236}">
-                <a16:creationId xmlns:a16="http://schemas.microsoft.com/office/drawing/2014/main" id="{65DE05C3-3828-4367-BEC7-9395A7727869}"/>
+                <a16:creationId xmlns:a16="http://schemas.microsoft.com/office/drawing/2014/main" id="{313C44E2-6CD7-4B76-89D4-7843B15F564B}"/>
               </a:ext>
             </a:extLst>
           </p:cNvPr>
@@ -6010,7 +6011,7 @@
           <p:cNvPr id="18" name="">
             <a:extLst xmlns:a="http://schemas.openxmlformats.org/drawingml/2006/main">
               <a:ext uri="{FF2B5EF4-FFF2-40B4-BE49-F238E27FC236}">
-                <a16:creationId xmlns:a16="http://schemas.microsoft.com/office/drawing/2014/main" id="{9ECDB89E-1009-4180-B914-94EF361A0DA8}"/>
+                <a16:creationId xmlns:a16="http://schemas.microsoft.com/office/drawing/2014/main" id="{A3B4B657-A4BC-4366-864A-FA03B9B27EE0}"/>
               </a:ext>
             </a:extLst>
           </p:cNvPr>
@@ -6045,7 +6046,7 @@
           <p:cNvPr id="19" name="">
             <a:extLst xmlns:a="http://schemas.openxmlformats.org/drawingml/2006/main">
               <a:ext uri="{FF2B5EF4-FFF2-40B4-BE49-F238E27FC236}">
-                <a16:creationId xmlns:a16="http://schemas.microsoft.com/office/drawing/2014/main" id="{BCDE9228-A36A-4FD3-A89A-3E6C37239771}"/>
+                <a16:creationId xmlns:a16="http://schemas.microsoft.com/office/drawing/2014/main" id="{A80C2529-FF02-4AA7-9EB6-AC34A27DCB92}"/>
               </a:ext>
             </a:extLst>
           </p:cNvPr>
@@ -6109,7 +6110,7 @@
           <p:cNvPr id="20" name="">
             <a:extLst xmlns:a="http://schemas.openxmlformats.org/drawingml/2006/main">
               <a:ext uri="{FF2B5EF4-FFF2-40B4-BE49-F238E27FC236}">
-                <a16:creationId xmlns:a16="http://schemas.microsoft.com/office/drawing/2014/main" id="{9A76208B-F4AD-4C59-8F47-27F7E80F6992}"/>
+                <a16:creationId xmlns:a16="http://schemas.microsoft.com/office/drawing/2014/main" id="{D98ABA01-6DDD-4B21-99AD-6059F518A22F}"/>
               </a:ext>
             </a:extLst>
           </p:cNvPr>
@@ -6144,7 +6145,7 @@
           <p:cNvPr id="21" name="">
             <a:extLst xmlns:a="http://schemas.openxmlformats.org/drawingml/2006/main">
               <a:ext uri="{FF2B5EF4-FFF2-40B4-BE49-F238E27FC236}">
-                <a16:creationId xmlns:a16="http://schemas.microsoft.com/office/drawing/2014/main" id="{F1941672-7E32-4A4C-A5AF-6BA774CACFC0}"/>
+                <a16:creationId xmlns:a16="http://schemas.microsoft.com/office/drawing/2014/main" id="{925286AB-4A53-40E7-AA80-EEE738B5A5F3}"/>
               </a:ext>
             </a:extLst>
           </p:cNvPr>
@@ -6208,7 +6209,7 @@
           <p:cNvPr id="22" name="">
             <a:extLst xmlns:a="http://schemas.openxmlformats.org/drawingml/2006/main">
               <a:ext uri="{FF2B5EF4-FFF2-40B4-BE49-F238E27FC236}">
-                <a16:creationId xmlns:a16="http://schemas.microsoft.com/office/drawing/2014/main" id="{557BDFCF-813B-4C7D-939A-D640315C38B5}"/>
+                <a16:creationId xmlns:a16="http://schemas.microsoft.com/office/drawing/2014/main" id="{E47F8460-C050-4374-A02A-4F62E969C628}"/>
               </a:ext>
             </a:extLst>
           </p:cNvPr>
@@ -6243,7 +6244,7 @@
           <p:cNvPr id="23" name="">
             <a:extLst xmlns:a="http://schemas.openxmlformats.org/drawingml/2006/main">
               <a:ext uri="{FF2B5EF4-FFF2-40B4-BE49-F238E27FC236}">
-                <a16:creationId xmlns:a16="http://schemas.microsoft.com/office/drawing/2014/main" id="{1E39090C-C2FC-4EC5-BF95-362CE097433E}"/>
+                <a16:creationId xmlns:a16="http://schemas.microsoft.com/office/drawing/2014/main" id="{0CDE7962-010F-43CC-9C33-2756630B8C47}"/>
               </a:ext>
             </a:extLst>
           </p:cNvPr>
@@ -6307,7 +6308,7 @@
           <p:cNvPr id="24" name="">
             <a:extLst xmlns:a="http://schemas.openxmlformats.org/drawingml/2006/main">
               <a:ext uri="{FF2B5EF4-FFF2-40B4-BE49-F238E27FC236}">
-                <a16:creationId xmlns:a16="http://schemas.microsoft.com/office/drawing/2014/main" id="{89CEC1C4-C424-4026-986B-8EFE0AB8FE07}"/>
+                <a16:creationId xmlns:a16="http://schemas.microsoft.com/office/drawing/2014/main" id="{38912602-77E8-42C2-8D9B-BEA1CEBF3F4F}"/>
               </a:ext>
             </a:extLst>
           </p:cNvPr>
@@ -6342,7 +6343,7 @@
           <p:cNvPr id="25" name="">
             <a:extLst xmlns:a="http://schemas.openxmlformats.org/drawingml/2006/main">
               <a:ext uri="{FF2B5EF4-FFF2-40B4-BE49-F238E27FC236}">
-                <a16:creationId xmlns:a16="http://schemas.microsoft.com/office/drawing/2014/main" id="{A9E40B8E-227C-48D2-86F6-1FB2D99294A7}"/>
+                <a16:creationId xmlns:a16="http://schemas.microsoft.com/office/drawing/2014/main" id="{36328908-FB98-4380-BB99-AFC1E374911E}"/>
               </a:ext>
             </a:extLst>
           </p:cNvPr>
@@ -6406,7 +6407,7 @@
           <p:cNvPr id="26" name="">
             <a:extLst xmlns:a="http://schemas.openxmlformats.org/drawingml/2006/main">
               <a:ext uri="{FF2B5EF4-FFF2-40B4-BE49-F238E27FC236}">
-                <a16:creationId xmlns:a16="http://schemas.microsoft.com/office/drawing/2014/main" id="{354976E0-AE80-4C1B-AA88-1211506500C4}"/>
+                <a16:creationId xmlns:a16="http://schemas.microsoft.com/office/drawing/2014/main" id="{0DF1E553-B28B-41B5-85FF-24E9FC6D62C8}"/>
               </a:ext>
             </a:extLst>
           </p:cNvPr>
@@ -6491,7 +6492,7 @@
     </p:spTree>
     <p:extLst>
       <p:ext uri="{BB962C8B-B14F-4D97-AF65-F5344CB8AC3E}">
-        <p14:creationId xmlns:p14="http://schemas.microsoft.com/office/powerpoint/2010/main" val="1729825183"/>
+        <p14:creationId xmlns:p14="http://schemas.microsoft.com/office/powerpoint/2010/main" val="190482761"/>
       </p:ext>
     </p:extLst>
   </p:cSld>
@@ -6515,7 +6516,7 @@
           <p:cNvPr id="1" name="">
             <a:extLst xmlns:a="http://schemas.openxmlformats.org/drawingml/2006/main">
               <a:ext uri="{FF2B5EF4-FFF2-40B4-BE49-F238E27FC236}">
-                <a16:creationId xmlns:a16="http://schemas.microsoft.com/office/drawing/2014/main" id="{6FAAC5DA-9F95-4005-B6AF-0D8A1A3AB806}"/>
+                <a16:creationId xmlns:a16="http://schemas.microsoft.com/office/drawing/2014/main" id="{E28EA699-2945-4C5B-85E4-30BDF29F5C2D}"/>
               </a:ext>
             </a:extLst>
           </p:cNvPr>
@@ -6550,7 +6551,7 @@
           <p:cNvPr id="2" name="kicker-marker">
             <a:extLst xmlns:a="http://schemas.openxmlformats.org/drawingml/2006/main">
               <a:ext uri="{FF2B5EF4-FFF2-40B4-BE49-F238E27FC236}">
-                <a16:creationId xmlns:a16="http://schemas.microsoft.com/office/drawing/2014/main" id="{551D6422-6062-4F61-8EC0-D4B113069B1D}"/>
+                <a16:creationId xmlns:a16="http://schemas.microsoft.com/office/drawing/2014/main" id="{7DB8F06D-EC37-4032-B9F0-E5B96710F808}"/>
               </a:ext>
             </a:extLst>
           </p:cNvPr>
@@ -6585,7 +6586,7 @@
           <p:cNvPr id="3" name="kicker-label">
             <a:extLst xmlns:a="http://schemas.openxmlformats.org/drawingml/2006/main">
               <a:ext uri="{FF2B5EF4-FFF2-40B4-BE49-F238E27FC236}">
-                <a16:creationId xmlns:a16="http://schemas.microsoft.com/office/drawing/2014/main" id="{2EF3829A-5BC2-4496-8A01-A1F029A19CD3}"/>
+                <a16:creationId xmlns:a16="http://schemas.microsoft.com/office/drawing/2014/main" id="{1C18417A-FE35-4151-B342-3C291495AFA9}"/>
               </a:ext>
             </a:extLst>
           </p:cNvPr>
@@ -6649,7 +6650,7 @@
           <p:cNvPr id="4" name="">
             <a:extLst xmlns:a="http://schemas.openxmlformats.org/drawingml/2006/main">
               <a:ext uri="{FF2B5EF4-FFF2-40B4-BE49-F238E27FC236}">
-                <a16:creationId xmlns:a16="http://schemas.microsoft.com/office/drawing/2014/main" id="{9E75DC35-A435-4019-94E9-F389E27F7153}"/>
+                <a16:creationId xmlns:a16="http://schemas.microsoft.com/office/drawing/2014/main" id="{9EADD103-72CC-4474-AE65-0CB9459C6A67}"/>
               </a:ext>
             </a:extLst>
           </p:cNvPr>
@@ -6713,7 +6714,7 @@
           <p:cNvPr id="5" name="">
             <a:extLst xmlns:a="http://schemas.openxmlformats.org/drawingml/2006/main">
               <a:ext uri="{FF2B5EF4-FFF2-40B4-BE49-F238E27FC236}">
-                <a16:creationId xmlns:a16="http://schemas.microsoft.com/office/drawing/2014/main" id="{7DCEC67B-7B05-4A3A-A84B-A8C3542D41B9}"/>
+                <a16:creationId xmlns:a16="http://schemas.microsoft.com/office/drawing/2014/main" id="{6C7837F4-9E25-4588-AD51-E73BB3364438}"/>
               </a:ext>
             </a:extLst>
           </p:cNvPr>
@@ -6748,7 +6749,7 @@
           <p:cNvPr id="6" name="">
             <a:extLst xmlns:a="http://schemas.openxmlformats.org/drawingml/2006/main">
               <a:ext uri="{FF2B5EF4-FFF2-40B4-BE49-F238E27FC236}">
-                <a16:creationId xmlns:a16="http://schemas.microsoft.com/office/drawing/2014/main" id="{44765FC3-A0B1-49AC-888A-FC4578680765}"/>
+                <a16:creationId xmlns:a16="http://schemas.microsoft.com/office/drawing/2014/main" id="{38670384-72B2-4E57-BC87-61F7906561BA}"/>
               </a:ext>
             </a:extLst>
           </p:cNvPr>
@@ -6812,7 +6813,7 @@
           <p:cNvPr id="7" name="">
             <a:extLst xmlns:a="http://schemas.openxmlformats.org/drawingml/2006/main">
               <a:ext uri="{FF2B5EF4-FFF2-40B4-BE49-F238E27FC236}">
-                <a16:creationId xmlns:a16="http://schemas.microsoft.com/office/drawing/2014/main" id="{953329A1-298A-4304-878F-6BF304D99283}"/>
+                <a16:creationId xmlns:a16="http://schemas.microsoft.com/office/drawing/2014/main" id="{FEF5B98A-8739-41D6-8DBC-932208A4C296}"/>
               </a:ext>
             </a:extLst>
           </p:cNvPr>
@@ -6847,7 +6848,7 @@
           <p:cNvPr id="8" name="">
             <a:extLst xmlns:a="http://schemas.openxmlformats.org/drawingml/2006/main">
               <a:ext uri="{FF2B5EF4-FFF2-40B4-BE49-F238E27FC236}">
-                <a16:creationId xmlns:a16="http://schemas.microsoft.com/office/drawing/2014/main" id="{A70B58DA-F5C8-4D0F-A638-CE8CFB0491BD}"/>
+                <a16:creationId xmlns:a16="http://schemas.microsoft.com/office/drawing/2014/main" id="{AF4D181E-1EED-4A23-BBB8-51898E7C42B1}"/>
               </a:ext>
             </a:extLst>
           </p:cNvPr>
@@ -6911,7 +6912,7 @@
           <p:cNvPr id="9" name="">
             <a:extLst xmlns:a="http://schemas.openxmlformats.org/drawingml/2006/main">
               <a:ext uri="{FF2B5EF4-FFF2-40B4-BE49-F238E27FC236}">
-                <a16:creationId xmlns:a16="http://schemas.microsoft.com/office/drawing/2014/main" id="{34522232-7ED7-4F02-92BF-5249FC2569F0}"/>
+                <a16:creationId xmlns:a16="http://schemas.microsoft.com/office/drawing/2014/main" id="{34AE6D0C-27D0-4D69-9452-6580B9490382}"/>
               </a:ext>
             </a:extLst>
           </p:cNvPr>
@@ -6975,7 +6976,7 @@
           <p:cNvPr id="10" name="">
             <a:extLst xmlns:a="http://schemas.openxmlformats.org/drawingml/2006/main">
               <a:ext uri="{FF2B5EF4-FFF2-40B4-BE49-F238E27FC236}">
-                <a16:creationId xmlns:a16="http://schemas.microsoft.com/office/drawing/2014/main" id="{899E5E1A-F0CF-4249-A347-520EC2238B0C}"/>
+                <a16:creationId xmlns:a16="http://schemas.microsoft.com/office/drawing/2014/main" id="{0856E066-A2CC-4F4B-8C85-74D72A8E92A8}"/>
               </a:ext>
             </a:extLst>
           </p:cNvPr>
@@ -7039,7 +7040,7 @@
           <p:cNvPr id="11" name="">
             <a:extLst xmlns:a="http://schemas.openxmlformats.org/drawingml/2006/main">
               <a:ext uri="{FF2B5EF4-FFF2-40B4-BE49-F238E27FC236}">
-                <a16:creationId xmlns:a16="http://schemas.microsoft.com/office/drawing/2014/main" id="{2CEDD9C8-D651-4DBF-B9A6-DBA83F65579D}"/>
+                <a16:creationId xmlns:a16="http://schemas.microsoft.com/office/drawing/2014/main" id="{E0B76B2C-F268-4FBA-9798-D3041A8D6ACE}"/>
               </a:ext>
             </a:extLst>
           </p:cNvPr>
@@ -7074,7 +7075,7 @@
           <p:cNvPr id="12" name="">
             <a:extLst xmlns:a="http://schemas.openxmlformats.org/drawingml/2006/main">
               <a:ext uri="{FF2B5EF4-FFF2-40B4-BE49-F238E27FC236}">
-                <a16:creationId xmlns:a16="http://schemas.microsoft.com/office/drawing/2014/main" id="{B972A830-C8BC-49F2-A70D-838CCFFDCE70}"/>
+                <a16:creationId xmlns:a16="http://schemas.microsoft.com/office/drawing/2014/main" id="{B2F42187-AFAE-47E7-AF36-96D22949183C}"/>
               </a:ext>
             </a:extLst>
           </p:cNvPr>
@@ -7138,7 +7139,7 @@
           <p:cNvPr id="13" name="">
             <a:extLst xmlns:a="http://schemas.openxmlformats.org/drawingml/2006/main">
               <a:ext uri="{FF2B5EF4-FFF2-40B4-BE49-F238E27FC236}">
-                <a16:creationId xmlns:a16="http://schemas.microsoft.com/office/drawing/2014/main" id="{49475C8F-409F-420C-B77C-3B7E848EEC5C}"/>
+                <a16:creationId xmlns:a16="http://schemas.microsoft.com/office/drawing/2014/main" id="{433C5768-A8F4-466C-ACC4-AE2547165BC5}"/>
               </a:ext>
             </a:extLst>
           </p:cNvPr>
@@ -7202,7 +7203,7 @@
           <p:cNvPr id="14" name="">
             <a:extLst xmlns:a="http://schemas.openxmlformats.org/drawingml/2006/main">
               <a:ext uri="{FF2B5EF4-FFF2-40B4-BE49-F238E27FC236}">
-                <a16:creationId xmlns:a16="http://schemas.microsoft.com/office/drawing/2014/main" id="{AB9E14EA-8BCC-40F6-A60E-A074166ED06A}"/>
+                <a16:creationId xmlns:a16="http://schemas.microsoft.com/office/drawing/2014/main" id="{9BEED6FE-09ED-4B2D-8216-06DB07FBA63F}"/>
               </a:ext>
             </a:extLst>
           </p:cNvPr>
@@ -7266,7 +7267,7 @@
           <p:cNvPr id="15" name="">
             <a:extLst xmlns:a="http://schemas.openxmlformats.org/drawingml/2006/main">
               <a:ext uri="{FF2B5EF4-FFF2-40B4-BE49-F238E27FC236}">
-                <a16:creationId xmlns:a16="http://schemas.microsoft.com/office/drawing/2014/main" id="{79170962-7DDC-4ED0-A0F0-71C9547B134D}"/>
+                <a16:creationId xmlns:a16="http://schemas.microsoft.com/office/drawing/2014/main" id="{0E7816C6-EE7C-4B84-BBC0-27D01C3B6979}"/>
               </a:ext>
             </a:extLst>
           </p:cNvPr>
@@ -7301,7 +7302,7 @@
           <p:cNvPr id="16" name="">
             <a:extLst xmlns:a="http://schemas.openxmlformats.org/drawingml/2006/main">
               <a:ext uri="{FF2B5EF4-FFF2-40B4-BE49-F238E27FC236}">
-                <a16:creationId xmlns:a16="http://schemas.microsoft.com/office/drawing/2014/main" id="{35340493-E487-4D80-B83A-05C809DF5E31}"/>
+                <a16:creationId xmlns:a16="http://schemas.microsoft.com/office/drawing/2014/main" id="{92992830-9C6A-458D-B872-0142245F54EB}"/>
               </a:ext>
             </a:extLst>
           </p:cNvPr>
@@ -7365,7 +7366,7 @@
           <p:cNvPr id="17" name="">
             <a:extLst xmlns:a="http://schemas.openxmlformats.org/drawingml/2006/main">
               <a:ext uri="{FF2B5EF4-FFF2-40B4-BE49-F238E27FC236}">
-                <a16:creationId xmlns:a16="http://schemas.microsoft.com/office/drawing/2014/main" id="{A02FF3B9-19B4-42EF-BC43-42DE68B92048}"/>
+                <a16:creationId xmlns:a16="http://schemas.microsoft.com/office/drawing/2014/main" id="{9C072AF7-0F61-48ED-96D2-978AAD2798BE}"/>
               </a:ext>
             </a:extLst>
           </p:cNvPr>
@@ -7429,7 +7430,7 @@
           <p:cNvPr id="18" name="">
             <a:extLst xmlns:a="http://schemas.openxmlformats.org/drawingml/2006/main">
               <a:ext uri="{FF2B5EF4-FFF2-40B4-BE49-F238E27FC236}">
-                <a16:creationId xmlns:a16="http://schemas.microsoft.com/office/drawing/2014/main" id="{C2E944F1-8299-4276-8CAD-252B339C8671}"/>
+                <a16:creationId xmlns:a16="http://schemas.microsoft.com/office/drawing/2014/main" id="{7CAD4E2A-5655-4EC5-A6B5-43038FDA6A06}"/>
               </a:ext>
             </a:extLst>
           </p:cNvPr>
@@ -7493,7 +7494,7 @@
           <p:cNvPr id="19" name="">
             <a:extLst xmlns:a="http://schemas.openxmlformats.org/drawingml/2006/main">
               <a:ext uri="{FF2B5EF4-FFF2-40B4-BE49-F238E27FC236}">
-                <a16:creationId xmlns:a16="http://schemas.microsoft.com/office/drawing/2014/main" id="{989D0EE0-0073-44B1-BBD9-509043FBB5F6}"/>
+                <a16:creationId xmlns:a16="http://schemas.microsoft.com/office/drawing/2014/main" id="{D9944574-813E-497A-9038-7F926963FE72}"/>
               </a:ext>
             </a:extLst>
           </p:cNvPr>
@@ -7526,7 +7527,7 @@
           <p:cNvPr id="20" name="">
             <a:extLst xmlns:a="http://schemas.openxmlformats.org/drawingml/2006/main">
               <a:ext uri="{FF2B5EF4-FFF2-40B4-BE49-F238E27FC236}">
-                <a16:creationId xmlns:a16="http://schemas.microsoft.com/office/drawing/2014/main" id="{C955B6BB-7D20-4B4F-8030-C8E65D0FC32C}"/>
+                <a16:creationId xmlns:a16="http://schemas.microsoft.com/office/drawing/2014/main" id="{42662677-6725-4EC2-864E-7E47A0A9C82B}"/>
               </a:ext>
             </a:extLst>
           </p:cNvPr>
@@ -7588,7 +7589,7 @@
     </p:spTree>
     <p:extLst>
       <p:ext uri="{BB962C8B-B14F-4D97-AF65-F5344CB8AC3E}">
-        <p14:creationId xmlns:p14="http://schemas.microsoft.com/office/powerpoint/2010/main" val="621732542"/>
+        <p14:creationId xmlns:p14="http://schemas.microsoft.com/office/powerpoint/2010/main" val="856585001"/>
       </p:ext>
     </p:extLst>
   </p:cSld>
@@ -7612,7 +7613,7 @@
           <p:cNvPr id="1" name="">
             <a:extLst xmlns:a="http://schemas.openxmlformats.org/drawingml/2006/main">
               <a:ext uri="{FF2B5EF4-FFF2-40B4-BE49-F238E27FC236}">
-                <a16:creationId xmlns:a16="http://schemas.microsoft.com/office/drawing/2014/main" id="{BB1C0C99-7B7D-443A-9C8B-218314E87327}"/>
+                <a16:creationId xmlns:a16="http://schemas.microsoft.com/office/drawing/2014/main" id="{5482D01A-E0D7-4A2B-A19A-06143AA83ABC}"/>
               </a:ext>
             </a:extLst>
           </p:cNvPr>
@@ -7647,7 +7648,7 @@
           <p:cNvPr id="2" name="kicker-marker">
             <a:extLst xmlns:a="http://schemas.openxmlformats.org/drawingml/2006/main">
               <a:ext uri="{FF2B5EF4-FFF2-40B4-BE49-F238E27FC236}">
-                <a16:creationId xmlns:a16="http://schemas.microsoft.com/office/drawing/2014/main" id="{83D25DA0-CC1D-4E65-8D27-EFA574B5B408}"/>
+                <a16:creationId xmlns:a16="http://schemas.microsoft.com/office/drawing/2014/main" id="{A04DB903-16F3-48BE-A339-F264D16AC5CC}"/>
               </a:ext>
             </a:extLst>
           </p:cNvPr>
@@ -7682,7 +7683,7 @@
           <p:cNvPr id="3" name="kicker-label">
             <a:extLst xmlns:a="http://schemas.openxmlformats.org/drawingml/2006/main">
               <a:ext uri="{FF2B5EF4-FFF2-40B4-BE49-F238E27FC236}">
-                <a16:creationId xmlns:a16="http://schemas.microsoft.com/office/drawing/2014/main" id="{122BDF39-E534-4BC1-AEBC-AB0E6C2B4AD2}"/>
+                <a16:creationId xmlns:a16="http://schemas.microsoft.com/office/drawing/2014/main" id="{92A0F71B-13D4-4802-8FA1-6E9752B70555}"/>
               </a:ext>
             </a:extLst>
           </p:cNvPr>
@@ -7746,7 +7747,7 @@
           <p:cNvPr id="4" name="">
             <a:extLst xmlns:a="http://schemas.openxmlformats.org/drawingml/2006/main">
               <a:ext uri="{FF2B5EF4-FFF2-40B4-BE49-F238E27FC236}">
-                <a16:creationId xmlns:a16="http://schemas.microsoft.com/office/drawing/2014/main" id="{FFF1559E-D030-454A-A1A4-45BCE7B316CB}"/>
+                <a16:creationId xmlns:a16="http://schemas.microsoft.com/office/drawing/2014/main" id="{41C57DC0-0C96-4E3C-9120-D9C85F9B43BF}"/>
               </a:ext>
             </a:extLst>
           </p:cNvPr>
@@ -7810,7 +7811,7 @@
           <p:cNvPr id="5" name="">
             <a:extLst xmlns:a="http://schemas.openxmlformats.org/drawingml/2006/main">
               <a:ext uri="{FF2B5EF4-FFF2-40B4-BE49-F238E27FC236}">
-                <a16:creationId xmlns:a16="http://schemas.microsoft.com/office/drawing/2014/main" id="{FC41C9E4-D693-488B-86B1-7599E596FC5F}"/>
+                <a16:creationId xmlns:a16="http://schemas.microsoft.com/office/drawing/2014/main" id="{539794D1-357D-4C29-BA91-161491D567EF}"/>
               </a:ext>
             </a:extLst>
           </p:cNvPr>
@@ -7845,7 +7846,7 @@
           <p:cNvPr id="6" name="">
             <a:extLst xmlns:a="http://schemas.openxmlformats.org/drawingml/2006/main">
               <a:ext uri="{FF2B5EF4-FFF2-40B4-BE49-F238E27FC236}">
-                <a16:creationId xmlns:a16="http://schemas.microsoft.com/office/drawing/2014/main" id="{D8E1895B-3341-4FF5-84C1-135CDCD96C10}"/>
+                <a16:creationId xmlns:a16="http://schemas.microsoft.com/office/drawing/2014/main" id="{3D6AD782-75B1-4B70-95CF-EBC7A026472F}"/>
               </a:ext>
             </a:extLst>
           </p:cNvPr>
@@ -7909,7 +7910,7 @@
           <p:cNvPr id="7" name="">
             <a:extLst xmlns:a="http://schemas.openxmlformats.org/drawingml/2006/main">
               <a:ext uri="{FF2B5EF4-FFF2-40B4-BE49-F238E27FC236}">
-                <a16:creationId xmlns:a16="http://schemas.microsoft.com/office/drawing/2014/main" id="{B3C2DCD9-04A2-452E-880A-4475261038F2}"/>
+                <a16:creationId xmlns:a16="http://schemas.microsoft.com/office/drawing/2014/main" id="{F318B9F9-0E26-4205-A354-66C6BA796070}"/>
               </a:ext>
             </a:extLst>
           </p:cNvPr>
@@ -7942,7 +7943,7 @@
           <p:cNvPr id="8" name="">
             <a:extLst xmlns:a="http://schemas.openxmlformats.org/drawingml/2006/main">
               <a:ext uri="{FF2B5EF4-FFF2-40B4-BE49-F238E27FC236}">
-                <a16:creationId xmlns:a16="http://schemas.microsoft.com/office/drawing/2014/main" id="{4F8FC056-5B37-49B6-88B5-8EC207AC8500}"/>
+                <a16:creationId xmlns:a16="http://schemas.microsoft.com/office/drawing/2014/main" id="{E0B99DBF-D80A-476D-82CC-7845309CD929}"/>
               </a:ext>
             </a:extLst>
           </p:cNvPr>
@@ -8006,7 +8007,7 @@
           <p:cNvPr id="9" name="">
             <a:extLst xmlns:a="http://schemas.openxmlformats.org/drawingml/2006/main">
               <a:ext uri="{FF2B5EF4-FFF2-40B4-BE49-F238E27FC236}">
-                <a16:creationId xmlns:a16="http://schemas.microsoft.com/office/drawing/2014/main" id="{25054B6E-F604-4B9C-9598-719E10D8F0B5}"/>
+                <a16:creationId xmlns:a16="http://schemas.microsoft.com/office/drawing/2014/main" id="{2CF28B7B-D0FD-462A-A272-4B0213B33FC4}"/>
               </a:ext>
             </a:extLst>
           </p:cNvPr>
@@ -8070,7 +8071,7 @@
           <p:cNvPr id="10" name="">
             <a:extLst xmlns:a="http://schemas.openxmlformats.org/drawingml/2006/main">
               <a:ext uri="{FF2B5EF4-FFF2-40B4-BE49-F238E27FC236}">
-                <a16:creationId xmlns:a16="http://schemas.microsoft.com/office/drawing/2014/main" id="{C666432E-98F7-4EFD-B3A4-A37D754F81C2}"/>
+                <a16:creationId xmlns:a16="http://schemas.microsoft.com/office/drawing/2014/main" id="{B574DDC8-D556-421D-8F54-79B836FB9356}"/>
               </a:ext>
             </a:extLst>
           </p:cNvPr>
@@ -8103,7 +8104,7 @@
           <p:cNvPr id="11" name="">
             <a:extLst xmlns:a="http://schemas.openxmlformats.org/drawingml/2006/main">
               <a:ext uri="{FF2B5EF4-FFF2-40B4-BE49-F238E27FC236}">
-                <a16:creationId xmlns:a16="http://schemas.microsoft.com/office/drawing/2014/main" id="{8A8C278B-13D4-494A-A7FE-9417BE83E1F7}"/>
+                <a16:creationId xmlns:a16="http://schemas.microsoft.com/office/drawing/2014/main" id="{D32DC060-E067-4202-B0EB-613AA73F62A7}"/>
               </a:ext>
             </a:extLst>
           </p:cNvPr>
@@ -8167,7 +8168,7 @@
           <p:cNvPr id="12" name="">
             <a:extLst xmlns:a="http://schemas.openxmlformats.org/drawingml/2006/main">
               <a:ext uri="{FF2B5EF4-FFF2-40B4-BE49-F238E27FC236}">
-                <a16:creationId xmlns:a16="http://schemas.microsoft.com/office/drawing/2014/main" id="{F8434615-DAA9-440A-9955-5A4137269E46}"/>
+                <a16:creationId xmlns:a16="http://schemas.microsoft.com/office/drawing/2014/main" id="{202F2657-6551-483A-A979-FAB3768919CF}"/>
               </a:ext>
             </a:extLst>
           </p:cNvPr>
@@ -8231,7 +8232,7 @@
           <p:cNvPr id="13" name="">
             <a:extLst xmlns:a="http://schemas.openxmlformats.org/drawingml/2006/main">
               <a:ext uri="{FF2B5EF4-FFF2-40B4-BE49-F238E27FC236}">
-                <a16:creationId xmlns:a16="http://schemas.microsoft.com/office/drawing/2014/main" id="{8EF0D879-F95D-446F-AB0A-473836D37992}"/>
+                <a16:creationId xmlns:a16="http://schemas.microsoft.com/office/drawing/2014/main" id="{12639F3A-46B7-4CF0-87FE-61359E8A41F7}"/>
               </a:ext>
             </a:extLst>
           </p:cNvPr>
@@ -8264,7 +8265,7 @@
           <p:cNvPr id="14" name="">
             <a:extLst xmlns:a="http://schemas.openxmlformats.org/drawingml/2006/main">
               <a:ext uri="{FF2B5EF4-FFF2-40B4-BE49-F238E27FC236}">
-                <a16:creationId xmlns:a16="http://schemas.microsoft.com/office/drawing/2014/main" id="{29301A25-9323-4515-A8AD-72626387031F}"/>
+                <a16:creationId xmlns:a16="http://schemas.microsoft.com/office/drawing/2014/main" id="{A4B2FB62-CB1F-4C20-9821-D63A74B9B1FC}"/>
               </a:ext>
             </a:extLst>
           </p:cNvPr>
@@ -8328,7 +8329,7 @@
           <p:cNvPr id="15" name="">
             <a:extLst xmlns:a="http://schemas.openxmlformats.org/drawingml/2006/main">
               <a:ext uri="{FF2B5EF4-FFF2-40B4-BE49-F238E27FC236}">
-                <a16:creationId xmlns:a16="http://schemas.microsoft.com/office/drawing/2014/main" id="{D81349C9-2ED5-486D-A3B9-6A5EDFC75D01}"/>
+                <a16:creationId xmlns:a16="http://schemas.microsoft.com/office/drawing/2014/main" id="{929CE089-3674-41DB-BD01-C7309F1C546E}"/>
               </a:ext>
             </a:extLst>
           </p:cNvPr>
@@ -8392,7 +8393,7 @@
           <p:cNvPr id="16" name="">
             <a:extLst xmlns:a="http://schemas.openxmlformats.org/drawingml/2006/main">
               <a:ext uri="{FF2B5EF4-FFF2-40B4-BE49-F238E27FC236}">
-                <a16:creationId xmlns:a16="http://schemas.microsoft.com/office/drawing/2014/main" id="{DF5CF99A-0B2D-452A-A823-CC2BDA818403}"/>
+                <a16:creationId xmlns:a16="http://schemas.microsoft.com/office/drawing/2014/main" id="{5D5BE1A9-835A-4F0F-AF0E-5D3E4C5E5DE9}"/>
               </a:ext>
             </a:extLst>
           </p:cNvPr>
@@ -8425,7 +8426,7 @@
           <p:cNvPr id="17" name="">
             <a:extLst xmlns:a="http://schemas.openxmlformats.org/drawingml/2006/main">
               <a:ext uri="{FF2B5EF4-FFF2-40B4-BE49-F238E27FC236}">
-                <a16:creationId xmlns:a16="http://schemas.microsoft.com/office/drawing/2014/main" id="{0B454BA0-9888-42F3-80E4-9675E1CC8E66}"/>
+                <a16:creationId xmlns:a16="http://schemas.microsoft.com/office/drawing/2014/main" id="{D9C60CBD-9026-4611-AD25-CEFECAAF7FE1}"/>
               </a:ext>
             </a:extLst>
           </p:cNvPr>
@@ -8489,7 +8490,7 @@
           <p:cNvPr id="18" name="">
             <a:extLst xmlns:a="http://schemas.openxmlformats.org/drawingml/2006/main">
               <a:ext uri="{FF2B5EF4-FFF2-40B4-BE49-F238E27FC236}">
-                <a16:creationId xmlns:a16="http://schemas.microsoft.com/office/drawing/2014/main" id="{C18DDFC6-A75F-4AD3-9FD2-86E521BC4794}"/>
+                <a16:creationId xmlns:a16="http://schemas.microsoft.com/office/drawing/2014/main" id="{7C30D853-D250-4497-9C8E-EB032BEA8925}"/>
               </a:ext>
             </a:extLst>
           </p:cNvPr>
@@ -8553,7 +8554,7 @@
           <p:cNvPr id="19" name="">
             <a:extLst xmlns:a="http://schemas.openxmlformats.org/drawingml/2006/main">
               <a:ext uri="{FF2B5EF4-FFF2-40B4-BE49-F238E27FC236}">
-                <a16:creationId xmlns:a16="http://schemas.microsoft.com/office/drawing/2014/main" id="{988E40B7-B8B6-4BBB-B404-B398B275D6BB}"/>
+                <a16:creationId xmlns:a16="http://schemas.microsoft.com/office/drawing/2014/main" id="{13FBDD1B-B361-4F52-A9BD-A7333C239D86}"/>
               </a:ext>
             </a:extLst>
           </p:cNvPr>
@@ -8586,7 +8587,7 @@
           <p:cNvPr id="20" name="">
             <a:extLst xmlns:a="http://schemas.openxmlformats.org/drawingml/2006/main">
               <a:ext uri="{FF2B5EF4-FFF2-40B4-BE49-F238E27FC236}">
-                <a16:creationId xmlns:a16="http://schemas.microsoft.com/office/drawing/2014/main" id="{92B16301-305F-4508-BA4D-85C8EFD4B5BA}"/>
+                <a16:creationId xmlns:a16="http://schemas.microsoft.com/office/drawing/2014/main" id="{105CEF3E-4FF3-48DE-B422-08964E26A1E5}"/>
               </a:ext>
             </a:extLst>
           </p:cNvPr>
@@ -8650,7 +8651,7 @@
           <p:cNvPr id="21" name="">
             <a:extLst xmlns:a="http://schemas.openxmlformats.org/drawingml/2006/main">
               <a:ext uri="{FF2B5EF4-FFF2-40B4-BE49-F238E27FC236}">
-                <a16:creationId xmlns:a16="http://schemas.microsoft.com/office/drawing/2014/main" id="{59F4A2A3-914E-4D1E-914D-738ED8EA7F64}"/>
+                <a16:creationId xmlns:a16="http://schemas.microsoft.com/office/drawing/2014/main" id="{DB640FD1-577E-406E-BABB-ACC1A47B7B53}"/>
               </a:ext>
             </a:extLst>
           </p:cNvPr>
@@ -8714,7 +8715,7 @@
           <p:cNvPr id="22" name="">
             <a:extLst xmlns:a="http://schemas.openxmlformats.org/drawingml/2006/main">
               <a:ext uri="{FF2B5EF4-FFF2-40B4-BE49-F238E27FC236}">
-                <a16:creationId xmlns:a16="http://schemas.microsoft.com/office/drawing/2014/main" id="{9FEB754D-8B11-4FCC-98F3-EE6A9BE6B3F8}"/>
+                <a16:creationId xmlns:a16="http://schemas.microsoft.com/office/drawing/2014/main" id="{5AE95B1A-23D0-42D3-B5C8-A2B8C6616448}"/>
               </a:ext>
             </a:extLst>
           </p:cNvPr>
@@ -8776,7 +8777,7 @@
     </p:spTree>
     <p:extLst>
       <p:ext uri="{BB962C8B-B14F-4D97-AF65-F5344CB8AC3E}">
-        <p14:creationId xmlns:p14="http://schemas.microsoft.com/office/powerpoint/2010/main" val="1360612133"/>
+        <p14:creationId xmlns:p14="http://schemas.microsoft.com/office/powerpoint/2010/main" val="1342462672"/>
       </p:ext>
     </p:extLst>
   </p:cSld>
@@ -8800,7 +8801,7 @@
           <p:cNvPr id="1" name="">
             <a:extLst xmlns:a="http://schemas.openxmlformats.org/drawingml/2006/main">
               <a:ext uri="{FF2B5EF4-FFF2-40B4-BE49-F238E27FC236}">
-                <a16:creationId xmlns:a16="http://schemas.microsoft.com/office/drawing/2014/main" id="{672D8314-FC06-4148-AE31-00984522EB77}"/>
+                <a16:creationId xmlns:a16="http://schemas.microsoft.com/office/drawing/2014/main" id="{635B0643-3925-433B-9CCB-C73020C91491}"/>
               </a:ext>
             </a:extLst>
           </p:cNvPr>
@@ -8835,7 +8836,7 @@
           <p:cNvPr id="2" name="kicker-marker">
             <a:extLst xmlns:a="http://schemas.openxmlformats.org/drawingml/2006/main">
               <a:ext uri="{FF2B5EF4-FFF2-40B4-BE49-F238E27FC236}">
-                <a16:creationId xmlns:a16="http://schemas.microsoft.com/office/drawing/2014/main" id="{0A3F315B-4B3A-4A4D-812B-493B13655F0B}"/>
+                <a16:creationId xmlns:a16="http://schemas.microsoft.com/office/drawing/2014/main" id="{E8258857-6DA2-4CBA-A456-E9DAA99F702B}"/>
               </a:ext>
             </a:extLst>
           </p:cNvPr>
@@ -8870,7 +8871,7 @@
           <p:cNvPr id="3" name="kicker-label">
             <a:extLst xmlns:a="http://schemas.openxmlformats.org/drawingml/2006/main">
               <a:ext uri="{FF2B5EF4-FFF2-40B4-BE49-F238E27FC236}">
-                <a16:creationId xmlns:a16="http://schemas.microsoft.com/office/drawing/2014/main" id="{8D261404-9BDA-4A98-9DE5-8173236097A3}"/>
+                <a16:creationId xmlns:a16="http://schemas.microsoft.com/office/drawing/2014/main" id="{22C4DF32-C4DE-4D13-9DCB-5556141DEFB4}"/>
               </a:ext>
             </a:extLst>
           </p:cNvPr>
@@ -8934,7 +8935,7 @@
           <p:cNvPr id="4" name="">
             <a:extLst xmlns:a="http://schemas.openxmlformats.org/drawingml/2006/main">
               <a:ext uri="{FF2B5EF4-FFF2-40B4-BE49-F238E27FC236}">
-                <a16:creationId xmlns:a16="http://schemas.microsoft.com/office/drawing/2014/main" id="{C4DE3C99-E929-4292-9391-C089FC4B6DA3}"/>
+                <a16:creationId xmlns:a16="http://schemas.microsoft.com/office/drawing/2014/main" id="{9BA86D77-2AE9-4576-986D-7A94175D03E4}"/>
               </a:ext>
             </a:extLst>
           </p:cNvPr>
@@ -8998,7 +8999,7 @@
           <p:cNvPr id="5" name="">
             <a:extLst xmlns:a="http://schemas.openxmlformats.org/drawingml/2006/main">
               <a:ext uri="{FF2B5EF4-FFF2-40B4-BE49-F238E27FC236}">
-                <a16:creationId xmlns:a16="http://schemas.microsoft.com/office/drawing/2014/main" id="{223D271F-90ED-43B4-8F22-74F31DAE8AE7}"/>
+                <a16:creationId xmlns:a16="http://schemas.microsoft.com/office/drawing/2014/main" id="{2B7870F4-FFB9-40F9-868C-5321EEF42A7E}"/>
               </a:ext>
             </a:extLst>
           </p:cNvPr>
@@ -9033,7 +9034,7 @@
           <p:cNvPr id="6" name="">
             <a:extLst xmlns:a="http://schemas.openxmlformats.org/drawingml/2006/main">
               <a:ext uri="{FF2B5EF4-FFF2-40B4-BE49-F238E27FC236}">
-                <a16:creationId xmlns:a16="http://schemas.microsoft.com/office/drawing/2014/main" id="{95B596FF-E197-4F8A-90E6-27817F906800}"/>
+                <a16:creationId xmlns:a16="http://schemas.microsoft.com/office/drawing/2014/main" id="{66A8615C-AF8D-4E11-875C-134AF01056DE}"/>
               </a:ext>
             </a:extLst>
           </p:cNvPr>
@@ -9097,7 +9098,7 @@
           <p:cNvPr id="7" name="">
             <a:extLst xmlns:a="http://schemas.openxmlformats.org/drawingml/2006/main">
               <a:ext uri="{FF2B5EF4-FFF2-40B4-BE49-F238E27FC236}">
-                <a16:creationId xmlns:a16="http://schemas.microsoft.com/office/drawing/2014/main" id="{DB3D680D-4A7B-4F03-8EC4-9653A957A808}"/>
+                <a16:creationId xmlns:a16="http://schemas.microsoft.com/office/drawing/2014/main" id="{8BFB68F7-1DEA-4925-8393-7E134ABBB81E}"/>
               </a:ext>
             </a:extLst>
           </p:cNvPr>
@@ -9130,7 +9131,7 @@
           <p:cNvPr id="8" name="">
             <a:extLst xmlns:a="http://schemas.openxmlformats.org/drawingml/2006/main">
               <a:ext uri="{FF2B5EF4-FFF2-40B4-BE49-F238E27FC236}">
-                <a16:creationId xmlns:a16="http://schemas.microsoft.com/office/drawing/2014/main" id="{46F5FA2B-88AE-4F9A-B570-00A2946B0F14}"/>
+                <a16:creationId xmlns:a16="http://schemas.microsoft.com/office/drawing/2014/main" id="{92F0A955-5608-441B-9CA4-A27F39C3BE16}"/>
               </a:ext>
             </a:extLst>
           </p:cNvPr>
@@ -9194,7 +9195,7 @@
           <p:cNvPr id="9" name="">
             <a:extLst xmlns:a="http://schemas.openxmlformats.org/drawingml/2006/main">
               <a:ext uri="{FF2B5EF4-FFF2-40B4-BE49-F238E27FC236}">
-                <a16:creationId xmlns:a16="http://schemas.microsoft.com/office/drawing/2014/main" id="{54353FAD-C4F4-405B-BD82-54DA8C8E34C0}"/>
+                <a16:creationId xmlns:a16="http://schemas.microsoft.com/office/drawing/2014/main" id="{6903AAB2-F647-4FE8-BD0C-8CFD02447DD9}"/>
               </a:ext>
             </a:extLst>
           </p:cNvPr>
@@ -9258,7 +9259,7 @@
           <p:cNvPr id="10" name="">
             <a:extLst xmlns:a="http://schemas.openxmlformats.org/drawingml/2006/main">
               <a:ext uri="{FF2B5EF4-FFF2-40B4-BE49-F238E27FC236}">
-                <a16:creationId xmlns:a16="http://schemas.microsoft.com/office/drawing/2014/main" id="{538A3E46-8C10-4510-9C06-41E77A685DAB}"/>
+                <a16:creationId xmlns:a16="http://schemas.microsoft.com/office/drawing/2014/main" id="{BDBFA103-7B29-4E36-9309-4B1929A88951}"/>
               </a:ext>
             </a:extLst>
           </p:cNvPr>
@@ -9291,7 +9292,7 @@
           <p:cNvPr id="11" name="">
             <a:extLst xmlns:a="http://schemas.openxmlformats.org/drawingml/2006/main">
               <a:ext uri="{FF2B5EF4-FFF2-40B4-BE49-F238E27FC236}">
-                <a16:creationId xmlns:a16="http://schemas.microsoft.com/office/drawing/2014/main" id="{5A7F9461-3E60-4EB1-B280-C28C7D8A8F3D}"/>
+                <a16:creationId xmlns:a16="http://schemas.microsoft.com/office/drawing/2014/main" id="{BBAEBBB0-9038-4080-90DE-2946F93F2812}"/>
               </a:ext>
             </a:extLst>
           </p:cNvPr>
@@ -9355,7 +9356,7 @@
           <p:cNvPr id="12" name="">
             <a:extLst xmlns:a="http://schemas.openxmlformats.org/drawingml/2006/main">
               <a:ext uri="{FF2B5EF4-FFF2-40B4-BE49-F238E27FC236}">
-                <a16:creationId xmlns:a16="http://schemas.microsoft.com/office/drawing/2014/main" id="{F99831A6-63E1-46A6-B588-1F1D80259A87}"/>
+                <a16:creationId xmlns:a16="http://schemas.microsoft.com/office/drawing/2014/main" id="{E441A38B-386E-4356-B6D1-142ACBBA2AFF}"/>
               </a:ext>
             </a:extLst>
           </p:cNvPr>
@@ -9419,7 +9420,7 @@
           <p:cNvPr id="13" name="">
             <a:extLst xmlns:a="http://schemas.openxmlformats.org/drawingml/2006/main">
               <a:ext uri="{FF2B5EF4-FFF2-40B4-BE49-F238E27FC236}">
-                <a16:creationId xmlns:a16="http://schemas.microsoft.com/office/drawing/2014/main" id="{5BAB91BE-8741-404C-8515-8484EA11F713}"/>
+                <a16:creationId xmlns:a16="http://schemas.microsoft.com/office/drawing/2014/main" id="{BF277EEE-46D5-463C-ADE3-22B74D54EC33}"/>
               </a:ext>
             </a:extLst>
           </p:cNvPr>
@@ -9452,7 +9453,7 @@
           <p:cNvPr id="14" name="">
             <a:extLst xmlns:a="http://schemas.openxmlformats.org/drawingml/2006/main">
               <a:ext uri="{FF2B5EF4-FFF2-40B4-BE49-F238E27FC236}">
-                <a16:creationId xmlns:a16="http://schemas.microsoft.com/office/drawing/2014/main" id="{AC204067-66F0-4FB7-AD83-540093E20AB4}"/>
+                <a16:creationId xmlns:a16="http://schemas.microsoft.com/office/drawing/2014/main" id="{7FA4824E-BBC1-4279-962A-36BF8B074128}"/>
               </a:ext>
             </a:extLst>
           </p:cNvPr>
@@ -9516,7 +9517,7 @@
           <p:cNvPr id="15" name="">
             <a:extLst xmlns:a="http://schemas.openxmlformats.org/drawingml/2006/main">
               <a:ext uri="{FF2B5EF4-FFF2-40B4-BE49-F238E27FC236}">
-                <a16:creationId xmlns:a16="http://schemas.microsoft.com/office/drawing/2014/main" id="{E789DE08-E235-45CA-A6C9-4629BDFA8218}"/>
+                <a16:creationId xmlns:a16="http://schemas.microsoft.com/office/drawing/2014/main" id="{4A2419CE-FECA-4320-BC6C-DBC0BA45EC0A}"/>
               </a:ext>
             </a:extLst>
           </p:cNvPr>
@@ -9580,7 +9581,7 @@
           <p:cNvPr id="16" name="">
             <a:extLst xmlns:a="http://schemas.openxmlformats.org/drawingml/2006/main">
               <a:ext uri="{FF2B5EF4-FFF2-40B4-BE49-F238E27FC236}">
-                <a16:creationId xmlns:a16="http://schemas.microsoft.com/office/drawing/2014/main" id="{E0ABA103-2A53-4B76-99DB-030973934A45}"/>
+                <a16:creationId xmlns:a16="http://schemas.microsoft.com/office/drawing/2014/main" id="{0A4CAA6B-2503-48FF-8BC4-8D6AE9EBA060}"/>
               </a:ext>
             </a:extLst>
           </p:cNvPr>
@@ -9613,7 +9614,7 @@
           <p:cNvPr id="17" name="">
             <a:extLst xmlns:a="http://schemas.openxmlformats.org/drawingml/2006/main">
               <a:ext uri="{FF2B5EF4-FFF2-40B4-BE49-F238E27FC236}">
-                <a16:creationId xmlns:a16="http://schemas.microsoft.com/office/drawing/2014/main" id="{B23DAB56-4BA8-46A0-812A-9E28801C876F}"/>
+                <a16:creationId xmlns:a16="http://schemas.microsoft.com/office/drawing/2014/main" id="{F8F2C4FA-B917-47D6-BFE6-C5F60D1E98CD}"/>
               </a:ext>
             </a:extLst>
           </p:cNvPr>
@@ -9677,7 +9678,7 @@
           <p:cNvPr id="18" name="">
             <a:extLst xmlns:a="http://schemas.openxmlformats.org/drawingml/2006/main">
               <a:ext uri="{FF2B5EF4-FFF2-40B4-BE49-F238E27FC236}">
-                <a16:creationId xmlns:a16="http://schemas.microsoft.com/office/drawing/2014/main" id="{4BF34754-66C6-4326-B6FA-964AA2CA3698}"/>
+                <a16:creationId xmlns:a16="http://schemas.microsoft.com/office/drawing/2014/main" id="{194C1A3A-EB2A-48EB-BDC4-6825D2560EB7}"/>
               </a:ext>
             </a:extLst>
           </p:cNvPr>
@@ -9741,7 +9742,7 @@
           <p:cNvPr id="19" name="">
             <a:extLst xmlns:a="http://schemas.openxmlformats.org/drawingml/2006/main">
               <a:ext uri="{FF2B5EF4-FFF2-40B4-BE49-F238E27FC236}">
-                <a16:creationId xmlns:a16="http://schemas.microsoft.com/office/drawing/2014/main" id="{D6357BC8-5333-4E13-8891-BAC33336440F}"/>
+                <a16:creationId xmlns:a16="http://schemas.microsoft.com/office/drawing/2014/main" id="{583B1B7F-3B3D-4EC6-8E53-39D7BA1D9472}"/>
               </a:ext>
             </a:extLst>
           </p:cNvPr>
@@ -9776,7 +9777,7 @@
           <p:cNvPr id="20" name="">
             <a:extLst xmlns:a="http://schemas.openxmlformats.org/drawingml/2006/main">
               <a:ext uri="{FF2B5EF4-FFF2-40B4-BE49-F238E27FC236}">
-                <a16:creationId xmlns:a16="http://schemas.microsoft.com/office/drawing/2014/main" id="{67F70DD7-127A-47A0-BC1E-86DE41C9D1B1}"/>
+                <a16:creationId xmlns:a16="http://schemas.microsoft.com/office/drawing/2014/main" id="{57ED2A71-961A-4A99-A45E-C467979C1B34}"/>
               </a:ext>
             </a:extLst>
           </p:cNvPr>
@@ -9840,7 +9841,7 @@
           <p:cNvPr id="21" name="">
             <a:extLst xmlns:a="http://schemas.openxmlformats.org/drawingml/2006/main">
               <a:ext uri="{FF2B5EF4-FFF2-40B4-BE49-F238E27FC236}">
-                <a16:creationId xmlns:a16="http://schemas.microsoft.com/office/drawing/2014/main" id="{43E2C67C-ACEC-4995-A3A5-03E0C1E485AF}"/>
+                <a16:creationId xmlns:a16="http://schemas.microsoft.com/office/drawing/2014/main" id="{7557E311-2E0D-4310-8C92-EC50423B50C8}"/>
               </a:ext>
             </a:extLst>
           </p:cNvPr>
@@ -9893,8 +9894,9 @@
                 <a:latin typeface="Aptos"/>
                 <a:ea typeface="Aptos"/>
                 <a:cs typeface="Aptos"/>
+                <a:hlinkClick xmlns:r="http://schemas.openxmlformats.org/officeDocument/2006/relationships" r:id="rIdSynthAMLDemo"/>
               </a:rPr>
-              <a:t>https://raw.githack.com/yq688m3JT/genAI_final/ae9c84ea574e9f8c48c84f1863ce82f77ea4f24e/docs/demo.html</a:t>
+              <a:t>https://raw.githack.com/yq688m3JT/genAI_final/a909764e2905cf627550479f619ade84aa52cfa9/docs/demo.html</a:t>
             </a:r>
           </a:p>
         </p:txBody>
@@ -9902,7 +9904,7 @@
     </p:spTree>
     <p:extLst>
       <p:ext uri="{BB962C8B-B14F-4D97-AF65-F5344CB8AC3E}">
-        <p14:creationId xmlns:p14="http://schemas.microsoft.com/office/powerpoint/2010/main" val="386717638"/>
+        <p14:creationId xmlns:p14="http://schemas.microsoft.com/office/powerpoint/2010/main" val="817236135"/>
       </p:ext>
     </p:extLst>
   </p:cSld>

</xml_diff>

<commit_message>
Pin no-input self-intake demo link
</commit_message>
<xml_diff>
--- a/docs/synthaml-final-presentation.pptx
+++ b/docs/synthaml-final-presentation.pptx
@@ -2,19 +2,19 @@
 <file path=ppt/presentation.xml><?xml version="1.0" encoding="utf-8"?>
 <p:presentation xmlns:p="http://schemas.openxmlformats.org/presentationml/2006/main">
   <p:sldMasterIdLst>
-    <p:sldMasterId xmlns:r="http://schemas.openxmlformats.org/officeDocument/2006/relationships" id="2147483648" r:id="Rcfef0ef060c8418c"/>
+    <p:sldMasterId xmlns:r="http://schemas.openxmlformats.org/officeDocument/2006/relationships" id="2147483648" r:id="Rd924b16acde44892"/>
   </p:sldMasterIdLst>
   <p:notesMasterIdLst>
-    <p:notesMasterId xmlns:r="http://schemas.openxmlformats.org/officeDocument/2006/relationships" r:id="R9d876333ddde406f"/>
+    <p:notesMasterId xmlns:r="http://schemas.openxmlformats.org/officeDocument/2006/relationships" r:id="R3685d0eae5ba4cdd"/>
   </p:notesMasterIdLst>
   <p:sldIdLst>
-    <p:sldId xmlns:r="http://schemas.openxmlformats.org/officeDocument/2006/relationships" id="256" r:id="R548c0bbe1e54443e"/>
-    <p:sldId xmlns:r="http://schemas.openxmlformats.org/officeDocument/2006/relationships" id="257" r:id="R6f1c515c0f2f4a47"/>
-    <p:sldId xmlns:r="http://schemas.openxmlformats.org/officeDocument/2006/relationships" id="258" r:id="R8773f2e9089a41fb"/>
-    <p:sldId xmlns:r="http://schemas.openxmlformats.org/officeDocument/2006/relationships" id="259" r:id="Rd10ba0bc75504158"/>
-    <p:sldId xmlns:r="http://schemas.openxmlformats.org/officeDocument/2006/relationships" id="260" r:id="R2143d4f99a1f403a"/>
-    <p:sldId xmlns:r="http://schemas.openxmlformats.org/officeDocument/2006/relationships" id="261" r:id="Rd314185a59ff4968"/>
-    <p:sldId xmlns:r="http://schemas.openxmlformats.org/officeDocument/2006/relationships" id="262" r:id="R51060c052ab346b9"/>
+    <p:sldId xmlns:r="http://schemas.openxmlformats.org/officeDocument/2006/relationships" id="256" r:id="Rb55482e210a149cb"/>
+    <p:sldId xmlns:r="http://schemas.openxmlformats.org/officeDocument/2006/relationships" id="257" r:id="R3b098815bf6b485c"/>
+    <p:sldId xmlns:r="http://schemas.openxmlformats.org/officeDocument/2006/relationships" id="258" r:id="R400cfa604c694247"/>
+    <p:sldId xmlns:r="http://schemas.openxmlformats.org/officeDocument/2006/relationships" id="259" r:id="Ra423dbf430bc41c4"/>
+    <p:sldId xmlns:r="http://schemas.openxmlformats.org/officeDocument/2006/relationships" id="260" r:id="R5313e6f2eb734d4d"/>
+    <p:sldId xmlns:r="http://schemas.openxmlformats.org/officeDocument/2006/relationships" id="261" r:id="R52067972c56442f0"/>
+    <p:sldId xmlns:r="http://schemas.openxmlformats.org/officeDocument/2006/relationships" id="262" r:id="R71d16ffba2bf4563"/>
   </p:sldIdLst>
   <p:sldSz cx="12192000" cy="6858000"/>
   <p:notesSz cx="6858000" cy="9144000"/>
@@ -957,7 +957,7 @@
   </p:cSld>
   <p:clrMap bg1="lt1" tx1="dk1" bg2="lt2" tx2="dk2" accent1="accent1" accent2="accent2" accent3="accent3" accent4="accent4" accent5="accent5" accent6="accent6" hlink="hlink" folHlink="folHlink"/>
   <p:sldLayoutIdLst>
-    <p:sldLayoutId xmlns:r="http://schemas.openxmlformats.org/officeDocument/2006/relationships" id="2147483649" r:id="Rd2ab3c0fce01427e"/>
+    <p:sldLayoutId xmlns:r="http://schemas.openxmlformats.org/officeDocument/2006/relationships" id="2147483649" r:id="Rae47736345fd4c78"/>
   </p:sldLayoutIdLst>
   <p:txStyles>
     <p:titleStyle>
@@ -1256,7 +1256,7 @@
           <p:cNvPr id="1" name="">
             <a:extLst xmlns:a="http://schemas.openxmlformats.org/drawingml/2006/main">
               <a:ext uri="{FF2B5EF4-FFF2-40B4-BE49-F238E27FC236}">
-                <a16:creationId xmlns:a16="http://schemas.microsoft.com/office/drawing/2014/main" id="{986C2AF5-EA10-4A9E-8282-C8A78118B0BF}"/>
+                <a16:creationId xmlns:a16="http://schemas.microsoft.com/office/drawing/2014/main" id="{F4C1A703-3F52-425E-B8BD-20635F4B779C}"/>
               </a:ext>
             </a:extLst>
           </p:cNvPr>
@@ -1291,7 +1291,7 @@
           <p:cNvPr id="2" name="">
             <a:extLst xmlns:a="http://schemas.openxmlformats.org/drawingml/2006/main">
               <a:ext uri="{FF2B5EF4-FFF2-40B4-BE49-F238E27FC236}">
-                <a16:creationId xmlns:a16="http://schemas.microsoft.com/office/drawing/2014/main" id="{8B9F09E3-CE97-42DA-B754-69512FF5622F}"/>
+                <a16:creationId xmlns:a16="http://schemas.microsoft.com/office/drawing/2014/main" id="{D9920C46-075D-40AC-A683-A979D08BF1FD}"/>
               </a:ext>
             </a:extLst>
           </p:cNvPr>
@@ -1326,7 +1326,7 @@
           <p:cNvPr id="3" name="">
             <a:extLst xmlns:a="http://schemas.openxmlformats.org/drawingml/2006/main">
               <a:ext uri="{FF2B5EF4-FFF2-40B4-BE49-F238E27FC236}">
-                <a16:creationId xmlns:a16="http://schemas.microsoft.com/office/drawing/2014/main" id="{99675DE5-D985-4E32-AFD5-C6AF36E297E1}"/>
+                <a16:creationId xmlns:a16="http://schemas.microsoft.com/office/drawing/2014/main" id="{48487979-E524-4DB6-8D72-1A050799586A}"/>
               </a:ext>
             </a:extLst>
           </p:cNvPr>
@@ -1390,7 +1390,7 @@
           <p:cNvPr id="4" name="">
             <a:extLst xmlns:a="http://schemas.openxmlformats.org/drawingml/2006/main">
               <a:ext uri="{FF2B5EF4-FFF2-40B4-BE49-F238E27FC236}">
-                <a16:creationId xmlns:a16="http://schemas.microsoft.com/office/drawing/2014/main" id="{D436324B-702F-4C20-B2A9-630B7347392D}"/>
+                <a16:creationId xmlns:a16="http://schemas.microsoft.com/office/drawing/2014/main" id="{AE9E4596-6D61-40C2-993D-9B4178783590}"/>
               </a:ext>
             </a:extLst>
           </p:cNvPr>
@@ -1454,7 +1454,7 @@
           <p:cNvPr id="5" name="">
             <a:extLst xmlns:a="http://schemas.openxmlformats.org/drawingml/2006/main">
               <a:ext uri="{FF2B5EF4-FFF2-40B4-BE49-F238E27FC236}">
-                <a16:creationId xmlns:a16="http://schemas.microsoft.com/office/drawing/2014/main" id="{907EA4C4-5830-4379-928A-13CDB6B2C8C5}"/>
+                <a16:creationId xmlns:a16="http://schemas.microsoft.com/office/drawing/2014/main" id="{C95EF540-8DB1-4390-8817-9786B706F11C}"/>
               </a:ext>
             </a:extLst>
           </p:cNvPr>
@@ -1518,7 +1518,7 @@
           <p:cNvPr id="6" name="">
             <a:extLst xmlns:a="http://schemas.openxmlformats.org/drawingml/2006/main">
               <a:ext uri="{FF2B5EF4-FFF2-40B4-BE49-F238E27FC236}">
-                <a16:creationId xmlns:a16="http://schemas.microsoft.com/office/drawing/2014/main" id="{1119CA1C-EF9A-4AD2-986A-DC7C32DBD967}"/>
+                <a16:creationId xmlns:a16="http://schemas.microsoft.com/office/drawing/2014/main" id="{E71B3368-7714-414C-91D1-EBEECFF165DA}"/>
               </a:ext>
             </a:extLst>
           </p:cNvPr>
@@ -1553,7 +1553,7 @@
           <p:cNvPr id="7" name="">
             <a:extLst xmlns:a="http://schemas.openxmlformats.org/drawingml/2006/main">
               <a:ext uri="{FF2B5EF4-FFF2-40B4-BE49-F238E27FC236}">
-                <a16:creationId xmlns:a16="http://schemas.microsoft.com/office/drawing/2014/main" id="{6D5B59BE-B27F-422A-93A8-1DA51BAA1DAD}"/>
+                <a16:creationId xmlns:a16="http://schemas.microsoft.com/office/drawing/2014/main" id="{5284406F-3B34-4369-9353-13FBFC4F71B6}"/>
               </a:ext>
             </a:extLst>
           </p:cNvPr>
@@ -1617,7 +1617,7 @@
           <p:cNvPr id="8" name="">
             <a:extLst xmlns:a="http://schemas.openxmlformats.org/drawingml/2006/main">
               <a:ext uri="{FF2B5EF4-FFF2-40B4-BE49-F238E27FC236}">
-                <a16:creationId xmlns:a16="http://schemas.microsoft.com/office/drawing/2014/main" id="{7EDB3EC2-CAA9-4EE1-884F-C1EC882115C4}"/>
+                <a16:creationId xmlns:a16="http://schemas.microsoft.com/office/drawing/2014/main" id="{EFEC45D1-F5CF-4965-A134-AAEC84D307DD}"/>
               </a:ext>
             </a:extLst>
           </p:cNvPr>
@@ -1681,7 +1681,7 @@
           <p:cNvPr id="9" name="">
             <a:extLst xmlns:a="http://schemas.openxmlformats.org/drawingml/2006/main">
               <a:ext uri="{FF2B5EF4-FFF2-40B4-BE49-F238E27FC236}">
-                <a16:creationId xmlns:a16="http://schemas.microsoft.com/office/drawing/2014/main" id="{D0F6B052-C993-40D6-A2F0-7354895725C3}"/>
+                <a16:creationId xmlns:a16="http://schemas.microsoft.com/office/drawing/2014/main" id="{0BF60E06-84D9-4602-9700-623E6CFADE2B}"/>
               </a:ext>
             </a:extLst>
           </p:cNvPr>
@@ -1745,7 +1745,7 @@
           <p:cNvPr id="10" name="">
             <a:extLst xmlns:a="http://schemas.openxmlformats.org/drawingml/2006/main">
               <a:ext uri="{FF2B5EF4-FFF2-40B4-BE49-F238E27FC236}">
-                <a16:creationId xmlns:a16="http://schemas.microsoft.com/office/drawing/2014/main" id="{BAA0AABD-813F-45A4-A26A-C9CDE57C510F}"/>
+                <a16:creationId xmlns:a16="http://schemas.microsoft.com/office/drawing/2014/main" id="{AE3A2460-77B6-4B89-BF92-5CFE77808035}"/>
               </a:ext>
             </a:extLst>
           </p:cNvPr>
@@ -1809,7 +1809,7 @@
           <p:cNvPr id="11" name="">
             <a:extLst xmlns:a="http://schemas.openxmlformats.org/drawingml/2006/main">
               <a:ext uri="{FF2B5EF4-FFF2-40B4-BE49-F238E27FC236}">
-                <a16:creationId xmlns:a16="http://schemas.microsoft.com/office/drawing/2014/main" id="{A65665BD-61E2-49C4-B511-323482CC3D1E}"/>
+                <a16:creationId xmlns:a16="http://schemas.microsoft.com/office/drawing/2014/main" id="{BA5DDC99-C014-40E8-BB12-C7B7DA1FFC46}"/>
               </a:ext>
             </a:extLst>
           </p:cNvPr>
@@ -1873,7 +1873,7 @@
           <p:cNvPr id="12" name="">
             <a:extLst xmlns:a="http://schemas.openxmlformats.org/drawingml/2006/main">
               <a:ext uri="{FF2B5EF4-FFF2-40B4-BE49-F238E27FC236}">
-                <a16:creationId xmlns:a16="http://schemas.microsoft.com/office/drawing/2014/main" id="{EB5034D4-B52F-48F8-9BC6-894481568138}"/>
+                <a16:creationId xmlns:a16="http://schemas.microsoft.com/office/drawing/2014/main" id="{340006DF-B416-43C3-9EFD-E53A714BE995}"/>
               </a:ext>
             </a:extLst>
           </p:cNvPr>
@@ -1937,7 +1937,7 @@
           <p:cNvPr id="13" name="">
             <a:extLst xmlns:a="http://schemas.openxmlformats.org/drawingml/2006/main">
               <a:ext uri="{FF2B5EF4-FFF2-40B4-BE49-F238E27FC236}">
-                <a16:creationId xmlns:a16="http://schemas.microsoft.com/office/drawing/2014/main" id="{AE70E98D-8A47-4AB0-AC9B-4269801FC0CC}"/>
+                <a16:creationId xmlns:a16="http://schemas.microsoft.com/office/drawing/2014/main" id="{59B62D8D-DBFA-4A0C-8A27-82D908B888FF}"/>
               </a:ext>
             </a:extLst>
           </p:cNvPr>
@@ -1972,7 +1972,7 @@
           <p:cNvPr id="14" name="">
             <a:extLst xmlns:a="http://schemas.openxmlformats.org/drawingml/2006/main">
               <a:ext uri="{FF2B5EF4-FFF2-40B4-BE49-F238E27FC236}">
-                <a16:creationId xmlns:a16="http://schemas.microsoft.com/office/drawing/2014/main" id="{03978FD1-3BDE-493E-B912-F4698A9F5CF3}"/>
+                <a16:creationId xmlns:a16="http://schemas.microsoft.com/office/drawing/2014/main" id="{500A97A7-BAF1-44E5-932E-299D330F2591}"/>
               </a:ext>
             </a:extLst>
           </p:cNvPr>
@@ -2036,7 +2036,7 @@
           <p:cNvPr id="15" name="">
             <a:extLst xmlns:a="http://schemas.openxmlformats.org/drawingml/2006/main">
               <a:ext uri="{FF2B5EF4-FFF2-40B4-BE49-F238E27FC236}">
-                <a16:creationId xmlns:a16="http://schemas.microsoft.com/office/drawing/2014/main" id="{44190A00-3650-404B-A5A9-51854BC34121}"/>
+                <a16:creationId xmlns:a16="http://schemas.microsoft.com/office/drawing/2014/main" id="{33F83B54-8437-48FB-A8B6-C16A656AD35A}"/>
               </a:ext>
             </a:extLst>
           </p:cNvPr>
@@ -2123,7 +2123,7 @@
           <p:cNvPr id="16" name="">
             <a:extLst xmlns:a="http://schemas.openxmlformats.org/drawingml/2006/main">
               <a:ext uri="{FF2B5EF4-FFF2-40B4-BE49-F238E27FC236}">
-                <a16:creationId xmlns:a16="http://schemas.microsoft.com/office/drawing/2014/main" id="{E4E5B31F-200F-453A-A69E-4FF89E33DBE6}"/>
+                <a16:creationId xmlns:a16="http://schemas.microsoft.com/office/drawing/2014/main" id="{549B2735-D7E9-4FAB-AF50-38D8C1BD8641}"/>
               </a:ext>
             </a:extLst>
           </p:cNvPr>
@@ -2187,7 +2187,7 @@
           <p:cNvPr id="17" name="">
             <a:extLst xmlns:a="http://schemas.openxmlformats.org/drawingml/2006/main">
               <a:ext uri="{FF2B5EF4-FFF2-40B4-BE49-F238E27FC236}">
-                <a16:creationId xmlns:a16="http://schemas.microsoft.com/office/drawing/2014/main" id="{0AD077D7-8926-4F51-A0BE-A4F738990934}"/>
+                <a16:creationId xmlns:a16="http://schemas.microsoft.com/office/drawing/2014/main" id="{950E7F76-FA45-40E8-ABB1-CB17E5A3080D}"/>
               </a:ext>
             </a:extLst>
           </p:cNvPr>
@@ -2242,7 +2242,7 @@
                 <a:cs typeface="Aptos"/>
                 <a:hlinkClick xmlns:r="http://schemas.openxmlformats.org/officeDocument/2006/relationships" r:id="rIdSynthAMLDemo"/>
               </a:rPr>
-              <a:t>https://raw.githack.com/yq688m3JT/genAI_final/a909764e2905cf627550479f619ade84aa52cfa9/docs/demo.html</a:t>
+              <a:t>https://raw.githack.com/yq688m3JT/genAI_final/96f03dbb7ecf9a5f13d39b6a0f8c61218ea87962/docs/demo.html</a:t>
             </a:r>
           </a:p>
         </p:txBody>
@@ -2250,7 +2250,7 @@
     </p:spTree>
     <p:extLst>
       <p:ext uri="{BB962C8B-B14F-4D97-AF65-F5344CB8AC3E}">
-        <p14:creationId xmlns:p14="http://schemas.microsoft.com/office/powerpoint/2010/main" val="1762840131"/>
+        <p14:creationId xmlns:p14="http://schemas.microsoft.com/office/powerpoint/2010/main" val="227035889"/>
       </p:ext>
     </p:extLst>
   </p:cSld>
@@ -2274,7 +2274,7 @@
           <p:cNvPr id="1" name="">
             <a:extLst xmlns:a="http://schemas.openxmlformats.org/drawingml/2006/main">
               <a:ext uri="{FF2B5EF4-FFF2-40B4-BE49-F238E27FC236}">
-                <a16:creationId xmlns:a16="http://schemas.microsoft.com/office/drawing/2014/main" id="{11B534BA-824D-4638-8D48-94244B1D632F}"/>
+                <a16:creationId xmlns:a16="http://schemas.microsoft.com/office/drawing/2014/main" id="{9A0F64D5-79A1-4326-B937-137AB4FC1A0B}"/>
               </a:ext>
             </a:extLst>
           </p:cNvPr>
@@ -2309,7 +2309,7 @@
           <p:cNvPr id="2" name="kicker-marker">
             <a:extLst xmlns:a="http://schemas.openxmlformats.org/drawingml/2006/main">
               <a:ext uri="{FF2B5EF4-FFF2-40B4-BE49-F238E27FC236}">
-                <a16:creationId xmlns:a16="http://schemas.microsoft.com/office/drawing/2014/main" id="{00C4AD68-8164-4856-B6EE-75F81BE12D43}"/>
+                <a16:creationId xmlns:a16="http://schemas.microsoft.com/office/drawing/2014/main" id="{BD6A93DE-F506-4B41-A8B9-F6601FF2BD9F}"/>
               </a:ext>
             </a:extLst>
           </p:cNvPr>
@@ -2344,7 +2344,7 @@
           <p:cNvPr id="3" name="kicker-label">
             <a:extLst xmlns:a="http://schemas.openxmlformats.org/drawingml/2006/main">
               <a:ext uri="{FF2B5EF4-FFF2-40B4-BE49-F238E27FC236}">
-                <a16:creationId xmlns:a16="http://schemas.microsoft.com/office/drawing/2014/main" id="{0EDB8118-B9B8-4BD2-9059-D1C746E09471}"/>
+                <a16:creationId xmlns:a16="http://schemas.microsoft.com/office/drawing/2014/main" id="{B3276053-9CB6-49F2-8687-714BF58BBFD0}"/>
               </a:ext>
             </a:extLst>
           </p:cNvPr>
@@ -2408,7 +2408,7 @@
           <p:cNvPr id="4" name="">
             <a:extLst xmlns:a="http://schemas.openxmlformats.org/drawingml/2006/main">
               <a:ext uri="{FF2B5EF4-FFF2-40B4-BE49-F238E27FC236}">
-                <a16:creationId xmlns:a16="http://schemas.microsoft.com/office/drawing/2014/main" id="{506CA177-5C3A-4591-8C51-47B33AB1278E}"/>
+                <a16:creationId xmlns:a16="http://schemas.microsoft.com/office/drawing/2014/main" id="{6B843209-C71D-438E-87DE-572BF06F5C0E}"/>
               </a:ext>
             </a:extLst>
           </p:cNvPr>
@@ -2472,7 +2472,7 @@
           <p:cNvPr id="5" name="">
             <a:extLst xmlns:a="http://schemas.openxmlformats.org/drawingml/2006/main">
               <a:ext uri="{FF2B5EF4-FFF2-40B4-BE49-F238E27FC236}">
-                <a16:creationId xmlns:a16="http://schemas.microsoft.com/office/drawing/2014/main" id="{2A9971B8-3E04-4928-BC0F-63B033EB00E9}"/>
+                <a16:creationId xmlns:a16="http://schemas.microsoft.com/office/drawing/2014/main" id="{8980568C-55AA-40BB-B09F-2931A8A25F19}"/>
               </a:ext>
             </a:extLst>
           </p:cNvPr>
@@ -2536,7 +2536,7 @@
           <p:cNvPr id="6" name="">
             <a:extLst xmlns:a="http://schemas.openxmlformats.org/drawingml/2006/main">
               <a:ext uri="{FF2B5EF4-FFF2-40B4-BE49-F238E27FC236}">
-                <a16:creationId xmlns:a16="http://schemas.microsoft.com/office/drawing/2014/main" id="{414EC91D-067B-4F36-B8AB-9F933C132A29}"/>
+                <a16:creationId xmlns:a16="http://schemas.microsoft.com/office/drawing/2014/main" id="{808F9A80-4DED-4B09-AA39-BA197AC10FDE}"/>
               </a:ext>
             </a:extLst>
           </p:cNvPr>
@@ -2571,7 +2571,7 @@
           <p:cNvPr id="7" name="">
             <a:extLst xmlns:a="http://schemas.openxmlformats.org/drawingml/2006/main">
               <a:ext uri="{FF2B5EF4-FFF2-40B4-BE49-F238E27FC236}">
-                <a16:creationId xmlns:a16="http://schemas.microsoft.com/office/drawing/2014/main" id="{0B34B94F-74C7-486F-8E5B-A6A7C86BACB8}"/>
+                <a16:creationId xmlns:a16="http://schemas.microsoft.com/office/drawing/2014/main" id="{CE938E04-49BC-4251-9CF1-0AAF35E7A280}"/>
               </a:ext>
             </a:extLst>
           </p:cNvPr>
@@ -2635,7 +2635,7 @@
           <p:cNvPr id="8" name="">
             <a:extLst xmlns:a="http://schemas.openxmlformats.org/drawingml/2006/main">
               <a:ext uri="{FF2B5EF4-FFF2-40B4-BE49-F238E27FC236}">
-                <a16:creationId xmlns:a16="http://schemas.microsoft.com/office/drawing/2014/main" id="{1FF4AEB7-D23A-41FB-9ADF-0517FCA511E8}"/>
+                <a16:creationId xmlns:a16="http://schemas.microsoft.com/office/drawing/2014/main" id="{FFEB3C9B-601F-45F6-BE77-3ED8D96ACAEC}"/>
               </a:ext>
             </a:extLst>
           </p:cNvPr>
@@ -2699,7 +2699,7 @@
           <p:cNvPr id="9" name="">
             <a:extLst xmlns:a="http://schemas.openxmlformats.org/drawingml/2006/main">
               <a:ext uri="{FF2B5EF4-FFF2-40B4-BE49-F238E27FC236}">
-                <a16:creationId xmlns:a16="http://schemas.microsoft.com/office/drawing/2014/main" id="{039A8938-CCF7-4D68-B25A-C6C229187439}"/>
+                <a16:creationId xmlns:a16="http://schemas.microsoft.com/office/drawing/2014/main" id="{40892F4F-87FE-4700-B155-88E3F0051265}"/>
               </a:ext>
             </a:extLst>
           </p:cNvPr>
@@ -2763,7 +2763,7 @@
           <p:cNvPr id="10" name="">
             <a:extLst xmlns:a="http://schemas.openxmlformats.org/drawingml/2006/main">
               <a:ext uri="{FF2B5EF4-FFF2-40B4-BE49-F238E27FC236}">
-                <a16:creationId xmlns:a16="http://schemas.microsoft.com/office/drawing/2014/main" id="{B5FF3C0D-E690-4FFA-8797-CA03593530D3}"/>
+                <a16:creationId xmlns:a16="http://schemas.microsoft.com/office/drawing/2014/main" id="{7879F359-B800-4942-A2FF-2050E1D3E34E}"/>
               </a:ext>
             </a:extLst>
           </p:cNvPr>
@@ -2798,7 +2798,7 @@
           <p:cNvPr id="11" name="">
             <a:extLst xmlns:a="http://schemas.openxmlformats.org/drawingml/2006/main">
               <a:ext uri="{FF2B5EF4-FFF2-40B4-BE49-F238E27FC236}">
-                <a16:creationId xmlns:a16="http://schemas.microsoft.com/office/drawing/2014/main" id="{9470DEB2-2550-4B7D-A5EC-12672564BC34}"/>
+                <a16:creationId xmlns:a16="http://schemas.microsoft.com/office/drawing/2014/main" id="{5CD24A53-1051-4060-BC5C-64E8B6D66A33}"/>
               </a:ext>
             </a:extLst>
           </p:cNvPr>
@@ -2833,7 +2833,7 @@
           <p:cNvPr id="12" name="">
             <a:extLst xmlns:a="http://schemas.openxmlformats.org/drawingml/2006/main">
               <a:ext uri="{FF2B5EF4-FFF2-40B4-BE49-F238E27FC236}">
-                <a16:creationId xmlns:a16="http://schemas.microsoft.com/office/drawing/2014/main" id="{3F7C31E1-53D2-4E41-8BA1-FAF55E457618}"/>
+                <a16:creationId xmlns:a16="http://schemas.microsoft.com/office/drawing/2014/main" id="{ED3980B1-7EAD-460C-9431-CDCBD0130C3B}"/>
               </a:ext>
             </a:extLst>
           </p:cNvPr>
@@ -2868,7 +2868,7 @@
           <p:cNvPr id="13" name="">
             <a:extLst xmlns:a="http://schemas.openxmlformats.org/drawingml/2006/main">
               <a:ext uri="{FF2B5EF4-FFF2-40B4-BE49-F238E27FC236}">
-                <a16:creationId xmlns:a16="http://schemas.microsoft.com/office/drawing/2014/main" id="{64FBA750-9631-4723-BA86-FF6A731F10C9}"/>
+                <a16:creationId xmlns:a16="http://schemas.microsoft.com/office/drawing/2014/main" id="{AFE20A30-5A99-42AB-8880-E99949A60FAF}"/>
               </a:ext>
             </a:extLst>
           </p:cNvPr>
@@ -2932,7 +2932,7 @@
           <p:cNvPr id="14" name="">
             <a:extLst xmlns:a="http://schemas.openxmlformats.org/drawingml/2006/main">
               <a:ext uri="{FF2B5EF4-FFF2-40B4-BE49-F238E27FC236}">
-                <a16:creationId xmlns:a16="http://schemas.microsoft.com/office/drawing/2014/main" id="{C02D943A-D7BB-43DC-A09B-A85F2F355B1C}"/>
+                <a16:creationId xmlns:a16="http://schemas.microsoft.com/office/drawing/2014/main" id="{A9AD6374-3D56-43CC-B735-6C894CB8BBB4}"/>
               </a:ext>
             </a:extLst>
           </p:cNvPr>
@@ -2996,7 +2996,7 @@
           <p:cNvPr id="15" name="">
             <a:extLst xmlns:a="http://schemas.openxmlformats.org/drawingml/2006/main">
               <a:ext uri="{FF2B5EF4-FFF2-40B4-BE49-F238E27FC236}">
-                <a16:creationId xmlns:a16="http://schemas.microsoft.com/office/drawing/2014/main" id="{AE833655-4278-491F-A300-DC2548BDA58A}"/>
+                <a16:creationId xmlns:a16="http://schemas.microsoft.com/office/drawing/2014/main" id="{A0FE7C64-18C7-44DD-A379-A9A022BDB5A4}"/>
               </a:ext>
             </a:extLst>
           </p:cNvPr>
@@ -3060,7 +3060,7 @@
           <p:cNvPr id="16" name="">
             <a:extLst xmlns:a="http://schemas.openxmlformats.org/drawingml/2006/main">
               <a:ext uri="{FF2B5EF4-FFF2-40B4-BE49-F238E27FC236}">
-                <a16:creationId xmlns:a16="http://schemas.microsoft.com/office/drawing/2014/main" id="{C2C55566-8664-4D1B-8F18-BE7BB189849D}"/>
+                <a16:creationId xmlns:a16="http://schemas.microsoft.com/office/drawing/2014/main" id="{20485A3D-8BBA-4E6A-B312-9537FFB5E098}"/>
               </a:ext>
             </a:extLst>
           </p:cNvPr>
@@ -3095,7 +3095,7 @@
           <p:cNvPr id="17" name="">
             <a:extLst xmlns:a="http://schemas.openxmlformats.org/drawingml/2006/main">
               <a:ext uri="{FF2B5EF4-FFF2-40B4-BE49-F238E27FC236}">
-                <a16:creationId xmlns:a16="http://schemas.microsoft.com/office/drawing/2014/main" id="{5A493191-0EAB-4DAD-9478-39E889E011E6}"/>
+                <a16:creationId xmlns:a16="http://schemas.microsoft.com/office/drawing/2014/main" id="{AB7E19B3-156B-4C7B-A2DA-C466C176CE76}"/>
               </a:ext>
             </a:extLst>
           </p:cNvPr>
@@ -3130,7 +3130,7 @@
           <p:cNvPr id="18" name="">
             <a:extLst xmlns:a="http://schemas.openxmlformats.org/drawingml/2006/main">
               <a:ext uri="{FF2B5EF4-FFF2-40B4-BE49-F238E27FC236}">
-                <a16:creationId xmlns:a16="http://schemas.microsoft.com/office/drawing/2014/main" id="{523808CA-89FF-4ED2-A6B9-C9648A01243A}"/>
+                <a16:creationId xmlns:a16="http://schemas.microsoft.com/office/drawing/2014/main" id="{1E2A829A-15D3-495D-9CDE-535F73A36AD7}"/>
               </a:ext>
             </a:extLst>
           </p:cNvPr>
@@ -3165,7 +3165,7 @@
           <p:cNvPr id="19" name="">
             <a:extLst xmlns:a="http://schemas.openxmlformats.org/drawingml/2006/main">
               <a:ext uri="{FF2B5EF4-FFF2-40B4-BE49-F238E27FC236}">
-                <a16:creationId xmlns:a16="http://schemas.microsoft.com/office/drawing/2014/main" id="{14E6E8DD-C97A-4727-909E-8706645C03C1}"/>
+                <a16:creationId xmlns:a16="http://schemas.microsoft.com/office/drawing/2014/main" id="{FF9D7EF1-FCD4-43F2-8452-4C28850358A0}"/>
               </a:ext>
             </a:extLst>
           </p:cNvPr>
@@ -3229,7 +3229,7 @@
           <p:cNvPr id="20" name="">
             <a:extLst xmlns:a="http://schemas.openxmlformats.org/drawingml/2006/main">
               <a:ext uri="{FF2B5EF4-FFF2-40B4-BE49-F238E27FC236}">
-                <a16:creationId xmlns:a16="http://schemas.microsoft.com/office/drawing/2014/main" id="{6C618694-5654-46EC-91AC-F60C516EA207}"/>
+                <a16:creationId xmlns:a16="http://schemas.microsoft.com/office/drawing/2014/main" id="{77FD9FD0-FE80-4E7F-B536-240042BB0A96}"/>
               </a:ext>
             </a:extLst>
           </p:cNvPr>
@@ -3293,7 +3293,7 @@
           <p:cNvPr id="21" name="">
             <a:extLst xmlns:a="http://schemas.openxmlformats.org/drawingml/2006/main">
               <a:ext uri="{FF2B5EF4-FFF2-40B4-BE49-F238E27FC236}">
-                <a16:creationId xmlns:a16="http://schemas.microsoft.com/office/drawing/2014/main" id="{E8C249E2-F8D6-4098-9A03-B360B48D77E4}"/>
+                <a16:creationId xmlns:a16="http://schemas.microsoft.com/office/drawing/2014/main" id="{88496288-83D6-4280-AECC-164D2D834D70}"/>
               </a:ext>
             </a:extLst>
           </p:cNvPr>
@@ -3357,7 +3357,7 @@
           <p:cNvPr id="22" name="">
             <a:extLst xmlns:a="http://schemas.openxmlformats.org/drawingml/2006/main">
               <a:ext uri="{FF2B5EF4-FFF2-40B4-BE49-F238E27FC236}">
-                <a16:creationId xmlns:a16="http://schemas.microsoft.com/office/drawing/2014/main" id="{95147C3D-69EF-42A7-90C5-7F0C14A1CFE3}"/>
+                <a16:creationId xmlns:a16="http://schemas.microsoft.com/office/drawing/2014/main" id="{9291DDD0-C837-491F-8E53-63AF47E9A32E}"/>
               </a:ext>
             </a:extLst>
           </p:cNvPr>
@@ -3390,7 +3390,7 @@
           <p:cNvPr id="23" name="">
             <a:extLst xmlns:a="http://schemas.openxmlformats.org/drawingml/2006/main">
               <a:ext uri="{FF2B5EF4-FFF2-40B4-BE49-F238E27FC236}">
-                <a16:creationId xmlns:a16="http://schemas.microsoft.com/office/drawing/2014/main" id="{B78908A6-0C3F-4E1A-A033-E2776250FF5E}"/>
+                <a16:creationId xmlns:a16="http://schemas.microsoft.com/office/drawing/2014/main" id="{BFC97353-FFA6-4245-B965-9E1F7CCFFFAC}"/>
               </a:ext>
             </a:extLst>
           </p:cNvPr>
@@ -3454,7 +3454,7 @@
           <p:cNvPr id="24" name="">
             <a:extLst xmlns:a="http://schemas.openxmlformats.org/drawingml/2006/main">
               <a:ext uri="{FF2B5EF4-FFF2-40B4-BE49-F238E27FC236}">
-                <a16:creationId xmlns:a16="http://schemas.microsoft.com/office/drawing/2014/main" id="{49EDCB6B-1A02-4790-AE33-F719FEDA054E}"/>
+                <a16:creationId xmlns:a16="http://schemas.microsoft.com/office/drawing/2014/main" id="{3DB4E131-396A-4456-A818-8140369980E6}"/>
               </a:ext>
             </a:extLst>
           </p:cNvPr>
@@ -3541,7 +3541,7 @@
           <p:cNvPr id="25" name="">
             <a:extLst xmlns:a="http://schemas.openxmlformats.org/drawingml/2006/main">
               <a:ext uri="{FF2B5EF4-FFF2-40B4-BE49-F238E27FC236}">
-                <a16:creationId xmlns:a16="http://schemas.microsoft.com/office/drawing/2014/main" id="{4AFAB65B-FABF-428C-86D8-77C9EAABA63E}"/>
+                <a16:creationId xmlns:a16="http://schemas.microsoft.com/office/drawing/2014/main" id="{127EF5F4-C168-475C-95B4-9C359F8A010E}"/>
               </a:ext>
             </a:extLst>
           </p:cNvPr>
@@ -3576,7 +3576,7 @@
           <p:cNvPr id="26" name="">
             <a:extLst xmlns:a="http://schemas.openxmlformats.org/drawingml/2006/main">
               <a:ext uri="{FF2B5EF4-FFF2-40B4-BE49-F238E27FC236}">
-                <a16:creationId xmlns:a16="http://schemas.microsoft.com/office/drawing/2014/main" id="{5C52724F-A72F-467A-8048-1E87EA728C15}"/>
+                <a16:creationId xmlns:a16="http://schemas.microsoft.com/office/drawing/2014/main" id="{DC30ADD9-2F49-4700-9C33-199BB68BEDD9}"/>
               </a:ext>
             </a:extLst>
           </p:cNvPr>
@@ -3638,7 +3638,7 @@
     </p:spTree>
     <p:extLst>
       <p:ext uri="{BB962C8B-B14F-4D97-AF65-F5344CB8AC3E}">
-        <p14:creationId xmlns:p14="http://schemas.microsoft.com/office/powerpoint/2010/main" val="55718997"/>
+        <p14:creationId xmlns:p14="http://schemas.microsoft.com/office/powerpoint/2010/main" val="486129083"/>
       </p:ext>
     </p:extLst>
   </p:cSld>
@@ -3662,7 +3662,7 @@
           <p:cNvPr id="1" name="">
             <a:extLst xmlns:a="http://schemas.openxmlformats.org/drawingml/2006/main">
               <a:ext uri="{FF2B5EF4-FFF2-40B4-BE49-F238E27FC236}">
-                <a16:creationId xmlns:a16="http://schemas.microsoft.com/office/drawing/2014/main" id="{94915A1B-30FE-4B96-9740-4CC6C767C647}"/>
+                <a16:creationId xmlns:a16="http://schemas.microsoft.com/office/drawing/2014/main" id="{E62B5037-190E-4B7B-ADE9-AF73C30C7CDA}"/>
               </a:ext>
             </a:extLst>
           </p:cNvPr>
@@ -3697,7 +3697,7 @@
           <p:cNvPr id="2" name="kicker-marker">
             <a:extLst xmlns:a="http://schemas.openxmlformats.org/drawingml/2006/main">
               <a:ext uri="{FF2B5EF4-FFF2-40B4-BE49-F238E27FC236}">
-                <a16:creationId xmlns:a16="http://schemas.microsoft.com/office/drawing/2014/main" id="{3BD3005B-A87D-4628-8C7B-1F02D2F62C9C}"/>
+                <a16:creationId xmlns:a16="http://schemas.microsoft.com/office/drawing/2014/main" id="{BC2760DE-48F6-4BED-876F-474A27279266}"/>
               </a:ext>
             </a:extLst>
           </p:cNvPr>
@@ -3732,7 +3732,7 @@
           <p:cNvPr id="3" name="kicker-label">
             <a:extLst xmlns:a="http://schemas.openxmlformats.org/drawingml/2006/main">
               <a:ext uri="{FF2B5EF4-FFF2-40B4-BE49-F238E27FC236}">
-                <a16:creationId xmlns:a16="http://schemas.microsoft.com/office/drawing/2014/main" id="{05A049CB-9C33-4C52-A937-E3A75676D886}"/>
+                <a16:creationId xmlns:a16="http://schemas.microsoft.com/office/drawing/2014/main" id="{9E2C9177-9F5F-4E41-A2CB-935B7B345D33}"/>
               </a:ext>
             </a:extLst>
           </p:cNvPr>
@@ -3796,7 +3796,7 @@
           <p:cNvPr id="4" name="">
             <a:extLst xmlns:a="http://schemas.openxmlformats.org/drawingml/2006/main">
               <a:ext uri="{FF2B5EF4-FFF2-40B4-BE49-F238E27FC236}">
-                <a16:creationId xmlns:a16="http://schemas.microsoft.com/office/drawing/2014/main" id="{CBD1475C-B99B-4729-97FE-11E885C9EBED}"/>
+                <a16:creationId xmlns:a16="http://schemas.microsoft.com/office/drawing/2014/main" id="{A57896AB-51B3-4B14-9D7D-59803A98150B}"/>
               </a:ext>
             </a:extLst>
           </p:cNvPr>
@@ -3860,7 +3860,7 @@
           <p:cNvPr id="5" name="">
             <a:extLst xmlns:a="http://schemas.openxmlformats.org/drawingml/2006/main">
               <a:ext uri="{FF2B5EF4-FFF2-40B4-BE49-F238E27FC236}">
-                <a16:creationId xmlns:a16="http://schemas.microsoft.com/office/drawing/2014/main" id="{63A48E5F-72B8-4C8D-B7A7-A66E404E1253}"/>
+                <a16:creationId xmlns:a16="http://schemas.microsoft.com/office/drawing/2014/main" id="{1B1B1502-000E-4E43-9B6C-E04181F0E074}"/>
               </a:ext>
             </a:extLst>
           </p:cNvPr>
@@ -3895,7 +3895,7 @@
           <p:cNvPr id="6" name="">
             <a:extLst xmlns:a="http://schemas.openxmlformats.org/drawingml/2006/main">
               <a:ext uri="{FF2B5EF4-FFF2-40B4-BE49-F238E27FC236}">
-                <a16:creationId xmlns:a16="http://schemas.microsoft.com/office/drawing/2014/main" id="{8E204E9F-E3E4-4081-AF53-95832CCEF8BF}"/>
+                <a16:creationId xmlns:a16="http://schemas.microsoft.com/office/drawing/2014/main" id="{D6AE82B0-6E12-4427-886D-A862E22584DB}"/>
               </a:ext>
             </a:extLst>
           </p:cNvPr>
@@ -3959,7 +3959,7 @@
           <p:cNvPr id="7" name="">
             <a:extLst xmlns:a="http://schemas.openxmlformats.org/drawingml/2006/main">
               <a:ext uri="{FF2B5EF4-FFF2-40B4-BE49-F238E27FC236}">
-                <a16:creationId xmlns:a16="http://schemas.microsoft.com/office/drawing/2014/main" id="{69E43565-73E1-485E-BF88-E88B9562311A}"/>
+                <a16:creationId xmlns:a16="http://schemas.microsoft.com/office/drawing/2014/main" id="{DDAAD0EA-1437-4789-A933-F3EC4F56E0DC}"/>
               </a:ext>
             </a:extLst>
           </p:cNvPr>
@@ -3992,7 +3992,7 @@
           <p:cNvPr id="8" name="">
             <a:extLst xmlns:a="http://schemas.openxmlformats.org/drawingml/2006/main">
               <a:ext uri="{FF2B5EF4-FFF2-40B4-BE49-F238E27FC236}">
-                <a16:creationId xmlns:a16="http://schemas.microsoft.com/office/drawing/2014/main" id="{39B552D6-5A90-423F-9F74-35F2D17427F9}"/>
+                <a16:creationId xmlns:a16="http://schemas.microsoft.com/office/drawing/2014/main" id="{A607298D-D8B8-49C1-B263-138515B0DE29}"/>
               </a:ext>
             </a:extLst>
           </p:cNvPr>
@@ -4056,7 +4056,7 @@
           <p:cNvPr id="9" name="">
             <a:extLst xmlns:a="http://schemas.openxmlformats.org/drawingml/2006/main">
               <a:ext uri="{FF2B5EF4-FFF2-40B4-BE49-F238E27FC236}">
-                <a16:creationId xmlns:a16="http://schemas.microsoft.com/office/drawing/2014/main" id="{6BE73ECC-CC27-42CF-8344-21FBA89912B9}"/>
+                <a16:creationId xmlns:a16="http://schemas.microsoft.com/office/drawing/2014/main" id="{BFE8CE02-3123-447F-85F8-FAD515F28B2D}"/>
               </a:ext>
             </a:extLst>
           </p:cNvPr>
@@ -4120,7 +4120,7 @@
           <p:cNvPr id="10" name="">
             <a:extLst xmlns:a="http://schemas.openxmlformats.org/drawingml/2006/main">
               <a:ext uri="{FF2B5EF4-FFF2-40B4-BE49-F238E27FC236}">
-                <a16:creationId xmlns:a16="http://schemas.microsoft.com/office/drawing/2014/main" id="{3D0CD225-F239-42A2-BDA5-F8E98099C0EC}"/>
+                <a16:creationId xmlns:a16="http://schemas.microsoft.com/office/drawing/2014/main" id="{5667D1FF-EF79-437B-82E1-728998D2B9F1}"/>
               </a:ext>
             </a:extLst>
           </p:cNvPr>
@@ -4184,7 +4184,7 @@
           <p:cNvPr id="11" name="">
             <a:extLst xmlns:a="http://schemas.openxmlformats.org/drawingml/2006/main">
               <a:ext uri="{FF2B5EF4-FFF2-40B4-BE49-F238E27FC236}">
-                <a16:creationId xmlns:a16="http://schemas.microsoft.com/office/drawing/2014/main" id="{ADA3A42D-6A07-4C04-8256-145FF1ED1EF8}"/>
+                <a16:creationId xmlns:a16="http://schemas.microsoft.com/office/drawing/2014/main" id="{D5F1483B-8773-478A-BBB0-F87E2427FF75}"/>
               </a:ext>
             </a:extLst>
           </p:cNvPr>
@@ -4219,7 +4219,7 @@
           <p:cNvPr id="12" name="">
             <a:extLst xmlns:a="http://schemas.openxmlformats.org/drawingml/2006/main">
               <a:ext uri="{FF2B5EF4-FFF2-40B4-BE49-F238E27FC236}">
-                <a16:creationId xmlns:a16="http://schemas.microsoft.com/office/drawing/2014/main" id="{830A27C2-0FEA-4271-86D7-39E31B3174BC}"/>
+                <a16:creationId xmlns:a16="http://schemas.microsoft.com/office/drawing/2014/main" id="{A9DE2D77-F838-4655-B7BA-5A30E4B907BD}"/>
               </a:ext>
             </a:extLst>
           </p:cNvPr>
@@ -4254,7 +4254,7 @@
           <p:cNvPr id="13" name="">
             <a:extLst xmlns:a="http://schemas.openxmlformats.org/drawingml/2006/main">
               <a:ext uri="{FF2B5EF4-FFF2-40B4-BE49-F238E27FC236}">
-                <a16:creationId xmlns:a16="http://schemas.microsoft.com/office/drawing/2014/main" id="{D4E5C55E-28F9-4CA4-9D54-E9FD7749112E}"/>
+                <a16:creationId xmlns:a16="http://schemas.microsoft.com/office/drawing/2014/main" id="{6665A379-DEC4-4484-A970-15FB62603F67}"/>
               </a:ext>
             </a:extLst>
           </p:cNvPr>
@@ -4287,7 +4287,7 @@
           <p:cNvPr id="14" name="">
             <a:extLst xmlns:a="http://schemas.openxmlformats.org/drawingml/2006/main">
               <a:ext uri="{FF2B5EF4-FFF2-40B4-BE49-F238E27FC236}">
-                <a16:creationId xmlns:a16="http://schemas.microsoft.com/office/drawing/2014/main" id="{E453FDF9-D0A8-4FF7-BF6F-E9BE2E878864}"/>
+                <a16:creationId xmlns:a16="http://schemas.microsoft.com/office/drawing/2014/main" id="{43F390EA-4150-4906-9ED6-4A10064274CF}"/>
               </a:ext>
             </a:extLst>
           </p:cNvPr>
@@ -4351,7 +4351,7 @@
           <p:cNvPr id="15" name="">
             <a:extLst xmlns:a="http://schemas.openxmlformats.org/drawingml/2006/main">
               <a:ext uri="{FF2B5EF4-FFF2-40B4-BE49-F238E27FC236}">
-                <a16:creationId xmlns:a16="http://schemas.microsoft.com/office/drawing/2014/main" id="{D755C995-CF7C-4059-8744-E87E0C4A384E}"/>
+                <a16:creationId xmlns:a16="http://schemas.microsoft.com/office/drawing/2014/main" id="{0A66EF9A-B8C1-4D62-AE5A-35585F9EE69D}"/>
               </a:ext>
             </a:extLst>
           </p:cNvPr>
@@ -4415,7 +4415,7 @@
           <p:cNvPr id="16" name="">
             <a:extLst xmlns:a="http://schemas.openxmlformats.org/drawingml/2006/main">
               <a:ext uri="{FF2B5EF4-FFF2-40B4-BE49-F238E27FC236}">
-                <a16:creationId xmlns:a16="http://schemas.microsoft.com/office/drawing/2014/main" id="{E08FB254-B4AC-4C3B-8961-E870E61D3D36}"/>
+                <a16:creationId xmlns:a16="http://schemas.microsoft.com/office/drawing/2014/main" id="{A482479D-71C2-42C2-BA0D-FEB7BF042CF1}"/>
               </a:ext>
             </a:extLst>
           </p:cNvPr>
@@ -4479,7 +4479,7 @@
           <p:cNvPr id="17" name="">
             <a:extLst xmlns:a="http://schemas.openxmlformats.org/drawingml/2006/main">
               <a:ext uri="{FF2B5EF4-FFF2-40B4-BE49-F238E27FC236}">
-                <a16:creationId xmlns:a16="http://schemas.microsoft.com/office/drawing/2014/main" id="{CE53234A-9CF3-42B0-81A1-6208D74DA919}"/>
+                <a16:creationId xmlns:a16="http://schemas.microsoft.com/office/drawing/2014/main" id="{220DBA3A-69A9-4273-AC8C-E9EAD077C7D6}"/>
               </a:ext>
             </a:extLst>
           </p:cNvPr>
@@ -4514,7 +4514,7 @@
           <p:cNvPr id="18" name="">
             <a:extLst xmlns:a="http://schemas.openxmlformats.org/drawingml/2006/main">
               <a:ext uri="{FF2B5EF4-FFF2-40B4-BE49-F238E27FC236}">
-                <a16:creationId xmlns:a16="http://schemas.microsoft.com/office/drawing/2014/main" id="{84593869-9B03-45B1-BFE1-7D55EF019DFA}"/>
+                <a16:creationId xmlns:a16="http://schemas.microsoft.com/office/drawing/2014/main" id="{F7CE41F8-B3FC-4E4B-82E7-1F9BF90CB2F8}"/>
               </a:ext>
             </a:extLst>
           </p:cNvPr>
@@ -4549,7 +4549,7 @@
           <p:cNvPr id="19" name="">
             <a:extLst xmlns:a="http://schemas.openxmlformats.org/drawingml/2006/main">
               <a:ext uri="{FF2B5EF4-FFF2-40B4-BE49-F238E27FC236}">
-                <a16:creationId xmlns:a16="http://schemas.microsoft.com/office/drawing/2014/main" id="{A4E764F3-5405-4FAB-9563-53274058DC5D}"/>
+                <a16:creationId xmlns:a16="http://schemas.microsoft.com/office/drawing/2014/main" id="{DAB0B1A3-F033-400A-8750-6EE0786E11DC}"/>
               </a:ext>
             </a:extLst>
           </p:cNvPr>
@@ -4582,7 +4582,7 @@
           <p:cNvPr id="20" name="">
             <a:extLst xmlns:a="http://schemas.openxmlformats.org/drawingml/2006/main">
               <a:ext uri="{FF2B5EF4-FFF2-40B4-BE49-F238E27FC236}">
-                <a16:creationId xmlns:a16="http://schemas.microsoft.com/office/drawing/2014/main" id="{841F84AB-0B8C-4735-9919-79FD961DB936}"/>
+                <a16:creationId xmlns:a16="http://schemas.microsoft.com/office/drawing/2014/main" id="{697781FA-E005-4772-9815-4168AA63C2A1}"/>
               </a:ext>
             </a:extLst>
           </p:cNvPr>
@@ -4646,7 +4646,7 @@
           <p:cNvPr id="21" name="">
             <a:extLst xmlns:a="http://schemas.openxmlformats.org/drawingml/2006/main">
               <a:ext uri="{FF2B5EF4-FFF2-40B4-BE49-F238E27FC236}">
-                <a16:creationId xmlns:a16="http://schemas.microsoft.com/office/drawing/2014/main" id="{754E0184-43A5-449C-A347-13FA6D51EB55}"/>
+                <a16:creationId xmlns:a16="http://schemas.microsoft.com/office/drawing/2014/main" id="{DDA5E6D4-5438-400C-B746-C0203CC7B403}"/>
               </a:ext>
             </a:extLst>
           </p:cNvPr>
@@ -4710,7 +4710,7 @@
           <p:cNvPr id="22" name="">
             <a:extLst xmlns:a="http://schemas.openxmlformats.org/drawingml/2006/main">
               <a:ext uri="{FF2B5EF4-FFF2-40B4-BE49-F238E27FC236}">
-                <a16:creationId xmlns:a16="http://schemas.microsoft.com/office/drawing/2014/main" id="{F2EDB626-00D1-4F61-937D-3A0C54C456C6}"/>
+                <a16:creationId xmlns:a16="http://schemas.microsoft.com/office/drawing/2014/main" id="{477C5383-D362-41D7-8D7B-4739A411B073}"/>
               </a:ext>
             </a:extLst>
           </p:cNvPr>
@@ -4774,7 +4774,7 @@
           <p:cNvPr id="23" name="">
             <a:extLst xmlns:a="http://schemas.openxmlformats.org/drawingml/2006/main">
               <a:ext uri="{FF2B5EF4-FFF2-40B4-BE49-F238E27FC236}">
-                <a16:creationId xmlns:a16="http://schemas.microsoft.com/office/drawing/2014/main" id="{B2D6585A-7E26-408E-8CFE-0F6E0E23C150}"/>
+                <a16:creationId xmlns:a16="http://schemas.microsoft.com/office/drawing/2014/main" id="{492FE10C-AFC8-4F47-9F6A-A52AEED37928}"/>
               </a:ext>
             </a:extLst>
           </p:cNvPr>
@@ -4809,7 +4809,7 @@
           <p:cNvPr id="24" name="">
             <a:extLst xmlns:a="http://schemas.openxmlformats.org/drawingml/2006/main">
               <a:ext uri="{FF2B5EF4-FFF2-40B4-BE49-F238E27FC236}">
-                <a16:creationId xmlns:a16="http://schemas.microsoft.com/office/drawing/2014/main" id="{4415ECAA-7EDB-4D5B-84FD-CCF8B7FB6817}"/>
+                <a16:creationId xmlns:a16="http://schemas.microsoft.com/office/drawing/2014/main" id="{A57C9062-CDDC-42D4-8B7C-06D94C4E8688}"/>
               </a:ext>
             </a:extLst>
           </p:cNvPr>
@@ -4844,7 +4844,7 @@
           <p:cNvPr id="25" name="">
             <a:extLst xmlns:a="http://schemas.openxmlformats.org/drawingml/2006/main">
               <a:ext uri="{FF2B5EF4-FFF2-40B4-BE49-F238E27FC236}">
-                <a16:creationId xmlns:a16="http://schemas.microsoft.com/office/drawing/2014/main" id="{FE88E21C-7152-491D-ADC3-B78DF56552E9}"/>
+                <a16:creationId xmlns:a16="http://schemas.microsoft.com/office/drawing/2014/main" id="{5472F43C-05F4-47AB-875E-B5B1E45E6C7E}"/>
               </a:ext>
             </a:extLst>
           </p:cNvPr>
@@ -4877,7 +4877,7 @@
           <p:cNvPr id="26" name="">
             <a:extLst xmlns:a="http://schemas.openxmlformats.org/drawingml/2006/main">
               <a:ext uri="{FF2B5EF4-FFF2-40B4-BE49-F238E27FC236}">
-                <a16:creationId xmlns:a16="http://schemas.microsoft.com/office/drawing/2014/main" id="{D9A6BAE7-DE3F-4B8E-94EB-388E7D3C47DB}"/>
+                <a16:creationId xmlns:a16="http://schemas.microsoft.com/office/drawing/2014/main" id="{A31C6B17-3665-476D-9E87-A8E366C1D7DB}"/>
               </a:ext>
             </a:extLst>
           </p:cNvPr>
@@ -4941,7 +4941,7 @@
           <p:cNvPr id="27" name="">
             <a:extLst xmlns:a="http://schemas.openxmlformats.org/drawingml/2006/main">
               <a:ext uri="{FF2B5EF4-FFF2-40B4-BE49-F238E27FC236}">
-                <a16:creationId xmlns:a16="http://schemas.microsoft.com/office/drawing/2014/main" id="{DCA4DEC9-18D2-4726-84FC-E5CF0B06F801}"/>
+                <a16:creationId xmlns:a16="http://schemas.microsoft.com/office/drawing/2014/main" id="{420E6898-F15B-41B8-99E5-E6E101A967E3}"/>
               </a:ext>
             </a:extLst>
           </p:cNvPr>
@@ -5005,7 +5005,7 @@
           <p:cNvPr id="28" name="">
             <a:extLst xmlns:a="http://schemas.openxmlformats.org/drawingml/2006/main">
               <a:ext uri="{FF2B5EF4-FFF2-40B4-BE49-F238E27FC236}">
-                <a16:creationId xmlns:a16="http://schemas.microsoft.com/office/drawing/2014/main" id="{5DAC62F0-30E1-4FCB-A8A2-3D49D42B58C5}"/>
+                <a16:creationId xmlns:a16="http://schemas.microsoft.com/office/drawing/2014/main" id="{A3454210-D56A-46F8-A695-CF640A4A3C32}"/>
               </a:ext>
             </a:extLst>
           </p:cNvPr>
@@ -5069,7 +5069,7 @@
           <p:cNvPr id="29" name="">
             <a:extLst xmlns:a="http://schemas.openxmlformats.org/drawingml/2006/main">
               <a:ext uri="{FF2B5EF4-FFF2-40B4-BE49-F238E27FC236}">
-                <a16:creationId xmlns:a16="http://schemas.microsoft.com/office/drawing/2014/main" id="{B5591A7E-84DF-4C79-913E-AE00763937EA}"/>
+                <a16:creationId xmlns:a16="http://schemas.microsoft.com/office/drawing/2014/main" id="{991148C4-48F5-4994-A99E-1FCB97A30EC3}"/>
               </a:ext>
             </a:extLst>
           </p:cNvPr>
@@ -5131,7 +5131,7 @@
     </p:spTree>
     <p:extLst>
       <p:ext uri="{BB962C8B-B14F-4D97-AF65-F5344CB8AC3E}">
-        <p14:creationId xmlns:p14="http://schemas.microsoft.com/office/powerpoint/2010/main" val="748237965"/>
+        <p14:creationId xmlns:p14="http://schemas.microsoft.com/office/powerpoint/2010/main" val="1151289259"/>
       </p:ext>
     </p:extLst>
   </p:cSld>
@@ -5155,7 +5155,7 @@
           <p:cNvPr id="1" name="">
             <a:extLst xmlns:a="http://schemas.openxmlformats.org/drawingml/2006/main">
               <a:ext uri="{FF2B5EF4-FFF2-40B4-BE49-F238E27FC236}">
-                <a16:creationId xmlns:a16="http://schemas.microsoft.com/office/drawing/2014/main" id="{FFDC7DA2-D411-44B9-916F-FBD1D828CA8D}"/>
+                <a16:creationId xmlns:a16="http://schemas.microsoft.com/office/drawing/2014/main" id="{1E1F89CC-7F07-4B35-8743-76AC9DEB345A}"/>
               </a:ext>
             </a:extLst>
           </p:cNvPr>
@@ -5190,7 +5190,7 @@
           <p:cNvPr id="2" name="kicker-marker">
             <a:extLst xmlns:a="http://schemas.openxmlformats.org/drawingml/2006/main">
               <a:ext uri="{FF2B5EF4-FFF2-40B4-BE49-F238E27FC236}">
-                <a16:creationId xmlns:a16="http://schemas.microsoft.com/office/drawing/2014/main" id="{48A4F569-6BAE-4D4D-AD26-6351D7D6C284}"/>
+                <a16:creationId xmlns:a16="http://schemas.microsoft.com/office/drawing/2014/main" id="{CBA9171B-57AC-44AE-888B-7615CF9615D0}"/>
               </a:ext>
             </a:extLst>
           </p:cNvPr>
@@ -5225,7 +5225,7 @@
           <p:cNvPr id="3" name="kicker-label">
             <a:extLst xmlns:a="http://schemas.openxmlformats.org/drawingml/2006/main">
               <a:ext uri="{FF2B5EF4-FFF2-40B4-BE49-F238E27FC236}">
-                <a16:creationId xmlns:a16="http://schemas.microsoft.com/office/drawing/2014/main" id="{0FD3262F-8E11-4967-87C3-876A64EC7E8A}"/>
+                <a16:creationId xmlns:a16="http://schemas.microsoft.com/office/drawing/2014/main" id="{1CC0EC12-C9A2-40C8-A1CB-E1D065CE80A7}"/>
               </a:ext>
             </a:extLst>
           </p:cNvPr>
@@ -5289,7 +5289,7 @@
           <p:cNvPr id="4" name="">
             <a:extLst xmlns:a="http://schemas.openxmlformats.org/drawingml/2006/main">
               <a:ext uri="{FF2B5EF4-FFF2-40B4-BE49-F238E27FC236}">
-                <a16:creationId xmlns:a16="http://schemas.microsoft.com/office/drawing/2014/main" id="{AD9F5D97-9E81-4DEA-A233-7FAD48E719CA}"/>
+                <a16:creationId xmlns:a16="http://schemas.microsoft.com/office/drawing/2014/main" id="{8730C888-AF9A-442F-9CDB-CC0BB8DF52FE}"/>
               </a:ext>
             </a:extLst>
           </p:cNvPr>
@@ -5353,7 +5353,7 @@
           <p:cNvPr id="5" name="">
             <a:extLst xmlns:a="http://schemas.openxmlformats.org/drawingml/2006/main">
               <a:ext uri="{FF2B5EF4-FFF2-40B4-BE49-F238E27FC236}">
-                <a16:creationId xmlns:a16="http://schemas.microsoft.com/office/drawing/2014/main" id="{D654C9CF-0982-4DBB-A0CD-0EA44482E059}"/>
+                <a16:creationId xmlns:a16="http://schemas.microsoft.com/office/drawing/2014/main" id="{23DE7BD0-01DF-468B-8706-828BCEC4BC22}"/>
               </a:ext>
             </a:extLst>
           </p:cNvPr>
@@ -5388,7 +5388,7 @@
           <p:cNvPr id="6" name="">
             <a:extLst xmlns:a="http://schemas.openxmlformats.org/drawingml/2006/main">
               <a:ext uri="{FF2B5EF4-FFF2-40B4-BE49-F238E27FC236}">
-                <a16:creationId xmlns:a16="http://schemas.microsoft.com/office/drawing/2014/main" id="{B6F1D055-4A33-4354-8BC4-C61BDD1D47B0}"/>
+                <a16:creationId xmlns:a16="http://schemas.microsoft.com/office/drawing/2014/main" id="{4ED2F318-E093-4971-BA72-77255A10852F}"/>
               </a:ext>
             </a:extLst>
           </p:cNvPr>
@@ -5452,7 +5452,7 @@
           <p:cNvPr id="7" name="">
             <a:extLst xmlns:a="http://schemas.openxmlformats.org/drawingml/2006/main">
               <a:ext uri="{FF2B5EF4-FFF2-40B4-BE49-F238E27FC236}">
-                <a16:creationId xmlns:a16="http://schemas.microsoft.com/office/drawing/2014/main" id="{862F63BF-C9D0-434E-891F-6C4B65895459}"/>
+                <a16:creationId xmlns:a16="http://schemas.microsoft.com/office/drawing/2014/main" id="{A1CD6146-1955-4003-8F9F-944535273713}"/>
               </a:ext>
             </a:extLst>
           </p:cNvPr>
@@ -5516,7 +5516,7 @@
           <p:cNvPr id="8" name="">
             <a:extLst xmlns:a="http://schemas.openxmlformats.org/drawingml/2006/main">
               <a:ext uri="{FF2B5EF4-FFF2-40B4-BE49-F238E27FC236}">
-                <a16:creationId xmlns:a16="http://schemas.microsoft.com/office/drawing/2014/main" id="{C39B6A33-BF79-4560-B780-477A6CBF01BE}"/>
+                <a16:creationId xmlns:a16="http://schemas.microsoft.com/office/drawing/2014/main" id="{4D00D0B8-7BF2-4D69-83B0-3337A2D54E50}"/>
               </a:ext>
             </a:extLst>
           </p:cNvPr>
@@ -5580,7 +5580,7 @@
           <p:cNvPr id="9" name="">
             <a:extLst xmlns:a="http://schemas.openxmlformats.org/drawingml/2006/main">
               <a:ext uri="{FF2B5EF4-FFF2-40B4-BE49-F238E27FC236}">
-                <a16:creationId xmlns:a16="http://schemas.microsoft.com/office/drawing/2014/main" id="{6B3F58B4-96D1-4F3D-80FD-6E09EC33C143}"/>
+                <a16:creationId xmlns:a16="http://schemas.microsoft.com/office/drawing/2014/main" id="{54B06CE2-3B9A-4D55-913A-F5D53F8C5554}"/>
               </a:ext>
             </a:extLst>
           </p:cNvPr>
@@ -5615,7 +5615,7 @@
           <p:cNvPr id="10" name="">
             <a:extLst xmlns:a="http://schemas.openxmlformats.org/drawingml/2006/main">
               <a:ext uri="{FF2B5EF4-FFF2-40B4-BE49-F238E27FC236}">
-                <a16:creationId xmlns:a16="http://schemas.microsoft.com/office/drawing/2014/main" id="{E411156E-763D-4595-AC25-F04D6A4B0501}"/>
+                <a16:creationId xmlns:a16="http://schemas.microsoft.com/office/drawing/2014/main" id="{775CD230-A3A1-4149-8D27-EBE53E2B7318}"/>
               </a:ext>
             </a:extLst>
           </p:cNvPr>
@@ -5650,7 +5650,7 @@
           <p:cNvPr id="11" name="">
             <a:extLst xmlns:a="http://schemas.openxmlformats.org/drawingml/2006/main">
               <a:ext uri="{FF2B5EF4-FFF2-40B4-BE49-F238E27FC236}">
-                <a16:creationId xmlns:a16="http://schemas.microsoft.com/office/drawing/2014/main" id="{DF68FAF8-5886-481C-B5A3-687B65B28763}"/>
+                <a16:creationId xmlns:a16="http://schemas.microsoft.com/office/drawing/2014/main" id="{04141469-8D60-4CAA-A507-B3918CC0050E}"/>
               </a:ext>
             </a:extLst>
           </p:cNvPr>
@@ -5714,7 +5714,7 @@
           <p:cNvPr id="12" name="">
             <a:extLst xmlns:a="http://schemas.openxmlformats.org/drawingml/2006/main">
               <a:ext uri="{FF2B5EF4-FFF2-40B4-BE49-F238E27FC236}">
-                <a16:creationId xmlns:a16="http://schemas.microsoft.com/office/drawing/2014/main" id="{5B8587C2-F431-47D6-A84C-3690A0B0438E}"/>
+                <a16:creationId xmlns:a16="http://schemas.microsoft.com/office/drawing/2014/main" id="{145364E4-0F99-4E6A-B9FC-A5C8ED80CC20}"/>
               </a:ext>
             </a:extLst>
           </p:cNvPr>
@@ -5778,7 +5778,7 @@
           <p:cNvPr id="13" name="">
             <a:extLst xmlns:a="http://schemas.openxmlformats.org/drawingml/2006/main">
               <a:ext uri="{FF2B5EF4-FFF2-40B4-BE49-F238E27FC236}">
-                <a16:creationId xmlns:a16="http://schemas.microsoft.com/office/drawing/2014/main" id="{12A306FD-51B6-4DBD-9DDE-8C76B71C6646}"/>
+                <a16:creationId xmlns:a16="http://schemas.microsoft.com/office/drawing/2014/main" id="{FE9AB68B-F412-41DD-A85F-1B32770D0ED3}"/>
               </a:ext>
             </a:extLst>
           </p:cNvPr>
@@ -5813,7 +5813,7 @@
           <p:cNvPr id="14" name="">
             <a:extLst xmlns:a="http://schemas.openxmlformats.org/drawingml/2006/main">
               <a:ext uri="{FF2B5EF4-FFF2-40B4-BE49-F238E27FC236}">
-                <a16:creationId xmlns:a16="http://schemas.microsoft.com/office/drawing/2014/main" id="{BE5D1B1D-7ACD-4050-88C9-768431CFEF6E}"/>
+                <a16:creationId xmlns:a16="http://schemas.microsoft.com/office/drawing/2014/main" id="{FC7F7A75-AC61-4DFD-BD59-B1EEF65B788A}"/>
               </a:ext>
             </a:extLst>
           </p:cNvPr>
@@ -5848,7 +5848,7 @@
           <p:cNvPr id="15" name="">
             <a:extLst xmlns:a="http://schemas.openxmlformats.org/drawingml/2006/main">
               <a:ext uri="{FF2B5EF4-FFF2-40B4-BE49-F238E27FC236}">
-                <a16:creationId xmlns:a16="http://schemas.microsoft.com/office/drawing/2014/main" id="{4658C2F3-5546-4424-937D-7309C40E296D}"/>
+                <a16:creationId xmlns:a16="http://schemas.microsoft.com/office/drawing/2014/main" id="{17C9D48B-6D90-414E-85B8-56C74F81E5E9}"/>
               </a:ext>
             </a:extLst>
           </p:cNvPr>
@@ -5912,7 +5912,7 @@
           <p:cNvPr id="16" name="">
             <a:extLst xmlns:a="http://schemas.openxmlformats.org/drawingml/2006/main">
               <a:ext uri="{FF2B5EF4-FFF2-40B4-BE49-F238E27FC236}">
-                <a16:creationId xmlns:a16="http://schemas.microsoft.com/office/drawing/2014/main" id="{84374AD6-A5CD-4FA5-9BA3-A54D48C9EDB9}"/>
+                <a16:creationId xmlns:a16="http://schemas.microsoft.com/office/drawing/2014/main" id="{79C2F6D5-1C63-4694-889E-ED3DA9271B0A}"/>
               </a:ext>
             </a:extLst>
           </p:cNvPr>
@@ -5947,7 +5947,7 @@
           <p:cNvPr id="17" name="">
             <a:extLst xmlns:a="http://schemas.openxmlformats.org/drawingml/2006/main">
               <a:ext uri="{FF2B5EF4-FFF2-40B4-BE49-F238E27FC236}">
-                <a16:creationId xmlns:a16="http://schemas.microsoft.com/office/drawing/2014/main" id="{313C44E2-6CD7-4B76-89D4-7843B15F564B}"/>
+                <a16:creationId xmlns:a16="http://schemas.microsoft.com/office/drawing/2014/main" id="{2B47646A-55D3-499C-B96C-D15142ABAC82}"/>
               </a:ext>
             </a:extLst>
           </p:cNvPr>
@@ -6011,7 +6011,7 @@
           <p:cNvPr id="18" name="">
             <a:extLst xmlns:a="http://schemas.openxmlformats.org/drawingml/2006/main">
               <a:ext uri="{FF2B5EF4-FFF2-40B4-BE49-F238E27FC236}">
-                <a16:creationId xmlns:a16="http://schemas.microsoft.com/office/drawing/2014/main" id="{A3B4B657-A4BC-4366-864A-FA03B9B27EE0}"/>
+                <a16:creationId xmlns:a16="http://schemas.microsoft.com/office/drawing/2014/main" id="{4814E0A1-F721-4284-832B-C33AF6B79AE0}"/>
               </a:ext>
             </a:extLst>
           </p:cNvPr>
@@ -6046,7 +6046,7 @@
           <p:cNvPr id="19" name="">
             <a:extLst xmlns:a="http://schemas.openxmlformats.org/drawingml/2006/main">
               <a:ext uri="{FF2B5EF4-FFF2-40B4-BE49-F238E27FC236}">
-                <a16:creationId xmlns:a16="http://schemas.microsoft.com/office/drawing/2014/main" id="{A80C2529-FF02-4AA7-9EB6-AC34A27DCB92}"/>
+                <a16:creationId xmlns:a16="http://schemas.microsoft.com/office/drawing/2014/main" id="{B127D455-7555-475D-A449-312D21FBCD0F}"/>
               </a:ext>
             </a:extLst>
           </p:cNvPr>
@@ -6110,7 +6110,7 @@
           <p:cNvPr id="20" name="">
             <a:extLst xmlns:a="http://schemas.openxmlformats.org/drawingml/2006/main">
               <a:ext uri="{FF2B5EF4-FFF2-40B4-BE49-F238E27FC236}">
-                <a16:creationId xmlns:a16="http://schemas.microsoft.com/office/drawing/2014/main" id="{D98ABA01-6DDD-4B21-99AD-6059F518A22F}"/>
+                <a16:creationId xmlns:a16="http://schemas.microsoft.com/office/drawing/2014/main" id="{C8BE6BA5-820F-40CA-BBC2-B2278047B555}"/>
               </a:ext>
             </a:extLst>
           </p:cNvPr>
@@ -6145,7 +6145,7 @@
           <p:cNvPr id="21" name="">
             <a:extLst xmlns:a="http://schemas.openxmlformats.org/drawingml/2006/main">
               <a:ext uri="{FF2B5EF4-FFF2-40B4-BE49-F238E27FC236}">
-                <a16:creationId xmlns:a16="http://schemas.microsoft.com/office/drawing/2014/main" id="{925286AB-4A53-40E7-AA80-EEE738B5A5F3}"/>
+                <a16:creationId xmlns:a16="http://schemas.microsoft.com/office/drawing/2014/main" id="{207284A7-3F94-4413-84F7-171EE175C5F9}"/>
               </a:ext>
             </a:extLst>
           </p:cNvPr>
@@ -6209,7 +6209,7 @@
           <p:cNvPr id="22" name="">
             <a:extLst xmlns:a="http://schemas.openxmlformats.org/drawingml/2006/main">
               <a:ext uri="{FF2B5EF4-FFF2-40B4-BE49-F238E27FC236}">
-                <a16:creationId xmlns:a16="http://schemas.microsoft.com/office/drawing/2014/main" id="{E47F8460-C050-4374-A02A-4F62E969C628}"/>
+                <a16:creationId xmlns:a16="http://schemas.microsoft.com/office/drawing/2014/main" id="{F8939AB0-EBC9-4F9C-86EF-A9D6F4509E3A}"/>
               </a:ext>
             </a:extLst>
           </p:cNvPr>
@@ -6244,7 +6244,7 @@
           <p:cNvPr id="23" name="">
             <a:extLst xmlns:a="http://schemas.openxmlformats.org/drawingml/2006/main">
               <a:ext uri="{FF2B5EF4-FFF2-40B4-BE49-F238E27FC236}">
-                <a16:creationId xmlns:a16="http://schemas.microsoft.com/office/drawing/2014/main" id="{0CDE7962-010F-43CC-9C33-2756630B8C47}"/>
+                <a16:creationId xmlns:a16="http://schemas.microsoft.com/office/drawing/2014/main" id="{D6FE3EF9-E77B-45D0-8F1A-D06204AC5458}"/>
               </a:ext>
             </a:extLst>
           </p:cNvPr>
@@ -6308,7 +6308,7 @@
           <p:cNvPr id="24" name="">
             <a:extLst xmlns:a="http://schemas.openxmlformats.org/drawingml/2006/main">
               <a:ext uri="{FF2B5EF4-FFF2-40B4-BE49-F238E27FC236}">
-                <a16:creationId xmlns:a16="http://schemas.microsoft.com/office/drawing/2014/main" id="{38912602-77E8-42C2-8D9B-BEA1CEBF3F4F}"/>
+                <a16:creationId xmlns:a16="http://schemas.microsoft.com/office/drawing/2014/main" id="{70B68AC5-63D6-4DC1-A6D4-84C14B6DD59B}"/>
               </a:ext>
             </a:extLst>
           </p:cNvPr>
@@ -6343,7 +6343,7 @@
           <p:cNvPr id="25" name="">
             <a:extLst xmlns:a="http://schemas.openxmlformats.org/drawingml/2006/main">
               <a:ext uri="{FF2B5EF4-FFF2-40B4-BE49-F238E27FC236}">
-                <a16:creationId xmlns:a16="http://schemas.microsoft.com/office/drawing/2014/main" id="{36328908-FB98-4380-BB99-AFC1E374911E}"/>
+                <a16:creationId xmlns:a16="http://schemas.microsoft.com/office/drawing/2014/main" id="{ABD77FC0-25D0-4B5D-A1A2-84F4D7CBC4E9}"/>
               </a:ext>
             </a:extLst>
           </p:cNvPr>
@@ -6407,7 +6407,7 @@
           <p:cNvPr id="26" name="">
             <a:extLst xmlns:a="http://schemas.openxmlformats.org/drawingml/2006/main">
               <a:ext uri="{FF2B5EF4-FFF2-40B4-BE49-F238E27FC236}">
-                <a16:creationId xmlns:a16="http://schemas.microsoft.com/office/drawing/2014/main" id="{0DF1E553-B28B-41B5-85FF-24E9FC6D62C8}"/>
+                <a16:creationId xmlns:a16="http://schemas.microsoft.com/office/drawing/2014/main" id="{1595EB4E-F4CA-4AA7-8442-396B7C812B4E}"/>
               </a:ext>
             </a:extLst>
           </p:cNvPr>
@@ -6492,7 +6492,7 @@
     </p:spTree>
     <p:extLst>
       <p:ext uri="{BB962C8B-B14F-4D97-AF65-F5344CB8AC3E}">
-        <p14:creationId xmlns:p14="http://schemas.microsoft.com/office/powerpoint/2010/main" val="190482761"/>
+        <p14:creationId xmlns:p14="http://schemas.microsoft.com/office/powerpoint/2010/main" val="1836185449"/>
       </p:ext>
     </p:extLst>
   </p:cSld>
@@ -6516,7 +6516,7 @@
           <p:cNvPr id="1" name="">
             <a:extLst xmlns:a="http://schemas.openxmlformats.org/drawingml/2006/main">
               <a:ext uri="{FF2B5EF4-FFF2-40B4-BE49-F238E27FC236}">
-                <a16:creationId xmlns:a16="http://schemas.microsoft.com/office/drawing/2014/main" id="{E28EA699-2945-4C5B-85E4-30BDF29F5C2D}"/>
+                <a16:creationId xmlns:a16="http://schemas.microsoft.com/office/drawing/2014/main" id="{A5669E92-EA6E-4371-A479-503AD75ABABF}"/>
               </a:ext>
             </a:extLst>
           </p:cNvPr>
@@ -6551,7 +6551,7 @@
           <p:cNvPr id="2" name="kicker-marker">
             <a:extLst xmlns:a="http://schemas.openxmlformats.org/drawingml/2006/main">
               <a:ext uri="{FF2B5EF4-FFF2-40B4-BE49-F238E27FC236}">
-                <a16:creationId xmlns:a16="http://schemas.microsoft.com/office/drawing/2014/main" id="{7DB8F06D-EC37-4032-B9F0-E5B96710F808}"/>
+                <a16:creationId xmlns:a16="http://schemas.microsoft.com/office/drawing/2014/main" id="{92029C50-C3AC-4251-B9A5-690312C9518A}"/>
               </a:ext>
             </a:extLst>
           </p:cNvPr>
@@ -6586,7 +6586,7 @@
           <p:cNvPr id="3" name="kicker-label">
             <a:extLst xmlns:a="http://schemas.openxmlformats.org/drawingml/2006/main">
               <a:ext uri="{FF2B5EF4-FFF2-40B4-BE49-F238E27FC236}">
-                <a16:creationId xmlns:a16="http://schemas.microsoft.com/office/drawing/2014/main" id="{1C18417A-FE35-4151-B342-3C291495AFA9}"/>
+                <a16:creationId xmlns:a16="http://schemas.microsoft.com/office/drawing/2014/main" id="{B39FFA66-BFDA-4846-90B2-FCD00A2D4C14}"/>
               </a:ext>
             </a:extLst>
           </p:cNvPr>
@@ -6650,7 +6650,7 @@
           <p:cNvPr id="4" name="">
             <a:extLst xmlns:a="http://schemas.openxmlformats.org/drawingml/2006/main">
               <a:ext uri="{FF2B5EF4-FFF2-40B4-BE49-F238E27FC236}">
-                <a16:creationId xmlns:a16="http://schemas.microsoft.com/office/drawing/2014/main" id="{9EADD103-72CC-4474-AE65-0CB9459C6A67}"/>
+                <a16:creationId xmlns:a16="http://schemas.microsoft.com/office/drawing/2014/main" id="{7CD69C2B-D590-42E9-873A-C3BBD26E02FF}"/>
               </a:ext>
             </a:extLst>
           </p:cNvPr>
@@ -6714,7 +6714,7 @@
           <p:cNvPr id="5" name="">
             <a:extLst xmlns:a="http://schemas.openxmlformats.org/drawingml/2006/main">
               <a:ext uri="{FF2B5EF4-FFF2-40B4-BE49-F238E27FC236}">
-                <a16:creationId xmlns:a16="http://schemas.microsoft.com/office/drawing/2014/main" id="{6C7837F4-9E25-4588-AD51-E73BB3364438}"/>
+                <a16:creationId xmlns:a16="http://schemas.microsoft.com/office/drawing/2014/main" id="{932B5682-9E76-47D0-9DD9-DE74E2456AF5}"/>
               </a:ext>
             </a:extLst>
           </p:cNvPr>
@@ -6749,7 +6749,7 @@
           <p:cNvPr id="6" name="">
             <a:extLst xmlns:a="http://schemas.openxmlformats.org/drawingml/2006/main">
               <a:ext uri="{FF2B5EF4-FFF2-40B4-BE49-F238E27FC236}">
-                <a16:creationId xmlns:a16="http://schemas.microsoft.com/office/drawing/2014/main" id="{38670384-72B2-4E57-BC87-61F7906561BA}"/>
+                <a16:creationId xmlns:a16="http://schemas.microsoft.com/office/drawing/2014/main" id="{C6821AFD-0664-4540-B408-9856C70ED5E4}"/>
               </a:ext>
             </a:extLst>
           </p:cNvPr>
@@ -6813,7 +6813,7 @@
           <p:cNvPr id="7" name="">
             <a:extLst xmlns:a="http://schemas.openxmlformats.org/drawingml/2006/main">
               <a:ext uri="{FF2B5EF4-FFF2-40B4-BE49-F238E27FC236}">
-                <a16:creationId xmlns:a16="http://schemas.microsoft.com/office/drawing/2014/main" id="{FEF5B98A-8739-41D6-8DBC-932208A4C296}"/>
+                <a16:creationId xmlns:a16="http://schemas.microsoft.com/office/drawing/2014/main" id="{C28A349D-D494-4044-96AC-98DD442AF241}"/>
               </a:ext>
             </a:extLst>
           </p:cNvPr>
@@ -6848,7 +6848,7 @@
           <p:cNvPr id="8" name="">
             <a:extLst xmlns:a="http://schemas.openxmlformats.org/drawingml/2006/main">
               <a:ext uri="{FF2B5EF4-FFF2-40B4-BE49-F238E27FC236}">
-                <a16:creationId xmlns:a16="http://schemas.microsoft.com/office/drawing/2014/main" id="{AF4D181E-1EED-4A23-BBB8-51898E7C42B1}"/>
+                <a16:creationId xmlns:a16="http://schemas.microsoft.com/office/drawing/2014/main" id="{DB733487-097B-40ED-805F-3728C426F1BC}"/>
               </a:ext>
             </a:extLst>
           </p:cNvPr>
@@ -6912,7 +6912,7 @@
           <p:cNvPr id="9" name="">
             <a:extLst xmlns:a="http://schemas.openxmlformats.org/drawingml/2006/main">
               <a:ext uri="{FF2B5EF4-FFF2-40B4-BE49-F238E27FC236}">
-                <a16:creationId xmlns:a16="http://schemas.microsoft.com/office/drawing/2014/main" id="{34AE6D0C-27D0-4D69-9452-6580B9490382}"/>
+                <a16:creationId xmlns:a16="http://schemas.microsoft.com/office/drawing/2014/main" id="{BE20B841-90C1-4C49-BBBC-8BBF636EAD47}"/>
               </a:ext>
             </a:extLst>
           </p:cNvPr>
@@ -6976,7 +6976,7 @@
           <p:cNvPr id="10" name="">
             <a:extLst xmlns:a="http://schemas.openxmlformats.org/drawingml/2006/main">
               <a:ext uri="{FF2B5EF4-FFF2-40B4-BE49-F238E27FC236}">
-                <a16:creationId xmlns:a16="http://schemas.microsoft.com/office/drawing/2014/main" id="{0856E066-A2CC-4F4B-8C85-74D72A8E92A8}"/>
+                <a16:creationId xmlns:a16="http://schemas.microsoft.com/office/drawing/2014/main" id="{0B59D41A-026F-4A4F-A56E-9599D2732E3D}"/>
               </a:ext>
             </a:extLst>
           </p:cNvPr>
@@ -7040,7 +7040,7 @@
           <p:cNvPr id="11" name="">
             <a:extLst xmlns:a="http://schemas.openxmlformats.org/drawingml/2006/main">
               <a:ext uri="{FF2B5EF4-FFF2-40B4-BE49-F238E27FC236}">
-                <a16:creationId xmlns:a16="http://schemas.microsoft.com/office/drawing/2014/main" id="{E0B76B2C-F268-4FBA-9798-D3041A8D6ACE}"/>
+                <a16:creationId xmlns:a16="http://schemas.microsoft.com/office/drawing/2014/main" id="{9C81D712-87C2-4CE8-B263-26B1EC778DA2}"/>
               </a:ext>
             </a:extLst>
           </p:cNvPr>
@@ -7075,7 +7075,7 @@
           <p:cNvPr id="12" name="">
             <a:extLst xmlns:a="http://schemas.openxmlformats.org/drawingml/2006/main">
               <a:ext uri="{FF2B5EF4-FFF2-40B4-BE49-F238E27FC236}">
-                <a16:creationId xmlns:a16="http://schemas.microsoft.com/office/drawing/2014/main" id="{B2F42187-AFAE-47E7-AF36-96D22949183C}"/>
+                <a16:creationId xmlns:a16="http://schemas.microsoft.com/office/drawing/2014/main" id="{3ECB939E-A001-4956-9154-F9AEB9CAD816}"/>
               </a:ext>
             </a:extLst>
           </p:cNvPr>
@@ -7139,7 +7139,7 @@
           <p:cNvPr id="13" name="">
             <a:extLst xmlns:a="http://schemas.openxmlformats.org/drawingml/2006/main">
               <a:ext uri="{FF2B5EF4-FFF2-40B4-BE49-F238E27FC236}">
-                <a16:creationId xmlns:a16="http://schemas.microsoft.com/office/drawing/2014/main" id="{433C5768-A8F4-466C-ACC4-AE2547165BC5}"/>
+                <a16:creationId xmlns:a16="http://schemas.microsoft.com/office/drawing/2014/main" id="{EA338B8E-4971-432F-B597-27D9896CC872}"/>
               </a:ext>
             </a:extLst>
           </p:cNvPr>
@@ -7203,7 +7203,7 @@
           <p:cNvPr id="14" name="">
             <a:extLst xmlns:a="http://schemas.openxmlformats.org/drawingml/2006/main">
               <a:ext uri="{FF2B5EF4-FFF2-40B4-BE49-F238E27FC236}">
-                <a16:creationId xmlns:a16="http://schemas.microsoft.com/office/drawing/2014/main" id="{9BEED6FE-09ED-4B2D-8216-06DB07FBA63F}"/>
+                <a16:creationId xmlns:a16="http://schemas.microsoft.com/office/drawing/2014/main" id="{309C7EAE-DC72-4038-9EEE-31FA0F610F7C}"/>
               </a:ext>
             </a:extLst>
           </p:cNvPr>
@@ -7267,7 +7267,7 @@
           <p:cNvPr id="15" name="">
             <a:extLst xmlns:a="http://schemas.openxmlformats.org/drawingml/2006/main">
               <a:ext uri="{FF2B5EF4-FFF2-40B4-BE49-F238E27FC236}">
-                <a16:creationId xmlns:a16="http://schemas.microsoft.com/office/drawing/2014/main" id="{0E7816C6-EE7C-4B84-BBC0-27D01C3B6979}"/>
+                <a16:creationId xmlns:a16="http://schemas.microsoft.com/office/drawing/2014/main" id="{5E581A47-0326-4AFF-955F-A971A82D7C3B}"/>
               </a:ext>
             </a:extLst>
           </p:cNvPr>
@@ -7302,7 +7302,7 @@
           <p:cNvPr id="16" name="">
             <a:extLst xmlns:a="http://schemas.openxmlformats.org/drawingml/2006/main">
               <a:ext uri="{FF2B5EF4-FFF2-40B4-BE49-F238E27FC236}">
-                <a16:creationId xmlns:a16="http://schemas.microsoft.com/office/drawing/2014/main" id="{92992830-9C6A-458D-B872-0142245F54EB}"/>
+                <a16:creationId xmlns:a16="http://schemas.microsoft.com/office/drawing/2014/main" id="{C0DDAAAD-227E-436A-8F0D-75D4B3178BB8}"/>
               </a:ext>
             </a:extLst>
           </p:cNvPr>
@@ -7366,7 +7366,7 @@
           <p:cNvPr id="17" name="">
             <a:extLst xmlns:a="http://schemas.openxmlformats.org/drawingml/2006/main">
               <a:ext uri="{FF2B5EF4-FFF2-40B4-BE49-F238E27FC236}">
-                <a16:creationId xmlns:a16="http://schemas.microsoft.com/office/drawing/2014/main" id="{9C072AF7-0F61-48ED-96D2-978AAD2798BE}"/>
+                <a16:creationId xmlns:a16="http://schemas.microsoft.com/office/drawing/2014/main" id="{E6ABEB49-4215-4CDE-A2B9-ABDF0928D03D}"/>
               </a:ext>
             </a:extLst>
           </p:cNvPr>
@@ -7430,7 +7430,7 @@
           <p:cNvPr id="18" name="">
             <a:extLst xmlns:a="http://schemas.openxmlformats.org/drawingml/2006/main">
               <a:ext uri="{FF2B5EF4-FFF2-40B4-BE49-F238E27FC236}">
-                <a16:creationId xmlns:a16="http://schemas.microsoft.com/office/drawing/2014/main" id="{7CAD4E2A-5655-4EC5-A6B5-43038FDA6A06}"/>
+                <a16:creationId xmlns:a16="http://schemas.microsoft.com/office/drawing/2014/main" id="{F9233B0F-4DCC-42FF-A9B9-40AE49BA0E56}"/>
               </a:ext>
             </a:extLst>
           </p:cNvPr>
@@ -7494,7 +7494,7 @@
           <p:cNvPr id="19" name="">
             <a:extLst xmlns:a="http://schemas.openxmlformats.org/drawingml/2006/main">
               <a:ext uri="{FF2B5EF4-FFF2-40B4-BE49-F238E27FC236}">
-                <a16:creationId xmlns:a16="http://schemas.microsoft.com/office/drawing/2014/main" id="{D9944574-813E-497A-9038-7F926963FE72}"/>
+                <a16:creationId xmlns:a16="http://schemas.microsoft.com/office/drawing/2014/main" id="{3CDF7B97-EFD1-41B0-88C9-EB87802BFD3C}"/>
               </a:ext>
             </a:extLst>
           </p:cNvPr>
@@ -7527,7 +7527,7 @@
           <p:cNvPr id="20" name="">
             <a:extLst xmlns:a="http://schemas.openxmlformats.org/drawingml/2006/main">
               <a:ext uri="{FF2B5EF4-FFF2-40B4-BE49-F238E27FC236}">
-                <a16:creationId xmlns:a16="http://schemas.microsoft.com/office/drawing/2014/main" id="{42662677-6725-4EC2-864E-7E47A0A9C82B}"/>
+                <a16:creationId xmlns:a16="http://schemas.microsoft.com/office/drawing/2014/main" id="{6A91CAC5-E2AE-4F7B-B6B3-1AC1259F8F83}"/>
               </a:ext>
             </a:extLst>
           </p:cNvPr>
@@ -7589,7 +7589,7 @@
     </p:spTree>
     <p:extLst>
       <p:ext uri="{BB962C8B-B14F-4D97-AF65-F5344CB8AC3E}">
-        <p14:creationId xmlns:p14="http://schemas.microsoft.com/office/powerpoint/2010/main" val="856585001"/>
+        <p14:creationId xmlns:p14="http://schemas.microsoft.com/office/powerpoint/2010/main" val="1966885048"/>
       </p:ext>
     </p:extLst>
   </p:cSld>
@@ -7613,7 +7613,7 @@
           <p:cNvPr id="1" name="">
             <a:extLst xmlns:a="http://schemas.openxmlformats.org/drawingml/2006/main">
               <a:ext uri="{FF2B5EF4-FFF2-40B4-BE49-F238E27FC236}">
-                <a16:creationId xmlns:a16="http://schemas.microsoft.com/office/drawing/2014/main" id="{5482D01A-E0D7-4A2B-A19A-06143AA83ABC}"/>
+                <a16:creationId xmlns:a16="http://schemas.microsoft.com/office/drawing/2014/main" id="{0EE2C43F-9D9C-4017-8265-CB86FC9163D8}"/>
               </a:ext>
             </a:extLst>
           </p:cNvPr>
@@ -7648,7 +7648,7 @@
           <p:cNvPr id="2" name="kicker-marker">
             <a:extLst xmlns:a="http://schemas.openxmlformats.org/drawingml/2006/main">
               <a:ext uri="{FF2B5EF4-FFF2-40B4-BE49-F238E27FC236}">
-                <a16:creationId xmlns:a16="http://schemas.microsoft.com/office/drawing/2014/main" id="{A04DB903-16F3-48BE-A339-F264D16AC5CC}"/>
+                <a16:creationId xmlns:a16="http://schemas.microsoft.com/office/drawing/2014/main" id="{AC250607-FECC-47E5-AA9F-EBE1C8115BB7}"/>
               </a:ext>
             </a:extLst>
           </p:cNvPr>
@@ -7683,7 +7683,7 @@
           <p:cNvPr id="3" name="kicker-label">
             <a:extLst xmlns:a="http://schemas.openxmlformats.org/drawingml/2006/main">
               <a:ext uri="{FF2B5EF4-FFF2-40B4-BE49-F238E27FC236}">
-                <a16:creationId xmlns:a16="http://schemas.microsoft.com/office/drawing/2014/main" id="{92A0F71B-13D4-4802-8FA1-6E9752B70555}"/>
+                <a16:creationId xmlns:a16="http://schemas.microsoft.com/office/drawing/2014/main" id="{AC7AC452-210C-4FE9-B54C-02647BC2C580}"/>
               </a:ext>
             </a:extLst>
           </p:cNvPr>
@@ -7747,7 +7747,7 @@
           <p:cNvPr id="4" name="">
             <a:extLst xmlns:a="http://schemas.openxmlformats.org/drawingml/2006/main">
               <a:ext uri="{FF2B5EF4-FFF2-40B4-BE49-F238E27FC236}">
-                <a16:creationId xmlns:a16="http://schemas.microsoft.com/office/drawing/2014/main" id="{41C57DC0-0C96-4E3C-9120-D9C85F9B43BF}"/>
+                <a16:creationId xmlns:a16="http://schemas.microsoft.com/office/drawing/2014/main" id="{9B5E84C9-B385-4283-88FF-E86272B60A41}"/>
               </a:ext>
             </a:extLst>
           </p:cNvPr>
@@ -7811,7 +7811,7 @@
           <p:cNvPr id="5" name="">
             <a:extLst xmlns:a="http://schemas.openxmlformats.org/drawingml/2006/main">
               <a:ext uri="{FF2B5EF4-FFF2-40B4-BE49-F238E27FC236}">
-                <a16:creationId xmlns:a16="http://schemas.microsoft.com/office/drawing/2014/main" id="{539794D1-357D-4C29-BA91-161491D567EF}"/>
+                <a16:creationId xmlns:a16="http://schemas.microsoft.com/office/drawing/2014/main" id="{BC089B0B-ED17-440A-9448-FA6B312440B5}"/>
               </a:ext>
             </a:extLst>
           </p:cNvPr>
@@ -7846,7 +7846,7 @@
           <p:cNvPr id="6" name="">
             <a:extLst xmlns:a="http://schemas.openxmlformats.org/drawingml/2006/main">
               <a:ext uri="{FF2B5EF4-FFF2-40B4-BE49-F238E27FC236}">
-                <a16:creationId xmlns:a16="http://schemas.microsoft.com/office/drawing/2014/main" id="{3D6AD782-75B1-4B70-95CF-EBC7A026472F}"/>
+                <a16:creationId xmlns:a16="http://schemas.microsoft.com/office/drawing/2014/main" id="{36C41C35-6418-4F53-9008-8E4862D22178}"/>
               </a:ext>
             </a:extLst>
           </p:cNvPr>
@@ -7910,7 +7910,7 @@
           <p:cNvPr id="7" name="">
             <a:extLst xmlns:a="http://schemas.openxmlformats.org/drawingml/2006/main">
               <a:ext uri="{FF2B5EF4-FFF2-40B4-BE49-F238E27FC236}">
-                <a16:creationId xmlns:a16="http://schemas.microsoft.com/office/drawing/2014/main" id="{F318B9F9-0E26-4205-A354-66C6BA796070}"/>
+                <a16:creationId xmlns:a16="http://schemas.microsoft.com/office/drawing/2014/main" id="{F00FA5F2-2F2C-40E5-9514-1277BC47197E}"/>
               </a:ext>
             </a:extLst>
           </p:cNvPr>
@@ -7943,7 +7943,7 @@
           <p:cNvPr id="8" name="">
             <a:extLst xmlns:a="http://schemas.openxmlformats.org/drawingml/2006/main">
               <a:ext uri="{FF2B5EF4-FFF2-40B4-BE49-F238E27FC236}">
-                <a16:creationId xmlns:a16="http://schemas.microsoft.com/office/drawing/2014/main" id="{E0B99DBF-D80A-476D-82CC-7845309CD929}"/>
+                <a16:creationId xmlns:a16="http://schemas.microsoft.com/office/drawing/2014/main" id="{9E99A40A-E6B8-4F68-BDD4-18BD064EEEC0}"/>
               </a:ext>
             </a:extLst>
           </p:cNvPr>
@@ -8007,7 +8007,7 @@
           <p:cNvPr id="9" name="">
             <a:extLst xmlns:a="http://schemas.openxmlformats.org/drawingml/2006/main">
               <a:ext uri="{FF2B5EF4-FFF2-40B4-BE49-F238E27FC236}">
-                <a16:creationId xmlns:a16="http://schemas.microsoft.com/office/drawing/2014/main" id="{2CF28B7B-D0FD-462A-A272-4B0213B33FC4}"/>
+                <a16:creationId xmlns:a16="http://schemas.microsoft.com/office/drawing/2014/main" id="{F1C76E42-DFE9-4496-BF2C-1D19B46EACC0}"/>
               </a:ext>
             </a:extLst>
           </p:cNvPr>
@@ -8071,7 +8071,7 @@
           <p:cNvPr id="10" name="">
             <a:extLst xmlns:a="http://schemas.openxmlformats.org/drawingml/2006/main">
               <a:ext uri="{FF2B5EF4-FFF2-40B4-BE49-F238E27FC236}">
-                <a16:creationId xmlns:a16="http://schemas.microsoft.com/office/drawing/2014/main" id="{B574DDC8-D556-421D-8F54-79B836FB9356}"/>
+                <a16:creationId xmlns:a16="http://schemas.microsoft.com/office/drawing/2014/main" id="{363B138E-8101-4EE3-A71B-FDB8927ED053}"/>
               </a:ext>
             </a:extLst>
           </p:cNvPr>
@@ -8104,7 +8104,7 @@
           <p:cNvPr id="11" name="">
             <a:extLst xmlns:a="http://schemas.openxmlformats.org/drawingml/2006/main">
               <a:ext uri="{FF2B5EF4-FFF2-40B4-BE49-F238E27FC236}">
-                <a16:creationId xmlns:a16="http://schemas.microsoft.com/office/drawing/2014/main" id="{D32DC060-E067-4202-B0EB-613AA73F62A7}"/>
+                <a16:creationId xmlns:a16="http://schemas.microsoft.com/office/drawing/2014/main" id="{B0160E21-3692-4137-B98F-F9AADE3DA99A}"/>
               </a:ext>
             </a:extLst>
           </p:cNvPr>
@@ -8168,7 +8168,7 @@
           <p:cNvPr id="12" name="">
             <a:extLst xmlns:a="http://schemas.openxmlformats.org/drawingml/2006/main">
               <a:ext uri="{FF2B5EF4-FFF2-40B4-BE49-F238E27FC236}">
-                <a16:creationId xmlns:a16="http://schemas.microsoft.com/office/drawing/2014/main" id="{202F2657-6551-483A-A979-FAB3768919CF}"/>
+                <a16:creationId xmlns:a16="http://schemas.microsoft.com/office/drawing/2014/main" id="{1C91DBA4-8784-4F11-A464-86C4417DD46D}"/>
               </a:ext>
             </a:extLst>
           </p:cNvPr>
@@ -8232,7 +8232,7 @@
           <p:cNvPr id="13" name="">
             <a:extLst xmlns:a="http://schemas.openxmlformats.org/drawingml/2006/main">
               <a:ext uri="{FF2B5EF4-FFF2-40B4-BE49-F238E27FC236}">
-                <a16:creationId xmlns:a16="http://schemas.microsoft.com/office/drawing/2014/main" id="{12639F3A-46B7-4CF0-87FE-61359E8A41F7}"/>
+                <a16:creationId xmlns:a16="http://schemas.microsoft.com/office/drawing/2014/main" id="{90A23F71-AA9B-49B9-AA1C-BD8F8F31C7B7}"/>
               </a:ext>
             </a:extLst>
           </p:cNvPr>
@@ -8265,7 +8265,7 @@
           <p:cNvPr id="14" name="">
             <a:extLst xmlns:a="http://schemas.openxmlformats.org/drawingml/2006/main">
               <a:ext uri="{FF2B5EF4-FFF2-40B4-BE49-F238E27FC236}">
-                <a16:creationId xmlns:a16="http://schemas.microsoft.com/office/drawing/2014/main" id="{A4B2FB62-CB1F-4C20-9821-D63A74B9B1FC}"/>
+                <a16:creationId xmlns:a16="http://schemas.microsoft.com/office/drawing/2014/main" id="{C91F7C8E-7DB1-47E7-BF0F-C73BD0E2CF3A}"/>
               </a:ext>
             </a:extLst>
           </p:cNvPr>
@@ -8329,7 +8329,7 @@
           <p:cNvPr id="15" name="">
             <a:extLst xmlns:a="http://schemas.openxmlformats.org/drawingml/2006/main">
               <a:ext uri="{FF2B5EF4-FFF2-40B4-BE49-F238E27FC236}">
-                <a16:creationId xmlns:a16="http://schemas.microsoft.com/office/drawing/2014/main" id="{929CE089-3674-41DB-BD01-C7309F1C546E}"/>
+                <a16:creationId xmlns:a16="http://schemas.microsoft.com/office/drawing/2014/main" id="{19075306-A44B-48FE-A90D-50E7BFF7222C}"/>
               </a:ext>
             </a:extLst>
           </p:cNvPr>
@@ -8393,7 +8393,7 @@
           <p:cNvPr id="16" name="">
             <a:extLst xmlns:a="http://schemas.openxmlformats.org/drawingml/2006/main">
               <a:ext uri="{FF2B5EF4-FFF2-40B4-BE49-F238E27FC236}">
-                <a16:creationId xmlns:a16="http://schemas.microsoft.com/office/drawing/2014/main" id="{5D5BE1A9-835A-4F0F-AF0E-5D3E4C5E5DE9}"/>
+                <a16:creationId xmlns:a16="http://schemas.microsoft.com/office/drawing/2014/main" id="{4FEE39D4-4E45-4410-A92C-06504979FD32}"/>
               </a:ext>
             </a:extLst>
           </p:cNvPr>
@@ -8426,7 +8426,7 @@
           <p:cNvPr id="17" name="">
             <a:extLst xmlns:a="http://schemas.openxmlformats.org/drawingml/2006/main">
               <a:ext uri="{FF2B5EF4-FFF2-40B4-BE49-F238E27FC236}">
-                <a16:creationId xmlns:a16="http://schemas.microsoft.com/office/drawing/2014/main" id="{D9C60CBD-9026-4611-AD25-CEFECAAF7FE1}"/>
+                <a16:creationId xmlns:a16="http://schemas.microsoft.com/office/drawing/2014/main" id="{252C0FA9-01F1-402E-A3BF-9493CDE581F5}"/>
               </a:ext>
             </a:extLst>
           </p:cNvPr>
@@ -8490,7 +8490,7 @@
           <p:cNvPr id="18" name="">
             <a:extLst xmlns:a="http://schemas.openxmlformats.org/drawingml/2006/main">
               <a:ext uri="{FF2B5EF4-FFF2-40B4-BE49-F238E27FC236}">
-                <a16:creationId xmlns:a16="http://schemas.microsoft.com/office/drawing/2014/main" id="{7C30D853-D250-4497-9C8E-EB032BEA8925}"/>
+                <a16:creationId xmlns:a16="http://schemas.microsoft.com/office/drawing/2014/main" id="{AFDA0B47-466D-4BDE-B578-D8A5A8D5B8C8}"/>
               </a:ext>
             </a:extLst>
           </p:cNvPr>
@@ -8554,7 +8554,7 @@
           <p:cNvPr id="19" name="">
             <a:extLst xmlns:a="http://schemas.openxmlformats.org/drawingml/2006/main">
               <a:ext uri="{FF2B5EF4-FFF2-40B4-BE49-F238E27FC236}">
-                <a16:creationId xmlns:a16="http://schemas.microsoft.com/office/drawing/2014/main" id="{13FBDD1B-B361-4F52-A9BD-A7333C239D86}"/>
+                <a16:creationId xmlns:a16="http://schemas.microsoft.com/office/drawing/2014/main" id="{859174BB-BAEB-43EE-87C8-530460FDAA7E}"/>
               </a:ext>
             </a:extLst>
           </p:cNvPr>
@@ -8587,7 +8587,7 @@
           <p:cNvPr id="20" name="">
             <a:extLst xmlns:a="http://schemas.openxmlformats.org/drawingml/2006/main">
               <a:ext uri="{FF2B5EF4-FFF2-40B4-BE49-F238E27FC236}">
-                <a16:creationId xmlns:a16="http://schemas.microsoft.com/office/drawing/2014/main" id="{105CEF3E-4FF3-48DE-B422-08964E26A1E5}"/>
+                <a16:creationId xmlns:a16="http://schemas.microsoft.com/office/drawing/2014/main" id="{D7C71B76-68CD-46F0-ACF5-A0218BB26AFD}"/>
               </a:ext>
             </a:extLst>
           </p:cNvPr>
@@ -8651,7 +8651,7 @@
           <p:cNvPr id="21" name="">
             <a:extLst xmlns:a="http://schemas.openxmlformats.org/drawingml/2006/main">
               <a:ext uri="{FF2B5EF4-FFF2-40B4-BE49-F238E27FC236}">
-                <a16:creationId xmlns:a16="http://schemas.microsoft.com/office/drawing/2014/main" id="{DB640FD1-577E-406E-BABB-ACC1A47B7B53}"/>
+                <a16:creationId xmlns:a16="http://schemas.microsoft.com/office/drawing/2014/main" id="{FED8FF46-F67A-4407-97D1-25E752DC48D1}"/>
               </a:ext>
             </a:extLst>
           </p:cNvPr>
@@ -8715,7 +8715,7 @@
           <p:cNvPr id="22" name="">
             <a:extLst xmlns:a="http://schemas.openxmlformats.org/drawingml/2006/main">
               <a:ext uri="{FF2B5EF4-FFF2-40B4-BE49-F238E27FC236}">
-                <a16:creationId xmlns:a16="http://schemas.microsoft.com/office/drawing/2014/main" id="{5AE95B1A-23D0-42D3-B5C8-A2B8C6616448}"/>
+                <a16:creationId xmlns:a16="http://schemas.microsoft.com/office/drawing/2014/main" id="{7005492D-0303-48D2-A053-4A8EE94B141E}"/>
               </a:ext>
             </a:extLst>
           </p:cNvPr>
@@ -8777,7 +8777,7 @@
     </p:spTree>
     <p:extLst>
       <p:ext uri="{BB962C8B-B14F-4D97-AF65-F5344CB8AC3E}">
-        <p14:creationId xmlns:p14="http://schemas.microsoft.com/office/powerpoint/2010/main" val="1342462672"/>
+        <p14:creationId xmlns:p14="http://schemas.microsoft.com/office/powerpoint/2010/main" val="36154676"/>
       </p:ext>
     </p:extLst>
   </p:cSld>
@@ -8801,7 +8801,7 @@
           <p:cNvPr id="1" name="">
             <a:extLst xmlns:a="http://schemas.openxmlformats.org/drawingml/2006/main">
               <a:ext uri="{FF2B5EF4-FFF2-40B4-BE49-F238E27FC236}">
-                <a16:creationId xmlns:a16="http://schemas.microsoft.com/office/drawing/2014/main" id="{635B0643-3925-433B-9CCB-C73020C91491}"/>
+                <a16:creationId xmlns:a16="http://schemas.microsoft.com/office/drawing/2014/main" id="{28FA72A8-367B-4B1C-86C9-1EC77CFE8782}"/>
               </a:ext>
             </a:extLst>
           </p:cNvPr>
@@ -8836,7 +8836,7 @@
           <p:cNvPr id="2" name="kicker-marker">
             <a:extLst xmlns:a="http://schemas.openxmlformats.org/drawingml/2006/main">
               <a:ext uri="{FF2B5EF4-FFF2-40B4-BE49-F238E27FC236}">
-                <a16:creationId xmlns:a16="http://schemas.microsoft.com/office/drawing/2014/main" id="{E8258857-6DA2-4CBA-A456-E9DAA99F702B}"/>
+                <a16:creationId xmlns:a16="http://schemas.microsoft.com/office/drawing/2014/main" id="{8474D59D-B06F-4C8A-B943-2B0DCB618C5D}"/>
               </a:ext>
             </a:extLst>
           </p:cNvPr>
@@ -8871,7 +8871,7 @@
           <p:cNvPr id="3" name="kicker-label">
             <a:extLst xmlns:a="http://schemas.openxmlformats.org/drawingml/2006/main">
               <a:ext uri="{FF2B5EF4-FFF2-40B4-BE49-F238E27FC236}">
-                <a16:creationId xmlns:a16="http://schemas.microsoft.com/office/drawing/2014/main" id="{22C4DF32-C4DE-4D13-9DCB-5556141DEFB4}"/>
+                <a16:creationId xmlns:a16="http://schemas.microsoft.com/office/drawing/2014/main" id="{90A09229-9B6A-4AFE-BE98-33D63CF07D81}"/>
               </a:ext>
             </a:extLst>
           </p:cNvPr>
@@ -8935,7 +8935,7 @@
           <p:cNvPr id="4" name="">
             <a:extLst xmlns:a="http://schemas.openxmlformats.org/drawingml/2006/main">
               <a:ext uri="{FF2B5EF4-FFF2-40B4-BE49-F238E27FC236}">
-                <a16:creationId xmlns:a16="http://schemas.microsoft.com/office/drawing/2014/main" id="{9BA86D77-2AE9-4576-986D-7A94175D03E4}"/>
+                <a16:creationId xmlns:a16="http://schemas.microsoft.com/office/drawing/2014/main" id="{7335E6DB-31DE-460C-8330-B351D42FE427}"/>
               </a:ext>
             </a:extLst>
           </p:cNvPr>
@@ -8999,7 +8999,7 @@
           <p:cNvPr id="5" name="">
             <a:extLst xmlns:a="http://schemas.openxmlformats.org/drawingml/2006/main">
               <a:ext uri="{FF2B5EF4-FFF2-40B4-BE49-F238E27FC236}">
-                <a16:creationId xmlns:a16="http://schemas.microsoft.com/office/drawing/2014/main" id="{2B7870F4-FFB9-40F9-868C-5321EEF42A7E}"/>
+                <a16:creationId xmlns:a16="http://schemas.microsoft.com/office/drawing/2014/main" id="{C6A717ED-2D4C-4239-A3DA-E75358363F34}"/>
               </a:ext>
             </a:extLst>
           </p:cNvPr>
@@ -9034,7 +9034,7 @@
           <p:cNvPr id="6" name="">
             <a:extLst xmlns:a="http://schemas.openxmlformats.org/drawingml/2006/main">
               <a:ext uri="{FF2B5EF4-FFF2-40B4-BE49-F238E27FC236}">
-                <a16:creationId xmlns:a16="http://schemas.microsoft.com/office/drawing/2014/main" id="{66A8615C-AF8D-4E11-875C-134AF01056DE}"/>
+                <a16:creationId xmlns:a16="http://schemas.microsoft.com/office/drawing/2014/main" id="{8D2D43EC-7BB3-45B0-AD8B-64D4F130D9A5}"/>
               </a:ext>
             </a:extLst>
           </p:cNvPr>
@@ -9098,7 +9098,7 @@
           <p:cNvPr id="7" name="">
             <a:extLst xmlns:a="http://schemas.openxmlformats.org/drawingml/2006/main">
               <a:ext uri="{FF2B5EF4-FFF2-40B4-BE49-F238E27FC236}">
-                <a16:creationId xmlns:a16="http://schemas.microsoft.com/office/drawing/2014/main" id="{8BFB68F7-1DEA-4925-8393-7E134ABBB81E}"/>
+                <a16:creationId xmlns:a16="http://schemas.microsoft.com/office/drawing/2014/main" id="{49FB4021-A3B7-4AB6-8E41-5CEC105B025C}"/>
               </a:ext>
             </a:extLst>
           </p:cNvPr>
@@ -9131,7 +9131,7 @@
           <p:cNvPr id="8" name="">
             <a:extLst xmlns:a="http://schemas.openxmlformats.org/drawingml/2006/main">
               <a:ext uri="{FF2B5EF4-FFF2-40B4-BE49-F238E27FC236}">
-                <a16:creationId xmlns:a16="http://schemas.microsoft.com/office/drawing/2014/main" id="{92F0A955-5608-441B-9CA4-A27F39C3BE16}"/>
+                <a16:creationId xmlns:a16="http://schemas.microsoft.com/office/drawing/2014/main" id="{0EE384B6-1AFE-408A-A07C-40EE5D015A34}"/>
               </a:ext>
             </a:extLst>
           </p:cNvPr>
@@ -9195,7 +9195,7 @@
           <p:cNvPr id="9" name="">
             <a:extLst xmlns:a="http://schemas.openxmlformats.org/drawingml/2006/main">
               <a:ext uri="{FF2B5EF4-FFF2-40B4-BE49-F238E27FC236}">
-                <a16:creationId xmlns:a16="http://schemas.microsoft.com/office/drawing/2014/main" id="{6903AAB2-F647-4FE8-BD0C-8CFD02447DD9}"/>
+                <a16:creationId xmlns:a16="http://schemas.microsoft.com/office/drawing/2014/main" id="{A424FE40-FA38-4F35-B937-1A99A52F184A}"/>
               </a:ext>
             </a:extLst>
           </p:cNvPr>
@@ -9249,7 +9249,7 @@
                 <a:ea typeface="Aptos"/>
                 <a:cs typeface="Aptos"/>
               </a:rPr>
-              <a:t>Show the sample laundering records and run pattern discovery.</a:t>
+              <a:t>Show the synced case-record queue and run pattern discovery.</a:t>
             </a:r>
           </a:p>
         </p:txBody>
@@ -9259,7 +9259,7 @@
           <p:cNvPr id="10" name="">
             <a:extLst xmlns:a="http://schemas.openxmlformats.org/drawingml/2006/main">
               <a:ext uri="{FF2B5EF4-FFF2-40B4-BE49-F238E27FC236}">
-                <a16:creationId xmlns:a16="http://schemas.microsoft.com/office/drawing/2014/main" id="{BDBFA103-7B29-4E36-9309-4B1929A88951}"/>
+                <a16:creationId xmlns:a16="http://schemas.microsoft.com/office/drawing/2014/main" id="{AA3F1468-EA03-4103-B157-E468C55E6271}"/>
               </a:ext>
             </a:extLst>
           </p:cNvPr>
@@ -9292,7 +9292,7 @@
           <p:cNvPr id="11" name="">
             <a:extLst xmlns:a="http://schemas.openxmlformats.org/drawingml/2006/main">
               <a:ext uri="{FF2B5EF4-FFF2-40B4-BE49-F238E27FC236}">
-                <a16:creationId xmlns:a16="http://schemas.microsoft.com/office/drawing/2014/main" id="{BBAEBBB0-9038-4080-90DE-2946F93F2812}"/>
+                <a16:creationId xmlns:a16="http://schemas.microsoft.com/office/drawing/2014/main" id="{60BCB323-4355-44CE-98E5-7A8F641DD499}"/>
               </a:ext>
             </a:extLst>
           </p:cNvPr>
@@ -9356,7 +9356,7 @@
           <p:cNvPr id="12" name="">
             <a:extLst xmlns:a="http://schemas.openxmlformats.org/drawingml/2006/main">
               <a:ext uri="{FF2B5EF4-FFF2-40B4-BE49-F238E27FC236}">
-                <a16:creationId xmlns:a16="http://schemas.microsoft.com/office/drawing/2014/main" id="{E441A38B-386E-4356-B6D1-142ACBBA2AFF}"/>
+                <a16:creationId xmlns:a16="http://schemas.microsoft.com/office/drawing/2014/main" id="{E805D046-B3E6-4366-94F1-25E1D25B1DF8}"/>
               </a:ext>
             </a:extLst>
           </p:cNvPr>
@@ -9420,7 +9420,7 @@
           <p:cNvPr id="13" name="">
             <a:extLst xmlns:a="http://schemas.openxmlformats.org/drawingml/2006/main">
               <a:ext uri="{FF2B5EF4-FFF2-40B4-BE49-F238E27FC236}">
-                <a16:creationId xmlns:a16="http://schemas.microsoft.com/office/drawing/2014/main" id="{BF277EEE-46D5-463C-ADE3-22B74D54EC33}"/>
+                <a16:creationId xmlns:a16="http://schemas.microsoft.com/office/drawing/2014/main" id="{0F83449F-B943-425C-9A5A-725196BF8C7A}"/>
               </a:ext>
             </a:extLst>
           </p:cNvPr>
@@ -9453,7 +9453,7 @@
           <p:cNvPr id="14" name="">
             <a:extLst xmlns:a="http://schemas.openxmlformats.org/drawingml/2006/main">
               <a:ext uri="{FF2B5EF4-FFF2-40B4-BE49-F238E27FC236}">
-                <a16:creationId xmlns:a16="http://schemas.microsoft.com/office/drawing/2014/main" id="{7FA4824E-BBC1-4279-962A-36BF8B074128}"/>
+                <a16:creationId xmlns:a16="http://schemas.microsoft.com/office/drawing/2014/main" id="{80BC862D-F466-41FE-9237-DAA13CAF91D9}"/>
               </a:ext>
             </a:extLst>
           </p:cNvPr>
@@ -9517,7 +9517,7 @@
           <p:cNvPr id="15" name="">
             <a:extLst xmlns:a="http://schemas.openxmlformats.org/drawingml/2006/main">
               <a:ext uri="{FF2B5EF4-FFF2-40B4-BE49-F238E27FC236}">
-                <a16:creationId xmlns:a16="http://schemas.microsoft.com/office/drawing/2014/main" id="{4A2419CE-FECA-4320-BC6C-DBC0BA45EC0A}"/>
+                <a16:creationId xmlns:a16="http://schemas.microsoft.com/office/drawing/2014/main" id="{EF3CA293-CFEA-4E7D-8F50-87AA4B1F30C7}"/>
               </a:ext>
             </a:extLst>
           </p:cNvPr>
@@ -9581,7 +9581,7 @@
           <p:cNvPr id="16" name="">
             <a:extLst xmlns:a="http://schemas.openxmlformats.org/drawingml/2006/main">
               <a:ext uri="{FF2B5EF4-FFF2-40B4-BE49-F238E27FC236}">
-                <a16:creationId xmlns:a16="http://schemas.microsoft.com/office/drawing/2014/main" id="{0A4CAA6B-2503-48FF-8BC4-8D6AE9EBA060}"/>
+                <a16:creationId xmlns:a16="http://schemas.microsoft.com/office/drawing/2014/main" id="{73084ECE-4DE8-4057-9029-29B418F8C634}"/>
               </a:ext>
             </a:extLst>
           </p:cNvPr>
@@ -9614,7 +9614,7 @@
           <p:cNvPr id="17" name="">
             <a:extLst xmlns:a="http://schemas.openxmlformats.org/drawingml/2006/main">
               <a:ext uri="{FF2B5EF4-FFF2-40B4-BE49-F238E27FC236}">
-                <a16:creationId xmlns:a16="http://schemas.microsoft.com/office/drawing/2014/main" id="{F8F2C4FA-B917-47D6-BFE6-C5F60D1E98CD}"/>
+                <a16:creationId xmlns:a16="http://schemas.microsoft.com/office/drawing/2014/main" id="{6BB7B380-480D-4281-9743-00F9E36E4A2A}"/>
               </a:ext>
             </a:extLst>
           </p:cNvPr>
@@ -9678,7 +9678,7 @@
           <p:cNvPr id="18" name="">
             <a:extLst xmlns:a="http://schemas.openxmlformats.org/drawingml/2006/main">
               <a:ext uri="{FF2B5EF4-FFF2-40B4-BE49-F238E27FC236}">
-                <a16:creationId xmlns:a16="http://schemas.microsoft.com/office/drawing/2014/main" id="{194C1A3A-EB2A-48EB-BDC4-6825D2560EB7}"/>
+                <a16:creationId xmlns:a16="http://schemas.microsoft.com/office/drawing/2014/main" id="{DFE28048-9FFC-4D6A-812A-C1D42AC4DEA3}"/>
               </a:ext>
             </a:extLst>
           </p:cNvPr>
@@ -9742,7 +9742,7 @@
           <p:cNvPr id="19" name="">
             <a:extLst xmlns:a="http://schemas.openxmlformats.org/drawingml/2006/main">
               <a:ext uri="{FF2B5EF4-FFF2-40B4-BE49-F238E27FC236}">
-                <a16:creationId xmlns:a16="http://schemas.microsoft.com/office/drawing/2014/main" id="{583B1B7F-3B3D-4EC6-8E53-39D7BA1D9472}"/>
+                <a16:creationId xmlns:a16="http://schemas.microsoft.com/office/drawing/2014/main" id="{701DA878-6F70-4659-808A-60249F6BB1A9}"/>
               </a:ext>
             </a:extLst>
           </p:cNvPr>
@@ -9777,7 +9777,7 @@
           <p:cNvPr id="20" name="">
             <a:extLst xmlns:a="http://schemas.openxmlformats.org/drawingml/2006/main">
               <a:ext uri="{FF2B5EF4-FFF2-40B4-BE49-F238E27FC236}">
-                <a16:creationId xmlns:a16="http://schemas.microsoft.com/office/drawing/2014/main" id="{57ED2A71-961A-4A99-A45E-C467979C1B34}"/>
+                <a16:creationId xmlns:a16="http://schemas.microsoft.com/office/drawing/2014/main" id="{73C6116F-F38B-4977-96AB-A45981DFF0E3}"/>
               </a:ext>
             </a:extLst>
           </p:cNvPr>
@@ -9841,7 +9841,7 @@
           <p:cNvPr id="21" name="">
             <a:extLst xmlns:a="http://schemas.openxmlformats.org/drawingml/2006/main">
               <a:ext uri="{FF2B5EF4-FFF2-40B4-BE49-F238E27FC236}">
-                <a16:creationId xmlns:a16="http://schemas.microsoft.com/office/drawing/2014/main" id="{7557E311-2E0D-4310-8C92-EC50423B50C8}"/>
+                <a16:creationId xmlns:a16="http://schemas.microsoft.com/office/drawing/2014/main" id="{966B212C-9C3C-4526-BDDA-F2993237E5C7}"/>
               </a:ext>
             </a:extLst>
           </p:cNvPr>
@@ -9896,7 +9896,7 @@
                 <a:cs typeface="Aptos"/>
                 <a:hlinkClick xmlns:r="http://schemas.openxmlformats.org/officeDocument/2006/relationships" r:id="rIdSynthAMLDemo"/>
               </a:rPr>
-              <a:t>https://raw.githack.com/yq688m3JT/genAI_final/a909764e2905cf627550479f619ade84aa52cfa9/docs/demo.html</a:t>
+              <a:t>https://raw.githack.com/yq688m3JT/genAI_final/96f03dbb7ecf9a5f13d39b6a0f8c61218ea87962/docs/demo.html</a:t>
             </a:r>
           </a:p>
         </p:txBody>
@@ -9904,7 +9904,7 @@
     </p:spTree>
     <p:extLst>
       <p:ext uri="{BB962C8B-B14F-4D97-AF65-F5344CB8AC3E}">
-        <p14:creationId xmlns:p14="http://schemas.microsoft.com/office/powerpoint/2010/main" val="817236135"/>
+        <p14:creationId xmlns:p14="http://schemas.microsoft.com/office/powerpoint/2010/main" val="49551851"/>
       </p:ext>
     </p:extLst>
   </p:cSld>

</xml_diff>